<commit_message>
Notebook de la clase 1 ampliado: exploración de variables de la EOD por tipo; columna Colab en el calendario
Co-Authored-By: Claude Fable 5 <noreply@anthropic.com>
</commit_message>
<xml_diff>
--- a/presentaciones/clase01_fundamentos_ecosistema.pptx
+++ b/presentaciones/clase01_fundamentos_ecosistema.pptx
@@ -8656,7 +8656,7 @@
                 </a:solidFill>
                 <a:latin typeface="Fira Sans"/>
               </a:rPr>
-              <a:t>Leeremos la tabla de viajes de la EOD directo desde una URL.</a:t>
+              <a:t>Leeremos la tabla de viajes de la EOD desde una URL: shape, head, info.</a:t>
             </a:r>
           </a:p>
           <a:p>
@@ -8684,7 +8684,7 @@
                 </a:solidFill>
                 <a:latin typeface="Fira Sans"/>
               </a:rPr>
-              <a:t>Tres miradas iniciales a cualquier tabla: shape, head, info.</a:t>
+              <a:t>Variables cualitativas: contar con value_counts, resolver códigos contra las tablas de parámetros y recalcular el reparto modal en vivo.</a:t>
             </a:r>
           </a:p>
           <a:p>
@@ -8712,7 +8712,35 @@
                 </a:solidFill>
                 <a:latin typeface="Fira Sans"/>
               </a:rPr>
-              <a:t>Y el histograma de duración de los viajes, para cerrar el circuito datos → tabla → gráfico.</a:t>
+              <a:t>Variables cuantitativas: describe y el histograma de duración de los viajes; y una discreta, los viajes por persona.</a:t>
+            </a:r>
+          </a:p>
+          <a:p>
+            <a:pPr>
+              <a:lnSpc>
+                <a:spcPct val="112000"/>
+              </a:lnSpc>
+              <a:spcAft>
+                <a:spcPts val="900"/>
+              </a:spcAft>
+            </a:pPr>
+            <a:r>
+              <a:rPr sz="1800" b="1">
+                <a:solidFill>
+                  <a:srgbClr val="E0A437"/>
+                </a:solidFill>
+                <a:latin typeface="Fira Sans"/>
+              </a:rPr>
+              <a:t>▸ </a:t>
+            </a:r>
+            <a:r>
+              <a:rPr sz="1800" b="1">
+                <a:solidFill>
+                  <a:srgbClr val="1D3557"/>
+                </a:solidFill>
+                <a:latin typeface="Fira Sans"/>
+              </a:rPr>
+              <a:t>El hilo es el de la clase: el tipo de cada variable define qué análisis es válido.</a:t>
             </a:r>
           </a:p>
         </p:txBody>

</xml_diff>

<commit_message>
Clase 1: merge introducido con la tabla de comunas y promedios por grupo con groupby
Co-Authored-By: Claude Fable 5 <noreply@anthropic.com>
</commit_message>
<xml_diff>
--- a/presentaciones/clase01_fundamentos_ecosistema.pptx
+++ b/presentaciones/clase01_fundamentos_ecosistema.pptx
@@ -41,6 +41,7 @@
     <p:sldId id="289" r:id="rId40"/>
     <p:sldId id="290" r:id="rId41"/>
     <p:sldId id="291" r:id="rId42"/>
+    <p:sldId id="292" r:id="rId43"/>
   </p:sldIdLst>
   <p:sldSz cx="9144000" cy="5138928" type="screen4x3"/>
   <p:notesSz cx="6858000" cy="9144000"/>
@@ -7954,35 +7955,78 @@
                 </a:solidFill>
                 <a:latin typeface="Fira Sans"/>
               </a:rPr>
-              <a:t>Matplotlib: del DataFrame al gráfico</a:t>
-            </a:r>
-          </a:p>
-        </p:txBody>
-      </p:sp>
-      <p:pic>
-        <p:nvPicPr>
-          <p:cNvPr id="4" name="Picture 3" descr="06_hist_tiempo.png"/>
-          <p:cNvPicPr>
-            <a:picLocks noChangeAspect="1"/>
-          </p:cNvPicPr>
-          <p:nvPr/>
-        </p:nvPicPr>
-        <p:blipFill>
-          <a:blip r:embed="rId2"/>
-          <a:stretch>
-            <a:fillRect/>
-          </a:stretch>
-        </p:blipFill>
-        <p:spPr>
-          <a:xfrm>
-            <a:off x="1778310" y="1143000"/>
-            <a:ext cx="5587379" cy="3154680"/>
-          </a:xfrm>
-          <a:prstGeom prst="rect">
-            <a:avLst/>
-          </a:prstGeom>
-        </p:spPr>
-      </p:pic>
+              <a:t>Pandas: unir tablas con merge</a:t>
+            </a:r>
+          </a:p>
+        </p:txBody>
+      </p:sp>
+      <p:sp>
+        <p:nvSpPr>
+          <p:cNvPr id="4" name="Rectangle 3"/>
+          <p:cNvSpPr/>
+          <p:nvPr/>
+        </p:nvSpPr>
+        <p:spPr>
+          <a:xfrm>
+            <a:off x="704088" y="1280160"/>
+            <a:ext cx="7744968" cy="1371600"/>
+          </a:xfrm>
+          <a:prstGeom prst="rect">
+            <a:avLst/>
+          </a:prstGeom>
+          <a:solidFill>
+            <a:srgbClr val="F0F2F5"/>
+          </a:solidFill>
+          <a:ln>
+            <a:solidFill>
+              <a:srgbClr val="D8DDE3"/>
+            </a:solidFill>
+          </a:ln>
+          <a:effectLst/>
+        </p:spPr>
+        <p:style>
+          <a:lnRef idx="1">
+            <a:schemeClr val="accent1"/>
+          </a:lnRef>
+          <a:fillRef idx="3">
+            <a:schemeClr val="accent1"/>
+          </a:fillRef>
+          <a:effectRef idx="2">
+            <a:schemeClr val="accent1"/>
+          </a:effectRef>
+          <a:fontRef idx="minor">
+            <a:schemeClr val="lt1"/>
+          </a:fontRef>
+        </p:style>
+        <p:txBody>
+          <a:bodyPr rtlCol="0" anchor="ctr" wrap="square" lIns="228600" tIns="137160"/>
+          <a:lstStyle/>
+          <a:p>
+            <a:pPr/>
+            <a:r>
+              <a:rPr sz="1500" b="0">
+                <a:solidFill>
+                  <a:srgbClr val="1D3557"/>
+                </a:solidFill>
+                <a:latin typeface="Menlo"/>
+              </a:rPr>
+              <a:t>comunas = pd.read_csv(URL_COMUNAS)   # Id, Comuna</a:t>
+            </a:r>
+          </a:p>
+          <a:p>
+            <a:pPr/>
+            <a:r>
+              <a:rPr sz="1500" b="0">
+                <a:solidFill>
+                  <a:srgbClr val="1D3557"/>
+                </a:solidFill>
+                <a:latin typeface="Menlo"/>
+              </a:rPr>
+              <a:t>viajes.merge(comunas, left_on="ComunaOrigen", right_on="Id")</a:t>
+            </a:r>
+          </a:p>
+        </p:txBody>
+      </p:sp>
       <p:sp>
         <p:nvSpPr>
           <p:cNvPr id="5" name="TextBox 4"/>
@@ -7991,8 +8035,8 @@
         </p:nvSpPr>
         <p:spPr>
           <a:xfrm>
-            <a:off x="704088" y="4434840"/>
-            <a:ext cx="7744968" cy="457200"/>
+            <a:off x="704088" y="2880360"/>
+            <a:ext cx="7744968" cy="1097280"/>
           </a:xfrm>
           <a:prstGeom prst="rect">
             <a:avLst/>
@@ -8005,14 +8049,31 @@
           </a:bodyPr>
           <a:lstStyle/>
           <a:p>
-            <a:r>
-              <a:rPr sz="1300" b="0">
-                <a:solidFill>
-                  <a:srgbClr val="333333"/>
-                </a:solidFill>
-                <a:latin typeface="Fira Sans"/>
-              </a:rPr>
-              <a:t>Este histograma sale de la tabla de viajes con unas seis líneas de código; el notebook de la clase las muestra completas.</a:t>
+            <a:pPr>
+              <a:lnSpc>
+                <a:spcPct val="112000"/>
+              </a:lnSpc>
+              <a:spcAft>
+                <a:spcPts val="900"/>
+              </a:spcAft>
+            </a:pPr>
+            <a:r>
+              <a:rPr sz="1600" b="1">
+                <a:solidFill>
+                  <a:srgbClr val="E0A437"/>
+                </a:solidFill>
+                <a:latin typeface="Fira Sans"/>
+              </a:rPr>
+              <a:t>▸ </a:t>
+            </a:r>
+            <a:r>
+              <a:rPr sz="1600" b="0">
+                <a:solidFill>
+                  <a:srgbClr val="000000"/>
+                </a:solidFill>
+                <a:latin typeface="Fira Sans"/>
+              </a:rPr>
+              <a:t>Los códigos de una tabla se traducen uniéndola con su tabla de parámetros: merge empareja filas por una columna común. En el notebook lo usamos para ponerle nombre a comunas y modos de viaje.</a:t>
             </a:r>
           </a:p>
         </p:txBody>
@@ -8108,21 +8169,45 @@
                 </a:solidFill>
                 <a:latin typeface="Fira Sans"/>
               </a:rPr>
-              <a:t>Jupyter y uv: el entorno de trabajo</a:t>
-            </a:r>
-          </a:p>
-        </p:txBody>
-      </p:sp>
-      <p:sp>
-        <p:nvSpPr>
-          <p:cNvPr id="4" name="TextBox 3"/>
+              <a:t>Matplotlib: del DataFrame al gráfico</a:t>
+            </a:r>
+          </a:p>
+        </p:txBody>
+      </p:sp>
+      <p:pic>
+        <p:nvPicPr>
+          <p:cNvPr id="4" name="Picture 3" descr="06_hist_tiempo.png"/>
+          <p:cNvPicPr>
+            <a:picLocks noChangeAspect="1"/>
+          </p:cNvPicPr>
+          <p:nvPr/>
+        </p:nvPicPr>
+        <p:blipFill>
+          <a:blip r:embed="rId2"/>
+          <a:stretch>
+            <a:fillRect/>
+          </a:stretch>
+        </p:blipFill>
+        <p:spPr>
+          <a:xfrm>
+            <a:off x="1778310" y="1143000"/>
+            <a:ext cx="5587379" cy="3154680"/>
+          </a:xfrm>
+          <a:prstGeom prst="rect">
+            <a:avLst/>
+          </a:prstGeom>
+        </p:spPr>
+      </p:pic>
+      <p:sp>
+        <p:nvSpPr>
+          <p:cNvPr id="5" name="TextBox 4"/>
           <p:cNvSpPr txBox="1"/>
           <p:nvPr/>
         </p:nvSpPr>
         <p:spPr>
           <a:xfrm>
-            <a:off x="704088" y="1353312"/>
-            <a:ext cx="7744968" cy="3300984"/>
+            <a:off x="704088" y="4434840"/>
+            <a:ext cx="7744968" cy="457200"/>
           </a:xfrm>
           <a:prstGeom prst="rect">
             <a:avLst/>
@@ -8135,115 +8220,14 @@
           </a:bodyPr>
           <a:lstStyle/>
           <a:p>
-            <a:pPr>
-              <a:lnSpc>
-                <a:spcPct val="112000"/>
-              </a:lnSpc>
-              <a:spcAft>
-                <a:spcPts val="900"/>
-              </a:spcAft>
-            </a:pPr>
-            <a:r>
-              <a:rPr sz="1800" b="1">
-                <a:solidFill>
-                  <a:srgbClr val="E0A437"/>
-                </a:solidFill>
-                <a:latin typeface="Fira Sans"/>
-              </a:rPr>
-              <a:t>▸ </a:t>
-            </a:r>
-            <a:r>
-              <a:rPr sz="1800" b="0">
-                <a:solidFill>
-                  <a:srgbClr val="000000"/>
-                </a:solidFill>
-                <a:latin typeface="Fira Sans"/>
-              </a:rPr>
-              <a:t>Jupyter: notebooks que mezclan texto, código y resultados; el formato en que trabajaremos todas las clases.</a:t>
-            </a:r>
-          </a:p>
-          <a:p>
-            <a:pPr>
-              <a:lnSpc>
-                <a:spcPct val="112000"/>
-              </a:lnSpc>
-              <a:spcAft>
-                <a:spcPts val="900"/>
-              </a:spcAft>
-            </a:pPr>
-            <a:r>
-              <a:rPr sz="1800" b="1">
-                <a:solidFill>
-                  <a:srgbClr val="E0A437"/>
-                </a:solidFill>
-                <a:latin typeface="Fira Sans"/>
-              </a:rPr>
-              <a:t>▸ </a:t>
-            </a:r>
-            <a:r>
-              <a:rPr sz="1800" b="0">
-                <a:solidFill>
-                  <a:srgbClr val="000000"/>
-                </a:solidFill>
-                <a:latin typeface="Fira Sans"/>
-              </a:rPr>
-              <a:t>uv: administra Python, los paquetes y sus versiones, para que todo el curso trabaje con el mismo entorno.</a:t>
-            </a:r>
-          </a:p>
-          <a:p>
-            <a:pPr>
-              <a:lnSpc>
-                <a:spcPct val="112000"/>
-              </a:lnSpc>
-              <a:spcAft>
-                <a:spcPts val="900"/>
-              </a:spcAft>
-            </a:pPr>
-            <a:r>
-              <a:rPr sz="1800" b="1">
-                <a:solidFill>
-                  <a:srgbClr val="E0A437"/>
-                </a:solidFill>
-                <a:latin typeface="Fira Sans"/>
-              </a:rPr>
-              <a:t>▸ </a:t>
-            </a:r>
-            <a:r>
-              <a:rPr sz="1800" b="0">
-                <a:solidFill>
-                  <a:srgbClr val="000000"/>
-                </a:solidFill>
-                <a:latin typeface="Fira Sans"/>
-              </a:rPr>
-              <a:t>Alternativa sin instalar nada: Google Colab ejecuta los mismos notebooks en la nube.</a:t>
-            </a:r>
-          </a:p>
-          <a:p>
-            <a:pPr>
-              <a:lnSpc>
-                <a:spcPct val="112000"/>
-              </a:lnSpc>
-              <a:spcAft>
-                <a:spcPts val="900"/>
-              </a:spcAft>
-            </a:pPr>
-            <a:r>
-              <a:rPr sz="1800" b="1">
-                <a:solidFill>
-                  <a:srgbClr val="E0A437"/>
-                </a:solidFill>
-                <a:latin typeface="Fira Sans"/>
-              </a:rPr>
-              <a:t>▸ </a:t>
-            </a:r>
-            <a:r>
-              <a:rPr sz="1800" b="0">
-                <a:solidFill>
-                  <a:srgbClr val="000000"/>
-                </a:solidFill>
-                <a:latin typeface="Fira Sans"/>
-              </a:rPr>
-              <a:t>Todo el material queda en el repositorio del módulo: github.com/daniopitz/diplomado-cdd</a:t>
+            <a:r>
+              <a:rPr sz="1300" b="0">
+                <a:solidFill>
+                  <a:srgbClr val="333333"/>
+                </a:solidFill>
+                <a:latin typeface="Fira Sans"/>
+              </a:rPr>
+              <a:t>Este histograma sale de la tabla de viajes con unas seis líneas de código; el notebook de la clase las muestra completas.</a:t>
             </a:r>
           </a:p>
         </p:txBody>
@@ -8339,112 +8323,21 @@
                 </a:solidFill>
                 <a:latin typeface="Fira Sans"/>
               </a:rPr>
-              <a:t>Puesta en marcha del entorno</a:t>
-            </a:r>
-          </a:p>
-        </p:txBody>
-      </p:sp>
-      <p:sp>
-        <p:nvSpPr>
-          <p:cNvPr id="4" name="Rectangle 3"/>
-          <p:cNvSpPr/>
-          <p:nvPr/>
-        </p:nvSpPr>
-        <p:spPr>
-          <a:xfrm>
-            <a:off x="704088" y="1280160"/>
-            <a:ext cx="7744968" cy="2377440"/>
-          </a:xfrm>
-          <a:prstGeom prst="rect">
-            <a:avLst/>
-          </a:prstGeom>
-          <a:solidFill>
-            <a:srgbClr val="F0F2F5"/>
-          </a:solidFill>
-          <a:ln>
-            <a:solidFill>
-              <a:srgbClr val="D8DDE3"/>
-            </a:solidFill>
-          </a:ln>
-          <a:effectLst/>
-        </p:spPr>
-        <p:style>
-          <a:lnRef idx="1">
-            <a:schemeClr val="accent1"/>
-          </a:lnRef>
-          <a:fillRef idx="3">
-            <a:schemeClr val="accent1"/>
-          </a:fillRef>
-          <a:effectRef idx="2">
-            <a:schemeClr val="accent1"/>
-          </a:effectRef>
-          <a:fontRef idx="minor">
-            <a:schemeClr val="lt1"/>
-          </a:fontRef>
-        </p:style>
-        <p:txBody>
-          <a:bodyPr rtlCol="0" anchor="ctr" wrap="square" lIns="228600" tIns="137160"/>
-          <a:lstStyle/>
-          <a:p>
-            <a:pPr/>
-            <a:r>
-              <a:rPr sz="1500" b="0">
-                <a:solidFill>
-                  <a:srgbClr val="1D3557"/>
-                </a:solidFill>
-                <a:latin typeface="Menlo"/>
-              </a:rPr>
-              <a:t>uv init --bare --python 3.12</a:t>
-            </a:r>
-          </a:p>
-          <a:p>
-            <a:pPr/>
-            <a:r>
-              <a:rPr sz="1500" b="0">
-                <a:solidFill>
-                  <a:srgbClr val="1D3557"/>
-                </a:solidFill>
-                <a:latin typeface="Menlo"/>
-              </a:rPr>
-              <a:t>uv add numpy pandas matplotlib seaborn scipy</a:t>
-            </a:r>
-          </a:p>
-          <a:p>
-            <a:pPr/>
-            <a:r>
-              <a:rPr sz="1500" b="0">
-                <a:solidFill>
-                  <a:srgbClr val="1D3557"/>
-                </a:solidFill>
-                <a:latin typeface="Menlo"/>
-              </a:rPr>
-              <a:t>uv add statsmodels scikit-learn jupyterlab</a:t>
-            </a:r>
-          </a:p>
-          <a:p>
-            <a:pPr/>
-            <a:r>
-              <a:rPr sz="1500" b="0">
-                <a:solidFill>
-                  <a:srgbClr val="1D3557"/>
-                </a:solidFill>
-                <a:latin typeface="Menlo"/>
-              </a:rPr>
-              <a:t>uv run jupyter lab</a:t>
-            </a:r>
-          </a:p>
-        </p:txBody>
-      </p:sp>
-      <p:sp>
-        <p:nvSpPr>
-          <p:cNvPr id="5" name="TextBox 4"/>
+              <a:t>Jupyter y uv: el entorno de trabajo</a:t>
+            </a:r>
+          </a:p>
+        </p:txBody>
+      </p:sp>
+      <p:sp>
+        <p:nvSpPr>
+          <p:cNvPr id="4" name="TextBox 3"/>
           <p:cNvSpPr txBox="1"/>
           <p:nvPr/>
         </p:nvSpPr>
         <p:spPr>
           <a:xfrm>
-            <a:off x="704088" y="3886200"/>
-            <a:ext cx="7744968" cy="1097280"/>
+            <a:off x="704088" y="1353312"/>
+            <a:ext cx="7744968" cy="3300984"/>
           </a:xfrm>
           <a:prstGeom prst="rect">
             <a:avLst/>
@@ -8466,7 +8359,7 @@
               </a:spcAft>
             </a:pPr>
             <a:r>
-              <a:rPr sz="1600" b="1">
+              <a:rPr sz="1800" b="1">
                 <a:solidFill>
                   <a:srgbClr val="E0A437"/>
                 </a:solidFill>
@@ -8475,13 +8368,97 @@
               <a:t>▸ </a:t>
             </a:r>
             <a:r>
-              <a:rPr sz="1600" b="0">
+              <a:rPr sz="1800" b="0">
                 <a:solidFill>
                   <a:srgbClr val="000000"/>
                 </a:solidFill>
                 <a:latin typeface="Fira Sans"/>
               </a:rPr>
-              <a:t>La guía de instalación del repositorio detalla estos pasos por sistema operativo y los problemas frecuentes. Lo hacemos juntos ahora; debe quedar funcionando antes de la clase 2.</a:t>
+              <a:t>Jupyter: notebooks que mezclan texto, código y resultados; el formato en que trabajaremos todas las clases.</a:t>
+            </a:r>
+          </a:p>
+          <a:p>
+            <a:pPr>
+              <a:lnSpc>
+                <a:spcPct val="112000"/>
+              </a:lnSpc>
+              <a:spcAft>
+                <a:spcPts val="900"/>
+              </a:spcAft>
+            </a:pPr>
+            <a:r>
+              <a:rPr sz="1800" b="1">
+                <a:solidFill>
+                  <a:srgbClr val="E0A437"/>
+                </a:solidFill>
+                <a:latin typeface="Fira Sans"/>
+              </a:rPr>
+              <a:t>▸ </a:t>
+            </a:r>
+            <a:r>
+              <a:rPr sz="1800" b="0">
+                <a:solidFill>
+                  <a:srgbClr val="000000"/>
+                </a:solidFill>
+                <a:latin typeface="Fira Sans"/>
+              </a:rPr>
+              <a:t>uv: administra Python, los paquetes y sus versiones, para que todo el curso trabaje con el mismo entorno.</a:t>
+            </a:r>
+          </a:p>
+          <a:p>
+            <a:pPr>
+              <a:lnSpc>
+                <a:spcPct val="112000"/>
+              </a:lnSpc>
+              <a:spcAft>
+                <a:spcPts val="900"/>
+              </a:spcAft>
+            </a:pPr>
+            <a:r>
+              <a:rPr sz="1800" b="1">
+                <a:solidFill>
+                  <a:srgbClr val="E0A437"/>
+                </a:solidFill>
+                <a:latin typeface="Fira Sans"/>
+              </a:rPr>
+              <a:t>▸ </a:t>
+            </a:r>
+            <a:r>
+              <a:rPr sz="1800" b="0">
+                <a:solidFill>
+                  <a:srgbClr val="000000"/>
+                </a:solidFill>
+                <a:latin typeface="Fira Sans"/>
+              </a:rPr>
+              <a:t>Alternativa sin instalar nada: Google Colab ejecuta los mismos notebooks en la nube.</a:t>
+            </a:r>
+          </a:p>
+          <a:p>
+            <a:pPr>
+              <a:lnSpc>
+                <a:spcPct val="112000"/>
+              </a:lnSpc>
+              <a:spcAft>
+                <a:spcPts val="900"/>
+              </a:spcAft>
+            </a:pPr>
+            <a:r>
+              <a:rPr sz="1800" b="1">
+                <a:solidFill>
+                  <a:srgbClr val="E0A437"/>
+                </a:solidFill>
+                <a:latin typeface="Fira Sans"/>
+              </a:rPr>
+              <a:t>▸ </a:t>
+            </a:r>
+            <a:r>
+              <a:rPr sz="1800" b="0">
+                <a:solidFill>
+                  <a:srgbClr val="000000"/>
+                </a:solidFill>
+                <a:latin typeface="Fira Sans"/>
+              </a:rPr>
+              <a:t>Todo el material queda en el repositorio del módulo: github.com/daniopitz/diplomado-cdd</a:t>
             </a:r>
           </a:p>
         </p:txBody>
@@ -8577,21 +8554,112 @@
                 </a:solidFill>
                 <a:latin typeface="Fira Sans"/>
               </a:rPr>
-              <a:t>Manos al teclado: el notebook de hoy</a:t>
-            </a:r>
-          </a:p>
-        </p:txBody>
-      </p:sp>
-      <p:sp>
-        <p:nvSpPr>
-          <p:cNvPr id="4" name="TextBox 3"/>
+              <a:t>Puesta en marcha del entorno</a:t>
+            </a:r>
+          </a:p>
+        </p:txBody>
+      </p:sp>
+      <p:sp>
+        <p:nvSpPr>
+          <p:cNvPr id="4" name="Rectangle 3"/>
+          <p:cNvSpPr/>
+          <p:nvPr/>
+        </p:nvSpPr>
+        <p:spPr>
+          <a:xfrm>
+            <a:off x="704088" y="1280160"/>
+            <a:ext cx="7744968" cy="2377440"/>
+          </a:xfrm>
+          <a:prstGeom prst="rect">
+            <a:avLst/>
+          </a:prstGeom>
+          <a:solidFill>
+            <a:srgbClr val="F0F2F5"/>
+          </a:solidFill>
+          <a:ln>
+            <a:solidFill>
+              <a:srgbClr val="D8DDE3"/>
+            </a:solidFill>
+          </a:ln>
+          <a:effectLst/>
+        </p:spPr>
+        <p:style>
+          <a:lnRef idx="1">
+            <a:schemeClr val="accent1"/>
+          </a:lnRef>
+          <a:fillRef idx="3">
+            <a:schemeClr val="accent1"/>
+          </a:fillRef>
+          <a:effectRef idx="2">
+            <a:schemeClr val="accent1"/>
+          </a:effectRef>
+          <a:fontRef idx="minor">
+            <a:schemeClr val="lt1"/>
+          </a:fontRef>
+        </p:style>
+        <p:txBody>
+          <a:bodyPr rtlCol="0" anchor="ctr" wrap="square" lIns="228600" tIns="137160"/>
+          <a:lstStyle/>
+          <a:p>
+            <a:pPr/>
+            <a:r>
+              <a:rPr sz="1500" b="0">
+                <a:solidFill>
+                  <a:srgbClr val="1D3557"/>
+                </a:solidFill>
+                <a:latin typeface="Menlo"/>
+              </a:rPr>
+              <a:t>uv init --bare --python 3.12</a:t>
+            </a:r>
+          </a:p>
+          <a:p>
+            <a:pPr/>
+            <a:r>
+              <a:rPr sz="1500" b="0">
+                <a:solidFill>
+                  <a:srgbClr val="1D3557"/>
+                </a:solidFill>
+                <a:latin typeface="Menlo"/>
+              </a:rPr>
+              <a:t>uv add numpy pandas matplotlib seaborn scipy</a:t>
+            </a:r>
+          </a:p>
+          <a:p>
+            <a:pPr/>
+            <a:r>
+              <a:rPr sz="1500" b="0">
+                <a:solidFill>
+                  <a:srgbClr val="1D3557"/>
+                </a:solidFill>
+                <a:latin typeface="Menlo"/>
+              </a:rPr>
+              <a:t>uv add statsmodels scikit-learn jupyterlab</a:t>
+            </a:r>
+          </a:p>
+          <a:p>
+            <a:pPr/>
+            <a:r>
+              <a:rPr sz="1500" b="0">
+                <a:solidFill>
+                  <a:srgbClr val="1D3557"/>
+                </a:solidFill>
+                <a:latin typeface="Menlo"/>
+              </a:rPr>
+              <a:t>uv run jupyter lab</a:t>
+            </a:r>
+          </a:p>
+        </p:txBody>
+      </p:sp>
+      <p:sp>
+        <p:nvSpPr>
+          <p:cNvPr id="5" name="TextBox 4"/>
           <p:cNvSpPr txBox="1"/>
           <p:nvPr/>
         </p:nvSpPr>
         <p:spPr>
           <a:xfrm>
-            <a:off x="704088" y="1353312"/>
-            <a:ext cx="7744968" cy="3300984"/>
+            <a:off x="704088" y="3886200"/>
+            <a:ext cx="7744968" cy="1097280"/>
           </a:xfrm>
           <a:prstGeom prst="rect">
             <a:avLst/>
@@ -8613,7 +8681,7 @@
               </a:spcAft>
             </a:pPr>
             <a:r>
-              <a:rPr sz="1800" b="1">
+              <a:rPr sz="1600" b="1">
                 <a:solidFill>
                   <a:srgbClr val="E0A437"/>
                 </a:solidFill>
@@ -8622,125 +8690,13 @@
               <a:t>▸ </a:t>
             </a:r>
             <a:r>
-              <a:rPr sz="1800" b="0">
+              <a:rPr sz="1600" b="0">
                 <a:solidFill>
                   <a:srgbClr val="000000"/>
                 </a:solidFill>
                 <a:latin typeface="Fira Sans"/>
               </a:rPr>
-              <a:t>Abrimos el notebook 01 del repositorio (o en Colab, con el enlace del README).</a:t>
-            </a:r>
-          </a:p>
-          <a:p>
-            <a:pPr>
-              <a:lnSpc>
-                <a:spcPct val="112000"/>
-              </a:lnSpc>
-              <a:spcAft>
-                <a:spcPts val="900"/>
-              </a:spcAft>
-            </a:pPr>
-            <a:r>
-              <a:rPr sz="1800" b="1">
-                <a:solidFill>
-                  <a:srgbClr val="E0A437"/>
-                </a:solidFill>
-                <a:latin typeface="Fira Sans"/>
-              </a:rPr>
-              <a:t>▸ </a:t>
-            </a:r>
-            <a:r>
-              <a:rPr sz="1800" b="0">
-                <a:solidFill>
-                  <a:srgbClr val="000000"/>
-                </a:solidFill>
-                <a:latin typeface="Fira Sans"/>
-              </a:rPr>
-              <a:t>Leeremos la tabla de viajes de la EOD desde una URL: shape, head, info.</a:t>
-            </a:r>
-          </a:p>
-          <a:p>
-            <a:pPr>
-              <a:lnSpc>
-                <a:spcPct val="112000"/>
-              </a:lnSpc>
-              <a:spcAft>
-                <a:spcPts val="900"/>
-              </a:spcAft>
-            </a:pPr>
-            <a:r>
-              <a:rPr sz="1800" b="1">
-                <a:solidFill>
-                  <a:srgbClr val="E0A437"/>
-                </a:solidFill>
-                <a:latin typeface="Fira Sans"/>
-              </a:rPr>
-              <a:t>▸ </a:t>
-            </a:r>
-            <a:r>
-              <a:rPr sz="1800" b="0">
-                <a:solidFill>
-                  <a:srgbClr val="000000"/>
-                </a:solidFill>
-                <a:latin typeface="Fira Sans"/>
-              </a:rPr>
-              <a:t>Variables cualitativas: contar con value_counts, resolver códigos contra las tablas de parámetros y recalcular el reparto modal en vivo.</a:t>
-            </a:r>
-          </a:p>
-          <a:p>
-            <a:pPr>
-              <a:lnSpc>
-                <a:spcPct val="112000"/>
-              </a:lnSpc>
-              <a:spcAft>
-                <a:spcPts val="900"/>
-              </a:spcAft>
-            </a:pPr>
-            <a:r>
-              <a:rPr sz="1800" b="1">
-                <a:solidFill>
-                  <a:srgbClr val="E0A437"/>
-                </a:solidFill>
-                <a:latin typeface="Fira Sans"/>
-              </a:rPr>
-              <a:t>▸ </a:t>
-            </a:r>
-            <a:r>
-              <a:rPr sz="1800" b="0">
-                <a:solidFill>
-                  <a:srgbClr val="000000"/>
-                </a:solidFill>
-                <a:latin typeface="Fira Sans"/>
-              </a:rPr>
-              <a:t>Variables cuantitativas: describe y el histograma de duración de los viajes; y una discreta, los viajes por persona.</a:t>
-            </a:r>
-          </a:p>
-          <a:p>
-            <a:pPr>
-              <a:lnSpc>
-                <a:spcPct val="112000"/>
-              </a:lnSpc>
-              <a:spcAft>
-                <a:spcPts val="900"/>
-              </a:spcAft>
-            </a:pPr>
-            <a:r>
-              <a:rPr sz="1800" b="1">
-                <a:solidFill>
-                  <a:srgbClr val="E0A437"/>
-                </a:solidFill>
-                <a:latin typeface="Fira Sans"/>
-              </a:rPr>
-              <a:t>▸ </a:t>
-            </a:r>
-            <a:r>
-              <a:rPr sz="1800" b="1">
-                <a:solidFill>
-                  <a:srgbClr val="1D3557"/>
-                </a:solidFill>
-                <a:latin typeface="Fira Sans"/>
-              </a:rPr>
-              <a:t>El hilo es el de la clase: el tipo de cada variable define qué análisis es válido.</a:t>
+              <a:t>La guía de instalación del repositorio detalla estos pasos por sistema operativo y los problemas frecuentes. Lo hacemos juntos ahora; debe quedar funcionando antes de la clase 2.</a:t>
             </a:r>
           </a:p>
         </p:txBody>
@@ -8836,7 +8792,7 @@
                 </a:solidFill>
                 <a:latin typeface="Fira Sans"/>
               </a:rPr>
-              <a:t>Antes de cerrar: su turno</a:t>
+              <a:t>Manos al teclado: el notebook de hoy</a:t>
             </a:r>
           </a:p>
         </p:txBody>
@@ -8881,13 +8837,13 @@
               <a:t>▸ </a:t>
             </a:r>
             <a:r>
-              <a:rPr sz="1800" b="1">
-                <a:solidFill>
-                  <a:srgbClr val="1D3557"/>
-                </a:solidFill>
-                <a:latin typeface="Fira Sans"/>
-              </a:rPr>
-              <a:t>Escriba en el chat una decisión de su trabajo que hoy se toma por intuición y que podría tomarse con datos.</a:t>
+              <a:rPr sz="1800" b="0">
+                <a:solidFill>
+                  <a:srgbClr val="000000"/>
+                </a:solidFill>
+                <a:latin typeface="Fira Sans"/>
+              </a:rPr>
+              <a:t>Notebook 01, del repositorio o en Colab: la tabla de viajes de la EOD por URL, con shape, head e info.</a:t>
             </a:r>
           </a:p>
           <a:p>
@@ -8915,7 +8871,7 @@
                 </a:solidFill>
                 <a:latin typeface="Fira Sans"/>
               </a:rPr>
-              <a:t>Comentaremos dos o tres: cuál sería la pregunta, qué datos harían falta, qué etapa del ciclo sería la difícil.</a:t>
+              <a:t>Cualitativas: contar con value_counts y traducir códigos con merge (comunas y modos), recalculando el reparto modal en vivo.</a:t>
             </a:r>
           </a:p>
           <a:p>
@@ -8943,7 +8899,63 @@
                 </a:solidFill>
                 <a:latin typeface="Fira Sans"/>
               </a:rPr>
-              <a:t>Guarde la suya: puede ser el germen de su proyecto final.</a:t>
+              <a:t>Cuantitativas: describe y el histograma de duración; y una discreta, los viajes por persona.</a:t>
+            </a:r>
+          </a:p>
+          <a:p>
+            <a:pPr>
+              <a:lnSpc>
+                <a:spcPct val="112000"/>
+              </a:lnSpc>
+              <a:spcAft>
+                <a:spcPts val="900"/>
+              </a:spcAft>
+            </a:pPr>
+            <a:r>
+              <a:rPr sz="1800" b="1">
+                <a:solidFill>
+                  <a:srgbClr val="E0A437"/>
+                </a:solidFill>
+                <a:latin typeface="Fira Sans"/>
+              </a:rPr>
+              <a:t>▸ </a:t>
+            </a:r>
+            <a:r>
+              <a:rPr sz="1800" b="0">
+                <a:solidFill>
+                  <a:srgbClr val="000000"/>
+                </a:solidFill>
+                <a:latin typeface="Fira Sans"/>
+              </a:rPr>
+              <a:t>Cruce de ambas: la duración media por comuna, con groupby.</a:t>
+            </a:r>
+          </a:p>
+          <a:p>
+            <a:pPr>
+              <a:lnSpc>
+                <a:spcPct val="112000"/>
+              </a:lnSpc>
+              <a:spcAft>
+                <a:spcPts val="900"/>
+              </a:spcAft>
+            </a:pPr>
+            <a:r>
+              <a:rPr sz="1800" b="1">
+                <a:solidFill>
+                  <a:srgbClr val="E0A437"/>
+                </a:solidFill>
+                <a:latin typeface="Fira Sans"/>
+              </a:rPr>
+              <a:t>▸ </a:t>
+            </a:r>
+            <a:r>
+              <a:rPr sz="1800" b="1">
+                <a:solidFill>
+                  <a:srgbClr val="1D3557"/>
+                </a:solidFill>
+                <a:latin typeface="Fira Sans"/>
+              </a:rPr>
+              <a:t>El hilo es el de la clase: el tipo de cada variable define qué análisis es válido.</a:t>
             </a:r>
           </a:p>
         </p:txBody>
@@ -8957,6 +8969,209 @@
 </file>
 
 <file path=ppt/slides/slide36.xml><?xml version="1.0" encoding="utf-8"?>
+<p:sld xmlns:a="http://schemas.openxmlformats.org/drawingml/2006/main" xmlns:p="http://schemas.openxmlformats.org/presentationml/2006/main" xmlns:r="http://schemas.openxmlformats.org/officeDocument/2006/relationships">
+  <p:cSld>
+    <p:spTree>
+      <p:nvGrpSpPr>
+        <p:cNvPr id="1" name=""/>
+        <p:cNvGrpSpPr/>
+        <p:nvPr/>
+      </p:nvGrpSpPr>
+      <p:grpSpPr/>
+      <p:sp>
+        <p:nvSpPr>
+          <p:cNvPr id="2" name="Rectangle 1"/>
+          <p:cNvSpPr/>
+          <p:nvPr/>
+        </p:nvSpPr>
+        <p:spPr>
+          <a:xfrm>
+            <a:off x="0" y="0"/>
+            <a:ext cx="9144000" cy="5138928"/>
+          </a:xfrm>
+          <a:prstGeom prst="rect">
+            <a:avLst/>
+          </a:prstGeom>
+          <a:solidFill>
+            <a:srgbClr val="FAFBFC"/>
+          </a:solidFill>
+          <a:ln>
+            <a:noFill/>
+          </a:ln>
+          <a:effectLst/>
+        </p:spPr>
+        <p:style>
+          <a:lnRef idx="1">
+            <a:schemeClr val="accent1"/>
+          </a:lnRef>
+          <a:fillRef idx="3">
+            <a:schemeClr val="accent1"/>
+          </a:fillRef>
+          <a:effectRef idx="2">
+            <a:schemeClr val="accent1"/>
+          </a:effectRef>
+          <a:fontRef idx="minor">
+            <a:schemeClr val="lt1"/>
+          </a:fontRef>
+        </p:style>
+        <p:txBody>
+          <a:bodyPr rtlCol="0" anchor="ctr"/>
+          <a:lstStyle/>
+          <a:p>
+            <a:pPr algn="ctr"/>
+          </a:p>
+        </p:txBody>
+      </p:sp>
+      <p:sp>
+        <p:nvSpPr>
+          <p:cNvPr id="3" name="TextBox 2"/>
+          <p:cNvSpPr txBox="1"/>
+          <p:nvPr/>
+        </p:nvSpPr>
+        <p:spPr>
+          <a:xfrm>
+            <a:off x="402336" y="301752"/>
+            <a:ext cx="8348472" cy="795528"/>
+          </a:xfrm>
+          <a:prstGeom prst="rect">
+            <a:avLst/>
+          </a:prstGeom>
+          <a:noFill/>
+        </p:spPr>
+        <p:txBody>
+          <a:bodyPr wrap="square">
+            <a:spAutoFit/>
+          </a:bodyPr>
+          <a:lstStyle/>
+          <a:p>
+            <a:r>
+              <a:rPr sz="2800" b="1">
+                <a:solidFill>
+                  <a:srgbClr val="0F0F0F"/>
+                </a:solidFill>
+                <a:latin typeface="Fira Sans"/>
+              </a:rPr>
+              <a:t>Antes de cerrar: su turno</a:t>
+            </a:r>
+          </a:p>
+        </p:txBody>
+      </p:sp>
+      <p:sp>
+        <p:nvSpPr>
+          <p:cNvPr id="4" name="TextBox 3"/>
+          <p:cNvSpPr txBox="1"/>
+          <p:nvPr/>
+        </p:nvSpPr>
+        <p:spPr>
+          <a:xfrm>
+            <a:off x="704088" y="1353312"/>
+            <a:ext cx="7744968" cy="3300984"/>
+          </a:xfrm>
+          <a:prstGeom prst="rect">
+            <a:avLst/>
+          </a:prstGeom>
+          <a:noFill/>
+        </p:spPr>
+        <p:txBody>
+          <a:bodyPr wrap="square">
+            <a:spAutoFit/>
+          </a:bodyPr>
+          <a:lstStyle/>
+          <a:p>
+            <a:pPr>
+              <a:lnSpc>
+                <a:spcPct val="112000"/>
+              </a:lnSpc>
+              <a:spcAft>
+                <a:spcPts val="900"/>
+              </a:spcAft>
+            </a:pPr>
+            <a:r>
+              <a:rPr sz="1800" b="1">
+                <a:solidFill>
+                  <a:srgbClr val="E0A437"/>
+                </a:solidFill>
+                <a:latin typeface="Fira Sans"/>
+              </a:rPr>
+              <a:t>▸ </a:t>
+            </a:r>
+            <a:r>
+              <a:rPr sz="1800" b="1">
+                <a:solidFill>
+                  <a:srgbClr val="1D3557"/>
+                </a:solidFill>
+                <a:latin typeface="Fira Sans"/>
+              </a:rPr>
+              <a:t>Escriba en el chat una decisión de su trabajo que hoy se toma por intuición y que podría tomarse con datos.</a:t>
+            </a:r>
+          </a:p>
+          <a:p>
+            <a:pPr>
+              <a:lnSpc>
+                <a:spcPct val="112000"/>
+              </a:lnSpc>
+              <a:spcAft>
+                <a:spcPts val="900"/>
+              </a:spcAft>
+            </a:pPr>
+            <a:r>
+              <a:rPr sz="1800" b="1">
+                <a:solidFill>
+                  <a:srgbClr val="E0A437"/>
+                </a:solidFill>
+                <a:latin typeface="Fira Sans"/>
+              </a:rPr>
+              <a:t>▸ </a:t>
+            </a:r>
+            <a:r>
+              <a:rPr sz="1800" b="0">
+                <a:solidFill>
+                  <a:srgbClr val="000000"/>
+                </a:solidFill>
+                <a:latin typeface="Fira Sans"/>
+              </a:rPr>
+              <a:t>Comentaremos dos o tres: cuál sería la pregunta, qué datos harían falta, qué etapa del ciclo sería la difícil.</a:t>
+            </a:r>
+          </a:p>
+          <a:p>
+            <a:pPr>
+              <a:lnSpc>
+                <a:spcPct val="112000"/>
+              </a:lnSpc>
+              <a:spcAft>
+                <a:spcPts val="900"/>
+              </a:spcAft>
+            </a:pPr>
+            <a:r>
+              <a:rPr sz="1800" b="1">
+                <a:solidFill>
+                  <a:srgbClr val="E0A437"/>
+                </a:solidFill>
+                <a:latin typeface="Fira Sans"/>
+              </a:rPr>
+              <a:t>▸ </a:t>
+            </a:r>
+            <a:r>
+              <a:rPr sz="1800" b="0">
+                <a:solidFill>
+                  <a:srgbClr val="000000"/>
+                </a:solidFill>
+                <a:latin typeface="Fira Sans"/>
+              </a:rPr>
+              <a:t>Guarde la suya: puede ser el germen de su proyecto final.</a:t>
+            </a:r>
+          </a:p>
+        </p:txBody>
+      </p:sp>
+    </p:spTree>
+  </p:cSld>
+  <p:clrMapOvr>
+    <a:masterClrMapping/>
+  </p:clrMapOvr>
+</p:sld>
+</file>
+
+<file path=ppt/slides/slide37.xml><?xml version="1.0" encoding="utf-8"?>
 <p:sld xmlns:a="http://schemas.openxmlformats.org/drawingml/2006/main" xmlns:p="http://schemas.openxmlformats.org/presentationml/2006/main" xmlns:r="http://schemas.openxmlformats.org/officeDocument/2006/relationships">
   <p:cSld>
     <p:spTree>

</xml_diff>

<commit_message>
Reparto modal con las categorías Bip! agrupadas en una sola, en figura y notebook
Co-Authored-By: Claude Fable 5 <noreply@anthropic.com>
</commit_message>
<xml_diff>
--- a/presentaciones/clase01_fundamentos_ecosistema.pptx
+++ b/presentaciones/clase01_fundamentos_ecosistema.pptx
@@ -10026,8 +10026,8 @@
         </p:blipFill>
         <p:spPr>
           <a:xfrm>
-            <a:off x="1718083" y="1143000"/>
-            <a:ext cx="5707832" cy="3154680"/>
+            <a:off x="1604462" y="1143000"/>
+            <a:ext cx="5935075" cy="3154680"/>
           </a:xfrm>
           <a:prstGeom prst="rect">
             <a:avLst/>

</xml_diff>

<commit_message>
Revisión de contenido de la clase 1: lenguaje técnico en notebooks y slides, tres slides redundantes eliminadas, entradas del ciclo corregidas
Co-Authored-By: Claude Fable 5 <noreply@anthropic.com>
</commit_message>
<xml_diff>
--- a/presentaciones/clase01_fundamentos_ecosistema.pptx
+++ b/presentaciones/clase01_fundamentos_ecosistema.pptx
@@ -34,9 +34,6 @@
     <p:sldId id="282" r:id="rId33"/>
     <p:sldId id="283" r:id="rId34"/>
     <p:sldId id="284" r:id="rId35"/>
-    <p:sldId id="285" r:id="rId36"/>
-    <p:sldId id="286" r:id="rId37"/>
-    <p:sldId id="287" r:id="rId38"/>
   </p:sldIdLst>
   <p:sldSz cx="9144000" cy="5138928" type="screen4x3"/>
   <p:notesSz cx="6858000" cy="9144000"/>
@@ -3444,7 +3441,7 @@
                 </a:solidFill>
                 <a:latin typeface="Fira Sans"/>
               </a:rPr>
-              <a:t>No es una línea de montaje: los hallazgos de una etapa devuelven el proyecto a etapas anteriores.</a:t>
+              <a:t>El ciclo tiene dos entradas: una necesidad del dominio o datos ya disponibles. Los hallazgos de una etapa pueden devolver el proyecto a etapas anteriores.</a:t>
             </a:r>
           </a:p>
         </p:txBody>
@@ -3540,7 +3537,7 @@
                 </a:solidFill>
                 <a:latin typeface="Fira Sans"/>
               </a:rPr>
-              <a:t>El ciclo, aplicado al episodio de Snow</a:t>
+              <a:t>Tres advertencias sobre el ciclo</a:t>
             </a:r>
           </a:p>
         </p:txBody>
@@ -3591,7 +3588,7 @@
                 </a:solidFill>
                 <a:latin typeface="Fira Sans"/>
               </a:rPr>
-              <a:t>Pregunta: ¿dónde vivían los muertos del brote?</a:t>
+              <a:t>Cargar y limpiar datos consume en promedio el 45% del tiempo de trabajo, más que el modelamiento (Anaconda, 2020; encuesta a 2.360 profesionales).</a:t>
             </a:r>
           </a:p>
           <a:p>
@@ -3619,7 +3616,7 @@
                 </a:solidFill>
                 <a:latin typeface="Fira Sans"/>
               </a:rPr>
-              <a:t>Obtención: los registros de defunciones del barrio, casa por casa.</a:t>
+              <a:t>El ciclo se recorre varias veces: un hallazgo cambia la pregunta y una limpieza revela problemas nuevos.</a:t>
             </a:r>
           </a:p>
           <a:p>
@@ -3647,91 +3644,7 @@
                 </a:solidFill>
                 <a:latin typeface="Fira Sans"/>
               </a:rPr>
-              <a:t>Exploración: cada muerte marcada sobre el mapa de Soho.</a:t>
-            </a:r>
-          </a:p>
-          <a:p>
-            <a:pPr>
-              <a:lnSpc>
-                <a:spcPct val="112000"/>
-              </a:lnSpc>
-              <a:spcAft>
-                <a:spcPts val="900"/>
-              </a:spcAft>
-            </a:pPr>
-            <a:r>
-              <a:rPr sz="1800" b="1">
-                <a:solidFill>
-                  <a:srgbClr val="E0A437"/>
-                </a:solidFill>
-                <a:latin typeface="Fira Sans"/>
-              </a:rPr>
-              <a:t>▸ </a:t>
-            </a:r>
-            <a:r>
-              <a:rPr sz="1800" b="0">
-                <a:solidFill>
-                  <a:srgbClr val="000000"/>
-                </a:solidFill>
-                <a:latin typeface="Fira Sans"/>
-              </a:rPr>
-              <a:t>Análisis: la concentración alrededor de la bomba de Broad Street.</a:t>
-            </a:r>
-          </a:p>
-          <a:p>
-            <a:pPr>
-              <a:lnSpc>
-                <a:spcPct val="112000"/>
-              </a:lnSpc>
-              <a:spcAft>
-                <a:spcPts val="900"/>
-              </a:spcAft>
-            </a:pPr>
-            <a:r>
-              <a:rPr sz="1800" b="1">
-                <a:solidFill>
-                  <a:srgbClr val="E0A437"/>
-                </a:solidFill>
-                <a:latin typeface="Fira Sans"/>
-              </a:rPr>
-              <a:t>▸ </a:t>
-            </a:r>
-            <a:r>
-              <a:rPr sz="1800" b="0">
-                <a:solidFill>
-                  <a:srgbClr val="000000"/>
-                </a:solidFill>
-                <a:latin typeface="Fira Sans"/>
-              </a:rPr>
-              <a:t>Comunicación y decisión: el informe a las autoridades y el retiro de la palanca de la bomba.</a:t>
-            </a:r>
-          </a:p>
-          <a:p>
-            <a:pPr>
-              <a:lnSpc>
-                <a:spcPct val="112000"/>
-              </a:lnSpc>
-              <a:spcAft>
-                <a:spcPts val="900"/>
-              </a:spcAft>
-            </a:pPr>
-            <a:r>
-              <a:rPr sz="1800" b="1">
-                <a:solidFill>
-                  <a:srgbClr val="E0A437"/>
-                </a:solidFill>
-                <a:latin typeface="Fira Sans"/>
-              </a:rPr>
-              <a:t>▸ </a:t>
-            </a:r>
-            <a:r>
-              <a:rPr sz="1800" b="1">
-                <a:solidFill>
-                  <a:srgbClr val="1D3557"/>
-                </a:solidFill>
-                <a:latin typeface="Fira Sans"/>
-              </a:rPr>
-              <a:t>El mismo recorrido que haremos hoy con datos de Santiago, en el notebook.</a:t>
+              <a:t>Un error en la formulación del problema invalida las etapas posteriores; conviene revisarla antes de invertir en el resto.</a:t>
             </a:r>
           </a:p>
         </p:txBody>
@@ -3827,7 +3740,7 @@
                 </a:solidFill>
                 <a:latin typeface="Fira Sans"/>
               </a:rPr>
-              <a:t>Tres advertencias sobre el ciclo</a:t>
+              <a:t>El proyecto final del módulo</a:t>
             </a:r>
           </a:p>
         </p:txBody>
@@ -3878,7 +3791,7 @@
                 </a:solidFill>
                 <a:latin typeface="Fira Sans"/>
               </a:rPr>
-              <a:t>La mayor parte del tiempo se va en obtener, limpiar y entender los datos, no en modelar: conviene planificar con eso en mente.</a:t>
+              <a:t>El módulo se evalúa con un proyecto aplicado sobre datos reales, que recorre el ciclo completo: pregunta, datos, exploración, análisis y comunicación.</a:t>
             </a:r>
           </a:p>
           <a:p>
@@ -3906,7 +3819,7 @@
                 </a:solidFill>
                 <a:latin typeface="Fira Sans"/>
               </a:rPr>
-              <a:t>El ciclo se recorre varias veces: un hallazgo cambia la pregunta, una limpieza revela problemas nuevos.</a:t>
+              <a:t>Puede usar datos de su propio trabajo o un conjunto de datos público.</a:t>
             </a:r>
           </a:p>
           <a:p>
@@ -3928,13 +3841,41 @@
               <a:t>▸ </a:t>
             </a:r>
             <a:r>
+              <a:rPr sz="1800" b="1">
+                <a:solidFill>
+                  <a:srgbClr val="1D3557"/>
+                </a:solidFill>
+                <a:latin typeface="Fira Sans"/>
+              </a:rPr>
+              <a:t>Desde hoy: anote las preguntas de su trabajo que le gustaría responder con datos.</a:t>
+            </a:r>
+          </a:p>
+          <a:p>
+            <a:pPr>
+              <a:lnSpc>
+                <a:spcPct val="112000"/>
+              </a:lnSpc>
+              <a:spcAft>
+                <a:spcPts val="900"/>
+              </a:spcAft>
+            </a:pPr>
+            <a:r>
+              <a:rPr sz="1800" b="1">
+                <a:solidFill>
+                  <a:srgbClr val="E0A437"/>
+                </a:solidFill>
+                <a:latin typeface="Fira Sans"/>
+              </a:rPr>
+              <a:t>▸ </a:t>
+            </a:r>
+            <a:r>
               <a:rPr sz="1800" b="0">
                 <a:solidFill>
                   <a:srgbClr val="000000"/>
                 </a:solidFill>
                 <a:latin typeface="Fira Sans"/>
               </a:rPr>
-              <a:t>La etapa más barata de arreglar es la primera: una pregunta mal planteada invalida todo lo que sigue.</a:t>
+              <a:t>El enunciado y la pauta se publican en las próximas clases.</a:t>
             </a:r>
           </a:p>
         </p:txBody>
@@ -3972,7 +3913,7 @@
             <a:avLst/>
           </a:prstGeom>
           <a:solidFill>
-            <a:srgbClr val="FAFBFC"/>
+            <a:srgbClr val="1D3557"/>
           </a:solidFill>
           <a:ln>
             <a:noFill/>
@@ -4009,8 +3950,8 @@
         </p:nvSpPr>
         <p:spPr>
           <a:xfrm>
-            <a:off x="402336" y="301752"/>
-            <a:ext cx="8348472" cy="795528"/>
+            <a:off x="603504" y="1847088"/>
+            <a:ext cx="7946136" cy="1399032"/>
           </a:xfrm>
           <a:prstGeom prst="rect">
             <a:avLst/>
@@ -4024,148 +3965,24 @@
           <a:lstStyle/>
           <a:p>
             <a:r>
-              <a:rPr sz="2800" b="1">
-                <a:solidFill>
-                  <a:srgbClr val="0F0F0F"/>
-                </a:solidFill>
-                <a:latin typeface="Fira Sans"/>
-              </a:rPr>
-              <a:t>El proyecto final del módulo</a:t>
-            </a:r>
-          </a:p>
-        </p:txBody>
-      </p:sp>
-      <p:sp>
-        <p:nvSpPr>
-          <p:cNvPr id="4" name="TextBox 3"/>
-          <p:cNvSpPr txBox="1"/>
-          <p:nvPr/>
-        </p:nvSpPr>
-        <p:spPr>
-          <a:xfrm>
-            <a:off x="704088" y="1353312"/>
-            <a:ext cx="7744968" cy="3300984"/>
-          </a:xfrm>
-          <a:prstGeom prst="rect">
-            <a:avLst/>
-          </a:prstGeom>
-          <a:noFill/>
-        </p:spPr>
-        <p:txBody>
-          <a:bodyPr wrap="square">
-            <a:spAutoFit/>
-          </a:bodyPr>
-          <a:lstStyle/>
-          <a:p>
-            <a:pPr>
-              <a:lnSpc>
-                <a:spcPct val="112000"/>
-              </a:lnSpc>
-              <a:spcAft>
-                <a:spcPts val="900"/>
-              </a:spcAft>
-            </a:pPr>
-            <a:r>
-              <a:rPr sz="1800" b="1">
+              <a:rPr sz="3400" b="1">
+                <a:solidFill>
+                  <a:srgbClr val="FFFFFF"/>
+                </a:solidFill>
+                <a:latin typeface="Fira Sans"/>
+              </a:rPr>
+              <a:t>Tipos de datos y tipos de variables</a:t>
+            </a:r>
+          </a:p>
+          <a:p>
+            <a:r>
+              <a:rPr sz="1800" b="0">
                 <a:solidFill>
                   <a:srgbClr val="E0A437"/>
                 </a:solidFill>
                 <a:latin typeface="Fira Sans"/>
               </a:rPr>
-              <a:t>▸ </a:t>
-            </a:r>
-            <a:r>
-              <a:rPr sz="1800" b="0">
-                <a:solidFill>
-                  <a:srgbClr val="000000"/>
-                </a:solidFill>
-                <a:latin typeface="Fira Sans"/>
-              </a:rPr>
-              <a:t>El módulo se evalúa con un proyecto aplicado sobre datos reales, que recorre el ciclo completo: pregunta, datos, exploración, análisis y comunicación.</a:t>
-            </a:r>
-          </a:p>
-          <a:p>
-            <a:pPr>
-              <a:lnSpc>
-                <a:spcPct val="112000"/>
-              </a:lnSpc>
-              <a:spcAft>
-                <a:spcPts val="900"/>
-              </a:spcAft>
-            </a:pPr>
-            <a:r>
-              <a:rPr sz="1800" b="1">
-                <a:solidFill>
-                  <a:srgbClr val="E0A437"/>
-                </a:solidFill>
-                <a:latin typeface="Fira Sans"/>
-              </a:rPr>
-              <a:t>▸ </a:t>
-            </a:r>
-            <a:r>
-              <a:rPr sz="1800" b="0">
-                <a:solidFill>
-                  <a:srgbClr val="000000"/>
-                </a:solidFill>
-                <a:latin typeface="Fira Sans"/>
-              </a:rPr>
-              <a:t>Puede usar datos de su propio trabajo o un conjunto de datos público.</a:t>
-            </a:r>
-          </a:p>
-          <a:p>
-            <a:pPr>
-              <a:lnSpc>
-                <a:spcPct val="112000"/>
-              </a:lnSpc>
-              <a:spcAft>
-                <a:spcPts val="900"/>
-              </a:spcAft>
-            </a:pPr>
-            <a:r>
-              <a:rPr sz="1800" b="1">
-                <a:solidFill>
-                  <a:srgbClr val="E0A437"/>
-                </a:solidFill>
-                <a:latin typeface="Fira Sans"/>
-              </a:rPr>
-              <a:t>▸ </a:t>
-            </a:r>
-            <a:r>
-              <a:rPr sz="1800" b="1">
-                <a:solidFill>
-                  <a:srgbClr val="1D3557"/>
-                </a:solidFill>
-                <a:latin typeface="Fira Sans"/>
-              </a:rPr>
-              <a:t>Desde hoy: anote las preguntas de su trabajo que le gustaría responder con datos.</a:t>
-            </a:r>
-          </a:p>
-          <a:p>
-            <a:pPr>
-              <a:lnSpc>
-                <a:spcPct val="112000"/>
-              </a:lnSpc>
-              <a:spcAft>
-                <a:spcPts val="900"/>
-              </a:spcAft>
-            </a:pPr>
-            <a:r>
-              <a:rPr sz="1800" b="1">
-                <a:solidFill>
-                  <a:srgbClr val="E0A437"/>
-                </a:solidFill>
-                <a:latin typeface="Fira Sans"/>
-              </a:rPr>
-              <a:t>▸ </a:t>
-            </a:r>
-            <a:r>
-              <a:rPr sz="1800" b="0">
-                <a:solidFill>
-                  <a:srgbClr val="000000"/>
-                </a:solidFill>
-                <a:latin typeface="Fira Sans"/>
-              </a:rPr>
-              <a:t>El enunciado y la pauta se publican en las próximas clases.</a:t>
+              <a:t>Qué análisis admite cada columna</a:t>
             </a:r>
           </a:p>
         </p:txBody>
@@ -4203,7 +4020,7 @@
             <a:avLst/>
           </a:prstGeom>
           <a:solidFill>
-            <a:srgbClr val="1D3557"/>
+            <a:srgbClr val="FAFBFC"/>
           </a:solidFill>
           <a:ln>
             <a:noFill/>
@@ -4240,8 +4057,8 @@
         </p:nvSpPr>
         <p:spPr>
           <a:xfrm>
-            <a:off x="603504" y="1847088"/>
-            <a:ext cx="7946136" cy="1399032"/>
+            <a:off x="402336" y="301752"/>
+            <a:ext cx="8348472" cy="795528"/>
           </a:xfrm>
           <a:prstGeom prst="rect">
             <a:avLst/>
@@ -4255,24 +4072,120 @@
           <a:lstStyle/>
           <a:p>
             <a:r>
-              <a:rPr sz="3400" b="1">
-                <a:solidFill>
-                  <a:srgbClr val="FFFFFF"/>
-                </a:solidFill>
-                <a:latin typeface="Fira Sans"/>
-              </a:rPr>
-              <a:t>Tipos de datos y tipos de variables</a:t>
-            </a:r>
-          </a:p>
-          <a:p>
+              <a:rPr sz="2800" b="1">
+                <a:solidFill>
+                  <a:srgbClr val="0F0F0F"/>
+                </a:solidFill>
+                <a:latin typeface="Fira Sans"/>
+              </a:rPr>
+              <a:t>Datos estructurados y no estructurados</a:t>
+            </a:r>
+          </a:p>
+        </p:txBody>
+      </p:sp>
+      <p:sp>
+        <p:nvSpPr>
+          <p:cNvPr id="4" name="TextBox 3"/>
+          <p:cNvSpPr txBox="1"/>
+          <p:nvPr/>
+        </p:nvSpPr>
+        <p:spPr>
+          <a:xfrm>
+            <a:off x="704088" y="1353312"/>
+            <a:ext cx="7744968" cy="3300984"/>
+          </a:xfrm>
+          <a:prstGeom prst="rect">
+            <a:avLst/>
+          </a:prstGeom>
+          <a:noFill/>
+        </p:spPr>
+        <p:txBody>
+          <a:bodyPr wrap="square">
+            <a:spAutoFit/>
+          </a:bodyPr>
+          <a:lstStyle/>
+          <a:p>
+            <a:pPr>
+              <a:lnSpc>
+                <a:spcPct val="112000"/>
+              </a:lnSpc>
+              <a:spcAft>
+                <a:spcPts val="900"/>
+              </a:spcAft>
+            </a:pPr>
+            <a:r>
+              <a:rPr sz="1800" b="1">
+                <a:solidFill>
+                  <a:srgbClr val="E0A437"/>
+                </a:solidFill>
+                <a:latin typeface="Fira Sans"/>
+              </a:rPr>
+              <a:t>▸ </a:t>
+            </a:r>
             <a:r>
               <a:rPr sz="1800" b="0">
                 <a:solidFill>
+                  <a:srgbClr val="000000"/>
+                </a:solidFill>
+                <a:latin typeface="Fira Sans"/>
+              </a:rPr>
+              <a:t>Estructurados: tablas con filas y columnas (la EOD, una base de ventas, un registro de sensores). Son el foco de este módulo.</a:t>
+            </a:r>
+          </a:p>
+          <a:p>
+            <a:pPr>
+              <a:lnSpc>
+                <a:spcPct val="112000"/>
+              </a:lnSpc>
+              <a:spcAft>
+                <a:spcPts val="900"/>
+              </a:spcAft>
+            </a:pPr>
+            <a:r>
+              <a:rPr sz="1800" b="1">
+                <a:solidFill>
                   <a:srgbClr val="E0A437"/>
                 </a:solidFill>
                 <a:latin typeface="Fira Sans"/>
               </a:rPr>
-              <a:t>Qué análisis admite cada columna</a:t>
+              <a:t>▸ </a:t>
+            </a:r>
+            <a:r>
+              <a:rPr sz="1800" b="0">
+                <a:solidFill>
+                  <a:srgbClr val="000000"/>
+                </a:solidFill>
+                <a:latin typeface="Fira Sans"/>
+              </a:rPr>
+              <a:t>No estructurados: texto libre, imágenes, audio. Se trabajan en los módulos de machine learning y deep learning del diplomado.</a:t>
+            </a:r>
+          </a:p>
+          <a:p>
+            <a:pPr>
+              <a:lnSpc>
+                <a:spcPct val="112000"/>
+              </a:lnSpc>
+              <a:spcAft>
+                <a:spcPts val="900"/>
+              </a:spcAft>
+            </a:pPr>
+            <a:r>
+              <a:rPr sz="1800" b="1">
+                <a:solidFill>
+                  <a:srgbClr val="E0A437"/>
+                </a:solidFill>
+                <a:latin typeface="Fira Sans"/>
+              </a:rPr>
+              <a:t>▸ </a:t>
+            </a:r>
+            <a:r>
+              <a:rPr sz="1800" b="0">
+                <a:solidFill>
+                  <a:srgbClr val="000000"/>
+                </a:solidFill>
+                <a:latin typeface="Fira Sans"/>
+              </a:rPr>
+              <a:t>En la práctica, analizar datos no estructurados suele requerir convertirlos primero en representaciones tabulares o numéricas.</a:t>
             </a:r>
           </a:p>
         </p:txBody>
@@ -4368,21 +4281,45 @@
                 </a:solidFill>
                 <a:latin typeface="Fira Sans"/>
               </a:rPr>
-              <a:t>Datos estructurados y no estructurados</a:t>
-            </a:r>
-          </a:p>
-        </p:txBody>
-      </p:sp>
-      <p:sp>
-        <p:nvSpPr>
-          <p:cNvPr id="4" name="TextBox 3"/>
+              <a:t>Tipos de variables</a:t>
+            </a:r>
+          </a:p>
+        </p:txBody>
+      </p:sp>
+      <p:pic>
+        <p:nvPicPr>
+          <p:cNvPr id="4" name="Picture 3" descr="04_tipos_variables.png"/>
+          <p:cNvPicPr>
+            <a:picLocks noChangeAspect="1"/>
+          </p:cNvPicPr>
+          <p:nvPr/>
+        </p:nvPicPr>
+        <p:blipFill>
+          <a:blip r:embed="rId2"/>
+          <a:stretch>
+            <a:fillRect/>
+          </a:stretch>
+        </p:blipFill>
+        <p:spPr>
+          <a:xfrm>
+            <a:off x="1423172" y="1143000"/>
+            <a:ext cx="6297654" cy="3154680"/>
+          </a:xfrm>
+          <a:prstGeom prst="rect">
+            <a:avLst/>
+          </a:prstGeom>
+        </p:spPr>
+      </p:pic>
+      <p:sp>
+        <p:nvSpPr>
+          <p:cNvPr id="5" name="TextBox 4"/>
           <p:cNvSpPr txBox="1"/>
           <p:nvPr/>
         </p:nvSpPr>
         <p:spPr>
           <a:xfrm>
-            <a:off x="704088" y="1353312"/>
-            <a:ext cx="7744968" cy="3300984"/>
+            <a:off x="704088" y="4434840"/>
+            <a:ext cx="7744968" cy="457200"/>
           </a:xfrm>
           <a:prstGeom prst="rect">
             <a:avLst/>
@@ -4395,87 +4332,14 @@
           </a:bodyPr>
           <a:lstStyle/>
           <a:p>
-            <a:pPr>
-              <a:lnSpc>
-                <a:spcPct val="112000"/>
-              </a:lnSpc>
-              <a:spcAft>
-                <a:spcPts val="900"/>
-              </a:spcAft>
-            </a:pPr>
-            <a:r>
-              <a:rPr sz="1800" b="1">
-                <a:solidFill>
-                  <a:srgbClr val="E0A437"/>
-                </a:solidFill>
-                <a:latin typeface="Fira Sans"/>
-              </a:rPr>
-              <a:t>▸ </a:t>
-            </a:r>
-            <a:r>
-              <a:rPr sz="1800" b="0">
-                <a:solidFill>
-                  <a:srgbClr val="000000"/>
-                </a:solidFill>
-                <a:latin typeface="Fira Sans"/>
-              </a:rPr>
-              <a:t>Estructurados: tablas con filas y columnas (la EOD, una base de ventas, un registro de sensores). Son el foco de este módulo.</a:t>
-            </a:r>
-          </a:p>
-          <a:p>
-            <a:pPr>
-              <a:lnSpc>
-                <a:spcPct val="112000"/>
-              </a:lnSpc>
-              <a:spcAft>
-                <a:spcPts val="900"/>
-              </a:spcAft>
-            </a:pPr>
-            <a:r>
-              <a:rPr sz="1800" b="1">
-                <a:solidFill>
-                  <a:srgbClr val="E0A437"/>
-                </a:solidFill>
-                <a:latin typeface="Fira Sans"/>
-              </a:rPr>
-              <a:t>▸ </a:t>
-            </a:r>
-            <a:r>
-              <a:rPr sz="1800" b="0">
-                <a:solidFill>
-                  <a:srgbClr val="000000"/>
-                </a:solidFill>
-                <a:latin typeface="Fira Sans"/>
-              </a:rPr>
-              <a:t>No estructurados: texto libre, imágenes, audio. Se trabajan en los módulos de machine learning y deep learning del diplomado.</a:t>
-            </a:r>
-          </a:p>
-          <a:p>
-            <a:pPr>
-              <a:lnSpc>
-                <a:spcPct val="112000"/>
-              </a:lnSpc>
-              <a:spcAft>
-                <a:spcPts val="900"/>
-              </a:spcAft>
-            </a:pPr>
-            <a:r>
-              <a:rPr sz="1800" b="1">
-                <a:solidFill>
-                  <a:srgbClr val="E0A437"/>
-                </a:solidFill>
-                <a:latin typeface="Fira Sans"/>
-              </a:rPr>
-              <a:t>▸ </a:t>
-            </a:r>
-            <a:r>
-              <a:rPr sz="1800" b="0">
-                <a:solidFill>
-                  <a:srgbClr val="000000"/>
-                </a:solidFill>
-                <a:latin typeface="Fira Sans"/>
-              </a:rPr>
-              <a:t>Frontera práctica: casi todo análisis termina convirtiendo lo no estructurado en una tabla.</a:t>
+            <a:r>
+              <a:rPr sz="1300" b="0">
+                <a:solidFill>
+                  <a:srgbClr val="333333"/>
+                </a:solidFill>
+                <a:latin typeface="Fira Sans"/>
+              </a:rPr>
+              <a:t>La misma tabla mezcla los cuatro tipos; cada columna se analiza según el suyo.</a:t>
             </a:r>
           </a:p>
         </p:txBody>
@@ -4571,45 +4435,21 @@
                 </a:solidFill>
                 <a:latin typeface="Fira Sans"/>
               </a:rPr>
-              <a:t>Tipos de variables</a:t>
-            </a:r>
-          </a:p>
-        </p:txBody>
-      </p:sp>
-      <p:pic>
-        <p:nvPicPr>
-          <p:cNvPr id="4" name="Picture 3" descr="04_tipos_variables.png"/>
-          <p:cNvPicPr>
-            <a:picLocks noChangeAspect="1"/>
-          </p:cNvPicPr>
-          <p:nvPr/>
-        </p:nvPicPr>
-        <p:blipFill>
-          <a:blip r:embed="rId2"/>
-          <a:stretch>
-            <a:fillRect/>
-          </a:stretch>
-        </p:blipFill>
-        <p:spPr>
-          <a:xfrm>
-            <a:off x="1423172" y="1143000"/>
-            <a:ext cx="6297654" cy="3154680"/>
-          </a:xfrm>
-          <a:prstGeom prst="rect">
-            <a:avLst/>
-          </a:prstGeom>
-        </p:spPr>
-      </p:pic>
-      <p:sp>
-        <p:nvSpPr>
-          <p:cNvPr id="5" name="TextBox 4"/>
+              <a:t>Códigos numéricos: variables nominales</a:t>
+            </a:r>
+          </a:p>
+        </p:txBody>
+      </p:sp>
+      <p:sp>
+        <p:nvSpPr>
+          <p:cNvPr id="4" name="TextBox 3"/>
           <p:cNvSpPr txBox="1"/>
           <p:nvPr/>
         </p:nvSpPr>
         <p:spPr>
           <a:xfrm>
-            <a:off x="704088" y="4434840"/>
-            <a:ext cx="7744968" cy="457200"/>
+            <a:off x="704088" y="1353312"/>
+            <a:ext cx="7744968" cy="3300984"/>
           </a:xfrm>
           <a:prstGeom prst="rect">
             <a:avLst/>
@@ -4622,14 +4462,115 @@
           </a:bodyPr>
           <a:lstStyle/>
           <a:p>
-            <a:r>
-              <a:rPr sz="1300" b="0">
-                <a:solidFill>
-                  <a:srgbClr val="333333"/>
-                </a:solidFill>
-                <a:latin typeface="Fira Sans"/>
-              </a:rPr>
-              <a:t>La misma tabla mezcla los cuatro tipos; cada columna se analiza según el suyo.</a:t>
+            <a:pPr>
+              <a:lnSpc>
+                <a:spcPct val="112000"/>
+              </a:lnSpc>
+              <a:spcAft>
+                <a:spcPts val="900"/>
+              </a:spcAft>
+            </a:pPr>
+            <a:r>
+              <a:rPr sz="1800" b="1">
+                <a:solidFill>
+                  <a:srgbClr val="E0A437"/>
+                </a:solidFill>
+                <a:latin typeface="Fira Sans"/>
+              </a:rPr>
+              <a:t>▸ </a:t>
+            </a:r>
+            <a:r>
+              <a:rPr sz="1800" b="0">
+                <a:solidFill>
+                  <a:srgbClr val="000000"/>
+                </a:solidFill>
+                <a:latin typeface="Fira Sans"/>
+              </a:rPr>
+              <a:t>En la encuesta de viajes que exploraremos hoy en el notebook, la columna ComunaOrigen vale 94, 71, 13... pero es una variable nominal: los números son códigos de comuna.</a:t>
+            </a:r>
+          </a:p>
+          <a:p>
+            <a:pPr>
+              <a:lnSpc>
+                <a:spcPct val="112000"/>
+              </a:lnSpc>
+              <a:spcAft>
+                <a:spcPts val="900"/>
+              </a:spcAft>
+            </a:pPr>
+            <a:r>
+              <a:rPr sz="1800" b="1">
+                <a:solidFill>
+                  <a:srgbClr val="E0A437"/>
+                </a:solidFill>
+                <a:latin typeface="Fira Sans"/>
+              </a:rPr>
+              <a:t>▸ </a:t>
+            </a:r>
+            <a:r>
+              <a:rPr sz="1800" b="0">
+                <a:solidFill>
+                  <a:srgbClr val="000000"/>
+                </a:solidFill>
+                <a:latin typeface="Fira Sans"/>
+              </a:rPr>
+              <a:t>Promediar códigos de comuna no significa nada; contar viajes por comuna, sí.</a:t>
+            </a:r>
+          </a:p>
+          <a:p>
+            <a:pPr>
+              <a:lnSpc>
+                <a:spcPct val="112000"/>
+              </a:lnSpc>
+              <a:spcAft>
+                <a:spcPts val="900"/>
+              </a:spcAft>
+            </a:pPr>
+            <a:r>
+              <a:rPr sz="1800" b="1">
+                <a:solidFill>
+                  <a:srgbClr val="E0A437"/>
+                </a:solidFill>
+                <a:latin typeface="Fira Sans"/>
+              </a:rPr>
+              <a:t>▸ </a:t>
+            </a:r>
+            <a:r>
+              <a:rPr sz="1800" b="1">
+                <a:solidFill>
+                  <a:srgbClr val="1D3557"/>
+                </a:solidFill>
+                <a:latin typeface="Fira Sans"/>
+              </a:rPr>
+              <a:t>El tipo de la variable define qué resumen y qué gráfico son válidos: es lo primero que se revisa al abrir una tabla.</a:t>
+            </a:r>
+          </a:p>
+          <a:p>
+            <a:pPr>
+              <a:lnSpc>
+                <a:spcPct val="112000"/>
+              </a:lnSpc>
+              <a:spcAft>
+                <a:spcPts val="900"/>
+              </a:spcAft>
+            </a:pPr>
+            <a:r>
+              <a:rPr sz="1800" b="1">
+                <a:solidFill>
+                  <a:srgbClr val="E0A437"/>
+                </a:solidFill>
+                <a:latin typeface="Fira Sans"/>
+              </a:rPr>
+              <a:t>▸ </a:t>
+            </a:r>
+            <a:r>
+              <a:rPr sz="1800" b="0">
+                <a:solidFill>
+                  <a:srgbClr val="000000"/>
+                </a:solidFill>
+                <a:latin typeface="Fira Sans"/>
+              </a:rPr>
+              <a:t>En la clase 2 esto se vuelve operativo: cada resumen de la estadística descriptiva aplica a ciertos tipos de variables.</a:t>
             </a:r>
           </a:p>
         </p:txBody>
@@ -4667,7 +4608,7 @@
             <a:avLst/>
           </a:prstGeom>
           <a:solidFill>
-            <a:srgbClr val="FAFBFC"/>
+            <a:srgbClr val="1D3557"/>
           </a:solidFill>
           <a:ln>
             <a:noFill/>
@@ -4704,8 +4645,8 @@
         </p:nvSpPr>
         <p:spPr>
           <a:xfrm>
-            <a:off x="402336" y="301752"/>
-            <a:ext cx="8348472" cy="795528"/>
+            <a:off x="603504" y="1847088"/>
+            <a:ext cx="7946136" cy="1399032"/>
           </a:xfrm>
           <a:prstGeom prst="rect">
             <a:avLst/>
@@ -4719,148 +4660,24 @@
           <a:lstStyle/>
           <a:p>
             <a:r>
-              <a:rPr sz="2800" b="1">
-                <a:solidFill>
-                  <a:srgbClr val="0F0F0F"/>
-                </a:solidFill>
-                <a:latin typeface="Fira Sans"/>
-              </a:rPr>
-              <a:t>Códigos numéricos: variables nominales</a:t>
-            </a:r>
-          </a:p>
-        </p:txBody>
-      </p:sp>
-      <p:sp>
-        <p:nvSpPr>
-          <p:cNvPr id="4" name="TextBox 3"/>
-          <p:cNvSpPr txBox="1"/>
-          <p:nvPr/>
-        </p:nvSpPr>
-        <p:spPr>
-          <a:xfrm>
-            <a:off x="704088" y="1353312"/>
-            <a:ext cx="7744968" cy="3300984"/>
-          </a:xfrm>
-          <a:prstGeom prst="rect">
-            <a:avLst/>
-          </a:prstGeom>
-          <a:noFill/>
-        </p:spPr>
-        <p:txBody>
-          <a:bodyPr wrap="square">
-            <a:spAutoFit/>
-          </a:bodyPr>
-          <a:lstStyle/>
-          <a:p>
-            <a:pPr>
-              <a:lnSpc>
-                <a:spcPct val="112000"/>
-              </a:lnSpc>
-              <a:spcAft>
-                <a:spcPts val="900"/>
-              </a:spcAft>
-            </a:pPr>
-            <a:r>
-              <a:rPr sz="1800" b="1">
+              <a:rPr sz="3400" b="1">
+                <a:solidFill>
+                  <a:srgbClr val="FFFFFF"/>
+                </a:solidFill>
+                <a:latin typeface="Fira Sans"/>
+              </a:rPr>
+              <a:t>Recreo</a:t>
+            </a:r>
+          </a:p>
+          <a:p>
+            <a:r>
+              <a:rPr sz="1800" b="0">
                 <a:solidFill>
                   <a:srgbClr val="E0A437"/>
                 </a:solidFill>
                 <a:latin typeface="Fira Sans"/>
               </a:rPr>
-              <a:t>▸ </a:t>
-            </a:r>
-            <a:r>
-              <a:rPr sz="1800" b="0">
-                <a:solidFill>
-                  <a:srgbClr val="000000"/>
-                </a:solidFill>
-                <a:latin typeface="Fira Sans"/>
-              </a:rPr>
-              <a:t>En la encuesta de viajes que exploraremos hoy en el notebook, la columna ComunaOrigen vale 94, 71, 13... pero es una variable nominal: los números son códigos de comuna.</a:t>
-            </a:r>
-          </a:p>
-          <a:p>
-            <a:pPr>
-              <a:lnSpc>
-                <a:spcPct val="112000"/>
-              </a:lnSpc>
-              <a:spcAft>
-                <a:spcPts val="900"/>
-              </a:spcAft>
-            </a:pPr>
-            <a:r>
-              <a:rPr sz="1800" b="1">
-                <a:solidFill>
-                  <a:srgbClr val="E0A437"/>
-                </a:solidFill>
-                <a:latin typeface="Fira Sans"/>
-              </a:rPr>
-              <a:t>▸ </a:t>
-            </a:r>
-            <a:r>
-              <a:rPr sz="1800" b="0">
-                <a:solidFill>
-                  <a:srgbClr val="000000"/>
-                </a:solidFill>
-                <a:latin typeface="Fira Sans"/>
-              </a:rPr>
-              <a:t>Promediar códigos de comuna no significa nada; contar viajes por comuna, sí.</a:t>
-            </a:r>
-          </a:p>
-          <a:p>
-            <a:pPr>
-              <a:lnSpc>
-                <a:spcPct val="112000"/>
-              </a:lnSpc>
-              <a:spcAft>
-                <a:spcPts val="900"/>
-              </a:spcAft>
-            </a:pPr>
-            <a:r>
-              <a:rPr sz="1800" b="1">
-                <a:solidFill>
-                  <a:srgbClr val="E0A437"/>
-                </a:solidFill>
-                <a:latin typeface="Fira Sans"/>
-              </a:rPr>
-              <a:t>▸ </a:t>
-            </a:r>
-            <a:r>
-              <a:rPr sz="1800" b="1">
-                <a:solidFill>
-                  <a:srgbClr val="1D3557"/>
-                </a:solidFill>
-                <a:latin typeface="Fira Sans"/>
-              </a:rPr>
-              <a:t>El tipo de la variable define qué resumen y qué gráfico son válidos: es lo primero que se revisa al abrir una tabla.</a:t>
-            </a:r>
-          </a:p>
-          <a:p>
-            <a:pPr>
-              <a:lnSpc>
-                <a:spcPct val="112000"/>
-              </a:lnSpc>
-              <a:spcAft>
-                <a:spcPts val="900"/>
-              </a:spcAft>
-            </a:pPr>
-            <a:r>
-              <a:rPr sz="1800" b="1">
-                <a:solidFill>
-                  <a:srgbClr val="E0A437"/>
-                </a:solidFill>
-                <a:latin typeface="Fira Sans"/>
-              </a:rPr>
-              <a:t>▸ </a:t>
-            </a:r>
-            <a:r>
-              <a:rPr sz="1800" b="0">
-                <a:solidFill>
-                  <a:srgbClr val="000000"/>
-                </a:solidFill>
-                <a:latin typeface="Fira Sans"/>
-              </a:rPr>
-              <a:t>En la clase 2 esto se vuelve operativo: cada resumen de la estadística descriptiva aplica a ciertos tipos de variables.</a:t>
+              <a:t>10 minutos</a:t>
             </a:r>
           </a:p>
         </p:txBody>
@@ -4956,7 +4773,7 @@
                 </a:solidFill>
                 <a:latin typeface="Fira Sans"/>
               </a:rPr>
-              <a:t>Recreo</a:t>
+              <a:t>El ecosistema Python</a:t>
             </a:r>
           </a:p>
           <a:p>
@@ -4967,7 +4784,7 @@
                 </a:solidFill>
                 <a:latin typeface="Fira Sans"/>
               </a:rPr>
-              <a:t>10 minutos</a:t>
+              <a:t>NumPy, Pandas y Matplotlib, más Jupyter y uv</a:t>
             </a:r>
           </a:p>
         </p:txBody>
@@ -5005,7 +4822,7 @@
             <a:avLst/>
           </a:prstGeom>
           <a:solidFill>
-            <a:srgbClr val="1D3557"/>
+            <a:srgbClr val="FAFBFC"/>
           </a:solidFill>
           <a:ln>
             <a:noFill/>
@@ -5042,8 +4859,8 @@
         </p:nvSpPr>
         <p:spPr>
           <a:xfrm>
-            <a:off x="603504" y="1847088"/>
-            <a:ext cx="7946136" cy="1399032"/>
+            <a:off x="402336" y="301752"/>
+            <a:ext cx="8348472" cy="795528"/>
           </a:xfrm>
           <a:prstGeom prst="rect">
             <a:avLst/>
@@ -5057,24 +4874,71 @@
           <a:lstStyle/>
           <a:p>
             <a:r>
-              <a:rPr sz="3400" b="1">
-                <a:solidFill>
-                  <a:srgbClr val="FFFFFF"/>
-                </a:solidFill>
-                <a:latin typeface="Fira Sans"/>
-              </a:rPr>
-              <a:t>El ecosistema Python</a:t>
-            </a:r>
-          </a:p>
-          <a:p>
-            <a:r>
-              <a:rPr sz="1800" b="0">
-                <a:solidFill>
-                  <a:srgbClr val="E0A437"/>
-                </a:solidFill>
-                <a:latin typeface="Fira Sans"/>
-              </a:rPr>
-              <a:t>NumPy, Pandas y Matplotlib, más Jupyter y uv</a:t>
+              <a:rPr sz="2800" b="1">
+                <a:solidFill>
+                  <a:srgbClr val="0F0F0F"/>
+                </a:solidFill>
+                <a:latin typeface="Fira Sans"/>
+              </a:rPr>
+              <a:t>Las herramientas del módulo</a:t>
+            </a:r>
+          </a:p>
+        </p:txBody>
+      </p:sp>
+      <p:pic>
+        <p:nvPicPr>
+          <p:cNvPr id="4" name="Picture 3" descr="05_ecosistema.png"/>
+          <p:cNvPicPr>
+            <a:picLocks noChangeAspect="1"/>
+          </p:cNvPicPr>
+          <p:nvPr/>
+        </p:nvPicPr>
+        <p:blipFill>
+          <a:blip r:embed="rId2"/>
+          <a:stretch>
+            <a:fillRect/>
+          </a:stretch>
+        </p:blipFill>
+        <p:spPr>
+          <a:xfrm>
+            <a:off x="1417319" y="1143000"/>
+            <a:ext cx="6309360" cy="2814584"/>
+          </a:xfrm>
+          <a:prstGeom prst="rect">
+            <a:avLst/>
+          </a:prstGeom>
+        </p:spPr>
+      </p:pic>
+      <p:sp>
+        <p:nvSpPr>
+          <p:cNvPr id="5" name="TextBox 4"/>
+          <p:cNvSpPr txBox="1"/>
+          <p:nvPr/>
+        </p:nvSpPr>
+        <p:spPr>
+          <a:xfrm>
+            <a:off x="704088" y="4434840"/>
+            <a:ext cx="7744968" cy="457200"/>
+          </a:xfrm>
+          <a:prstGeom prst="rect">
+            <a:avLst/>
+          </a:prstGeom>
+          <a:noFill/>
+        </p:spPr>
+        <p:txBody>
+          <a:bodyPr wrap="square">
+            <a:spAutoFit/>
+          </a:bodyPr>
+          <a:lstStyle/>
+          <a:p>
+            <a:r>
+              <a:rPr sz="1300" b="0">
+                <a:solidFill>
+                  <a:srgbClr val="333333"/>
+                </a:solidFill>
+                <a:latin typeface="Fira Sans"/>
+              </a:rPr>
+              <a:t>Python trae la sintaxis; NumPy, Pandas y Matplotlib traen el trabajo con datos. Jupyter y uv son el entorno donde todo corre.</a:t>
             </a:r>
           </a:p>
         </p:txBody>
@@ -5429,35 +5293,90 @@
                 </a:solidFill>
                 <a:latin typeface="Fira Sans"/>
               </a:rPr>
-              <a:t>Las herramientas del módulo</a:t>
-            </a:r>
-          </a:p>
-        </p:txBody>
-      </p:sp>
-      <p:pic>
-        <p:nvPicPr>
-          <p:cNvPr id="4" name="Picture 3" descr="05_ecosistema.png"/>
-          <p:cNvPicPr>
-            <a:picLocks noChangeAspect="1"/>
-          </p:cNvPicPr>
-          <p:nvPr/>
-        </p:nvPicPr>
-        <p:blipFill>
-          <a:blip r:embed="rId2"/>
-          <a:stretch>
-            <a:fillRect/>
-          </a:stretch>
-        </p:blipFill>
-        <p:spPr>
-          <a:xfrm>
-            <a:off x="1417319" y="1143000"/>
-            <a:ext cx="6309360" cy="2814584"/>
-          </a:xfrm>
-          <a:prstGeom prst="rect">
-            <a:avLst/>
-          </a:prstGeom>
-        </p:spPr>
-      </p:pic>
+              <a:t>NumPy: cálculo sobre arreglos completos</a:t>
+            </a:r>
+          </a:p>
+        </p:txBody>
+      </p:sp>
+      <p:sp>
+        <p:nvSpPr>
+          <p:cNvPr id="4" name="Rectangle 3"/>
+          <p:cNvSpPr/>
+          <p:nvPr/>
+        </p:nvSpPr>
+        <p:spPr>
+          <a:xfrm>
+            <a:off x="704088" y="1280160"/>
+            <a:ext cx="7744968" cy="1874520"/>
+          </a:xfrm>
+          <a:prstGeom prst="rect">
+            <a:avLst/>
+          </a:prstGeom>
+          <a:solidFill>
+            <a:srgbClr val="F0F2F5"/>
+          </a:solidFill>
+          <a:ln>
+            <a:solidFill>
+              <a:srgbClr val="D8DDE3"/>
+            </a:solidFill>
+          </a:ln>
+          <a:effectLst/>
+        </p:spPr>
+        <p:style>
+          <a:lnRef idx="1">
+            <a:schemeClr val="accent1"/>
+          </a:lnRef>
+          <a:fillRef idx="3">
+            <a:schemeClr val="accent1"/>
+          </a:fillRef>
+          <a:effectRef idx="2">
+            <a:schemeClr val="accent1"/>
+          </a:effectRef>
+          <a:fontRef idx="minor">
+            <a:schemeClr val="lt1"/>
+          </a:fontRef>
+        </p:style>
+        <p:txBody>
+          <a:bodyPr rtlCol="0" anchor="ctr" wrap="square" lIns="228600" tIns="137160"/>
+          <a:lstStyle/>
+          <a:p>
+            <a:pPr/>
+            <a:r>
+              <a:rPr sz="1500" b="0">
+                <a:solidFill>
+                  <a:srgbClr val="1D3557"/>
+                </a:solidFill>
+                <a:latin typeface="Menlo"/>
+              </a:rPr>
+              <a:t>import numpy as np</a:t>
+            </a:r>
+          </a:p>
+          <a:p>
+            <a:pPr/>
+            <a:r>
+              <a:rPr sz="1500" b="0">
+                <a:solidFill>
+                  <a:srgbClr val="1D3557"/>
+                </a:solidFill>
+                <a:latin typeface="Menlo"/>
+              </a:rPr>
+              <a:t>tiempos = np.array([70, 105, 90, 25, 40])</a:t>
+            </a:r>
+          </a:p>
+          <a:p>
+            <a:pPr/>
+            <a:r>
+              <a:rPr sz="1500" b="0">
+                <a:solidFill>
+                  <a:srgbClr val="1D3557"/>
+                </a:solidFill>
+                <a:latin typeface="Menlo"/>
+              </a:rPr>
+              <a:t>tiempos.mean()          # 66.0, sin escribir un ciclo</a:t>
+            </a:r>
+          </a:p>
+        </p:txBody>
+      </p:sp>
       <p:sp>
         <p:nvSpPr>
           <p:cNvPr id="5" name="TextBox 4"/>
@@ -5466,8 +5385,8 @@
         </p:nvSpPr>
         <p:spPr>
           <a:xfrm>
-            <a:off x="704088" y="4434840"/>
-            <a:ext cx="7744968" cy="457200"/>
+            <a:off x="704088" y="3383279"/>
+            <a:ext cx="7744968" cy="1097280"/>
           </a:xfrm>
           <a:prstGeom prst="rect">
             <a:avLst/>
@@ -5480,14 +5399,31 @@
           </a:bodyPr>
           <a:lstStyle/>
           <a:p>
-            <a:r>
-              <a:rPr sz="1300" b="0">
-                <a:solidFill>
-                  <a:srgbClr val="333333"/>
-                </a:solidFill>
-                <a:latin typeface="Fira Sans"/>
-              </a:rPr>
-              <a:t>Python trae la sintaxis; NumPy, Pandas y Matplotlib traen el trabajo con datos. Jupyter y uv son el entorno donde todo corre.</a:t>
+            <a:pPr>
+              <a:lnSpc>
+                <a:spcPct val="112000"/>
+              </a:lnSpc>
+              <a:spcAft>
+                <a:spcPts val="900"/>
+              </a:spcAft>
+            </a:pPr>
+            <a:r>
+              <a:rPr sz="1600" b="1">
+                <a:solidFill>
+                  <a:srgbClr val="E0A437"/>
+                </a:solidFill>
+                <a:latin typeface="Fira Sans"/>
+              </a:rPr>
+              <a:t>▸ </a:t>
+            </a:r>
+            <a:r>
+              <a:rPr sz="1600" b="0">
+                <a:solidFill>
+                  <a:srgbClr val="000000"/>
+                </a:solidFill>
+                <a:latin typeface="Fira Sans"/>
+              </a:rPr>
+              <a:t>La operación se aplica al arreglo completo (vectorización): menos código y mucho más rápido que iterar en Python puro. Es la base sobre la que se construye todo lo demás.</a:t>
             </a:r>
           </a:p>
         </p:txBody>
@@ -5583,7 +5519,7 @@
                 </a:solidFill>
                 <a:latin typeface="Fira Sans"/>
               </a:rPr>
-              <a:t>NumPy: cálculo sobre arreglos completos</a:t>
+              <a:t>Pandas: la tabla como objeto de trabajo</a:t>
             </a:r>
           </a:p>
         </p:txBody>
@@ -5638,7 +5574,7 @@
                 </a:solidFill>
                 <a:latin typeface="Menlo"/>
               </a:rPr>
-              <a:t>import numpy as np</a:t>
+              <a:t>import pandas as pd</a:t>
             </a:r>
           </a:p>
           <a:p>
@@ -5650,7 +5586,7 @@
                 </a:solidFill>
                 <a:latin typeface="Menlo"/>
               </a:rPr>
-              <a:t>tiempos = np.array([70, 105, 90, 25, 40])</a:t>
+              <a:t>viajes = pd.read_csv(URL_VIAJES, sep=";", decimal=",")</a:t>
             </a:r>
           </a:p>
           <a:p>
@@ -5662,7 +5598,7 @@
                 </a:solidFill>
                 <a:latin typeface="Menlo"/>
               </a:rPr>
-              <a:t>tiempos.mean()          # 66.0, sin escribir un ciclo</a:t>
+              <a:t>viajes.head()</a:t>
             </a:r>
           </a:p>
         </p:txBody>
@@ -5713,7 +5649,7 @@
                 </a:solidFill>
                 <a:latin typeface="Fira Sans"/>
               </a:rPr>
-              <a:t>La operación se aplica al arreglo completo (vectorización): menos código y mucho más rápido que iterar en Python puro. Es la base sobre la que se construye todo lo demás.</a:t>
+              <a:t>El DataFrame es una tabla con columnas etiquetadas, cada una de su propio tipo. Con esas tres líneas se abre la EOD completa: lo haremos en vivo en el notebook de hoy.</a:t>
             </a:r>
           </a:p>
         </p:txBody>
@@ -5809,90 +5745,35 @@
                 </a:solidFill>
                 <a:latin typeface="Fira Sans"/>
               </a:rPr>
-              <a:t>Pandas: la tabla como objeto de trabajo</a:t>
-            </a:r>
-          </a:p>
-        </p:txBody>
-      </p:sp>
-      <p:sp>
-        <p:nvSpPr>
-          <p:cNvPr id="4" name="Rectangle 3"/>
-          <p:cNvSpPr/>
-          <p:nvPr/>
-        </p:nvSpPr>
-        <p:spPr>
-          <a:xfrm>
-            <a:off x="704088" y="1280160"/>
-            <a:ext cx="7744968" cy="1874520"/>
-          </a:xfrm>
-          <a:prstGeom prst="rect">
-            <a:avLst/>
-          </a:prstGeom>
-          <a:solidFill>
-            <a:srgbClr val="F0F2F5"/>
-          </a:solidFill>
-          <a:ln>
-            <a:solidFill>
-              <a:srgbClr val="D8DDE3"/>
-            </a:solidFill>
-          </a:ln>
-          <a:effectLst/>
-        </p:spPr>
-        <p:style>
-          <a:lnRef idx="1">
-            <a:schemeClr val="accent1"/>
-          </a:lnRef>
-          <a:fillRef idx="3">
-            <a:schemeClr val="accent1"/>
-          </a:fillRef>
-          <a:effectRef idx="2">
-            <a:schemeClr val="accent1"/>
-          </a:effectRef>
-          <a:fontRef idx="minor">
-            <a:schemeClr val="lt1"/>
-          </a:fontRef>
-        </p:style>
-        <p:txBody>
-          <a:bodyPr rtlCol="0" anchor="ctr" wrap="square" lIns="228600" tIns="137160"/>
-          <a:lstStyle/>
-          <a:p>
-            <a:pPr/>
-            <a:r>
-              <a:rPr sz="1500" b="0">
-                <a:solidFill>
-                  <a:srgbClr val="1D3557"/>
-                </a:solidFill>
-                <a:latin typeface="Menlo"/>
-              </a:rPr>
-              <a:t>import pandas as pd</a:t>
-            </a:r>
-          </a:p>
-          <a:p>
-            <a:pPr/>
-            <a:r>
-              <a:rPr sz="1500" b="0">
-                <a:solidFill>
-                  <a:srgbClr val="1D3557"/>
-                </a:solidFill>
-                <a:latin typeface="Menlo"/>
-              </a:rPr>
-              <a:t>viajes = pd.read_csv(URL_VIAJES, sep=";", decimal=",")</a:t>
-            </a:r>
-          </a:p>
-          <a:p>
-            <a:pPr/>
-            <a:r>
-              <a:rPr sz="1500" b="0">
-                <a:solidFill>
-                  <a:srgbClr val="1D3557"/>
-                </a:solidFill>
-                <a:latin typeface="Menlo"/>
-              </a:rPr>
-              <a:t>viajes.head()</a:t>
-            </a:r>
-          </a:p>
-        </p:txBody>
-      </p:sp>
+              <a:t>La Encuesta Origen Destino de Santiago 2012</a:t>
+            </a:r>
+          </a:p>
+        </p:txBody>
+      </p:sp>
+      <p:pic>
+        <p:nvPicPr>
+          <p:cNvPr id="4" name="Picture 3" descr="02_df_viajes.png"/>
+          <p:cNvPicPr>
+            <a:picLocks noChangeAspect="1"/>
+          </p:cNvPicPr>
+          <p:nvPr/>
+        </p:nvPicPr>
+        <p:blipFill>
+          <a:blip r:embed="rId2"/>
+          <a:stretch>
+            <a:fillRect/>
+          </a:stretch>
+        </p:blipFill>
+        <p:spPr>
+          <a:xfrm>
+            <a:off x="1417319" y="1143000"/>
+            <a:ext cx="6309360" cy="2296353"/>
+          </a:xfrm>
+          <a:prstGeom prst="rect">
+            <a:avLst/>
+          </a:prstGeom>
+        </p:spPr>
+      </p:pic>
       <p:sp>
         <p:nvSpPr>
           <p:cNvPr id="5" name="TextBox 4"/>
@@ -5901,8 +5782,8 @@
         </p:nvSpPr>
         <p:spPr>
           <a:xfrm>
-            <a:off x="704088" y="3383279"/>
-            <a:ext cx="7744968" cy="1097280"/>
+            <a:off x="704088" y="4434840"/>
+            <a:ext cx="7744968" cy="457200"/>
           </a:xfrm>
           <a:prstGeom prst="rect">
             <a:avLst/>
@@ -5915,31 +5796,14 @@
           </a:bodyPr>
           <a:lstStyle/>
           <a:p>
-            <a:pPr>
-              <a:lnSpc>
-                <a:spcPct val="112000"/>
-              </a:lnSpc>
-              <a:spcAft>
-                <a:spcPts val="900"/>
-              </a:spcAft>
-            </a:pPr>
-            <a:r>
-              <a:rPr sz="1600" b="1">
-                <a:solidFill>
-                  <a:srgbClr val="E0A437"/>
-                </a:solidFill>
-                <a:latin typeface="Fira Sans"/>
-              </a:rPr>
-              <a:t>▸ </a:t>
-            </a:r>
-            <a:r>
-              <a:rPr sz="1600" b="0">
-                <a:solidFill>
-                  <a:srgbClr val="000000"/>
-                </a:solidFill>
-                <a:latin typeface="Fira Sans"/>
-              </a:rPr>
-              <a:t>El DataFrame es una tabla con columnas etiquetadas, cada una de su propio tipo. Con esas tres líneas se abre la EOD completa: lo haremos en vivo en el notebook de hoy.</a:t>
+            <a:r>
+              <a:rPr sz="1300" b="0">
+                <a:solidFill>
+                  <a:srgbClr val="333333"/>
+                </a:solidFill>
+                <a:latin typeface="Fira Sans"/>
+              </a:rPr>
+              <a:t>EOD Santiago 2012: 18.264 hogares, 60.054 personas y 113.591 viajes registrados. Cada fila es un viaje; los códigos se resuelven contra tablas de parámetros.</a:t>
             </a:r>
           </a:p>
         </p:txBody>
@@ -6035,35 +5899,78 @@
                 </a:solidFill>
                 <a:latin typeface="Fira Sans"/>
               </a:rPr>
-              <a:t>La Encuesta Origen Destino de Santiago 2012</a:t>
-            </a:r>
-          </a:p>
-        </p:txBody>
-      </p:sp>
-      <p:pic>
-        <p:nvPicPr>
-          <p:cNvPr id="4" name="Picture 3" descr="02_df_viajes.png"/>
-          <p:cNvPicPr>
-            <a:picLocks noChangeAspect="1"/>
-          </p:cNvPicPr>
-          <p:nvPr/>
-        </p:nvPicPr>
-        <p:blipFill>
-          <a:blip r:embed="rId2"/>
-          <a:stretch>
-            <a:fillRect/>
-          </a:stretch>
-        </p:blipFill>
-        <p:spPr>
-          <a:xfrm>
-            <a:off x="1417319" y="1143000"/>
-            <a:ext cx="6309360" cy="2296353"/>
-          </a:xfrm>
-          <a:prstGeom prst="rect">
-            <a:avLst/>
-          </a:prstGeom>
-        </p:spPr>
-      </p:pic>
+              <a:t>Pandas: unir tablas con merge</a:t>
+            </a:r>
+          </a:p>
+        </p:txBody>
+      </p:sp>
+      <p:sp>
+        <p:nvSpPr>
+          <p:cNvPr id="4" name="Rectangle 3"/>
+          <p:cNvSpPr/>
+          <p:nvPr/>
+        </p:nvSpPr>
+        <p:spPr>
+          <a:xfrm>
+            <a:off x="704088" y="1280160"/>
+            <a:ext cx="7744968" cy="1371600"/>
+          </a:xfrm>
+          <a:prstGeom prst="rect">
+            <a:avLst/>
+          </a:prstGeom>
+          <a:solidFill>
+            <a:srgbClr val="F0F2F5"/>
+          </a:solidFill>
+          <a:ln>
+            <a:solidFill>
+              <a:srgbClr val="D8DDE3"/>
+            </a:solidFill>
+          </a:ln>
+          <a:effectLst/>
+        </p:spPr>
+        <p:style>
+          <a:lnRef idx="1">
+            <a:schemeClr val="accent1"/>
+          </a:lnRef>
+          <a:fillRef idx="3">
+            <a:schemeClr val="accent1"/>
+          </a:fillRef>
+          <a:effectRef idx="2">
+            <a:schemeClr val="accent1"/>
+          </a:effectRef>
+          <a:fontRef idx="minor">
+            <a:schemeClr val="lt1"/>
+          </a:fontRef>
+        </p:style>
+        <p:txBody>
+          <a:bodyPr rtlCol="0" anchor="ctr" wrap="square" lIns="228600" tIns="137160"/>
+          <a:lstStyle/>
+          <a:p>
+            <a:pPr/>
+            <a:r>
+              <a:rPr sz="1500" b="0">
+                <a:solidFill>
+                  <a:srgbClr val="1D3557"/>
+                </a:solidFill>
+                <a:latin typeface="Menlo"/>
+              </a:rPr>
+              <a:t>comunas = pd.read_csv(URL_COMUNAS)   # Id, Comuna</a:t>
+            </a:r>
+          </a:p>
+          <a:p>
+            <a:pPr/>
+            <a:r>
+              <a:rPr sz="1500" b="0">
+                <a:solidFill>
+                  <a:srgbClr val="1D3557"/>
+                </a:solidFill>
+                <a:latin typeface="Menlo"/>
+              </a:rPr>
+              <a:t>viajes.merge(comunas, left_on="ComunaOrigen", right_on="Id")</a:t>
+            </a:r>
+          </a:p>
+        </p:txBody>
+      </p:sp>
       <p:sp>
         <p:nvSpPr>
           <p:cNvPr id="5" name="TextBox 4"/>
@@ -6072,8 +5979,8 @@
         </p:nvSpPr>
         <p:spPr>
           <a:xfrm>
-            <a:off x="704088" y="4434840"/>
-            <a:ext cx="7744968" cy="457200"/>
+            <a:off x="704088" y="2880360"/>
+            <a:ext cx="7744968" cy="1097280"/>
           </a:xfrm>
           <a:prstGeom prst="rect">
             <a:avLst/>
@@ -6086,14 +5993,31 @@
           </a:bodyPr>
           <a:lstStyle/>
           <a:p>
-            <a:r>
-              <a:rPr sz="1300" b="0">
-                <a:solidFill>
-                  <a:srgbClr val="333333"/>
-                </a:solidFill>
-                <a:latin typeface="Fira Sans"/>
-              </a:rPr>
-              <a:t>EOD Santiago 2012: 18.264 hogares, 60.054 personas y 113.591 viajes registrados. Cada fila es un viaje; los códigos se resuelven contra tablas de parámetros.</a:t>
+            <a:pPr>
+              <a:lnSpc>
+                <a:spcPct val="112000"/>
+              </a:lnSpc>
+              <a:spcAft>
+                <a:spcPts val="900"/>
+              </a:spcAft>
+            </a:pPr>
+            <a:r>
+              <a:rPr sz="1600" b="1">
+                <a:solidFill>
+                  <a:srgbClr val="E0A437"/>
+                </a:solidFill>
+                <a:latin typeface="Fira Sans"/>
+              </a:rPr>
+              <a:t>▸ </a:t>
+            </a:r>
+            <a:r>
+              <a:rPr sz="1600" b="0">
+                <a:solidFill>
+                  <a:srgbClr val="000000"/>
+                </a:solidFill>
+                <a:latin typeface="Fira Sans"/>
+              </a:rPr>
+              <a:t>Los códigos de una tabla se traducen uniéndola con su tabla de parámetros: merge empareja filas por una columna común. En el notebook lo usamos para ponerle nombre a comunas y modos de viaje.</a:t>
             </a:r>
           </a:p>
         </p:txBody>
@@ -6189,78 +6113,35 @@
                 </a:solidFill>
                 <a:latin typeface="Fira Sans"/>
               </a:rPr>
-              <a:t>Pandas: unir tablas con merge</a:t>
-            </a:r>
-          </a:p>
-        </p:txBody>
-      </p:sp>
-      <p:sp>
-        <p:nvSpPr>
-          <p:cNvPr id="4" name="Rectangle 3"/>
-          <p:cNvSpPr/>
-          <p:nvPr/>
-        </p:nvSpPr>
-        <p:spPr>
-          <a:xfrm>
-            <a:off x="704088" y="1280160"/>
-            <a:ext cx="7744968" cy="1371600"/>
-          </a:xfrm>
-          <a:prstGeom prst="rect">
-            <a:avLst/>
-          </a:prstGeom>
-          <a:solidFill>
-            <a:srgbClr val="F0F2F5"/>
-          </a:solidFill>
-          <a:ln>
-            <a:solidFill>
-              <a:srgbClr val="D8DDE3"/>
-            </a:solidFill>
-          </a:ln>
-          <a:effectLst/>
-        </p:spPr>
-        <p:style>
-          <a:lnRef idx="1">
-            <a:schemeClr val="accent1"/>
-          </a:lnRef>
-          <a:fillRef idx="3">
-            <a:schemeClr val="accent1"/>
-          </a:fillRef>
-          <a:effectRef idx="2">
-            <a:schemeClr val="accent1"/>
-          </a:effectRef>
-          <a:fontRef idx="minor">
-            <a:schemeClr val="lt1"/>
-          </a:fontRef>
-        </p:style>
-        <p:txBody>
-          <a:bodyPr rtlCol="0" anchor="ctr" wrap="square" lIns="228600" tIns="137160"/>
-          <a:lstStyle/>
-          <a:p>
-            <a:pPr/>
-            <a:r>
-              <a:rPr sz="1500" b="0">
-                <a:solidFill>
-                  <a:srgbClr val="1D3557"/>
-                </a:solidFill>
-                <a:latin typeface="Menlo"/>
-              </a:rPr>
-              <a:t>comunas = pd.read_csv(URL_COMUNAS)   # Id, Comuna</a:t>
-            </a:r>
-          </a:p>
-          <a:p>
-            <a:pPr/>
-            <a:r>
-              <a:rPr sz="1500" b="0">
-                <a:solidFill>
-                  <a:srgbClr val="1D3557"/>
-                </a:solidFill>
-                <a:latin typeface="Menlo"/>
-              </a:rPr>
-              <a:t>viajes.merge(comunas, left_on="ComunaOrigen", right_on="Id")</a:t>
-            </a:r>
-          </a:p>
-        </p:txBody>
-      </p:sp>
+              <a:t>Matplotlib: del DataFrame al gráfico</a:t>
+            </a:r>
+          </a:p>
+        </p:txBody>
+      </p:sp>
+      <p:pic>
+        <p:nvPicPr>
+          <p:cNvPr id="4" name="Picture 3" descr="06_hist_tiempo.png"/>
+          <p:cNvPicPr>
+            <a:picLocks noChangeAspect="1"/>
+          </p:cNvPicPr>
+          <p:nvPr/>
+        </p:nvPicPr>
+        <p:blipFill>
+          <a:blip r:embed="rId2"/>
+          <a:stretch>
+            <a:fillRect/>
+          </a:stretch>
+        </p:blipFill>
+        <p:spPr>
+          <a:xfrm>
+            <a:off x="1778310" y="1143000"/>
+            <a:ext cx="5587379" cy="3154680"/>
+          </a:xfrm>
+          <a:prstGeom prst="rect">
+            <a:avLst/>
+          </a:prstGeom>
+        </p:spPr>
+      </p:pic>
       <p:sp>
         <p:nvSpPr>
           <p:cNvPr id="5" name="TextBox 4"/>
@@ -6269,8 +6150,8 @@
         </p:nvSpPr>
         <p:spPr>
           <a:xfrm>
-            <a:off x="704088" y="2880360"/>
-            <a:ext cx="7744968" cy="1097280"/>
+            <a:off x="704088" y="4434840"/>
+            <a:ext cx="7744968" cy="457200"/>
           </a:xfrm>
           <a:prstGeom prst="rect">
             <a:avLst/>
@@ -6283,31 +6164,14 @@
           </a:bodyPr>
           <a:lstStyle/>
           <a:p>
-            <a:pPr>
-              <a:lnSpc>
-                <a:spcPct val="112000"/>
-              </a:lnSpc>
-              <a:spcAft>
-                <a:spcPts val="900"/>
-              </a:spcAft>
-            </a:pPr>
-            <a:r>
-              <a:rPr sz="1600" b="1">
-                <a:solidFill>
-                  <a:srgbClr val="E0A437"/>
-                </a:solidFill>
-                <a:latin typeface="Fira Sans"/>
-              </a:rPr>
-              <a:t>▸ </a:t>
-            </a:r>
-            <a:r>
-              <a:rPr sz="1600" b="0">
-                <a:solidFill>
-                  <a:srgbClr val="000000"/>
-                </a:solidFill>
-                <a:latin typeface="Fira Sans"/>
-              </a:rPr>
-              <a:t>Los códigos de una tabla se traducen uniéndola con su tabla de parámetros: merge empareja filas por una columna común. En el notebook lo usamos para ponerle nombre a comunas y modos de viaje.</a:t>
+            <a:r>
+              <a:rPr sz="1300" b="0">
+                <a:solidFill>
+                  <a:srgbClr val="333333"/>
+                </a:solidFill>
+                <a:latin typeface="Fira Sans"/>
+              </a:rPr>
+              <a:t>Este histograma sale de la tabla de viajes con unas seis líneas de código; el notebook de la clase las muestra completas.</a:t>
             </a:r>
           </a:p>
         </p:txBody>
@@ -6403,35 +6267,102 @@
                 </a:solidFill>
                 <a:latin typeface="Fira Sans"/>
               </a:rPr>
-              <a:t>Matplotlib: del DataFrame al gráfico</a:t>
-            </a:r>
-          </a:p>
-        </p:txBody>
-      </p:sp>
-      <p:pic>
-        <p:nvPicPr>
-          <p:cNvPr id="4" name="Picture 3" descr="06_hist_tiempo.png"/>
-          <p:cNvPicPr>
-            <a:picLocks noChangeAspect="1"/>
-          </p:cNvPicPr>
-          <p:nvPr/>
-        </p:nvPicPr>
-        <p:blipFill>
-          <a:blip r:embed="rId2"/>
-          <a:stretch>
-            <a:fillRect/>
-          </a:stretch>
-        </p:blipFill>
-        <p:spPr>
-          <a:xfrm>
-            <a:off x="1778310" y="1143000"/>
-            <a:ext cx="5587379" cy="3154680"/>
-          </a:xfrm>
-          <a:prstGeom prst="rect">
-            <a:avLst/>
-          </a:prstGeom>
-        </p:spPr>
-      </p:pic>
+              <a:t>Puesta en marcha del entorno</a:t>
+            </a:r>
+          </a:p>
+        </p:txBody>
+      </p:sp>
+      <p:sp>
+        <p:nvSpPr>
+          <p:cNvPr id="4" name="Rectangle 3"/>
+          <p:cNvSpPr/>
+          <p:nvPr/>
+        </p:nvSpPr>
+        <p:spPr>
+          <a:xfrm>
+            <a:off x="704088" y="1280160"/>
+            <a:ext cx="7744968" cy="2377440"/>
+          </a:xfrm>
+          <a:prstGeom prst="rect">
+            <a:avLst/>
+          </a:prstGeom>
+          <a:solidFill>
+            <a:srgbClr val="F0F2F5"/>
+          </a:solidFill>
+          <a:ln>
+            <a:solidFill>
+              <a:srgbClr val="D8DDE3"/>
+            </a:solidFill>
+          </a:ln>
+          <a:effectLst/>
+        </p:spPr>
+        <p:style>
+          <a:lnRef idx="1">
+            <a:schemeClr val="accent1"/>
+          </a:lnRef>
+          <a:fillRef idx="3">
+            <a:schemeClr val="accent1"/>
+          </a:fillRef>
+          <a:effectRef idx="2">
+            <a:schemeClr val="accent1"/>
+          </a:effectRef>
+          <a:fontRef idx="minor">
+            <a:schemeClr val="lt1"/>
+          </a:fontRef>
+        </p:style>
+        <p:txBody>
+          <a:bodyPr rtlCol="0" anchor="ctr" wrap="square" lIns="228600" tIns="137160"/>
+          <a:lstStyle/>
+          <a:p>
+            <a:pPr/>
+            <a:r>
+              <a:rPr sz="1500" b="0">
+                <a:solidFill>
+                  <a:srgbClr val="1D3557"/>
+                </a:solidFill>
+                <a:latin typeface="Menlo"/>
+              </a:rPr>
+              <a:t>uv init --bare --python 3.12</a:t>
+            </a:r>
+          </a:p>
+          <a:p>
+            <a:pPr/>
+            <a:r>
+              <a:rPr sz="1500" b="0">
+                <a:solidFill>
+                  <a:srgbClr val="1D3557"/>
+                </a:solidFill>
+                <a:latin typeface="Menlo"/>
+              </a:rPr>
+              <a:t>uv add numpy pandas matplotlib seaborn scipy</a:t>
+            </a:r>
+          </a:p>
+          <a:p>
+            <a:pPr/>
+            <a:r>
+              <a:rPr sz="1500" b="0">
+                <a:solidFill>
+                  <a:srgbClr val="1D3557"/>
+                </a:solidFill>
+                <a:latin typeface="Menlo"/>
+              </a:rPr>
+              <a:t>uv add statsmodels scikit-learn jupyterlab</a:t>
+            </a:r>
+          </a:p>
+          <a:p>
+            <a:pPr/>
+            <a:r>
+              <a:rPr sz="1500" b="0">
+                <a:solidFill>
+                  <a:srgbClr val="1D3557"/>
+                </a:solidFill>
+                <a:latin typeface="Menlo"/>
+              </a:rPr>
+              <a:t>uv run jupyter lab</a:t>
+            </a:r>
+          </a:p>
+        </p:txBody>
+      </p:sp>
       <p:sp>
         <p:nvSpPr>
           <p:cNvPr id="5" name="TextBox 4"/>
@@ -6440,8 +6371,8 @@
         </p:nvSpPr>
         <p:spPr>
           <a:xfrm>
-            <a:off x="704088" y="4434840"/>
-            <a:ext cx="7744968" cy="457200"/>
+            <a:off x="704088" y="3886200"/>
+            <a:ext cx="7744968" cy="1097280"/>
           </a:xfrm>
           <a:prstGeom prst="rect">
             <a:avLst/>
@@ -6454,14 +6385,31 @@
           </a:bodyPr>
           <a:lstStyle/>
           <a:p>
-            <a:r>
-              <a:rPr sz="1300" b="0">
-                <a:solidFill>
-                  <a:srgbClr val="333333"/>
-                </a:solidFill>
-                <a:latin typeface="Fira Sans"/>
-              </a:rPr>
-              <a:t>Este histograma sale de la tabla de viajes con unas seis líneas de código; el notebook de la clase las muestra completas.</a:t>
+            <a:pPr>
+              <a:lnSpc>
+                <a:spcPct val="112000"/>
+              </a:lnSpc>
+              <a:spcAft>
+                <a:spcPts val="900"/>
+              </a:spcAft>
+            </a:pPr>
+            <a:r>
+              <a:rPr sz="1600" b="1">
+                <a:solidFill>
+                  <a:srgbClr val="E0A437"/>
+                </a:solidFill>
+                <a:latin typeface="Fira Sans"/>
+              </a:rPr>
+              <a:t>▸ </a:t>
+            </a:r>
+            <a:r>
+              <a:rPr sz="1600" b="0">
+                <a:solidFill>
+                  <a:srgbClr val="000000"/>
+                </a:solidFill>
+                <a:latin typeface="Fira Sans"/>
+              </a:rPr>
+              <a:t>La guía de instalación del repositorio (github.com/daniopitz/diplomado-cdd) detalla estos pasos por sistema operativo y los problemas frecuentes. Lo hacemos juntos ahora; debe quedar funcionando antes de la clase 2. Alternativa sin instalar nada: Google Colab, con los enlaces del repositorio.</a:t>
             </a:r>
           </a:p>
         </p:txBody>
@@ -6557,21 +6505,45 @@
                 </a:solidFill>
                 <a:latin typeface="Fira Sans"/>
               </a:rPr>
-              <a:t>Jupyter y uv: el entorno de trabajo</a:t>
-            </a:r>
-          </a:p>
-        </p:txBody>
-      </p:sp>
-      <p:sp>
-        <p:nvSpPr>
-          <p:cNvPr id="4" name="TextBox 3"/>
+              <a:t>Reparto modal de Santiago, EOD 2012</a:t>
+            </a:r>
+          </a:p>
+        </p:txBody>
+      </p:sp>
+      <p:pic>
+        <p:nvPicPr>
+          <p:cNvPr id="4" name="Picture 3" descr="01_reparto_modal.png"/>
+          <p:cNvPicPr>
+            <a:picLocks noChangeAspect="1"/>
+          </p:cNvPicPr>
+          <p:nvPr/>
+        </p:nvPicPr>
+        <p:blipFill>
+          <a:blip r:embed="rId2"/>
+          <a:stretch>
+            <a:fillRect/>
+          </a:stretch>
+        </p:blipFill>
+        <p:spPr>
+          <a:xfrm>
+            <a:off x="1604462" y="1143000"/>
+            <a:ext cx="5935075" cy="3154680"/>
+          </a:xfrm>
+          <a:prstGeom prst="rect">
+            <a:avLst/>
+          </a:prstGeom>
+        </p:spPr>
+      </p:pic>
+      <p:sp>
+        <p:nvSpPr>
+          <p:cNvPr id="5" name="TextBox 4"/>
           <p:cNvSpPr txBox="1"/>
           <p:nvPr/>
         </p:nvSpPr>
         <p:spPr>
           <a:xfrm>
-            <a:off x="704088" y="1353312"/>
-            <a:ext cx="7744968" cy="3300984"/>
+            <a:off x="704088" y="4434840"/>
+            <a:ext cx="7744968" cy="457200"/>
           </a:xfrm>
           <a:prstGeom prst="rect">
             <a:avLst/>
@@ -6584,115 +6556,14 @@
           </a:bodyPr>
           <a:lstStyle/>
           <a:p>
-            <a:pPr>
-              <a:lnSpc>
-                <a:spcPct val="112000"/>
-              </a:lnSpc>
-              <a:spcAft>
-                <a:spcPts val="900"/>
-              </a:spcAft>
-            </a:pPr>
-            <a:r>
-              <a:rPr sz="1800" b="1">
-                <a:solidFill>
-                  <a:srgbClr val="E0A437"/>
-                </a:solidFill>
-                <a:latin typeface="Fira Sans"/>
-              </a:rPr>
-              <a:t>▸ </a:t>
-            </a:r>
-            <a:r>
-              <a:rPr sz="1800" b="0">
-                <a:solidFill>
-                  <a:srgbClr val="000000"/>
-                </a:solidFill>
-                <a:latin typeface="Fira Sans"/>
-              </a:rPr>
-              <a:t>Jupyter: notebooks que mezclan texto, código y resultados; el formato en que trabajaremos todas las clases.</a:t>
-            </a:r>
-          </a:p>
-          <a:p>
-            <a:pPr>
-              <a:lnSpc>
-                <a:spcPct val="112000"/>
-              </a:lnSpc>
-              <a:spcAft>
-                <a:spcPts val="900"/>
-              </a:spcAft>
-            </a:pPr>
-            <a:r>
-              <a:rPr sz="1800" b="1">
-                <a:solidFill>
-                  <a:srgbClr val="E0A437"/>
-                </a:solidFill>
-                <a:latin typeface="Fira Sans"/>
-              </a:rPr>
-              <a:t>▸ </a:t>
-            </a:r>
-            <a:r>
-              <a:rPr sz="1800" b="0">
-                <a:solidFill>
-                  <a:srgbClr val="000000"/>
-                </a:solidFill>
-                <a:latin typeface="Fira Sans"/>
-              </a:rPr>
-              <a:t>uv: administra Python, los paquetes y sus versiones, para que todo el curso trabaje con el mismo entorno.</a:t>
-            </a:r>
-          </a:p>
-          <a:p>
-            <a:pPr>
-              <a:lnSpc>
-                <a:spcPct val="112000"/>
-              </a:lnSpc>
-              <a:spcAft>
-                <a:spcPts val="900"/>
-              </a:spcAft>
-            </a:pPr>
-            <a:r>
-              <a:rPr sz="1800" b="1">
-                <a:solidFill>
-                  <a:srgbClr val="E0A437"/>
-                </a:solidFill>
-                <a:latin typeface="Fira Sans"/>
-              </a:rPr>
-              <a:t>▸ </a:t>
-            </a:r>
-            <a:r>
-              <a:rPr sz="1800" b="0">
-                <a:solidFill>
-                  <a:srgbClr val="000000"/>
-                </a:solidFill>
-                <a:latin typeface="Fira Sans"/>
-              </a:rPr>
-              <a:t>Alternativa sin instalar nada: Google Colab ejecuta los mismos notebooks en la nube.</a:t>
-            </a:r>
-          </a:p>
-          <a:p>
-            <a:pPr>
-              <a:lnSpc>
-                <a:spcPct val="112000"/>
-              </a:lnSpc>
-              <a:spcAft>
-                <a:spcPts val="900"/>
-              </a:spcAft>
-            </a:pPr>
-            <a:r>
-              <a:rPr sz="1800" b="1">
-                <a:solidFill>
-                  <a:srgbClr val="E0A437"/>
-                </a:solidFill>
-                <a:latin typeface="Fira Sans"/>
-              </a:rPr>
-              <a:t>▸ </a:t>
-            </a:r>
-            <a:r>
-              <a:rPr sz="1800" b="0">
-                <a:solidFill>
-                  <a:srgbClr val="000000"/>
-                </a:solidFill>
-                <a:latin typeface="Fira Sans"/>
-              </a:rPr>
-              <a:t>Todo el material queda en el repositorio del módulo: github.com/daniopitz/diplomado-cdd</a:t>
+            <a:r>
+              <a:rPr sz="1300" b="0">
+                <a:solidFill>
+                  <a:srgbClr val="333333"/>
+                </a:solidFill>
+                <a:latin typeface="Fira Sans"/>
+              </a:rPr>
+              <a:t>Uno de cada tres viajes es a pie. Esta versión está ponderada por factores de expansión, así que habla de la ciudad; en el notebook calcularemos la versión muestral, y la diferencia entre ambas abre las clases 2 y 3.</a:t>
             </a:r>
           </a:p>
         </p:txBody>
@@ -6788,112 +6659,21 @@
                 </a:solidFill>
                 <a:latin typeface="Fira Sans"/>
               </a:rPr>
-              <a:t>Puesta en marcha del entorno</a:t>
-            </a:r>
-          </a:p>
-        </p:txBody>
-      </p:sp>
-      <p:sp>
-        <p:nvSpPr>
-          <p:cNvPr id="4" name="Rectangle 3"/>
-          <p:cNvSpPr/>
-          <p:nvPr/>
-        </p:nvSpPr>
-        <p:spPr>
-          <a:xfrm>
-            <a:off x="704088" y="1280160"/>
-            <a:ext cx="7744968" cy="2377440"/>
-          </a:xfrm>
-          <a:prstGeom prst="rect">
-            <a:avLst/>
-          </a:prstGeom>
-          <a:solidFill>
-            <a:srgbClr val="F0F2F5"/>
-          </a:solidFill>
-          <a:ln>
-            <a:solidFill>
-              <a:srgbClr val="D8DDE3"/>
-            </a:solidFill>
-          </a:ln>
-          <a:effectLst/>
-        </p:spPr>
-        <p:style>
-          <a:lnRef idx="1">
-            <a:schemeClr val="accent1"/>
-          </a:lnRef>
-          <a:fillRef idx="3">
-            <a:schemeClr val="accent1"/>
-          </a:fillRef>
-          <a:effectRef idx="2">
-            <a:schemeClr val="accent1"/>
-          </a:effectRef>
-          <a:fontRef idx="minor">
-            <a:schemeClr val="lt1"/>
-          </a:fontRef>
-        </p:style>
-        <p:txBody>
-          <a:bodyPr rtlCol="0" anchor="ctr" wrap="square" lIns="228600" tIns="137160"/>
-          <a:lstStyle/>
-          <a:p>
-            <a:pPr/>
-            <a:r>
-              <a:rPr sz="1500" b="0">
-                <a:solidFill>
-                  <a:srgbClr val="1D3557"/>
-                </a:solidFill>
-                <a:latin typeface="Menlo"/>
-              </a:rPr>
-              <a:t>uv init --bare --python 3.12</a:t>
-            </a:r>
-          </a:p>
-          <a:p>
-            <a:pPr/>
-            <a:r>
-              <a:rPr sz="1500" b="0">
-                <a:solidFill>
-                  <a:srgbClr val="1D3557"/>
-                </a:solidFill>
-                <a:latin typeface="Menlo"/>
-              </a:rPr>
-              <a:t>uv add numpy pandas matplotlib seaborn scipy</a:t>
-            </a:r>
-          </a:p>
-          <a:p>
-            <a:pPr/>
-            <a:r>
-              <a:rPr sz="1500" b="0">
-                <a:solidFill>
-                  <a:srgbClr val="1D3557"/>
-                </a:solidFill>
-                <a:latin typeface="Menlo"/>
-              </a:rPr>
-              <a:t>uv add statsmodels scikit-learn jupyterlab</a:t>
-            </a:r>
-          </a:p>
-          <a:p>
-            <a:pPr/>
-            <a:r>
-              <a:rPr sz="1500" b="0">
-                <a:solidFill>
-                  <a:srgbClr val="1D3557"/>
-                </a:solidFill>
-                <a:latin typeface="Menlo"/>
-              </a:rPr>
-              <a:t>uv run jupyter lab</a:t>
-            </a:r>
-          </a:p>
-        </p:txBody>
-      </p:sp>
-      <p:sp>
-        <p:nvSpPr>
-          <p:cNvPr id="5" name="TextBox 4"/>
+              <a:t>Actividad de cierre</a:t>
+            </a:r>
+          </a:p>
+        </p:txBody>
+      </p:sp>
+      <p:sp>
+        <p:nvSpPr>
+          <p:cNvPr id="4" name="TextBox 3"/>
           <p:cNvSpPr txBox="1"/>
           <p:nvPr/>
         </p:nvSpPr>
         <p:spPr>
           <a:xfrm>
-            <a:off x="704088" y="3886200"/>
-            <a:ext cx="7744968" cy="1097280"/>
+            <a:off x="704088" y="1353312"/>
+            <a:ext cx="7744968" cy="3300984"/>
           </a:xfrm>
           <a:prstGeom prst="rect">
             <a:avLst/>
@@ -6915,7 +6695,7 @@
               </a:spcAft>
             </a:pPr>
             <a:r>
-              <a:rPr sz="1600" b="1">
+              <a:rPr sz="1800" b="1">
                 <a:solidFill>
                   <a:srgbClr val="E0A437"/>
                 </a:solidFill>
@@ -6924,13 +6704,69 @@
               <a:t>▸ </a:t>
             </a:r>
             <a:r>
-              <a:rPr sz="1600" b="0">
+              <a:rPr sz="1800" b="1">
+                <a:solidFill>
+                  <a:srgbClr val="1D3557"/>
+                </a:solidFill>
+                <a:latin typeface="Fira Sans"/>
+              </a:rPr>
+              <a:t>Escriba en el chat una decisión de su trabajo que hoy se toma por intuición y podría tomarse con datos, o un conjunto de datos que su organización acumula y no analiza.</a:t>
+            </a:r>
+          </a:p>
+          <a:p>
+            <a:pPr>
+              <a:lnSpc>
+                <a:spcPct val="112000"/>
+              </a:lnSpc>
+              <a:spcAft>
+                <a:spcPts val="900"/>
+              </a:spcAft>
+            </a:pPr>
+            <a:r>
+              <a:rPr sz="1800" b="1">
+                <a:solidFill>
+                  <a:srgbClr val="E0A437"/>
+                </a:solidFill>
+                <a:latin typeface="Fira Sans"/>
+              </a:rPr>
+              <a:t>▸ </a:t>
+            </a:r>
+            <a:r>
+              <a:rPr sz="1800" b="0">
                 <a:solidFill>
                   <a:srgbClr val="000000"/>
                 </a:solidFill>
                 <a:latin typeface="Fira Sans"/>
               </a:rPr>
-              <a:t>La guía de instalación del repositorio detalla estos pasos por sistema operativo y los problemas frecuentes. Lo hacemos juntos ahora; debe quedar funcionando antes de la clase 2.</a:t>
+              <a:t>Comentaremos dos o tres: cuál sería la pregunta, qué datos harían falta, qué etapa del ciclo sería la difícil.</a:t>
+            </a:r>
+          </a:p>
+          <a:p>
+            <a:pPr>
+              <a:lnSpc>
+                <a:spcPct val="112000"/>
+              </a:lnSpc>
+              <a:spcAft>
+                <a:spcPts val="900"/>
+              </a:spcAft>
+            </a:pPr>
+            <a:r>
+              <a:rPr sz="1800" b="1">
+                <a:solidFill>
+                  <a:srgbClr val="E0A437"/>
+                </a:solidFill>
+                <a:latin typeface="Fira Sans"/>
+              </a:rPr>
+              <a:t>▸ </a:t>
+            </a:r>
+            <a:r>
+              <a:rPr sz="1800" b="0">
+                <a:solidFill>
+                  <a:srgbClr val="000000"/>
+                </a:solidFill>
+                <a:latin typeface="Fira Sans"/>
+              </a:rPr>
+              <a:t>Guarde la suya: puede ser el germen de su proyecto final.</a:t>
             </a:r>
           </a:p>
         </p:txBody>
@@ -7026,45 +6862,21 @@
                 </a:solidFill>
                 <a:latin typeface="Fira Sans"/>
               </a:rPr>
-              <a:t>Reparto modal de Santiago, EOD 2012</a:t>
-            </a:r>
-          </a:p>
-        </p:txBody>
-      </p:sp>
-      <p:pic>
-        <p:nvPicPr>
-          <p:cNvPr id="4" name="Picture 3" descr="01_reparto_modal.png"/>
-          <p:cNvPicPr>
-            <a:picLocks noChangeAspect="1"/>
-          </p:cNvPicPr>
-          <p:nvPr/>
-        </p:nvPicPr>
-        <p:blipFill>
-          <a:blip r:embed="rId2"/>
-          <a:stretch>
-            <a:fillRect/>
-          </a:stretch>
-        </p:blipFill>
-        <p:spPr>
-          <a:xfrm>
-            <a:off x="1604462" y="1143000"/>
-            <a:ext cx="5935075" cy="3154680"/>
-          </a:xfrm>
-          <a:prstGeom prst="rect">
-            <a:avLst/>
-          </a:prstGeom>
-        </p:spPr>
-      </p:pic>
-      <p:sp>
-        <p:nvSpPr>
-          <p:cNvPr id="5" name="TextBox 4"/>
+              <a:t>Síntesis</a:t>
+            </a:r>
+          </a:p>
+        </p:txBody>
+      </p:sp>
+      <p:sp>
+        <p:nvSpPr>
+          <p:cNvPr id="4" name="TextBox 3"/>
           <p:cNvSpPr txBox="1"/>
           <p:nvPr/>
         </p:nvSpPr>
         <p:spPr>
           <a:xfrm>
-            <a:off x="704088" y="4434840"/>
-            <a:ext cx="7744968" cy="457200"/>
+            <a:off x="704088" y="1353312"/>
+            <a:ext cx="7744968" cy="3300984"/>
           </a:xfrm>
           <a:prstGeom prst="rect">
             <a:avLst/>
@@ -7077,14 +6889,143 @@
           </a:bodyPr>
           <a:lstStyle/>
           <a:p>
-            <a:r>
-              <a:rPr sz="1300" b="0">
-                <a:solidFill>
-                  <a:srgbClr val="333333"/>
-                </a:solidFill>
-                <a:latin typeface="Fira Sans"/>
-              </a:rPr>
-              <a:t>Uno de cada tres viajes es a pie. Esta versión está ponderada por factores de expansión, así que habla de la ciudad; en el notebook calcularemos la versión muestral, y la diferencia entre ambas abre las clases 2 y 3.</a:t>
+            <a:pPr>
+              <a:lnSpc>
+                <a:spcPct val="112000"/>
+              </a:lnSpc>
+              <a:spcAft>
+                <a:spcPts val="900"/>
+              </a:spcAft>
+            </a:pPr>
+            <a:r>
+              <a:rPr sz="1800" b="1">
+                <a:solidFill>
+                  <a:srgbClr val="E0A437"/>
+                </a:solidFill>
+                <a:latin typeface="Fira Sans"/>
+              </a:rPr>
+              <a:t>▸ </a:t>
+            </a:r>
+            <a:r>
+              <a:rPr sz="1800" b="1">
+                <a:solidFill>
+                  <a:srgbClr val="1D3557"/>
+                </a:solidFill>
+                <a:latin typeface="Fira Sans"/>
+              </a:rPr>
+              <a:t>El tipo de cada variable determina qué resúmenes, gráficos y análisis son válidos.</a:t>
+            </a:r>
+          </a:p>
+          <a:p>
+            <a:pPr>
+              <a:lnSpc>
+                <a:spcPct val="112000"/>
+              </a:lnSpc>
+              <a:spcAft>
+                <a:spcPts val="900"/>
+              </a:spcAft>
+            </a:pPr>
+            <a:r>
+              <a:rPr sz="1800" b="1">
+                <a:solidFill>
+                  <a:srgbClr val="E0A437"/>
+                </a:solidFill>
+                <a:latin typeface="Fira Sans"/>
+              </a:rPr>
+              <a:t>▸ </a:t>
+            </a:r>
+            <a:r>
+              <a:rPr sz="1800" b="0">
+                <a:solidFill>
+                  <a:srgbClr val="000000"/>
+                </a:solidFill>
+                <a:latin typeface="Fira Sans"/>
+              </a:rPr>
+              <a:t>Ciencia de datos: extracción generalizable de conocimiento a partir de los datos (Dhar, 2013); combina estadística, computación y dominio.</a:t>
+            </a:r>
+          </a:p>
+          <a:p>
+            <a:pPr>
+              <a:lnSpc>
+                <a:spcPct val="112000"/>
+              </a:lnSpc>
+              <a:spcAft>
+                <a:spcPts val="900"/>
+              </a:spcAft>
+            </a:pPr>
+            <a:r>
+              <a:rPr sz="1800" b="1">
+                <a:solidFill>
+                  <a:srgbClr val="E0A437"/>
+                </a:solidFill>
+                <a:latin typeface="Fira Sans"/>
+              </a:rPr>
+              <a:t>▸ </a:t>
+            </a:r>
+            <a:r>
+              <a:rPr sz="1800" b="0">
+                <a:solidFill>
+                  <a:srgbClr val="000000"/>
+                </a:solidFill>
+                <a:latin typeface="Fira Sans"/>
+              </a:rPr>
+              <a:t>El ciclo de vida tiene dos entradas (una necesidad del dominio o datos disponibles) y se recorre de forma iterativa.</a:t>
+            </a:r>
+          </a:p>
+          <a:p>
+            <a:pPr>
+              <a:lnSpc>
+                <a:spcPct val="112000"/>
+              </a:lnSpc>
+              <a:spcAft>
+                <a:spcPts val="900"/>
+              </a:spcAft>
+            </a:pPr>
+            <a:r>
+              <a:rPr sz="1800" b="1">
+                <a:solidFill>
+                  <a:srgbClr val="E0A437"/>
+                </a:solidFill>
+                <a:latin typeface="Fira Sans"/>
+              </a:rPr>
+              <a:t>▸ </a:t>
+            </a:r>
+            <a:r>
+              <a:rPr sz="1800" b="0">
+                <a:solidFill>
+                  <a:srgbClr val="000000"/>
+                </a:solidFill>
+                <a:latin typeface="Fira Sans"/>
+              </a:rPr>
+              <a:t>La preparación de datos consume cerca de la mitad del tiempo de un proyecto (Anaconda, 2020).</a:t>
+            </a:r>
+          </a:p>
+          <a:p>
+            <a:pPr>
+              <a:lnSpc>
+                <a:spcPct val="112000"/>
+              </a:lnSpc>
+              <a:spcAft>
+                <a:spcPts val="900"/>
+              </a:spcAft>
+            </a:pPr>
+            <a:r>
+              <a:rPr sz="1800" b="1">
+                <a:solidFill>
+                  <a:srgbClr val="E0A437"/>
+                </a:solidFill>
+                <a:latin typeface="Fira Sans"/>
+              </a:rPr>
+              <a:t>▸ </a:t>
+            </a:r>
+            <a:r>
+              <a:rPr sz="1800" b="0">
+                <a:solidFill>
+                  <a:srgbClr val="000000"/>
+                </a:solidFill>
+                <a:latin typeface="Fira Sans"/>
+              </a:rPr>
+              <a:t>Próxima clase (jueves 27): estadística descriptiva, con el entorno ya funcionando.</a:t>
             </a:r>
           </a:p>
         </p:txBody>
@@ -7180,7 +7121,7 @@
                 </a:solidFill>
                 <a:latin typeface="Fira Sans"/>
               </a:rPr>
-              <a:t>El notebook de la clase</a:t>
+              <a:t>Referencias</a:t>
             </a:r>
           </a:p>
         </p:txBody>
@@ -7193,8 +7134,8 @@
         </p:nvSpPr>
         <p:spPr>
           <a:xfrm>
-            <a:off x="704088" y="1353312"/>
-            <a:ext cx="7744968" cy="3300984"/>
+            <a:off x="704088" y="1234440"/>
+            <a:ext cx="7744968" cy="3566160"/>
           </a:xfrm>
           <a:prstGeom prst="rect">
             <a:avLst/>
@@ -7209,141 +7150,115 @@
           <a:p>
             <a:pPr>
               <a:lnSpc>
-                <a:spcPct val="112000"/>
+                <a:spcPct val="115000"/>
               </a:lnSpc>
               <a:spcAft>
-                <a:spcPts val="900"/>
+                <a:spcPts val="700"/>
               </a:spcAft>
             </a:pPr>
             <a:r>
-              <a:rPr sz="1800" b="1">
-                <a:solidFill>
-                  <a:srgbClr val="E0A437"/>
-                </a:solidFill>
-                <a:latin typeface="Fira Sans"/>
-              </a:rPr>
-              <a:t>▸ </a:t>
-            </a:r>
-            <a:r>
-              <a:rPr sz="1800" b="0">
-                <a:solidFill>
-                  <a:srgbClr val="000000"/>
-                </a:solidFill>
-                <a:latin typeface="Fira Sans"/>
-              </a:rPr>
-              <a:t>Notebook 01, del repositorio o en Colab: la tabla de viajes de la EOD por URL, con shape, head e info.</a:t>
+              <a:rPr sz="1300" b="0">
+                <a:solidFill>
+                  <a:srgbClr val="333333"/>
+                </a:solidFill>
+                <a:latin typeface="Fira Sans"/>
+              </a:rPr>
+              <a:t>Snow, J. (1855). On the Mode of Communication of Cholera (2ª edición). Londres: John Churchill.</a:t>
             </a:r>
           </a:p>
           <a:p>
             <a:pPr>
               <a:lnSpc>
-                <a:spcPct val="112000"/>
+                <a:spcPct val="115000"/>
               </a:lnSpc>
               <a:spcAft>
-                <a:spcPts val="900"/>
+                <a:spcPts val="700"/>
               </a:spcAft>
             </a:pPr>
             <a:r>
-              <a:rPr sz="1800" b="1">
-                <a:solidFill>
-                  <a:srgbClr val="E0A437"/>
-                </a:solidFill>
-                <a:latin typeface="Fira Sans"/>
-              </a:rPr>
-              <a:t>▸ </a:t>
-            </a:r>
-            <a:r>
-              <a:rPr sz="1800" b="0">
-                <a:solidFill>
-                  <a:srgbClr val="000000"/>
-                </a:solidFill>
-                <a:latin typeface="Fira Sans"/>
-              </a:rPr>
-              <a:t>Cualitativas: contar con value_counts y traducir códigos con merge (comunas y modos), recalculando el reparto modal en vivo.</a:t>
+              <a:rPr sz="1300" b="0">
+                <a:solidFill>
+                  <a:srgbClr val="333333"/>
+                </a:solidFill>
+                <a:latin typeface="Fira Sans"/>
+              </a:rPr>
+              <a:t>Anaconda (2020). 2020 State of Data Science. Reporte de encuesta (n=2.360). anaconda.com/resources/whitepaper/state-of-data-science-2020</a:t>
             </a:r>
           </a:p>
           <a:p>
             <a:pPr>
               <a:lnSpc>
-                <a:spcPct val="112000"/>
+                <a:spcPct val="115000"/>
               </a:lnSpc>
               <a:spcAft>
-                <a:spcPts val="900"/>
+                <a:spcPts val="700"/>
               </a:spcAft>
             </a:pPr>
             <a:r>
-              <a:rPr sz="1800" b="1">
-                <a:solidFill>
-                  <a:srgbClr val="E0A437"/>
-                </a:solidFill>
-                <a:latin typeface="Fira Sans"/>
-              </a:rPr>
-              <a:t>▸ </a:t>
-            </a:r>
-            <a:r>
-              <a:rPr sz="1800" b="0">
-                <a:solidFill>
-                  <a:srgbClr val="000000"/>
-                </a:solidFill>
-                <a:latin typeface="Fira Sans"/>
-              </a:rPr>
-              <a:t>Cuantitativas: describe y el histograma de duración; y una discreta, los viajes por persona.</a:t>
+              <a:rPr sz="1300" b="0">
+                <a:solidFill>
+                  <a:srgbClr val="333333"/>
+                </a:solidFill>
+                <a:latin typeface="Fira Sans"/>
+              </a:rPr>
+              <a:t>Cleveland, W. S. (2001). Data Science: An Action Plan for Expanding the Technical Areas of the Field of Statistics. International Statistical Review, 69(1), 21-26.</a:t>
             </a:r>
           </a:p>
           <a:p>
             <a:pPr>
               <a:lnSpc>
-                <a:spcPct val="112000"/>
+                <a:spcPct val="115000"/>
               </a:lnSpc>
               <a:spcAft>
-                <a:spcPts val="900"/>
+                <a:spcPts val="700"/>
               </a:spcAft>
             </a:pPr>
             <a:r>
-              <a:rPr sz="1800" b="1">
-                <a:solidFill>
-                  <a:srgbClr val="E0A437"/>
-                </a:solidFill>
-                <a:latin typeface="Fira Sans"/>
-              </a:rPr>
-              <a:t>▸ </a:t>
-            </a:r>
-            <a:r>
-              <a:rPr sz="1800" b="0">
-                <a:solidFill>
-                  <a:srgbClr val="000000"/>
-                </a:solidFill>
-                <a:latin typeface="Fira Sans"/>
-              </a:rPr>
-              <a:t>Cruce de ambas: la duración media por comuna, con groupby.</a:t>
+              <a:rPr sz="1300" b="0">
+                <a:solidFill>
+                  <a:srgbClr val="333333"/>
+                </a:solidFill>
+                <a:latin typeface="Fira Sans"/>
+              </a:rPr>
+              <a:t>Dhar, V. (2013). Data Science and Prediction. Communications of the ACM, 56(12), 64-73.</a:t>
             </a:r>
           </a:p>
           <a:p>
             <a:pPr>
               <a:lnSpc>
-                <a:spcPct val="112000"/>
+                <a:spcPct val="115000"/>
               </a:lnSpc>
               <a:spcAft>
-                <a:spcPts val="900"/>
+                <a:spcPts val="700"/>
               </a:spcAft>
             </a:pPr>
             <a:r>
-              <a:rPr sz="1800" b="1">
-                <a:solidFill>
-                  <a:srgbClr val="E0A437"/>
-                </a:solidFill>
-                <a:latin typeface="Fira Sans"/>
-              </a:rPr>
-              <a:t>▸ </a:t>
-            </a:r>
-            <a:r>
-              <a:rPr sz="1800" b="1">
-                <a:solidFill>
-                  <a:srgbClr val="1D3557"/>
-                </a:solidFill>
-                <a:latin typeface="Fira Sans"/>
-              </a:rPr>
-              <a:t>El hilo es el de la clase: el tipo de cada variable define qué análisis es válido.</a:t>
+              <a:rPr sz="1300" b="0">
+                <a:solidFill>
+                  <a:srgbClr val="333333"/>
+                </a:solidFill>
+                <a:latin typeface="Fira Sans"/>
+              </a:rPr>
+              <a:t>Donoho, D. (2017). 50 Years of Data Science. Journal of Computational and Graphical Statistics, 26(4), 745-766.</a:t>
+            </a:r>
+          </a:p>
+          <a:p>
+            <a:pPr>
+              <a:lnSpc>
+                <a:spcPct val="115000"/>
+              </a:lnSpc>
+              <a:spcAft>
+                <a:spcPts val="700"/>
+              </a:spcAft>
+            </a:pPr>
+            <a:r>
+              <a:rPr sz="1300" b="0">
+                <a:solidFill>
+                  <a:srgbClr val="333333"/>
+                </a:solidFill>
+                <a:latin typeface="Fira Sans"/>
+              </a:rPr>
+              <a:t>VanderPlas, J. (2016). Python Data Science Handbook. O'Reilly. Versión en línea: jakevdp.github.io/PythonDataScienceHandbook</a:t>
             </a:r>
           </a:p>
         </p:txBody>
@@ -7439,7 +7354,7 @@
                 </a:solidFill>
                 <a:latin typeface="Fira Sans"/>
               </a:rPr>
-              <a:t>El mensaje de la clase</a:t>
+              <a:t>El concepto central de la clase</a:t>
             </a:r>
           </a:p>
         </p:txBody>
@@ -7490,7 +7405,7 @@
                 </a:solidFill>
                 <a:latin typeface="Fira Sans"/>
               </a:rPr>
-              <a:t>Un proyecto de datos empieza en la pregunta, no en los datos.</a:t>
+              <a:t>El tipo de cada variable determina qué resúmenes, gráficos y análisis son válidos.</a:t>
             </a:r>
           </a:p>
           <a:p>
@@ -7518,7 +7433,7 @@
                 </a:solidFill>
                 <a:latin typeface="Fira Sans"/>
               </a:rPr>
-              <a:t>Las herramientas cambian (hoy Python, hace 20 años planillas), pero la lógica del trabajo con datos se mantiene.</a:t>
+              <a:t>Primero se presenta como marco (tipos de datos y tipos de variables) y luego se aplica columna a columna sobre una encuesta real, en el notebook.</a:t>
             </a:r>
           </a:p>
           <a:p>
@@ -7546,683 +7461,7 @@
                 </a:solidFill>
                 <a:latin typeface="Fira Sans"/>
               </a:rPr>
-              <a:t>Al final de la clase volveremos sobre esta idea con un caso completo a la vista.</a:t>
-            </a:r>
-          </a:p>
-        </p:txBody>
-      </p:sp>
-    </p:spTree>
-  </p:cSld>
-  <p:clrMapOvr>
-    <a:masterClrMapping/>
-  </p:clrMapOvr>
-</p:sld>
-</file>
-
-<file path=ppt/slides/slide30.xml><?xml version="1.0" encoding="utf-8"?>
-<p:sld xmlns:a="http://schemas.openxmlformats.org/drawingml/2006/main" xmlns:p="http://schemas.openxmlformats.org/presentationml/2006/main" xmlns:r="http://schemas.openxmlformats.org/officeDocument/2006/relationships">
-  <p:cSld>
-    <p:spTree>
-      <p:nvGrpSpPr>
-        <p:cNvPr id="1" name=""/>
-        <p:cNvGrpSpPr/>
-        <p:nvPr/>
-      </p:nvGrpSpPr>
-      <p:grpSpPr/>
-      <p:sp>
-        <p:nvSpPr>
-          <p:cNvPr id="2" name="Rectangle 1"/>
-          <p:cNvSpPr/>
-          <p:nvPr/>
-        </p:nvSpPr>
-        <p:spPr>
-          <a:xfrm>
-            <a:off x="0" y="0"/>
-            <a:ext cx="9144000" cy="5138928"/>
-          </a:xfrm>
-          <a:prstGeom prst="rect">
-            <a:avLst/>
-          </a:prstGeom>
-          <a:solidFill>
-            <a:srgbClr val="FAFBFC"/>
-          </a:solidFill>
-          <a:ln>
-            <a:noFill/>
-          </a:ln>
-          <a:effectLst/>
-        </p:spPr>
-        <p:style>
-          <a:lnRef idx="1">
-            <a:schemeClr val="accent1"/>
-          </a:lnRef>
-          <a:fillRef idx="3">
-            <a:schemeClr val="accent1"/>
-          </a:fillRef>
-          <a:effectRef idx="2">
-            <a:schemeClr val="accent1"/>
-          </a:effectRef>
-          <a:fontRef idx="minor">
-            <a:schemeClr val="lt1"/>
-          </a:fontRef>
-        </p:style>
-        <p:txBody>
-          <a:bodyPr rtlCol="0" anchor="ctr"/>
-          <a:lstStyle/>
-          <a:p>
-            <a:pPr algn="ctr"/>
-          </a:p>
-        </p:txBody>
-      </p:sp>
-      <p:sp>
-        <p:nvSpPr>
-          <p:cNvPr id="3" name="TextBox 2"/>
-          <p:cNvSpPr txBox="1"/>
-          <p:nvPr/>
-        </p:nvSpPr>
-        <p:spPr>
-          <a:xfrm>
-            <a:off x="402336" y="301752"/>
-            <a:ext cx="8348472" cy="795528"/>
-          </a:xfrm>
-          <a:prstGeom prst="rect">
-            <a:avLst/>
-          </a:prstGeom>
-          <a:noFill/>
-        </p:spPr>
-        <p:txBody>
-          <a:bodyPr wrap="square">
-            <a:spAutoFit/>
-          </a:bodyPr>
-          <a:lstStyle/>
-          <a:p>
-            <a:r>
-              <a:rPr sz="2800" b="1">
-                <a:solidFill>
-                  <a:srgbClr val="0F0F0F"/>
-                </a:solidFill>
-                <a:latin typeface="Fira Sans"/>
-              </a:rPr>
-              <a:t>Actividad de cierre</a:t>
-            </a:r>
-          </a:p>
-        </p:txBody>
-      </p:sp>
-      <p:sp>
-        <p:nvSpPr>
-          <p:cNvPr id="4" name="TextBox 3"/>
-          <p:cNvSpPr txBox="1"/>
-          <p:nvPr/>
-        </p:nvSpPr>
-        <p:spPr>
-          <a:xfrm>
-            <a:off x="704088" y="1353312"/>
-            <a:ext cx="7744968" cy="3300984"/>
-          </a:xfrm>
-          <a:prstGeom prst="rect">
-            <a:avLst/>
-          </a:prstGeom>
-          <a:noFill/>
-        </p:spPr>
-        <p:txBody>
-          <a:bodyPr wrap="square">
-            <a:spAutoFit/>
-          </a:bodyPr>
-          <a:lstStyle/>
-          <a:p>
-            <a:pPr>
-              <a:lnSpc>
-                <a:spcPct val="112000"/>
-              </a:lnSpc>
-              <a:spcAft>
-                <a:spcPts val="900"/>
-              </a:spcAft>
-            </a:pPr>
-            <a:r>
-              <a:rPr sz="1800" b="1">
-                <a:solidFill>
-                  <a:srgbClr val="E0A437"/>
-                </a:solidFill>
-                <a:latin typeface="Fira Sans"/>
-              </a:rPr>
-              <a:t>▸ </a:t>
-            </a:r>
-            <a:r>
-              <a:rPr sz="1800" b="1">
-                <a:solidFill>
-                  <a:srgbClr val="1D3557"/>
-                </a:solidFill>
-                <a:latin typeface="Fira Sans"/>
-              </a:rPr>
-              <a:t>Escriba en el chat una decisión de su trabajo que hoy se toma por intuición y que podría tomarse con datos.</a:t>
-            </a:r>
-          </a:p>
-          <a:p>
-            <a:pPr>
-              <a:lnSpc>
-                <a:spcPct val="112000"/>
-              </a:lnSpc>
-              <a:spcAft>
-                <a:spcPts val="900"/>
-              </a:spcAft>
-            </a:pPr>
-            <a:r>
-              <a:rPr sz="1800" b="1">
-                <a:solidFill>
-                  <a:srgbClr val="E0A437"/>
-                </a:solidFill>
-                <a:latin typeface="Fira Sans"/>
-              </a:rPr>
-              <a:t>▸ </a:t>
-            </a:r>
-            <a:r>
-              <a:rPr sz="1800" b="0">
-                <a:solidFill>
-                  <a:srgbClr val="000000"/>
-                </a:solidFill>
-                <a:latin typeface="Fira Sans"/>
-              </a:rPr>
-              <a:t>Comentaremos dos o tres: cuál sería la pregunta, qué datos harían falta, qué etapa del ciclo sería la difícil.</a:t>
-            </a:r>
-          </a:p>
-          <a:p>
-            <a:pPr>
-              <a:lnSpc>
-                <a:spcPct val="112000"/>
-              </a:lnSpc>
-              <a:spcAft>
-                <a:spcPts val="900"/>
-              </a:spcAft>
-            </a:pPr>
-            <a:r>
-              <a:rPr sz="1800" b="1">
-                <a:solidFill>
-                  <a:srgbClr val="E0A437"/>
-                </a:solidFill>
-                <a:latin typeface="Fira Sans"/>
-              </a:rPr>
-              <a:t>▸ </a:t>
-            </a:r>
-            <a:r>
-              <a:rPr sz="1800" b="0">
-                <a:solidFill>
-                  <a:srgbClr val="000000"/>
-                </a:solidFill>
-                <a:latin typeface="Fira Sans"/>
-              </a:rPr>
-              <a:t>Guarde la suya: puede ser el germen de su proyecto final.</a:t>
-            </a:r>
-          </a:p>
-        </p:txBody>
-      </p:sp>
-    </p:spTree>
-  </p:cSld>
-  <p:clrMapOvr>
-    <a:masterClrMapping/>
-  </p:clrMapOvr>
-</p:sld>
-</file>
-
-<file path=ppt/slides/slide31.xml><?xml version="1.0" encoding="utf-8"?>
-<p:sld xmlns:a="http://schemas.openxmlformats.org/drawingml/2006/main" xmlns:p="http://schemas.openxmlformats.org/presentationml/2006/main" xmlns:r="http://schemas.openxmlformats.org/officeDocument/2006/relationships">
-  <p:cSld>
-    <p:spTree>
-      <p:nvGrpSpPr>
-        <p:cNvPr id="1" name=""/>
-        <p:cNvGrpSpPr/>
-        <p:nvPr/>
-      </p:nvGrpSpPr>
-      <p:grpSpPr/>
-      <p:sp>
-        <p:nvSpPr>
-          <p:cNvPr id="2" name="Rectangle 1"/>
-          <p:cNvSpPr/>
-          <p:nvPr/>
-        </p:nvSpPr>
-        <p:spPr>
-          <a:xfrm>
-            <a:off x="0" y="0"/>
-            <a:ext cx="9144000" cy="5138928"/>
-          </a:xfrm>
-          <a:prstGeom prst="rect">
-            <a:avLst/>
-          </a:prstGeom>
-          <a:solidFill>
-            <a:srgbClr val="FAFBFC"/>
-          </a:solidFill>
-          <a:ln>
-            <a:noFill/>
-          </a:ln>
-          <a:effectLst/>
-        </p:spPr>
-        <p:style>
-          <a:lnRef idx="1">
-            <a:schemeClr val="accent1"/>
-          </a:lnRef>
-          <a:fillRef idx="3">
-            <a:schemeClr val="accent1"/>
-          </a:fillRef>
-          <a:effectRef idx="2">
-            <a:schemeClr val="accent1"/>
-          </a:effectRef>
-          <a:fontRef idx="minor">
-            <a:schemeClr val="lt1"/>
-          </a:fontRef>
-        </p:style>
-        <p:txBody>
-          <a:bodyPr rtlCol="0" anchor="ctr"/>
-          <a:lstStyle/>
-          <a:p>
-            <a:pPr algn="ctr"/>
-          </a:p>
-        </p:txBody>
-      </p:sp>
-      <p:sp>
-        <p:nvSpPr>
-          <p:cNvPr id="3" name="TextBox 2"/>
-          <p:cNvSpPr txBox="1"/>
-          <p:nvPr/>
-        </p:nvSpPr>
-        <p:spPr>
-          <a:xfrm>
-            <a:off x="402336" y="301752"/>
-            <a:ext cx="8348472" cy="795528"/>
-          </a:xfrm>
-          <a:prstGeom prst="rect">
-            <a:avLst/>
-          </a:prstGeom>
-          <a:noFill/>
-        </p:spPr>
-        <p:txBody>
-          <a:bodyPr wrap="square">
-            <a:spAutoFit/>
-          </a:bodyPr>
-          <a:lstStyle/>
-          <a:p>
-            <a:r>
-              <a:rPr sz="2800" b="1">
-                <a:solidFill>
-                  <a:srgbClr val="0F0F0F"/>
-                </a:solidFill>
-                <a:latin typeface="Fira Sans"/>
-              </a:rPr>
-              <a:t>Síntesis</a:t>
-            </a:r>
-          </a:p>
-        </p:txBody>
-      </p:sp>
-      <p:sp>
-        <p:nvSpPr>
-          <p:cNvPr id="4" name="TextBox 3"/>
-          <p:cNvSpPr txBox="1"/>
-          <p:nvPr/>
-        </p:nvSpPr>
-        <p:spPr>
-          <a:xfrm>
-            <a:off x="704088" y="1353312"/>
-            <a:ext cx="7744968" cy="3300984"/>
-          </a:xfrm>
-          <a:prstGeom prst="rect">
-            <a:avLst/>
-          </a:prstGeom>
-          <a:noFill/>
-        </p:spPr>
-        <p:txBody>
-          <a:bodyPr wrap="square">
-            <a:spAutoFit/>
-          </a:bodyPr>
-          <a:lstStyle/>
-          <a:p>
-            <a:pPr>
-              <a:lnSpc>
-                <a:spcPct val="112000"/>
-              </a:lnSpc>
-              <a:spcAft>
-                <a:spcPts val="900"/>
-              </a:spcAft>
-            </a:pPr>
-            <a:r>
-              <a:rPr sz="1800" b="1">
-                <a:solidFill>
-                  <a:srgbClr val="E0A437"/>
-                </a:solidFill>
-                <a:latin typeface="Fira Sans"/>
-              </a:rPr>
-              <a:t>▸ </a:t>
-            </a:r>
-            <a:r>
-              <a:rPr sz="1800" b="1">
-                <a:solidFill>
-                  <a:srgbClr val="1D3557"/>
-                </a:solidFill>
-                <a:latin typeface="Fira Sans"/>
-              </a:rPr>
-              <a:t>Un proyecto de datos empieza en la pregunta, no en los datos.</a:t>
-            </a:r>
-          </a:p>
-          <a:p>
-            <a:pPr>
-              <a:lnSpc>
-                <a:spcPct val="112000"/>
-              </a:lnSpc>
-              <a:spcAft>
-                <a:spcPts val="900"/>
-              </a:spcAft>
-            </a:pPr>
-            <a:r>
-              <a:rPr sz="1800" b="1">
-                <a:solidFill>
-                  <a:srgbClr val="E0A437"/>
-                </a:solidFill>
-                <a:latin typeface="Fira Sans"/>
-              </a:rPr>
-              <a:t>▸ </a:t>
-            </a:r>
-            <a:r>
-              <a:rPr sz="1800" b="0">
-                <a:solidFill>
-                  <a:srgbClr val="000000"/>
-                </a:solidFill>
-                <a:latin typeface="Fira Sans"/>
-              </a:rPr>
-              <a:t>La ciencia de datos es la extracción generalizable de conocimiento desde los datos (Dhar, 2013), y une estadística, computación y dominio.</a:t>
-            </a:r>
-          </a:p>
-          <a:p>
-            <a:pPr>
-              <a:lnSpc>
-                <a:spcPct val="112000"/>
-              </a:lnSpc>
-              <a:spcAft>
-                <a:spcPts val="900"/>
-              </a:spcAft>
-            </a:pPr>
-            <a:r>
-              <a:rPr sz="1800" b="1">
-                <a:solidFill>
-                  <a:srgbClr val="E0A437"/>
-                </a:solidFill>
-                <a:latin typeface="Fira Sans"/>
-              </a:rPr>
-              <a:t>▸ </a:t>
-            </a:r>
-            <a:r>
-              <a:rPr sz="1800" b="0">
-                <a:solidFill>
-                  <a:srgbClr val="000000"/>
-                </a:solidFill>
-                <a:latin typeface="Fira Sans"/>
-              </a:rPr>
-              <a:t>El ciclo de vida ordena el trabajo y se recorre más de una vez.</a:t>
-            </a:r>
-          </a:p>
-          <a:p>
-            <a:pPr>
-              <a:lnSpc>
-                <a:spcPct val="112000"/>
-              </a:lnSpc>
-              <a:spcAft>
-                <a:spcPts val="900"/>
-              </a:spcAft>
-            </a:pPr>
-            <a:r>
-              <a:rPr sz="1800" b="1">
-                <a:solidFill>
-                  <a:srgbClr val="E0A437"/>
-                </a:solidFill>
-                <a:latin typeface="Fira Sans"/>
-              </a:rPr>
-              <a:t>▸ </a:t>
-            </a:r>
-            <a:r>
-              <a:rPr sz="1800" b="0">
-                <a:solidFill>
-                  <a:srgbClr val="000000"/>
-                </a:solidFill>
-                <a:latin typeface="Fira Sans"/>
-              </a:rPr>
-              <a:t>El tipo de cada variable define qué análisis es válido.</a:t>
-            </a:r>
-          </a:p>
-          <a:p>
-            <a:pPr>
-              <a:lnSpc>
-                <a:spcPct val="112000"/>
-              </a:lnSpc>
-              <a:spcAft>
-                <a:spcPts val="900"/>
-              </a:spcAft>
-            </a:pPr>
-            <a:r>
-              <a:rPr sz="1800" b="1">
-                <a:solidFill>
-                  <a:srgbClr val="E0A437"/>
-                </a:solidFill>
-                <a:latin typeface="Fira Sans"/>
-              </a:rPr>
-              <a:t>▸ </a:t>
-            </a:r>
-            <a:r>
-              <a:rPr sz="1800" b="0">
-                <a:solidFill>
-                  <a:srgbClr val="000000"/>
-                </a:solidFill>
-                <a:latin typeface="Fira Sans"/>
-              </a:rPr>
-              <a:t>Próxima clase (jueves 27): estadística descriptiva, con el entorno ya funcionando.</a:t>
-            </a:r>
-          </a:p>
-        </p:txBody>
-      </p:sp>
-    </p:spTree>
-  </p:cSld>
-  <p:clrMapOvr>
-    <a:masterClrMapping/>
-  </p:clrMapOvr>
-</p:sld>
-</file>
-
-<file path=ppt/slides/slide32.xml><?xml version="1.0" encoding="utf-8"?>
-<p:sld xmlns:a="http://schemas.openxmlformats.org/drawingml/2006/main" xmlns:p="http://schemas.openxmlformats.org/presentationml/2006/main" xmlns:r="http://schemas.openxmlformats.org/officeDocument/2006/relationships">
-  <p:cSld>
-    <p:spTree>
-      <p:nvGrpSpPr>
-        <p:cNvPr id="1" name=""/>
-        <p:cNvGrpSpPr/>
-        <p:nvPr/>
-      </p:nvGrpSpPr>
-      <p:grpSpPr/>
-      <p:sp>
-        <p:nvSpPr>
-          <p:cNvPr id="2" name="Rectangle 1"/>
-          <p:cNvSpPr/>
-          <p:nvPr/>
-        </p:nvSpPr>
-        <p:spPr>
-          <a:xfrm>
-            <a:off x="0" y="0"/>
-            <a:ext cx="9144000" cy="5138928"/>
-          </a:xfrm>
-          <a:prstGeom prst="rect">
-            <a:avLst/>
-          </a:prstGeom>
-          <a:solidFill>
-            <a:srgbClr val="FAFBFC"/>
-          </a:solidFill>
-          <a:ln>
-            <a:noFill/>
-          </a:ln>
-          <a:effectLst/>
-        </p:spPr>
-        <p:style>
-          <a:lnRef idx="1">
-            <a:schemeClr val="accent1"/>
-          </a:lnRef>
-          <a:fillRef idx="3">
-            <a:schemeClr val="accent1"/>
-          </a:fillRef>
-          <a:effectRef idx="2">
-            <a:schemeClr val="accent1"/>
-          </a:effectRef>
-          <a:fontRef idx="minor">
-            <a:schemeClr val="lt1"/>
-          </a:fontRef>
-        </p:style>
-        <p:txBody>
-          <a:bodyPr rtlCol="0" anchor="ctr"/>
-          <a:lstStyle/>
-          <a:p>
-            <a:pPr algn="ctr"/>
-          </a:p>
-        </p:txBody>
-      </p:sp>
-      <p:sp>
-        <p:nvSpPr>
-          <p:cNvPr id="3" name="TextBox 2"/>
-          <p:cNvSpPr txBox="1"/>
-          <p:nvPr/>
-        </p:nvSpPr>
-        <p:spPr>
-          <a:xfrm>
-            <a:off x="402336" y="301752"/>
-            <a:ext cx="8348472" cy="795528"/>
-          </a:xfrm>
-          <a:prstGeom prst="rect">
-            <a:avLst/>
-          </a:prstGeom>
-          <a:noFill/>
-        </p:spPr>
-        <p:txBody>
-          <a:bodyPr wrap="square">
-            <a:spAutoFit/>
-          </a:bodyPr>
-          <a:lstStyle/>
-          <a:p>
-            <a:r>
-              <a:rPr sz="2800" b="1">
-                <a:solidFill>
-                  <a:srgbClr val="0F0F0F"/>
-                </a:solidFill>
-                <a:latin typeface="Fira Sans"/>
-              </a:rPr>
-              <a:t>Referencias</a:t>
-            </a:r>
-          </a:p>
-        </p:txBody>
-      </p:sp>
-      <p:sp>
-        <p:nvSpPr>
-          <p:cNvPr id="4" name="TextBox 3"/>
-          <p:cNvSpPr txBox="1"/>
-          <p:nvPr/>
-        </p:nvSpPr>
-        <p:spPr>
-          <a:xfrm>
-            <a:off x="704088" y="1234440"/>
-            <a:ext cx="7744968" cy="3566160"/>
-          </a:xfrm>
-          <a:prstGeom prst="rect">
-            <a:avLst/>
-          </a:prstGeom>
-          <a:noFill/>
-        </p:spPr>
-        <p:txBody>
-          <a:bodyPr wrap="square">
-            <a:spAutoFit/>
-          </a:bodyPr>
-          <a:lstStyle/>
-          <a:p>
-            <a:pPr>
-              <a:lnSpc>
-                <a:spcPct val="115000"/>
-              </a:lnSpc>
-              <a:spcAft>
-                <a:spcPts val="700"/>
-              </a:spcAft>
-            </a:pPr>
-            <a:r>
-              <a:rPr sz="1300" b="0">
-                <a:solidFill>
-                  <a:srgbClr val="333333"/>
-                </a:solidFill>
-                <a:latin typeface="Fira Sans"/>
-              </a:rPr>
-              <a:t>Snow, J. (1855). On the Mode of Communication of Cholera (2ª edición). Londres: John Churchill.</a:t>
-            </a:r>
-          </a:p>
-          <a:p>
-            <a:pPr>
-              <a:lnSpc>
-                <a:spcPct val="115000"/>
-              </a:lnSpc>
-              <a:spcAft>
-                <a:spcPts val="700"/>
-              </a:spcAft>
-            </a:pPr>
-            <a:r>
-              <a:rPr sz="1300" b="0">
-                <a:solidFill>
-                  <a:srgbClr val="333333"/>
-                </a:solidFill>
-                <a:latin typeface="Fira Sans"/>
-              </a:rPr>
-              <a:t>Cleveland, W. S. (2001). Data Science: An Action Plan for Expanding the Technical Areas of the Field of Statistics. International Statistical Review, 69(1), 21-26.</a:t>
-            </a:r>
-          </a:p>
-          <a:p>
-            <a:pPr>
-              <a:lnSpc>
-                <a:spcPct val="115000"/>
-              </a:lnSpc>
-              <a:spcAft>
-                <a:spcPts val="700"/>
-              </a:spcAft>
-            </a:pPr>
-            <a:r>
-              <a:rPr sz="1300" b="0">
-                <a:solidFill>
-                  <a:srgbClr val="333333"/>
-                </a:solidFill>
-                <a:latin typeface="Fira Sans"/>
-              </a:rPr>
-              <a:t>Dhar, V. (2013). Data Science and Prediction. Communications of the ACM, 56(12), 64-73.</a:t>
-            </a:r>
-          </a:p>
-          <a:p>
-            <a:pPr>
-              <a:lnSpc>
-                <a:spcPct val="115000"/>
-              </a:lnSpc>
-              <a:spcAft>
-                <a:spcPts val="700"/>
-              </a:spcAft>
-            </a:pPr>
-            <a:r>
-              <a:rPr sz="1300" b="0">
-                <a:solidFill>
-                  <a:srgbClr val="333333"/>
-                </a:solidFill>
-                <a:latin typeface="Fira Sans"/>
-              </a:rPr>
-              <a:t>Donoho, D. (2017). 50 Years of Data Science. Journal of Computational and Graphical Statistics, 26(4), 745-766.</a:t>
-            </a:r>
-          </a:p>
-          <a:p>
-            <a:pPr>
-              <a:lnSpc>
-                <a:spcPct val="115000"/>
-              </a:lnSpc>
-              <a:spcAft>
-                <a:spcPts val="700"/>
-              </a:spcAft>
-            </a:pPr>
-            <a:r>
-              <a:rPr sz="1300" b="0">
-                <a:solidFill>
-                  <a:srgbClr val="333333"/>
-                </a:solidFill>
-                <a:latin typeface="Fira Sans"/>
-              </a:rPr>
-              <a:t>VanderPlas, J. (2016). Python Data Science Handbook. O'Reilly. Versión en línea: jakevdp.github.io/PythonDataScienceHandbook</a:t>
+              <a:t>Es el criterio de partida de todo el módulo: la estadística descriptiva (clase 2) y el EDA (clase 3) se organizan según el tipo de variable.</a:t>
             </a:r>
           </a:p>
         </p:txBody>
@@ -8532,7 +7771,7 @@
                 </a:solidFill>
                 <a:latin typeface="Fira Sans"/>
               </a:rPr>
-              <a:t>La palabra clave es generalizable: lo aprendido en estos datos debe sostenerse más allá de ellos. Ahí viven la inferencia y la predicción, que estructuran la segunda mitad del módulo.</a:t>
+              <a:t>Generalizable: las conclusiones deben ser válidas fuera de los datos usados para obtenerlas. Este requisito define los dos objetivos del análisis, inferencia y predicción (clases 5 a 8).</a:t>
             </a:r>
           </a:p>
           <a:p>
@@ -8560,7 +7799,7 @@
                 </a:solidFill>
                 <a:latin typeface="Fira Sans"/>
               </a:rPr>
-              <a:t>No es una definición de la industria: Cleveland (2001) propuso el área como una ampliación técnica de la estadística, y Donoho (2017) la sistematiza como heredera de 50 años de análisis de datos.</a:t>
+              <a:t>Cleveland (2001) propuso el área como una ampliación técnica de la estadística; Donoho (2017) revisa su desarrollo durante los últimos 50 años.</a:t>
             </a:r>
           </a:p>
         </p:txBody>

</xml_diff>

<commit_message>
Portada con el nombre del módulo, outline sin EOD; fuera las slides del concepto central y de Snow
Co-Authored-By: Claude Fable 5 <noreply@anthropic.com>
</commit_message>
<xml_diff>
--- a/presentaciones/clase01_fundamentos_ecosistema.pptx
+++ b/presentaciones/clase01_fundamentos_ecosistema.pptx
@@ -32,8 +32,6 @@
     <p:sldId id="280" r:id="rId31"/>
     <p:sldId id="281" r:id="rId32"/>
     <p:sldId id="282" r:id="rId33"/>
-    <p:sldId id="283" r:id="rId34"/>
-    <p:sldId id="284" r:id="rId35"/>
   </p:sldIdLst>
   <p:sldSz cx="9144000" cy="5138928" type="screen4x3"/>
   <p:notesSz cx="6858000" cy="9144000"/>
@@ -3189,7 +3187,7 @@
                 </a:solidFill>
                 <a:latin typeface="Fira Sans"/>
               </a:rPr>
-              <a:t>Fundamentos de la ciencia de datos</a:t>
+              <a:t>Introducción y fundamentos estadísticos</a:t>
             </a:r>
           </a:p>
         </p:txBody>
@@ -3242,7 +3240,7 @@
                 </a:solidFill>
                 <a:latin typeface="Fira Sans"/>
               </a:rPr>
-              <a:t>Clase 1 · Módulo 1 del diplomado</a:t>
+              <a:t>Clase 1 · Introducción</a:t>
             </a:r>
           </a:p>
         </p:txBody>
@@ -3383,45 +3381,21 @@
                 </a:solidFill>
                 <a:latin typeface="Fira Sans"/>
               </a:rPr>
-              <a:t>Las etapas de un proyecto de ciencia de datos</a:t>
-            </a:r>
-          </a:p>
-        </p:txBody>
-      </p:sp>
-      <p:pic>
-        <p:nvPicPr>
-          <p:cNvPr id="4" name="Picture 3" descr="03_ciclo_vida.png"/>
-          <p:cNvPicPr>
-            <a:picLocks noChangeAspect="1"/>
-          </p:cNvPicPr>
-          <p:nvPr/>
-        </p:nvPicPr>
-        <p:blipFill>
-          <a:blip r:embed="rId2"/>
-          <a:stretch>
-            <a:fillRect/>
-          </a:stretch>
-        </p:blipFill>
-        <p:spPr>
-          <a:xfrm>
-            <a:off x="1417319" y="1143000"/>
-            <a:ext cx="6309360" cy="2137325"/>
-          </a:xfrm>
-          <a:prstGeom prst="rect">
-            <a:avLst/>
-          </a:prstGeom>
-        </p:spPr>
-      </p:pic>
-      <p:sp>
-        <p:nvSpPr>
-          <p:cNvPr id="5" name="TextBox 4"/>
+              <a:t>El proyecto final del módulo</a:t>
+            </a:r>
+          </a:p>
+        </p:txBody>
+      </p:sp>
+      <p:sp>
+        <p:nvSpPr>
+          <p:cNvPr id="4" name="TextBox 3"/>
           <p:cNvSpPr txBox="1"/>
           <p:nvPr/>
         </p:nvSpPr>
         <p:spPr>
           <a:xfrm>
-            <a:off x="704088" y="4434840"/>
-            <a:ext cx="7744968" cy="457200"/>
+            <a:off x="704088" y="1353312"/>
+            <a:ext cx="7744968" cy="3300984"/>
           </a:xfrm>
           <a:prstGeom prst="rect">
             <a:avLst/>
@@ -3434,14 +3408,115 @@
           </a:bodyPr>
           <a:lstStyle/>
           <a:p>
-            <a:r>
-              <a:rPr sz="1300" b="0">
-                <a:solidFill>
-                  <a:srgbClr val="333333"/>
-                </a:solidFill>
-                <a:latin typeface="Fira Sans"/>
-              </a:rPr>
-              <a:t>El ciclo tiene dos entradas: una necesidad del dominio o datos ya disponibles. Los hallazgos de una etapa pueden devolver el proyecto a etapas anteriores.</a:t>
+            <a:pPr>
+              <a:lnSpc>
+                <a:spcPct val="112000"/>
+              </a:lnSpc>
+              <a:spcAft>
+                <a:spcPts val="900"/>
+              </a:spcAft>
+            </a:pPr>
+            <a:r>
+              <a:rPr sz="1800" b="1">
+                <a:solidFill>
+                  <a:srgbClr val="E0A437"/>
+                </a:solidFill>
+                <a:latin typeface="Fira Sans"/>
+              </a:rPr>
+              <a:t>▸ </a:t>
+            </a:r>
+            <a:r>
+              <a:rPr sz="1800" b="0">
+                <a:solidFill>
+                  <a:srgbClr val="000000"/>
+                </a:solidFill>
+                <a:latin typeface="Fira Sans"/>
+              </a:rPr>
+              <a:t>El módulo se evalúa con un proyecto aplicado sobre datos reales, que recorre el ciclo completo: pregunta, datos, exploración, análisis y comunicación.</a:t>
+            </a:r>
+          </a:p>
+          <a:p>
+            <a:pPr>
+              <a:lnSpc>
+                <a:spcPct val="112000"/>
+              </a:lnSpc>
+              <a:spcAft>
+                <a:spcPts val="900"/>
+              </a:spcAft>
+            </a:pPr>
+            <a:r>
+              <a:rPr sz="1800" b="1">
+                <a:solidFill>
+                  <a:srgbClr val="E0A437"/>
+                </a:solidFill>
+                <a:latin typeface="Fira Sans"/>
+              </a:rPr>
+              <a:t>▸ </a:t>
+            </a:r>
+            <a:r>
+              <a:rPr sz="1800" b="0">
+                <a:solidFill>
+                  <a:srgbClr val="000000"/>
+                </a:solidFill>
+                <a:latin typeface="Fira Sans"/>
+              </a:rPr>
+              <a:t>Puede usar datos de su propio trabajo o un conjunto de datos público.</a:t>
+            </a:r>
+          </a:p>
+          <a:p>
+            <a:pPr>
+              <a:lnSpc>
+                <a:spcPct val="112000"/>
+              </a:lnSpc>
+              <a:spcAft>
+                <a:spcPts val="900"/>
+              </a:spcAft>
+            </a:pPr>
+            <a:r>
+              <a:rPr sz="1800" b="1">
+                <a:solidFill>
+                  <a:srgbClr val="E0A437"/>
+                </a:solidFill>
+                <a:latin typeface="Fira Sans"/>
+              </a:rPr>
+              <a:t>▸ </a:t>
+            </a:r>
+            <a:r>
+              <a:rPr sz="1800" b="1">
+                <a:solidFill>
+                  <a:srgbClr val="1D3557"/>
+                </a:solidFill>
+                <a:latin typeface="Fira Sans"/>
+              </a:rPr>
+              <a:t>Desde hoy: anote las preguntas de su trabajo que le gustaría responder con datos.</a:t>
+            </a:r>
+          </a:p>
+          <a:p>
+            <a:pPr>
+              <a:lnSpc>
+                <a:spcPct val="112000"/>
+              </a:lnSpc>
+              <a:spcAft>
+                <a:spcPts val="900"/>
+              </a:spcAft>
+            </a:pPr>
+            <a:r>
+              <a:rPr sz="1800" b="1">
+                <a:solidFill>
+                  <a:srgbClr val="E0A437"/>
+                </a:solidFill>
+                <a:latin typeface="Fira Sans"/>
+              </a:rPr>
+              <a:t>▸ </a:t>
+            </a:r>
+            <a:r>
+              <a:rPr sz="1800" b="0">
+                <a:solidFill>
+                  <a:srgbClr val="000000"/>
+                </a:solidFill>
+                <a:latin typeface="Fira Sans"/>
+              </a:rPr>
+              <a:t>El enunciado y la pauta se publican en las próximas clases.</a:t>
             </a:r>
           </a:p>
         </p:txBody>
@@ -3479,7 +3554,7 @@
             <a:avLst/>
           </a:prstGeom>
           <a:solidFill>
-            <a:srgbClr val="FAFBFC"/>
+            <a:srgbClr val="1D3557"/>
           </a:solidFill>
           <a:ln>
             <a:noFill/>
@@ -3516,8 +3591,8 @@
         </p:nvSpPr>
         <p:spPr>
           <a:xfrm>
-            <a:off x="402336" y="301752"/>
-            <a:ext cx="8348472" cy="795528"/>
+            <a:off x="603504" y="1847088"/>
+            <a:ext cx="7946136" cy="1399032"/>
           </a:xfrm>
           <a:prstGeom prst="rect">
             <a:avLst/>
@@ -3531,120 +3606,24 @@
           <a:lstStyle/>
           <a:p>
             <a:r>
-              <a:rPr sz="2800" b="1">
-                <a:solidFill>
-                  <a:srgbClr val="0F0F0F"/>
-                </a:solidFill>
-                <a:latin typeface="Fira Sans"/>
-              </a:rPr>
-              <a:t>Tres advertencias sobre el ciclo</a:t>
-            </a:r>
-          </a:p>
-        </p:txBody>
-      </p:sp>
-      <p:sp>
-        <p:nvSpPr>
-          <p:cNvPr id="4" name="TextBox 3"/>
-          <p:cNvSpPr txBox="1"/>
-          <p:nvPr/>
-        </p:nvSpPr>
-        <p:spPr>
-          <a:xfrm>
-            <a:off x="704088" y="1353312"/>
-            <a:ext cx="7744968" cy="3300984"/>
-          </a:xfrm>
-          <a:prstGeom prst="rect">
-            <a:avLst/>
-          </a:prstGeom>
-          <a:noFill/>
-        </p:spPr>
-        <p:txBody>
-          <a:bodyPr wrap="square">
-            <a:spAutoFit/>
-          </a:bodyPr>
-          <a:lstStyle/>
-          <a:p>
-            <a:pPr>
-              <a:lnSpc>
-                <a:spcPct val="112000"/>
-              </a:lnSpc>
-              <a:spcAft>
-                <a:spcPts val="900"/>
-              </a:spcAft>
-            </a:pPr>
-            <a:r>
-              <a:rPr sz="1800" b="1">
+              <a:rPr sz="3400" b="1">
+                <a:solidFill>
+                  <a:srgbClr val="FFFFFF"/>
+                </a:solidFill>
+                <a:latin typeface="Fira Sans"/>
+              </a:rPr>
+              <a:t>Tipos de datos y tipos de variables</a:t>
+            </a:r>
+          </a:p>
+          <a:p>
+            <a:r>
+              <a:rPr sz="1800" b="0">
                 <a:solidFill>
                   <a:srgbClr val="E0A437"/>
                 </a:solidFill>
                 <a:latin typeface="Fira Sans"/>
               </a:rPr>
-              <a:t>▸ </a:t>
-            </a:r>
-            <a:r>
-              <a:rPr sz="1800" b="0">
-                <a:solidFill>
-                  <a:srgbClr val="000000"/>
-                </a:solidFill>
-                <a:latin typeface="Fira Sans"/>
-              </a:rPr>
-              <a:t>Cargar y limpiar datos consume en promedio el 45% del tiempo de trabajo, más que el modelamiento (Anaconda, 2020; encuesta a 2.360 profesionales).</a:t>
-            </a:r>
-          </a:p>
-          <a:p>
-            <a:pPr>
-              <a:lnSpc>
-                <a:spcPct val="112000"/>
-              </a:lnSpc>
-              <a:spcAft>
-                <a:spcPts val="900"/>
-              </a:spcAft>
-            </a:pPr>
-            <a:r>
-              <a:rPr sz="1800" b="1">
-                <a:solidFill>
-                  <a:srgbClr val="E0A437"/>
-                </a:solidFill>
-                <a:latin typeface="Fira Sans"/>
-              </a:rPr>
-              <a:t>▸ </a:t>
-            </a:r>
-            <a:r>
-              <a:rPr sz="1800" b="0">
-                <a:solidFill>
-                  <a:srgbClr val="000000"/>
-                </a:solidFill>
-                <a:latin typeface="Fira Sans"/>
-              </a:rPr>
-              <a:t>El ciclo se recorre varias veces: un hallazgo cambia la pregunta y una limpieza revela problemas nuevos.</a:t>
-            </a:r>
-          </a:p>
-          <a:p>
-            <a:pPr>
-              <a:lnSpc>
-                <a:spcPct val="112000"/>
-              </a:lnSpc>
-              <a:spcAft>
-                <a:spcPts val="900"/>
-              </a:spcAft>
-            </a:pPr>
-            <a:r>
-              <a:rPr sz="1800" b="1">
-                <a:solidFill>
-                  <a:srgbClr val="E0A437"/>
-                </a:solidFill>
-                <a:latin typeface="Fira Sans"/>
-              </a:rPr>
-              <a:t>▸ </a:t>
-            </a:r>
-            <a:r>
-              <a:rPr sz="1800" b="0">
-                <a:solidFill>
-                  <a:srgbClr val="000000"/>
-                </a:solidFill>
-                <a:latin typeface="Fira Sans"/>
-              </a:rPr>
-              <a:t>Un error en la formulación del problema invalida las etapas posteriores; conviene revisarla antes de invertir en el resto.</a:t>
+              <a:t>Qué análisis admite cada columna</a:t>
             </a:r>
           </a:p>
         </p:txBody>
@@ -3740,7 +3719,7 @@
                 </a:solidFill>
                 <a:latin typeface="Fira Sans"/>
               </a:rPr>
-              <a:t>El proyecto final del módulo</a:t>
+              <a:t>Datos estructurados y no estructurados</a:t>
             </a:r>
           </a:p>
         </p:txBody>
@@ -3791,7 +3770,7 @@
                 </a:solidFill>
                 <a:latin typeface="Fira Sans"/>
               </a:rPr>
-              <a:t>El módulo se evalúa con un proyecto aplicado sobre datos reales, que recorre el ciclo completo: pregunta, datos, exploración, análisis y comunicación.</a:t>
+              <a:t>Estructurados: tablas con filas y columnas (la EOD, una base de ventas, un registro de sensores). Son el foco de este módulo.</a:t>
             </a:r>
           </a:p>
           <a:p>
@@ -3819,7 +3798,7 @@
                 </a:solidFill>
                 <a:latin typeface="Fira Sans"/>
               </a:rPr>
-              <a:t>Puede usar datos de su propio trabajo o un conjunto de datos público.</a:t>
+              <a:t>No estructurados: texto libre, imágenes, audio. Se trabajan en los módulos de machine learning y deep learning del diplomado.</a:t>
             </a:r>
           </a:p>
           <a:p>
@@ -3841,41 +3820,13 @@
               <a:t>▸ </a:t>
             </a:r>
             <a:r>
-              <a:rPr sz="1800" b="1">
-                <a:solidFill>
-                  <a:srgbClr val="1D3557"/>
-                </a:solidFill>
-                <a:latin typeface="Fira Sans"/>
-              </a:rPr>
-              <a:t>Desde hoy: anote las preguntas de su trabajo que le gustaría responder con datos.</a:t>
-            </a:r>
-          </a:p>
-          <a:p>
-            <a:pPr>
-              <a:lnSpc>
-                <a:spcPct val="112000"/>
-              </a:lnSpc>
-              <a:spcAft>
-                <a:spcPts val="900"/>
-              </a:spcAft>
-            </a:pPr>
-            <a:r>
-              <a:rPr sz="1800" b="1">
-                <a:solidFill>
-                  <a:srgbClr val="E0A437"/>
-                </a:solidFill>
-                <a:latin typeface="Fira Sans"/>
-              </a:rPr>
-              <a:t>▸ </a:t>
-            </a:r>
-            <a:r>
               <a:rPr sz="1800" b="0">
                 <a:solidFill>
                   <a:srgbClr val="000000"/>
                 </a:solidFill>
                 <a:latin typeface="Fira Sans"/>
               </a:rPr>
-              <a:t>El enunciado y la pauta se publican en las próximas clases.</a:t>
+              <a:t>En la práctica, analizar datos no estructurados suele requerir convertirlos primero en representaciones tabulares o numéricas.</a:t>
             </a:r>
           </a:p>
         </p:txBody>
@@ -3913,7 +3864,7 @@
             <a:avLst/>
           </a:prstGeom>
           <a:solidFill>
-            <a:srgbClr val="1D3557"/>
+            <a:srgbClr val="FAFBFC"/>
           </a:solidFill>
           <a:ln>
             <a:noFill/>
@@ -3950,8 +3901,8 @@
         </p:nvSpPr>
         <p:spPr>
           <a:xfrm>
-            <a:off x="603504" y="1847088"/>
-            <a:ext cx="7946136" cy="1399032"/>
+            <a:off x="402336" y="301752"/>
+            <a:ext cx="8348472" cy="795528"/>
           </a:xfrm>
           <a:prstGeom prst="rect">
             <a:avLst/>
@@ -3965,24 +3916,71 @@
           <a:lstStyle/>
           <a:p>
             <a:r>
-              <a:rPr sz="3400" b="1">
-                <a:solidFill>
-                  <a:srgbClr val="FFFFFF"/>
-                </a:solidFill>
-                <a:latin typeface="Fira Sans"/>
-              </a:rPr>
-              <a:t>Tipos de datos y tipos de variables</a:t>
-            </a:r>
-          </a:p>
-          <a:p>
-            <a:r>
-              <a:rPr sz="1800" b="0">
-                <a:solidFill>
-                  <a:srgbClr val="E0A437"/>
-                </a:solidFill>
-                <a:latin typeface="Fira Sans"/>
-              </a:rPr>
-              <a:t>Qué análisis admite cada columna</a:t>
+              <a:rPr sz="2800" b="1">
+                <a:solidFill>
+                  <a:srgbClr val="0F0F0F"/>
+                </a:solidFill>
+                <a:latin typeface="Fira Sans"/>
+              </a:rPr>
+              <a:t>Tipos de variables</a:t>
+            </a:r>
+          </a:p>
+        </p:txBody>
+      </p:sp>
+      <p:pic>
+        <p:nvPicPr>
+          <p:cNvPr id="4" name="Picture 3" descr="04_tipos_variables.png"/>
+          <p:cNvPicPr>
+            <a:picLocks noChangeAspect="1"/>
+          </p:cNvPicPr>
+          <p:nvPr/>
+        </p:nvPicPr>
+        <p:blipFill>
+          <a:blip r:embed="rId2"/>
+          <a:stretch>
+            <a:fillRect/>
+          </a:stretch>
+        </p:blipFill>
+        <p:spPr>
+          <a:xfrm>
+            <a:off x="1423172" y="1143000"/>
+            <a:ext cx="6297654" cy="3154680"/>
+          </a:xfrm>
+          <a:prstGeom prst="rect">
+            <a:avLst/>
+          </a:prstGeom>
+        </p:spPr>
+      </p:pic>
+      <p:sp>
+        <p:nvSpPr>
+          <p:cNvPr id="5" name="TextBox 4"/>
+          <p:cNvSpPr txBox="1"/>
+          <p:nvPr/>
+        </p:nvSpPr>
+        <p:spPr>
+          <a:xfrm>
+            <a:off x="704088" y="4434840"/>
+            <a:ext cx="7744968" cy="457200"/>
+          </a:xfrm>
+          <a:prstGeom prst="rect">
+            <a:avLst/>
+          </a:prstGeom>
+          <a:noFill/>
+        </p:spPr>
+        <p:txBody>
+          <a:bodyPr wrap="square">
+            <a:spAutoFit/>
+          </a:bodyPr>
+          <a:lstStyle/>
+          <a:p>
+            <a:r>
+              <a:rPr sz="1300" b="0">
+                <a:solidFill>
+                  <a:srgbClr val="333333"/>
+                </a:solidFill>
+                <a:latin typeface="Fira Sans"/>
+              </a:rPr>
+              <a:t>La misma tabla mezcla los cuatro tipos; cada columna se analiza según el suyo.</a:t>
             </a:r>
           </a:p>
         </p:txBody>
@@ -4078,7 +4076,7 @@
                 </a:solidFill>
                 <a:latin typeface="Fira Sans"/>
               </a:rPr>
-              <a:t>Datos estructurados y no estructurados</a:t>
+              <a:t>Códigos numéricos: variables nominales</a:t>
             </a:r>
           </a:p>
         </p:txBody>
@@ -4129,7 +4127,7 @@
                 </a:solidFill>
                 <a:latin typeface="Fira Sans"/>
               </a:rPr>
-              <a:t>Estructurados: tablas con filas y columnas (la EOD, una base de ventas, un registro de sensores). Son el foco de este módulo.</a:t>
+              <a:t>En la encuesta de viajes que exploraremos hoy en el notebook, la columna ComunaOrigen vale 94, 71, 13... pero es una variable nominal: los números son códigos de comuna.</a:t>
             </a:r>
           </a:p>
           <a:p>
@@ -4157,7 +4155,7 @@
                 </a:solidFill>
                 <a:latin typeface="Fira Sans"/>
               </a:rPr>
-              <a:t>No estructurados: texto libre, imágenes, audio. Se trabajan en los módulos de machine learning y deep learning del diplomado.</a:t>
+              <a:t>Promediar códigos de comuna no significa nada; contar viajes por comuna, sí.</a:t>
             </a:r>
           </a:p>
           <a:p>
@@ -4179,13 +4177,41 @@
               <a:t>▸ </a:t>
             </a:r>
             <a:r>
+              <a:rPr sz="1800" b="1">
+                <a:solidFill>
+                  <a:srgbClr val="1D3557"/>
+                </a:solidFill>
+                <a:latin typeface="Fira Sans"/>
+              </a:rPr>
+              <a:t>El tipo de la variable define qué resumen y qué gráfico son válidos: es lo primero que se revisa al abrir una tabla.</a:t>
+            </a:r>
+          </a:p>
+          <a:p>
+            <a:pPr>
+              <a:lnSpc>
+                <a:spcPct val="112000"/>
+              </a:lnSpc>
+              <a:spcAft>
+                <a:spcPts val="900"/>
+              </a:spcAft>
+            </a:pPr>
+            <a:r>
+              <a:rPr sz="1800" b="1">
+                <a:solidFill>
+                  <a:srgbClr val="E0A437"/>
+                </a:solidFill>
+                <a:latin typeface="Fira Sans"/>
+              </a:rPr>
+              <a:t>▸ </a:t>
+            </a:r>
+            <a:r>
               <a:rPr sz="1800" b="0">
                 <a:solidFill>
                   <a:srgbClr val="000000"/>
                 </a:solidFill>
                 <a:latin typeface="Fira Sans"/>
               </a:rPr>
-              <a:t>En la práctica, analizar datos no estructurados suele requerir convertirlos primero en representaciones tabulares o numéricas.</a:t>
+              <a:t>En la clase 2 esto se vuelve operativo: cada resumen de la estadística descriptiva aplica a ciertos tipos de variables.</a:t>
             </a:r>
           </a:p>
         </p:txBody>
@@ -4223,7 +4249,7 @@
             <a:avLst/>
           </a:prstGeom>
           <a:solidFill>
-            <a:srgbClr val="FAFBFC"/>
+            <a:srgbClr val="1D3557"/>
           </a:solidFill>
           <a:ln>
             <a:noFill/>
@@ -4260,8 +4286,8 @@
         </p:nvSpPr>
         <p:spPr>
           <a:xfrm>
-            <a:off x="402336" y="301752"/>
-            <a:ext cx="8348472" cy="795528"/>
+            <a:off x="603504" y="1847088"/>
+            <a:ext cx="7946136" cy="1399032"/>
           </a:xfrm>
           <a:prstGeom prst="rect">
             <a:avLst/>
@@ -4275,71 +4301,24 @@
           <a:lstStyle/>
           <a:p>
             <a:r>
-              <a:rPr sz="2800" b="1">
-                <a:solidFill>
-                  <a:srgbClr val="0F0F0F"/>
-                </a:solidFill>
-                <a:latin typeface="Fira Sans"/>
-              </a:rPr>
-              <a:t>Tipos de variables</a:t>
-            </a:r>
-          </a:p>
-        </p:txBody>
-      </p:sp>
-      <p:pic>
-        <p:nvPicPr>
-          <p:cNvPr id="4" name="Picture 3" descr="04_tipos_variables.png"/>
-          <p:cNvPicPr>
-            <a:picLocks noChangeAspect="1"/>
-          </p:cNvPicPr>
-          <p:nvPr/>
-        </p:nvPicPr>
-        <p:blipFill>
-          <a:blip r:embed="rId2"/>
-          <a:stretch>
-            <a:fillRect/>
-          </a:stretch>
-        </p:blipFill>
-        <p:spPr>
-          <a:xfrm>
-            <a:off x="1423172" y="1143000"/>
-            <a:ext cx="6297654" cy="3154680"/>
-          </a:xfrm>
-          <a:prstGeom prst="rect">
-            <a:avLst/>
-          </a:prstGeom>
-        </p:spPr>
-      </p:pic>
-      <p:sp>
-        <p:nvSpPr>
-          <p:cNvPr id="5" name="TextBox 4"/>
-          <p:cNvSpPr txBox="1"/>
-          <p:nvPr/>
-        </p:nvSpPr>
-        <p:spPr>
-          <a:xfrm>
-            <a:off x="704088" y="4434840"/>
-            <a:ext cx="7744968" cy="457200"/>
-          </a:xfrm>
-          <a:prstGeom prst="rect">
-            <a:avLst/>
-          </a:prstGeom>
-          <a:noFill/>
-        </p:spPr>
-        <p:txBody>
-          <a:bodyPr wrap="square">
-            <a:spAutoFit/>
-          </a:bodyPr>
-          <a:lstStyle/>
-          <a:p>
-            <a:r>
-              <a:rPr sz="1300" b="0">
-                <a:solidFill>
-                  <a:srgbClr val="333333"/>
-                </a:solidFill>
-                <a:latin typeface="Fira Sans"/>
-              </a:rPr>
-              <a:t>La misma tabla mezcla los cuatro tipos; cada columna se analiza según el suyo.</a:t>
+              <a:rPr sz="3400" b="1">
+                <a:solidFill>
+                  <a:srgbClr val="FFFFFF"/>
+                </a:solidFill>
+                <a:latin typeface="Fira Sans"/>
+              </a:rPr>
+              <a:t>Recreo</a:t>
+            </a:r>
+          </a:p>
+          <a:p>
+            <a:r>
+              <a:rPr sz="1800" b="0">
+                <a:solidFill>
+                  <a:srgbClr val="E0A437"/>
+                </a:solidFill>
+                <a:latin typeface="Fira Sans"/>
+              </a:rPr>
+              <a:t>10 minutos</a:t>
             </a:r>
           </a:p>
         </p:txBody>
@@ -4377,7 +4356,7 @@
             <a:avLst/>
           </a:prstGeom>
           <a:solidFill>
-            <a:srgbClr val="FAFBFC"/>
+            <a:srgbClr val="1D3557"/>
           </a:solidFill>
           <a:ln>
             <a:noFill/>
@@ -4414,8 +4393,8 @@
         </p:nvSpPr>
         <p:spPr>
           <a:xfrm>
-            <a:off x="402336" y="301752"/>
-            <a:ext cx="8348472" cy="795528"/>
+            <a:off x="603504" y="1847088"/>
+            <a:ext cx="7946136" cy="1399032"/>
           </a:xfrm>
           <a:prstGeom prst="rect">
             <a:avLst/>
@@ -4429,148 +4408,24 @@
           <a:lstStyle/>
           <a:p>
             <a:r>
-              <a:rPr sz="2800" b="1">
-                <a:solidFill>
-                  <a:srgbClr val="0F0F0F"/>
-                </a:solidFill>
-                <a:latin typeface="Fira Sans"/>
-              </a:rPr>
-              <a:t>Códigos numéricos: variables nominales</a:t>
-            </a:r>
-          </a:p>
-        </p:txBody>
-      </p:sp>
-      <p:sp>
-        <p:nvSpPr>
-          <p:cNvPr id="4" name="TextBox 3"/>
-          <p:cNvSpPr txBox="1"/>
-          <p:nvPr/>
-        </p:nvSpPr>
-        <p:spPr>
-          <a:xfrm>
-            <a:off x="704088" y="1353312"/>
-            <a:ext cx="7744968" cy="3300984"/>
-          </a:xfrm>
-          <a:prstGeom prst="rect">
-            <a:avLst/>
-          </a:prstGeom>
-          <a:noFill/>
-        </p:spPr>
-        <p:txBody>
-          <a:bodyPr wrap="square">
-            <a:spAutoFit/>
-          </a:bodyPr>
-          <a:lstStyle/>
-          <a:p>
-            <a:pPr>
-              <a:lnSpc>
-                <a:spcPct val="112000"/>
-              </a:lnSpc>
-              <a:spcAft>
-                <a:spcPts val="900"/>
-              </a:spcAft>
-            </a:pPr>
-            <a:r>
-              <a:rPr sz="1800" b="1">
+              <a:rPr sz="3400" b="1">
+                <a:solidFill>
+                  <a:srgbClr val="FFFFFF"/>
+                </a:solidFill>
+                <a:latin typeface="Fira Sans"/>
+              </a:rPr>
+              <a:t>El ecosistema Python</a:t>
+            </a:r>
+          </a:p>
+          <a:p>
+            <a:r>
+              <a:rPr sz="1800" b="0">
                 <a:solidFill>
                   <a:srgbClr val="E0A437"/>
                 </a:solidFill>
                 <a:latin typeface="Fira Sans"/>
               </a:rPr>
-              <a:t>▸ </a:t>
-            </a:r>
-            <a:r>
-              <a:rPr sz="1800" b="0">
-                <a:solidFill>
-                  <a:srgbClr val="000000"/>
-                </a:solidFill>
-                <a:latin typeface="Fira Sans"/>
-              </a:rPr>
-              <a:t>En la encuesta de viajes que exploraremos hoy en el notebook, la columna ComunaOrigen vale 94, 71, 13... pero es una variable nominal: los números son códigos de comuna.</a:t>
-            </a:r>
-          </a:p>
-          <a:p>
-            <a:pPr>
-              <a:lnSpc>
-                <a:spcPct val="112000"/>
-              </a:lnSpc>
-              <a:spcAft>
-                <a:spcPts val="900"/>
-              </a:spcAft>
-            </a:pPr>
-            <a:r>
-              <a:rPr sz="1800" b="1">
-                <a:solidFill>
-                  <a:srgbClr val="E0A437"/>
-                </a:solidFill>
-                <a:latin typeface="Fira Sans"/>
-              </a:rPr>
-              <a:t>▸ </a:t>
-            </a:r>
-            <a:r>
-              <a:rPr sz="1800" b="0">
-                <a:solidFill>
-                  <a:srgbClr val="000000"/>
-                </a:solidFill>
-                <a:latin typeface="Fira Sans"/>
-              </a:rPr>
-              <a:t>Promediar códigos de comuna no significa nada; contar viajes por comuna, sí.</a:t>
-            </a:r>
-          </a:p>
-          <a:p>
-            <a:pPr>
-              <a:lnSpc>
-                <a:spcPct val="112000"/>
-              </a:lnSpc>
-              <a:spcAft>
-                <a:spcPts val="900"/>
-              </a:spcAft>
-            </a:pPr>
-            <a:r>
-              <a:rPr sz="1800" b="1">
-                <a:solidFill>
-                  <a:srgbClr val="E0A437"/>
-                </a:solidFill>
-                <a:latin typeface="Fira Sans"/>
-              </a:rPr>
-              <a:t>▸ </a:t>
-            </a:r>
-            <a:r>
-              <a:rPr sz="1800" b="1">
-                <a:solidFill>
-                  <a:srgbClr val="1D3557"/>
-                </a:solidFill>
-                <a:latin typeface="Fira Sans"/>
-              </a:rPr>
-              <a:t>El tipo de la variable define qué resumen y qué gráfico son válidos: es lo primero que se revisa al abrir una tabla.</a:t>
-            </a:r>
-          </a:p>
-          <a:p>
-            <a:pPr>
-              <a:lnSpc>
-                <a:spcPct val="112000"/>
-              </a:lnSpc>
-              <a:spcAft>
-                <a:spcPts val="900"/>
-              </a:spcAft>
-            </a:pPr>
-            <a:r>
-              <a:rPr sz="1800" b="1">
-                <a:solidFill>
-                  <a:srgbClr val="E0A437"/>
-                </a:solidFill>
-                <a:latin typeface="Fira Sans"/>
-              </a:rPr>
-              <a:t>▸ </a:t>
-            </a:r>
-            <a:r>
-              <a:rPr sz="1800" b="0">
-                <a:solidFill>
-                  <a:srgbClr val="000000"/>
-                </a:solidFill>
-                <a:latin typeface="Fira Sans"/>
-              </a:rPr>
-              <a:t>En la clase 2 esto se vuelve operativo: cada resumen de la estadística descriptiva aplica a ciertos tipos de variables.</a:t>
+              <a:t>NumPy, Pandas y Matplotlib, más Jupyter y uv</a:t>
             </a:r>
           </a:p>
         </p:txBody>
@@ -4608,7 +4463,7 @@
             <a:avLst/>
           </a:prstGeom>
           <a:solidFill>
-            <a:srgbClr val="1D3557"/>
+            <a:srgbClr val="FAFBFC"/>
           </a:solidFill>
           <a:ln>
             <a:noFill/>
@@ -4645,8 +4500,8 @@
         </p:nvSpPr>
         <p:spPr>
           <a:xfrm>
-            <a:off x="603504" y="1847088"/>
-            <a:ext cx="7946136" cy="1399032"/>
+            <a:off x="402336" y="301752"/>
+            <a:ext cx="8348472" cy="795528"/>
           </a:xfrm>
           <a:prstGeom prst="rect">
             <a:avLst/>
@@ -4660,24 +4515,71 @@
           <a:lstStyle/>
           <a:p>
             <a:r>
-              <a:rPr sz="3400" b="1">
-                <a:solidFill>
-                  <a:srgbClr val="FFFFFF"/>
-                </a:solidFill>
-                <a:latin typeface="Fira Sans"/>
-              </a:rPr>
-              <a:t>Recreo</a:t>
-            </a:r>
-          </a:p>
-          <a:p>
-            <a:r>
-              <a:rPr sz="1800" b="0">
-                <a:solidFill>
-                  <a:srgbClr val="E0A437"/>
-                </a:solidFill>
-                <a:latin typeface="Fira Sans"/>
-              </a:rPr>
-              <a:t>10 minutos</a:t>
+              <a:rPr sz="2800" b="1">
+                <a:solidFill>
+                  <a:srgbClr val="0F0F0F"/>
+                </a:solidFill>
+                <a:latin typeface="Fira Sans"/>
+              </a:rPr>
+              <a:t>Las herramientas del módulo</a:t>
+            </a:r>
+          </a:p>
+        </p:txBody>
+      </p:sp>
+      <p:pic>
+        <p:nvPicPr>
+          <p:cNvPr id="4" name="Picture 3" descr="05_ecosistema.png"/>
+          <p:cNvPicPr>
+            <a:picLocks noChangeAspect="1"/>
+          </p:cNvPicPr>
+          <p:nvPr/>
+        </p:nvPicPr>
+        <p:blipFill>
+          <a:blip r:embed="rId2"/>
+          <a:stretch>
+            <a:fillRect/>
+          </a:stretch>
+        </p:blipFill>
+        <p:spPr>
+          <a:xfrm>
+            <a:off x="1417319" y="1143000"/>
+            <a:ext cx="6309360" cy="2814584"/>
+          </a:xfrm>
+          <a:prstGeom prst="rect">
+            <a:avLst/>
+          </a:prstGeom>
+        </p:spPr>
+      </p:pic>
+      <p:sp>
+        <p:nvSpPr>
+          <p:cNvPr id="5" name="TextBox 4"/>
+          <p:cNvSpPr txBox="1"/>
+          <p:nvPr/>
+        </p:nvSpPr>
+        <p:spPr>
+          <a:xfrm>
+            <a:off x="704088" y="4434840"/>
+            <a:ext cx="7744968" cy="457200"/>
+          </a:xfrm>
+          <a:prstGeom prst="rect">
+            <a:avLst/>
+          </a:prstGeom>
+          <a:noFill/>
+        </p:spPr>
+        <p:txBody>
+          <a:bodyPr wrap="square">
+            <a:spAutoFit/>
+          </a:bodyPr>
+          <a:lstStyle/>
+          <a:p>
+            <a:r>
+              <a:rPr sz="1300" b="0">
+                <a:solidFill>
+                  <a:srgbClr val="333333"/>
+                </a:solidFill>
+                <a:latin typeface="Fira Sans"/>
+              </a:rPr>
+              <a:t>Python trae la sintaxis; NumPy, Pandas y Matplotlib traen el trabajo con datos. Jupyter y uv son el entorno donde todo corre.</a:t>
             </a:r>
           </a:p>
         </p:txBody>
@@ -4715,7 +4617,7 @@
             <a:avLst/>
           </a:prstGeom>
           <a:solidFill>
-            <a:srgbClr val="1D3557"/>
+            <a:srgbClr val="FAFBFC"/>
           </a:solidFill>
           <a:ln>
             <a:noFill/>
@@ -4752,8 +4654,8 @@
         </p:nvSpPr>
         <p:spPr>
           <a:xfrm>
-            <a:off x="603504" y="1847088"/>
-            <a:ext cx="7946136" cy="1399032"/>
+            <a:off x="402336" y="301752"/>
+            <a:ext cx="8348472" cy="795528"/>
           </a:xfrm>
           <a:prstGeom prst="rect">
             <a:avLst/>
@@ -4767,24 +4669,143 @@
           <a:lstStyle/>
           <a:p>
             <a:r>
-              <a:rPr sz="3400" b="1">
-                <a:solidFill>
-                  <a:srgbClr val="FFFFFF"/>
-                </a:solidFill>
-                <a:latin typeface="Fira Sans"/>
-              </a:rPr>
-              <a:t>El ecosistema Python</a:t>
-            </a:r>
-          </a:p>
-          <a:p>
-            <a:r>
-              <a:rPr sz="1800" b="0">
+              <a:rPr sz="2800" b="1">
+                <a:solidFill>
+                  <a:srgbClr val="0F0F0F"/>
+                </a:solidFill>
+                <a:latin typeface="Fira Sans"/>
+              </a:rPr>
+              <a:t>NumPy: cálculo sobre arreglos completos</a:t>
+            </a:r>
+          </a:p>
+        </p:txBody>
+      </p:sp>
+      <p:sp>
+        <p:nvSpPr>
+          <p:cNvPr id="4" name="Rectangle 3"/>
+          <p:cNvSpPr/>
+          <p:nvPr/>
+        </p:nvSpPr>
+        <p:spPr>
+          <a:xfrm>
+            <a:off x="704088" y="1280160"/>
+            <a:ext cx="7744968" cy="1874520"/>
+          </a:xfrm>
+          <a:prstGeom prst="rect">
+            <a:avLst/>
+          </a:prstGeom>
+          <a:solidFill>
+            <a:srgbClr val="F0F2F5"/>
+          </a:solidFill>
+          <a:ln>
+            <a:solidFill>
+              <a:srgbClr val="D8DDE3"/>
+            </a:solidFill>
+          </a:ln>
+          <a:effectLst/>
+        </p:spPr>
+        <p:style>
+          <a:lnRef idx="1">
+            <a:schemeClr val="accent1"/>
+          </a:lnRef>
+          <a:fillRef idx="3">
+            <a:schemeClr val="accent1"/>
+          </a:fillRef>
+          <a:effectRef idx="2">
+            <a:schemeClr val="accent1"/>
+          </a:effectRef>
+          <a:fontRef idx="minor">
+            <a:schemeClr val="lt1"/>
+          </a:fontRef>
+        </p:style>
+        <p:txBody>
+          <a:bodyPr rtlCol="0" anchor="ctr" wrap="square" lIns="228600" tIns="137160"/>
+          <a:lstStyle/>
+          <a:p>
+            <a:pPr/>
+            <a:r>
+              <a:rPr sz="1500" b="0">
+                <a:solidFill>
+                  <a:srgbClr val="1D3557"/>
+                </a:solidFill>
+                <a:latin typeface="Menlo"/>
+              </a:rPr>
+              <a:t>import numpy as np</a:t>
+            </a:r>
+          </a:p>
+          <a:p>
+            <a:pPr/>
+            <a:r>
+              <a:rPr sz="1500" b="0">
+                <a:solidFill>
+                  <a:srgbClr val="1D3557"/>
+                </a:solidFill>
+                <a:latin typeface="Menlo"/>
+              </a:rPr>
+              <a:t>tiempos = np.array([70, 105, 90, 25, 40])</a:t>
+            </a:r>
+          </a:p>
+          <a:p>
+            <a:pPr/>
+            <a:r>
+              <a:rPr sz="1500" b="0">
+                <a:solidFill>
+                  <a:srgbClr val="1D3557"/>
+                </a:solidFill>
+                <a:latin typeface="Menlo"/>
+              </a:rPr>
+              <a:t>tiempos.mean()          # 66.0, sin escribir un ciclo</a:t>
+            </a:r>
+          </a:p>
+        </p:txBody>
+      </p:sp>
+      <p:sp>
+        <p:nvSpPr>
+          <p:cNvPr id="5" name="TextBox 4"/>
+          <p:cNvSpPr txBox="1"/>
+          <p:nvPr/>
+        </p:nvSpPr>
+        <p:spPr>
+          <a:xfrm>
+            <a:off x="704088" y="3383279"/>
+            <a:ext cx="7744968" cy="1097280"/>
+          </a:xfrm>
+          <a:prstGeom prst="rect">
+            <a:avLst/>
+          </a:prstGeom>
+          <a:noFill/>
+        </p:spPr>
+        <p:txBody>
+          <a:bodyPr wrap="square">
+            <a:spAutoFit/>
+          </a:bodyPr>
+          <a:lstStyle/>
+          <a:p>
+            <a:pPr>
+              <a:lnSpc>
+                <a:spcPct val="112000"/>
+              </a:lnSpc>
+              <a:spcAft>
+                <a:spcPts val="900"/>
+              </a:spcAft>
+            </a:pPr>
+            <a:r>
+              <a:rPr sz="1600" b="1">
                 <a:solidFill>
                   <a:srgbClr val="E0A437"/>
                 </a:solidFill>
                 <a:latin typeface="Fira Sans"/>
               </a:rPr>
-              <a:t>NumPy, Pandas y Matplotlib, más Jupyter y uv</a:t>
+              <a:t>▸ </a:t>
+            </a:r>
+            <a:r>
+              <a:rPr sz="1600" b="0">
+                <a:solidFill>
+                  <a:srgbClr val="000000"/>
+                </a:solidFill>
+                <a:latin typeface="Fira Sans"/>
+              </a:rPr>
+              <a:t>La operación se aplica al arreglo completo (vectorización): menos código y mucho más rápido que iterar en Python puro. Es la base sobre la que se construye todo lo demás.</a:t>
             </a:r>
           </a:p>
         </p:txBody>
@@ -4880,35 +4901,90 @@
                 </a:solidFill>
                 <a:latin typeface="Fira Sans"/>
               </a:rPr>
-              <a:t>Las herramientas del módulo</a:t>
-            </a:r>
-          </a:p>
-        </p:txBody>
-      </p:sp>
-      <p:pic>
-        <p:nvPicPr>
-          <p:cNvPr id="4" name="Picture 3" descr="05_ecosistema.png"/>
-          <p:cNvPicPr>
-            <a:picLocks noChangeAspect="1"/>
-          </p:cNvPicPr>
-          <p:nvPr/>
-        </p:nvPicPr>
-        <p:blipFill>
-          <a:blip r:embed="rId2"/>
-          <a:stretch>
-            <a:fillRect/>
-          </a:stretch>
-        </p:blipFill>
-        <p:spPr>
-          <a:xfrm>
-            <a:off x="1417319" y="1143000"/>
-            <a:ext cx="6309360" cy="2814584"/>
-          </a:xfrm>
-          <a:prstGeom prst="rect">
-            <a:avLst/>
-          </a:prstGeom>
-        </p:spPr>
-      </p:pic>
+              <a:t>Pandas: la tabla como objeto de trabajo</a:t>
+            </a:r>
+          </a:p>
+        </p:txBody>
+      </p:sp>
+      <p:sp>
+        <p:nvSpPr>
+          <p:cNvPr id="4" name="Rectangle 3"/>
+          <p:cNvSpPr/>
+          <p:nvPr/>
+        </p:nvSpPr>
+        <p:spPr>
+          <a:xfrm>
+            <a:off x="704088" y="1280160"/>
+            <a:ext cx="7744968" cy="1874520"/>
+          </a:xfrm>
+          <a:prstGeom prst="rect">
+            <a:avLst/>
+          </a:prstGeom>
+          <a:solidFill>
+            <a:srgbClr val="F0F2F5"/>
+          </a:solidFill>
+          <a:ln>
+            <a:solidFill>
+              <a:srgbClr val="D8DDE3"/>
+            </a:solidFill>
+          </a:ln>
+          <a:effectLst/>
+        </p:spPr>
+        <p:style>
+          <a:lnRef idx="1">
+            <a:schemeClr val="accent1"/>
+          </a:lnRef>
+          <a:fillRef idx="3">
+            <a:schemeClr val="accent1"/>
+          </a:fillRef>
+          <a:effectRef idx="2">
+            <a:schemeClr val="accent1"/>
+          </a:effectRef>
+          <a:fontRef idx="minor">
+            <a:schemeClr val="lt1"/>
+          </a:fontRef>
+        </p:style>
+        <p:txBody>
+          <a:bodyPr rtlCol="0" anchor="ctr" wrap="square" lIns="228600" tIns="137160"/>
+          <a:lstStyle/>
+          <a:p>
+            <a:pPr/>
+            <a:r>
+              <a:rPr sz="1500" b="0">
+                <a:solidFill>
+                  <a:srgbClr val="1D3557"/>
+                </a:solidFill>
+                <a:latin typeface="Menlo"/>
+              </a:rPr>
+              <a:t>import pandas as pd</a:t>
+            </a:r>
+          </a:p>
+          <a:p>
+            <a:pPr/>
+            <a:r>
+              <a:rPr sz="1500" b="0">
+                <a:solidFill>
+                  <a:srgbClr val="1D3557"/>
+                </a:solidFill>
+                <a:latin typeface="Menlo"/>
+              </a:rPr>
+              <a:t>viajes = pd.read_csv(URL_VIAJES, sep=";", decimal=",")</a:t>
+            </a:r>
+          </a:p>
+          <a:p>
+            <a:pPr/>
+            <a:r>
+              <a:rPr sz="1500" b="0">
+                <a:solidFill>
+                  <a:srgbClr val="1D3557"/>
+                </a:solidFill>
+                <a:latin typeface="Menlo"/>
+              </a:rPr>
+              <a:t>viajes.head()</a:t>
+            </a:r>
+          </a:p>
+        </p:txBody>
+      </p:sp>
       <p:sp>
         <p:nvSpPr>
           <p:cNvPr id="5" name="TextBox 4"/>
@@ -4917,8 +4993,8 @@
         </p:nvSpPr>
         <p:spPr>
           <a:xfrm>
-            <a:off x="704088" y="4434840"/>
-            <a:ext cx="7744968" cy="457200"/>
+            <a:off x="704088" y="3383279"/>
+            <a:ext cx="7744968" cy="1097280"/>
           </a:xfrm>
           <a:prstGeom prst="rect">
             <a:avLst/>
@@ -4931,14 +5007,31 @@
           </a:bodyPr>
           <a:lstStyle/>
           <a:p>
-            <a:r>
-              <a:rPr sz="1300" b="0">
-                <a:solidFill>
-                  <a:srgbClr val="333333"/>
-                </a:solidFill>
-                <a:latin typeface="Fira Sans"/>
-              </a:rPr>
-              <a:t>Python trae la sintaxis; NumPy, Pandas y Matplotlib traen el trabajo con datos. Jupyter y uv son el entorno donde todo corre.</a:t>
+            <a:pPr>
+              <a:lnSpc>
+                <a:spcPct val="112000"/>
+              </a:lnSpc>
+              <a:spcAft>
+                <a:spcPts val="900"/>
+              </a:spcAft>
+            </a:pPr>
+            <a:r>
+              <a:rPr sz="1600" b="1">
+                <a:solidFill>
+                  <a:srgbClr val="E0A437"/>
+                </a:solidFill>
+                <a:latin typeface="Fira Sans"/>
+              </a:rPr>
+              <a:t>▸ </a:t>
+            </a:r>
+            <a:r>
+              <a:rPr sz="1600" b="0">
+                <a:solidFill>
+                  <a:srgbClr val="000000"/>
+                </a:solidFill>
+                <a:latin typeface="Fira Sans"/>
+              </a:rPr>
+              <a:t>El DataFrame es una tabla con columnas etiquetadas, cada una de su propio tipo. Con esas tres líneas se abre la EOD completa: lo haremos en vivo en el notebook de hoy.</a:t>
             </a:r>
           </a:p>
         </p:txBody>
@@ -5085,7 +5178,7 @@
                 </a:solidFill>
                 <a:latin typeface="Fira Sans"/>
               </a:rPr>
-              <a:t>1. Qué es la ciencia de datos: definiciones y el episodio de Snow.</a:t>
+              <a:t>1. Qué es la ciencia de datos.</a:t>
             </a:r>
           </a:p>
           <a:p>
@@ -5197,7 +5290,7 @@
                 </a:solidFill>
                 <a:latin typeface="Fira Sans"/>
               </a:rPr>
-              <a:t>5. Puesta en marcha del entorno y práctica con datos reales: la Encuesta Origen Destino de Santiago.</a:t>
+              <a:t>5. Puesta en marcha del entorno y ejemplo con Pandas.</a:t>
             </a:r>
           </a:p>
         </p:txBody>
@@ -5293,90 +5386,35 @@
                 </a:solidFill>
                 <a:latin typeface="Fira Sans"/>
               </a:rPr>
-              <a:t>NumPy: cálculo sobre arreglos completos</a:t>
-            </a:r>
-          </a:p>
-        </p:txBody>
-      </p:sp>
-      <p:sp>
-        <p:nvSpPr>
-          <p:cNvPr id="4" name="Rectangle 3"/>
-          <p:cNvSpPr/>
-          <p:nvPr/>
-        </p:nvSpPr>
-        <p:spPr>
-          <a:xfrm>
-            <a:off x="704088" y="1280160"/>
-            <a:ext cx="7744968" cy="1874520"/>
-          </a:xfrm>
-          <a:prstGeom prst="rect">
-            <a:avLst/>
-          </a:prstGeom>
-          <a:solidFill>
-            <a:srgbClr val="F0F2F5"/>
-          </a:solidFill>
-          <a:ln>
-            <a:solidFill>
-              <a:srgbClr val="D8DDE3"/>
-            </a:solidFill>
-          </a:ln>
-          <a:effectLst/>
-        </p:spPr>
-        <p:style>
-          <a:lnRef idx="1">
-            <a:schemeClr val="accent1"/>
-          </a:lnRef>
-          <a:fillRef idx="3">
-            <a:schemeClr val="accent1"/>
-          </a:fillRef>
-          <a:effectRef idx="2">
-            <a:schemeClr val="accent1"/>
-          </a:effectRef>
-          <a:fontRef idx="minor">
-            <a:schemeClr val="lt1"/>
-          </a:fontRef>
-        </p:style>
-        <p:txBody>
-          <a:bodyPr rtlCol="0" anchor="ctr" wrap="square" lIns="228600" tIns="137160"/>
-          <a:lstStyle/>
-          <a:p>
-            <a:pPr/>
-            <a:r>
-              <a:rPr sz="1500" b="0">
-                <a:solidFill>
-                  <a:srgbClr val="1D3557"/>
-                </a:solidFill>
-                <a:latin typeface="Menlo"/>
-              </a:rPr>
-              <a:t>import numpy as np</a:t>
-            </a:r>
-          </a:p>
-          <a:p>
-            <a:pPr/>
-            <a:r>
-              <a:rPr sz="1500" b="0">
-                <a:solidFill>
-                  <a:srgbClr val="1D3557"/>
-                </a:solidFill>
-                <a:latin typeface="Menlo"/>
-              </a:rPr>
-              <a:t>tiempos = np.array([70, 105, 90, 25, 40])</a:t>
-            </a:r>
-          </a:p>
-          <a:p>
-            <a:pPr/>
-            <a:r>
-              <a:rPr sz="1500" b="0">
-                <a:solidFill>
-                  <a:srgbClr val="1D3557"/>
-                </a:solidFill>
-                <a:latin typeface="Menlo"/>
-              </a:rPr>
-              <a:t>tiempos.mean()          # 66.0, sin escribir un ciclo</a:t>
-            </a:r>
-          </a:p>
-        </p:txBody>
-      </p:sp>
+              <a:t>La Encuesta Origen Destino de Santiago 2012</a:t>
+            </a:r>
+          </a:p>
+        </p:txBody>
+      </p:sp>
+      <p:pic>
+        <p:nvPicPr>
+          <p:cNvPr id="4" name="Picture 3" descr="02_df_viajes.png"/>
+          <p:cNvPicPr>
+            <a:picLocks noChangeAspect="1"/>
+          </p:cNvPicPr>
+          <p:nvPr/>
+        </p:nvPicPr>
+        <p:blipFill>
+          <a:blip r:embed="rId2"/>
+          <a:stretch>
+            <a:fillRect/>
+          </a:stretch>
+        </p:blipFill>
+        <p:spPr>
+          <a:xfrm>
+            <a:off x="1417319" y="1143000"/>
+            <a:ext cx="6309360" cy="2296353"/>
+          </a:xfrm>
+          <a:prstGeom prst="rect">
+            <a:avLst/>
+          </a:prstGeom>
+        </p:spPr>
+      </p:pic>
       <p:sp>
         <p:nvSpPr>
           <p:cNvPr id="5" name="TextBox 4"/>
@@ -5385,8 +5423,8 @@
         </p:nvSpPr>
         <p:spPr>
           <a:xfrm>
-            <a:off x="704088" y="3383279"/>
-            <a:ext cx="7744968" cy="1097280"/>
+            <a:off x="704088" y="4434840"/>
+            <a:ext cx="7744968" cy="457200"/>
           </a:xfrm>
           <a:prstGeom prst="rect">
             <a:avLst/>
@@ -5399,31 +5437,14 @@
           </a:bodyPr>
           <a:lstStyle/>
           <a:p>
-            <a:pPr>
-              <a:lnSpc>
-                <a:spcPct val="112000"/>
-              </a:lnSpc>
-              <a:spcAft>
-                <a:spcPts val="900"/>
-              </a:spcAft>
-            </a:pPr>
-            <a:r>
-              <a:rPr sz="1600" b="1">
-                <a:solidFill>
-                  <a:srgbClr val="E0A437"/>
-                </a:solidFill>
-                <a:latin typeface="Fira Sans"/>
-              </a:rPr>
-              <a:t>▸ </a:t>
-            </a:r>
-            <a:r>
-              <a:rPr sz="1600" b="0">
-                <a:solidFill>
-                  <a:srgbClr val="000000"/>
-                </a:solidFill>
-                <a:latin typeface="Fira Sans"/>
-              </a:rPr>
-              <a:t>La operación se aplica al arreglo completo (vectorización): menos código y mucho más rápido que iterar en Python puro. Es la base sobre la que se construye todo lo demás.</a:t>
+            <a:r>
+              <a:rPr sz="1300" b="0">
+                <a:solidFill>
+                  <a:srgbClr val="333333"/>
+                </a:solidFill>
+                <a:latin typeface="Fira Sans"/>
+              </a:rPr>
+              <a:t>EOD Santiago 2012: 18.264 hogares, 60.054 personas y 113.591 viajes registrados. Cada fila es un viaje; los códigos se resuelven contra tablas de parámetros.</a:t>
             </a:r>
           </a:p>
         </p:txBody>
@@ -5519,7 +5540,7 @@
                 </a:solidFill>
                 <a:latin typeface="Fira Sans"/>
               </a:rPr>
-              <a:t>Pandas: la tabla como objeto de trabajo</a:t>
+              <a:t>Pandas: unir tablas con merge</a:t>
             </a:r>
           </a:p>
         </p:txBody>
@@ -5533,7 +5554,7 @@
         <p:spPr>
           <a:xfrm>
             <a:off x="704088" y="1280160"/>
-            <a:ext cx="7744968" cy="1874520"/>
+            <a:ext cx="7744968" cy="1371600"/>
           </a:xfrm>
           <a:prstGeom prst="rect">
             <a:avLst/>
@@ -5574,7 +5595,7 @@
                 </a:solidFill>
                 <a:latin typeface="Menlo"/>
               </a:rPr>
-              <a:t>import pandas as pd</a:t>
+              <a:t>comunas = pd.read_csv(URL_COMUNAS)   # Id, Comuna</a:t>
             </a:r>
           </a:p>
           <a:p>
@@ -5586,19 +5607,7 @@
                 </a:solidFill>
                 <a:latin typeface="Menlo"/>
               </a:rPr>
-              <a:t>viajes = pd.read_csv(URL_VIAJES, sep=";", decimal=",")</a:t>
-            </a:r>
-          </a:p>
-          <a:p>
-            <a:pPr/>
-            <a:r>
-              <a:rPr sz="1500" b="0">
-                <a:solidFill>
-                  <a:srgbClr val="1D3557"/>
-                </a:solidFill>
-                <a:latin typeface="Menlo"/>
-              </a:rPr>
-              <a:t>viajes.head()</a:t>
+              <a:t>viajes.merge(comunas, left_on="ComunaOrigen", right_on="Id")</a:t>
             </a:r>
           </a:p>
         </p:txBody>
@@ -5611,7 +5620,7 @@
         </p:nvSpPr>
         <p:spPr>
           <a:xfrm>
-            <a:off x="704088" y="3383279"/>
+            <a:off x="704088" y="2880360"/>
             <a:ext cx="7744968" cy="1097280"/>
           </a:xfrm>
           <a:prstGeom prst="rect">
@@ -5649,7 +5658,7 @@
                 </a:solidFill>
                 <a:latin typeface="Fira Sans"/>
               </a:rPr>
-              <a:t>El DataFrame es una tabla con columnas etiquetadas, cada una de su propio tipo. Con esas tres líneas se abre la EOD completa: lo haremos en vivo en el notebook de hoy.</a:t>
+              <a:t>Los códigos de una tabla se traducen uniéndola con su tabla de parámetros: merge empareja filas por una columna común. En el notebook lo usamos para ponerle nombre a comunas y modos de viaje.</a:t>
             </a:r>
           </a:p>
         </p:txBody>
@@ -5745,14 +5754,14 @@
                 </a:solidFill>
                 <a:latin typeface="Fira Sans"/>
               </a:rPr>
-              <a:t>La Encuesta Origen Destino de Santiago 2012</a:t>
+              <a:t>Matplotlib: del DataFrame al gráfico</a:t>
             </a:r>
           </a:p>
         </p:txBody>
       </p:sp>
       <p:pic>
         <p:nvPicPr>
-          <p:cNvPr id="4" name="Picture 3" descr="02_df_viajes.png"/>
+          <p:cNvPr id="4" name="Picture 3" descr="06_hist_tiempo.png"/>
           <p:cNvPicPr>
             <a:picLocks noChangeAspect="1"/>
           </p:cNvPicPr>
@@ -5766,8 +5775,8 @@
         </p:blipFill>
         <p:spPr>
           <a:xfrm>
-            <a:off x="1417319" y="1143000"/>
-            <a:ext cx="6309360" cy="2296353"/>
+            <a:off x="1778310" y="1143000"/>
+            <a:ext cx="5587379" cy="3154680"/>
           </a:xfrm>
           <a:prstGeom prst="rect">
             <a:avLst/>
@@ -5803,7 +5812,7 @@
                 </a:solidFill>
                 <a:latin typeface="Fira Sans"/>
               </a:rPr>
-              <a:t>EOD Santiago 2012: 18.264 hogares, 60.054 personas y 113.591 viajes registrados. Cada fila es un viaje; los códigos se resuelven contra tablas de parámetros.</a:t>
+              <a:t>Este histograma sale de la tabla de viajes con unas seis líneas de código; el notebook de la clase las muestra completas.</a:t>
             </a:r>
           </a:p>
         </p:txBody>
@@ -5899,7 +5908,7 @@
                 </a:solidFill>
                 <a:latin typeface="Fira Sans"/>
               </a:rPr>
-              <a:t>Pandas: unir tablas con merge</a:t>
+              <a:t>Puesta en marcha del entorno</a:t>
             </a:r>
           </a:p>
         </p:txBody>
@@ -5913,7 +5922,7 @@
         <p:spPr>
           <a:xfrm>
             <a:off x="704088" y="1280160"/>
-            <a:ext cx="7744968" cy="1371600"/>
+            <a:ext cx="7744968" cy="2377440"/>
           </a:xfrm>
           <a:prstGeom prst="rect">
             <a:avLst/>
@@ -5954,7 +5963,7 @@
                 </a:solidFill>
                 <a:latin typeface="Menlo"/>
               </a:rPr>
-              <a:t>comunas = pd.read_csv(URL_COMUNAS)   # Id, Comuna</a:t>
+              <a:t>uv init --bare --python 3.12</a:t>
             </a:r>
           </a:p>
           <a:p>
@@ -5966,7 +5975,31 @@
                 </a:solidFill>
                 <a:latin typeface="Menlo"/>
               </a:rPr>
-              <a:t>viajes.merge(comunas, left_on="ComunaOrigen", right_on="Id")</a:t>
+              <a:t>uv add numpy pandas matplotlib seaborn scipy</a:t>
+            </a:r>
+          </a:p>
+          <a:p>
+            <a:pPr/>
+            <a:r>
+              <a:rPr sz="1500" b="0">
+                <a:solidFill>
+                  <a:srgbClr val="1D3557"/>
+                </a:solidFill>
+                <a:latin typeface="Menlo"/>
+              </a:rPr>
+              <a:t>uv add statsmodels scikit-learn jupyterlab</a:t>
+            </a:r>
+          </a:p>
+          <a:p>
+            <a:pPr/>
+            <a:r>
+              <a:rPr sz="1500" b="0">
+                <a:solidFill>
+                  <a:srgbClr val="1D3557"/>
+                </a:solidFill>
+                <a:latin typeface="Menlo"/>
+              </a:rPr>
+              <a:t>uv run jupyter lab</a:t>
             </a:r>
           </a:p>
         </p:txBody>
@@ -5979,7 +6012,7 @@
         </p:nvSpPr>
         <p:spPr>
           <a:xfrm>
-            <a:off x="704088" y="2880360"/>
+            <a:off x="704088" y="3886200"/>
             <a:ext cx="7744968" cy="1097280"/>
           </a:xfrm>
           <a:prstGeom prst="rect">
@@ -6017,7 +6050,7 @@
                 </a:solidFill>
                 <a:latin typeface="Fira Sans"/>
               </a:rPr>
-              <a:t>Los códigos de una tabla se traducen uniéndola con su tabla de parámetros: merge empareja filas por una columna común. En el notebook lo usamos para ponerle nombre a comunas y modos de viaje.</a:t>
+              <a:t>La guía de instalación del repositorio (github.com/daniopitz/diplomado-cdd) detalla estos pasos por sistema operativo y los problemas frecuentes. Lo hacemos juntos ahora; debe quedar funcionando antes de la clase 2. Alternativa sin instalar nada: Google Colab, con los enlaces del repositorio.</a:t>
             </a:r>
           </a:p>
         </p:txBody>
@@ -6113,14 +6146,14 @@
                 </a:solidFill>
                 <a:latin typeface="Fira Sans"/>
               </a:rPr>
-              <a:t>Matplotlib: del DataFrame al gráfico</a:t>
+              <a:t>Reparto modal de Santiago, EOD 2012</a:t>
             </a:r>
           </a:p>
         </p:txBody>
       </p:sp>
       <p:pic>
         <p:nvPicPr>
-          <p:cNvPr id="4" name="Picture 3" descr="06_hist_tiempo.png"/>
+          <p:cNvPr id="4" name="Picture 3" descr="01_reparto_modal.png"/>
           <p:cNvPicPr>
             <a:picLocks noChangeAspect="1"/>
           </p:cNvPicPr>
@@ -6134,8 +6167,8 @@
         </p:blipFill>
         <p:spPr>
           <a:xfrm>
-            <a:off x="1778310" y="1143000"/>
-            <a:ext cx="5587379" cy="3154680"/>
+            <a:off x="1604462" y="1143000"/>
+            <a:ext cx="5935075" cy="3154680"/>
           </a:xfrm>
           <a:prstGeom prst="rect">
             <a:avLst/>
@@ -6171,7 +6204,7 @@
                 </a:solidFill>
                 <a:latin typeface="Fira Sans"/>
               </a:rPr>
-              <a:t>Este histograma sale de la tabla de viajes con unas seis líneas de código; el notebook de la clase las muestra completas.</a:t>
+              <a:t>Uno de cada tres viajes es a pie. Esta versión está ponderada por factores de expansión, así que habla de la ciudad; en el notebook calcularemos la versión muestral, y la diferencia entre ambas abre las clases 2 y 3.</a:t>
             </a:r>
           </a:p>
         </p:txBody>
@@ -6267,112 +6300,21 @@
                 </a:solidFill>
                 <a:latin typeface="Fira Sans"/>
               </a:rPr>
-              <a:t>Puesta en marcha del entorno</a:t>
-            </a:r>
-          </a:p>
-        </p:txBody>
-      </p:sp>
-      <p:sp>
-        <p:nvSpPr>
-          <p:cNvPr id="4" name="Rectangle 3"/>
-          <p:cNvSpPr/>
-          <p:nvPr/>
-        </p:nvSpPr>
-        <p:spPr>
-          <a:xfrm>
-            <a:off x="704088" y="1280160"/>
-            <a:ext cx="7744968" cy="2377440"/>
-          </a:xfrm>
-          <a:prstGeom prst="rect">
-            <a:avLst/>
-          </a:prstGeom>
-          <a:solidFill>
-            <a:srgbClr val="F0F2F5"/>
-          </a:solidFill>
-          <a:ln>
-            <a:solidFill>
-              <a:srgbClr val="D8DDE3"/>
-            </a:solidFill>
-          </a:ln>
-          <a:effectLst/>
-        </p:spPr>
-        <p:style>
-          <a:lnRef idx="1">
-            <a:schemeClr val="accent1"/>
-          </a:lnRef>
-          <a:fillRef idx="3">
-            <a:schemeClr val="accent1"/>
-          </a:fillRef>
-          <a:effectRef idx="2">
-            <a:schemeClr val="accent1"/>
-          </a:effectRef>
-          <a:fontRef idx="minor">
-            <a:schemeClr val="lt1"/>
-          </a:fontRef>
-        </p:style>
-        <p:txBody>
-          <a:bodyPr rtlCol="0" anchor="ctr" wrap="square" lIns="228600" tIns="137160"/>
-          <a:lstStyle/>
-          <a:p>
-            <a:pPr/>
-            <a:r>
-              <a:rPr sz="1500" b="0">
-                <a:solidFill>
-                  <a:srgbClr val="1D3557"/>
-                </a:solidFill>
-                <a:latin typeface="Menlo"/>
-              </a:rPr>
-              <a:t>uv init --bare --python 3.12</a:t>
-            </a:r>
-          </a:p>
-          <a:p>
-            <a:pPr/>
-            <a:r>
-              <a:rPr sz="1500" b="0">
-                <a:solidFill>
-                  <a:srgbClr val="1D3557"/>
-                </a:solidFill>
-                <a:latin typeface="Menlo"/>
-              </a:rPr>
-              <a:t>uv add numpy pandas matplotlib seaborn scipy</a:t>
-            </a:r>
-          </a:p>
-          <a:p>
-            <a:pPr/>
-            <a:r>
-              <a:rPr sz="1500" b="0">
-                <a:solidFill>
-                  <a:srgbClr val="1D3557"/>
-                </a:solidFill>
-                <a:latin typeface="Menlo"/>
-              </a:rPr>
-              <a:t>uv add statsmodels scikit-learn jupyterlab</a:t>
-            </a:r>
-          </a:p>
-          <a:p>
-            <a:pPr/>
-            <a:r>
-              <a:rPr sz="1500" b="0">
-                <a:solidFill>
-                  <a:srgbClr val="1D3557"/>
-                </a:solidFill>
-                <a:latin typeface="Menlo"/>
-              </a:rPr>
-              <a:t>uv run jupyter lab</a:t>
-            </a:r>
-          </a:p>
-        </p:txBody>
-      </p:sp>
-      <p:sp>
-        <p:nvSpPr>
-          <p:cNvPr id="5" name="TextBox 4"/>
+              <a:t>Actividad de cierre</a:t>
+            </a:r>
+          </a:p>
+        </p:txBody>
+      </p:sp>
+      <p:sp>
+        <p:nvSpPr>
+          <p:cNvPr id="4" name="TextBox 3"/>
           <p:cNvSpPr txBox="1"/>
           <p:nvPr/>
         </p:nvSpPr>
         <p:spPr>
           <a:xfrm>
-            <a:off x="704088" y="3886200"/>
-            <a:ext cx="7744968" cy="1097280"/>
+            <a:off x="704088" y="1353312"/>
+            <a:ext cx="7744968" cy="3300984"/>
           </a:xfrm>
           <a:prstGeom prst="rect">
             <a:avLst/>
@@ -6394,7 +6336,7 @@
               </a:spcAft>
             </a:pPr>
             <a:r>
-              <a:rPr sz="1600" b="1">
+              <a:rPr sz="1800" b="1">
                 <a:solidFill>
                   <a:srgbClr val="E0A437"/>
                 </a:solidFill>
@@ -6403,13 +6345,69 @@
               <a:t>▸ </a:t>
             </a:r>
             <a:r>
-              <a:rPr sz="1600" b="0">
+              <a:rPr sz="1800" b="1">
+                <a:solidFill>
+                  <a:srgbClr val="1D3557"/>
+                </a:solidFill>
+                <a:latin typeface="Fira Sans"/>
+              </a:rPr>
+              <a:t>Escriba en el chat una decisión de su trabajo que hoy se toma por intuición y podría tomarse con datos, o un conjunto de datos que su organización acumula y no analiza.</a:t>
+            </a:r>
+          </a:p>
+          <a:p>
+            <a:pPr>
+              <a:lnSpc>
+                <a:spcPct val="112000"/>
+              </a:lnSpc>
+              <a:spcAft>
+                <a:spcPts val="900"/>
+              </a:spcAft>
+            </a:pPr>
+            <a:r>
+              <a:rPr sz="1800" b="1">
+                <a:solidFill>
+                  <a:srgbClr val="E0A437"/>
+                </a:solidFill>
+                <a:latin typeface="Fira Sans"/>
+              </a:rPr>
+              <a:t>▸ </a:t>
+            </a:r>
+            <a:r>
+              <a:rPr sz="1800" b="0">
                 <a:solidFill>
                   <a:srgbClr val="000000"/>
                 </a:solidFill>
                 <a:latin typeface="Fira Sans"/>
               </a:rPr>
-              <a:t>La guía de instalación del repositorio (github.com/daniopitz/diplomado-cdd) detalla estos pasos por sistema operativo y los problemas frecuentes. Lo hacemos juntos ahora; debe quedar funcionando antes de la clase 2. Alternativa sin instalar nada: Google Colab, con los enlaces del repositorio.</a:t>
+              <a:t>Comentaremos dos o tres: cuál sería la pregunta, qué datos harían falta, qué etapa del ciclo sería la difícil.</a:t>
+            </a:r>
+          </a:p>
+          <a:p>
+            <a:pPr>
+              <a:lnSpc>
+                <a:spcPct val="112000"/>
+              </a:lnSpc>
+              <a:spcAft>
+                <a:spcPts val="900"/>
+              </a:spcAft>
+            </a:pPr>
+            <a:r>
+              <a:rPr sz="1800" b="1">
+                <a:solidFill>
+                  <a:srgbClr val="E0A437"/>
+                </a:solidFill>
+                <a:latin typeface="Fira Sans"/>
+              </a:rPr>
+              <a:t>▸ </a:t>
+            </a:r>
+            <a:r>
+              <a:rPr sz="1800" b="0">
+                <a:solidFill>
+                  <a:srgbClr val="000000"/>
+                </a:solidFill>
+                <a:latin typeface="Fira Sans"/>
+              </a:rPr>
+              <a:t>Guarde la suya: puede ser el germen de su proyecto final.</a:t>
             </a:r>
           </a:p>
         </p:txBody>
@@ -6505,45 +6503,21 @@
                 </a:solidFill>
                 <a:latin typeface="Fira Sans"/>
               </a:rPr>
-              <a:t>Reparto modal de Santiago, EOD 2012</a:t>
-            </a:r>
-          </a:p>
-        </p:txBody>
-      </p:sp>
-      <p:pic>
-        <p:nvPicPr>
-          <p:cNvPr id="4" name="Picture 3" descr="01_reparto_modal.png"/>
-          <p:cNvPicPr>
-            <a:picLocks noChangeAspect="1"/>
-          </p:cNvPicPr>
-          <p:nvPr/>
-        </p:nvPicPr>
-        <p:blipFill>
-          <a:blip r:embed="rId2"/>
-          <a:stretch>
-            <a:fillRect/>
-          </a:stretch>
-        </p:blipFill>
-        <p:spPr>
-          <a:xfrm>
-            <a:off x="1604462" y="1143000"/>
-            <a:ext cx="5935075" cy="3154680"/>
-          </a:xfrm>
-          <a:prstGeom prst="rect">
-            <a:avLst/>
-          </a:prstGeom>
-        </p:spPr>
-      </p:pic>
-      <p:sp>
-        <p:nvSpPr>
-          <p:cNvPr id="5" name="TextBox 4"/>
+              <a:t>Síntesis</a:t>
+            </a:r>
+          </a:p>
+        </p:txBody>
+      </p:sp>
+      <p:sp>
+        <p:nvSpPr>
+          <p:cNvPr id="4" name="TextBox 3"/>
           <p:cNvSpPr txBox="1"/>
           <p:nvPr/>
         </p:nvSpPr>
         <p:spPr>
           <a:xfrm>
-            <a:off x="704088" y="4434840"/>
-            <a:ext cx="7744968" cy="457200"/>
+            <a:off x="704088" y="1353312"/>
+            <a:ext cx="7744968" cy="3300984"/>
           </a:xfrm>
           <a:prstGeom prst="rect">
             <a:avLst/>
@@ -6556,14 +6530,143 @@
           </a:bodyPr>
           <a:lstStyle/>
           <a:p>
-            <a:r>
-              <a:rPr sz="1300" b="0">
-                <a:solidFill>
-                  <a:srgbClr val="333333"/>
-                </a:solidFill>
-                <a:latin typeface="Fira Sans"/>
-              </a:rPr>
-              <a:t>Uno de cada tres viajes es a pie. Esta versión está ponderada por factores de expansión, así que habla de la ciudad; en el notebook calcularemos la versión muestral, y la diferencia entre ambas abre las clases 2 y 3.</a:t>
+            <a:pPr>
+              <a:lnSpc>
+                <a:spcPct val="112000"/>
+              </a:lnSpc>
+              <a:spcAft>
+                <a:spcPts val="900"/>
+              </a:spcAft>
+            </a:pPr>
+            <a:r>
+              <a:rPr sz="1800" b="1">
+                <a:solidFill>
+                  <a:srgbClr val="E0A437"/>
+                </a:solidFill>
+                <a:latin typeface="Fira Sans"/>
+              </a:rPr>
+              <a:t>▸ </a:t>
+            </a:r>
+            <a:r>
+              <a:rPr sz="1800" b="1">
+                <a:solidFill>
+                  <a:srgbClr val="1D3557"/>
+                </a:solidFill>
+                <a:latin typeface="Fira Sans"/>
+              </a:rPr>
+              <a:t>El tipo de cada variable determina qué resúmenes, gráficos y análisis son válidos.</a:t>
+            </a:r>
+          </a:p>
+          <a:p>
+            <a:pPr>
+              <a:lnSpc>
+                <a:spcPct val="112000"/>
+              </a:lnSpc>
+              <a:spcAft>
+                <a:spcPts val="900"/>
+              </a:spcAft>
+            </a:pPr>
+            <a:r>
+              <a:rPr sz="1800" b="1">
+                <a:solidFill>
+                  <a:srgbClr val="E0A437"/>
+                </a:solidFill>
+                <a:latin typeface="Fira Sans"/>
+              </a:rPr>
+              <a:t>▸ </a:t>
+            </a:r>
+            <a:r>
+              <a:rPr sz="1800" b="0">
+                <a:solidFill>
+                  <a:srgbClr val="000000"/>
+                </a:solidFill>
+                <a:latin typeface="Fira Sans"/>
+              </a:rPr>
+              <a:t>Ciencia de datos: extracción generalizable de conocimiento a partir de los datos (Dhar, 2013); combina estadística, computación y dominio.</a:t>
+            </a:r>
+          </a:p>
+          <a:p>
+            <a:pPr>
+              <a:lnSpc>
+                <a:spcPct val="112000"/>
+              </a:lnSpc>
+              <a:spcAft>
+                <a:spcPts val="900"/>
+              </a:spcAft>
+            </a:pPr>
+            <a:r>
+              <a:rPr sz="1800" b="1">
+                <a:solidFill>
+                  <a:srgbClr val="E0A437"/>
+                </a:solidFill>
+                <a:latin typeface="Fira Sans"/>
+              </a:rPr>
+              <a:t>▸ </a:t>
+            </a:r>
+            <a:r>
+              <a:rPr sz="1800" b="0">
+                <a:solidFill>
+                  <a:srgbClr val="000000"/>
+                </a:solidFill>
+                <a:latin typeface="Fira Sans"/>
+              </a:rPr>
+              <a:t>El ciclo de vida tiene dos entradas (una necesidad del dominio o datos disponibles) y se recorre de forma iterativa.</a:t>
+            </a:r>
+          </a:p>
+          <a:p>
+            <a:pPr>
+              <a:lnSpc>
+                <a:spcPct val="112000"/>
+              </a:lnSpc>
+              <a:spcAft>
+                <a:spcPts val="900"/>
+              </a:spcAft>
+            </a:pPr>
+            <a:r>
+              <a:rPr sz="1800" b="1">
+                <a:solidFill>
+                  <a:srgbClr val="E0A437"/>
+                </a:solidFill>
+                <a:latin typeface="Fira Sans"/>
+              </a:rPr>
+              <a:t>▸ </a:t>
+            </a:r>
+            <a:r>
+              <a:rPr sz="1800" b="0">
+                <a:solidFill>
+                  <a:srgbClr val="000000"/>
+                </a:solidFill>
+                <a:latin typeface="Fira Sans"/>
+              </a:rPr>
+              <a:t>La preparación de datos consume cerca de la mitad del tiempo de un proyecto (Anaconda, 2020).</a:t>
+            </a:r>
+          </a:p>
+          <a:p>
+            <a:pPr>
+              <a:lnSpc>
+                <a:spcPct val="112000"/>
+              </a:lnSpc>
+              <a:spcAft>
+                <a:spcPts val="900"/>
+              </a:spcAft>
+            </a:pPr>
+            <a:r>
+              <a:rPr sz="1800" b="1">
+                <a:solidFill>
+                  <a:srgbClr val="E0A437"/>
+                </a:solidFill>
+                <a:latin typeface="Fira Sans"/>
+              </a:rPr>
+              <a:t>▸ </a:t>
+            </a:r>
+            <a:r>
+              <a:rPr sz="1800" b="0">
+                <a:solidFill>
+                  <a:srgbClr val="000000"/>
+                </a:solidFill>
+                <a:latin typeface="Fira Sans"/>
+              </a:rPr>
+              <a:t>Próxima clase (jueves 27): estadística descriptiva, con el entorno ya funcionando.</a:t>
             </a:r>
           </a:p>
         </p:txBody>
@@ -6659,7 +6762,7 @@
                 </a:solidFill>
                 <a:latin typeface="Fira Sans"/>
               </a:rPr>
-              <a:t>Actividad de cierre</a:t>
+              <a:t>Referencias</a:t>
             </a:r>
           </a:p>
         </p:txBody>
@@ -6672,8 +6775,8 @@
         </p:nvSpPr>
         <p:spPr>
           <a:xfrm>
-            <a:off x="704088" y="1353312"/>
-            <a:ext cx="7744968" cy="3300984"/>
+            <a:off x="704088" y="1234440"/>
+            <a:ext cx="7744968" cy="3566160"/>
           </a:xfrm>
           <a:prstGeom prst="rect">
             <a:avLst/>
@@ -6685,487 +6788,6 @@
             <a:spAutoFit/>
           </a:bodyPr>
           <a:lstStyle/>
-          <a:p>
-            <a:pPr>
-              <a:lnSpc>
-                <a:spcPct val="112000"/>
-              </a:lnSpc>
-              <a:spcAft>
-                <a:spcPts val="900"/>
-              </a:spcAft>
-            </a:pPr>
-            <a:r>
-              <a:rPr sz="1800" b="1">
-                <a:solidFill>
-                  <a:srgbClr val="E0A437"/>
-                </a:solidFill>
-                <a:latin typeface="Fira Sans"/>
-              </a:rPr>
-              <a:t>▸ </a:t>
-            </a:r>
-            <a:r>
-              <a:rPr sz="1800" b="1">
-                <a:solidFill>
-                  <a:srgbClr val="1D3557"/>
-                </a:solidFill>
-                <a:latin typeface="Fira Sans"/>
-              </a:rPr>
-              <a:t>Escriba en el chat una decisión de su trabajo que hoy se toma por intuición y podría tomarse con datos, o un conjunto de datos que su organización acumula y no analiza.</a:t>
-            </a:r>
-          </a:p>
-          <a:p>
-            <a:pPr>
-              <a:lnSpc>
-                <a:spcPct val="112000"/>
-              </a:lnSpc>
-              <a:spcAft>
-                <a:spcPts val="900"/>
-              </a:spcAft>
-            </a:pPr>
-            <a:r>
-              <a:rPr sz="1800" b="1">
-                <a:solidFill>
-                  <a:srgbClr val="E0A437"/>
-                </a:solidFill>
-                <a:latin typeface="Fira Sans"/>
-              </a:rPr>
-              <a:t>▸ </a:t>
-            </a:r>
-            <a:r>
-              <a:rPr sz="1800" b="0">
-                <a:solidFill>
-                  <a:srgbClr val="000000"/>
-                </a:solidFill>
-                <a:latin typeface="Fira Sans"/>
-              </a:rPr>
-              <a:t>Comentaremos dos o tres: cuál sería la pregunta, qué datos harían falta, qué etapa del ciclo sería la difícil.</a:t>
-            </a:r>
-          </a:p>
-          <a:p>
-            <a:pPr>
-              <a:lnSpc>
-                <a:spcPct val="112000"/>
-              </a:lnSpc>
-              <a:spcAft>
-                <a:spcPts val="900"/>
-              </a:spcAft>
-            </a:pPr>
-            <a:r>
-              <a:rPr sz="1800" b="1">
-                <a:solidFill>
-                  <a:srgbClr val="E0A437"/>
-                </a:solidFill>
-                <a:latin typeface="Fira Sans"/>
-              </a:rPr>
-              <a:t>▸ </a:t>
-            </a:r>
-            <a:r>
-              <a:rPr sz="1800" b="0">
-                <a:solidFill>
-                  <a:srgbClr val="000000"/>
-                </a:solidFill>
-                <a:latin typeface="Fira Sans"/>
-              </a:rPr>
-              <a:t>Guarde la suya: puede ser el germen de su proyecto final.</a:t>
-            </a:r>
-          </a:p>
-        </p:txBody>
-      </p:sp>
-    </p:spTree>
-  </p:cSld>
-  <p:clrMapOvr>
-    <a:masterClrMapping/>
-  </p:clrMapOvr>
-</p:sld>
-</file>
-
-<file path=ppt/slides/slide28.xml><?xml version="1.0" encoding="utf-8"?>
-<p:sld xmlns:a="http://schemas.openxmlformats.org/drawingml/2006/main" xmlns:p="http://schemas.openxmlformats.org/presentationml/2006/main" xmlns:r="http://schemas.openxmlformats.org/officeDocument/2006/relationships">
-  <p:cSld>
-    <p:spTree>
-      <p:nvGrpSpPr>
-        <p:cNvPr id="1" name=""/>
-        <p:cNvGrpSpPr/>
-        <p:nvPr/>
-      </p:nvGrpSpPr>
-      <p:grpSpPr/>
-      <p:sp>
-        <p:nvSpPr>
-          <p:cNvPr id="2" name="Rectangle 1"/>
-          <p:cNvSpPr/>
-          <p:nvPr/>
-        </p:nvSpPr>
-        <p:spPr>
-          <a:xfrm>
-            <a:off x="0" y="0"/>
-            <a:ext cx="9144000" cy="5138928"/>
-          </a:xfrm>
-          <a:prstGeom prst="rect">
-            <a:avLst/>
-          </a:prstGeom>
-          <a:solidFill>
-            <a:srgbClr val="FAFBFC"/>
-          </a:solidFill>
-          <a:ln>
-            <a:noFill/>
-          </a:ln>
-          <a:effectLst/>
-        </p:spPr>
-        <p:style>
-          <a:lnRef idx="1">
-            <a:schemeClr val="accent1"/>
-          </a:lnRef>
-          <a:fillRef idx="3">
-            <a:schemeClr val="accent1"/>
-          </a:fillRef>
-          <a:effectRef idx="2">
-            <a:schemeClr val="accent1"/>
-          </a:effectRef>
-          <a:fontRef idx="minor">
-            <a:schemeClr val="lt1"/>
-          </a:fontRef>
-        </p:style>
-        <p:txBody>
-          <a:bodyPr rtlCol="0" anchor="ctr"/>
-          <a:lstStyle/>
-          <a:p>
-            <a:pPr algn="ctr"/>
-          </a:p>
-        </p:txBody>
-      </p:sp>
-      <p:sp>
-        <p:nvSpPr>
-          <p:cNvPr id="3" name="TextBox 2"/>
-          <p:cNvSpPr txBox="1"/>
-          <p:nvPr/>
-        </p:nvSpPr>
-        <p:spPr>
-          <a:xfrm>
-            <a:off x="402336" y="301752"/>
-            <a:ext cx="8348472" cy="795528"/>
-          </a:xfrm>
-          <a:prstGeom prst="rect">
-            <a:avLst/>
-          </a:prstGeom>
-          <a:noFill/>
-        </p:spPr>
-        <p:txBody>
-          <a:bodyPr wrap="square">
-            <a:spAutoFit/>
-          </a:bodyPr>
-          <a:lstStyle/>
-          <a:p>
-            <a:r>
-              <a:rPr sz="2800" b="1">
-                <a:solidFill>
-                  <a:srgbClr val="0F0F0F"/>
-                </a:solidFill>
-                <a:latin typeface="Fira Sans"/>
-              </a:rPr>
-              <a:t>Síntesis</a:t>
-            </a:r>
-          </a:p>
-        </p:txBody>
-      </p:sp>
-      <p:sp>
-        <p:nvSpPr>
-          <p:cNvPr id="4" name="TextBox 3"/>
-          <p:cNvSpPr txBox="1"/>
-          <p:nvPr/>
-        </p:nvSpPr>
-        <p:spPr>
-          <a:xfrm>
-            <a:off x="704088" y="1353312"/>
-            <a:ext cx="7744968" cy="3300984"/>
-          </a:xfrm>
-          <a:prstGeom prst="rect">
-            <a:avLst/>
-          </a:prstGeom>
-          <a:noFill/>
-        </p:spPr>
-        <p:txBody>
-          <a:bodyPr wrap="square">
-            <a:spAutoFit/>
-          </a:bodyPr>
-          <a:lstStyle/>
-          <a:p>
-            <a:pPr>
-              <a:lnSpc>
-                <a:spcPct val="112000"/>
-              </a:lnSpc>
-              <a:spcAft>
-                <a:spcPts val="900"/>
-              </a:spcAft>
-            </a:pPr>
-            <a:r>
-              <a:rPr sz="1800" b="1">
-                <a:solidFill>
-                  <a:srgbClr val="E0A437"/>
-                </a:solidFill>
-                <a:latin typeface="Fira Sans"/>
-              </a:rPr>
-              <a:t>▸ </a:t>
-            </a:r>
-            <a:r>
-              <a:rPr sz="1800" b="1">
-                <a:solidFill>
-                  <a:srgbClr val="1D3557"/>
-                </a:solidFill>
-                <a:latin typeface="Fira Sans"/>
-              </a:rPr>
-              <a:t>El tipo de cada variable determina qué resúmenes, gráficos y análisis son válidos.</a:t>
-            </a:r>
-          </a:p>
-          <a:p>
-            <a:pPr>
-              <a:lnSpc>
-                <a:spcPct val="112000"/>
-              </a:lnSpc>
-              <a:spcAft>
-                <a:spcPts val="900"/>
-              </a:spcAft>
-            </a:pPr>
-            <a:r>
-              <a:rPr sz="1800" b="1">
-                <a:solidFill>
-                  <a:srgbClr val="E0A437"/>
-                </a:solidFill>
-                <a:latin typeface="Fira Sans"/>
-              </a:rPr>
-              <a:t>▸ </a:t>
-            </a:r>
-            <a:r>
-              <a:rPr sz="1800" b="0">
-                <a:solidFill>
-                  <a:srgbClr val="000000"/>
-                </a:solidFill>
-                <a:latin typeface="Fira Sans"/>
-              </a:rPr>
-              <a:t>Ciencia de datos: extracción generalizable de conocimiento a partir de los datos (Dhar, 2013); combina estadística, computación y dominio.</a:t>
-            </a:r>
-          </a:p>
-          <a:p>
-            <a:pPr>
-              <a:lnSpc>
-                <a:spcPct val="112000"/>
-              </a:lnSpc>
-              <a:spcAft>
-                <a:spcPts val="900"/>
-              </a:spcAft>
-            </a:pPr>
-            <a:r>
-              <a:rPr sz="1800" b="1">
-                <a:solidFill>
-                  <a:srgbClr val="E0A437"/>
-                </a:solidFill>
-                <a:latin typeface="Fira Sans"/>
-              </a:rPr>
-              <a:t>▸ </a:t>
-            </a:r>
-            <a:r>
-              <a:rPr sz="1800" b="0">
-                <a:solidFill>
-                  <a:srgbClr val="000000"/>
-                </a:solidFill>
-                <a:latin typeface="Fira Sans"/>
-              </a:rPr>
-              <a:t>El ciclo de vida tiene dos entradas (una necesidad del dominio o datos disponibles) y se recorre de forma iterativa.</a:t>
-            </a:r>
-          </a:p>
-          <a:p>
-            <a:pPr>
-              <a:lnSpc>
-                <a:spcPct val="112000"/>
-              </a:lnSpc>
-              <a:spcAft>
-                <a:spcPts val="900"/>
-              </a:spcAft>
-            </a:pPr>
-            <a:r>
-              <a:rPr sz="1800" b="1">
-                <a:solidFill>
-                  <a:srgbClr val="E0A437"/>
-                </a:solidFill>
-                <a:latin typeface="Fira Sans"/>
-              </a:rPr>
-              <a:t>▸ </a:t>
-            </a:r>
-            <a:r>
-              <a:rPr sz="1800" b="0">
-                <a:solidFill>
-                  <a:srgbClr val="000000"/>
-                </a:solidFill>
-                <a:latin typeface="Fira Sans"/>
-              </a:rPr>
-              <a:t>La preparación de datos consume cerca de la mitad del tiempo de un proyecto (Anaconda, 2020).</a:t>
-            </a:r>
-          </a:p>
-          <a:p>
-            <a:pPr>
-              <a:lnSpc>
-                <a:spcPct val="112000"/>
-              </a:lnSpc>
-              <a:spcAft>
-                <a:spcPts val="900"/>
-              </a:spcAft>
-            </a:pPr>
-            <a:r>
-              <a:rPr sz="1800" b="1">
-                <a:solidFill>
-                  <a:srgbClr val="E0A437"/>
-                </a:solidFill>
-                <a:latin typeface="Fira Sans"/>
-              </a:rPr>
-              <a:t>▸ </a:t>
-            </a:r>
-            <a:r>
-              <a:rPr sz="1800" b="0">
-                <a:solidFill>
-                  <a:srgbClr val="000000"/>
-                </a:solidFill>
-                <a:latin typeface="Fira Sans"/>
-              </a:rPr>
-              <a:t>Próxima clase (jueves 27): estadística descriptiva, con el entorno ya funcionando.</a:t>
-            </a:r>
-          </a:p>
-        </p:txBody>
-      </p:sp>
-    </p:spTree>
-  </p:cSld>
-  <p:clrMapOvr>
-    <a:masterClrMapping/>
-  </p:clrMapOvr>
-</p:sld>
-</file>
-
-<file path=ppt/slides/slide29.xml><?xml version="1.0" encoding="utf-8"?>
-<p:sld xmlns:a="http://schemas.openxmlformats.org/drawingml/2006/main" xmlns:p="http://schemas.openxmlformats.org/presentationml/2006/main" xmlns:r="http://schemas.openxmlformats.org/officeDocument/2006/relationships">
-  <p:cSld>
-    <p:spTree>
-      <p:nvGrpSpPr>
-        <p:cNvPr id="1" name=""/>
-        <p:cNvGrpSpPr/>
-        <p:nvPr/>
-      </p:nvGrpSpPr>
-      <p:grpSpPr/>
-      <p:sp>
-        <p:nvSpPr>
-          <p:cNvPr id="2" name="Rectangle 1"/>
-          <p:cNvSpPr/>
-          <p:nvPr/>
-        </p:nvSpPr>
-        <p:spPr>
-          <a:xfrm>
-            <a:off x="0" y="0"/>
-            <a:ext cx="9144000" cy="5138928"/>
-          </a:xfrm>
-          <a:prstGeom prst="rect">
-            <a:avLst/>
-          </a:prstGeom>
-          <a:solidFill>
-            <a:srgbClr val="FAFBFC"/>
-          </a:solidFill>
-          <a:ln>
-            <a:noFill/>
-          </a:ln>
-          <a:effectLst/>
-        </p:spPr>
-        <p:style>
-          <a:lnRef idx="1">
-            <a:schemeClr val="accent1"/>
-          </a:lnRef>
-          <a:fillRef idx="3">
-            <a:schemeClr val="accent1"/>
-          </a:fillRef>
-          <a:effectRef idx="2">
-            <a:schemeClr val="accent1"/>
-          </a:effectRef>
-          <a:fontRef idx="minor">
-            <a:schemeClr val="lt1"/>
-          </a:fontRef>
-        </p:style>
-        <p:txBody>
-          <a:bodyPr rtlCol="0" anchor="ctr"/>
-          <a:lstStyle/>
-          <a:p>
-            <a:pPr algn="ctr"/>
-          </a:p>
-        </p:txBody>
-      </p:sp>
-      <p:sp>
-        <p:nvSpPr>
-          <p:cNvPr id="3" name="TextBox 2"/>
-          <p:cNvSpPr txBox="1"/>
-          <p:nvPr/>
-        </p:nvSpPr>
-        <p:spPr>
-          <a:xfrm>
-            <a:off x="402336" y="301752"/>
-            <a:ext cx="8348472" cy="795528"/>
-          </a:xfrm>
-          <a:prstGeom prst="rect">
-            <a:avLst/>
-          </a:prstGeom>
-          <a:noFill/>
-        </p:spPr>
-        <p:txBody>
-          <a:bodyPr wrap="square">
-            <a:spAutoFit/>
-          </a:bodyPr>
-          <a:lstStyle/>
-          <a:p>
-            <a:r>
-              <a:rPr sz="2800" b="1">
-                <a:solidFill>
-                  <a:srgbClr val="0F0F0F"/>
-                </a:solidFill>
-                <a:latin typeface="Fira Sans"/>
-              </a:rPr>
-              <a:t>Referencias</a:t>
-            </a:r>
-          </a:p>
-        </p:txBody>
-      </p:sp>
-      <p:sp>
-        <p:nvSpPr>
-          <p:cNvPr id="4" name="TextBox 3"/>
-          <p:cNvSpPr txBox="1"/>
-          <p:nvPr/>
-        </p:nvSpPr>
-        <p:spPr>
-          <a:xfrm>
-            <a:off x="704088" y="1234440"/>
-            <a:ext cx="7744968" cy="3566160"/>
-          </a:xfrm>
-          <a:prstGeom prst="rect">
-            <a:avLst/>
-          </a:prstGeom>
-          <a:noFill/>
-        </p:spPr>
-        <p:txBody>
-          <a:bodyPr wrap="square">
-            <a:spAutoFit/>
-          </a:bodyPr>
-          <a:lstStyle/>
-          <a:p>
-            <a:pPr>
-              <a:lnSpc>
-                <a:spcPct val="115000"/>
-              </a:lnSpc>
-              <a:spcAft>
-                <a:spcPts val="700"/>
-              </a:spcAft>
-            </a:pPr>
-            <a:r>
-              <a:rPr sz="1300" b="0">
-                <a:solidFill>
-                  <a:srgbClr val="333333"/>
-                </a:solidFill>
-                <a:latin typeface="Fira Sans"/>
-              </a:rPr>
-              <a:t>Snow, J. (1855). On the Mode of Communication of Cholera (2ª edición). Londres: John Churchill.</a:t>
-            </a:r>
-          </a:p>
           <a:p>
             <a:pPr>
               <a:lnSpc>
@@ -7296,7 +6918,7 @@
             <a:avLst/>
           </a:prstGeom>
           <a:solidFill>
-            <a:srgbClr val="FAFBFC"/>
+            <a:srgbClr val="1D3557"/>
           </a:solidFill>
           <a:ln>
             <a:noFill/>
@@ -7333,8 +6955,8 @@
         </p:nvSpPr>
         <p:spPr>
           <a:xfrm>
-            <a:off x="402336" y="301752"/>
-            <a:ext cx="8348472" cy="795528"/>
+            <a:off x="603504" y="1847088"/>
+            <a:ext cx="7946136" cy="1399032"/>
           </a:xfrm>
           <a:prstGeom prst="rect">
             <a:avLst/>
@@ -7348,120 +6970,24 @@
           <a:lstStyle/>
           <a:p>
             <a:r>
-              <a:rPr sz="2800" b="1">
-                <a:solidFill>
-                  <a:srgbClr val="0F0F0F"/>
-                </a:solidFill>
-                <a:latin typeface="Fira Sans"/>
-              </a:rPr>
-              <a:t>El concepto central de la clase</a:t>
-            </a:r>
-          </a:p>
-        </p:txBody>
-      </p:sp>
-      <p:sp>
-        <p:nvSpPr>
-          <p:cNvPr id="4" name="TextBox 3"/>
-          <p:cNvSpPr txBox="1"/>
-          <p:nvPr/>
-        </p:nvSpPr>
-        <p:spPr>
-          <a:xfrm>
-            <a:off x="704088" y="1353312"/>
-            <a:ext cx="7744968" cy="3300984"/>
-          </a:xfrm>
-          <a:prstGeom prst="rect">
-            <a:avLst/>
-          </a:prstGeom>
-          <a:noFill/>
-        </p:spPr>
-        <p:txBody>
-          <a:bodyPr wrap="square">
-            <a:spAutoFit/>
-          </a:bodyPr>
-          <a:lstStyle/>
-          <a:p>
-            <a:pPr>
-              <a:lnSpc>
-                <a:spcPct val="112000"/>
-              </a:lnSpc>
-              <a:spcAft>
-                <a:spcPts val="900"/>
-              </a:spcAft>
-            </a:pPr>
-            <a:r>
-              <a:rPr sz="1800" b="1">
+              <a:rPr sz="3400" b="1">
+                <a:solidFill>
+                  <a:srgbClr val="FFFFFF"/>
+                </a:solidFill>
+                <a:latin typeface="Fira Sans"/>
+              </a:rPr>
+              <a:t>¿Qué es la ciencia de datos?</a:t>
+            </a:r>
+          </a:p>
+          <a:p>
+            <a:r>
+              <a:rPr sz="1800" b="0">
                 <a:solidFill>
                   <a:srgbClr val="E0A437"/>
                 </a:solidFill>
                 <a:latin typeface="Fira Sans"/>
               </a:rPr>
-              <a:t>▸ </a:t>
-            </a:r>
-            <a:r>
-              <a:rPr sz="1800" b="1">
-                <a:solidFill>
-                  <a:srgbClr val="1D3557"/>
-                </a:solidFill>
-                <a:latin typeface="Fira Sans"/>
-              </a:rPr>
-              <a:t>El tipo de cada variable determina qué resúmenes, gráficos y análisis son válidos.</a:t>
-            </a:r>
-          </a:p>
-          <a:p>
-            <a:pPr>
-              <a:lnSpc>
-                <a:spcPct val="112000"/>
-              </a:lnSpc>
-              <a:spcAft>
-                <a:spcPts val="900"/>
-              </a:spcAft>
-            </a:pPr>
-            <a:r>
-              <a:rPr sz="1800" b="1">
-                <a:solidFill>
-                  <a:srgbClr val="E0A437"/>
-                </a:solidFill>
-                <a:latin typeface="Fira Sans"/>
-              </a:rPr>
-              <a:t>▸ </a:t>
-            </a:r>
-            <a:r>
-              <a:rPr sz="1800" b="0">
-                <a:solidFill>
-                  <a:srgbClr val="000000"/>
-                </a:solidFill>
-                <a:latin typeface="Fira Sans"/>
-              </a:rPr>
-              <a:t>Primero se presenta como marco (tipos de datos y tipos de variables) y luego se aplica columna a columna sobre una encuesta real, en el notebook.</a:t>
-            </a:r>
-          </a:p>
-          <a:p>
-            <a:pPr>
-              <a:lnSpc>
-                <a:spcPct val="112000"/>
-              </a:lnSpc>
-              <a:spcAft>
-                <a:spcPts val="900"/>
-              </a:spcAft>
-            </a:pPr>
-            <a:r>
-              <a:rPr sz="1800" b="1">
-                <a:solidFill>
-                  <a:srgbClr val="E0A437"/>
-                </a:solidFill>
-                <a:latin typeface="Fira Sans"/>
-              </a:rPr>
-              <a:t>▸ </a:t>
-            </a:r>
-            <a:r>
-              <a:rPr sz="1800" b="0">
-                <a:solidFill>
-                  <a:srgbClr val="000000"/>
-                </a:solidFill>
-                <a:latin typeface="Fira Sans"/>
-              </a:rPr>
-              <a:t>Es el criterio de partida de todo el módulo: la estadística descriptiva (clase 2) y el EDA (clase 3) se organizan según el tipo de variable.</a:t>
+              <a:t>Definición, componentes y objetivos</a:t>
             </a:r>
           </a:p>
         </p:txBody>
@@ -7499,7 +7025,7 @@
             <a:avLst/>
           </a:prstGeom>
           <a:solidFill>
-            <a:srgbClr val="1D3557"/>
+            <a:srgbClr val="FAFBFC"/>
           </a:solidFill>
           <a:ln>
             <a:noFill/>
@@ -7536,8 +7062,8 @@
         </p:nvSpPr>
         <p:spPr>
           <a:xfrm>
-            <a:off x="603504" y="1847088"/>
-            <a:ext cx="7946136" cy="1399032"/>
+            <a:off x="402336" y="301752"/>
+            <a:ext cx="8348472" cy="795528"/>
           </a:xfrm>
           <a:prstGeom prst="rect">
             <a:avLst/>
@@ -7551,24 +7077,148 @@
           <a:lstStyle/>
           <a:p>
             <a:r>
-              <a:rPr sz="3400" b="1">
-                <a:solidFill>
-                  <a:srgbClr val="FFFFFF"/>
-                </a:solidFill>
-                <a:latin typeface="Fira Sans"/>
-              </a:rPr>
-              <a:t>¿Qué es la ciencia de datos?</a:t>
-            </a:r>
-          </a:p>
-          <a:p>
+              <a:rPr sz="2800" b="1">
+                <a:solidFill>
+                  <a:srgbClr val="0F0F0F"/>
+                </a:solidFill>
+                <a:latin typeface="Fira Sans"/>
+              </a:rPr>
+              <a:t>Una definición formal</a:t>
+            </a:r>
+          </a:p>
+        </p:txBody>
+      </p:sp>
+      <p:sp>
+        <p:nvSpPr>
+          <p:cNvPr id="4" name="TextBox 3"/>
+          <p:cNvSpPr txBox="1"/>
+          <p:nvPr/>
+        </p:nvSpPr>
+        <p:spPr>
+          <a:xfrm>
+            <a:off x="704088" y="1353312"/>
+            <a:ext cx="7744968" cy="3300984"/>
+          </a:xfrm>
+          <a:prstGeom prst="rect">
+            <a:avLst/>
+          </a:prstGeom>
+          <a:noFill/>
+        </p:spPr>
+        <p:txBody>
+          <a:bodyPr wrap="square">
+            <a:spAutoFit/>
+          </a:bodyPr>
+          <a:lstStyle/>
+          <a:p>
+            <a:pPr>
+              <a:lnSpc>
+                <a:spcPct val="112000"/>
+              </a:lnSpc>
+              <a:spcAft>
+                <a:spcPts val="900"/>
+              </a:spcAft>
+            </a:pPr>
+            <a:r>
+              <a:rPr sz="1800" b="1">
+                <a:solidFill>
+                  <a:srgbClr val="E0A437"/>
+                </a:solidFill>
+                <a:latin typeface="Fira Sans"/>
+              </a:rPr>
+              <a:t>▸ </a:t>
+            </a:r>
+            <a:r>
+              <a:rPr sz="1800" b="1">
+                <a:solidFill>
+                  <a:srgbClr val="1D3557"/>
+                </a:solidFill>
+                <a:latin typeface="Fira Sans"/>
+              </a:rPr>
+              <a:t>“Data science is the study of the generalizable extraction of knowledge from data” (Dhar, 2013, CACM).</a:t>
+            </a:r>
+          </a:p>
+          <a:p>
+            <a:pPr>
+              <a:lnSpc>
+                <a:spcPct val="112000"/>
+              </a:lnSpc>
+              <a:spcAft>
+                <a:spcPts val="900"/>
+              </a:spcAft>
+            </a:pPr>
+            <a:r>
+              <a:rPr sz="1800" b="1">
+                <a:solidFill>
+                  <a:srgbClr val="E0A437"/>
+                </a:solidFill>
+                <a:latin typeface="Fira Sans"/>
+              </a:rPr>
+              <a:t>▸ </a:t>
+            </a:r>
             <a:r>
               <a:rPr sz="1800" b="0">
                 <a:solidFill>
+                  <a:srgbClr val="000000"/>
+                </a:solidFill>
+                <a:latin typeface="Fira Sans"/>
+              </a:rPr>
+              <a:t>Es decir: el estudio de la extracción generalizable de conocimiento a partir de los datos.</a:t>
+            </a:r>
+          </a:p>
+          <a:p>
+            <a:pPr>
+              <a:lnSpc>
+                <a:spcPct val="112000"/>
+              </a:lnSpc>
+              <a:spcAft>
+                <a:spcPts val="900"/>
+              </a:spcAft>
+            </a:pPr>
+            <a:r>
+              <a:rPr sz="1800" b="1">
+                <a:solidFill>
                   <a:srgbClr val="E0A437"/>
                 </a:solidFill>
                 <a:latin typeface="Fira Sans"/>
               </a:rPr>
-              <a:t>Definición, componentes y objetivos</a:t>
+              <a:t>▸ </a:t>
+            </a:r>
+            <a:r>
+              <a:rPr sz="1800" b="0">
+                <a:solidFill>
+                  <a:srgbClr val="000000"/>
+                </a:solidFill>
+                <a:latin typeface="Fira Sans"/>
+              </a:rPr>
+              <a:t>Generalizable: las conclusiones deben ser válidas fuera de los datos usados para obtenerlas. Este requisito define los dos objetivos del análisis, inferencia y predicción (clases 5 a 8).</a:t>
+            </a:r>
+          </a:p>
+          <a:p>
+            <a:pPr>
+              <a:lnSpc>
+                <a:spcPct val="112000"/>
+              </a:lnSpc>
+              <a:spcAft>
+                <a:spcPts val="900"/>
+              </a:spcAft>
+            </a:pPr>
+            <a:r>
+              <a:rPr sz="1800" b="1">
+                <a:solidFill>
+                  <a:srgbClr val="E0A437"/>
+                </a:solidFill>
+                <a:latin typeface="Fira Sans"/>
+              </a:rPr>
+              <a:t>▸ </a:t>
+            </a:r>
+            <a:r>
+              <a:rPr sz="1800" b="0">
+                <a:solidFill>
+                  <a:srgbClr val="000000"/>
+                </a:solidFill>
+                <a:latin typeface="Fira Sans"/>
+              </a:rPr>
+              <a:t>Cleveland (2001) propuso el área como una ampliación técnica de la estadística; Donoho (2017) revisa su desarrollo durante los últimos 50 años.</a:t>
             </a:r>
           </a:p>
         </p:txBody>
@@ -7664,21 +7314,45 @@
                 </a:solidFill>
                 <a:latin typeface="Fira Sans"/>
               </a:rPr>
-              <a:t>Una definición formal</a:t>
-            </a:r>
-          </a:p>
-        </p:txBody>
-      </p:sp>
-      <p:sp>
-        <p:nvSpPr>
-          <p:cNvPr id="4" name="TextBox 3"/>
+              <a:t>Tres componentes en intersección</a:t>
+            </a:r>
+          </a:p>
+        </p:txBody>
+      </p:sp>
+      <p:pic>
+        <p:nvPicPr>
+          <p:cNvPr id="4" name="Picture 3" descr="07_componentes.png"/>
+          <p:cNvPicPr>
+            <a:picLocks noChangeAspect="1"/>
+          </p:cNvPicPr>
+          <p:nvPr/>
+        </p:nvPicPr>
+        <p:blipFill>
+          <a:blip r:embed="rId2"/>
+          <a:stretch>
+            <a:fillRect/>
+          </a:stretch>
+        </p:blipFill>
+        <p:spPr>
+          <a:xfrm>
+            <a:off x="2316727" y="1143000"/>
+            <a:ext cx="4510544" cy="3154680"/>
+          </a:xfrm>
+          <a:prstGeom prst="rect">
+            <a:avLst/>
+          </a:prstGeom>
+        </p:spPr>
+      </p:pic>
+      <p:sp>
+        <p:nvSpPr>
+          <p:cNvPr id="5" name="TextBox 4"/>
           <p:cNvSpPr txBox="1"/>
           <p:nvPr/>
         </p:nvSpPr>
         <p:spPr>
           <a:xfrm>
-            <a:off x="704088" y="1353312"/>
-            <a:ext cx="7744968" cy="3300984"/>
+            <a:off x="704088" y="4434840"/>
+            <a:ext cx="7744968" cy="457200"/>
           </a:xfrm>
           <a:prstGeom prst="rect">
             <a:avLst/>
@@ -7691,115 +7365,14 @@
           </a:bodyPr>
           <a:lstStyle/>
           <a:p>
-            <a:pPr>
-              <a:lnSpc>
-                <a:spcPct val="112000"/>
-              </a:lnSpc>
-              <a:spcAft>
-                <a:spcPts val="900"/>
-              </a:spcAft>
-            </a:pPr>
-            <a:r>
-              <a:rPr sz="1800" b="1">
-                <a:solidFill>
-                  <a:srgbClr val="E0A437"/>
-                </a:solidFill>
-                <a:latin typeface="Fira Sans"/>
-              </a:rPr>
-              <a:t>▸ </a:t>
-            </a:r>
-            <a:r>
-              <a:rPr sz="1800" b="1">
-                <a:solidFill>
-                  <a:srgbClr val="1D3557"/>
-                </a:solidFill>
-                <a:latin typeface="Fira Sans"/>
-              </a:rPr>
-              <a:t>“Data science is the study of the generalizable extraction of knowledge from data” (Dhar, 2013, CACM).</a:t>
-            </a:r>
-          </a:p>
-          <a:p>
-            <a:pPr>
-              <a:lnSpc>
-                <a:spcPct val="112000"/>
-              </a:lnSpc>
-              <a:spcAft>
-                <a:spcPts val="900"/>
-              </a:spcAft>
-            </a:pPr>
-            <a:r>
-              <a:rPr sz="1800" b="1">
-                <a:solidFill>
-                  <a:srgbClr val="E0A437"/>
-                </a:solidFill>
-                <a:latin typeface="Fira Sans"/>
-              </a:rPr>
-              <a:t>▸ </a:t>
-            </a:r>
-            <a:r>
-              <a:rPr sz="1800" b="0">
-                <a:solidFill>
-                  <a:srgbClr val="000000"/>
-                </a:solidFill>
-                <a:latin typeface="Fira Sans"/>
-              </a:rPr>
-              <a:t>Es decir: el estudio de la extracción generalizable de conocimiento a partir de los datos.</a:t>
-            </a:r>
-          </a:p>
-          <a:p>
-            <a:pPr>
-              <a:lnSpc>
-                <a:spcPct val="112000"/>
-              </a:lnSpc>
-              <a:spcAft>
-                <a:spcPts val="900"/>
-              </a:spcAft>
-            </a:pPr>
-            <a:r>
-              <a:rPr sz="1800" b="1">
-                <a:solidFill>
-                  <a:srgbClr val="E0A437"/>
-                </a:solidFill>
-                <a:latin typeface="Fira Sans"/>
-              </a:rPr>
-              <a:t>▸ </a:t>
-            </a:r>
-            <a:r>
-              <a:rPr sz="1800" b="0">
-                <a:solidFill>
-                  <a:srgbClr val="000000"/>
-                </a:solidFill>
-                <a:latin typeface="Fira Sans"/>
-              </a:rPr>
-              <a:t>Generalizable: las conclusiones deben ser válidas fuera de los datos usados para obtenerlas. Este requisito define los dos objetivos del análisis, inferencia y predicción (clases 5 a 8).</a:t>
-            </a:r>
-          </a:p>
-          <a:p>
-            <a:pPr>
-              <a:lnSpc>
-                <a:spcPct val="112000"/>
-              </a:lnSpc>
-              <a:spcAft>
-                <a:spcPts val="900"/>
-              </a:spcAft>
-            </a:pPr>
-            <a:r>
-              <a:rPr sz="1800" b="1">
-                <a:solidFill>
-                  <a:srgbClr val="E0A437"/>
-                </a:solidFill>
-                <a:latin typeface="Fira Sans"/>
-              </a:rPr>
-              <a:t>▸ </a:t>
-            </a:r>
-            <a:r>
-              <a:rPr sz="1800" b="0">
-                <a:solidFill>
-                  <a:srgbClr val="000000"/>
-                </a:solidFill>
-                <a:latin typeface="Fira Sans"/>
-              </a:rPr>
-              <a:t>Cleveland (2001) propuso el área como una ampliación técnica de la estadística; Donoho (2017) revisa su desarrollo durante los últimos 50 años.</a:t>
+            <a:r>
+              <a:rPr sz="1300" b="0">
+                <a:solidFill>
+                  <a:srgbClr val="333333"/>
+                </a:solidFill>
+                <a:latin typeface="Fira Sans"/>
+              </a:rPr>
+              <a:t>La literatura describe la disciplina en la intersección de estadística, computación y conocimiento del dominio (Cleveland, 2001; Donoho, 2017).</a:t>
             </a:r>
           </a:p>
         </p:txBody>
@@ -7895,14 +7468,14 @@
                 </a:solidFill>
                 <a:latin typeface="Fira Sans"/>
               </a:rPr>
-              <a:t>Tres componentes en intersección</a:t>
+              <a:t>Dos objetivos: inferencia y predicción</a:t>
             </a:r>
           </a:p>
         </p:txBody>
       </p:sp>
       <p:pic>
         <p:nvPicPr>
-          <p:cNvPr id="4" name="Picture 3" descr="07_componentes.png"/>
+          <p:cNvPr id="4" name="Picture 3" descr="08_inferencia_prediccion.png"/>
           <p:cNvPicPr>
             <a:picLocks noChangeAspect="1"/>
           </p:cNvPicPr>
@@ -7916,8 +7489,8 @@
         </p:blipFill>
         <p:spPr>
           <a:xfrm>
-            <a:off x="2316727" y="1143000"/>
-            <a:ext cx="4510544" cy="3154680"/>
+            <a:off x="1417319" y="1143000"/>
+            <a:ext cx="6309360" cy="2342555"/>
           </a:xfrm>
           <a:prstGeom prst="rect">
             <a:avLst/>
@@ -7953,7 +7526,7 @@
                 </a:solidFill>
                 <a:latin typeface="Fira Sans"/>
               </a:rPr>
-              <a:t>La literatura describe la disciplina en la intersección de estadística, computación y conocimiento del dominio (Cleveland, 2001; Donoho, 2017).</a:t>
+              <a:t>Los dos grandes objetivos del trabajo con datos; estructuran las clases 5 a 8 del módulo.</a:t>
             </a:r>
           </a:p>
         </p:txBody>
@@ -7991,7 +7564,7 @@
             <a:avLst/>
           </a:prstGeom>
           <a:solidFill>
-            <a:srgbClr val="FAFBFC"/>
+            <a:srgbClr val="1D3557"/>
           </a:solidFill>
           <a:ln>
             <a:noFill/>
@@ -8028,8 +7601,8 @@
         </p:nvSpPr>
         <p:spPr>
           <a:xfrm>
-            <a:off x="402336" y="301752"/>
-            <a:ext cx="8348472" cy="795528"/>
+            <a:off x="603504" y="1847088"/>
+            <a:ext cx="7946136" cy="1399032"/>
           </a:xfrm>
           <a:prstGeom prst="rect">
             <a:avLst/>
@@ -8043,71 +7616,24 @@
           <a:lstStyle/>
           <a:p>
             <a:r>
-              <a:rPr sz="2800" b="1">
-                <a:solidFill>
-                  <a:srgbClr val="0F0F0F"/>
-                </a:solidFill>
-                <a:latin typeface="Fira Sans"/>
-              </a:rPr>
-              <a:t>Dos objetivos: inferencia y predicción</a:t>
-            </a:r>
-          </a:p>
-        </p:txBody>
-      </p:sp>
-      <p:pic>
-        <p:nvPicPr>
-          <p:cNvPr id="4" name="Picture 3" descr="08_inferencia_prediccion.png"/>
-          <p:cNvPicPr>
-            <a:picLocks noChangeAspect="1"/>
-          </p:cNvPicPr>
-          <p:nvPr/>
-        </p:nvPicPr>
-        <p:blipFill>
-          <a:blip r:embed="rId2"/>
-          <a:stretch>
-            <a:fillRect/>
-          </a:stretch>
-        </p:blipFill>
-        <p:spPr>
-          <a:xfrm>
-            <a:off x="1417319" y="1143000"/>
-            <a:ext cx="6309360" cy="2342555"/>
-          </a:xfrm>
-          <a:prstGeom prst="rect">
-            <a:avLst/>
-          </a:prstGeom>
-        </p:spPr>
-      </p:pic>
-      <p:sp>
-        <p:nvSpPr>
-          <p:cNvPr id="5" name="TextBox 4"/>
-          <p:cNvSpPr txBox="1"/>
-          <p:nvPr/>
-        </p:nvSpPr>
-        <p:spPr>
-          <a:xfrm>
-            <a:off x="704088" y="4434840"/>
-            <a:ext cx="7744968" cy="457200"/>
-          </a:xfrm>
-          <a:prstGeom prst="rect">
-            <a:avLst/>
-          </a:prstGeom>
-          <a:noFill/>
-        </p:spPr>
-        <p:txBody>
-          <a:bodyPr wrap="square">
-            <a:spAutoFit/>
-          </a:bodyPr>
-          <a:lstStyle/>
-          <a:p>
-            <a:r>
-              <a:rPr sz="1300" b="0">
-                <a:solidFill>
-                  <a:srgbClr val="333333"/>
-                </a:solidFill>
-                <a:latin typeface="Fira Sans"/>
-              </a:rPr>
-              <a:t>Los dos grandes objetivos del trabajo con datos; estructuran las clases 5 a 8 del módulo.</a:t>
+              <a:rPr sz="3400" b="1">
+                <a:solidFill>
+                  <a:srgbClr val="FFFFFF"/>
+                </a:solidFill>
+                <a:latin typeface="Fira Sans"/>
+              </a:rPr>
+              <a:t>El ciclo de vida de un proyecto</a:t>
+            </a:r>
+          </a:p>
+          <a:p>
+            <a:r>
+              <a:rPr sz="1800" b="0">
+                <a:solidFill>
+                  <a:srgbClr val="E0A437"/>
+                </a:solidFill>
+                <a:latin typeface="Fira Sans"/>
+              </a:rPr>
+              <a:t>Etapas, iteración y planificación</a:t>
             </a:r>
           </a:p>
         </p:txBody>
@@ -8203,21 +7729,45 @@
                 </a:solidFill>
                 <a:latin typeface="Fira Sans"/>
               </a:rPr>
-              <a:t>El episodio de John Snow (1854)</a:t>
-            </a:r>
-          </a:p>
-        </p:txBody>
-      </p:sp>
-      <p:sp>
-        <p:nvSpPr>
-          <p:cNvPr id="4" name="TextBox 3"/>
+              <a:t>Las etapas de un proyecto de ciencia de datos</a:t>
+            </a:r>
+          </a:p>
+        </p:txBody>
+      </p:sp>
+      <p:pic>
+        <p:nvPicPr>
+          <p:cNvPr id="4" name="Picture 3" descr="03_ciclo_vida.png"/>
+          <p:cNvPicPr>
+            <a:picLocks noChangeAspect="1"/>
+          </p:cNvPicPr>
+          <p:nvPr/>
+        </p:nvPicPr>
+        <p:blipFill>
+          <a:blip r:embed="rId2"/>
+          <a:stretch>
+            <a:fillRect/>
+          </a:stretch>
+        </p:blipFill>
+        <p:spPr>
+          <a:xfrm>
+            <a:off x="1417319" y="1143000"/>
+            <a:ext cx="6309360" cy="2137325"/>
+          </a:xfrm>
+          <a:prstGeom prst="rect">
+            <a:avLst/>
+          </a:prstGeom>
+        </p:spPr>
+      </p:pic>
+      <p:sp>
+        <p:nvSpPr>
+          <p:cNvPr id="5" name="TextBox 4"/>
           <p:cNvSpPr txBox="1"/>
           <p:nvPr/>
         </p:nvSpPr>
         <p:spPr>
           <a:xfrm>
-            <a:off x="704088" y="1353312"/>
-            <a:ext cx="7744968" cy="3300984"/>
+            <a:off x="704088" y="4434840"/>
+            <a:ext cx="7744968" cy="457200"/>
           </a:xfrm>
           <a:prstGeom prst="rect">
             <a:avLst/>
@@ -8230,171 +7780,14 @@
           </a:bodyPr>
           <a:lstStyle/>
           <a:p>
-            <a:pPr>
-              <a:lnSpc>
-                <a:spcPct val="112000"/>
-              </a:lnSpc>
-              <a:spcAft>
-                <a:spcPts val="900"/>
-              </a:spcAft>
-            </a:pPr>
-            <a:r>
-              <a:rPr sz="1800" b="1">
-                <a:solidFill>
-                  <a:srgbClr val="E0A437"/>
-                </a:solidFill>
-                <a:latin typeface="Fira Sans"/>
-              </a:rPr>
-              <a:t>▸ </a:t>
-            </a:r>
-            <a:r>
-              <a:rPr sz="1800" b="0">
-                <a:solidFill>
-                  <a:srgbClr val="000000"/>
-                </a:solidFill>
-                <a:latin typeface="Fira Sans"/>
-              </a:rPr>
-              <a:t>Londres, brote de cólera en el barrio de Soho: unas 600 muertes en pocas semanas.</a:t>
-            </a:r>
-          </a:p>
-          <a:p>
-            <a:pPr>
-              <a:lnSpc>
-                <a:spcPct val="112000"/>
-              </a:lnSpc>
-              <a:spcAft>
-                <a:spcPts val="900"/>
-              </a:spcAft>
-            </a:pPr>
-            <a:r>
-              <a:rPr sz="1800" b="1">
-                <a:solidFill>
-                  <a:srgbClr val="E0A437"/>
-                </a:solidFill>
-                <a:latin typeface="Fira Sans"/>
-              </a:rPr>
-              <a:t>▸ </a:t>
-            </a:r>
-            <a:r>
-              <a:rPr sz="1800" b="0">
-                <a:solidFill>
-                  <a:srgbClr val="000000"/>
-                </a:solidFill>
-                <a:latin typeface="Fira Sans"/>
-              </a:rPr>
-              <a:t>La teoría dominante culpaba al aire (los miasmas).</a:t>
-            </a:r>
-          </a:p>
-          <a:p>
-            <a:pPr>
-              <a:lnSpc>
-                <a:spcPct val="112000"/>
-              </a:lnSpc>
-              <a:spcAft>
-                <a:spcPts val="900"/>
-              </a:spcAft>
-            </a:pPr>
-            <a:r>
-              <a:rPr sz="1800" b="1">
-                <a:solidFill>
-                  <a:srgbClr val="E0A437"/>
-                </a:solidFill>
-                <a:latin typeface="Fira Sans"/>
-              </a:rPr>
-              <a:t>▸ </a:t>
-            </a:r>
-            <a:r>
-              <a:rPr sz="1800" b="0">
-                <a:solidFill>
-                  <a:srgbClr val="000000"/>
-                </a:solidFill>
-                <a:latin typeface="Fira Sans"/>
-              </a:rPr>
-              <a:t>El médico John Snow preguntó otra cosa: ¿dónde vivían los muertos?</a:t>
-            </a:r>
-          </a:p>
-          <a:p>
-            <a:pPr>
-              <a:lnSpc>
-                <a:spcPct val="112000"/>
-              </a:lnSpc>
-              <a:spcAft>
-                <a:spcPts val="900"/>
-              </a:spcAft>
-            </a:pPr>
-            <a:r>
-              <a:rPr sz="1800" b="1">
-                <a:solidFill>
-                  <a:srgbClr val="E0A437"/>
-                </a:solidFill>
-                <a:latin typeface="Fira Sans"/>
-              </a:rPr>
-              <a:t>▸ </a:t>
-            </a:r>
-            <a:r>
-              <a:rPr sz="1800" b="0">
-                <a:solidFill>
-                  <a:srgbClr val="000000"/>
-                </a:solidFill>
-                <a:latin typeface="Fira Sans"/>
-              </a:rPr>
-              <a:t>Marcó cada muerte en un mapa: se concentraban alrededor de la bomba de agua de Broad Street (Snow, 1855).</a:t>
-            </a:r>
-          </a:p>
-          <a:p>
-            <a:pPr>
-              <a:lnSpc>
-                <a:spcPct val="112000"/>
-              </a:lnSpc>
-              <a:spcAft>
-                <a:spcPts val="900"/>
-              </a:spcAft>
-            </a:pPr>
-            <a:r>
-              <a:rPr sz="1800" b="1">
-                <a:solidFill>
-                  <a:srgbClr val="E0A437"/>
-                </a:solidFill>
-                <a:latin typeface="Fira Sans"/>
-              </a:rPr>
-              <a:t>▸ </a:t>
-            </a:r>
-            <a:r>
-              <a:rPr sz="1800" b="1">
-                <a:solidFill>
-                  <a:srgbClr val="1D3557"/>
-                </a:solidFill>
-                <a:latin typeface="Fira Sans"/>
-              </a:rPr>
-              <a:t>La evidencia contradijo la teoría dominante: el agua, no el aire.</a:t>
-            </a:r>
-          </a:p>
-          <a:p>
-            <a:pPr>
-              <a:lnSpc>
-                <a:spcPct val="112000"/>
-              </a:lnSpc>
-              <a:spcAft>
-                <a:spcPts val="900"/>
-              </a:spcAft>
-            </a:pPr>
-            <a:r>
-              <a:rPr sz="1800" b="1">
-                <a:solidFill>
-                  <a:srgbClr val="E0A437"/>
-                </a:solidFill>
-                <a:latin typeface="Fira Sans"/>
-              </a:rPr>
-              <a:t>▸ </a:t>
-            </a:r>
-            <a:r>
-              <a:rPr sz="1800" b="0">
-                <a:solidFill>
-                  <a:srgbClr val="000000"/>
-                </a:solidFill>
-                <a:latin typeface="Fira Sans"/>
-              </a:rPr>
-              <a:t>El análisis partió de una pregunta concreta, no de la teoría disponible.</a:t>
+            <a:r>
+              <a:rPr sz="1300" b="0">
+                <a:solidFill>
+                  <a:srgbClr val="333333"/>
+                </a:solidFill>
+                <a:latin typeface="Fira Sans"/>
+              </a:rPr>
+              <a:t>El ciclo tiene dos entradas: una necesidad del dominio o datos ya disponibles. Los hallazgos de una etapa pueden devolver el proyecto a etapas anteriores.</a:t>
             </a:r>
           </a:p>
         </p:txBody>
@@ -8432,7 +7825,7 @@
             <a:avLst/>
           </a:prstGeom>
           <a:solidFill>
-            <a:srgbClr val="1D3557"/>
+            <a:srgbClr val="FAFBFC"/>
           </a:solidFill>
           <a:ln>
             <a:noFill/>
@@ -8469,8 +7862,8 @@
         </p:nvSpPr>
         <p:spPr>
           <a:xfrm>
-            <a:off x="603504" y="1847088"/>
-            <a:ext cx="7946136" cy="1399032"/>
+            <a:off x="402336" y="301752"/>
+            <a:ext cx="8348472" cy="795528"/>
           </a:xfrm>
           <a:prstGeom prst="rect">
             <a:avLst/>
@@ -8484,24 +7877,120 @@
           <a:lstStyle/>
           <a:p>
             <a:r>
-              <a:rPr sz="3400" b="1">
-                <a:solidFill>
-                  <a:srgbClr val="FFFFFF"/>
-                </a:solidFill>
-                <a:latin typeface="Fira Sans"/>
-              </a:rPr>
-              <a:t>El ciclo de vida de un proyecto</a:t>
-            </a:r>
-          </a:p>
-          <a:p>
+              <a:rPr sz="2800" b="1">
+                <a:solidFill>
+                  <a:srgbClr val="0F0F0F"/>
+                </a:solidFill>
+                <a:latin typeface="Fira Sans"/>
+              </a:rPr>
+              <a:t>Tres advertencias sobre el ciclo</a:t>
+            </a:r>
+          </a:p>
+        </p:txBody>
+      </p:sp>
+      <p:sp>
+        <p:nvSpPr>
+          <p:cNvPr id="4" name="TextBox 3"/>
+          <p:cNvSpPr txBox="1"/>
+          <p:nvPr/>
+        </p:nvSpPr>
+        <p:spPr>
+          <a:xfrm>
+            <a:off x="704088" y="1353312"/>
+            <a:ext cx="7744968" cy="3300984"/>
+          </a:xfrm>
+          <a:prstGeom prst="rect">
+            <a:avLst/>
+          </a:prstGeom>
+          <a:noFill/>
+        </p:spPr>
+        <p:txBody>
+          <a:bodyPr wrap="square">
+            <a:spAutoFit/>
+          </a:bodyPr>
+          <a:lstStyle/>
+          <a:p>
+            <a:pPr>
+              <a:lnSpc>
+                <a:spcPct val="112000"/>
+              </a:lnSpc>
+              <a:spcAft>
+                <a:spcPts val="900"/>
+              </a:spcAft>
+            </a:pPr>
+            <a:r>
+              <a:rPr sz="1800" b="1">
+                <a:solidFill>
+                  <a:srgbClr val="E0A437"/>
+                </a:solidFill>
+                <a:latin typeface="Fira Sans"/>
+              </a:rPr>
+              <a:t>▸ </a:t>
+            </a:r>
             <a:r>
               <a:rPr sz="1800" b="0">
                 <a:solidFill>
+                  <a:srgbClr val="000000"/>
+                </a:solidFill>
+                <a:latin typeface="Fira Sans"/>
+              </a:rPr>
+              <a:t>Cargar y limpiar datos consume en promedio el 45% del tiempo de trabajo, más que el modelamiento (Anaconda, 2020; encuesta a 2.360 profesionales).</a:t>
+            </a:r>
+          </a:p>
+          <a:p>
+            <a:pPr>
+              <a:lnSpc>
+                <a:spcPct val="112000"/>
+              </a:lnSpc>
+              <a:spcAft>
+                <a:spcPts val="900"/>
+              </a:spcAft>
+            </a:pPr>
+            <a:r>
+              <a:rPr sz="1800" b="1">
+                <a:solidFill>
                   <a:srgbClr val="E0A437"/>
                 </a:solidFill>
                 <a:latin typeface="Fira Sans"/>
               </a:rPr>
-              <a:t>Etapas, iteración y planificación</a:t>
+              <a:t>▸ </a:t>
+            </a:r>
+            <a:r>
+              <a:rPr sz="1800" b="0">
+                <a:solidFill>
+                  <a:srgbClr val="000000"/>
+                </a:solidFill>
+                <a:latin typeface="Fira Sans"/>
+              </a:rPr>
+              <a:t>El ciclo se recorre varias veces: un hallazgo cambia la pregunta y una limpieza revela problemas nuevos.</a:t>
+            </a:r>
+          </a:p>
+          <a:p>
+            <a:pPr>
+              <a:lnSpc>
+                <a:spcPct val="112000"/>
+              </a:lnSpc>
+              <a:spcAft>
+                <a:spcPts val="900"/>
+              </a:spcAft>
+            </a:pPr>
+            <a:r>
+              <a:rPr sz="1800" b="1">
+                <a:solidFill>
+                  <a:srgbClr val="E0A437"/>
+                </a:solidFill>
+                <a:latin typeface="Fira Sans"/>
+              </a:rPr>
+              <a:t>▸ </a:t>
+            </a:r>
+            <a:r>
+              <a:rPr sz="1800" b="0">
+                <a:solidFill>
+                  <a:srgbClr val="000000"/>
+                </a:solidFill>
+                <a:latin typeface="Fira Sans"/>
+              </a:rPr>
+              <a:t>Un error en la formulación del problema invalida las etapas posteriores; conviene revisarla antes de invertir en el resto.</a:t>
             </a:r>
           </a:p>
         </p:txBody>

</xml_diff>

<commit_message>
Ejemplos dibujados en datos estructurados y no estructurados; fuera la actividad de cierre
Co-Authored-By: Claude Fable 5 <noreply@anthropic.com>
</commit_message>
<xml_diff>
--- a/presentaciones/clase01_fundamentos_ecosistema.pptx
+++ b/presentaciones/clase01_fundamentos_ecosistema.pptx
@@ -31,7 +31,6 @@
     <p:sldId id="279" r:id="rId30"/>
     <p:sldId id="280" r:id="rId31"/>
     <p:sldId id="281" r:id="rId32"/>
-    <p:sldId id="282" r:id="rId33"/>
   </p:sldIdLst>
   <p:sldSz cx="9144000" cy="5138928" type="screen4x3"/>
   <p:notesSz cx="6858000" cy="9144000"/>
@@ -3724,16 +3723,40 @@
           </a:p>
         </p:txBody>
       </p:sp>
-      <p:sp>
-        <p:nvSpPr>
-          <p:cNvPr id="4" name="TextBox 3"/>
+      <p:pic>
+        <p:nvPicPr>
+          <p:cNvPr id="4" name="Picture 3" descr="09_estructurados.png"/>
+          <p:cNvPicPr>
+            <a:picLocks noChangeAspect="1"/>
+          </p:cNvPicPr>
+          <p:nvPr/>
+        </p:nvPicPr>
+        <p:blipFill>
+          <a:blip r:embed="rId2"/>
+          <a:stretch>
+            <a:fillRect/>
+          </a:stretch>
+        </p:blipFill>
+        <p:spPr>
+          <a:xfrm>
+            <a:off x="1417319" y="1143000"/>
+            <a:ext cx="6309360" cy="2884949"/>
+          </a:xfrm>
+          <a:prstGeom prst="rect">
+            <a:avLst/>
+          </a:prstGeom>
+        </p:spPr>
+      </p:pic>
+      <p:sp>
+        <p:nvSpPr>
+          <p:cNvPr id="5" name="TextBox 4"/>
           <p:cNvSpPr txBox="1"/>
           <p:nvPr/>
         </p:nvSpPr>
         <p:spPr>
           <a:xfrm>
-            <a:off x="704088" y="1353312"/>
-            <a:ext cx="7744968" cy="3300984"/>
+            <a:off x="704088" y="4434840"/>
+            <a:ext cx="7744968" cy="457200"/>
           </a:xfrm>
           <a:prstGeom prst="rect">
             <a:avLst/>
@@ -3746,87 +3769,14 @@
           </a:bodyPr>
           <a:lstStyle/>
           <a:p>
-            <a:pPr>
-              <a:lnSpc>
-                <a:spcPct val="112000"/>
-              </a:lnSpc>
-              <a:spcAft>
-                <a:spcPts val="900"/>
-              </a:spcAft>
-            </a:pPr>
-            <a:r>
-              <a:rPr sz="1800" b="1">
-                <a:solidFill>
-                  <a:srgbClr val="E0A437"/>
-                </a:solidFill>
-                <a:latin typeface="Fira Sans"/>
-              </a:rPr>
-              <a:t>▸ </a:t>
-            </a:r>
-            <a:r>
-              <a:rPr sz="1800" b="0">
-                <a:solidFill>
-                  <a:srgbClr val="000000"/>
-                </a:solidFill>
-                <a:latin typeface="Fira Sans"/>
-              </a:rPr>
-              <a:t>Estructurados: tablas con filas y columnas (la EOD, una base de ventas, un registro de sensores). Son el foco de este módulo.</a:t>
-            </a:r>
-          </a:p>
-          <a:p>
-            <a:pPr>
-              <a:lnSpc>
-                <a:spcPct val="112000"/>
-              </a:lnSpc>
-              <a:spcAft>
-                <a:spcPts val="900"/>
-              </a:spcAft>
-            </a:pPr>
-            <a:r>
-              <a:rPr sz="1800" b="1">
-                <a:solidFill>
-                  <a:srgbClr val="E0A437"/>
-                </a:solidFill>
-                <a:latin typeface="Fira Sans"/>
-              </a:rPr>
-              <a:t>▸ </a:t>
-            </a:r>
-            <a:r>
-              <a:rPr sz="1800" b="0">
-                <a:solidFill>
-                  <a:srgbClr val="000000"/>
-                </a:solidFill>
-                <a:latin typeface="Fira Sans"/>
-              </a:rPr>
-              <a:t>No estructurados: texto libre, imágenes, audio. Se trabajan en los módulos de machine learning y deep learning del diplomado.</a:t>
-            </a:r>
-          </a:p>
-          <a:p>
-            <a:pPr>
-              <a:lnSpc>
-                <a:spcPct val="112000"/>
-              </a:lnSpc>
-              <a:spcAft>
-                <a:spcPts val="900"/>
-              </a:spcAft>
-            </a:pPr>
-            <a:r>
-              <a:rPr sz="1800" b="1">
-                <a:solidFill>
-                  <a:srgbClr val="E0A437"/>
-                </a:solidFill>
-                <a:latin typeface="Fira Sans"/>
-              </a:rPr>
-              <a:t>▸ </a:t>
-            </a:r>
-            <a:r>
-              <a:rPr sz="1800" b="0">
-                <a:solidFill>
-                  <a:srgbClr val="000000"/>
-                </a:solidFill>
-                <a:latin typeface="Fira Sans"/>
-              </a:rPr>
-              <a:t>En la práctica, analizar datos no estructurados suele requerir convertirlos primero en representaciones tabulares o numéricas.</a:t>
+            <a:r>
+              <a:rPr sz="1300" b="0">
+                <a:solidFill>
+                  <a:srgbClr val="333333"/>
+                </a:solidFill>
+                <a:latin typeface="Fira Sans"/>
+              </a:rPr>
+              <a:t>Los no estructurados se trabajan en los módulos de machine learning y deep learning; en la práctica, analizarlos suele requerir convertirlos primero en representaciones tabulares o numéricas.</a:t>
             </a:r>
           </a:p>
         </p:txBody>
@@ -6300,7 +6250,7 @@
                 </a:solidFill>
                 <a:latin typeface="Fira Sans"/>
               </a:rPr>
-              <a:t>Actividad de cierre</a:t>
+              <a:t>Síntesis</a:t>
             </a:r>
           </a:p>
         </p:txBody>
@@ -6351,7 +6301,7 @@
                 </a:solidFill>
                 <a:latin typeface="Fira Sans"/>
               </a:rPr>
-              <a:t>Escriba en el chat una decisión de su trabajo que hoy se toma por intuición y podría tomarse con datos, o un conjunto de datos que su organización acumula y no analiza.</a:t>
+              <a:t>El tipo de cada variable determina qué resúmenes, gráficos y análisis son válidos.</a:t>
             </a:r>
           </a:p>
           <a:p>
@@ -6379,7 +6329,7 @@
                 </a:solidFill>
                 <a:latin typeface="Fira Sans"/>
               </a:rPr>
-              <a:t>Comentaremos dos o tres: cuál sería la pregunta, qué datos harían falta, qué etapa del ciclo sería la difícil.</a:t>
+              <a:t>Ciencia de datos: extracción generalizable de conocimiento a partir de los datos (Dhar, 2013); combina estadística, computación y dominio.</a:t>
             </a:r>
           </a:p>
           <a:p>
@@ -6407,7 +6357,63 @@
                 </a:solidFill>
                 <a:latin typeface="Fira Sans"/>
               </a:rPr>
-              <a:t>Guarde la suya: puede ser el germen de su proyecto final.</a:t>
+              <a:t>El ciclo de vida tiene dos entradas (una necesidad del dominio o datos disponibles) y se recorre de forma iterativa.</a:t>
+            </a:r>
+          </a:p>
+          <a:p>
+            <a:pPr>
+              <a:lnSpc>
+                <a:spcPct val="112000"/>
+              </a:lnSpc>
+              <a:spcAft>
+                <a:spcPts val="900"/>
+              </a:spcAft>
+            </a:pPr>
+            <a:r>
+              <a:rPr sz="1800" b="1">
+                <a:solidFill>
+                  <a:srgbClr val="E0A437"/>
+                </a:solidFill>
+                <a:latin typeface="Fira Sans"/>
+              </a:rPr>
+              <a:t>▸ </a:t>
+            </a:r>
+            <a:r>
+              <a:rPr sz="1800" b="0">
+                <a:solidFill>
+                  <a:srgbClr val="000000"/>
+                </a:solidFill>
+                <a:latin typeface="Fira Sans"/>
+              </a:rPr>
+              <a:t>La preparación de datos consume cerca de la mitad del tiempo de un proyecto (Anaconda, 2020).</a:t>
+            </a:r>
+          </a:p>
+          <a:p>
+            <a:pPr>
+              <a:lnSpc>
+                <a:spcPct val="112000"/>
+              </a:lnSpc>
+              <a:spcAft>
+                <a:spcPts val="900"/>
+              </a:spcAft>
+            </a:pPr>
+            <a:r>
+              <a:rPr sz="1800" b="1">
+                <a:solidFill>
+                  <a:srgbClr val="E0A437"/>
+                </a:solidFill>
+                <a:latin typeface="Fira Sans"/>
+              </a:rPr>
+              <a:t>▸ </a:t>
+            </a:r>
+            <a:r>
+              <a:rPr sz="1800" b="0">
+                <a:solidFill>
+                  <a:srgbClr val="000000"/>
+                </a:solidFill>
+                <a:latin typeface="Fira Sans"/>
+              </a:rPr>
+              <a:t>Próxima clase (jueves 27): estadística descriptiva, con el entorno ya funcionando.</a:t>
             </a:r>
           </a:p>
         </p:txBody>
@@ -6421,265 +6427,6 @@
 </file>
 
 <file path=ppt/slides/slide26.xml><?xml version="1.0" encoding="utf-8"?>
-<p:sld xmlns:a="http://schemas.openxmlformats.org/drawingml/2006/main" xmlns:p="http://schemas.openxmlformats.org/presentationml/2006/main" xmlns:r="http://schemas.openxmlformats.org/officeDocument/2006/relationships">
-  <p:cSld>
-    <p:spTree>
-      <p:nvGrpSpPr>
-        <p:cNvPr id="1" name=""/>
-        <p:cNvGrpSpPr/>
-        <p:nvPr/>
-      </p:nvGrpSpPr>
-      <p:grpSpPr/>
-      <p:sp>
-        <p:nvSpPr>
-          <p:cNvPr id="2" name="Rectangle 1"/>
-          <p:cNvSpPr/>
-          <p:nvPr/>
-        </p:nvSpPr>
-        <p:spPr>
-          <a:xfrm>
-            <a:off x="0" y="0"/>
-            <a:ext cx="9144000" cy="5138928"/>
-          </a:xfrm>
-          <a:prstGeom prst="rect">
-            <a:avLst/>
-          </a:prstGeom>
-          <a:solidFill>
-            <a:srgbClr val="FAFBFC"/>
-          </a:solidFill>
-          <a:ln>
-            <a:noFill/>
-          </a:ln>
-          <a:effectLst/>
-        </p:spPr>
-        <p:style>
-          <a:lnRef idx="1">
-            <a:schemeClr val="accent1"/>
-          </a:lnRef>
-          <a:fillRef idx="3">
-            <a:schemeClr val="accent1"/>
-          </a:fillRef>
-          <a:effectRef idx="2">
-            <a:schemeClr val="accent1"/>
-          </a:effectRef>
-          <a:fontRef idx="minor">
-            <a:schemeClr val="lt1"/>
-          </a:fontRef>
-        </p:style>
-        <p:txBody>
-          <a:bodyPr rtlCol="0" anchor="ctr"/>
-          <a:lstStyle/>
-          <a:p>
-            <a:pPr algn="ctr"/>
-          </a:p>
-        </p:txBody>
-      </p:sp>
-      <p:sp>
-        <p:nvSpPr>
-          <p:cNvPr id="3" name="TextBox 2"/>
-          <p:cNvSpPr txBox="1"/>
-          <p:nvPr/>
-        </p:nvSpPr>
-        <p:spPr>
-          <a:xfrm>
-            <a:off x="402336" y="301752"/>
-            <a:ext cx="8348472" cy="795528"/>
-          </a:xfrm>
-          <a:prstGeom prst="rect">
-            <a:avLst/>
-          </a:prstGeom>
-          <a:noFill/>
-        </p:spPr>
-        <p:txBody>
-          <a:bodyPr wrap="square">
-            <a:spAutoFit/>
-          </a:bodyPr>
-          <a:lstStyle/>
-          <a:p>
-            <a:r>
-              <a:rPr sz="2800" b="1">
-                <a:solidFill>
-                  <a:srgbClr val="0F0F0F"/>
-                </a:solidFill>
-                <a:latin typeface="Fira Sans"/>
-              </a:rPr>
-              <a:t>Síntesis</a:t>
-            </a:r>
-          </a:p>
-        </p:txBody>
-      </p:sp>
-      <p:sp>
-        <p:nvSpPr>
-          <p:cNvPr id="4" name="TextBox 3"/>
-          <p:cNvSpPr txBox="1"/>
-          <p:nvPr/>
-        </p:nvSpPr>
-        <p:spPr>
-          <a:xfrm>
-            <a:off x="704088" y="1353312"/>
-            <a:ext cx="7744968" cy="3300984"/>
-          </a:xfrm>
-          <a:prstGeom prst="rect">
-            <a:avLst/>
-          </a:prstGeom>
-          <a:noFill/>
-        </p:spPr>
-        <p:txBody>
-          <a:bodyPr wrap="square">
-            <a:spAutoFit/>
-          </a:bodyPr>
-          <a:lstStyle/>
-          <a:p>
-            <a:pPr>
-              <a:lnSpc>
-                <a:spcPct val="112000"/>
-              </a:lnSpc>
-              <a:spcAft>
-                <a:spcPts val="900"/>
-              </a:spcAft>
-            </a:pPr>
-            <a:r>
-              <a:rPr sz="1800" b="1">
-                <a:solidFill>
-                  <a:srgbClr val="E0A437"/>
-                </a:solidFill>
-                <a:latin typeface="Fira Sans"/>
-              </a:rPr>
-              <a:t>▸ </a:t>
-            </a:r>
-            <a:r>
-              <a:rPr sz="1800" b="1">
-                <a:solidFill>
-                  <a:srgbClr val="1D3557"/>
-                </a:solidFill>
-                <a:latin typeface="Fira Sans"/>
-              </a:rPr>
-              <a:t>El tipo de cada variable determina qué resúmenes, gráficos y análisis son válidos.</a:t>
-            </a:r>
-          </a:p>
-          <a:p>
-            <a:pPr>
-              <a:lnSpc>
-                <a:spcPct val="112000"/>
-              </a:lnSpc>
-              <a:spcAft>
-                <a:spcPts val="900"/>
-              </a:spcAft>
-            </a:pPr>
-            <a:r>
-              <a:rPr sz="1800" b="1">
-                <a:solidFill>
-                  <a:srgbClr val="E0A437"/>
-                </a:solidFill>
-                <a:latin typeface="Fira Sans"/>
-              </a:rPr>
-              <a:t>▸ </a:t>
-            </a:r>
-            <a:r>
-              <a:rPr sz="1800" b="0">
-                <a:solidFill>
-                  <a:srgbClr val="000000"/>
-                </a:solidFill>
-                <a:latin typeface="Fira Sans"/>
-              </a:rPr>
-              <a:t>Ciencia de datos: extracción generalizable de conocimiento a partir de los datos (Dhar, 2013); combina estadística, computación y dominio.</a:t>
-            </a:r>
-          </a:p>
-          <a:p>
-            <a:pPr>
-              <a:lnSpc>
-                <a:spcPct val="112000"/>
-              </a:lnSpc>
-              <a:spcAft>
-                <a:spcPts val="900"/>
-              </a:spcAft>
-            </a:pPr>
-            <a:r>
-              <a:rPr sz="1800" b="1">
-                <a:solidFill>
-                  <a:srgbClr val="E0A437"/>
-                </a:solidFill>
-                <a:latin typeface="Fira Sans"/>
-              </a:rPr>
-              <a:t>▸ </a:t>
-            </a:r>
-            <a:r>
-              <a:rPr sz="1800" b="0">
-                <a:solidFill>
-                  <a:srgbClr val="000000"/>
-                </a:solidFill>
-                <a:latin typeface="Fira Sans"/>
-              </a:rPr>
-              <a:t>El ciclo de vida tiene dos entradas (una necesidad del dominio o datos disponibles) y se recorre de forma iterativa.</a:t>
-            </a:r>
-          </a:p>
-          <a:p>
-            <a:pPr>
-              <a:lnSpc>
-                <a:spcPct val="112000"/>
-              </a:lnSpc>
-              <a:spcAft>
-                <a:spcPts val="900"/>
-              </a:spcAft>
-            </a:pPr>
-            <a:r>
-              <a:rPr sz="1800" b="1">
-                <a:solidFill>
-                  <a:srgbClr val="E0A437"/>
-                </a:solidFill>
-                <a:latin typeface="Fira Sans"/>
-              </a:rPr>
-              <a:t>▸ </a:t>
-            </a:r>
-            <a:r>
-              <a:rPr sz="1800" b="0">
-                <a:solidFill>
-                  <a:srgbClr val="000000"/>
-                </a:solidFill>
-                <a:latin typeface="Fira Sans"/>
-              </a:rPr>
-              <a:t>La preparación de datos consume cerca de la mitad del tiempo de un proyecto (Anaconda, 2020).</a:t>
-            </a:r>
-          </a:p>
-          <a:p>
-            <a:pPr>
-              <a:lnSpc>
-                <a:spcPct val="112000"/>
-              </a:lnSpc>
-              <a:spcAft>
-                <a:spcPts val="900"/>
-              </a:spcAft>
-            </a:pPr>
-            <a:r>
-              <a:rPr sz="1800" b="1">
-                <a:solidFill>
-                  <a:srgbClr val="E0A437"/>
-                </a:solidFill>
-                <a:latin typeface="Fira Sans"/>
-              </a:rPr>
-              <a:t>▸ </a:t>
-            </a:r>
-            <a:r>
-              <a:rPr sz="1800" b="0">
-                <a:solidFill>
-                  <a:srgbClr val="000000"/>
-                </a:solidFill>
-                <a:latin typeface="Fira Sans"/>
-              </a:rPr>
-              <a:t>Próxima clase (jueves 27): estadística descriptiva, con el entorno ya funcionando.</a:t>
-            </a:r>
-          </a:p>
-        </p:txBody>
-      </p:sp>
-    </p:spTree>
-  </p:cSld>
-  <p:clrMapOvr>
-    <a:masterClrMapping/>
-  </p:clrMapOvr>
-</p:sld>
-</file>
-
-<file path=ppt/slides/slide27.xml><?xml version="1.0" encoding="utf-8"?>
 <p:sld xmlns:a="http://schemas.openxmlformats.org/drawingml/2006/main" xmlns:p="http://schemas.openxmlformats.org/presentationml/2006/main" xmlns:r="http://schemas.openxmlformats.org/officeDocument/2006/relationships">
   <p:cSld>
     <p:spTree>

</xml_diff>

<commit_message>
Evaluación oficial del módulo: tres actividades del proyecto Capstone según el programa; programa agregado al repo
Co-Authored-By: Claude Fable 5 <noreply@anthropic.com>
</commit_message>
<xml_diff>
--- a/presentaciones/clase01_fundamentos_ecosistema.pptx
+++ b/presentaciones/clase01_fundamentos_ecosistema.pptx
@@ -3380,7 +3380,7 @@
                 </a:solidFill>
                 <a:latin typeface="Fira Sans"/>
               </a:rPr>
-              <a:t>El proyecto final del módulo</a:t>
+              <a:t>Evaluación del módulo</a:t>
             </a:r>
           </a:p>
         </p:txBody>
@@ -3431,7 +3431,91 @@
                 </a:solidFill>
                 <a:latin typeface="Fira Sans"/>
               </a:rPr>
-              <a:t>El módulo se evalúa con un proyecto aplicado sobre datos reales, que recorre el ciclo completo: pregunta, datos, exploración, análisis y comunicación.</a:t>
+              <a:t>Tres actividades, asociadas al proyecto Capstone del diplomado (programa oficial de la asignatura):</a:t>
+            </a:r>
+          </a:p>
+          <a:p>
+            <a:pPr>
+              <a:lnSpc>
+                <a:spcPct val="112000"/>
+              </a:lnSpc>
+              <a:spcAft>
+                <a:spcPts val="500"/>
+              </a:spcAft>
+            </a:pPr>
+            <a:r>
+              <a:rPr sz="1400" b="0">
+                <a:solidFill>
+                  <a:srgbClr val="333333"/>
+                </a:solidFill>
+                <a:latin typeface="Fira Sans"/>
+              </a:rPr>
+              <a:t>     ◦  </a:t>
+            </a:r>
+            <a:r>
+              <a:rPr sz="1400" b="0">
+                <a:solidFill>
+                  <a:srgbClr val="333333"/>
+                </a:solidFill>
+                <a:latin typeface="Fira Sans"/>
+              </a:rPr>
+              <a:t>Formulación del proyecto Capstone y de la innovación propuesta (30%).</a:t>
+            </a:r>
+          </a:p>
+          <a:p>
+            <a:pPr>
+              <a:lnSpc>
+                <a:spcPct val="112000"/>
+              </a:lnSpc>
+              <a:spcAft>
+                <a:spcPts val="500"/>
+              </a:spcAft>
+            </a:pPr>
+            <a:r>
+              <a:rPr sz="1400" b="0">
+                <a:solidFill>
+                  <a:srgbClr val="333333"/>
+                </a:solidFill>
+                <a:latin typeface="Fira Sans"/>
+              </a:rPr>
+              <a:t>     ◦  </a:t>
+            </a:r>
+            <a:r>
+              <a:rPr sz="1400" b="0">
+                <a:solidFill>
+                  <a:srgbClr val="333333"/>
+                </a:solidFill>
+                <a:latin typeface="Fira Sans"/>
+              </a:rPr>
+              <a:t>Primer análisis exploratorio de datos, en código con NumPy, Pandas y Matplotlib sobre datos del proyecto (40%).</a:t>
+            </a:r>
+          </a:p>
+          <a:p>
+            <a:pPr>
+              <a:lnSpc>
+                <a:spcPct val="112000"/>
+              </a:lnSpc>
+              <a:spcAft>
+                <a:spcPts val="500"/>
+              </a:spcAft>
+            </a:pPr>
+            <a:r>
+              <a:rPr sz="1400" b="0">
+                <a:solidFill>
+                  <a:srgbClr val="333333"/>
+                </a:solidFill>
+                <a:latin typeface="Fira Sans"/>
+              </a:rPr>
+              <a:t>     ◦  </a:t>
+            </a:r>
+            <a:r>
+              <a:rPr sz="1400" b="0">
+                <a:solidFill>
+                  <a:srgbClr val="333333"/>
+                </a:solidFill>
+                <a:latin typeface="Fira Sans"/>
+              </a:rPr>
+              <a:t>Informe de avance: comunicación oral y escrita de los primeros hallazgos (25%).</a:t>
             </a:r>
           </a:p>
           <a:p>
@@ -3453,13 +3537,13 @@
               <a:t>▸ </a:t>
             </a:r>
             <a:r>
-              <a:rPr sz="1800" b="0">
-                <a:solidFill>
-                  <a:srgbClr val="000000"/>
-                </a:solidFill>
-                <a:latin typeface="Fira Sans"/>
-              </a:rPr>
-              <a:t>Puede usar datos de su propio trabajo o un conjunto de datos público.</a:t>
+              <a:rPr sz="1800" b="1">
+                <a:solidFill>
+                  <a:srgbClr val="1D3557"/>
+                </a:solidFill>
+                <a:latin typeface="Fira Sans"/>
+              </a:rPr>
+              <a:t>El proyecto Capstone parte en este módulo: defina un problema de su contexto profesional abordable con datos.</a:t>
             </a:r>
           </a:p>
           <a:p>
@@ -3481,41 +3565,13 @@
               <a:t>▸ </a:t>
             </a:r>
             <a:r>
-              <a:rPr sz="1800" b="1">
-                <a:solidFill>
-                  <a:srgbClr val="1D3557"/>
-                </a:solidFill>
-                <a:latin typeface="Fira Sans"/>
-              </a:rPr>
-              <a:t>Desde hoy: anote las preguntas de su trabajo que le gustaría responder con datos.</a:t>
-            </a:r>
-          </a:p>
-          <a:p>
-            <a:pPr>
-              <a:lnSpc>
-                <a:spcPct val="112000"/>
-              </a:lnSpc>
-              <a:spcAft>
-                <a:spcPts val="900"/>
-              </a:spcAft>
-            </a:pPr>
-            <a:r>
-              <a:rPr sz="1800" b="1">
-                <a:solidFill>
-                  <a:srgbClr val="E0A437"/>
-                </a:solidFill>
-                <a:latin typeface="Fira Sans"/>
-              </a:rPr>
-              <a:t>▸ </a:t>
-            </a:r>
-            <a:r>
               <a:rPr sz="1800" b="0">
                 <a:solidFill>
                   <a:srgbClr val="000000"/>
                 </a:solidFill>
                 <a:latin typeface="Fira Sans"/>
               </a:rPr>
-              <a:t>El enunciado y la pauta se publican en las próximas clases.</a:t>
+              <a:t>Calificación mínima de aprobación: 60%. Fechas y pautas se publican durante el módulo.</a:t>
             </a:r>
           </a:p>
         </p:txBody>

</xml_diff>

<commit_message>
Fechas de las evaluaciones en la slide de evaluación y en el calendario de clases
Co-Authored-By: Claude Fable 5 <noreply@anthropic.com>
</commit_message>
<xml_diff>
--- a/presentaciones/clase01_fundamentos_ecosistema.pptx
+++ b/presentaciones/clase01_fundamentos_ecosistema.pptx
@@ -3459,7 +3459,7 @@
                 </a:solidFill>
                 <a:latin typeface="Fira Sans"/>
               </a:rPr>
-              <a:t>Formulación del proyecto Capstone y de la innovación propuesta (30%).</a:t>
+              <a:t>Formulación del proyecto y de la innovación propuesta (30%): pauta el ju 27-ago, presentación breve de la idea el ju 03-sep, entrega el lu 07-sep.</a:t>
             </a:r>
           </a:p>
           <a:p>
@@ -3487,7 +3487,7 @@
                 </a:solidFill>
                 <a:latin typeface="Fira Sans"/>
               </a:rPr>
-              <a:t>Primer análisis exploratorio de datos, en código con NumPy, Pandas y Matplotlib sobre datos del proyecto (40%).</a:t>
+              <a:t>Primer análisis exploratorio de datos, en código con NumPy, Pandas y Matplotlib sobre datos del proyecto (40%): pauta el ju 03-sep, entrega el lu 15-sep.</a:t>
             </a:r>
           </a:p>
           <a:p>
@@ -3515,7 +3515,7 @@
                 </a:solidFill>
                 <a:latin typeface="Fira Sans"/>
               </a:rPr>
-              <a:t>Informe de avance: comunicación oral y escrita de los primeros hallazgos (25%).</a:t>
+              <a:t>Informe de avance (25%): presentación oral el ma 22-sep e informe escrito el vi 25-sep.</a:t>
             </a:r>
           </a:p>
           <a:p>
@@ -3571,7 +3571,7 @@
                 </a:solidFill>
                 <a:latin typeface="Fira Sans"/>
               </a:rPr>
-              <a:t>Calificación mínima de aprobación: 60%. Fechas y pautas se publican durante el módulo.</a:t>
+              <a:t>Calificación mínima de aprobación: 60%. Fechas por confirmar en el aula virtual.</a:t>
             </a:r>
           </a:p>
         </p:txBody>

</xml_diff>

<commit_message>
Slide de evaluación con tabla de actividades, ponderaciones y fechas
Co-Authored-By: Claude Fable 5 <noreply@anthropic.com>
</commit_message>
<xml_diff>
--- a/presentaciones/clase01_fundamentos_ecosistema.pptx
+++ b/presentaciones/clase01_fundamentos_ecosistema.pptx
@@ -3385,16 +3385,439 @@
           </a:p>
         </p:txBody>
       </p:sp>
-      <p:sp>
-        <p:nvSpPr>
-          <p:cNvPr id="4" name="TextBox 3"/>
+      <p:graphicFrame>
+        <p:nvGraphicFramePr>
+          <p:cNvPr id="4" name="Table 3"/>
+          <p:cNvGraphicFramePr>
+            <a:graphicFrameLocks noGrp="1"/>
+          </p:cNvGraphicFramePr>
+          <p:nvPr/>
+        </p:nvGraphicFramePr>
+        <p:xfrm>
+          <a:off x="502920" y="1188720"/>
+          <a:ext cx="8138160" cy="2697480"/>
+        </p:xfrm>
+        <a:graphic>
+          <a:graphicData uri="http://schemas.openxmlformats.org/drawingml/2006/table">
+            <a:tbl>
+              <a:tblPr firstRow="1" bandRow="1">
+                <a:tableStyleId>{5C22544A-7EE6-4342-B048-85BDC9FD1C3A}</a:tableStyleId>
+              </a:tblPr>
+              <a:tblGrid>
+                <a:gridCol w="3566160"/>
+                <a:gridCol w="868680"/>
+                <a:gridCol w="3703320"/>
+              </a:tblGrid>
+              <a:tr h="457200">
+                <a:tc>
+                  <a:txBody>
+                    <a:bodyPr wrap="square"/>
+                    <a:lstStyle/>
+                    <a:p>
+                      <a:pPr>
+                        <a:lnSpc>
+                          <a:spcPct val="110000"/>
+                        </a:lnSpc>
+                      </a:pPr>
+                      <a:r>
+                        <a:rPr sz="1400" b="1">
+                          <a:solidFill>
+                            <a:srgbClr val="FFFFFF"/>
+                          </a:solidFill>
+                          <a:latin typeface="Fira Sans"/>
+                        </a:rPr>
+                        <a:t>Actividad</a:t>
+                      </a:r>
+                    </a:p>
+                  </a:txBody>
+                  <a:tcPr>
+                    <a:solidFill>
+                      <a:srgbClr val="1D3557"/>
+                    </a:solidFill>
+                  </a:tcPr>
+                </a:tc>
+                <a:tc>
+                  <a:txBody>
+                    <a:bodyPr wrap="square"/>
+                    <a:lstStyle/>
+                    <a:p>
+                      <a:pPr>
+                        <a:lnSpc>
+                          <a:spcPct val="110000"/>
+                        </a:lnSpc>
+                      </a:pPr>
+                      <a:r>
+                        <a:rPr sz="1400" b="1">
+                          <a:solidFill>
+                            <a:srgbClr val="FFFFFF"/>
+                          </a:solidFill>
+                          <a:latin typeface="Fira Sans"/>
+                        </a:rPr>
+                        <a:t>Pond.</a:t>
+                      </a:r>
+                    </a:p>
+                  </a:txBody>
+                  <a:tcPr>
+                    <a:solidFill>
+                      <a:srgbClr val="1D3557"/>
+                    </a:solidFill>
+                  </a:tcPr>
+                </a:tc>
+                <a:tc>
+                  <a:txBody>
+                    <a:bodyPr wrap="square"/>
+                    <a:lstStyle/>
+                    <a:p>
+                      <a:pPr>
+                        <a:lnSpc>
+                          <a:spcPct val="110000"/>
+                        </a:lnSpc>
+                      </a:pPr>
+                      <a:r>
+                        <a:rPr sz="1400" b="1">
+                          <a:solidFill>
+                            <a:srgbClr val="FFFFFF"/>
+                          </a:solidFill>
+                          <a:latin typeface="Fira Sans"/>
+                        </a:rPr>
+                        <a:t>Hitos</a:t>
+                      </a:r>
+                    </a:p>
+                  </a:txBody>
+                  <a:tcPr>
+                    <a:solidFill>
+                      <a:srgbClr val="1D3557"/>
+                    </a:solidFill>
+                  </a:tcPr>
+                </a:tc>
+              </a:tr>
+              <a:tr h="868680">
+                <a:tc>
+                  <a:txBody>
+                    <a:bodyPr wrap="square"/>
+                    <a:lstStyle/>
+                    <a:p>
+                      <a:pPr>
+                        <a:lnSpc>
+                          <a:spcPct val="110000"/>
+                        </a:lnSpc>
+                      </a:pPr>
+                      <a:r>
+                        <a:rPr sz="1300" b="0">
+                          <a:solidFill>
+                            <a:srgbClr val="000000"/>
+                          </a:solidFill>
+                          <a:latin typeface="Fira Sans"/>
+                        </a:rPr>
+                        <a:t>Formulación del proyecto Capstone y de la innovación propuesta</a:t>
+                      </a:r>
+                    </a:p>
+                  </a:txBody>
+                  <a:tcPr>
+                    <a:solidFill>
+                      <a:srgbClr val="FFFFFF"/>
+                    </a:solidFill>
+                  </a:tcPr>
+                </a:tc>
+                <a:tc>
+                  <a:txBody>
+                    <a:bodyPr wrap="square"/>
+                    <a:lstStyle/>
+                    <a:p>
+                      <a:pPr>
+                        <a:lnSpc>
+                          <a:spcPct val="110000"/>
+                        </a:lnSpc>
+                      </a:pPr>
+                      <a:r>
+                        <a:rPr sz="1300" b="0">
+                          <a:solidFill>
+                            <a:srgbClr val="000000"/>
+                          </a:solidFill>
+                          <a:latin typeface="Fira Sans"/>
+                        </a:rPr>
+                        <a:t>30%</a:t>
+                      </a:r>
+                    </a:p>
+                  </a:txBody>
+                  <a:tcPr>
+                    <a:solidFill>
+                      <a:srgbClr val="FFFFFF"/>
+                    </a:solidFill>
+                  </a:tcPr>
+                </a:tc>
+                <a:tc>
+                  <a:txBody>
+                    <a:bodyPr wrap="square"/>
+                    <a:lstStyle/>
+                    <a:p>
+                      <a:pPr>
+                        <a:lnSpc>
+                          <a:spcPct val="110000"/>
+                        </a:lnSpc>
+                      </a:pPr>
+                      <a:r>
+                        <a:rPr sz="1300" b="0">
+                          <a:solidFill>
+                            <a:srgbClr val="000000"/>
+                          </a:solidFill>
+                          <a:latin typeface="Fira Sans"/>
+                        </a:rPr>
+                        <a:t>Pauta: ju 27-ago</a:t>
+                      </a:r>
+                    </a:p>
+                    <a:p>
+                      <a:pPr>
+                        <a:lnSpc>
+                          <a:spcPct val="110000"/>
+                        </a:lnSpc>
+                      </a:pPr>
+                      <a:r>
+                        <a:rPr sz="1300" b="0">
+                          <a:solidFill>
+                            <a:srgbClr val="000000"/>
+                          </a:solidFill>
+                          <a:latin typeface="Fira Sans"/>
+                        </a:rPr>
+                        <a:t>Presentación de la idea: ju 03-sep</a:t>
+                      </a:r>
+                    </a:p>
+                    <a:p>
+                      <a:pPr>
+                        <a:lnSpc>
+                          <a:spcPct val="110000"/>
+                        </a:lnSpc>
+                      </a:pPr>
+                      <a:r>
+                        <a:rPr sz="1300" b="0">
+                          <a:solidFill>
+                            <a:srgbClr val="000000"/>
+                          </a:solidFill>
+                          <a:latin typeface="Fira Sans"/>
+                        </a:rPr>
+                        <a:t>Entrega: lu 07-sep</a:t>
+                      </a:r>
+                    </a:p>
+                  </a:txBody>
+                  <a:tcPr>
+                    <a:solidFill>
+                      <a:srgbClr val="FFFFFF"/>
+                    </a:solidFill>
+                  </a:tcPr>
+                </a:tc>
+              </a:tr>
+              <a:tr h="685800">
+                <a:tc>
+                  <a:txBody>
+                    <a:bodyPr wrap="square"/>
+                    <a:lstStyle/>
+                    <a:p>
+                      <a:pPr>
+                        <a:lnSpc>
+                          <a:spcPct val="110000"/>
+                        </a:lnSpc>
+                      </a:pPr>
+                      <a:r>
+                        <a:rPr sz="1300" b="0">
+                          <a:solidFill>
+                            <a:srgbClr val="000000"/>
+                          </a:solidFill>
+                          <a:latin typeface="Fira Sans"/>
+                        </a:rPr>
+                        <a:t>Primer análisis exploratorio de datos (NumPy, Pandas y Matplotlib)</a:t>
+                      </a:r>
+                    </a:p>
+                  </a:txBody>
+                  <a:tcPr>
+                    <a:solidFill>
+                      <a:srgbClr val="FFFFFF"/>
+                    </a:solidFill>
+                  </a:tcPr>
+                </a:tc>
+                <a:tc>
+                  <a:txBody>
+                    <a:bodyPr wrap="square"/>
+                    <a:lstStyle/>
+                    <a:p>
+                      <a:pPr>
+                        <a:lnSpc>
+                          <a:spcPct val="110000"/>
+                        </a:lnSpc>
+                      </a:pPr>
+                      <a:r>
+                        <a:rPr sz="1300" b="0">
+                          <a:solidFill>
+                            <a:srgbClr val="000000"/>
+                          </a:solidFill>
+                          <a:latin typeface="Fira Sans"/>
+                        </a:rPr>
+                        <a:t>40%</a:t>
+                      </a:r>
+                    </a:p>
+                  </a:txBody>
+                  <a:tcPr>
+                    <a:solidFill>
+                      <a:srgbClr val="FFFFFF"/>
+                    </a:solidFill>
+                  </a:tcPr>
+                </a:tc>
+                <a:tc>
+                  <a:txBody>
+                    <a:bodyPr wrap="square"/>
+                    <a:lstStyle/>
+                    <a:p>
+                      <a:pPr>
+                        <a:lnSpc>
+                          <a:spcPct val="110000"/>
+                        </a:lnSpc>
+                      </a:pPr>
+                      <a:r>
+                        <a:rPr sz="1300" b="0">
+                          <a:solidFill>
+                            <a:srgbClr val="000000"/>
+                          </a:solidFill>
+                          <a:latin typeface="Fira Sans"/>
+                        </a:rPr>
+                        <a:t>Pauta: ju 03-sep</a:t>
+                      </a:r>
+                    </a:p>
+                    <a:p>
+                      <a:pPr>
+                        <a:lnSpc>
+                          <a:spcPct val="110000"/>
+                        </a:lnSpc>
+                      </a:pPr>
+                      <a:r>
+                        <a:rPr sz="1300" b="0">
+                          <a:solidFill>
+                            <a:srgbClr val="000000"/>
+                          </a:solidFill>
+                          <a:latin typeface="Fira Sans"/>
+                        </a:rPr>
+                        <a:t>Entrega: lu 15-sep</a:t>
+                      </a:r>
+                    </a:p>
+                  </a:txBody>
+                  <a:tcPr>
+                    <a:solidFill>
+                      <a:srgbClr val="FFFFFF"/>
+                    </a:solidFill>
+                  </a:tcPr>
+                </a:tc>
+              </a:tr>
+              <a:tr h="685800">
+                <a:tc>
+                  <a:txBody>
+                    <a:bodyPr wrap="square"/>
+                    <a:lstStyle/>
+                    <a:p>
+                      <a:pPr>
+                        <a:lnSpc>
+                          <a:spcPct val="110000"/>
+                        </a:lnSpc>
+                      </a:pPr>
+                      <a:r>
+                        <a:rPr sz="1300" b="0">
+                          <a:solidFill>
+                            <a:srgbClr val="000000"/>
+                          </a:solidFill>
+                          <a:latin typeface="Fira Sans"/>
+                        </a:rPr>
+                        <a:t>Informe de avance del proyecto</a:t>
+                      </a:r>
+                    </a:p>
+                  </a:txBody>
+                  <a:tcPr>
+                    <a:solidFill>
+                      <a:srgbClr val="FFFFFF"/>
+                    </a:solidFill>
+                  </a:tcPr>
+                </a:tc>
+                <a:tc>
+                  <a:txBody>
+                    <a:bodyPr wrap="square"/>
+                    <a:lstStyle/>
+                    <a:p>
+                      <a:pPr>
+                        <a:lnSpc>
+                          <a:spcPct val="110000"/>
+                        </a:lnSpc>
+                      </a:pPr>
+                      <a:r>
+                        <a:rPr sz="1300" b="0">
+                          <a:solidFill>
+                            <a:srgbClr val="000000"/>
+                          </a:solidFill>
+                          <a:latin typeface="Fira Sans"/>
+                        </a:rPr>
+                        <a:t>25%</a:t>
+                      </a:r>
+                    </a:p>
+                  </a:txBody>
+                  <a:tcPr>
+                    <a:solidFill>
+                      <a:srgbClr val="FFFFFF"/>
+                    </a:solidFill>
+                  </a:tcPr>
+                </a:tc>
+                <a:tc>
+                  <a:txBody>
+                    <a:bodyPr wrap="square"/>
+                    <a:lstStyle/>
+                    <a:p>
+                      <a:pPr>
+                        <a:lnSpc>
+                          <a:spcPct val="110000"/>
+                        </a:lnSpc>
+                      </a:pPr>
+                      <a:r>
+                        <a:rPr sz="1300" b="0">
+                          <a:solidFill>
+                            <a:srgbClr val="000000"/>
+                          </a:solidFill>
+                          <a:latin typeface="Fira Sans"/>
+                        </a:rPr>
+                        <a:t>Presentación oral: ma 22-sep</a:t>
+                      </a:r>
+                    </a:p>
+                    <a:p>
+                      <a:pPr>
+                        <a:lnSpc>
+                          <a:spcPct val="110000"/>
+                        </a:lnSpc>
+                      </a:pPr>
+                      <a:r>
+                        <a:rPr sz="1300" b="0">
+                          <a:solidFill>
+                            <a:srgbClr val="000000"/>
+                          </a:solidFill>
+                          <a:latin typeface="Fira Sans"/>
+                        </a:rPr>
+                        <a:t>Informe escrito: vi 25-sep</a:t>
+                      </a:r>
+                    </a:p>
+                  </a:txBody>
+                  <a:tcPr>
+                    <a:solidFill>
+                      <a:srgbClr val="FFFFFF"/>
+                    </a:solidFill>
+                  </a:tcPr>
+                </a:tc>
+              </a:tr>
+            </a:tbl>
+          </a:graphicData>
+        </a:graphic>
+      </p:graphicFrame>
+      <p:sp>
+        <p:nvSpPr>
+          <p:cNvPr id="5" name="TextBox 4"/>
           <p:cNvSpPr txBox="1"/>
           <p:nvPr/>
         </p:nvSpPr>
         <p:spPr>
           <a:xfrm>
-            <a:off x="704088" y="1353312"/>
-            <a:ext cx="7744968" cy="3300984"/>
+            <a:off x="502920" y="4297680"/>
+            <a:ext cx="8138160" cy="640080"/>
           </a:xfrm>
           <a:prstGeom prst="rect">
             <a:avLst/>
@@ -3407,171 +3830,14 @@
           </a:bodyPr>
           <a:lstStyle/>
           <a:p>
-            <a:pPr>
-              <a:lnSpc>
-                <a:spcPct val="112000"/>
-              </a:lnSpc>
-              <a:spcAft>
-                <a:spcPts val="900"/>
-              </a:spcAft>
-            </a:pPr>
-            <a:r>
-              <a:rPr sz="1800" b="1">
-                <a:solidFill>
-                  <a:srgbClr val="E0A437"/>
-                </a:solidFill>
-                <a:latin typeface="Fira Sans"/>
-              </a:rPr>
-              <a:t>▸ </a:t>
-            </a:r>
-            <a:r>
-              <a:rPr sz="1800" b="0">
-                <a:solidFill>
-                  <a:srgbClr val="000000"/>
-                </a:solidFill>
-                <a:latin typeface="Fira Sans"/>
-              </a:rPr>
-              <a:t>Tres actividades, asociadas al proyecto Capstone del diplomado (programa oficial de la asignatura):</a:t>
-            </a:r>
-          </a:p>
-          <a:p>
-            <a:pPr>
-              <a:lnSpc>
-                <a:spcPct val="112000"/>
-              </a:lnSpc>
-              <a:spcAft>
-                <a:spcPts val="500"/>
-              </a:spcAft>
-            </a:pPr>
-            <a:r>
-              <a:rPr sz="1400" b="0">
+            <a:r>
+              <a:rPr sz="1300" b="0">
                 <a:solidFill>
                   <a:srgbClr val="333333"/>
                 </a:solidFill>
                 <a:latin typeface="Fira Sans"/>
               </a:rPr>
-              <a:t>     ◦  </a:t>
-            </a:r>
-            <a:r>
-              <a:rPr sz="1400" b="0">
-                <a:solidFill>
-                  <a:srgbClr val="333333"/>
-                </a:solidFill>
-                <a:latin typeface="Fira Sans"/>
-              </a:rPr>
-              <a:t>Formulación del proyecto y de la innovación propuesta (30%): pauta el ju 27-ago, presentación breve de la idea el ju 03-sep, entrega el lu 07-sep.</a:t>
-            </a:r>
-          </a:p>
-          <a:p>
-            <a:pPr>
-              <a:lnSpc>
-                <a:spcPct val="112000"/>
-              </a:lnSpc>
-              <a:spcAft>
-                <a:spcPts val="500"/>
-              </a:spcAft>
-            </a:pPr>
-            <a:r>
-              <a:rPr sz="1400" b="0">
-                <a:solidFill>
-                  <a:srgbClr val="333333"/>
-                </a:solidFill>
-                <a:latin typeface="Fira Sans"/>
-              </a:rPr>
-              <a:t>     ◦  </a:t>
-            </a:r>
-            <a:r>
-              <a:rPr sz="1400" b="0">
-                <a:solidFill>
-                  <a:srgbClr val="333333"/>
-                </a:solidFill>
-                <a:latin typeface="Fira Sans"/>
-              </a:rPr>
-              <a:t>Primer análisis exploratorio de datos, en código con NumPy, Pandas y Matplotlib sobre datos del proyecto (40%): pauta el ju 03-sep, entrega el lu 15-sep.</a:t>
-            </a:r>
-          </a:p>
-          <a:p>
-            <a:pPr>
-              <a:lnSpc>
-                <a:spcPct val="112000"/>
-              </a:lnSpc>
-              <a:spcAft>
-                <a:spcPts val="500"/>
-              </a:spcAft>
-            </a:pPr>
-            <a:r>
-              <a:rPr sz="1400" b="0">
-                <a:solidFill>
-                  <a:srgbClr val="333333"/>
-                </a:solidFill>
-                <a:latin typeface="Fira Sans"/>
-              </a:rPr>
-              <a:t>     ◦  </a:t>
-            </a:r>
-            <a:r>
-              <a:rPr sz="1400" b="0">
-                <a:solidFill>
-                  <a:srgbClr val="333333"/>
-                </a:solidFill>
-                <a:latin typeface="Fira Sans"/>
-              </a:rPr>
-              <a:t>Informe de avance (25%): presentación oral el ma 22-sep e informe escrito el vi 25-sep.</a:t>
-            </a:r>
-          </a:p>
-          <a:p>
-            <a:pPr>
-              <a:lnSpc>
-                <a:spcPct val="112000"/>
-              </a:lnSpc>
-              <a:spcAft>
-                <a:spcPts val="900"/>
-              </a:spcAft>
-            </a:pPr>
-            <a:r>
-              <a:rPr sz="1800" b="1">
-                <a:solidFill>
-                  <a:srgbClr val="E0A437"/>
-                </a:solidFill>
-                <a:latin typeface="Fira Sans"/>
-              </a:rPr>
-              <a:t>▸ </a:t>
-            </a:r>
-            <a:r>
-              <a:rPr sz="1800" b="1">
-                <a:solidFill>
-                  <a:srgbClr val="1D3557"/>
-                </a:solidFill>
-                <a:latin typeface="Fira Sans"/>
-              </a:rPr>
-              <a:t>El proyecto Capstone parte en este módulo: defina un problema de su contexto profesional abordable con datos.</a:t>
-            </a:r>
-          </a:p>
-          <a:p>
-            <a:pPr>
-              <a:lnSpc>
-                <a:spcPct val="112000"/>
-              </a:lnSpc>
-              <a:spcAft>
-                <a:spcPts val="900"/>
-              </a:spcAft>
-            </a:pPr>
-            <a:r>
-              <a:rPr sz="1800" b="1">
-                <a:solidFill>
-                  <a:srgbClr val="E0A437"/>
-                </a:solidFill>
-                <a:latin typeface="Fira Sans"/>
-              </a:rPr>
-              <a:t>▸ </a:t>
-            </a:r>
-            <a:r>
-              <a:rPr sz="1800" b="0">
-                <a:solidFill>
-                  <a:srgbClr val="000000"/>
-                </a:solidFill>
-                <a:latin typeface="Fira Sans"/>
-              </a:rPr>
-              <a:t>Calificación mínima de aprobación: 60%. Fechas por confirmar en el aula virtual.</a:t>
+              <a:t>Tres actividades asociadas al proyecto Capstone (programa oficial). Calificación mínima de aprobación: 60%. Fechas por confirmar en el aula virtual.</a:t>
             </a:r>
           </a:p>
         </p:txBody>

</xml_diff>

<commit_message>
Rúbrica en lugar de pauta en las evaluaciones del módulo
Co-Authored-By: Claude Fable 5 <noreply@anthropic.com>
</commit_message>
<xml_diff>
--- a/presentaciones/clase01_fundamentos_ecosistema.pptx
+++ b/presentaciones/clase01_fundamentos_ecosistema.pptx
@@ -3563,7 +3563,7 @@
                           </a:solidFill>
                           <a:latin typeface="Fira Sans"/>
                         </a:rPr>
-                        <a:t>Pauta: ju 27-ago</a:t>
+                        <a:t>Rúbrica: ju 27-ago</a:t>
                       </a:r>
                     </a:p>
                     <a:p>
@@ -3678,7 +3678,7 @@
                           </a:solidFill>
                           <a:latin typeface="Fira Sans"/>
                         </a:rPr>
-                        <a:t>Pauta: ju 03-sep</a:t>
+                        <a:t>Rúbrica: ju 03-sep</a:t>
                       </a:r>
                     </a:p>
                     <a:p>

</xml_diff>

<commit_message>
Entregas primero y destacadas en el calendario de evaluaciones (README y slide)
Co-Authored-By: Claude Fable 5 <noreply@anthropic.com>
</commit_message>
<xml_diff>
--- a/presentaciones/clase01_fundamentos_ecosistema.pptx
+++ b/presentaciones/clase01_fundamentos_ecosistema.pptx
@@ -3557,6 +3557,22 @@
                         </a:lnSpc>
                       </a:pPr>
                       <a:r>
+                        <a:rPr sz="1300" b="1">
+                          <a:solidFill>
+                            <a:srgbClr val="1D3557"/>
+                          </a:solidFill>
+                          <a:latin typeface="Fira Sans"/>
+                        </a:rPr>
+                        <a:t>Entrega: lu 07-sep</a:t>
+                      </a:r>
+                    </a:p>
+                    <a:p>
+                      <a:pPr>
+                        <a:lnSpc>
+                          <a:spcPct val="110000"/>
+                        </a:lnSpc>
+                      </a:pPr>
+                      <a:r>
                         <a:rPr sz="1300" b="0">
                           <a:solidFill>
                             <a:srgbClr val="000000"/>
@@ -3580,22 +3596,6 @@
                           <a:latin typeface="Fira Sans"/>
                         </a:rPr>
                         <a:t>Presentación de la idea: ju 03-sep</a:t>
-                      </a:r>
-                    </a:p>
-                    <a:p>
-                      <a:pPr>
-                        <a:lnSpc>
-                          <a:spcPct val="110000"/>
-                        </a:lnSpc>
-                      </a:pPr>
-                      <a:r>
-                        <a:rPr sz="1300" b="0">
-                          <a:solidFill>
-                            <a:srgbClr val="000000"/>
-                          </a:solidFill>
-                          <a:latin typeface="Fira Sans"/>
-                        </a:rPr>
-                        <a:t>Entrega: lu 07-sep</a:t>
                       </a:r>
                     </a:p>
                   </a:txBody>
@@ -3672,13 +3672,13 @@
                         </a:lnSpc>
                       </a:pPr>
                       <a:r>
-                        <a:rPr sz="1300" b="0">
+                        <a:rPr sz="1300" b="1">
                           <a:solidFill>
-                            <a:srgbClr val="000000"/>
+                            <a:srgbClr val="1D3557"/>
                           </a:solidFill>
                           <a:latin typeface="Fira Sans"/>
                         </a:rPr>
-                        <a:t>Rúbrica: ju 03-sep</a:t>
+                        <a:t>Entrega: lu 15-sep</a:t>
                       </a:r>
                     </a:p>
                     <a:p>
@@ -3694,7 +3694,7 @@
                           </a:solidFill>
                           <a:latin typeface="Fira Sans"/>
                         </a:rPr>
-                        <a:t>Entrega: lu 15-sep</a:t>
+                        <a:t>Rúbrica: ju 03-sep</a:t>
                       </a:r>
                     </a:p>
                   </a:txBody>
@@ -3771,13 +3771,13 @@
                         </a:lnSpc>
                       </a:pPr>
                       <a:r>
-                        <a:rPr sz="1300" b="0">
+                        <a:rPr sz="1300" b="1">
                           <a:solidFill>
-                            <a:srgbClr val="000000"/>
+                            <a:srgbClr val="1D3557"/>
                           </a:solidFill>
                           <a:latin typeface="Fira Sans"/>
                         </a:rPr>
-                        <a:t>Presentación oral: ma 22-sep</a:t>
+                        <a:t>Informe escrito: vi 25-sep</a:t>
                       </a:r>
                     </a:p>
                     <a:p>
@@ -3793,7 +3793,7 @@
                           </a:solidFill>
                           <a:latin typeface="Fira Sans"/>
                         </a:rPr>
-                        <a:t>Informe escrito: vi 25-sep</a:t>
+                        <a:t>Presentación oral: ma 22-sep</a:t>
                       </a:r>
                     </a:p>
                   </a:txBody>

</xml_diff>

<commit_message>
Slide sobre datos disponibles que condicionan la pregunta, en la sección del ciclo
Co-Authored-By: Claude Fable 5 <noreply@anthropic.com>
</commit_message>
<xml_diff>
--- a/presentaciones/clase01_fundamentos_ecosistema.pptx
+++ b/presentaciones/clase01_fundamentos_ecosistema.pptx
@@ -31,6 +31,7 @@
     <p:sldId id="279" r:id="rId30"/>
     <p:sldId id="280" r:id="rId31"/>
     <p:sldId id="281" r:id="rId32"/>
+    <p:sldId id="282" r:id="rId33"/>
   </p:sldIdLst>
   <p:sldSz cx="9144000" cy="5138928" type="screen4x3"/>
   <p:notesSz cx="6858000" cy="9144000"/>
@@ -3298,6 +3299,209 @@
 </file>
 
 <file path=ppt/slides/slide10.xml><?xml version="1.0" encoding="utf-8"?>
+<p:sld xmlns:a="http://schemas.openxmlformats.org/drawingml/2006/main" xmlns:p="http://schemas.openxmlformats.org/presentationml/2006/main" xmlns:r="http://schemas.openxmlformats.org/officeDocument/2006/relationships">
+  <p:cSld>
+    <p:spTree>
+      <p:nvGrpSpPr>
+        <p:cNvPr id="1" name=""/>
+        <p:cNvGrpSpPr/>
+        <p:nvPr/>
+      </p:nvGrpSpPr>
+      <p:grpSpPr/>
+      <p:sp>
+        <p:nvSpPr>
+          <p:cNvPr id="2" name="Rectangle 1"/>
+          <p:cNvSpPr/>
+          <p:nvPr/>
+        </p:nvSpPr>
+        <p:spPr>
+          <a:xfrm>
+            <a:off x="0" y="0"/>
+            <a:ext cx="9144000" cy="5138928"/>
+          </a:xfrm>
+          <a:prstGeom prst="rect">
+            <a:avLst/>
+          </a:prstGeom>
+          <a:solidFill>
+            <a:srgbClr val="FAFBFC"/>
+          </a:solidFill>
+          <a:ln>
+            <a:noFill/>
+          </a:ln>
+          <a:effectLst/>
+        </p:spPr>
+        <p:style>
+          <a:lnRef idx="1">
+            <a:schemeClr val="accent1"/>
+          </a:lnRef>
+          <a:fillRef idx="3">
+            <a:schemeClr val="accent1"/>
+          </a:fillRef>
+          <a:effectRef idx="2">
+            <a:schemeClr val="accent1"/>
+          </a:effectRef>
+          <a:fontRef idx="minor">
+            <a:schemeClr val="lt1"/>
+          </a:fontRef>
+        </p:style>
+        <p:txBody>
+          <a:bodyPr rtlCol="0" anchor="ctr"/>
+          <a:lstStyle/>
+          <a:p>
+            <a:pPr algn="ctr"/>
+          </a:p>
+        </p:txBody>
+      </p:sp>
+      <p:sp>
+        <p:nvSpPr>
+          <p:cNvPr id="3" name="TextBox 2"/>
+          <p:cNvSpPr txBox="1"/>
+          <p:nvPr/>
+        </p:nvSpPr>
+        <p:spPr>
+          <a:xfrm>
+            <a:off x="402336" y="301752"/>
+            <a:ext cx="8348472" cy="795528"/>
+          </a:xfrm>
+          <a:prstGeom prst="rect">
+            <a:avLst/>
+          </a:prstGeom>
+          <a:noFill/>
+        </p:spPr>
+        <p:txBody>
+          <a:bodyPr wrap="square">
+            <a:spAutoFit/>
+          </a:bodyPr>
+          <a:lstStyle/>
+          <a:p>
+            <a:r>
+              <a:rPr sz="2800" b="1">
+                <a:solidFill>
+                  <a:srgbClr val="0F0F0F"/>
+                </a:solidFill>
+                <a:latin typeface="Fira Sans"/>
+              </a:rPr>
+              <a:t>Tres advertencias sobre el ciclo</a:t>
+            </a:r>
+          </a:p>
+        </p:txBody>
+      </p:sp>
+      <p:sp>
+        <p:nvSpPr>
+          <p:cNvPr id="4" name="TextBox 3"/>
+          <p:cNvSpPr txBox="1"/>
+          <p:nvPr/>
+        </p:nvSpPr>
+        <p:spPr>
+          <a:xfrm>
+            <a:off x="704088" y="1353312"/>
+            <a:ext cx="7744968" cy="3300984"/>
+          </a:xfrm>
+          <a:prstGeom prst="rect">
+            <a:avLst/>
+          </a:prstGeom>
+          <a:noFill/>
+        </p:spPr>
+        <p:txBody>
+          <a:bodyPr wrap="square">
+            <a:spAutoFit/>
+          </a:bodyPr>
+          <a:lstStyle/>
+          <a:p>
+            <a:pPr>
+              <a:lnSpc>
+                <a:spcPct val="112000"/>
+              </a:lnSpc>
+              <a:spcAft>
+                <a:spcPts val="900"/>
+              </a:spcAft>
+            </a:pPr>
+            <a:r>
+              <a:rPr sz="1800" b="1">
+                <a:solidFill>
+                  <a:srgbClr val="E0A437"/>
+                </a:solidFill>
+                <a:latin typeface="Fira Sans"/>
+              </a:rPr>
+              <a:t>▸ </a:t>
+            </a:r>
+            <a:r>
+              <a:rPr sz="1800" b="0">
+                <a:solidFill>
+                  <a:srgbClr val="000000"/>
+                </a:solidFill>
+                <a:latin typeface="Fira Sans"/>
+              </a:rPr>
+              <a:t>Cargar y limpiar datos consume en promedio el 45% del tiempo de trabajo, más que el modelamiento (Anaconda, 2020; encuesta a 2.360 profesionales).</a:t>
+            </a:r>
+          </a:p>
+          <a:p>
+            <a:pPr>
+              <a:lnSpc>
+                <a:spcPct val="112000"/>
+              </a:lnSpc>
+              <a:spcAft>
+                <a:spcPts val="900"/>
+              </a:spcAft>
+            </a:pPr>
+            <a:r>
+              <a:rPr sz="1800" b="1">
+                <a:solidFill>
+                  <a:srgbClr val="E0A437"/>
+                </a:solidFill>
+                <a:latin typeface="Fira Sans"/>
+              </a:rPr>
+              <a:t>▸ </a:t>
+            </a:r>
+            <a:r>
+              <a:rPr sz="1800" b="0">
+                <a:solidFill>
+                  <a:srgbClr val="000000"/>
+                </a:solidFill>
+                <a:latin typeface="Fira Sans"/>
+              </a:rPr>
+              <a:t>El ciclo se recorre varias veces: un hallazgo cambia la pregunta y una limpieza revela problemas nuevos.</a:t>
+            </a:r>
+          </a:p>
+          <a:p>
+            <a:pPr>
+              <a:lnSpc>
+                <a:spcPct val="112000"/>
+              </a:lnSpc>
+              <a:spcAft>
+                <a:spcPts val="900"/>
+              </a:spcAft>
+            </a:pPr>
+            <a:r>
+              <a:rPr sz="1800" b="1">
+                <a:solidFill>
+                  <a:srgbClr val="E0A437"/>
+                </a:solidFill>
+                <a:latin typeface="Fira Sans"/>
+              </a:rPr>
+              <a:t>▸ </a:t>
+            </a:r>
+            <a:r>
+              <a:rPr sz="1800" b="0">
+                <a:solidFill>
+                  <a:srgbClr val="000000"/>
+                </a:solidFill>
+                <a:latin typeface="Fira Sans"/>
+              </a:rPr>
+              <a:t>Un error en la formulación del problema invalida las etapas posteriores; conviene revisarla antes de invertir en el resto.</a:t>
+            </a:r>
+          </a:p>
+        </p:txBody>
+      </p:sp>
+    </p:spTree>
+  </p:cSld>
+  <p:clrMapOvr>
+    <a:masterClrMapping/>
+  </p:clrMapOvr>
+</p:sld>
+</file>
+
+<file path=ppt/slides/slide11.xml><?xml version="1.0" encoding="utf-8"?>
 <p:sld xmlns:a="http://schemas.openxmlformats.org/drawingml/2006/main" xmlns:p="http://schemas.openxmlformats.org/presentationml/2006/main" xmlns:r="http://schemas.openxmlformats.org/officeDocument/2006/relationships">
   <p:cSld>
     <p:spTree>
@@ -3850,113 +4054,6 @@
 </p:sld>
 </file>
 
-<file path=ppt/slides/slide11.xml><?xml version="1.0" encoding="utf-8"?>
-<p:sld xmlns:a="http://schemas.openxmlformats.org/drawingml/2006/main" xmlns:p="http://schemas.openxmlformats.org/presentationml/2006/main" xmlns:r="http://schemas.openxmlformats.org/officeDocument/2006/relationships">
-  <p:cSld>
-    <p:spTree>
-      <p:nvGrpSpPr>
-        <p:cNvPr id="1" name=""/>
-        <p:cNvGrpSpPr/>
-        <p:nvPr/>
-      </p:nvGrpSpPr>
-      <p:grpSpPr/>
-      <p:sp>
-        <p:nvSpPr>
-          <p:cNvPr id="2" name="Rectangle 1"/>
-          <p:cNvSpPr/>
-          <p:nvPr/>
-        </p:nvSpPr>
-        <p:spPr>
-          <a:xfrm>
-            <a:off x="0" y="0"/>
-            <a:ext cx="9144000" cy="5138928"/>
-          </a:xfrm>
-          <a:prstGeom prst="rect">
-            <a:avLst/>
-          </a:prstGeom>
-          <a:solidFill>
-            <a:srgbClr val="1D3557"/>
-          </a:solidFill>
-          <a:ln>
-            <a:noFill/>
-          </a:ln>
-          <a:effectLst/>
-        </p:spPr>
-        <p:style>
-          <a:lnRef idx="1">
-            <a:schemeClr val="accent1"/>
-          </a:lnRef>
-          <a:fillRef idx="3">
-            <a:schemeClr val="accent1"/>
-          </a:fillRef>
-          <a:effectRef idx="2">
-            <a:schemeClr val="accent1"/>
-          </a:effectRef>
-          <a:fontRef idx="minor">
-            <a:schemeClr val="lt1"/>
-          </a:fontRef>
-        </p:style>
-        <p:txBody>
-          <a:bodyPr rtlCol="0" anchor="ctr"/>
-          <a:lstStyle/>
-          <a:p>
-            <a:pPr algn="ctr"/>
-          </a:p>
-        </p:txBody>
-      </p:sp>
-      <p:sp>
-        <p:nvSpPr>
-          <p:cNvPr id="3" name="TextBox 2"/>
-          <p:cNvSpPr txBox="1"/>
-          <p:nvPr/>
-        </p:nvSpPr>
-        <p:spPr>
-          <a:xfrm>
-            <a:off x="603504" y="1847088"/>
-            <a:ext cx="7946136" cy="1399032"/>
-          </a:xfrm>
-          <a:prstGeom prst="rect">
-            <a:avLst/>
-          </a:prstGeom>
-          <a:noFill/>
-        </p:spPr>
-        <p:txBody>
-          <a:bodyPr wrap="square">
-            <a:spAutoFit/>
-          </a:bodyPr>
-          <a:lstStyle/>
-          <a:p>
-            <a:r>
-              <a:rPr sz="3400" b="1">
-                <a:solidFill>
-                  <a:srgbClr val="FFFFFF"/>
-                </a:solidFill>
-                <a:latin typeface="Fira Sans"/>
-              </a:rPr>
-              <a:t>Tipos de datos y tipos de variables</a:t>
-            </a:r>
-          </a:p>
-          <a:p>
-            <a:r>
-              <a:rPr sz="1800" b="0">
-                <a:solidFill>
-                  <a:srgbClr val="E0A437"/>
-                </a:solidFill>
-                <a:latin typeface="Fira Sans"/>
-              </a:rPr>
-              <a:t>Qué análisis admite cada columna</a:t>
-            </a:r>
-          </a:p>
-        </p:txBody>
-      </p:sp>
-    </p:spTree>
-  </p:cSld>
-  <p:clrMapOvr>
-    <a:masterClrMapping/>
-  </p:clrMapOvr>
-</p:sld>
-</file>
-
 <file path=ppt/slides/slide12.xml><?xml version="1.0" encoding="utf-8"?>
 <p:sld xmlns:a="http://schemas.openxmlformats.org/drawingml/2006/main" xmlns:p="http://schemas.openxmlformats.org/presentationml/2006/main" xmlns:r="http://schemas.openxmlformats.org/officeDocument/2006/relationships">
   <p:cSld>
@@ -3982,7 +4079,7 @@
             <a:avLst/>
           </a:prstGeom>
           <a:solidFill>
-            <a:srgbClr val="FAFBFC"/>
+            <a:srgbClr val="1D3557"/>
           </a:solidFill>
           <a:ln>
             <a:noFill/>
@@ -4019,8 +4116,8 @@
         </p:nvSpPr>
         <p:spPr>
           <a:xfrm>
-            <a:off x="402336" y="301752"/>
-            <a:ext cx="8348472" cy="795528"/>
+            <a:off x="603504" y="1847088"/>
+            <a:ext cx="7946136" cy="1399032"/>
           </a:xfrm>
           <a:prstGeom prst="rect">
             <a:avLst/>
@@ -4034,71 +4131,24 @@
           <a:lstStyle/>
           <a:p>
             <a:r>
-              <a:rPr sz="2800" b="1">
-                <a:solidFill>
-                  <a:srgbClr val="0F0F0F"/>
-                </a:solidFill>
-                <a:latin typeface="Fira Sans"/>
-              </a:rPr>
-              <a:t>Datos estructurados y no estructurados</a:t>
-            </a:r>
-          </a:p>
-        </p:txBody>
-      </p:sp>
-      <p:pic>
-        <p:nvPicPr>
-          <p:cNvPr id="4" name="Picture 3" descr="09_estructurados.png"/>
-          <p:cNvPicPr>
-            <a:picLocks noChangeAspect="1"/>
-          </p:cNvPicPr>
-          <p:nvPr/>
-        </p:nvPicPr>
-        <p:blipFill>
-          <a:blip r:embed="rId2"/>
-          <a:stretch>
-            <a:fillRect/>
-          </a:stretch>
-        </p:blipFill>
-        <p:spPr>
-          <a:xfrm>
-            <a:off x="1417319" y="1143000"/>
-            <a:ext cx="6309360" cy="2884949"/>
-          </a:xfrm>
-          <a:prstGeom prst="rect">
-            <a:avLst/>
-          </a:prstGeom>
-        </p:spPr>
-      </p:pic>
-      <p:sp>
-        <p:nvSpPr>
-          <p:cNvPr id="5" name="TextBox 4"/>
-          <p:cNvSpPr txBox="1"/>
-          <p:nvPr/>
-        </p:nvSpPr>
-        <p:spPr>
-          <a:xfrm>
-            <a:off x="704088" y="4434840"/>
-            <a:ext cx="7744968" cy="457200"/>
-          </a:xfrm>
-          <a:prstGeom prst="rect">
-            <a:avLst/>
-          </a:prstGeom>
-          <a:noFill/>
-        </p:spPr>
-        <p:txBody>
-          <a:bodyPr wrap="square">
-            <a:spAutoFit/>
-          </a:bodyPr>
-          <a:lstStyle/>
-          <a:p>
-            <a:r>
-              <a:rPr sz="1300" b="0">
-                <a:solidFill>
-                  <a:srgbClr val="333333"/>
-                </a:solidFill>
-                <a:latin typeface="Fira Sans"/>
-              </a:rPr>
-              <a:t>Los no estructurados se trabajan en los módulos de machine learning y deep learning; en la práctica, analizarlos suele requerir convertirlos primero en representaciones tabulares o numéricas.</a:t>
+              <a:rPr sz="3400" b="1">
+                <a:solidFill>
+                  <a:srgbClr val="FFFFFF"/>
+                </a:solidFill>
+                <a:latin typeface="Fira Sans"/>
+              </a:rPr>
+              <a:t>Tipos de datos y tipos de variables</a:t>
+            </a:r>
+          </a:p>
+          <a:p>
+            <a:r>
+              <a:rPr sz="1800" b="0">
+                <a:solidFill>
+                  <a:srgbClr val="E0A437"/>
+                </a:solidFill>
+                <a:latin typeface="Fira Sans"/>
+              </a:rPr>
+              <a:t>Qué análisis admite cada columna</a:t>
             </a:r>
           </a:p>
         </p:txBody>
@@ -4194,14 +4244,14 @@
                 </a:solidFill>
                 <a:latin typeface="Fira Sans"/>
               </a:rPr>
-              <a:t>Tipos de variables</a:t>
+              <a:t>Datos estructurados y no estructurados</a:t>
             </a:r>
           </a:p>
         </p:txBody>
       </p:sp>
       <p:pic>
         <p:nvPicPr>
-          <p:cNvPr id="4" name="Picture 3" descr="04_tipos_variables.png"/>
+          <p:cNvPr id="4" name="Picture 3" descr="09_estructurados.png"/>
           <p:cNvPicPr>
             <a:picLocks noChangeAspect="1"/>
           </p:cNvPicPr>
@@ -4215,8 +4265,8 @@
         </p:blipFill>
         <p:spPr>
           <a:xfrm>
-            <a:off x="1423172" y="1143000"/>
-            <a:ext cx="6297654" cy="3154680"/>
+            <a:off x="1417319" y="1143000"/>
+            <a:ext cx="6309360" cy="2884949"/>
           </a:xfrm>
           <a:prstGeom prst="rect">
             <a:avLst/>
@@ -4252,7 +4302,7 @@
                 </a:solidFill>
                 <a:latin typeface="Fira Sans"/>
               </a:rPr>
-              <a:t>La misma tabla mezcla los cuatro tipos; cada columna se analiza según el suyo.</a:t>
+              <a:t>Los no estructurados se trabajan en los módulos de machine learning y deep learning; en la práctica, analizarlos suele requerir convertirlos primero en representaciones tabulares o numéricas.</a:t>
             </a:r>
           </a:p>
         </p:txBody>
@@ -4348,21 +4398,45 @@
                 </a:solidFill>
                 <a:latin typeface="Fira Sans"/>
               </a:rPr>
-              <a:t>Códigos numéricos: variables nominales</a:t>
-            </a:r>
-          </a:p>
-        </p:txBody>
-      </p:sp>
-      <p:sp>
-        <p:nvSpPr>
-          <p:cNvPr id="4" name="TextBox 3"/>
+              <a:t>Tipos de variables</a:t>
+            </a:r>
+          </a:p>
+        </p:txBody>
+      </p:sp>
+      <p:pic>
+        <p:nvPicPr>
+          <p:cNvPr id="4" name="Picture 3" descr="04_tipos_variables.png"/>
+          <p:cNvPicPr>
+            <a:picLocks noChangeAspect="1"/>
+          </p:cNvPicPr>
+          <p:nvPr/>
+        </p:nvPicPr>
+        <p:blipFill>
+          <a:blip r:embed="rId2"/>
+          <a:stretch>
+            <a:fillRect/>
+          </a:stretch>
+        </p:blipFill>
+        <p:spPr>
+          <a:xfrm>
+            <a:off x="1423172" y="1143000"/>
+            <a:ext cx="6297654" cy="3154680"/>
+          </a:xfrm>
+          <a:prstGeom prst="rect">
+            <a:avLst/>
+          </a:prstGeom>
+        </p:spPr>
+      </p:pic>
+      <p:sp>
+        <p:nvSpPr>
+          <p:cNvPr id="5" name="TextBox 4"/>
           <p:cNvSpPr txBox="1"/>
           <p:nvPr/>
         </p:nvSpPr>
         <p:spPr>
           <a:xfrm>
-            <a:off x="704088" y="1353312"/>
-            <a:ext cx="7744968" cy="3300984"/>
+            <a:off x="704088" y="4434840"/>
+            <a:ext cx="7744968" cy="457200"/>
           </a:xfrm>
           <a:prstGeom prst="rect">
             <a:avLst/>
@@ -4375,115 +4449,14 @@
           </a:bodyPr>
           <a:lstStyle/>
           <a:p>
-            <a:pPr>
-              <a:lnSpc>
-                <a:spcPct val="112000"/>
-              </a:lnSpc>
-              <a:spcAft>
-                <a:spcPts val="900"/>
-              </a:spcAft>
-            </a:pPr>
-            <a:r>
-              <a:rPr sz="1800" b="1">
-                <a:solidFill>
-                  <a:srgbClr val="E0A437"/>
-                </a:solidFill>
-                <a:latin typeface="Fira Sans"/>
-              </a:rPr>
-              <a:t>▸ </a:t>
-            </a:r>
-            <a:r>
-              <a:rPr sz="1800" b="0">
-                <a:solidFill>
-                  <a:srgbClr val="000000"/>
-                </a:solidFill>
-                <a:latin typeface="Fira Sans"/>
-              </a:rPr>
-              <a:t>En la encuesta de viajes que exploraremos hoy en el notebook, la columna ComunaOrigen vale 94, 71, 13... pero es una variable nominal: los números son códigos de comuna.</a:t>
-            </a:r>
-          </a:p>
-          <a:p>
-            <a:pPr>
-              <a:lnSpc>
-                <a:spcPct val="112000"/>
-              </a:lnSpc>
-              <a:spcAft>
-                <a:spcPts val="900"/>
-              </a:spcAft>
-            </a:pPr>
-            <a:r>
-              <a:rPr sz="1800" b="1">
-                <a:solidFill>
-                  <a:srgbClr val="E0A437"/>
-                </a:solidFill>
-                <a:latin typeface="Fira Sans"/>
-              </a:rPr>
-              <a:t>▸ </a:t>
-            </a:r>
-            <a:r>
-              <a:rPr sz="1800" b="0">
-                <a:solidFill>
-                  <a:srgbClr val="000000"/>
-                </a:solidFill>
-                <a:latin typeface="Fira Sans"/>
-              </a:rPr>
-              <a:t>Promediar códigos de comuna no significa nada; contar viajes por comuna, sí.</a:t>
-            </a:r>
-          </a:p>
-          <a:p>
-            <a:pPr>
-              <a:lnSpc>
-                <a:spcPct val="112000"/>
-              </a:lnSpc>
-              <a:spcAft>
-                <a:spcPts val="900"/>
-              </a:spcAft>
-            </a:pPr>
-            <a:r>
-              <a:rPr sz="1800" b="1">
-                <a:solidFill>
-                  <a:srgbClr val="E0A437"/>
-                </a:solidFill>
-                <a:latin typeface="Fira Sans"/>
-              </a:rPr>
-              <a:t>▸ </a:t>
-            </a:r>
-            <a:r>
-              <a:rPr sz="1800" b="1">
-                <a:solidFill>
-                  <a:srgbClr val="1D3557"/>
-                </a:solidFill>
-                <a:latin typeface="Fira Sans"/>
-              </a:rPr>
-              <a:t>El tipo de la variable define qué resumen y qué gráfico son válidos: es lo primero que se revisa al abrir una tabla.</a:t>
-            </a:r>
-          </a:p>
-          <a:p>
-            <a:pPr>
-              <a:lnSpc>
-                <a:spcPct val="112000"/>
-              </a:lnSpc>
-              <a:spcAft>
-                <a:spcPts val="900"/>
-              </a:spcAft>
-            </a:pPr>
-            <a:r>
-              <a:rPr sz="1800" b="1">
-                <a:solidFill>
-                  <a:srgbClr val="E0A437"/>
-                </a:solidFill>
-                <a:latin typeface="Fira Sans"/>
-              </a:rPr>
-              <a:t>▸ </a:t>
-            </a:r>
-            <a:r>
-              <a:rPr sz="1800" b="0">
-                <a:solidFill>
-                  <a:srgbClr val="000000"/>
-                </a:solidFill>
-                <a:latin typeface="Fira Sans"/>
-              </a:rPr>
-              <a:t>En la clase 2 esto se vuelve operativo: cada resumen de la estadística descriptiva aplica a ciertos tipos de variables.</a:t>
+            <a:r>
+              <a:rPr sz="1300" b="0">
+                <a:solidFill>
+                  <a:srgbClr val="333333"/>
+                </a:solidFill>
+                <a:latin typeface="Fira Sans"/>
+              </a:rPr>
+              <a:t>La misma tabla mezcla los cuatro tipos; cada columna se analiza según el suyo.</a:t>
             </a:r>
           </a:p>
         </p:txBody>
@@ -4521,7 +4494,7 @@
             <a:avLst/>
           </a:prstGeom>
           <a:solidFill>
-            <a:srgbClr val="1D3557"/>
+            <a:srgbClr val="FAFBFC"/>
           </a:solidFill>
           <a:ln>
             <a:noFill/>
@@ -4558,8 +4531,8 @@
         </p:nvSpPr>
         <p:spPr>
           <a:xfrm>
-            <a:off x="603504" y="1847088"/>
-            <a:ext cx="7946136" cy="1399032"/>
+            <a:off x="402336" y="301752"/>
+            <a:ext cx="8348472" cy="795528"/>
           </a:xfrm>
           <a:prstGeom prst="rect">
             <a:avLst/>
@@ -4573,24 +4546,148 @@
           <a:lstStyle/>
           <a:p>
             <a:r>
-              <a:rPr sz="3400" b="1">
-                <a:solidFill>
-                  <a:srgbClr val="FFFFFF"/>
-                </a:solidFill>
-                <a:latin typeface="Fira Sans"/>
-              </a:rPr>
-              <a:t>Recreo</a:t>
-            </a:r>
-          </a:p>
-          <a:p>
+              <a:rPr sz="2800" b="1">
+                <a:solidFill>
+                  <a:srgbClr val="0F0F0F"/>
+                </a:solidFill>
+                <a:latin typeface="Fira Sans"/>
+              </a:rPr>
+              <a:t>Códigos numéricos: variables nominales</a:t>
+            </a:r>
+          </a:p>
+        </p:txBody>
+      </p:sp>
+      <p:sp>
+        <p:nvSpPr>
+          <p:cNvPr id="4" name="TextBox 3"/>
+          <p:cNvSpPr txBox="1"/>
+          <p:nvPr/>
+        </p:nvSpPr>
+        <p:spPr>
+          <a:xfrm>
+            <a:off x="704088" y="1353312"/>
+            <a:ext cx="7744968" cy="3300984"/>
+          </a:xfrm>
+          <a:prstGeom prst="rect">
+            <a:avLst/>
+          </a:prstGeom>
+          <a:noFill/>
+        </p:spPr>
+        <p:txBody>
+          <a:bodyPr wrap="square">
+            <a:spAutoFit/>
+          </a:bodyPr>
+          <a:lstStyle/>
+          <a:p>
+            <a:pPr>
+              <a:lnSpc>
+                <a:spcPct val="112000"/>
+              </a:lnSpc>
+              <a:spcAft>
+                <a:spcPts val="900"/>
+              </a:spcAft>
+            </a:pPr>
+            <a:r>
+              <a:rPr sz="1800" b="1">
+                <a:solidFill>
+                  <a:srgbClr val="E0A437"/>
+                </a:solidFill>
+                <a:latin typeface="Fira Sans"/>
+              </a:rPr>
+              <a:t>▸ </a:t>
+            </a:r>
             <a:r>
               <a:rPr sz="1800" b="0">
                 <a:solidFill>
+                  <a:srgbClr val="000000"/>
+                </a:solidFill>
+                <a:latin typeface="Fira Sans"/>
+              </a:rPr>
+              <a:t>En la encuesta de viajes que exploraremos hoy en el notebook, la columna ComunaOrigen vale 94, 71, 13... pero es una variable nominal: los números son códigos de comuna.</a:t>
+            </a:r>
+          </a:p>
+          <a:p>
+            <a:pPr>
+              <a:lnSpc>
+                <a:spcPct val="112000"/>
+              </a:lnSpc>
+              <a:spcAft>
+                <a:spcPts val="900"/>
+              </a:spcAft>
+            </a:pPr>
+            <a:r>
+              <a:rPr sz="1800" b="1">
+                <a:solidFill>
                   <a:srgbClr val="E0A437"/>
                 </a:solidFill>
                 <a:latin typeface="Fira Sans"/>
               </a:rPr>
-              <a:t>10 minutos</a:t>
+              <a:t>▸ </a:t>
+            </a:r>
+            <a:r>
+              <a:rPr sz="1800" b="0">
+                <a:solidFill>
+                  <a:srgbClr val="000000"/>
+                </a:solidFill>
+                <a:latin typeface="Fira Sans"/>
+              </a:rPr>
+              <a:t>Promediar códigos de comuna no significa nada; contar viajes por comuna, sí.</a:t>
+            </a:r>
+          </a:p>
+          <a:p>
+            <a:pPr>
+              <a:lnSpc>
+                <a:spcPct val="112000"/>
+              </a:lnSpc>
+              <a:spcAft>
+                <a:spcPts val="900"/>
+              </a:spcAft>
+            </a:pPr>
+            <a:r>
+              <a:rPr sz="1800" b="1">
+                <a:solidFill>
+                  <a:srgbClr val="E0A437"/>
+                </a:solidFill>
+                <a:latin typeface="Fira Sans"/>
+              </a:rPr>
+              <a:t>▸ </a:t>
+            </a:r>
+            <a:r>
+              <a:rPr sz="1800" b="1">
+                <a:solidFill>
+                  <a:srgbClr val="1D3557"/>
+                </a:solidFill>
+                <a:latin typeface="Fira Sans"/>
+              </a:rPr>
+              <a:t>El tipo de la variable define qué resumen y qué gráfico son válidos: es lo primero que se revisa al abrir una tabla.</a:t>
+            </a:r>
+          </a:p>
+          <a:p>
+            <a:pPr>
+              <a:lnSpc>
+                <a:spcPct val="112000"/>
+              </a:lnSpc>
+              <a:spcAft>
+                <a:spcPts val="900"/>
+              </a:spcAft>
+            </a:pPr>
+            <a:r>
+              <a:rPr sz="1800" b="1">
+                <a:solidFill>
+                  <a:srgbClr val="E0A437"/>
+                </a:solidFill>
+                <a:latin typeface="Fira Sans"/>
+              </a:rPr>
+              <a:t>▸ </a:t>
+            </a:r>
+            <a:r>
+              <a:rPr sz="1800" b="0">
+                <a:solidFill>
+                  <a:srgbClr val="000000"/>
+                </a:solidFill>
+                <a:latin typeface="Fira Sans"/>
+              </a:rPr>
+              <a:t>En la clase 2 esto se vuelve operativo: cada resumen de la estadística descriptiva aplica a ciertos tipos de variables.</a:t>
             </a:r>
           </a:p>
         </p:txBody>
@@ -4686,7 +4783,7 @@
                 </a:solidFill>
                 <a:latin typeface="Fira Sans"/>
               </a:rPr>
-              <a:t>El ecosistema Python</a:t>
+              <a:t>Recreo</a:t>
             </a:r>
           </a:p>
           <a:p>
@@ -4697,7 +4794,7 @@
                 </a:solidFill>
                 <a:latin typeface="Fira Sans"/>
               </a:rPr>
-              <a:t>NumPy, Pandas y Matplotlib, más Jupyter y uv</a:t>
+              <a:t>10 minutos</a:t>
             </a:r>
           </a:p>
         </p:txBody>
@@ -4735,7 +4832,7 @@
             <a:avLst/>
           </a:prstGeom>
           <a:solidFill>
-            <a:srgbClr val="FAFBFC"/>
+            <a:srgbClr val="1D3557"/>
           </a:solidFill>
           <a:ln>
             <a:noFill/>
@@ -4772,8 +4869,8 @@
         </p:nvSpPr>
         <p:spPr>
           <a:xfrm>
-            <a:off x="402336" y="301752"/>
-            <a:ext cx="8348472" cy="795528"/>
+            <a:off x="603504" y="1847088"/>
+            <a:ext cx="7946136" cy="1399032"/>
           </a:xfrm>
           <a:prstGeom prst="rect">
             <a:avLst/>
@@ -4787,71 +4884,24 @@
           <a:lstStyle/>
           <a:p>
             <a:r>
-              <a:rPr sz="2800" b="1">
-                <a:solidFill>
-                  <a:srgbClr val="0F0F0F"/>
-                </a:solidFill>
-                <a:latin typeface="Fira Sans"/>
-              </a:rPr>
-              <a:t>Las herramientas del módulo</a:t>
-            </a:r>
-          </a:p>
-        </p:txBody>
-      </p:sp>
-      <p:pic>
-        <p:nvPicPr>
-          <p:cNvPr id="4" name="Picture 3" descr="05_ecosistema.png"/>
-          <p:cNvPicPr>
-            <a:picLocks noChangeAspect="1"/>
-          </p:cNvPicPr>
-          <p:nvPr/>
-        </p:nvPicPr>
-        <p:blipFill>
-          <a:blip r:embed="rId2"/>
-          <a:stretch>
-            <a:fillRect/>
-          </a:stretch>
-        </p:blipFill>
-        <p:spPr>
-          <a:xfrm>
-            <a:off x="1417319" y="1143000"/>
-            <a:ext cx="6309360" cy="2814584"/>
-          </a:xfrm>
-          <a:prstGeom prst="rect">
-            <a:avLst/>
-          </a:prstGeom>
-        </p:spPr>
-      </p:pic>
-      <p:sp>
-        <p:nvSpPr>
-          <p:cNvPr id="5" name="TextBox 4"/>
-          <p:cNvSpPr txBox="1"/>
-          <p:nvPr/>
-        </p:nvSpPr>
-        <p:spPr>
-          <a:xfrm>
-            <a:off x="704088" y="4434840"/>
-            <a:ext cx="7744968" cy="457200"/>
-          </a:xfrm>
-          <a:prstGeom prst="rect">
-            <a:avLst/>
-          </a:prstGeom>
-          <a:noFill/>
-        </p:spPr>
-        <p:txBody>
-          <a:bodyPr wrap="square">
-            <a:spAutoFit/>
-          </a:bodyPr>
-          <a:lstStyle/>
-          <a:p>
-            <a:r>
-              <a:rPr sz="1300" b="0">
-                <a:solidFill>
-                  <a:srgbClr val="333333"/>
-                </a:solidFill>
-                <a:latin typeface="Fira Sans"/>
-              </a:rPr>
-              <a:t>Python trae la sintaxis; NumPy, Pandas y Matplotlib traen el trabajo con datos. Jupyter y uv son el entorno donde todo corre.</a:t>
+              <a:rPr sz="3400" b="1">
+                <a:solidFill>
+                  <a:srgbClr val="FFFFFF"/>
+                </a:solidFill>
+                <a:latin typeface="Fira Sans"/>
+              </a:rPr>
+              <a:t>El ecosistema Python</a:t>
+            </a:r>
+          </a:p>
+          <a:p>
+            <a:r>
+              <a:rPr sz="1800" b="0">
+                <a:solidFill>
+                  <a:srgbClr val="E0A437"/>
+                </a:solidFill>
+                <a:latin typeface="Fira Sans"/>
+              </a:rPr>
+              <a:t>NumPy, Pandas y Matplotlib, más Jupyter y uv</a:t>
             </a:r>
           </a:p>
         </p:txBody>
@@ -4947,90 +4997,35 @@
                 </a:solidFill>
                 <a:latin typeface="Fira Sans"/>
               </a:rPr>
-              <a:t>NumPy: cálculo sobre arreglos completos</a:t>
-            </a:r>
-          </a:p>
-        </p:txBody>
-      </p:sp>
-      <p:sp>
-        <p:nvSpPr>
-          <p:cNvPr id="4" name="Rectangle 3"/>
-          <p:cNvSpPr/>
-          <p:nvPr/>
-        </p:nvSpPr>
-        <p:spPr>
-          <a:xfrm>
-            <a:off x="704088" y="1280160"/>
-            <a:ext cx="7744968" cy="1874520"/>
-          </a:xfrm>
-          <a:prstGeom prst="rect">
-            <a:avLst/>
-          </a:prstGeom>
-          <a:solidFill>
-            <a:srgbClr val="F0F2F5"/>
-          </a:solidFill>
-          <a:ln>
-            <a:solidFill>
-              <a:srgbClr val="D8DDE3"/>
-            </a:solidFill>
-          </a:ln>
-          <a:effectLst/>
-        </p:spPr>
-        <p:style>
-          <a:lnRef idx="1">
-            <a:schemeClr val="accent1"/>
-          </a:lnRef>
-          <a:fillRef idx="3">
-            <a:schemeClr val="accent1"/>
-          </a:fillRef>
-          <a:effectRef idx="2">
-            <a:schemeClr val="accent1"/>
-          </a:effectRef>
-          <a:fontRef idx="minor">
-            <a:schemeClr val="lt1"/>
-          </a:fontRef>
-        </p:style>
-        <p:txBody>
-          <a:bodyPr rtlCol="0" anchor="ctr" wrap="square" lIns="228600" tIns="137160"/>
-          <a:lstStyle/>
-          <a:p>
-            <a:pPr/>
-            <a:r>
-              <a:rPr sz="1500" b="0">
-                <a:solidFill>
-                  <a:srgbClr val="1D3557"/>
-                </a:solidFill>
-                <a:latin typeface="Menlo"/>
-              </a:rPr>
-              <a:t>import numpy as np</a:t>
-            </a:r>
-          </a:p>
-          <a:p>
-            <a:pPr/>
-            <a:r>
-              <a:rPr sz="1500" b="0">
-                <a:solidFill>
-                  <a:srgbClr val="1D3557"/>
-                </a:solidFill>
-                <a:latin typeface="Menlo"/>
-              </a:rPr>
-              <a:t>tiempos = np.array([70, 105, 90, 25, 40])</a:t>
-            </a:r>
-          </a:p>
-          <a:p>
-            <a:pPr/>
-            <a:r>
-              <a:rPr sz="1500" b="0">
-                <a:solidFill>
-                  <a:srgbClr val="1D3557"/>
-                </a:solidFill>
-                <a:latin typeface="Menlo"/>
-              </a:rPr>
-              <a:t>tiempos.mean()          # 66.0, sin escribir un ciclo</a:t>
-            </a:r>
-          </a:p>
-        </p:txBody>
-      </p:sp>
+              <a:t>Las herramientas del módulo</a:t>
+            </a:r>
+          </a:p>
+        </p:txBody>
+      </p:sp>
+      <p:pic>
+        <p:nvPicPr>
+          <p:cNvPr id="4" name="Picture 3" descr="05_ecosistema.png"/>
+          <p:cNvPicPr>
+            <a:picLocks noChangeAspect="1"/>
+          </p:cNvPicPr>
+          <p:nvPr/>
+        </p:nvPicPr>
+        <p:blipFill>
+          <a:blip r:embed="rId2"/>
+          <a:stretch>
+            <a:fillRect/>
+          </a:stretch>
+        </p:blipFill>
+        <p:spPr>
+          <a:xfrm>
+            <a:off x="1417319" y="1143000"/>
+            <a:ext cx="6309360" cy="2814584"/>
+          </a:xfrm>
+          <a:prstGeom prst="rect">
+            <a:avLst/>
+          </a:prstGeom>
+        </p:spPr>
+      </p:pic>
       <p:sp>
         <p:nvSpPr>
           <p:cNvPr id="5" name="TextBox 4"/>
@@ -5039,8 +5034,8 @@
         </p:nvSpPr>
         <p:spPr>
           <a:xfrm>
-            <a:off x="704088" y="3383279"/>
-            <a:ext cx="7744968" cy="1097280"/>
+            <a:off x="704088" y="4434840"/>
+            <a:ext cx="7744968" cy="457200"/>
           </a:xfrm>
           <a:prstGeom prst="rect">
             <a:avLst/>
@@ -5053,31 +5048,14 @@
           </a:bodyPr>
           <a:lstStyle/>
           <a:p>
-            <a:pPr>
-              <a:lnSpc>
-                <a:spcPct val="112000"/>
-              </a:lnSpc>
-              <a:spcAft>
-                <a:spcPts val="900"/>
-              </a:spcAft>
-            </a:pPr>
-            <a:r>
-              <a:rPr sz="1600" b="1">
-                <a:solidFill>
-                  <a:srgbClr val="E0A437"/>
-                </a:solidFill>
-                <a:latin typeface="Fira Sans"/>
-              </a:rPr>
-              <a:t>▸ </a:t>
-            </a:r>
-            <a:r>
-              <a:rPr sz="1600" b="0">
-                <a:solidFill>
-                  <a:srgbClr val="000000"/>
-                </a:solidFill>
-                <a:latin typeface="Fira Sans"/>
-              </a:rPr>
-              <a:t>La operación se aplica al arreglo completo (vectorización): menos código y mucho más rápido que iterar en Python puro. Es la base sobre la que se construye todo lo demás.</a:t>
+            <a:r>
+              <a:rPr sz="1300" b="0">
+                <a:solidFill>
+                  <a:srgbClr val="333333"/>
+                </a:solidFill>
+                <a:latin typeface="Fira Sans"/>
+              </a:rPr>
+              <a:t>Python trae la sintaxis; NumPy, Pandas y Matplotlib traen el trabajo con datos. Jupyter y uv son el entorno donde todo corre.</a:t>
             </a:r>
           </a:p>
         </p:txBody>
@@ -5173,7 +5151,7 @@
                 </a:solidFill>
                 <a:latin typeface="Fira Sans"/>
               </a:rPr>
-              <a:t>Pandas: la tabla como objeto de trabajo</a:t>
+              <a:t>NumPy: cálculo sobre arreglos completos</a:t>
             </a:r>
           </a:p>
         </p:txBody>
@@ -5228,7 +5206,7 @@
                 </a:solidFill>
                 <a:latin typeface="Menlo"/>
               </a:rPr>
-              <a:t>import pandas as pd</a:t>
+              <a:t>import numpy as np</a:t>
             </a:r>
           </a:p>
           <a:p>
@@ -5240,7 +5218,7 @@
                 </a:solidFill>
                 <a:latin typeface="Menlo"/>
               </a:rPr>
-              <a:t>viajes = pd.read_csv(URL_VIAJES, sep=";", decimal=",")</a:t>
+              <a:t>tiempos = np.array([70, 105, 90, 25, 40])</a:t>
             </a:r>
           </a:p>
           <a:p>
@@ -5252,7 +5230,7 @@
                 </a:solidFill>
                 <a:latin typeface="Menlo"/>
               </a:rPr>
-              <a:t>viajes.head()</a:t>
+              <a:t>tiempos.mean()          # 66.0, sin escribir un ciclo</a:t>
             </a:r>
           </a:p>
         </p:txBody>
@@ -5303,7 +5281,7 @@
                 </a:solidFill>
                 <a:latin typeface="Fira Sans"/>
               </a:rPr>
-              <a:t>El DataFrame es una tabla con columnas etiquetadas, cada una de su propio tipo. Con esas tres líneas se abre la EOD completa: lo haremos en vivo en el notebook de hoy.</a:t>
+              <a:t>La operación se aplica al arreglo completo (vectorización): menos código y mucho más rápido que iterar en Python puro. Es la base sobre la que se construye todo lo demás.</a:t>
             </a:r>
           </a:p>
         </p:txBody>
@@ -5658,35 +5636,90 @@
                 </a:solidFill>
                 <a:latin typeface="Fira Sans"/>
               </a:rPr>
-              <a:t>La Encuesta Origen Destino de Santiago 2012</a:t>
-            </a:r>
-          </a:p>
-        </p:txBody>
-      </p:sp>
-      <p:pic>
-        <p:nvPicPr>
-          <p:cNvPr id="4" name="Picture 3" descr="02_df_viajes.png"/>
-          <p:cNvPicPr>
-            <a:picLocks noChangeAspect="1"/>
-          </p:cNvPicPr>
-          <p:nvPr/>
-        </p:nvPicPr>
-        <p:blipFill>
-          <a:blip r:embed="rId2"/>
-          <a:stretch>
-            <a:fillRect/>
-          </a:stretch>
-        </p:blipFill>
-        <p:spPr>
-          <a:xfrm>
-            <a:off x="1417319" y="1143000"/>
-            <a:ext cx="6309360" cy="2296353"/>
-          </a:xfrm>
-          <a:prstGeom prst="rect">
-            <a:avLst/>
-          </a:prstGeom>
-        </p:spPr>
-      </p:pic>
+              <a:t>Pandas: la tabla como objeto de trabajo</a:t>
+            </a:r>
+          </a:p>
+        </p:txBody>
+      </p:sp>
+      <p:sp>
+        <p:nvSpPr>
+          <p:cNvPr id="4" name="Rectangle 3"/>
+          <p:cNvSpPr/>
+          <p:nvPr/>
+        </p:nvSpPr>
+        <p:spPr>
+          <a:xfrm>
+            <a:off x="704088" y="1280160"/>
+            <a:ext cx="7744968" cy="1874520"/>
+          </a:xfrm>
+          <a:prstGeom prst="rect">
+            <a:avLst/>
+          </a:prstGeom>
+          <a:solidFill>
+            <a:srgbClr val="F0F2F5"/>
+          </a:solidFill>
+          <a:ln>
+            <a:solidFill>
+              <a:srgbClr val="D8DDE3"/>
+            </a:solidFill>
+          </a:ln>
+          <a:effectLst/>
+        </p:spPr>
+        <p:style>
+          <a:lnRef idx="1">
+            <a:schemeClr val="accent1"/>
+          </a:lnRef>
+          <a:fillRef idx="3">
+            <a:schemeClr val="accent1"/>
+          </a:fillRef>
+          <a:effectRef idx="2">
+            <a:schemeClr val="accent1"/>
+          </a:effectRef>
+          <a:fontRef idx="minor">
+            <a:schemeClr val="lt1"/>
+          </a:fontRef>
+        </p:style>
+        <p:txBody>
+          <a:bodyPr rtlCol="0" anchor="ctr" wrap="square" lIns="228600" tIns="137160"/>
+          <a:lstStyle/>
+          <a:p>
+            <a:pPr/>
+            <a:r>
+              <a:rPr sz="1500" b="0">
+                <a:solidFill>
+                  <a:srgbClr val="1D3557"/>
+                </a:solidFill>
+                <a:latin typeface="Menlo"/>
+              </a:rPr>
+              <a:t>import pandas as pd</a:t>
+            </a:r>
+          </a:p>
+          <a:p>
+            <a:pPr/>
+            <a:r>
+              <a:rPr sz="1500" b="0">
+                <a:solidFill>
+                  <a:srgbClr val="1D3557"/>
+                </a:solidFill>
+                <a:latin typeface="Menlo"/>
+              </a:rPr>
+              <a:t>viajes = pd.read_csv(URL_VIAJES, sep=";", decimal=",")</a:t>
+            </a:r>
+          </a:p>
+          <a:p>
+            <a:pPr/>
+            <a:r>
+              <a:rPr sz="1500" b="0">
+                <a:solidFill>
+                  <a:srgbClr val="1D3557"/>
+                </a:solidFill>
+                <a:latin typeface="Menlo"/>
+              </a:rPr>
+              <a:t>viajes.head()</a:t>
+            </a:r>
+          </a:p>
+        </p:txBody>
+      </p:sp>
       <p:sp>
         <p:nvSpPr>
           <p:cNvPr id="5" name="TextBox 4"/>
@@ -5695,8 +5728,8 @@
         </p:nvSpPr>
         <p:spPr>
           <a:xfrm>
-            <a:off x="704088" y="4434840"/>
-            <a:ext cx="7744968" cy="457200"/>
+            <a:off x="704088" y="3383279"/>
+            <a:ext cx="7744968" cy="1097280"/>
           </a:xfrm>
           <a:prstGeom prst="rect">
             <a:avLst/>
@@ -5709,14 +5742,31 @@
           </a:bodyPr>
           <a:lstStyle/>
           <a:p>
-            <a:r>
-              <a:rPr sz="1300" b="0">
-                <a:solidFill>
-                  <a:srgbClr val="333333"/>
-                </a:solidFill>
-                <a:latin typeface="Fira Sans"/>
-              </a:rPr>
-              <a:t>EOD Santiago 2012: 18.264 hogares, 60.054 personas y 113.591 viajes registrados. Cada fila es un viaje; los códigos se resuelven contra tablas de parámetros.</a:t>
+            <a:pPr>
+              <a:lnSpc>
+                <a:spcPct val="112000"/>
+              </a:lnSpc>
+              <a:spcAft>
+                <a:spcPts val="900"/>
+              </a:spcAft>
+            </a:pPr>
+            <a:r>
+              <a:rPr sz="1600" b="1">
+                <a:solidFill>
+                  <a:srgbClr val="E0A437"/>
+                </a:solidFill>
+                <a:latin typeface="Fira Sans"/>
+              </a:rPr>
+              <a:t>▸ </a:t>
+            </a:r>
+            <a:r>
+              <a:rPr sz="1600" b="0">
+                <a:solidFill>
+                  <a:srgbClr val="000000"/>
+                </a:solidFill>
+                <a:latin typeface="Fira Sans"/>
+              </a:rPr>
+              <a:t>El DataFrame es una tabla con columnas etiquetadas, cada una de su propio tipo. Con esas tres líneas se abre la EOD completa: lo haremos en vivo en el notebook de hoy.</a:t>
             </a:r>
           </a:p>
         </p:txBody>
@@ -5812,78 +5862,35 @@
                 </a:solidFill>
                 <a:latin typeface="Fira Sans"/>
               </a:rPr>
-              <a:t>Pandas: unir tablas con merge</a:t>
-            </a:r>
-          </a:p>
-        </p:txBody>
-      </p:sp>
-      <p:sp>
-        <p:nvSpPr>
-          <p:cNvPr id="4" name="Rectangle 3"/>
-          <p:cNvSpPr/>
-          <p:nvPr/>
-        </p:nvSpPr>
-        <p:spPr>
-          <a:xfrm>
-            <a:off x="704088" y="1280160"/>
-            <a:ext cx="7744968" cy="1371600"/>
-          </a:xfrm>
-          <a:prstGeom prst="rect">
-            <a:avLst/>
-          </a:prstGeom>
-          <a:solidFill>
-            <a:srgbClr val="F0F2F5"/>
-          </a:solidFill>
-          <a:ln>
-            <a:solidFill>
-              <a:srgbClr val="D8DDE3"/>
-            </a:solidFill>
-          </a:ln>
-          <a:effectLst/>
-        </p:spPr>
-        <p:style>
-          <a:lnRef idx="1">
-            <a:schemeClr val="accent1"/>
-          </a:lnRef>
-          <a:fillRef idx="3">
-            <a:schemeClr val="accent1"/>
-          </a:fillRef>
-          <a:effectRef idx="2">
-            <a:schemeClr val="accent1"/>
-          </a:effectRef>
-          <a:fontRef idx="minor">
-            <a:schemeClr val="lt1"/>
-          </a:fontRef>
-        </p:style>
-        <p:txBody>
-          <a:bodyPr rtlCol="0" anchor="ctr" wrap="square" lIns="228600" tIns="137160"/>
-          <a:lstStyle/>
-          <a:p>
-            <a:pPr/>
-            <a:r>
-              <a:rPr sz="1500" b="0">
-                <a:solidFill>
-                  <a:srgbClr val="1D3557"/>
-                </a:solidFill>
-                <a:latin typeface="Menlo"/>
-              </a:rPr>
-              <a:t>comunas = pd.read_csv(URL_COMUNAS)   # Id, Comuna</a:t>
-            </a:r>
-          </a:p>
-          <a:p>
-            <a:pPr/>
-            <a:r>
-              <a:rPr sz="1500" b="0">
-                <a:solidFill>
-                  <a:srgbClr val="1D3557"/>
-                </a:solidFill>
-                <a:latin typeface="Menlo"/>
-              </a:rPr>
-              <a:t>viajes.merge(comunas, left_on="ComunaOrigen", right_on="Id")</a:t>
-            </a:r>
-          </a:p>
-        </p:txBody>
-      </p:sp>
+              <a:t>La Encuesta Origen Destino de Santiago 2012</a:t>
+            </a:r>
+          </a:p>
+        </p:txBody>
+      </p:sp>
+      <p:pic>
+        <p:nvPicPr>
+          <p:cNvPr id="4" name="Picture 3" descr="02_df_viajes.png"/>
+          <p:cNvPicPr>
+            <a:picLocks noChangeAspect="1"/>
+          </p:cNvPicPr>
+          <p:nvPr/>
+        </p:nvPicPr>
+        <p:blipFill>
+          <a:blip r:embed="rId2"/>
+          <a:stretch>
+            <a:fillRect/>
+          </a:stretch>
+        </p:blipFill>
+        <p:spPr>
+          <a:xfrm>
+            <a:off x="1417319" y="1143000"/>
+            <a:ext cx="6309360" cy="2296353"/>
+          </a:xfrm>
+          <a:prstGeom prst="rect">
+            <a:avLst/>
+          </a:prstGeom>
+        </p:spPr>
+      </p:pic>
       <p:sp>
         <p:nvSpPr>
           <p:cNvPr id="5" name="TextBox 4"/>
@@ -5892,8 +5899,8 @@
         </p:nvSpPr>
         <p:spPr>
           <a:xfrm>
-            <a:off x="704088" y="2880360"/>
-            <a:ext cx="7744968" cy="1097280"/>
+            <a:off x="704088" y="4434840"/>
+            <a:ext cx="7744968" cy="457200"/>
           </a:xfrm>
           <a:prstGeom prst="rect">
             <a:avLst/>
@@ -5906,31 +5913,14 @@
           </a:bodyPr>
           <a:lstStyle/>
           <a:p>
-            <a:pPr>
-              <a:lnSpc>
-                <a:spcPct val="112000"/>
-              </a:lnSpc>
-              <a:spcAft>
-                <a:spcPts val="900"/>
-              </a:spcAft>
-            </a:pPr>
-            <a:r>
-              <a:rPr sz="1600" b="1">
-                <a:solidFill>
-                  <a:srgbClr val="E0A437"/>
-                </a:solidFill>
-                <a:latin typeface="Fira Sans"/>
-              </a:rPr>
-              <a:t>▸ </a:t>
-            </a:r>
-            <a:r>
-              <a:rPr sz="1600" b="0">
-                <a:solidFill>
-                  <a:srgbClr val="000000"/>
-                </a:solidFill>
-                <a:latin typeface="Fira Sans"/>
-              </a:rPr>
-              <a:t>Los códigos de una tabla se traducen uniéndola con su tabla de parámetros: merge empareja filas por una columna común. En el notebook lo usamos para ponerle nombre a comunas y modos de viaje.</a:t>
+            <a:r>
+              <a:rPr sz="1300" b="0">
+                <a:solidFill>
+                  <a:srgbClr val="333333"/>
+                </a:solidFill>
+                <a:latin typeface="Fira Sans"/>
+              </a:rPr>
+              <a:t>EOD Santiago 2012: 18.264 hogares, 60.054 personas y 113.591 viajes registrados. Cada fila es un viaje; los códigos se resuelven contra tablas de parámetros.</a:t>
             </a:r>
           </a:p>
         </p:txBody>
@@ -6026,35 +6016,78 @@
                 </a:solidFill>
                 <a:latin typeface="Fira Sans"/>
               </a:rPr>
-              <a:t>Matplotlib: del DataFrame al gráfico</a:t>
-            </a:r>
-          </a:p>
-        </p:txBody>
-      </p:sp>
-      <p:pic>
-        <p:nvPicPr>
-          <p:cNvPr id="4" name="Picture 3" descr="06_hist_tiempo.png"/>
-          <p:cNvPicPr>
-            <a:picLocks noChangeAspect="1"/>
-          </p:cNvPicPr>
-          <p:nvPr/>
-        </p:nvPicPr>
-        <p:blipFill>
-          <a:blip r:embed="rId2"/>
-          <a:stretch>
-            <a:fillRect/>
-          </a:stretch>
-        </p:blipFill>
-        <p:spPr>
-          <a:xfrm>
-            <a:off x="1778310" y="1143000"/>
-            <a:ext cx="5587379" cy="3154680"/>
-          </a:xfrm>
-          <a:prstGeom prst="rect">
-            <a:avLst/>
-          </a:prstGeom>
-        </p:spPr>
-      </p:pic>
+              <a:t>Pandas: unir tablas con merge</a:t>
+            </a:r>
+          </a:p>
+        </p:txBody>
+      </p:sp>
+      <p:sp>
+        <p:nvSpPr>
+          <p:cNvPr id="4" name="Rectangle 3"/>
+          <p:cNvSpPr/>
+          <p:nvPr/>
+        </p:nvSpPr>
+        <p:spPr>
+          <a:xfrm>
+            <a:off x="704088" y="1280160"/>
+            <a:ext cx="7744968" cy="1371600"/>
+          </a:xfrm>
+          <a:prstGeom prst="rect">
+            <a:avLst/>
+          </a:prstGeom>
+          <a:solidFill>
+            <a:srgbClr val="F0F2F5"/>
+          </a:solidFill>
+          <a:ln>
+            <a:solidFill>
+              <a:srgbClr val="D8DDE3"/>
+            </a:solidFill>
+          </a:ln>
+          <a:effectLst/>
+        </p:spPr>
+        <p:style>
+          <a:lnRef idx="1">
+            <a:schemeClr val="accent1"/>
+          </a:lnRef>
+          <a:fillRef idx="3">
+            <a:schemeClr val="accent1"/>
+          </a:fillRef>
+          <a:effectRef idx="2">
+            <a:schemeClr val="accent1"/>
+          </a:effectRef>
+          <a:fontRef idx="minor">
+            <a:schemeClr val="lt1"/>
+          </a:fontRef>
+        </p:style>
+        <p:txBody>
+          <a:bodyPr rtlCol="0" anchor="ctr" wrap="square" lIns="228600" tIns="137160"/>
+          <a:lstStyle/>
+          <a:p>
+            <a:pPr/>
+            <a:r>
+              <a:rPr sz="1500" b="0">
+                <a:solidFill>
+                  <a:srgbClr val="1D3557"/>
+                </a:solidFill>
+                <a:latin typeface="Menlo"/>
+              </a:rPr>
+              <a:t>comunas = pd.read_csv(URL_COMUNAS)   # Id, Comuna</a:t>
+            </a:r>
+          </a:p>
+          <a:p>
+            <a:pPr/>
+            <a:r>
+              <a:rPr sz="1500" b="0">
+                <a:solidFill>
+                  <a:srgbClr val="1D3557"/>
+                </a:solidFill>
+                <a:latin typeface="Menlo"/>
+              </a:rPr>
+              <a:t>viajes.merge(comunas, left_on="ComunaOrigen", right_on="Id")</a:t>
+            </a:r>
+          </a:p>
+        </p:txBody>
+      </p:sp>
       <p:sp>
         <p:nvSpPr>
           <p:cNvPr id="5" name="TextBox 4"/>
@@ -6063,8 +6096,8 @@
         </p:nvSpPr>
         <p:spPr>
           <a:xfrm>
-            <a:off x="704088" y="4434840"/>
-            <a:ext cx="7744968" cy="457200"/>
+            <a:off x="704088" y="2880360"/>
+            <a:ext cx="7744968" cy="1097280"/>
           </a:xfrm>
           <a:prstGeom prst="rect">
             <a:avLst/>
@@ -6077,14 +6110,31 @@
           </a:bodyPr>
           <a:lstStyle/>
           <a:p>
-            <a:r>
-              <a:rPr sz="1300" b="0">
-                <a:solidFill>
-                  <a:srgbClr val="333333"/>
-                </a:solidFill>
-                <a:latin typeface="Fira Sans"/>
-              </a:rPr>
-              <a:t>Este histograma sale de la tabla de viajes con unas seis líneas de código; el notebook de la clase las muestra completas.</a:t>
+            <a:pPr>
+              <a:lnSpc>
+                <a:spcPct val="112000"/>
+              </a:lnSpc>
+              <a:spcAft>
+                <a:spcPts val="900"/>
+              </a:spcAft>
+            </a:pPr>
+            <a:r>
+              <a:rPr sz="1600" b="1">
+                <a:solidFill>
+                  <a:srgbClr val="E0A437"/>
+                </a:solidFill>
+                <a:latin typeface="Fira Sans"/>
+              </a:rPr>
+              <a:t>▸ </a:t>
+            </a:r>
+            <a:r>
+              <a:rPr sz="1600" b="0">
+                <a:solidFill>
+                  <a:srgbClr val="000000"/>
+                </a:solidFill>
+                <a:latin typeface="Fira Sans"/>
+              </a:rPr>
+              <a:t>Los códigos de una tabla se traducen uniéndola con su tabla de parámetros: merge empareja filas por una columna común. En el notebook lo usamos para ponerle nombre a comunas y modos de viaje.</a:t>
             </a:r>
           </a:p>
         </p:txBody>
@@ -6180,102 +6230,35 @@
                 </a:solidFill>
                 <a:latin typeface="Fira Sans"/>
               </a:rPr>
-              <a:t>Puesta en marcha del entorno</a:t>
-            </a:r>
-          </a:p>
-        </p:txBody>
-      </p:sp>
-      <p:sp>
-        <p:nvSpPr>
-          <p:cNvPr id="4" name="Rectangle 3"/>
-          <p:cNvSpPr/>
-          <p:nvPr/>
-        </p:nvSpPr>
-        <p:spPr>
-          <a:xfrm>
-            <a:off x="704088" y="1280160"/>
-            <a:ext cx="7744968" cy="2377440"/>
-          </a:xfrm>
-          <a:prstGeom prst="rect">
-            <a:avLst/>
-          </a:prstGeom>
-          <a:solidFill>
-            <a:srgbClr val="F0F2F5"/>
-          </a:solidFill>
-          <a:ln>
-            <a:solidFill>
-              <a:srgbClr val="D8DDE3"/>
-            </a:solidFill>
-          </a:ln>
-          <a:effectLst/>
-        </p:spPr>
-        <p:style>
-          <a:lnRef idx="1">
-            <a:schemeClr val="accent1"/>
-          </a:lnRef>
-          <a:fillRef idx="3">
-            <a:schemeClr val="accent1"/>
-          </a:fillRef>
-          <a:effectRef idx="2">
-            <a:schemeClr val="accent1"/>
-          </a:effectRef>
-          <a:fontRef idx="minor">
-            <a:schemeClr val="lt1"/>
-          </a:fontRef>
-        </p:style>
-        <p:txBody>
-          <a:bodyPr rtlCol="0" anchor="ctr" wrap="square" lIns="228600" tIns="137160"/>
-          <a:lstStyle/>
-          <a:p>
-            <a:pPr/>
-            <a:r>
-              <a:rPr sz="1500" b="0">
-                <a:solidFill>
-                  <a:srgbClr val="1D3557"/>
-                </a:solidFill>
-                <a:latin typeface="Menlo"/>
-              </a:rPr>
-              <a:t>uv init --bare --python 3.12</a:t>
-            </a:r>
-          </a:p>
-          <a:p>
-            <a:pPr/>
-            <a:r>
-              <a:rPr sz="1500" b="0">
-                <a:solidFill>
-                  <a:srgbClr val="1D3557"/>
-                </a:solidFill>
-                <a:latin typeface="Menlo"/>
-              </a:rPr>
-              <a:t>uv add numpy pandas matplotlib seaborn scipy</a:t>
-            </a:r>
-          </a:p>
-          <a:p>
-            <a:pPr/>
-            <a:r>
-              <a:rPr sz="1500" b="0">
-                <a:solidFill>
-                  <a:srgbClr val="1D3557"/>
-                </a:solidFill>
-                <a:latin typeface="Menlo"/>
-              </a:rPr>
-              <a:t>uv add statsmodels scikit-learn jupyterlab</a:t>
-            </a:r>
-          </a:p>
-          <a:p>
-            <a:pPr/>
-            <a:r>
-              <a:rPr sz="1500" b="0">
-                <a:solidFill>
-                  <a:srgbClr val="1D3557"/>
-                </a:solidFill>
-                <a:latin typeface="Menlo"/>
-              </a:rPr>
-              <a:t>uv run jupyter lab</a:t>
-            </a:r>
-          </a:p>
-        </p:txBody>
-      </p:sp>
+              <a:t>Matplotlib: del DataFrame al gráfico</a:t>
+            </a:r>
+          </a:p>
+        </p:txBody>
+      </p:sp>
+      <p:pic>
+        <p:nvPicPr>
+          <p:cNvPr id="4" name="Picture 3" descr="06_hist_tiempo.png"/>
+          <p:cNvPicPr>
+            <a:picLocks noChangeAspect="1"/>
+          </p:cNvPicPr>
+          <p:nvPr/>
+        </p:nvPicPr>
+        <p:blipFill>
+          <a:blip r:embed="rId2"/>
+          <a:stretch>
+            <a:fillRect/>
+          </a:stretch>
+        </p:blipFill>
+        <p:spPr>
+          <a:xfrm>
+            <a:off x="1778310" y="1143000"/>
+            <a:ext cx="5587379" cy="3154680"/>
+          </a:xfrm>
+          <a:prstGeom prst="rect">
+            <a:avLst/>
+          </a:prstGeom>
+        </p:spPr>
+      </p:pic>
       <p:sp>
         <p:nvSpPr>
           <p:cNvPr id="5" name="TextBox 4"/>
@@ -6284,8 +6267,8 @@
         </p:nvSpPr>
         <p:spPr>
           <a:xfrm>
-            <a:off x="704088" y="3886200"/>
-            <a:ext cx="7744968" cy="1097280"/>
+            <a:off x="704088" y="4434840"/>
+            <a:ext cx="7744968" cy="457200"/>
           </a:xfrm>
           <a:prstGeom prst="rect">
             <a:avLst/>
@@ -6298,31 +6281,14 @@
           </a:bodyPr>
           <a:lstStyle/>
           <a:p>
-            <a:pPr>
-              <a:lnSpc>
-                <a:spcPct val="112000"/>
-              </a:lnSpc>
-              <a:spcAft>
-                <a:spcPts val="900"/>
-              </a:spcAft>
-            </a:pPr>
-            <a:r>
-              <a:rPr sz="1600" b="1">
-                <a:solidFill>
-                  <a:srgbClr val="E0A437"/>
-                </a:solidFill>
-                <a:latin typeface="Fira Sans"/>
-              </a:rPr>
-              <a:t>▸ </a:t>
-            </a:r>
-            <a:r>
-              <a:rPr sz="1600" b="0">
-                <a:solidFill>
-                  <a:srgbClr val="000000"/>
-                </a:solidFill>
-                <a:latin typeface="Fira Sans"/>
-              </a:rPr>
-              <a:t>La guía de instalación del repositorio (github.com/daniopitz/diplomado-cdd) detalla estos pasos por sistema operativo y los problemas frecuentes. Lo hacemos juntos ahora; debe quedar funcionando antes de la clase 2. Alternativa sin instalar nada: Google Colab, con los enlaces del repositorio.</a:t>
+            <a:r>
+              <a:rPr sz="1300" b="0">
+                <a:solidFill>
+                  <a:srgbClr val="333333"/>
+                </a:solidFill>
+                <a:latin typeface="Fira Sans"/>
+              </a:rPr>
+              <a:t>Este histograma sale de la tabla de viajes con unas seis líneas de código; el notebook de la clase las muestra completas.</a:t>
             </a:r>
           </a:p>
         </p:txBody>
@@ -6418,35 +6384,102 @@
                 </a:solidFill>
                 <a:latin typeface="Fira Sans"/>
               </a:rPr>
-              <a:t>Reparto modal de Santiago, EOD 2012</a:t>
-            </a:r>
-          </a:p>
-        </p:txBody>
-      </p:sp>
-      <p:pic>
-        <p:nvPicPr>
-          <p:cNvPr id="4" name="Picture 3" descr="01_reparto_modal.png"/>
-          <p:cNvPicPr>
-            <a:picLocks noChangeAspect="1"/>
-          </p:cNvPicPr>
-          <p:nvPr/>
-        </p:nvPicPr>
-        <p:blipFill>
-          <a:blip r:embed="rId2"/>
-          <a:stretch>
-            <a:fillRect/>
-          </a:stretch>
-        </p:blipFill>
-        <p:spPr>
-          <a:xfrm>
-            <a:off x="1604462" y="1143000"/>
-            <a:ext cx="5935075" cy="3154680"/>
-          </a:xfrm>
-          <a:prstGeom prst="rect">
-            <a:avLst/>
-          </a:prstGeom>
-        </p:spPr>
-      </p:pic>
+              <a:t>Puesta en marcha del entorno</a:t>
+            </a:r>
+          </a:p>
+        </p:txBody>
+      </p:sp>
+      <p:sp>
+        <p:nvSpPr>
+          <p:cNvPr id="4" name="Rectangle 3"/>
+          <p:cNvSpPr/>
+          <p:nvPr/>
+        </p:nvSpPr>
+        <p:spPr>
+          <a:xfrm>
+            <a:off x="704088" y="1280160"/>
+            <a:ext cx="7744968" cy="2377440"/>
+          </a:xfrm>
+          <a:prstGeom prst="rect">
+            <a:avLst/>
+          </a:prstGeom>
+          <a:solidFill>
+            <a:srgbClr val="F0F2F5"/>
+          </a:solidFill>
+          <a:ln>
+            <a:solidFill>
+              <a:srgbClr val="D8DDE3"/>
+            </a:solidFill>
+          </a:ln>
+          <a:effectLst/>
+        </p:spPr>
+        <p:style>
+          <a:lnRef idx="1">
+            <a:schemeClr val="accent1"/>
+          </a:lnRef>
+          <a:fillRef idx="3">
+            <a:schemeClr val="accent1"/>
+          </a:fillRef>
+          <a:effectRef idx="2">
+            <a:schemeClr val="accent1"/>
+          </a:effectRef>
+          <a:fontRef idx="minor">
+            <a:schemeClr val="lt1"/>
+          </a:fontRef>
+        </p:style>
+        <p:txBody>
+          <a:bodyPr rtlCol="0" anchor="ctr" wrap="square" lIns="228600" tIns="137160"/>
+          <a:lstStyle/>
+          <a:p>
+            <a:pPr/>
+            <a:r>
+              <a:rPr sz="1500" b="0">
+                <a:solidFill>
+                  <a:srgbClr val="1D3557"/>
+                </a:solidFill>
+                <a:latin typeface="Menlo"/>
+              </a:rPr>
+              <a:t>uv init --bare --python 3.12</a:t>
+            </a:r>
+          </a:p>
+          <a:p>
+            <a:pPr/>
+            <a:r>
+              <a:rPr sz="1500" b="0">
+                <a:solidFill>
+                  <a:srgbClr val="1D3557"/>
+                </a:solidFill>
+                <a:latin typeface="Menlo"/>
+              </a:rPr>
+              <a:t>uv add numpy pandas matplotlib seaborn scipy</a:t>
+            </a:r>
+          </a:p>
+          <a:p>
+            <a:pPr/>
+            <a:r>
+              <a:rPr sz="1500" b="0">
+                <a:solidFill>
+                  <a:srgbClr val="1D3557"/>
+                </a:solidFill>
+                <a:latin typeface="Menlo"/>
+              </a:rPr>
+              <a:t>uv add statsmodels scikit-learn jupyterlab</a:t>
+            </a:r>
+          </a:p>
+          <a:p>
+            <a:pPr/>
+            <a:r>
+              <a:rPr sz="1500" b="0">
+                <a:solidFill>
+                  <a:srgbClr val="1D3557"/>
+                </a:solidFill>
+                <a:latin typeface="Menlo"/>
+              </a:rPr>
+              <a:t>uv run jupyter lab</a:t>
+            </a:r>
+          </a:p>
+        </p:txBody>
+      </p:sp>
       <p:sp>
         <p:nvSpPr>
           <p:cNvPr id="5" name="TextBox 4"/>
@@ -6455,8 +6488,8 @@
         </p:nvSpPr>
         <p:spPr>
           <a:xfrm>
-            <a:off x="704088" y="4434840"/>
-            <a:ext cx="7744968" cy="457200"/>
+            <a:off x="704088" y="3886200"/>
+            <a:ext cx="7744968" cy="1097280"/>
           </a:xfrm>
           <a:prstGeom prst="rect">
             <a:avLst/>
@@ -6469,14 +6502,31 @@
           </a:bodyPr>
           <a:lstStyle/>
           <a:p>
-            <a:r>
-              <a:rPr sz="1300" b="0">
-                <a:solidFill>
-                  <a:srgbClr val="333333"/>
-                </a:solidFill>
-                <a:latin typeface="Fira Sans"/>
-              </a:rPr>
-              <a:t>Uno de cada tres viajes es a pie. Esta versión está ponderada por factores de expansión, así que habla de la ciudad; en el notebook calcularemos la versión muestral, y la diferencia entre ambas abre las clases 2 y 3.</a:t>
+            <a:pPr>
+              <a:lnSpc>
+                <a:spcPct val="112000"/>
+              </a:lnSpc>
+              <a:spcAft>
+                <a:spcPts val="900"/>
+              </a:spcAft>
+            </a:pPr>
+            <a:r>
+              <a:rPr sz="1600" b="1">
+                <a:solidFill>
+                  <a:srgbClr val="E0A437"/>
+                </a:solidFill>
+                <a:latin typeface="Fira Sans"/>
+              </a:rPr>
+              <a:t>▸ </a:t>
+            </a:r>
+            <a:r>
+              <a:rPr sz="1600" b="0">
+                <a:solidFill>
+                  <a:srgbClr val="000000"/>
+                </a:solidFill>
+                <a:latin typeface="Fira Sans"/>
+              </a:rPr>
+              <a:t>La guía de instalación del repositorio (github.com/daniopitz/diplomado-cdd) detalla estos pasos por sistema operativo y los problemas frecuentes. Lo hacemos juntos ahora; debe quedar funcionando antes de la clase 2. Alternativa sin instalar nada: Google Colab, con los enlaces del repositorio.</a:t>
             </a:r>
           </a:p>
         </p:txBody>
@@ -6572,21 +6622,45 @@
                 </a:solidFill>
                 <a:latin typeface="Fira Sans"/>
               </a:rPr>
-              <a:t>Síntesis</a:t>
-            </a:r>
-          </a:p>
-        </p:txBody>
-      </p:sp>
-      <p:sp>
-        <p:nvSpPr>
-          <p:cNvPr id="4" name="TextBox 3"/>
+              <a:t>Reparto modal de Santiago, EOD 2012</a:t>
+            </a:r>
+          </a:p>
+        </p:txBody>
+      </p:sp>
+      <p:pic>
+        <p:nvPicPr>
+          <p:cNvPr id="4" name="Picture 3" descr="01_reparto_modal.png"/>
+          <p:cNvPicPr>
+            <a:picLocks noChangeAspect="1"/>
+          </p:cNvPicPr>
+          <p:nvPr/>
+        </p:nvPicPr>
+        <p:blipFill>
+          <a:blip r:embed="rId2"/>
+          <a:stretch>
+            <a:fillRect/>
+          </a:stretch>
+        </p:blipFill>
+        <p:spPr>
+          <a:xfrm>
+            <a:off x="1604462" y="1143000"/>
+            <a:ext cx="5935075" cy="3154680"/>
+          </a:xfrm>
+          <a:prstGeom prst="rect">
+            <a:avLst/>
+          </a:prstGeom>
+        </p:spPr>
+      </p:pic>
+      <p:sp>
+        <p:nvSpPr>
+          <p:cNvPr id="5" name="TextBox 4"/>
           <p:cNvSpPr txBox="1"/>
           <p:nvPr/>
         </p:nvSpPr>
         <p:spPr>
           <a:xfrm>
-            <a:off x="704088" y="1353312"/>
-            <a:ext cx="7744968" cy="3300984"/>
+            <a:off x="704088" y="4434840"/>
+            <a:ext cx="7744968" cy="457200"/>
           </a:xfrm>
           <a:prstGeom prst="rect">
             <a:avLst/>
@@ -6599,143 +6673,14 @@
           </a:bodyPr>
           <a:lstStyle/>
           <a:p>
-            <a:pPr>
-              <a:lnSpc>
-                <a:spcPct val="112000"/>
-              </a:lnSpc>
-              <a:spcAft>
-                <a:spcPts val="900"/>
-              </a:spcAft>
-            </a:pPr>
-            <a:r>
-              <a:rPr sz="1800" b="1">
-                <a:solidFill>
-                  <a:srgbClr val="E0A437"/>
-                </a:solidFill>
-                <a:latin typeface="Fira Sans"/>
-              </a:rPr>
-              <a:t>▸ </a:t>
-            </a:r>
-            <a:r>
-              <a:rPr sz="1800" b="1">
-                <a:solidFill>
-                  <a:srgbClr val="1D3557"/>
-                </a:solidFill>
-                <a:latin typeface="Fira Sans"/>
-              </a:rPr>
-              <a:t>El tipo de cada variable determina qué resúmenes, gráficos y análisis son válidos.</a:t>
-            </a:r>
-          </a:p>
-          <a:p>
-            <a:pPr>
-              <a:lnSpc>
-                <a:spcPct val="112000"/>
-              </a:lnSpc>
-              <a:spcAft>
-                <a:spcPts val="900"/>
-              </a:spcAft>
-            </a:pPr>
-            <a:r>
-              <a:rPr sz="1800" b="1">
-                <a:solidFill>
-                  <a:srgbClr val="E0A437"/>
-                </a:solidFill>
-                <a:latin typeface="Fira Sans"/>
-              </a:rPr>
-              <a:t>▸ </a:t>
-            </a:r>
-            <a:r>
-              <a:rPr sz="1800" b="0">
-                <a:solidFill>
-                  <a:srgbClr val="000000"/>
-                </a:solidFill>
-                <a:latin typeface="Fira Sans"/>
-              </a:rPr>
-              <a:t>Ciencia de datos: extracción generalizable de conocimiento a partir de los datos (Dhar, 2013); combina estadística, computación y dominio.</a:t>
-            </a:r>
-          </a:p>
-          <a:p>
-            <a:pPr>
-              <a:lnSpc>
-                <a:spcPct val="112000"/>
-              </a:lnSpc>
-              <a:spcAft>
-                <a:spcPts val="900"/>
-              </a:spcAft>
-            </a:pPr>
-            <a:r>
-              <a:rPr sz="1800" b="1">
-                <a:solidFill>
-                  <a:srgbClr val="E0A437"/>
-                </a:solidFill>
-                <a:latin typeface="Fira Sans"/>
-              </a:rPr>
-              <a:t>▸ </a:t>
-            </a:r>
-            <a:r>
-              <a:rPr sz="1800" b="0">
-                <a:solidFill>
-                  <a:srgbClr val="000000"/>
-                </a:solidFill>
-                <a:latin typeface="Fira Sans"/>
-              </a:rPr>
-              <a:t>El ciclo de vida tiene dos entradas (una necesidad del dominio o datos disponibles) y se recorre de forma iterativa.</a:t>
-            </a:r>
-          </a:p>
-          <a:p>
-            <a:pPr>
-              <a:lnSpc>
-                <a:spcPct val="112000"/>
-              </a:lnSpc>
-              <a:spcAft>
-                <a:spcPts val="900"/>
-              </a:spcAft>
-            </a:pPr>
-            <a:r>
-              <a:rPr sz="1800" b="1">
-                <a:solidFill>
-                  <a:srgbClr val="E0A437"/>
-                </a:solidFill>
-                <a:latin typeface="Fira Sans"/>
-              </a:rPr>
-              <a:t>▸ </a:t>
-            </a:r>
-            <a:r>
-              <a:rPr sz="1800" b="0">
-                <a:solidFill>
-                  <a:srgbClr val="000000"/>
-                </a:solidFill>
-                <a:latin typeface="Fira Sans"/>
-              </a:rPr>
-              <a:t>La preparación de datos consume cerca de la mitad del tiempo de un proyecto (Anaconda, 2020).</a:t>
-            </a:r>
-          </a:p>
-          <a:p>
-            <a:pPr>
-              <a:lnSpc>
-                <a:spcPct val="112000"/>
-              </a:lnSpc>
-              <a:spcAft>
-                <a:spcPts val="900"/>
-              </a:spcAft>
-            </a:pPr>
-            <a:r>
-              <a:rPr sz="1800" b="1">
-                <a:solidFill>
-                  <a:srgbClr val="E0A437"/>
-                </a:solidFill>
-                <a:latin typeface="Fira Sans"/>
-              </a:rPr>
-              <a:t>▸ </a:t>
-            </a:r>
-            <a:r>
-              <a:rPr sz="1800" b="0">
-                <a:solidFill>
-                  <a:srgbClr val="000000"/>
-                </a:solidFill>
-                <a:latin typeface="Fira Sans"/>
-              </a:rPr>
-              <a:t>Próxima clase (jueves 27): estadística descriptiva, con el entorno ya funcionando.</a:t>
+            <a:r>
+              <a:rPr sz="1300" b="0">
+                <a:solidFill>
+                  <a:srgbClr val="333333"/>
+                </a:solidFill>
+                <a:latin typeface="Fira Sans"/>
+              </a:rPr>
+              <a:t>Uno de cada tres viajes es a pie. Esta versión está ponderada por factores de expansión, así que habla de la ciudad; en el notebook calcularemos la versión muestral, y la diferencia entre ambas abre las clases 2 y 3.</a:t>
             </a:r>
           </a:p>
         </p:txBody>
@@ -6831,6 +6776,265 @@
                 </a:solidFill>
                 <a:latin typeface="Fira Sans"/>
               </a:rPr>
+              <a:t>Síntesis</a:t>
+            </a:r>
+          </a:p>
+        </p:txBody>
+      </p:sp>
+      <p:sp>
+        <p:nvSpPr>
+          <p:cNvPr id="4" name="TextBox 3"/>
+          <p:cNvSpPr txBox="1"/>
+          <p:nvPr/>
+        </p:nvSpPr>
+        <p:spPr>
+          <a:xfrm>
+            <a:off x="704088" y="1353312"/>
+            <a:ext cx="7744968" cy="3300984"/>
+          </a:xfrm>
+          <a:prstGeom prst="rect">
+            <a:avLst/>
+          </a:prstGeom>
+          <a:noFill/>
+        </p:spPr>
+        <p:txBody>
+          <a:bodyPr wrap="square">
+            <a:spAutoFit/>
+          </a:bodyPr>
+          <a:lstStyle/>
+          <a:p>
+            <a:pPr>
+              <a:lnSpc>
+                <a:spcPct val="112000"/>
+              </a:lnSpc>
+              <a:spcAft>
+                <a:spcPts val="900"/>
+              </a:spcAft>
+            </a:pPr>
+            <a:r>
+              <a:rPr sz="1800" b="1">
+                <a:solidFill>
+                  <a:srgbClr val="E0A437"/>
+                </a:solidFill>
+                <a:latin typeface="Fira Sans"/>
+              </a:rPr>
+              <a:t>▸ </a:t>
+            </a:r>
+            <a:r>
+              <a:rPr sz="1800" b="1">
+                <a:solidFill>
+                  <a:srgbClr val="1D3557"/>
+                </a:solidFill>
+                <a:latin typeface="Fira Sans"/>
+              </a:rPr>
+              <a:t>El tipo de cada variable determina qué resúmenes, gráficos y análisis son válidos.</a:t>
+            </a:r>
+          </a:p>
+          <a:p>
+            <a:pPr>
+              <a:lnSpc>
+                <a:spcPct val="112000"/>
+              </a:lnSpc>
+              <a:spcAft>
+                <a:spcPts val="900"/>
+              </a:spcAft>
+            </a:pPr>
+            <a:r>
+              <a:rPr sz="1800" b="1">
+                <a:solidFill>
+                  <a:srgbClr val="E0A437"/>
+                </a:solidFill>
+                <a:latin typeface="Fira Sans"/>
+              </a:rPr>
+              <a:t>▸ </a:t>
+            </a:r>
+            <a:r>
+              <a:rPr sz="1800" b="0">
+                <a:solidFill>
+                  <a:srgbClr val="000000"/>
+                </a:solidFill>
+                <a:latin typeface="Fira Sans"/>
+              </a:rPr>
+              <a:t>Ciencia de datos: extracción generalizable de conocimiento a partir de los datos (Dhar, 2013); combina estadística, computación y dominio.</a:t>
+            </a:r>
+          </a:p>
+          <a:p>
+            <a:pPr>
+              <a:lnSpc>
+                <a:spcPct val="112000"/>
+              </a:lnSpc>
+              <a:spcAft>
+                <a:spcPts val="900"/>
+              </a:spcAft>
+            </a:pPr>
+            <a:r>
+              <a:rPr sz="1800" b="1">
+                <a:solidFill>
+                  <a:srgbClr val="E0A437"/>
+                </a:solidFill>
+                <a:latin typeface="Fira Sans"/>
+              </a:rPr>
+              <a:t>▸ </a:t>
+            </a:r>
+            <a:r>
+              <a:rPr sz="1800" b="0">
+                <a:solidFill>
+                  <a:srgbClr val="000000"/>
+                </a:solidFill>
+                <a:latin typeface="Fira Sans"/>
+              </a:rPr>
+              <a:t>El ciclo de vida tiene dos entradas (una necesidad del dominio o datos disponibles) y se recorre de forma iterativa.</a:t>
+            </a:r>
+          </a:p>
+          <a:p>
+            <a:pPr>
+              <a:lnSpc>
+                <a:spcPct val="112000"/>
+              </a:lnSpc>
+              <a:spcAft>
+                <a:spcPts val="900"/>
+              </a:spcAft>
+            </a:pPr>
+            <a:r>
+              <a:rPr sz="1800" b="1">
+                <a:solidFill>
+                  <a:srgbClr val="E0A437"/>
+                </a:solidFill>
+                <a:latin typeface="Fira Sans"/>
+              </a:rPr>
+              <a:t>▸ </a:t>
+            </a:r>
+            <a:r>
+              <a:rPr sz="1800" b="0">
+                <a:solidFill>
+                  <a:srgbClr val="000000"/>
+                </a:solidFill>
+                <a:latin typeface="Fira Sans"/>
+              </a:rPr>
+              <a:t>La preparación de datos consume cerca de la mitad del tiempo de un proyecto (Anaconda, 2020).</a:t>
+            </a:r>
+          </a:p>
+          <a:p>
+            <a:pPr>
+              <a:lnSpc>
+                <a:spcPct val="112000"/>
+              </a:lnSpc>
+              <a:spcAft>
+                <a:spcPts val="900"/>
+              </a:spcAft>
+            </a:pPr>
+            <a:r>
+              <a:rPr sz="1800" b="1">
+                <a:solidFill>
+                  <a:srgbClr val="E0A437"/>
+                </a:solidFill>
+                <a:latin typeface="Fira Sans"/>
+              </a:rPr>
+              <a:t>▸ </a:t>
+            </a:r>
+            <a:r>
+              <a:rPr sz="1800" b="0">
+                <a:solidFill>
+                  <a:srgbClr val="000000"/>
+                </a:solidFill>
+                <a:latin typeface="Fira Sans"/>
+              </a:rPr>
+              <a:t>Próxima clase (jueves 27): estadística descriptiva, con el entorno ya funcionando.</a:t>
+            </a:r>
+          </a:p>
+        </p:txBody>
+      </p:sp>
+    </p:spTree>
+  </p:cSld>
+  <p:clrMapOvr>
+    <a:masterClrMapping/>
+  </p:clrMapOvr>
+</p:sld>
+</file>
+
+<file path=ppt/slides/slide27.xml><?xml version="1.0" encoding="utf-8"?>
+<p:sld xmlns:a="http://schemas.openxmlformats.org/drawingml/2006/main" xmlns:p="http://schemas.openxmlformats.org/presentationml/2006/main" xmlns:r="http://schemas.openxmlformats.org/officeDocument/2006/relationships">
+  <p:cSld>
+    <p:spTree>
+      <p:nvGrpSpPr>
+        <p:cNvPr id="1" name=""/>
+        <p:cNvGrpSpPr/>
+        <p:nvPr/>
+      </p:nvGrpSpPr>
+      <p:grpSpPr/>
+      <p:sp>
+        <p:nvSpPr>
+          <p:cNvPr id="2" name="Rectangle 1"/>
+          <p:cNvSpPr/>
+          <p:nvPr/>
+        </p:nvSpPr>
+        <p:spPr>
+          <a:xfrm>
+            <a:off x="0" y="0"/>
+            <a:ext cx="9144000" cy="5138928"/>
+          </a:xfrm>
+          <a:prstGeom prst="rect">
+            <a:avLst/>
+          </a:prstGeom>
+          <a:solidFill>
+            <a:srgbClr val="FAFBFC"/>
+          </a:solidFill>
+          <a:ln>
+            <a:noFill/>
+          </a:ln>
+          <a:effectLst/>
+        </p:spPr>
+        <p:style>
+          <a:lnRef idx="1">
+            <a:schemeClr val="accent1"/>
+          </a:lnRef>
+          <a:fillRef idx="3">
+            <a:schemeClr val="accent1"/>
+          </a:fillRef>
+          <a:effectRef idx="2">
+            <a:schemeClr val="accent1"/>
+          </a:effectRef>
+          <a:fontRef idx="minor">
+            <a:schemeClr val="lt1"/>
+          </a:fontRef>
+        </p:style>
+        <p:txBody>
+          <a:bodyPr rtlCol="0" anchor="ctr"/>
+          <a:lstStyle/>
+          <a:p>
+            <a:pPr algn="ctr"/>
+          </a:p>
+        </p:txBody>
+      </p:sp>
+      <p:sp>
+        <p:nvSpPr>
+          <p:cNvPr id="3" name="TextBox 2"/>
+          <p:cNvSpPr txBox="1"/>
+          <p:nvPr/>
+        </p:nvSpPr>
+        <p:spPr>
+          <a:xfrm>
+            <a:off x="402336" y="301752"/>
+            <a:ext cx="8348472" cy="795528"/>
+          </a:xfrm>
+          <a:prstGeom prst="rect">
+            <a:avLst/>
+          </a:prstGeom>
+          <a:noFill/>
+        </p:spPr>
+        <p:txBody>
+          <a:bodyPr wrap="square">
+            <a:spAutoFit/>
+          </a:bodyPr>
+          <a:lstStyle/>
+          <a:p>
+            <a:r>
+              <a:rPr sz="2800" b="1">
+                <a:solidFill>
+                  <a:srgbClr val="0F0F0F"/>
+                </a:solidFill>
+                <a:latin typeface="Fira Sans"/>
+              </a:rPr>
               <a:t>Referencias</a:t>
             </a:r>
           </a:p>
@@ -7952,7 +8156,7 @@
                 </a:solidFill>
                 <a:latin typeface="Fira Sans"/>
               </a:rPr>
-              <a:t>Tres advertencias sobre el ciclo</a:t>
+              <a:t>Los datos disponibles condicionan la pregunta</a:t>
             </a:r>
           </a:p>
         </p:txBody>
@@ -8003,7 +8207,7 @@
                 </a:solidFill>
                 <a:latin typeface="Fira Sans"/>
               </a:rPr>
-              <a:t>Cargar y limpiar datos consume en promedio el 45% del tiempo de trabajo, más que el modelamiento (Anaconda, 2020; encuesta a 2.360 profesionales).</a:t>
+              <a:t>Muchos proyectos parten al revés: primero están los datos (registros administrativos, transacciones, sensores) y de ellos surge la pregunta; lo disponible acota qué se puede responder.</a:t>
             </a:r>
           </a:p>
           <a:p>
@@ -8025,13 +8229,13 @@
               <a:t>▸ </a:t>
             </a:r>
             <a:r>
-              <a:rPr sz="1800" b="0">
-                <a:solidFill>
-                  <a:srgbClr val="000000"/>
-                </a:solidFill>
-                <a:latin typeface="Fira Sans"/>
-              </a:rPr>
-              <a:t>El ciclo se recorre varias veces: un hallazgo cambia la pregunta y una limpieza revela problemas nuevos.</a:t>
+              <a:rPr sz="1800" b="1">
+                <a:solidFill>
+                  <a:srgbClr val="1D3557"/>
+                </a:solidFill>
+                <a:latin typeface="Fira Sans"/>
+              </a:rPr>
+              <a:t>Es frecuente responder preguntas con datos que no fueron recolectados para responderlas.</a:t>
             </a:r>
           </a:p>
           <a:p>
@@ -8059,7 +8263,35 @@
                 </a:solidFill>
                 <a:latin typeface="Fira Sans"/>
               </a:rPr>
-              <a:t>Un error en la formulación del problema invalida las etapas posteriores; conviene revisarla antes de invertir en el resto.</a:t>
+              <a:t>Por eso el ciclo dedica tanto trabajo a limpieza, exploración y validación: los datos rara vez vienen hechos a la medida de la pregunta.</a:t>
+            </a:r>
+          </a:p>
+          <a:p>
+            <a:pPr>
+              <a:lnSpc>
+                <a:spcPct val="112000"/>
+              </a:lnSpc>
+              <a:spcAft>
+                <a:spcPts val="900"/>
+              </a:spcAft>
+            </a:pPr>
+            <a:r>
+              <a:rPr sz="1800" b="1">
+                <a:solidFill>
+                  <a:srgbClr val="E0A437"/>
+                </a:solidFill>
+                <a:latin typeface="Fira Sans"/>
+              </a:rPr>
+              <a:t>▸ </a:t>
+            </a:r>
+            <a:r>
+              <a:rPr sz="1800" b="0">
+                <a:solidFill>
+                  <a:srgbClr val="000000"/>
+                </a:solidFill>
+                <a:latin typeface="Fira Sans"/>
+              </a:rPr>
+              <a:t>Ejemplo: la encuesta de viajes de hoy se diseñó para planificar el transporte de Santiago; se ha usado también para estudiar acceso a servicios y desigualdad urbana.</a:t>
             </a:r>
           </a:p>
         </p:txBody>

</xml_diff>

<commit_message>
Slide de datos y pregunta como diagrama; ejemplo corregido: telefonía móvil como datos reutilizados, EOD como caso ideal
Co-Authored-By: Claude Fable 5 <noreply@anthropic.com>
</commit_message>
<xml_diff>
--- a/presentaciones/clase01_fundamentos_ecosistema.pptx
+++ b/presentaciones/clase01_fundamentos_ecosistema.pptx
@@ -8161,16 +8161,40 @@
           </a:p>
         </p:txBody>
       </p:sp>
-      <p:sp>
-        <p:nvSpPr>
-          <p:cNvPr id="4" name="TextBox 3"/>
+      <p:pic>
+        <p:nvPicPr>
+          <p:cNvPr id="4" name="Picture 3" descr="10_datos_pregunta.png"/>
+          <p:cNvPicPr>
+            <a:picLocks noChangeAspect="1"/>
+          </p:cNvPicPr>
+          <p:nvPr/>
+        </p:nvPicPr>
+        <p:blipFill>
+          <a:blip r:embed="rId2"/>
+          <a:stretch>
+            <a:fillRect/>
+          </a:stretch>
+        </p:blipFill>
+        <p:spPr>
+          <a:xfrm>
+            <a:off x="1417319" y="1143000"/>
+            <a:ext cx="6309360" cy="2409988"/>
+          </a:xfrm>
+          <a:prstGeom prst="rect">
+            <a:avLst/>
+          </a:prstGeom>
+        </p:spPr>
+      </p:pic>
+      <p:sp>
+        <p:nvSpPr>
+          <p:cNvPr id="5" name="TextBox 4"/>
           <p:cNvSpPr txBox="1"/>
           <p:nvPr/>
         </p:nvSpPr>
         <p:spPr>
           <a:xfrm>
-            <a:off x="704088" y="1353312"/>
-            <a:ext cx="7744968" cy="3300984"/>
+            <a:off x="704088" y="4434840"/>
+            <a:ext cx="7744968" cy="457200"/>
           </a:xfrm>
           <a:prstGeom prst="rect">
             <a:avLst/>
@@ -8183,115 +8207,14 @@
           </a:bodyPr>
           <a:lstStyle/>
           <a:p>
-            <a:pPr>
-              <a:lnSpc>
-                <a:spcPct val="112000"/>
-              </a:lnSpc>
-              <a:spcAft>
-                <a:spcPts val="900"/>
-              </a:spcAft>
-            </a:pPr>
-            <a:r>
-              <a:rPr sz="1800" b="1">
-                <a:solidFill>
-                  <a:srgbClr val="E0A437"/>
-                </a:solidFill>
-                <a:latin typeface="Fira Sans"/>
-              </a:rPr>
-              <a:t>▸ </a:t>
-            </a:r>
-            <a:r>
-              <a:rPr sz="1800" b="0">
-                <a:solidFill>
-                  <a:srgbClr val="000000"/>
-                </a:solidFill>
-                <a:latin typeface="Fira Sans"/>
-              </a:rPr>
-              <a:t>Muchos proyectos parten al revés: primero están los datos (registros administrativos, transacciones, sensores) y de ellos surge la pregunta; lo disponible acota qué se puede responder.</a:t>
-            </a:r>
-          </a:p>
-          <a:p>
-            <a:pPr>
-              <a:lnSpc>
-                <a:spcPct val="112000"/>
-              </a:lnSpc>
-              <a:spcAft>
-                <a:spcPts val="900"/>
-              </a:spcAft>
-            </a:pPr>
-            <a:r>
-              <a:rPr sz="1800" b="1">
-                <a:solidFill>
-                  <a:srgbClr val="E0A437"/>
-                </a:solidFill>
-                <a:latin typeface="Fira Sans"/>
-              </a:rPr>
-              <a:t>▸ </a:t>
-            </a:r>
-            <a:r>
-              <a:rPr sz="1800" b="1">
-                <a:solidFill>
-                  <a:srgbClr val="1D3557"/>
-                </a:solidFill>
-                <a:latin typeface="Fira Sans"/>
-              </a:rPr>
-              <a:t>Es frecuente responder preguntas con datos que no fueron recolectados para responderlas.</a:t>
-            </a:r>
-          </a:p>
-          <a:p>
-            <a:pPr>
-              <a:lnSpc>
-                <a:spcPct val="112000"/>
-              </a:lnSpc>
-              <a:spcAft>
-                <a:spcPts val="900"/>
-              </a:spcAft>
-            </a:pPr>
-            <a:r>
-              <a:rPr sz="1800" b="1">
-                <a:solidFill>
-                  <a:srgbClr val="E0A437"/>
-                </a:solidFill>
-                <a:latin typeface="Fira Sans"/>
-              </a:rPr>
-              <a:t>▸ </a:t>
-            </a:r>
-            <a:r>
-              <a:rPr sz="1800" b="0">
-                <a:solidFill>
-                  <a:srgbClr val="000000"/>
-                </a:solidFill>
-                <a:latin typeface="Fira Sans"/>
-              </a:rPr>
-              <a:t>Por eso el ciclo dedica tanto trabajo a limpieza, exploración y validación: los datos rara vez vienen hechos a la medida de la pregunta.</a:t>
-            </a:r>
-          </a:p>
-          <a:p>
-            <a:pPr>
-              <a:lnSpc>
-                <a:spcPct val="112000"/>
-              </a:lnSpc>
-              <a:spcAft>
-                <a:spcPts val="900"/>
-              </a:spcAft>
-            </a:pPr>
-            <a:r>
-              <a:rPr sz="1800" b="1">
-                <a:solidFill>
-                  <a:srgbClr val="E0A437"/>
-                </a:solidFill>
-                <a:latin typeface="Fira Sans"/>
-              </a:rPr>
-              <a:t>▸ </a:t>
-            </a:r>
-            <a:r>
-              <a:rPr sz="1800" b="0">
-                <a:solidFill>
-                  <a:srgbClr val="000000"/>
-                </a:solidFill>
-                <a:latin typeface="Fira Sans"/>
-              </a:rPr>
-              <a:t>Ejemplo: la encuesta de viajes de hoy se diseñó para planificar el transporte de Santiago; se ha usado también para estudiar acceso a servicios y desigualdad urbana.</a:t>
+            <a:r>
+              <a:rPr sz="1300" b="0">
+                <a:solidFill>
+                  <a:srgbClr val="333333"/>
+                </a:solidFill>
+                <a:latin typeface="Fira Sans"/>
+              </a:rPr>
+              <a:t>La encuesta de viajes de hoy es el caso ideal: se diseñó para estudiar la movilidad. El caso frecuente: los registros de telefonía móvil, generados para operar la red, se usan para estimar matrices de viaje y planificar transporte. Por eso el ciclo dedica tanto trabajo a limpieza y validación.</a:t>
             </a:r>
           </a:p>
         </p:txBody>

</xml_diff>

<commit_message>
Fuera la slide de códigos numéricos; el notebook cubre esa idea en vivo
Co-Authored-By: Claude Fable 5 <noreply@anthropic.com>
</commit_message>
<xml_diff>
--- a/presentaciones/clase01_fundamentos_ecosistema.pptx
+++ b/presentaciones/clase01_fundamentos_ecosistema.pptx
@@ -31,7 +31,6 @@
     <p:sldId id="279" r:id="rId30"/>
     <p:sldId id="280" r:id="rId31"/>
     <p:sldId id="281" r:id="rId32"/>
-    <p:sldId id="282" r:id="rId33"/>
   </p:sldIdLst>
   <p:sldSz cx="9144000" cy="5138928" type="screen4x3"/>
   <p:notesSz cx="6858000" cy="9144000"/>
@@ -4494,7 +4493,7 @@
             <a:avLst/>
           </a:prstGeom>
           <a:solidFill>
-            <a:srgbClr val="FAFBFC"/>
+            <a:srgbClr val="1D3557"/>
           </a:solidFill>
           <a:ln>
             <a:noFill/>
@@ -4531,8 +4530,8 @@
         </p:nvSpPr>
         <p:spPr>
           <a:xfrm>
-            <a:off x="402336" y="301752"/>
-            <a:ext cx="8348472" cy="795528"/>
+            <a:off x="603504" y="1847088"/>
+            <a:ext cx="7946136" cy="1399032"/>
           </a:xfrm>
           <a:prstGeom prst="rect">
             <a:avLst/>
@@ -4546,148 +4545,24 @@
           <a:lstStyle/>
           <a:p>
             <a:r>
-              <a:rPr sz="2800" b="1">
-                <a:solidFill>
-                  <a:srgbClr val="0F0F0F"/>
-                </a:solidFill>
-                <a:latin typeface="Fira Sans"/>
-              </a:rPr>
-              <a:t>Códigos numéricos: variables nominales</a:t>
-            </a:r>
-          </a:p>
-        </p:txBody>
-      </p:sp>
-      <p:sp>
-        <p:nvSpPr>
-          <p:cNvPr id="4" name="TextBox 3"/>
-          <p:cNvSpPr txBox="1"/>
-          <p:nvPr/>
-        </p:nvSpPr>
-        <p:spPr>
-          <a:xfrm>
-            <a:off x="704088" y="1353312"/>
-            <a:ext cx="7744968" cy="3300984"/>
-          </a:xfrm>
-          <a:prstGeom prst="rect">
-            <a:avLst/>
-          </a:prstGeom>
-          <a:noFill/>
-        </p:spPr>
-        <p:txBody>
-          <a:bodyPr wrap="square">
-            <a:spAutoFit/>
-          </a:bodyPr>
-          <a:lstStyle/>
-          <a:p>
-            <a:pPr>
-              <a:lnSpc>
-                <a:spcPct val="112000"/>
-              </a:lnSpc>
-              <a:spcAft>
-                <a:spcPts val="900"/>
-              </a:spcAft>
-            </a:pPr>
-            <a:r>
-              <a:rPr sz="1800" b="1">
+              <a:rPr sz="3400" b="1">
+                <a:solidFill>
+                  <a:srgbClr val="FFFFFF"/>
+                </a:solidFill>
+                <a:latin typeface="Fira Sans"/>
+              </a:rPr>
+              <a:t>Recreo</a:t>
+            </a:r>
+          </a:p>
+          <a:p>
+            <a:r>
+              <a:rPr sz="1800" b="0">
                 <a:solidFill>
                   <a:srgbClr val="E0A437"/>
                 </a:solidFill>
                 <a:latin typeface="Fira Sans"/>
               </a:rPr>
-              <a:t>▸ </a:t>
-            </a:r>
-            <a:r>
-              <a:rPr sz="1800" b="0">
-                <a:solidFill>
-                  <a:srgbClr val="000000"/>
-                </a:solidFill>
-                <a:latin typeface="Fira Sans"/>
-              </a:rPr>
-              <a:t>En la encuesta de viajes que exploraremos hoy en el notebook, la columna ComunaOrigen vale 94, 71, 13... pero es una variable nominal: los números son códigos de comuna.</a:t>
-            </a:r>
-          </a:p>
-          <a:p>
-            <a:pPr>
-              <a:lnSpc>
-                <a:spcPct val="112000"/>
-              </a:lnSpc>
-              <a:spcAft>
-                <a:spcPts val="900"/>
-              </a:spcAft>
-            </a:pPr>
-            <a:r>
-              <a:rPr sz="1800" b="1">
-                <a:solidFill>
-                  <a:srgbClr val="E0A437"/>
-                </a:solidFill>
-                <a:latin typeface="Fira Sans"/>
-              </a:rPr>
-              <a:t>▸ </a:t>
-            </a:r>
-            <a:r>
-              <a:rPr sz="1800" b="0">
-                <a:solidFill>
-                  <a:srgbClr val="000000"/>
-                </a:solidFill>
-                <a:latin typeface="Fira Sans"/>
-              </a:rPr>
-              <a:t>Promediar códigos de comuna no significa nada; contar viajes por comuna, sí.</a:t>
-            </a:r>
-          </a:p>
-          <a:p>
-            <a:pPr>
-              <a:lnSpc>
-                <a:spcPct val="112000"/>
-              </a:lnSpc>
-              <a:spcAft>
-                <a:spcPts val="900"/>
-              </a:spcAft>
-            </a:pPr>
-            <a:r>
-              <a:rPr sz="1800" b="1">
-                <a:solidFill>
-                  <a:srgbClr val="E0A437"/>
-                </a:solidFill>
-                <a:latin typeface="Fira Sans"/>
-              </a:rPr>
-              <a:t>▸ </a:t>
-            </a:r>
-            <a:r>
-              <a:rPr sz="1800" b="1">
-                <a:solidFill>
-                  <a:srgbClr val="1D3557"/>
-                </a:solidFill>
-                <a:latin typeface="Fira Sans"/>
-              </a:rPr>
-              <a:t>El tipo de la variable define qué resumen y qué gráfico son válidos: es lo primero que se revisa al abrir una tabla.</a:t>
-            </a:r>
-          </a:p>
-          <a:p>
-            <a:pPr>
-              <a:lnSpc>
-                <a:spcPct val="112000"/>
-              </a:lnSpc>
-              <a:spcAft>
-                <a:spcPts val="900"/>
-              </a:spcAft>
-            </a:pPr>
-            <a:r>
-              <a:rPr sz="1800" b="1">
-                <a:solidFill>
-                  <a:srgbClr val="E0A437"/>
-                </a:solidFill>
-                <a:latin typeface="Fira Sans"/>
-              </a:rPr>
-              <a:t>▸ </a:t>
-            </a:r>
-            <a:r>
-              <a:rPr sz="1800" b="0">
-                <a:solidFill>
-                  <a:srgbClr val="000000"/>
-                </a:solidFill>
-                <a:latin typeface="Fira Sans"/>
-              </a:rPr>
-              <a:t>En la clase 2 esto se vuelve operativo: cada resumen de la estadística descriptiva aplica a ciertos tipos de variables.</a:t>
+              <a:t>10 minutos</a:t>
             </a:r>
           </a:p>
         </p:txBody>
@@ -4783,7 +4658,7 @@
                 </a:solidFill>
                 <a:latin typeface="Fira Sans"/>
               </a:rPr>
-              <a:t>Recreo</a:t>
+              <a:t>El ecosistema Python</a:t>
             </a:r>
           </a:p>
           <a:p>
@@ -4794,7 +4669,7 @@
                 </a:solidFill>
                 <a:latin typeface="Fira Sans"/>
               </a:rPr>
-              <a:t>10 minutos</a:t>
+              <a:t>NumPy, Pandas y Matplotlib, más Jupyter y uv</a:t>
             </a:r>
           </a:p>
         </p:txBody>
@@ -4832,7 +4707,7 @@
             <a:avLst/>
           </a:prstGeom>
           <a:solidFill>
-            <a:srgbClr val="1D3557"/>
+            <a:srgbClr val="FAFBFC"/>
           </a:solidFill>
           <a:ln>
             <a:noFill/>
@@ -4869,8 +4744,8 @@
         </p:nvSpPr>
         <p:spPr>
           <a:xfrm>
-            <a:off x="603504" y="1847088"/>
-            <a:ext cx="7946136" cy="1399032"/>
+            <a:off x="402336" y="301752"/>
+            <a:ext cx="8348472" cy="795528"/>
           </a:xfrm>
           <a:prstGeom prst="rect">
             <a:avLst/>
@@ -4884,24 +4759,71 @@
           <a:lstStyle/>
           <a:p>
             <a:r>
-              <a:rPr sz="3400" b="1">
-                <a:solidFill>
-                  <a:srgbClr val="FFFFFF"/>
-                </a:solidFill>
-                <a:latin typeface="Fira Sans"/>
-              </a:rPr>
-              <a:t>El ecosistema Python</a:t>
-            </a:r>
-          </a:p>
-          <a:p>
-            <a:r>
-              <a:rPr sz="1800" b="0">
-                <a:solidFill>
-                  <a:srgbClr val="E0A437"/>
-                </a:solidFill>
-                <a:latin typeface="Fira Sans"/>
-              </a:rPr>
-              <a:t>NumPy, Pandas y Matplotlib, más Jupyter y uv</a:t>
+              <a:rPr sz="2800" b="1">
+                <a:solidFill>
+                  <a:srgbClr val="0F0F0F"/>
+                </a:solidFill>
+                <a:latin typeface="Fira Sans"/>
+              </a:rPr>
+              <a:t>Las herramientas del módulo</a:t>
+            </a:r>
+          </a:p>
+        </p:txBody>
+      </p:sp>
+      <p:pic>
+        <p:nvPicPr>
+          <p:cNvPr id="4" name="Picture 3" descr="05_ecosistema.png"/>
+          <p:cNvPicPr>
+            <a:picLocks noChangeAspect="1"/>
+          </p:cNvPicPr>
+          <p:nvPr/>
+        </p:nvPicPr>
+        <p:blipFill>
+          <a:blip r:embed="rId2"/>
+          <a:stretch>
+            <a:fillRect/>
+          </a:stretch>
+        </p:blipFill>
+        <p:spPr>
+          <a:xfrm>
+            <a:off x="1417319" y="1143000"/>
+            <a:ext cx="6309360" cy="2814584"/>
+          </a:xfrm>
+          <a:prstGeom prst="rect">
+            <a:avLst/>
+          </a:prstGeom>
+        </p:spPr>
+      </p:pic>
+      <p:sp>
+        <p:nvSpPr>
+          <p:cNvPr id="5" name="TextBox 4"/>
+          <p:cNvSpPr txBox="1"/>
+          <p:nvPr/>
+        </p:nvSpPr>
+        <p:spPr>
+          <a:xfrm>
+            <a:off x="704088" y="4434840"/>
+            <a:ext cx="7744968" cy="457200"/>
+          </a:xfrm>
+          <a:prstGeom prst="rect">
+            <a:avLst/>
+          </a:prstGeom>
+          <a:noFill/>
+        </p:spPr>
+        <p:txBody>
+          <a:bodyPr wrap="square">
+            <a:spAutoFit/>
+          </a:bodyPr>
+          <a:lstStyle/>
+          <a:p>
+            <a:r>
+              <a:rPr sz="1300" b="0">
+                <a:solidFill>
+                  <a:srgbClr val="333333"/>
+                </a:solidFill>
+                <a:latin typeface="Fira Sans"/>
+              </a:rPr>
+              <a:t>Python trae la sintaxis; NumPy, Pandas y Matplotlib traen el trabajo con datos. Jupyter y uv son el entorno donde todo corre.</a:t>
             </a:r>
           </a:p>
         </p:txBody>
@@ -4997,35 +4919,90 @@
                 </a:solidFill>
                 <a:latin typeface="Fira Sans"/>
               </a:rPr>
-              <a:t>Las herramientas del módulo</a:t>
-            </a:r>
-          </a:p>
-        </p:txBody>
-      </p:sp>
-      <p:pic>
-        <p:nvPicPr>
-          <p:cNvPr id="4" name="Picture 3" descr="05_ecosistema.png"/>
-          <p:cNvPicPr>
-            <a:picLocks noChangeAspect="1"/>
-          </p:cNvPicPr>
-          <p:nvPr/>
-        </p:nvPicPr>
-        <p:blipFill>
-          <a:blip r:embed="rId2"/>
-          <a:stretch>
-            <a:fillRect/>
-          </a:stretch>
-        </p:blipFill>
-        <p:spPr>
-          <a:xfrm>
-            <a:off x="1417319" y="1143000"/>
-            <a:ext cx="6309360" cy="2814584"/>
-          </a:xfrm>
-          <a:prstGeom prst="rect">
-            <a:avLst/>
-          </a:prstGeom>
-        </p:spPr>
-      </p:pic>
+              <a:t>NumPy: cálculo sobre arreglos completos</a:t>
+            </a:r>
+          </a:p>
+        </p:txBody>
+      </p:sp>
+      <p:sp>
+        <p:nvSpPr>
+          <p:cNvPr id="4" name="Rectangle 3"/>
+          <p:cNvSpPr/>
+          <p:nvPr/>
+        </p:nvSpPr>
+        <p:spPr>
+          <a:xfrm>
+            <a:off x="704088" y="1280160"/>
+            <a:ext cx="7744968" cy="1874520"/>
+          </a:xfrm>
+          <a:prstGeom prst="rect">
+            <a:avLst/>
+          </a:prstGeom>
+          <a:solidFill>
+            <a:srgbClr val="F0F2F5"/>
+          </a:solidFill>
+          <a:ln>
+            <a:solidFill>
+              <a:srgbClr val="D8DDE3"/>
+            </a:solidFill>
+          </a:ln>
+          <a:effectLst/>
+        </p:spPr>
+        <p:style>
+          <a:lnRef idx="1">
+            <a:schemeClr val="accent1"/>
+          </a:lnRef>
+          <a:fillRef idx="3">
+            <a:schemeClr val="accent1"/>
+          </a:fillRef>
+          <a:effectRef idx="2">
+            <a:schemeClr val="accent1"/>
+          </a:effectRef>
+          <a:fontRef idx="minor">
+            <a:schemeClr val="lt1"/>
+          </a:fontRef>
+        </p:style>
+        <p:txBody>
+          <a:bodyPr rtlCol="0" anchor="ctr" wrap="square" lIns="228600" tIns="137160"/>
+          <a:lstStyle/>
+          <a:p>
+            <a:pPr/>
+            <a:r>
+              <a:rPr sz="1500" b="0">
+                <a:solidFill>
+                  <a:srgbClr val="1D3557"/>
+                </a:solidFill>
+                <a:latin typeface="Menlo"/>
+              </a:rPr>
+              <a:t>import numpy as np</a:t>
+            </a:r>
+          </a:p>
+          <a:p>
+            <a:pPr/>
+            <a:r>
+              <a:rPr sz="1500" b="0">
+                <a:solidFill>
+                  <a:srgbClr val="1D3557"/>
+                </a:solidFill>
+                <a:latin typeface="Menlo"/>
+              </a:rPr>
+              <a:t>tiempos = np.array([70, 105, 90, 25, 40])</a:t>
+            </a:r>
+          </a:p>
+          <a:p>
+            <a:pPr/>
+            <a:r>
+              <a:rPr sz="1500" b="0">
+                <a:solidFill>
+                  <a:srgbClr val="1D3557"/>
+                </a:solidFill>
+                <a:latin typeface="Menlo"/>
+              </a:rPr>
+              <a:t>tiempos.mean()          # 66.0, sin escribir un ciclo</a:t>
+            </a:r>
+          </a:p>
+        </p:txBody>
+      </p:sp>
       <p:sp>
         <p:nvSpPr>
           <p:cNvPr id="5" name="TextBox 4"/>
@@ -5034,8 +5011,8 @@
         </p:nvSpPr>
         <p:spPr>
           <a:xfrm>
-            <a:off x="704088" y="4434840"/>
-            <a:ext cx="7744968" cy="457200"/>
+            <a:off x="704088" y="3383279"/>
+            <a:ext cx="7744968" cy="1097280"/>
           </a:xfrm>
           <a:prstGeom prst="rect">
             <a:avLst/>
@@ -5048,14 +5025,31 @@
           </a:bodyPr>
           <a:lstStyle/>
           <a:p>
-            <a:r>
-              <a:rPr sz="1300" b="0">
-                <a:solidFill>
-                  <a:srgbClr val="333333"/>
-                </a:solidFill>
-                <a:latin typeface="Fira Sans"/>
-              </a:rPr>
-              <a:t>Python trae la sintaxis; NumPy, Pandas y Matplotlib traen el trabajo con datos. Jupyter y uv son el entorno donde todo corre.</a:t>
+            <a:pPr>
+              <a:lnSpc>
+                <a:spcPct val="112000"/>
+              </a:lnSpc>
+              <a:spcAft>
+                <a:spcPts val="900"/>
+              </a:spcAft>
+            </a:pPr>
+            <a:r>
+              <a:rPr sz="1600" b="1">
+                <a:solidFill>
+                  <a:srgbClr val="E0A437"/>
+                </a:solidFill>
+                <a:latin typeface="Fira Sans"/>
+              </a:rPr>
+              <a:t>▸ </a:t>
+            </a:r>
+            <a:r>
+              <a:rPr sz="1600" b="0">
+                <a:solidFill>
+                  <a:srgbClr val="000000"/>
+                </a:solidFill>
+                <a:latin typeface="Fira Sans"/>
+              </a:rPr>
+              <a:t>La operación se aplica al arreglo completo (vectorización): menos código y mucho más rápido que iterar en Python puro. Es la base sobre la que se construye todo lo demás.</a:t>
             </a:r>
           </a:p>
         </p:txBody>
@@ -5151,7 +5145,7 @@
                 </a:solidFill>
                 <a:latin typeface="Fira Sans"/>
               </a:rPr>
-              <a:t>NumPy: cálculo sobre arreglos completos</a:t>
+              <a:t>Pandas: la tabla como objeto de trabajo</a:t>
             </a:r>
           </a:p>
         </p:txBody>
@@ -5206,7 +5200,7 @@
                 </a:solidFill>
                 <a:latin typeface="Menlo"/>
               </a:rPr>
-              <a:t>import numpy as np</a:t>
+              <a:t>import pandas as pd</a:t>
             </a:r>
           </a:p>
           <a:p>
@@ -5218,7 +5212,7 @@
                 </a:solidFill>
                 <a:latin typeface="Menlo"/>
               </a:rPr>
-              <a:t>tiempos = np.array([70, 105, 90, 25, 40])</a:t>
+              <a:t>viajes = pd.read_csv(URL_VIAJES, sep=";", decimal=",")</a:t>
             </a:r>
           </a:p>
           <a:p>
@@ -5230,7 +5224,7 @@
                 </a:solidFill>
                 <a:latin typeface="Menlo"/>
               </a:rPr>
-              <a:t>tiempos.mean()          # 66.0, sin escribir un ciclo</a:t>
+              <a:t>viajes.head()</a:t>
             </a:r>
           </a:p>
         </p:txBody>
@@ -5281,7 +5275,7 @@
                 </a:solidFill>
                 <a:latin typeface="Fira Sans"/>
               </a:rPr>
-              <a:t>La operación se aplica al arreglo completo (vectorización): menos código y mucho más rápido que iterar en Python puro. Es la base sobre la que se construye todo lo demás.</a:t>
+              <a:t>El DataFrame es una tabla con columnas etiquetadas, cada una de su propio tipo. Con esas tres líneas se abre la EOD completa: lo haremos en vivo en el notebook de hoy.</a:t>
             </a:r>
           </a:p>
         </p:txBody>
@@ -5636,90 +5630,35 @@
                 </a:solidFill>
                 <a:latin typeface="Fira Sans"/>
               </a:rPr>
-              <a:t>Pandas: la tabla como objeto de trabajo</a:t>
-            </a:r>
-          </a:p>
-        </p:txBody>
-      </p:sp>
-      <p:sp>
-        <p:nvSpPr>
-          <p:cNvPr id="4" name="Rectangle 3"/>
-          <p:cNvSpPr/>
-          <p:nvPr/>
-        </p:nvSpPr>
-        <p:spPr>
-          <a:xfrm>
-            <a:off x="704088" y="1280160"/>
-            <a:ext cx="7744968" cy="1874520"/>
-          </a:xfrm>
-          <a:prstGeom prst="rect">
-            <a:avLst/>
-          </a:prstGeom>
-          <a:solidFill>
-            <a:srgbClr val="F0F2F5"/>
-          </a:solidFill>
-          <a:ln>
-            <a:solidFill>
-              <a:srgbClr val="D8DDE3"/>
-            </a:solidFill>
-          </a:ln>
-          <a:effectLst/>
-        </p:spPr>
-        <p:style>
-          <a:lnRef idx="1">
-            <a:schemeClr val="accent1"/>
-          </a:lnRef>
-          <a:fillRef idx="3">
-            <a:schemeClr val="accent1"/>
-          </a:fillRef>
-          <a:effectRef idx="2">
-            <a:schemeClr val="accent1"/>
-          </a:effectRef>
-          <a:fontRef idx="minor">
-            <a:schemeClr val="lt1"/>
-          </a:fontRef>
-        </p:style>
-        <p:txBody>
-          <a:bodyPr rtlCol="0" anchor="ctr" wrap="square" lIns="228600" tIns="137160"/>
-          <a:lstStyle/>
-          <a:p>
-            <a:pPr/>
-            <a:r>
-              <a:rPr sz="1500" b="0">
-                <a:solidFill>
-                  <a:srgbClr val="1D3557"/>
-                </a:solidFill>
-                <a:latin typeface="Menlo"/>
-              </a:rPr>
-              <a:t>import pandas as pd</a:t>
-            </a:r>
-          </a:p>
-          <a:p>
-            <a:pPr/>
-            <a:r>
-              <a:rPr sz="1500" b="0">
-                <a:solidFill>
-                  <a:srgbClr val="1D3557"/>
-                </a:solidFill>
-                <a:latin typeface="Menlo"/>
-              </a:rPr>
-              <a:t>viajes = pd.read_csv(URL_VIAJES, sep=";", decimal=",")</a:t>
-            </a:r>
-          </a:p>
-          <a:p>
-            <a:pPr/>
-            <a:r>
-              <a:rPr sz="1500" b="0">
-                <a:solidFill>
-                  <a:srgbClr val="1D3557"/>
-                </a:solidFill>
-                <a:latin typeface="Menlo"/>
-              </a:rPr>
-              <a:t>viajes.head()</a:t>
-            </a:r>
-          </a:p>
-        </p:txBody>
-      </p:sp>
+              <a:t>La Encuesta Origen Destino de Santiago 2012</a:t>
+            </a:r>
+          </a:p>
+        </p:txBody>
+      </p:sp>
+      <p:pic>
+        <p:nvPicPr>
+          <p:cNvPr id="4" name="Picture 3" descr="02_df_viajes.png"/>
+          <p:cNvPicPr>
+            <a:picLocks noChangeAspect="1"/>
+          </p:cNvPicPr>
+          <p:nvPr/>
+        </p:nvPicPr>
+        <p:blipFill>
+          <a:blip r:embed="rId2"/>
+          <a:stretch>
+            <a:fillRect/>
+          </a:stretch>
+        </p:blipFill>
+        <p:spPr>
+          <a:xfrm>
+            <a:off x="1417319" y="1143000"/>
+            <a:ext cx="6309360" cy="2296353"/>
+          </a:xfrm>
+          <a:prstGeom prst="rect">
+            <a:avLst/>
+          </a:prstGeom>
+        </p:spPr>
+      </p:pic>
       <p:sp>
         <p:nvSpPr>
           <p:cNvPr id="5" name="TextBox 4"/>
@@ -5728,8 +5667,8 @@
         </p:nvSpPr>
         <p:spPr>
           <a:xfrm>
-            <a:off x="704088" y="3383279"/>
-            <a:ext cx="7744968" cy="1097280"/>
+            <a:off x="704088" y="4434840"/>
+            <a:ext cx="7744968" cy="457200"/>
           </a:xfrm>
           <a:prstGeom prst="rect">
             <a:avLst/>
@@ -5742,31 +5681,14 @@
           </a:bodyPr>
           <a:lstStyle/>
           <a:p>
-            <a:pPr>
-              <a:lnSpc>
-                <a:spcPct val="112000"/>
-              </a:lnSpc>
-              <a:spcAft>
-                <a:spcPts val="900"/>
-              </a:spcAft>
-            </a:pPr>
-            <a:r>
-              <a:rPr sz="1600" b="1">
-                <a:solidFill>
-                  <a:srgbClr val="E0A437"/>
-                </a:solidFill>
-                <a:latin typeface="Fira Sans"/>
-              </a:rPr>
-              <a:t>▸ </a:t>
-            </a:r>
-            <a:r>
-              <a:rPr sz="1600" b="0">
-                <a:solidFill>
-                  <a:srgbClr val="000000"/>
-                </a:solidFill>
-                <a:latin typeface="Fira Sans"/>
-              </a:rPr>
-              <a:t>El DataFrame es una tabla con columnas etiquetadas, cada una de su propio tipo. Con esas tres líneas se abre la EOD completa: lo haremos en vivo en el notebook de hoy.</a:t>
+            <a:r>
+              <a:rPr sz="1300" b="0">
+                <a:solidFill>
+                  <a:srgbClr val="333333"/>
+                </a:solidFill>
+                <a:latin typeface="Fira Sans"/>
+              </a:rPr>
+              <a:t>EOD Santiago 2012: 18.264 hogares, 60.054 personas y 113.591 viajes registrados. Cada fila es un viaje; los códigos se resuelven contra tablas de parámetros.</a:t>
             </a:r>
           </a:p>
         </p:txBody>
@@ -5862,35 +5784,78 @@
                 </a:solidFill>
                 <a:latin typeface="Fira Sans"/>
               </a:rPr>
-              <a:t>La Encuesta Origen Destino de Santiago 2012</a:t>
-            </a:r>
-          </a:p>
-        </p:txBody>
-      </p:sp>
-      <p:pic>
-        <p:nvPicPr>
-          <p:cNvPr id="4" name="Picture 3" descr="02_df_viajes.png"/>
-          <p:cNvPicPr>
-            <a:picLocks noChangeAspect="1"/>
-          </p:cNvPicPr>
-          <p:nvPr/>
-        </p:nvPicPr>
-        <p:blipFill>
-          <a:blip r:embed="rId2"/>
-          <a:stretch>
-            <a:fillRect/>
-          </a:stretch>
-        </p:blipFill>
-        <p:spPr>
-          <a:xfrm>
-            <a:off x="1417319" y="1143000"/>
-            <a:ext cx="6309360" cy="2296353"/>
-          </a:xfrm>
-          <a:prstGeom prst="rect">
-            <a:avLst/>
-          </a:prstGeom>
-        </p:spPr>
-      </p:pic>
+              <a:t>Pandas: unir tablas con merge</a:t>
+            </a:r>
+          </a:p>
+        </p:txBody>
+      </p:sp>
+      <p:sp>
+        <p:nvSpPr>
+          <p:cNvPr id="4" name="Rectangle 3"/>
+          <p:cNvSpPr/>
+          <p:nvPr/>
+        </p:nvSpPr>
+        <p:spPr>
+          <a:xfrm>
+            <a:off x="704088" y="1280160"/>
+            <a:ext cx="7744968" cy="1371600"/>
+          </a:xfrm>
+          <a:prstGeom prst="rect">
+            <a:avLst/>
+          </a:prstGeom>
+          <a:solidFill>
+            <a:srgbClr val="F0F2F5"/>
+          </a:solidFill>
+          <a:ln>
+            <a:solidFill>
+              <a:srgbClr val="D8DDE3"/>
+            </a:solidFill>
+          </a:ln>
+          <a:effectLst/>
+        </p:spPr>
+        <p:style>
+          <a:lnRef idx="1">
+            <a:schemeClr val="accent1"/>
+          </a:lnRef>
+          <a:fillRef idx="3">
+            <a:schemeClr val="accent1"/>
+          </a:fillRef>
+          <a:effectRef idx="2">
+            <a:schemeClr val="accent1"/>
+          </a:effectRef>
+          <a:fontRef idx="minor">
+            <a:schemeClr val="lt1"/>
+          </a:fontRef>
+        </p:style>
+        <p:txBody>
+          <a:bodyPr rtlCol="0" anchor="ctr" wrap="square" lIns="228600" tIns="137160"/>
+          <a:lstStyle/>
+          <a:p>
+            <a:pPr/>
+            <a:r>
+              <a:rPr sz="1500" b="0">
+                <a:solidFill>
+                  <a:srgbClr val="1D3557"/>
+                </a:solidFill>
+                <a:latin typeface="Menlo"/>
+              </a:rPr>
+              <a:t>comunas = pd.read_csv(URL_COMUNAS)   # Id, Comuna</a:t>
+            </a:r>
+          </a:p>
+          <a:p>
+            <a:pPr/>
+            <a:r>
+              <a:rPr sz="1500" b="0">
+                <a:solidFill>
+                  <a:srgbClr val="1D3557"/>
+                </a:solidFill>
+                <a:latin typeface="Menlo"/>
+              </a:rPr>
+              <a:t>viajes.merge(comunas, left_on="ComunaOrigen", right_on="Id")</a:t>
+            </a:r>
+          </a:p>
+        </p:txBody>
+      </p:sp>
       <p:sp>
         <p:nvSpPr>
           <p:cNvPr id="5" name="TextBox 4"/>
@@ -5899,8 +5864,8 @@
         </p:nvSpPr>
         <p:spPr>
           <a:xfrm>
-            <a:off x="704088" y="4434840"/>
-            <a:ext cx="7744968" cy="457200"/>
+            <a:off x="704088" y="2880360"/>
+            <a:ext cx="7744968" cy="1097280"/>
           </a:xfrm>
           <a:prstGeom prst="rect">
             <a:avLst/>
@@ -5913,14 +5878,31 @@
           </a:bodyPr>
           <a:lstStyle/>
           <a:p>
-            <a:r>
-              <a:rPr sz="1300" b="0">
-                <a:solidFill>
-                  <a:srgbClr val="333333"/>
-                </a:solidFill>
-                <a:latin typeface="Fira Sans"/>
-              </a:rPr>
-              <a:t>EOD Santiago 2012: 18.264 hogares, 60.054 personas y 113.591 viajes registrados. Cada fila es un viaje; los códigos se resuelven contra tablas de parámetros.</a:t>
+            <a:pPr>
+              <a:lnSpc>
+                <a:spcPct val="112000"/>
+              </a:lnSpc>
+              <a:spcAft>
+                <a:spcPts val="900"/>
+              </a:spcAft>
+            </a:pPr>
+            <a:r>
+              <a:rPr sz="1600" b="1">
+                <a:solidFill>
+                  <a:srgbClr val="E0A437"/>
+                </a:solidFill>
+                <a:latin typeface="Fira Sans"/>
+              </a:rPr>
+              <a:t>▸ </a:t>
+            </a:r>
+            <a:r>
+              <a:rPr sz="1600" b="0">
+                <a:solidFill>
+                  <a:srgbClr val="000000"/>
+                </a:solidFill>
+                <a:latin typeface="Fira Sans"/>
+              </a:rPr>
+              <a:t>Los códigos de una tabla se traducen uniéndola con su tabla de parámetros: merge empareja filas por una columna común. En el notebook lo usamos para ponerle nombre a comunas y modos de viaje.</a:t>
             </a:r>
           </a:p>
         </p:txBody>
@@ -6016,78 +5998,35 @@
                 </a:solidFill>
                 <a:latin typeface="Fira Sans"/>
               </a:rPr>
-              <a:t>Pandas: unir tablas con merge</a:t>
-            </a:r>
-          </a:p>
-        </p:txBody>
-      </p:sp>
-      <p:sp>
-        <p:nvSpPr>
-          <p:cNvPr id="4" name="Rectangle 3"/>
-          <p:cNvSpPr/>
-          <p:nvPr/>
-        </p:nvSpPr>
-        <p:spPr>
-          <a:xfrm>
-            <a:off x="704088" y="1280160"/>
-            <a:ext cx="7744968" cy="1371600"/>
-          </a:xfrm>
-          <a:prstGeom prst="rect">
-            <a:avLst/>
-          </a:prstGeom>
-          <a:solidFill>
-            <a:srgbClr val="F0F2F5"/>
-          </a:solidFill>
-          <a:ln>
-            <a:solidFill>
-              <a:srgbClr val="D8DDE3"/>
-            </a:solidFill>
-          </a:ln>
-          <a:effectLst/>
-        </p:spPr>
-        <p:style>
-          <a:lnRef idx="1">
-            <a:schemeClr val="accent1"/>
-          </a:lnRef>
-          <a:fillRef idx="3">
-            <a:schemeClr val="accent1"/>
-          </a:fillRef>
-          <a:effectRef idx="2">
-            <a:schemeClr val="accent1"/>
-          </a:effectRef>
-          <a:fontRef idx="minor">
-            <a:schemeClr val="lt1"/>
-          </a:fontRef>
-        </p:style>
-        <p:txBody>
-          <a:bodyPr rtlCol="0" anchor="ctr" wrap="square" lIns="228600" tIns="137160"/>
-          <a:lstStyle/>
-          <a:p>
-            <a:pPr/>
-            <a:r>
-              <a:rPr sz="1500" b="0">
-                <a:solidFill>
-                  <a:srgbClr val="1D3557"/>
-                </a:solidFill>
-                <a:latin typeface="Menlo"/>
-              </a:rPr>
-              <a:t>comunas = pd.read_csv(URL_COMUNAS)   # Id, Comuna</a:t>
-            </a:r>
-          </a:p>
-          <a:p>
-            <a:pPr/>
-            <a:r>
-              <a:rPr sz="1500" b="0">
-                <a:solidFill>
-                  <a:srgbClr val="1D3557"/>
-                </a:solidFill>
-                <a:latin typeface="Menlo"/>
-              </a:rPr>
-              <a:t>viajes.merge(comunas, left_on="ComunaOrigen", right_on="Id")</a:t>
-            </a:r>
-          </a:p>
-        </p:txBody>
-      </p:sp>
+              <a:t>Matplotlib: del DataFrame al gráfico</a:t>
+            </a:r>
+          </a:p>
+        </p:txBody>
+      </p:sp>
+      <p:pic>
+        <p:nvPicPr>
+          <p:cNvPr id="4" name="Picture 3" descr="06_hist_tiempo.png"/>
+          <p:cNvPicPr>
+            <a:picLocks noChangeAspect="1"/>
+          </p:cNvPicPr>
+          <p:nvPr/>
+        </p:nvPicPr>
+        <p:blipFill>
+          <a:blip r:embed="rId2"/>
+          <a:stretch>
+            <a:fillRect/>
+          </a:stretch>
+        </p:blipFill>
+        <p:spPr>
+          <a:xfrm>
+            <a:off x="1778310" y="1143000"/>
+            <a:ext cx="5587379" cy="3154680"/>
+          </a:xfrm>
+          <a:prstGeom prst="rect">
+            <a:avLst/>
+          </a:prstGeom>
+        </p:spPr>
+      </p:pic>
       <p:sp>
         <p:nvSpPr>
           <p:cNvPr id="5" name="TextBox 4"/>
@@ -6096,8 +6035,8 @@
         </p:nvSpPr>
         <p:spPr>
           <a:xfrm>
-            <a:off x="704088" y="2880360"/>
-            <a:ext cx="7744968" cy="1097280"/>
+            <a:off x="704088" y="4434840"/>
+            <a:ext cx="7744968" cy="457200"/>
           </a:xfrm>
           <a:prstGeom prst="rect">
             <a:avLst/>
@@ -6110,31 +6049,14 @@
           </a:bodyPr>
           <a:lstStyle/>
           <a:p>
-            <a:pPr>
-              <a:lnSpc>
-                <a:spcPct val="112000"/>
-              </a:lnSpc>
-              <a:spcAft>
-                <a:spcPts val="900"/>
-              </a:spcAft>
-            </a:pPr>
-            <a:r>
-              <a:rPr sz="1600" b="1">
-                <a:solidFill>
-                  <a:srgbClr val="E0A437"/>
-                </a:solidFill>
-                <a:latin typeface="Fira Sans"/>
-              </a:rPr>
-              <a:t>▸ </a:t>
-            </a:r>
-            <a:r>
-              <a:rPr sz="1600" b="0">
-                <a:solidFill>
-                  <a:srgbClr val="000000"/>
-                </a:solidFill>
-                <a:latin typeface="Fira Sans"/>
-              </a:rPr>
-              <a:t>Los códigos de una tabla se traducen uniéndola con su tabla de parámetros: merge empareja filas por una columna común. En el notebook lo usamos para ponerle nombre a comunas y modos de viaje.</a:t>
+            <a:r>
+              <a:rPr sz="1300" b="0">
+                <a:solidFill>
+                  <a:srgbClr val="333333"/>
+                </a:solidFill>
+                <a:latin typeface="Fira Sans"/>
+              </a:rPr>
+              <a:t>Este histograma sale de la tabla de viajes con unas seis líneas de código; el notebook de la clase las muestra completas.</a:t>
             </a:r>
           </a:p>
         </p:txBody>
@@ -6230,35 +6152,102 @@
                 </a:solidFill>
                 <a:latin typeface="Fira Sans"/>
               </a:rPr>
-              <a:t>Matplotlib: del DataFrame al gráfico</a:t>
-            </a:r>
-          </a:p>
-        </p:txBody>
-      </p:sp>
-      <p:pic>
-        <p:nvPicPr>
-          <p:cNvPr id="4" name="Picture 3" descr="06_hist_tiempo.png"/>
-          <p:cNvPicPr>
-            <a:picLocks noChangeAspect="1"/>
-          </p:cNvPicPr>
-          <p:nvPr/>
-        </p:nvPicPr>
-        <p:blipFill>
-          <a:blip r:embed="rId2"/>
-          <a:stretch>
-            <a:fillRect/>
-          </a:stretch>
-        </p:blipFill>
-        <p:spPr>
-          <a:xfrm>
-            <a:off x="1778310" y="1143000"/>
-            <a:ext cx="5587379" cy="3154680"/>
-          </a:xfrm>
-          <a:prstGeom prst="rect">
-            <a:avLst/>
-          </a:prstGeom>
-        </p:spPr>
-      </p:pic>
+              <a:t>Puesta en marcha del entorno</a:t>
+            </a:r>
+          </a:p>
+        </p:txBody>
+      </p:sp>
+      <p:sp>
+        <p:nvSpPr>
+          <p:cNvPr id="4" name="Rectangle 3"/>
+          <p:cNvSpPr/>
+          <p:nvPr/>
+        </p:nvSpPr>
+        <p:spPr>
+          <a:xfrm>
+            <a:off x="704088" y="1280160"/>
+            <a:ext cx="7744968" cy="2377440"/>
+          </a:xfrm>
+          <a:prstGeom prst="rect">
+            <a:avLst/>
+          </a:prstGeom>
+          <a:solidFill>
+            <a:srgbClr val="F0F2F5"/>
+          </a:solidFill>
+          <a:ln>
+            <a:solidFill>
+              <a:srgbClr val="D8DDE3"/>
+            </a:solidFill>
+          </a:ln>
+          <a:effectLst/>
+        </p:spPr>
+        <p:style>
+          <a:lnRef idx="1">
+            <a:schemeClr val="accent1"/>
+          </a:lnRef>
+          <a:fillRef idx="3">
+            <a:schemeClr val="accent1"/>
+          </a:fillRef>
+          <a:effectRef idx="2">
+            <a:schemeClr val="accent1"/>
+          </a:effectRef>
+          <a:fontRef idx="minor">
+            <a:schemeClr val="lt1"/>
+          </a:fontRef>
+        </p:style>
+        <p:txBody>
+          <a:bodyPr rtlCol="0" anchor="ctr" wrap="square" lIns="228600" tIns="137160"/>
+          <a:lstStyle/>
+          <a:p>
+            <a:pPr/>
+            <a:r>
+              <a:rPr sz="1500" b="0">
+                <a:solidFill>
+                  <a:srgbClr val="1D3557"/>
+                </a:solidFill>
+                <a:latin typeface="Menlo"/>
+              </a:rPr>
+              <a:t>uv init --bare --python 3.12</a:t>
+            </a:r>
+          </a:p>
+          <a:p>
+            <a:pPr/>
+            <a:r>
+              <a:rPr sz="1500" b="0">
+                <a:solidFill>
+                  <a:srgbClr val="1D3557"/>
+                </a:solidFill>
+                <a:latin typeface="Menlo"/>
+              </a:rPr>
+              <a:t>uv add numpy pandas matplotlib seaborn scipy</a:t>
+            </a:r>
+          </a:p>
+          <a:p>
+            <a:pPr/>
+            <a:r>
+              <a:rPr sz="1500" b="0">
+                <a:solidFill>
+                  <a:srgbClr val="1D3557"/>
+                </a:solidFill>
+                <a:latin typeface="Menlo"/>
+              </a:rPr>
+              <a:t>uv add statsmodels scikit-learn jupyterlab</a:t>
+            </a:r>
+          </a:p>
+          <a:p>
+            <a:pPr/>
+            <a:r>
+              <a:rPr sz="1500" b="0">
+                <a:solidFill>
+                  <a:srgbClr val="1D3557"/>
+                </a:solidFill>
+                <a:latin typeface="Menlo"/>
+              </a:rPr>
+              <a:t>uv run jupyter lab</a:t>
+            </a:r>
+          </a:p>
+        </p:txBody>
+      </p:sp>
       <p:sp>
         <p:nvSpPr>
           <p:cNvPr id="5" name="TextBox 4"/>
@@ -6267,8 +6256,8 @@
         </p:nvSpPr>
         <p:spPr>
           <a:xfrm>
-            <a:off x="704088" y="4434840"/>
-            <a:ext cx="7744968" cy="457200"/>
+            <a:off x="704088" y="3886200"/>
+            <a:ext cx="7744968" cy="1097280"/>
           </a:xfrm>
           <a:prstGeom prst="rect">
             <a:avLst/>
@@ -6281,14 +6270,31 @@
           </a:bodyPr>
           <a:lstStyle/>
           <a:p>
-            <a:r>
-              <a:rPr sz="1300" b="0">
-                <a:solidFill>
-                  <a:srgbClr val="333333"/>
-                </a:solidFill>
-                <a:latin typeface="Fira Sans"/>
-              </a:rPr>
-              <a:t>Este histograma sale de la tabla de viajes con unas seis líneas de código; el notebook de la clase las muestra completas.</a:t>
+            <a:pPr>
+              <a:lnSpc>
+                <a:spcPct val="112000"/>
+              </a:lnSpc>
+              <a:spcAft>
+                <a:spcPts val="900"/>
+              </a:spcAft>
+            </a:pPr>
+            <a:r>
+              <a:rPr sz="1600" b="1">
+                <a:solidFill>
+                  <a:srgbClr val="E0A437"/>
+                </a:solidFill>
+                <a:latin typeface="Fira Sans"/>
+              </a:rPr>
+              <a:t>▸ </a:t>
+            </a:r>
+            <a:r>
+              <a:rPr sz="1600" b="0">
+                <a:solidFill>
+                  <a:srgbClr val="000000"/>
+                </a:solidFill>
+                <a:latin typeface="Fira Sans"/>
+              </a:rPr>
+              <a:t>La guía de instalación del repositorio (github.com/daniopitz/diplomado-cdd) detalla estos pasos por sistema operativo y los problemas frecuentes. Lo hacemos juntos ahora; debe quedar funcionando antes de la clase 2. Alternativa sin instalar nada: Google Colab, con los enlaces del repositorio.</a:t>
             </a:r>
           </a:p>
         </p:txBody>
@@ -6384,102 +6390,35 @@
                 </a:solidFill>
                 <a:latin typeface="Fira Sans"/>
               </a:rPr>
-              <a:t>Puesta en marcha del entorno</a:t>
-            </a:r>
-          </a:p>
-        </p:txBody>
-      </p:sp>
-      <p:sp>
-        <p:nvSpPr>
-          <p:cNvPr id="4" name="Rectangle 3"/>
-          <p:cNvSpPr/>
-          <p:nvPr/>
-        </p:nvSpPr>
-        <p:spPr>
-          <a:xfrm>
-            <a:off x="704088" y="1280160"/>
-            <a:ext cx="7744968" cy="2377440"/>
-          </a:xfrm>
-          <a:prstGeom prst="rect">
-            <a:avLst/>
-          </a:prstGeom>
-          <a:solidFill>
-            <a:srgbClr val="F0F2F5"/>
-          </a:solidFill>
-          <a:ln>
-            <a:solidFill>
-              <a:srgbClr val="D8DDE3"/>
-            </a:solidFill>
-          </a:ln>
-          <a:effectLst/>
-        </p:spPr>
-        <p:style>
-          <a:lnRef idx="1">
-            <a:schemeClr val="accent1"/>
-          </a:lnRef>
-          <a:fillRef idx="3">
-            <a:schemeClr val="accent1"/>
-          </a:fillRef>
-          <a:effectRef idx="2">
-            <a:schemeClr val="accent1"/>
-          </a:effectRef>
-          <a:fontRef idx="minor">
-            <a:schemeClr val="lt1"/>
-          </a:fontRef>
-        </p:style>
-        <p:txBody>
-          <a:bodyPr rtlCol="0" anchor="ctr" wrap="square" lIns="228600" tIns="137160"/>
-          <a:lstStyle/>
-          <a:p>
-            <a:pPr/>
-            <a:r>
-              <a:rPr sz="1500" b="0">
-                <a:solidFill>
-                  <a:srgbClr val="1D3557"/>
-                </a:solidFill>
-                <a:latin typeface="Menlo"/>
-              </a:rPr>
-              <a:t>uv init --bare --python 3.12</a:t>
-            </a:r>
-          </a:p>
-          <a:p>
-            <a:pPr/>
-            <a:r>
-              <a:rPr sz="1500" b="0">
-                <a:solidFill>
-                  <a:srgbClr val="1D3557"/>
-                </a:solidFill>
-                <a:latin typeface="Menlo"/>
-              </a:rPr>
-              <a:t>uv add numpy pandas matplotlib seaborn scipy</a:t>
-            </a:r>
-          </a:p>
-          <a:p>
-            <a:pPr/>
-            <a:r>
-              <a:rPr sz="1500" b="0">
-                <a:solidFill>
-                  <a:srgbClr val="1D3557"/>
-                </a:solidFill>
-                <a:latin typeface="Menlo"/>
-              </a:rPr>
-              <a:t>uv add statsmodels scikit-learn jupyterlab</a:t>
-            </a:r>
-          </a:p>
-          <a:p>
-            <a:pPr/>
-            <a:r>
-              <a:rPr sz="1500" b="0">
-                <a:solidFill>
-                  <a:srgbClr val="1D3557"/>
-                </a:solidFill>
-                <a:latin typeface="Menlo"/>
-              </a:rPr>
-              <a:t>uv run jupyter lab</a:t>
-            </a:r>
-          </a:p>
-        </p:txBody>
-      </p:sp>
+              <a:t>Reparto modal de Santiago, EOD 2012</a:t>
+            </a:r>
+          </a:p>
+        </p:txBody>
+      </p:sp>
+      <p:pic>
+        <p:nvPicPr>
+          <p:cNvPr id="4" name="Picture 3" descr="01_reparto_modal.png"/>
+          <p:cNvPicPr>
+            <a:picLocks noChangeAspect="1"/>
+          </p:cNvPicPr>
+          <p:nvPr/>
+        </p:nvPicPr>
+        <p:blipFill>
+          <a:blip r:embed="rId2"/>
+          <a:stretch>
+            <a:fillRect/>
+          </a:stretch>
+        </p:blipFill>
+        <p:spPr>
+          <a:xfrm>
+            <a:off x="1604462" y="1143000"/>
+            <a:ext cx="5935075" cy="3154680"/>
+          </a:xfrm>
+          <a:prstGeom prst="rect">
+            <a:avLst/>
+          </a:prstGeom>
+        </p:spPr>
+      </p:pic>
       <p:sp>
         <p:nvSpPr>
           <p:cNvPr id="5" name="TextBox 4"/>
@@ -6488,8 +6427,8 @@
         </p:nvSpPr>
         <p:spPr>
           <a:xfrm>
-            <a:off x="704088" y="3886200"/>
-            <a:ext cx="7744968" cy="1097280"/>
+            <a:off x="704088" y="4434840"/>
+            <a:ext cx="7744968" cy="457200"/>
           </a:xfrm>
           <a:prstGeom prst="rect">
             <a:avLst/>
@@ -6502,31 +6441,14 @@
           </a:bodyPr>
           <a:lstStyle/>
           <a:p>
-            <a:pPr>
-              <a:lnSpc>
-                <a:spcPct val="112000"/>
-              </a:lnSpc>
-              <a:spcAft>
-                <a:spcPts val="900"/>
-              </a:spcAft>
-            </a:pPr>
-            <a:r>
-              <a:rPr sz="1600" b="1">
-                <a:solidFill>
-                  <a:srgbClr val="E0A437"/>
-                </a:solidFill>
-                <a:latin typeface="Fira Sans"/>
-              </a:rPr>
-              <a:t>▸ </a:t>
-            </a:r>
-            <a:r>
-              <a:rPr sz="1600" b="0">
-                <a:solidFill>
-                  <a:srgbClr val="000000"/>
-                </a:solidFill>
-                <a:latin typeface="Fira Sans"/>
-              </a:rPr>
-              <a:t>La guía de instalación del repositorio (github.com/daniopitz/diplomado-cdd) detalla estos pasos por sistema operativo y los problemas frecuentes. Lo hacemos juntos ahora; debe quedar funcionando antes de la clase 2. Alternativa sin instalar nada: Google Colab, con los enlaces del repositorio.</a:t>
+            <a:r>
+              <a:rPr sz="1300" b="0">
+                <a:solidFill>
+                  <a:srgbClr val="333333"/>
+                </a:solidFill>
+                <a:latin typeface="Fira Sans"/>
+              </a:rPr>
+              <a:t>Uno de cada tres viajes es a pie. Esta versión está ponderada por factores de expansión, así que habla de la ciudad; en el notebook calcularemos la versión muestral, y la diferencia entre ambas abre las clases 2 y 3.</a:t>
             </a:r>
           </a:p>
         </p:txBody>
@@ -6622,45 +6544,21 @@
                 </a:solidFill>
                 <a:latin typeface="Fira Sans"/>
               </a:rPr>
-              <a:t>Reparto modal de Santiago, EOD 2012</a:t>
-            </a:r>
-          </a:p>
-        </p:txBody>
-      </p:sp>
-      <p:pic>
-        <p:nvPicPr>
-          <p:cNvPr id="4" name="Picture 3" descr="01_reparto_modal.png"/>
-          <p:cNvPicPr>
-            <a:picLocks noChangeAspect="1"/>
-          </p:cNvPicPr>
-          <p:nvPr/>
-        </p:nvPicPr>
-        <p:blipFill>
-          <a:blip r:embed="rId2"/>
-          <a:stretch>
-            <a:fillRect/>
-          </a:stretch>
-        </p:blipFill>
-        <p:spPr>
-          <a:xfrm>
-            <a:off x="1604462" y="1143000"/>
-            <a:ext cx="5935075" cy="3154680"/>
-          </a:xfrm>
-          <a:prstGeom prst="rect">
-            <a:avLst/>
-          </a:prstGeom>
-        </p:spPr>
-      </p:pic>
-      <p:sp>
-        <p:nvSpPr>
-          <p:cNvPr id="5" name="TextBox 4"/>
+              <a:t>Síntesis</a:t>
+            </a:r>
+          </a:p>
+        </p:txBody>
+      </p:sp>
+      <p:sp>
+        <p:nvSpPr>
+          <p:cNvPr id="4" name="TextBox 3"/>
           <p:cNvSpPr txBox="1"/>
           <p:nvPr/>
         </p:nvSpPr>
         <p:spPr>
           <a:xfrm>
-            <a:off x="704088" y="4434840"/>
-            <a:ext cx="7744968" cy="457200"/>
+            <a:off x="704088" y="1353312"/>
+            <a:ext cx="7744968" cy="3300984"/>
           </a:xfrm>
           <a:prstGeom prst="rect">
             <a:avLst/>
@@ -6673,14 +6571,143 @@
           </a:bodyPr>
           <a:lstStyle/>
           <a:p>
-            <a:r>
-              <a:rPr sz="1300" b="0">
-                <a:solidFill>
-                  <a:srgbClr val="333333"/>
-                </a:solidFill>
-                <a:latin typeface="Fira Sans"/>
-              </a:rPr>
-              <a:t>Uno de cada tres viajes es a pie. Esta versión está ponderada por factores de expansión, así que habla de la ciudad; en el notebook calcularemos la versión muestral, y la diferencia entre ambas abre las clases 2 y 3.</a:t>
+            <a:pPr>
+              <a:lnSpc>
+                <a:spcPct val="112000"/>
+              </a:lnSpc>
+              <a:spcAft>
+                <a:spcPts val="900"/>
+              </a:spcAft>
+            </a:pPr>
+            <a:r>
+              <a:rPr sz="1800" b="1">
+                <a:solidFill>
+                  <a:srgbClr val="E0A437"/>
+                </a:solidFill>
+                <a:latin typeface="Fira Sans"/>
+              </a:rPr>
+              <a:t>▸ </a:t>
+            </a:r>
+            <a:r>
+              <a:rPr sz="1800" b="1">
+                <a:solidFill>
+                  <a:srgbClr val="1D3557"/>
+                </a:solidFill>
+                <a:latin typeface="Fira Sans"/>
+              </a:rPr>
+              <a:t>El tipo de cada variable determina qué resúmenes, gráficos y análisis son válidos.</a:t>
+            </a:r>
+          </a:p>
+          <a:p>
+            <a:pPr>
+              <a:lnSpc>
+                <a:spcPct val="112000"/>
+              </a:lnSpc>
+              <a:spcAft>
+                <a:spcPts val="900"/>
+              </a:spcAft>
+            </a:pPr>
+            <a:r>
+              <a:rPr sz="1800" b="1">
+                <a:solidFill>
+                  <a:srgbClr val="E0A437"/>
+                </a:solidFill>
+                <a:latin typeface="Fira Sans"/>
+              </a:rPr>
+              <a:t>▸ </a:t>
+            </a:r>
+            <a:r>
+              <a:rPr sz="1800" b="0">
+                <a:solidFill>
+                  <a:srgbClr val="000000"/>
+                </a:solidFill>
+                <a:latin typeface="Fira Sans"/>
+              </a:rPr>
+              <a:t>Ciencia de datos: extracción generalizable de conocimiento a partir de los datos (Dhar, 2013); combina estadística, computación y dominio.</a:t>
+            </a:r>
+          </a:p>
+          <a:p>
+            <a:pPr>
+              <a:lnSpc>
+                <a:spcPct val="112000"/>
+              </a:lnSpc>
+              <a:spcAft>
+                <a:spcPts val="900"/>
+              </a:spcAft>
+            </a:pPr>
+            <a:r>
+              <a:rPr sz="1800" b="1">
+                <a:solidFill>
+                  <a:srgbClr val="E0A437"/>
+                </a:solidFill>
+                <a:latin typeface="Fira Sans"/>
+              </a:rPr>
+              <a:t>▸ </a:t>
+            </a:r>
+            <a:r>
+              <a:rPr sz="1800" b="0">
+                <a:solidFill>
+                  <a:srgbClr val="000000"/>
+                </a:solidFill>
+                <a:latin typeface="Fira Sans"/>
+              </a:rPr>
+              <a:t>El ciclo de vida tiene dos entradas (una necesidad del dominio o datos disponibles) y se recorre de forma iterativa.</a:t>
+            </a:r>
+          </a:p>
+          <a:p>
+            <a:pPr>
+              <a:lnSpc>
+                <a:spcPct val="112000"/>
+              </a:lnSpc>
+              <a:spcAft>
+                <a:spcPts val="900"/>
+              </a:spcAft>
+            </a:pPr>
+            <a:r>
+              <a:rPr sz="1800" b="1">
+                <a:solidFill>
+                  <a:srgbClr val="E0A437"/>
+                </a:solidFill>
+                <a:latin typeface="Fira Sans"/>
+              </a:rPr>
+              <a:t>▸ </a:t>
+            </a:r>
+            <a:r>
+              <a:rPr sz="1800" b="0">
+                <a:solidFill>
+                  <a:srgbClr val="000000"/>
+                </a:solidFill>
+                <a:latin typeface="Fira Sans"/>
+              </a:rPr>
+              <a:t>La preparación de datos consume cerca de la mitad del tiempo de un proyecto (Anaconda, 2020).</a:t>
+            </a:r>
+          </a:p>
+          <a:p>
+            <a:pPr>
+              <a:lnSpc>
+                <a:spcPct val="112000"/>
+              </a:lnSpc>
+              <a:spcAft>
+                <a:spcPts val="900"/>
+              </a:spcAft>
+            </a:pPr>
+            <a:r>
+              <a:rPr sz="1800" b="1">
+                <a:solidFill>
+                  <a:srgbClr val="E0A437"/>
+                </a:solidFill>
+                <a:latin typeface="Fira Sans"/>
+              </a:rPr>
+              <a:t>▸ </a:t>
+            </a:r>
+            <a:r>
+              <a:rPr sz="1800" b="0">
+                <a:solidFill>
+                  <a:srgbClr val="000000"/>
+                </a:solidFill>
+                <a:latin typeface="Fira Sans"/>
+              </a:rPr>
+              <a:t>Próxima clase (jueves 27): estadística descriptiva, con el entorno ya funcionando.</a:t>
             </a:r>
           </a:p>
         </p:txBody>
@@ -6694,265 +6721,6 @@
 </file>
 
 <file path=ppt/slides/slide26.xml><?xml version="1.0" encoding="utf-8"?>
-<p:sld xmlns:a="http://schemas.openxmlformats.org/drawingml/2006/main" xmlns:p="http://schemas.openxmlformats.org/presentationml/2006/main" xmlns:r="http://schemas.openxmlformats.org/officeDocument/2006/relationships">
-  <p:cSld>
-    <p:spTree>
-      <p:nvGrpSpPr>
-        <p:cNvPr id="1" name=""/>
-        <p:cNvGrpSpPr/>
-        <p:nvPr/>
-      </p:nvGrpSpPr>
-      <p:grpSpPr/>
-      <p:sp>
-        <p:nvSpPr>
-          <p:cNvPr id="2" name="Rectangle 1"/>
-          <p:cNvSpPr/>
-          <p:nvPr/>
-        </p:nvSpPr>
-        <p:spPr>
-          <a:xfrm>
-            <a:off x="0" y="0"/>
-            <a:ext cx="9144000" cy="5138928"/>
-          </a:xfrm>
-          <a:prstGeom prst="rect">
-            <a:avLst/>
-          </a:prstGeom>
-          <a:solidFill>
-            <a:srgbClr val="FAFBFC"/>
-          </a:solidFill>
-          <a:ln>
-            <a:noFill/>
-          </a:ln>
-          <a:effectLst/>
-        </p:spPr>
-        <p:style>
-          <a:lnRef idx="1">
-            <a:schemeClr val="accent1"/>
-          </a:lnRef>
-          <a:fillRef idx="3">
-            <a:schemeClr val="accent1"/>
-          </a:fillRef>
-          <a:effectRef idx="2">
-            <a:schemeClr val="accent1"/>
-          </a:effectRef>
-          <a:fontRef idx="minor">
-            <a:schemeClr val="lt1"/>
-          </a:fontRef>
-        </p:style>
-        <p:txBody>
-          <a:bodyPr rtlCol="0" anchor="ctr"/>
-          <a:lstStyle/>
-          <a:p>
-            <a:pPr algn="ctr"/>
-          </a:p>
-        </p:txBody>
-      </p:sp>
-      <p:sp>
-        <p:nvSpPr>
-          <p:cNvPr id="3" name="TextBox 2"/>
-          <p:cNvSpPr txBox="1"/>
-          <p:nvPr/>
-        </p:nvSpPr>
-        <p:spPr>
-          <a:xfrm>
-            <a:off x="402336" y="301752"/>
-            <a:ext cx="8348472" cy="795528"/>
-          </a:xfrm>
-          <a:prstGeom prst="rect">
-            <a:avLst/>
-          </a:prstGeom>
-          <a:noFill/>
-        </p:spPr>
-        <p:txBody>
-          <a:bodyPr wrap="square">
-            <a:spAutoFit/>
-          </a:bodyPr>
-          <a:lstStyle/>
-          <a:p>
-            <a:r>
-              <a:rPr sz="2800" b="1">
-                <a:solidFill>
-                  <a:srgbClr val="0F0F0F"/>
-                </a:solidFill>
-                <a:latin typeface="Fira Sans"/>
-              </a:rPr>
-              <a:t>Síntesis</a:t>
-            </a:r>
-          </a:p>
-        </p:txBody>
-      </p:sp>
-      <p:sp>
-        <p:nvSpPr>
-          <p:cNvPr id="4" name="TextBox 3"/>
-          <p:cNvSpPr txBox="1"/>
-          <p:nvPr/>
-        </p:nvSpPr>
-        <p:spPr>
-          <a:xfrm>
-            <a:off x="704088" y="1353312"/>
-            <a:ext cx="7744968" cy="3300984"/>
-          </a:xfrm>
-          <a:prstGeom prst="rect">
-            <a:avLst/>
-          </a:prstGeom>
-          <a:noFill/>
-        </p:spPr>
-        <p:txBody>
-          <a:bodyPr wrap="square">
-            <a:spAutoFit/>
-          </a:bodyPr>
-          <a:lstStyle/>
-          <a:p>
-            <a:pPr>
-              <a:lnSpc>
-                <a:spcPct val="112000"/>
-              </a:lnSpc>
-              <a:spcAft>
-                <a:spcPts val="900"/>
-              </a:spcAft>
-            </a:pPr>
-            <a:r>
-              <a:rPr sz="1800" b="1">
-                <a:solidFill>
-                  <a:srgbClr val="E0A437"/>
-                </a:solidFill>
-                <a:latin typeface="Fira Sans"/>
-              </a:rPr>
-              <a:t>▸ </a:t>
-            </a:r>
-            <a:r>
-              <a:rPr sz="1800" b="1">
-                <a:solidFill>
-                  <a:srgbClr val="1D3557"/>
-                </a:solidFill>
-                <a:latin typeface="Fira Sans"/>
-              </a:rPr>
-              <a:t>El tipo de cada variable determina qué resúmenes, gráficos y análisis son válidos.</a:t>
-            </a:r>
-          </a:p>
-          <a:p>
-            <a:pPr>
-              <a:lnSpc>
-                <a:spcPct val="112000"/>
-              </a:lnSpc>
-              <a:spcAft>
-                <a:spcPts val="900"/>
-              </a:spcAft>
-            </a:pPr>
-            <a:r>
-              <a:rPr sz="1800" b="1">
-                <a:solidFill>
-                  <a:srgbClr val="E0A437"/>
-                </a:solidFill>
-                <a:latin typeface="Fira Sans"/>
-              </a:rPr>
-              <a:t>▸ </a:t>
-            </a:r>
-            <a:r>
-              <a:rPr sz="1800" b="0">
-                <a:solidFill>
-                  <a:srgbClr val="000000"/>
-                </a:solidFill>
-                <a:latin typeface="Fira Sans"/>
-              </a:rPr>
-              <a:t>Ciencia de datos: extracción generalizable de conocimiento a partir de los datos (Dhar, 2013); combina estadística, computación y dominio.</a:t>
-            </a:r>
-          </a:p>
-          <a:p>
-            <a:pPr>
-              <a:lnSpc>
-                <a:spcPct val="112000"/>
-              </a:lnSpc>
-              <a:spcAft>
-                <a:spcPts val="900"/>
-              </a:spcAft>
-            </a:pPr>
-            <a:r>
-              <a:rPr sz="1800" b="1">
-                <a:solidFill>
-                  <a:srgbClr val="E0A437"/>
-                </a:solidFill>
-                <a:latin typeface="Fira Sans"/>
-              </a:rPr>
-              <a:t>▸ </a:t>
-            </a:r>
-            <a:r>
-              <a:rPr sz="1800" b="0">
-                <a:solidFill>
-                  <a:srgbClr val="000000"/>
-                </a:solidFill>
-                <a:latin typeface="Fira Sans"/>
-              </a:rPr>
-              <a:t>El ciclo de vida tiene dos entradas (una necesidad del dominio o datos disponibles) y se recorre de forma iterativa.</a:t>
-            </a:r>
-          </a:p>
-          <a:p>
-            <a:pPr>
-              <a:lnSpc>
-                <a:spcPct val="112000"/>
-              </a:lnSpc>
-              <a:spcAft>
-                <a:spcPts val="900"/>
-              </a:spcAft>
-            </a:pPr>
-            <a:r>
-              <a:rPr sz="1800" b="1">
-                <a:solidFill>
-                  <a:srgbClr val="E0A437"/>
-                </a:solidFill>
-                <a:latin typeface="Fira Sans"/>
-              </a:rPr>
-              <a:t>▸ </a:t>
-            </a:r>
-            <a:r>
-              <a:rPr sz="1800" b="0">
-                <a:solidFill>
-                  <a:srgbClr val="000000"/>
-                </a:solidFill>
-                <a:latin typeface="Fira Sans"/>
-              </a:rPr>
-              <a:t>La preparación de datos consume cerca de la mitad del tiempo de un proyecto (Anaconda, 2020).</a:t>
-            </a:r>
-          </a:p>
-          <a:p>
-            <a:pPr>
-              <a:lnSpc>
-                <a:spcPct val="112000"/>
-              </a:lnSpc>
-              <a:spcAft>
-                <a:spcPts val="900"/>
-              </a:spcAft>
-            </a:pPr>
-            <a:r>
-              <a:rPr sz="1800" b="1">
-                <a:solidFill>
-                  <a:srgbClr val="E0A437"/>
-                </a:solidFill>
-                <a:latin typeface="Fira Sans"/>
-              </a:rPr>
-              <a:t>▸ </a:t>
-            </a:r>
-            <a:r>
-              <a:rPr sz="1800" b="0">
-                <a:solidFill>
-                  <a:srgbClr val="000000"/>
-                </a:solidFill>
-                <a:latin typeface="Fira Sans"/>
-              </a:rPr>
-              <a:t>Próxima clase (jueves 27): estadística descriptiva, con el entorno ya funcionando.</a:t>
-            </a:r>
-          </a:p>
-        </p:txBody>
-      </p:sp>
-    </p:spTree>
-  </p:cSld>
-  <p:clrMapOvr>
-    <a:masterClrMapping/>
-  </p:clrMapOvr>
-</p:sld>
-</file>
-
-<file path=ppt/slides/slide27.xml><?xml version="1.0" encoding="utf-8"?>
 <p:sld xmlns:a="http://schemas.openxmlformats.org/drawingml/2006/main" xmlns:p="http://schemas.openxmlformats.org/presentationml/2006/main" xmlns:r="http://schemas.openxmlformats.org/officeDocument/2006/relationships">
   <p:cSld>
     <p:spTree>

</xml_diff>

<commit_message>
Puesta en marcha antes del contenido de Python; slide con las dos opciones de trabajo (entorno local y Colab)
Co-Authored-By: Claude Fable 5 <noreply@anthropic.com>
</commit_message>
<xml_diff>
--- a/presentaciones/clase01_fundamentos_ecosistema.pptx
+++ b/presentaciones/clase01_fundamentos_ecosistema.pptx
@@ -31,6 +31,7 @@
     <p:sldId id="279" r:id="rId30"/>
     <p:sldId id="280" r:id="rId31"/>
     <p:sldId id="281" r:id="rId32"/>
+    <p:sldId id="282" r:id="rId33"/>
   </p:sldIdLst>
   <p:sldSz cx="9144000" cy="5138928" type="screen4x3"/>
   <p:notesSz cx="6858000" cy="9144000"/>
@@ -4919,100 +4920,21 @@
                 </a:solidFill>
                 <a:latin typeface="Fira Sans"/>
               </a:rPr>
-              <a:t>NumPy: cálculo sobre arreglos completos</a:t>
-            </a:r>
-          </a:p>
-        </p:txBody>
-      </p:sp>
-      <p:sp>
-        <p:nvSpPr>
-          <p:cNvPr id="4" name="Rectangle 3"/>
-          <p:cNvSpPr/>
-          <p:nvPr/>
-        </p:nvSpPr>
-        <p:spPr>
-          <a:xfrm>
-            <a:off x="704088" y="1280160"/>
-            <a:ext cx="7744968" cy="1874520"/>
-          </a:xfrm>
-          <a:prstGeom prst="rect">
-            <a:avLst/>
-          </a:prstGeom>
-          <a:solidFill>
-            <a:srgbClr val="F0F2F5"/>
-          </a:solidFill>
-          <a:ln>
-            <a:solidFill>
-              <a:srgbClr val="D8DDE3"/>
-            </a:solidFill>
-          </a:ln>
-          <a:effectLst/>
-        </p:spPr>
-        <p:style>
-          <a:lnRef idx="1">
-            <a:schemeClr val="accent1"/>
-          </a:lnRef>
-          <a:fillRef idx="3">
-            <a:schemeClr val="accent1"/>
-          </a:fillRef>
-          <a:effectRef idx="2">
-            <a:schemeClr val="accent1"/>
-          </a:effectRef>
-          <a:fontRef idx="minor">
-            <a:schemeClr val="lt1"/>
-          </a:fontRef>
-        </p:style>
-        <p:txBody>
-          <a:bodyPr rtlCol="0" anchor="ctr" wrap="square" lIns="228600" tIns="137160"/>
-          <a:lstStyle/>
-          <a:p>
-            <a:pPr/>
-            <a:r>
-              <a:rPr sz="1500" b="0">
-                <a:solidFill>
-                  <a:srgbClr val="1D3557"/>
-                </a:solidFill>
-                <a:latin typeface="Menlo"/>
-              </a:rPr>
-              <a:t>import numpy as np</a:t>
-            </a:r>
-          </a:p>
-          <a:p>
-            <a:pPr/>
-            <a:r>
-              <a:rPr sz="1500" b="0">
-                <a:solidFill>
-                  <a:srgbClr val="1D3557"/>
-                </a:solidFill>
-                <a:latin typeface="Menlo"/>
-              </a:rPr>
-              <a:t>tiempos = np.array([70, 105, 90, 25, 40])</a:t>
-            </a:r>
-          </a:p>
-          <a:p>
-            <a:pPr/>
-            <a:r>
-              <a:rPr sz="1500" b="0">
-                <a:solidFill>
-                  <a:srgbClr val="1D3557"/>
-                </a:solidFill>
-                <a:latin typeface="Menlo"/>
-              </a:rPr>
-              <a:t>tiempos.mean()          # 66.0, sin escribir un ciclo</a:t>
-            </a:r>
-          </a:p>
-        </p:txBody>
-      </p:sp>
-      <p:sp>
-        <p:nvSpPr>
-          <p:cNvPr id="5" name="TextBox 4"/>
+              <a:t>Dos formas de trabajar en el curso</a:t>
+            </a:r>
+          </a:p>
+        </p:txBody>
+      </p:sp>
+      <p:sp>
+        <p:nvSpPr>
+          <p:cNvPr id="4" name="TextBox 3"/>
           <p:cNvSpPr txBox="1"/>
           <p:nvPr/>
         </p:nvSpPr>
         <p:spPr>
           <a:xfrm>
-            <a:off x="704088" y="3383279"/>
-            <a:ext cx="7744968" cy="1097280"/>
+            <a:off x="704088" y="1353312"/>
+            <a:ext cx="7744968" cy="3300984"/>
           </a:xfrm>
           <a:prstGeom prst="rect">
             <a:avLst/>
@@ -5034,7 +4956,7 @@
               </a:spcAft>
             </a:pPr>
             <a:r>
-              <a:rPr sz="1600" b="1">
+              <a:rPr sz="1800" b="1">
                 <a:solidFill>
                   <a:srgbClr val="E0A437"/>
                 </a:solidFill>
@@ -5043,13 +4965,125 @@
               <a:t>▸ </a:t>
             </a:r>
             <a:r>
-              <a:rPr sz="1600" b="0">
+              <a:rPr sz="1800" b="1">
+                <a:solidFill>
+                  <a:srgbClr val="1D3557"/>
+                </a:solidFill>
+                <a:latin typeface="Fira Sans"/>
+              </a:rPr>
+              <a:t>Opción A, entorno local: uv administra Python y las librerías, y se trabaja en JupyterLab.</a:t>
+            </a:r>
+          </a:p>
+          <a:p>
+            <a:pPr>
+              <a:lnSpc>
+                <a:spcPct val="112000"/>
+              </a:lnSpc>
+              <a:spcAft>
+                <a:spcPts val="900"/>
+              </a:spcAft>
+            </a:pPr>
+            <a:r>
+              <a:rPr sz="1800" b="1">
+                <a:solidFill>
+                  <a:srgbClr val="E0A437"/>
+                </a:solidFill>
+                <a:latin typeface="Fira Sans"/>
+              </a:rPr>
+              <a:t>▸ </a:t>
+            </a:r>
+            <a:r>
+              <a:rPr sz="1800" b="0">
                 <a:solidFill>
                   <a:srgbClr val="000000"/>
                 </a:solidFill>
                 <a:latin typeface="Fira Sans"/>
               </a:rPr>
-              <a:t>La operación se aplica al arreglo completo (vectorización): menos código y mucho más rápido que iterar en Python puro. Es la base sobre la que se construye todo lo demás.</a:t>
+              <a:t>La guía de instalación del repositorio detalla los pasos por sistema operativo y los problemas frecuentes.</a:t>
+            </a:r>
+          </a:p>
+          <a:p>
+            <a:pPr>
+              <a:lnSpc>
+                <a:spcPct val="112000"/>
+              </a:lnSpc>
+              <a:spcAft>
+                <a:spcPts val="900"/>
+              </a:spcAft>
+            </a:pPr>
+            <a:r>
+              <a:rPr sz="1800" b="1">
+                <a:solidFill>
+                  <a:srgbClr val="E0A437"/>
+                </a:solidFill>
+                <a:latin typeface="Fira Sans"/>
+              </a:rPr>
+              <a:t>▸ </a:t>
+            </a:r>
+            <a:r>
+              <a:rPr sz="1800" b="1">
+                <a:solidFill>
+                  <a:srgbClr val="1D3557"/>
+                </a:solidFill>
+                <a:latin typeface="Fira Sans"/>
+              </a:rPr>
+              <a:t>Opción B, Google Colab: los notebooks corren en la nube, sin instalar nada; se abren con los enlaces del README del repositorio.</a:t>
+            </a:r>
+          </a:p>
+          <a:p>
+            <a:pPr>
+              <a:lnSpc>
+                <a:spcPct val="112000"/>
+              </a:lnSpc>
+              <a:spcAft>
+                <a:spcPts val="900"/>
+              </a:spcAft>
+            </a:pPr>
+            <a:r>
+              <a:rPr sz="1800" b="1">
+                <a:solidFill>
+                  <a:srgbClr val="E0A437"/>
+                </a:solidFill>
+                <a:latin typeface="Fira Sans"/>
+              </a:rPr>
+              <a:t>▸ </a:t>
+            </a:r>
+            <a:r>
+              <a:rPr sz="1800" b="0">
+                <a:solidFill>
+                  <a:srgbClr val="000000"/>
+                </a:solidFill>
+                <a:latin typeface="Fira Sans"/>
+              </a:rPr>
+              <a:t>Solo requiere una cuenta de Google. Es la alternativa si su computador tiene restricciones de instalación.</a:t>
+            </a:r>
+          </a:p>
+          <a:p>
+            <a:pPr>
+              <a:lnSpc>
+                <a:spcPct val="112000"/>
+              </a:lnSpc>
+              <a:spcAft>
+                <a:spcPts val="900"/>
+              </a:spcAft>
+            </a:pPr>
+            <a:r>
+              <a:rPr sz="1800" b="1">
+                <a:solidFill>
+                  <a:srgbClr val="E0A437"/>
+                </a:solidFill>
+                <a:latin typeface="Fira Sans"/>
+              </a:rPr>
+              <a:t>▸ </a:t>
+            </a:r>
+            <a:r>
+              <a:rPr sz="1800" b="0">
+                <a:solidFill>
+                  <a:srgbClr val="000000"/>
+                </a:solidFill>
+                <a:latin typeface="Fira Sans"/>
+              </a:rPr>
+              <a:t>Ambas opciones usan los mismos notebooks y los mismos datos (se leen desde una URL). Material en github.com/daniopitz/diplomado-cdd</a:t>
             </a:r>
           </a:p>
         </p:txBody>
@@ -5145,7 +5179,7 @@
                 </a:solidFill>
                 <a:latin typeface="Fira Sans"/>
               </a:rPr>
-              <a:t>Pandas: la tabla como objeto de trabajo</a:t>
+              <a:t>Puesta en marcha del entorno local</a:t>
             </a:r>
           </a:p>
         </p:txBody>
@@ -5159,7 +5193,7 @@
         <p:spPr>
           <a:xfrm>
             <a:off x="704088" y="1280160"/>
-            <a:ext cx="7744968" cy="1874520"/>
+            <a:ext cx="7744968" cy="2377440"/>
           </a:xfrm>
           <a:prstGeom prst="rect">
             <a:avLst/>
@@ -5200,7 +5234,7 @@
                 </a:solidFill>
                 <a:latin typeface="Menlo"/>
               </a:rPr>
-              <a:t>import pandas as pd</a:t>
+              <a:t>uv init --bare --python 3.12</a:t>
             </a:r>
           </a:p>
           <a:p>
@@ -5212,7 +5246,7 @@
                 </a:solidFill>
                 <a:latin typeface="Menlo"/>
               </a:rPr>
-              <a:t>viajes = pd.read_csv(URL_VIAJES, sep=";", decimal=",")</a:t>
+              <a:t>uv add numpy pandas matplotlib seaborn scipy</a:t>
             </a:r>
           </a:p>
           <a:p>
@@ -5224,7 +5258,19 @@
                 </a:solidFill>
                 <a:latin typeface="Menlo"/>
               </a:rPr>
-              <a:t>viajes.head()</a:t>
+              <a:t>uv add statsmodels scikit-learn jupyterlab</a:t>
+            </a:r>
+          </a:p>
+          <a:p>
+            <a:pPr/>
+            <a:r>
+              <a:rPr sz="1500" b="0">
+                <a:solidFill>
+                  <a:srgbClr val="1D3557"/>
+                </a:solidFill>
+                <a:latin typeface="Menlo"/>
+              </a:rPr>
+              <a:t>uv run jupyter lab</a:t>
             </a:r>
           </a:p>
         </p:txBody>
@@ -5237,7 +5283,7 @@
         </p:nvSpPr>
         <p:spPr>
           <a:xfrm>
-            <a:off x="704088" y="3383279"/>
+            <a:off x="704088" y="3886200"/>
             <a:ext cx="7744968" cy="1097280"/>
           </a:xfrm>
           <a:prstGeom prst="rect">
@@ -5275,7 +5321,7 @@
                 </a:solidFill>
                 <a:latin typeface="Fira Sans"/>
               </a:rPr>
-              <a:t>El DataFrame es una tabla con columnas etiquetadas, cada una de su propio tipo. Con esas tres líneas se abre la EOD completa: lo haremos en vivo en el notebook de hoy.</a:t>
+              <a:t>Lo hacemos juntos ahora; debe quedar funcionando antes de la clase 2. Si algo falla, siga la clase en Colab y revise después la sección de problemas frecuentes de la guía, o escríbanos.</a:t>
             </a:r>
           </a:p>
         </p:txBody>
@@ -5630,35 +5676,90 @@
                 </a:solidFill>
                 <a:latin typeface="Fira Sans"/>
               </a:rPr>
-              <a:t>La Encuesta Origen Destino de Santiago 2012</a:t>
-            </a:r>
-          </a:p>
-        </p:txBody>
-      </p:sp>
-      <p:pic>
-        <p:nvPicPr>
-          <p:cNvPr id="4" name="Picture 3" descr="02_df_viajes.png"/>
-          <p:cNvPicPr>
-            <a:picLocks noChangeAspect="1"/>
-          </p:cNvPicPr>
-          <p:nvPr/>
-        </p:nvPicPr>
-        <p:blipFill>
-          <a:blip r:embed="rId2"/>
-          <a:stretch>
-            <a:fillRect/>
-          </a:stretch>
-        </p:blipFill>
-        <p:spPr>
-          <a:xfrm>
-            <a:off x="1417319" y="1143000"/>
-            <a:ext cx="6309360" cy="2296353"/>
-          </a:xfrm>
-          <a:prstGeom prst="rect">
-            <a:avLst/>
-          </a:prstGeom>
-        </p:spPr>
-      </p:pic>
+              <a:t>NumPy: cálculo sobre arreglos completos</a:t>
+            </a:r>
+          </a:p>
+        </p:txBody>
+      </p:sp>
+      <p:sp>
+        <p:nvSpPr>
+          <p:cNvPr id="4" name="Rectangle 3"/>
+          <p:cNvSpPr/>
+          <p:nvPr/>
+        </p:nvSpPr>
+        <p:spPr>
+          <a:xfrm>
+            <a:off x="704088" y="1280160"/>
+            <a:ext cx="7744968" cy="1874520"/>
+          </a:xfrm>
+          <a:prstGeom prst="rect">
+            <a:avLst/>
+          </a:prstGeom>
+          <a:solidFill>
+            <a:srgbClr val="F0F2F5"/>
+          </a:solidFill>
+          <a:ln>
+            <a:solidFill>
+              <a:srgbClr val="D8DDE3"/>
+            </a:solidFill>
+          </a:ln>
+          <a:effectLst/>
+        </p:spPr>
+        <p:style>
+          <a:lnRef idx="1">
+            <a:schemeClr val="accent1"/>
+          </a:lnRef>
+          <a:fillRef idx="3">
+            <a:schemeClr val="accent1"/>
+          </a:fillRef>
+          <a:effectRef idx="2">
+            <a:schemeClr val="accent1"/>
+          </a:effectRef>
+          <a:fontRef idx="minor">
+            <a:schemeClr val="lt1"/>
+          </a:fontRef>
+        </p:style>
+        <p:txBody>
+          <a:bodyPr rtlCol="0" anchor="ctr" wrap="square" lIns="228600" tIns="137160"/>
+          <a:lstStyle/>
+          <a:p>
+            <a:pPr/>
+            <a:r>
+              <a:rPr sz="1500" b="0">
+                <a:solidFill>
+                  <a:srgbClr val="1D3557"/>
+                </a:solidFill>
+                <a:latin typeface="Menlo"/>
+              </a:rPr>
+              <a:t>import numpy as np</a:t>
+            </a:r>
+          </a:p>
+          <a:p>
+            <a:pPr/>
+            <a:r>
+              <a:rPr sz="1500" b="0">
+                <a:solidFill>
+                  <a:srgbClr val="1D3557"/>
+                </a:solidFill>
+                <a:latin typeface="Menlo"/>
+              </a:rPr>
+              <a:t>tiempos = np.array([70, 105, 90, 25, 40])</a:t>
+            </a:r>
+          </a:p>
+          <a:p>
+            <a:pPr/>
+            <a:r>
+              <a:rPr sz="1500" b="0">
+                <a:solidFill>
+                  <a:srgbClr val="1D3557"/>
+                </a:solidFill>
+                <a:latin typeface="Menlo"/>
+              </a:rPr>
+              <a:t>tiempos.mean()          # 66.0, sin escribir un ciclo</a:t>
+            </a:r>
+          </a:p>
+        </p:txBody>
+      </p:sp>
       <p:sp>
         <p:nvSpPr>
           <p:cNvPr id="5" name="TextBox 4"/>
@@ -5667,8 +5768,8 @@
         </p:nvSpPr>
         <p:spPr>
           <a:xfrm>
-            <a:off x="704088" y="4434840"/>
-            <a:ext cx="7744968" cy="457200"/>
+            <a:off x="704088" y="3383279"/>
+            <a:ext cx="7744968" cy="1097280"/>
           </a:xfrm>
           <a:prstGeom prst="rect">
             <a:avLst/>
@@ -5681,14 +5782,31 @@
           </a:bodyPr>
           <a:lstStyle/>
           <a:p>
-            <a:r>
-              <a:rPr sz="1300" b="0">
-                <a:solidFill>
-                  <a:srgbClr val="333333"/>
-                </a:solidFill>
-                <a:latin typeface="Fira Sans"/>
-              </a:rPr>
-              <a:t>EOD Santiago 2012: 18.264 hogares, 60.054 personas y 113.591 viajes registrados. Cada fila es un viaje; los códigos se resuelven contra tablas de parámetros.</a:t>
+            <a:pPr>
+              <a:lnSpc>
+                <a:spcPct val="112000"/>
+              </a:lnSpc>
+              <a:spcAft>
+                <a:spcPts val="900"/>
+              </a:spcAft>
+            </a:pPr>
+            <a:r>
+              <a:rPr sz="1600" b="1">
+                <a:solidFill>
+                  <a:srgbClr val="E0A437"/>
+                </a:solidFill>
+                <a:latin typeface="Fira Sans"/>
+              </a:rPr>
+              <a:t>▸ </a:t>
+            </a:r>
+            <a:r>
+              <a:rPr sz="1600" b="0">
+                <a:solidFill>
+                  <a:srgbClr val="000000"/>
+                </a:solidFill>
+                <a:latin typeface="Fira Sans"/>
+              </a:rPr>
+              <a:t>La operación se aplica al arreglo completo (vectorización): menos código y mucho más rápido que iterar en Python puro. Es la base sobre la que se construye todo lo demás.</a:t>
             </a:r>
           </a:p>
         </p:txBody>
@@ -5784,7 +5902,7 @@
                 </a:solidFill>
                 <a:latin typeface="Fira Sans"/>
               </a:rPr>
-              <a:t>Pandas: unir tablas con merge</a:t>
+              <a:t>Pandas: la tabla como objeto de trabajo</a:t>
             </a:r>
           </a:p>
         </p:txBody>
@@ -5798,7 +5916,7 @@
         <p:spPr>
           <a:xfrm>
             <a:off x="704088" y="1280160"/>
-            <a:ext cx="7744968" cy="1371600"/>
+            <a:ext cx="7744968" cy="1874520"/>
           </a:xfrm>
           <a:prstGeom prst="rect">
             <a:avLst/>
@@ -5839,7 +5957,7 @@
                 </a:solidFill>
                 <a:latin typeface="Menlo"/>
               </a:rPr>
-              <a:t>comunas = pd.read_csv(URL_COMUNAS)   # Id, Comuna</a:t>
+              <a:t>import pandas as pd</a:t>
             </a:r>
           </a:p>
           <a:p>
@@ -5851,7 +5969,19 @@
                 </a:solidFill>
                 <a:latin typeface="Menlo"/>
               </a:rPr>
-              <a:t>viajes.merge(comunas, left_on="ComunaOrigen", right_on="Id")</a:t>
+              <a:t>viajes = pd.read_csv(URL_VIAJES, sep=";", decimal=",")</a:t>
+            </a:r>
+          </a:p>
+          <a:p>
+            <a:pPr/>
+            <a:r>
+              <a:rPr sz="1500" b="0">
+                <a:solidFill>
+                  <a:srgbClr val="1D3557"/>
+                </a:solidFill>
+                <a:latin typeface="Menlo"/>
+              </a:rPr>
+              <a:t>viajes.head()</a:t>
             </a:r>
           </a:p>
         </p:txBody>
@@ -5864,7 +5994,7 @@
         </p:nvSpPr>
         <p:spPr>
           <a:xfrm>
-            <a:off x="704088" y="2880360"/>
+            <a:off x="704088" y="3383279"/>
             <a:ext cx="7744968" cy="1097280"/>
           </a:xfrm>
           <a:prstGeom prst="rect">
@@ -5902,7 +6032,7 @@
                 </a:solidFill>
                 <a:latin typeface="Fira Sans"/>
               </a:rPr>
-              <a:t>Los códigos de una tabla se traducen uniéndola con su tabla de parámetros: merge empareja filas por una columna común. En el notebook lo usamos para ponerle nombre a comunas y modos de viaje.</a:t>
+              <a:t>El DataFrame es una tabla con columnas etiquetadas, cada una de su propio tipo. Con esas tres líneas se abre la EOD completa: lo haremos en vivo en el notebook de hoy.</a:t>
             </a:r>
           </a:p>
         </p:txBody>
@@ -5998,14 +6128,14 @@
                 </a:solidFill>
                 <a:latin typeface="Fira Sans"/>
               </a:rPr>
-              <a:t>Matplotlib: del DataFrame al gráfico</a:t>
+              <a:t>La Encuesta Origen Destino de Santiago 2012</a:t>
             </a:r>
           </a:p>
         </p:txBody>
       </p:sp>
       <p:pic>
         <p:nvPicPr>
-          <p:cNvPr id="4" name="Picture 3" descr="06_hist_tiempo.png"/>
+          <p:cNvPr id="4" name="Picture 3" descr="02_df_viajes.png"/>
           <p:cNvPicPr>
             <a:picLocks noChangeAspect="1"/>
           </p:cNvPicPr>
@@ -6019,8 +6149,8 @@
         </p:blipFill>
         <p:spPr>
           <a:xfrm>
-            <a:off x="1778310" y="1143000"/>
-            <a:ext cx="5587379" cy="3154680"/>
+            <a:off x="1417319" y="1143000"/>
+            <a:ext cx="6309360" cy="2296353"/>
           </a:xfrm>
           <a:prstGeom prst="rect">
             <a:avLst/>
@@ -6056,7 +6186,7 @@
                 </a:solidFill>
                 <a:latin typeface="Fira Sans"/>
               </a:rPr>
-              <a:t>Este histograma sale de la tabla de viajes con unas seis líneas de código; el notebook de la clase las muestra completas.</a:t>
+              <a:t>EOD Santiago 2012: 18.264 hogares, 60.054 personas y 113.591 viajes registrados. Cada fila es un viaje; los códigos se resuelven contra tablas de parámetros.</a:t>
             </a:r>
           </a:p>
         </p:txBody>
@@ -6152,7 +6282,7 @@
                 </a:solidFill>
                 <a:latin typeface="Fira Sans"/>
               </a:rPr>
-              <a:t>Puesta en marcha del entorno</a:t>
+              <a:t>Pandas: unir tablas con merge</a:t>
             </a:r>
           </a:p>
         </p:txBody>
@@ -6166,7 +6296,7 @@
         <p:spPr>
           <a:xfrm>
             <a:off x="704088" y="1280160"/>
-            <a:ext cx="7744968" cy="2377440"/>
+            <a:ext cx="7744968" cy="1371600"/>
           </a:xfrm>
           <a:prstGeom prst="rect">
             <a:avLst/>
@@ -6207,7 +6337,7 @@
                 </a:solidFill>
                 <a:latin typeface="Menlo"/>
               </a:rPr>
-              <a:t>uv init --bare --python 3.12</a:t>
+              <a:t>comunas = pd.read_csv(URL_COMUNAS)   # Id, Comuna</a:t>
             </a:r>
           </a:p>
           <a:p>
@@ -6219,31 +6349,7 @@
                 </a:solidFill>
                 <a:latin typeface="Menlo"/>
               </a:rPr>
-              <a:t>uv add numpy pandas matplotlib seaborn scipy</a:t>
-            </a:r>
-          </a:p>
-          <a:p>
-            <a:pPr/>
-            <a:r>
-              <a:rPr sz="1500" b="0">
-                <a:solidFill>
-                  <a:srgbClr val="1D3557"/>
-                </a:solidFill>
-                <a:latin typeface="Menlo"/>
-              </a:rPr>
-              <a:t>uv add statsmodels scikit-learn jupyterlab</a:t>
-            </a:r>
-          </a:p>
-          <a:p>
-            <a:pPr/>
-            <a:r>
-              <a:rPr sz="1500" b="0">
-                <a:solidFill>
-                  <a:srgbClr val="1D3557"/>
-                </a:solidFill>
-                <a:latin typeface="Menlo"/>
-              </a:rPr>
-              <a:t>uv run jupyter lab</a:t>
+              <a:t>viajes.merge(comunas, left_on="ComunaOrigen", right_on="Id")</a:t>
             </a:r>
           </a:p>
         </p:txBody>
@@ -6256,7 +6362,7 @@
         </p:nvSpPr>
         <p:spPr>
           <a:xfrm>
-            <a:off x="704088" y="3886200"/>
+            <a:off x="704088" y="2880360"/>
             <a:ext cx="7744968" cy="1097280"/>
           </a:xfrm>
           <a:prstGeom prst="rect">
@@ -6294,7 +6400,7 @@
                 </a:solidFill>
                 <a:latin typeface="Fira Sans"/>
               </a:rPr>
-              <a:t>La guía de instalación del repositorio (github.com/daniopitz/diplomado-cdd) detalla estos pasos por sistema operativo y los problemas frecuentes. Lo hacemos juntos ahora; debe quedar funcionando antes de la clase 2. Alternativa sin instalar nada: Google Colab, con los enlaces del repositorio.</a:t>
+              <a:t>Los códigos de una tabla se traducen uniéndola con su tabla de parámetros: merge empareja filas por una columna común. En el notebook lo usamos para ponerle nombre a comunas y modos de viaje.</a:t>
             </a:r>
           </a:p>
         </p:txBody>
@@ -6390,14 +6496,14 @@
                 </a:solidFill>
                 <a:latin typeface="Fira Sans"/>
               </a:rPr>
-              <a:t>Reparto modal de Santiago, EOD 2012</a:t>
+              <a:t>Matplotlib: del DataFrame al gráfico</a:t>
             </a:r>
           </a:p>
         </p:txBody>
       </p:sp>
       <p:pic>
         <p:nvPicPr>
-          <p:cNvPr id="4" name="Picture 3" descr="01_reparto_modal.png"/>
+          <p:cNvPr id="4" name="Picture 3" descr="06_hist_tiempo.png"/>
           <p:cNvPicPr>
             <a:picLocks noChangeAspect="1"/>
           </p:cNvPicPr>
@@ -6411,8 +6517,8 @@
         </p:blipFill>
         <p:spPr>
           <a:xfrm>
-            <a:off x="1604462" y="1143000"/>
-            <a:ext cx="5935075" cy="3154680"/>
+            <a:off x="1778310" y="1143000"/>
+            <a:ext cx="5587379" cy="3154680"/>
           </a:xfrm>
           <a:prstGeom prst="rect">
             <a:avLst/>
@@ -6448,7 +6554,7 @@
                 </a:solidFill>
                 <a:latin typeface="Fira Sans"/>
               </a:rPr>
-              <a:t>Uno de cada tres viajes es a pie. Esta versión está ponderada por factores de expansión, así que habla de la ciudad; en el notebook calcularemos la versión muestral, y la diferencia entre ambas abre las clases 2 y 3.</a:t>
+              <a:t>Este histograma sale de la tabla de viajes con unas seis líneas de código; el notebook de la clase las muestra completas.</a:t>
             </a:r>
           </a:p>
         </p:txBody>
@@ -6544,21 +6650,45 @@
                 </a:solidFill>
                 <a:latin typeface="Fira Sans"/>
               </a:rPr>
-              <a:t>Síntesis</a:t>
-            </a:r>
-          </a:p>
-        </p:txBody>
-      </p:sp>
-      <p:sp>
-        <p:nvSpPr>
-          <p:cNvPr id="4" name="TextBox 3"/>
+              <a:t>Reparto modal de Santiago, EOD 2012</a:t>
+            </a:r>
+          </a:p>
+        </p:txBody>
+      </p:sp>
+      <p:pic>
+        <p:nvPicPr>
+          <p:cNvPr id="4" name="Picture 3" descr="01_reparto_modal.png"/>
+          <p:cNvPicPr>
+            <a:picLocks noChangeAspect="1"/>
+          </p:cNvPicPr>
+          <p:nvPr/>
+        </p:nvPicPr>
+        <p:blipFill>
+          <a:blip r:embed="rId2"/>
+          <a:stretch>
+            <a:fillRect/>
+          </a:stretch>
+        </p:blipFill>
+        <p:spPr>
+          <a:xfrm>
+            <a:off x="1604462" y="1143000"/>
+            <a:ext cx="5935075" cy="3154680"/>
+          </a:xfrm>
+          <a:prstGeom prst="rect">
+            <a:avLst/>
+          </a:prstGeom>
+        </p:spPr>
+      </p:pic>
+      <p:sp>
+        <p:nvSpPr>
+          <p:cNvPr id="5" name="TextBox 4"/>
           <p:cNvSpPr txBox="1"/>
           <p:nvPr/>
         </p:nvSpPr>
         <p:spPr>
           <a:xfrm>
-            <a:off x="704088" y="1353312"/>
-            <a:ext cx="7744968" cy="3300984"/>
+            <a:off x="704088" y="4434840"/>
+            <a:ext cx="7744968" cy="457200"/>
           </a:xfrm>
           <a:prstGeom prst="rect">
             <a:avLst/>
@@ -6571,143 +6701,14 @@
           </a:bodyPr>
           <a:lstStyle/>
           <a:p>
-            <a:pPr>
-              <a:lnSpc>
-                <a:spcPct val="112000"/>
-              </a:lnSpc>
-              <a:spcAft>
-                <a:spcPts val="900"/>
-              </a:spcAft>
-            </a:pPr>
-            <a:r>
-              <a:rPr sz="1800" b="1">
-                <a:solidFill>
-                  <a:srgbClr val="E0A437"/>
-                </a:solidFill>
-                <a:latin typeface="Fira Sans"/>
-              </a:rPr>
-              <a:t>▸ </a:t>
-            </a:r>
-            <a:r>
-              <a:rPr sz="1800" b="1">
-                <a:solidFill>
-                  <a:srgbClr val="1D3557"/>
-                </a:solidFill>
-                <a:latin typeface="Fira Sans"/>
-              </a:rPr>
-              <a:t>El tipo de cada variable determina qué resúmenes, gráficos y análisis son válidos.</a:t>
-            </a:r>
-          </a:p>
-          <a:p>
-            <a:pPr>
-              <a:lnSpc>
-                <a:spcPct val="112000"/>
-              </a:lnSpc>
-              <a:spcAft>
-                <a:spcPts val="900"/>
-              </a:spcAft>
-            </a:pPr>
-            <a:r>
-              <a:rPr sz="1800" b="1">
-                <a:solidFill>
-                  <a:srgbClr val="E0A437"/>
-                </a:solidFill>
-                <a:latin typeface="Fira Sans"/>
-              </a:rPr>
-              <a:t>▸ </a:t>
-            </a:r>
-            <a:r>
-              <a:rPr sz="1800" b="0">
-                <a:solidFill>
-                  <a:srgbClr val="000000"/>
-                </a:solidFill>
-                <a:latin typeface="Fira Sans"/>
-              </a:rPr>
-              <a:t>Ciencia de datos: extracción generalizable de conocimiento a partir de los datos (Dhar, 2013); combina estadística, computación y dominio.</a:t>
-            </a:r>
-          </a:p>
-          <a:p>
-            <a:pPr>
-              <a:lnSpc>
-                <a:spcPct val="112000"/>
-              </a:lnSpc>
-              <a:spcAft>
-                <a:spcPts val="900"/>
-              </a:spcAft>
-            </a:pPr>
-            <a:r>
-              <a:rPr sz="1800" b="1">
-                <a:solidFill>
-                  <a:srgbClr val="E0A437"/>
-                </a:solidFill>
-                <a:latin typeface="Fira Sans"/>
-              </a:rPr>
-              <a:t>▸ </a:t>
-            </a:r>
-            <a:r>
-              <a:rPr sz="1800" b="0">
-                <a:solidFill>
-                  <a:srgbClr val="000000"/>
-                </a:solidFill>
-                <a:latin typeface="Fira Sans"/>
-              </a:rPr>
-              <a:t>El ciclo de vida tiene dos entradas (una necesidad del dominio o datos disponibles) y se recorre de forma iterativa.</a:t>
-            </a:r>
-          </a:p>
-          <a:p>
-            <a:pPr>
-              <a:lnSpc>
-                <a:spcPct val="112000"/>
-              </a:lnSpc>
-              <a:spcAft>
-                <a:spcPts val="900"/>
-              </a:spcAft>
-            </a:pPr>
-            <a:r>
-              <a:rPr sz="1800" b="1">
-                <a:solidFill>
-                  <a:srgbClr val="E0A437"/>
-                </a:solidFill>
-                <a:latin typeface="Fira Sans"/>
-              </a:rPr>
-              <a:t>▸ </a:t>
-            </a:r>
-            <a:r>
-              <a:rPr sz="1800" b="0">
-                <a:solidFill>
-                  <a:srgbClr val="000000"/>
-                </a:solidFill>
-                <a:latin typeface="Fira Sans"/>
-              </a:rPr>
-              <a:t>La preparación de datos consume cerca de la mitad del tiempo de un proyecto (Anaconda, 2020).</a:t>
-            </a:r>
-          </a:p>
-          <a:p>
-            <a:pPr>
-              <a:lnSpc>
-                <a:spcPct val="112000"/>
-              </a:lnSpc>
-              <a:spcAft>
-                <a:spcPts val="900"/>
-              </a:spcAft>
-            </a:pPr>
-            <a:r>
-              <a:rPr sz="1800" b="1">
-                <a:solidFill>
-                  <a:srgbClr val="E0A437"/>
-                </a:solidFill>
-                <a:latin typeface="Fira Sans"/>
-              </a:rPr>
-              <a:t>▸ </a:t>
-            </a:r>
-            <a:r>
-              <a:rPr sz="1800" b="0">
-                <a:solidFill>
-                  <a:srgbClr val="000000"/>
-                </a:solidFill>
-                <a:latin typeface="Fira Sans"/>
-              </a:rPr>
-              <a:t>Próxima clase (jueves 27): estadística descriptiva, con el entorno ya funcionando.</a:t>
+            <a:r>
+              <a:rPr sz="1300" b="0">
+                <a:solidFill>
+                  <a:srgbClr val="333333"/>
+                </a:solidFill>
+                <a:latin typeface="Fira Sans"/>
+              </a:rPr>
+              <a:t>Uno de cada tres viajes es a pie. Esta versión está ponderada por factores de expansión, así que habla de la ciudad; en el notebook calcularemos la versión muestral, y la diferencia entre ambas abre las clases 2 y 3.</a:t>
             </a:r>
           </a:p>
         </p:txBody>
@@ -6721,6 +6722,265 @@
 </file>
 
 <file path=ppt/slides/slide26.xml><?xml version="1.0" encoding="utf-8"?>
+<p:sld xmlns:a="http://schemas.openxmlformats.org/drawingml/2006/main" xmlns:p="http://schemas.openxmlformats.org/presentationml/2006/main" xmlns:r="http://schemas.openxmlformats.org/officeDocument/2006/relationships">
+  <p:cSld>
+    <p:spTree>
+      <p:nvGrpSpPr>
+        <p:cNvPr id="1" name=""/>
+        <p:cNvGrpSpPr/>
+        <p:nvPr/>
+      </p:nvGrpSpPr>
+      <p:grpSpPr/>
+      <p:sp>
+        <p:nvSpPr>
+          <p:cNvPr id="2" name="Rectangle 1"/>
+          <p:cNvSpPr/>
+          <p:nvPr/>
+        </p:nvSpPr>
+        <p:spPr>
+          <a:xfrm>
+            <a:off x="0" y="0"/>
+            <a:ext cx="9144000" cy="5138928"/>
+          </a:xfrm>
+          <a:prstGeom prst="rect">
+            <a:avLst/>
+          </a:prstGeom>
+          <a:solidFill>
+            <a:srgbClr val="FAFBFC"/>
+          </a:solidFill>
+          <a:ln>
+            <a:noFill/>
+          </a:ln>
+          <a:effectLst/>
+        </p:spPr>
+        <p:style>
+          <a:lnRef idx="1">
+            <a:schemeClr val="accent1"/>
+          </a:lnRef>
+          <a:fillRef idx="3">
+            <a:schemeClr val="accent1"/>
+          </a:fillRef>
+          <a:effectRef idx="2">
+            <a:schemeClr val="accent1"/>
+          </a:effectRef>
+          <a:fontRef idx="minor">
+            <a:schemeClr val="lt1"/>
+          </a:fontRef>
+        </p:style>
+        <p:txBody>
+          <a:bodyPr rtlCol="0" anchor="ctr"/>
+          <a:lstStyle/>
+          <a:p>
+            <a:pPr algn="ctr"/>
+          </a:p>
+        </p:txBody>
+      </p:sp>
+      <p:sp>
+        <p:nvSpPr>
+          <p:cNvPr id="3" name="TextBox 2"/>
+          <p:cNvSpPr txBox="1"/>
+          <p:nvPr/>
+        </p:nvSpPr>
+        <p:spPr>
+          <a:xfrm>
+            <a:off x="402336" y="301752"/>
+            <a:ext cx="8348472" cy="795528"/>
+          </a:xfrm>
+          <a:prstGeom prst="rect">
+            <a:avLst/>
+          </a:prstGeom>
+          <a:noFill/>
+        </p:spPr>
+        <p:txBody>
+          <a:bodyPr wrap="square">
+            <a:spAutoFit/>
+          </a:bodyPr>
+          <a:lstStyle/>
+          <a:p>
+            <a:r>
+              <a:rPr sz="2800" b="1">
+                <a:solidFill>
+                  <a:srgbClr val="0F0F0F"/>
+                </a:solidFill>
+                <a:latin typeface="Fira Sans"/>
+              </a:rPr>
+              <a:t>Síntesis</a:t>
+            </a:r>
+          </a:p>
+        </p:txBody>
+      </p:sp>
+      <p:sp>
+        <p:nvSpPr>
+          <p:cNvPr id="4" name="TextBox 3"/>
+          <p:cNvSpPr txBox="1"/>
+          <p:nvPr/>
+        </p:nvSpPr>
+        <p:spPr>
+          <a:xfrm>
+            <a:off x="704088" y="1353312"/>
+            <a:ext cx="7744968" cy="3300984"/>
+          </a:xfrm>
+          <a:prstGeom prst="rect">
+            <a:avLst/>
+          </a:prstGeom>
+          <a:noFill/>
+        </p:spPr>
+        <p:txBody>
+          <a:bodyPr wrap="square">
+            <a:spAutoFit/>
+          </a:bodyPr>
+          <a:lstStyle/>
+          <a:p>
+            <a:pPr>
+              <a:lnSpc>
+                <a:spcPct val="112000"/>
+              </a:lnSpc>
+              <a:spcAft>
+                <a:spcPts val="900"/>
+              </a:spcAft>
+            </a:pPr>
+            <a:r>
+              <a:rPr sz="1800" b="1">
+                <a:solidFill>
+                  <a:srgbClr val="E0A437"/>
+                </a:solidFill>
+                <a:latin typeface="Fira Sans"/>
+              </a:rPr>
+              <a:t>▸ </a:t>
+            </a:r>
+            <a:r>
+              <a:rPr sz="1800" b="1">
+                <a:solidFill>
+                  <a:srgbClr val="1D3557"/>
+                </a:solidFill>
+                <a:latin typeface="Fira Sans"/>
+              </a:rPr>
+              <a:t>El tipo de cada variable determina qué resúmenes, gráficos y análisis son válidos.</a:t>
+            </a:r>
+          </a:p>
+          <a:p>
+            <a:pPr>
+              <a:lnSpc>
+                <a:spcPct val="112000"/>
+              </a:lnSpc>
+              <a:spcAft>
+                <a:spcPts val="900"/>
+              </a:spcAft>
+            </a:pPr>
+            <a:r>
+              <a:rPr sz="1800" b="1">
+                <a:solidFill>
+                  <a:srgbClr val="E0A437"/>
+                </a:solidFill>
+                <a:latin typeface="Fira Sans"/>
+              </a:rPr>
+              <a:t>▸ </a:t>
+            </a:r>
+            <a:r>
+              <a:rPr sz="1800" b="0">
+                <a:solidFill>
+                  <a:srgbClr val="000000"/>
+                </a:solidFill>
+                <a:latin typeface="Fira Sans"/>
+              </a:rPr>
+              <a:t>Ciencia de datos: extracción generalizable de conocimiento a partir de los datos (Dhar, 2013); combina estadística, computación y dominio.</a:t>
+            </a:r>
+          </a:p>
+          <a:p>
+            <a:pPr>
+              <a:lnSpc>
+                <a:spcPct val="112000"/>
+              </a:lnSpc>
+              <a:spcAft>
+                <a:spcPts val="900"/>
+              </a:spcAft>
+            </a:pPr>
+            <a:r>
+              <a:rPr sz="1800" b="1">
+                <a:solidFill>
+                  <a:srgbClr val="E0A437"/>
+                </a:solidFill>
+                <a:latin typeface="Fira Sans"/>
+              </a:rPr>
+              <a:t>▸ </a:t>
+            </a:r>
+            <a:r>
+              <a:rPr sz="1800" b="0">
+                <a:solidFill>
+                  <a:srgbClr val="000000"/>
+                </a:solidFill>
+                <a:latin typeface="Fira Sans"/>
+              </a:rPr>
+              <a:t>El ciclo de vida tiene dos entradas (una necesidad del dominio o datos disponibles) y se recorre de forma iterativa.</a:t>
+            </a:r>
+          </a:p>
+          <a:p>
+            <a:pPr>
+              <a:lnSpc>
+                <a:spcPct val="112000"/>
+              </a:lnSpc>
+              <a:spcAft>
+                <a:spcPts val="900"/>
+              </a:spcAft>
+            </a:pPr>
+            <a:r>
+              <a:rPr sz="1800" b="1">
+                <a:solidFill>
+                  <a:srgbClr val="E0A437"/>
+                </a:solidFill>
+                <a:latin typeface="Fira Sans"/>
+              </a:rPr>
+              <a:t>▸ </a:t>
+            </a:r>
+            <a:r>
+              <a:rPr sz="1800" b="0">
+                <a:solidFill>
+                  <a:srgbClr val="000000"/>
+                </a:solidFill>
+                <a:latin typeface="Fira Sans"/>
+              </a:rPr>
+              <a:t>La preparación de datos consume cerca de la mitad del tiempo de un proyecto (Anaconda, 2020).</a:t>
+            </a:r>
+          </a:p>
+          <a:p>
+            <a:pPr>
+              <a:lnSpc>
+                <a:spcPct val="112000"/>
+              </a:lnSpc>
+              <a:spcAft>
+                <a:spcPts val="900"/>
+              </a:spcAft>
+            </a:pPr>
+            <a:r>
+              <a:rPr sz="1800" b="1">
+                <a:solidFill>
+                  <a:srgbClr val="E0A437"/>
+                </a:solidFill>
+                <a:latin typeface="Fira Sans"/>
+              </a:rPr>
+              <a:t>▸ </a:t>
+            </a:r>
+            <a:r>
+              <a:rPr sz="1800" b="0">
+                <a:solidFill>
+                  <a:srgbClr val="000000"/>
+                </a:solidFill>
+                <a:latin typeface="Fira Sans"/>
+              </a:rPr>
+              <a:t>Próxima clase (jueves 27): estadística descriptiva, con el entorno ya funcionando.</a:t>
+            </a:r>
+          </a:p>
+        </p:txBody>
+      </p:sp>
+    </p:spTree>
+  </p:cSld>
+  <p:clrMapOvr>
+    <a:masterClrMapping/>
+  </p:clrMapOvr>
+</p:sld>
+</file>
+
+<file path=ppt/slides/slide27.xml><?xml version="1.0" encoding="utf-8"?>
 <p:sld xmlns:a="http://schemas.openxmlformats.org/drawingml/2006/main" xmlns:p="http://schemas.openxmlformats.org/presentationml/2006/main" xmlns:r="http://schemas.openxmlformats.org/officeDocument/2006/relationships">
   <p:cSld>
     <p:spTree>

</xml_diff>

<commit_message>
Notebook: opciones de merge con diagrama, sección de factor de expansión resuelta, apply y scatter; slides de Pandas con DataFrame real, otras herramientas y tres gráficos básicos
Co-Authored-By: Claude Fable 5 <noreply@anthropic.com>
</commit_message>
<xml_diff>
--- a/presentaciones/clase01_fundamentos_ecosistema.pptx
+++ b/presentaciones/clase01_fundamentos_ecosistema.pptx
@@ -5915,8 +5915,8 @@
         </p:nvSpPr>
         <p:spPr>
           <a:xfrm>
-            <a:off x="704088" y="1280160"/>
-            <a:ext cx="7744968" cy="1874520"/>
+            <a:off x="704088" y="1143000"/>
+            <a:ext cx="7744968" cy="1325880"/>
           </a:xfrm>
           <a:prstGeom prst="rect">
             <a:avLst/>
@@ -5946,12 +5946,12 @@
           </a:fontRef>
         </p:style>
         <p:txBody>
-          <a:bodyPr rtlCol="0" anchor="ctr" wrap="square" lIns="228600" tIns="137160"/>
-          <a:lstStyle/>
-          <a:p>
-            <a:pPr/>
-            <a:r>
-              <a:rPr sz="1500" b="0">
+          <a:bodyPr rtlCol="0" anchor="ctr" wrap="square" lIns="228600" tIns="109728"/>
+          <a:lstStyle/>
+          <a:p>
+            <a:pPr algn="l"/>
+            <a:r>
+              <a:rPr sz="1400" b="0">
                 <a:solidFill>
                   <a:srgbClr val="1D3557"/>
                 </a:solidFill>
@@ -5961,9 +5961,9 @@
             </a:r>
           </a:p>
           <a:p>
-            <a:pPr/>
-            <a:r>
-              <a:rPr sz="1500" b="0">
+            <a:pPr algn="l"/>
+            <a:r>
+              <a:rPr sz="1400" b="0">
                 <a:solidFill>
                   <a:srgbClr val="1D3557"/>
                 </a:solidFill>
@@ -5973,9 +5973,9 @@
             </a:r>
           </a:p>
           <a:p>
-            <a:pPr/>
-            <a:r>
-              <a:rPr sz="1500" b="0">
+            <a:pPr algn="l"/>
+            <a:r>
+              <a:rPr sz="1400" b="0">
                 <a:solidFill>
                   <a:srgbClr val="1D3557"/>
                 </a:solidFill>
@@ -5986,16 +5986,40 @@
           </a:p>
         </p:txBody>
       </p:sp>
-      <p:sp>
-        <p:nvSpPr>
-          <p:cNvPr id="5" name="TextBox 4"/>
+      <p:pic>
+        <p:nvPicPr>
+          <p:cNvPr id="5" name="Picture 4" descr="02_df_viajes.png"/>
+          <p:cNvPicPr>
+            <a:picLocks noChangeAspect="1"/>
+          </p:cNvPicPr>
+          <p:nvPr/>
+        </p:nvPicPr>
+        <p:blipFill>
+          <a:blip r:embed="rId2"/>
+          <a:stretch>
+            <a:fillRect/>
+          </a:stretch>
+        </p:blipFill>
+        <p:spPr>
+          <a:xfrm>
+            <a:off x="1828800" y="2606040"/>
+            <a:ext cx="5486400" cy="1996828"/>
+          </a:xfrm>
+          <a:prstGeom prst="rect">
+            <a:avLst/>
+          </a:prstGeom>
+        </p:spPr>
+      </p:pic>
+      <p:sp>
+        <p:nvSpPr>
+          <p:cNvPr id="6" name="TextBox 5"/>
           <p:cNvSpPr txBox="1"/>
           <p:nvPr/>
         </p:nvSpPr>
         <p:spPr>
           <a:xfrm>
-            <a:off x="704088" y="3383279"/>
-            <a:ext cx="7744968" cy="1097280"/>
+            <a:off x="704088" y="4590288"/>
+            <a:ext cx="7744968" cy="502920"/>
           </a:xfrm>
           <a:prstGeom prst="rect">
             <a:avLst/>
@@ -6008,31 +6032,14 @@
           </a:bodyPr>
           <a:lstStyle/>
           <a:p>
-            <a:pPr>
-              <a:lnSpc>
-                <a:spcPct val="112000"/>
-              </a:lnSpc>
-              <a:spcAft>
-                <a:spcPts val="900"/>
-              </a:spcAft>
-            </a:pPr>
-            <a:r>
-              <a:rPr sz="1600" b="1">
-                <a:solidFill>
-                  <a:srgbClr val="E0A437"/>
-                </a:solidFill>
-                <a:latin typeface="Fira Sans"/>
-              </a:rPr>
-              <a:t>▸ </a:t>
-            </a:r>
-            <a:r>
-              <a:rPr sz="1600" b="0">
-                <a:solidFill>
-                  <a:srgbClr val="000000"/>
-                </a:solidFill>
-                <a:latin typeface="Fira Sans"/>
-              </a:rPr>
-              <a:t>El DataFrame es una tabla con columnas etiquetadas, cada una de su propio tipo. Con esas tres líneas se abre la EOD completa: lo haremos en vivo en el notebook de hoy.</a:t>
+            <a:r>
+              <a:rPr sz="1300" b="0">
+                <a:solidFill>
+                  <a:srgbClr val="333333"/>
+                </a:solidFill>
+                <a:latin typeface="Fira Sans"/>
+              </a:rPr>
+              <a:t>Con esas tres líneas se abre la EOD 2012 completa: 18.264 hogares, 60.054 personas y 113.591 viajes. Cada columna es una variable de su propio tipo.</a:t>
             </a:r>
           </a:p>
         </p:txBody>
@@ -6128,35 +6135,78 @@
                 </a:solidFill>
                 <a:latin typeface="Fira Sans"/>
               </a:rPr>
-              <a:t>La Encuesta Origen Destino de Santiago 2012</a:t>
-            </a:r>
-          </a:p>
-        </p:txBody>
-      </p:sp>
-      <p:pic>
-        <p:nvPicPr>
-          <p:cNvPr id="4" name="Picture 3" descr="02_df_viajes.png"/>
-          <p:cNvPicPr>
-            <a:picLocks noChangeAspect="1"/>
-          </p:cNvPicPr>
-          <p:nvPr/>
-        </p:nvPicPr>
-        <p:blipFill>
-          <a:blip r:embed="rId2"/>
-          <a:stretch>
-            <a:fillRect/>
-          </a:stretch>
-        </p:blipFill>
-        <p:spPr>
-          <a:xfrm>
-            <a:off x="1417319" y="1143000"/>
-            <a:ext cx="6309360" cy="2296353"/>
-          </a:xfrm>
-          <a:prstGeom prst="rect">
-            <a:avLst/>
-          </a:prstGeom>
-        </p:spPr>
-      </p:pic>
+              <a:t>Pandas: unir tablas con merge</a:t>
+            </a:r>
+          </a:p>
+        </p:txBody>
+      </p:sp>
+      <p:sp>
+        <p:nvSpPr>
+          <p:cNvPr id="4" name="Rectangle 3"/>
+          <p:cNvSpPr/>
+          <p:nvPr/>
+        </p:nvSpPr>
+        <p:spPr>
+          <a:xfrm>
+            <a:off x="704088" y="1280160"/>
+            <a:ext cx="7744968" cy="1371600"/>
+          </a:xfrm>
+          <a:prstGeom prst="rect">
+            <a:avLst/>
+          </a:prstGeom>
+          <a:solidFill>
+            <a:srgbClr val="F0F2F5"/>
+          </a:solidFill>
+          <a:ln>
+            <a:solidFill>
+              <a:srgbClr val="D8DDE3"/>
+            </a:solidFill>
+          </a:ln>
+          <a:effectLst/>
+        </p:spPr>
+        <p:style>
+          <a:lnRef idx="1">
+            <a:schemeClr val="accent1"/>
+          </a:lnRef>
+          <a:fillRef idx="3">
+            <a:schemeClr val="accent1"/>
+          </a:fillRef>
+          <a:effectRef idx="2">
+            <a:schemeClr val="accent1"/>
+          </a:effectRef>
+          <a:fontRef idx="minor">
+            <a:schemeClr val="lt1"/>
+          </a:fontRef>
+        </p:style>
+        <p:txBody>
+          <a:bodyPr rtlCol="0" anchor="ctr" wrap="square" lIns="228600" tIns="137160"/>
+          <a:lstStyle/>
+          <a:p>
+            <a:pPr/>
+            <a:r>
+              <a:rPr sz="1500" b="0">
+                <a:solidFill>
+                  <a:srgbClr val="1D3557"/>
+                </a:solidFill>
+                <a:latin typeface="Menlo"/>
+              </a:rPr>
+              <a:t>comunas = pd.read_csv(URL_COMUNAS)   # Id, Comuna</a:t>
+            </a:r>
+          </a:p>
+          <a:p>
+            <a:pPr/>
+            <a:r>
+              <a:rPr sz="1500" b="0">
+                <a:solidFill>
+                  <a:srgbClr val="1D3557"/>
+                </a:solidFill>
+                <a:latin typeface="Menlo"/>
+              </a:rPr>
+              <a:t>viajes.merge(comunas, left_on="ComunaOrigen", right_on="Id")</a:t>
+            </a:r>
+          </a:p>
+        </p:txBody>
+      </p:sp>
       <p:sp>
         <p:nvSpPr>
           <p:cNvPr id="5" name="TextBox 4"/>
@@ -6165,8 +6215,8 @@
         </p:nvSpPr>
         <p:spPr>
           <a:xfrm>
-            <a:off x="704088" y="4434840"/>
-            <a:ext cx="7744968" cy="457200"/>
+            <a:off x="704088" y="2880360"/>
+            <a:ext cx="7744968" cy="1097280"/>
           </a:xfrm>
           <a:prstGeom prst="rect">
             <a:avLst/>
@@ -6179,14 +6229,31 @@
           </a:bodyPr>
           <a:lstStyle/>
           <a:p>
-            <a:r>
-              <a:rPr sz="1300" b="0">
-                <a:solidFill>
-                  <a:srgbClr val="333333"/>
-                </a:solidFill>
-                <a:latin typeface="Fira Sans"/>
-              </a:rPr>
-              <a:t>EOD Santiago 2012: 18.264 hogares, 60.054 personas y 113.591 viajes registrados. Cada fila es un viaje; los códigos se resuelven contra tablas de parámetros.</a:t>
+            <a:pPr>
+              <a:lnSpc>
+                <a:spcPct val="112000"/>
+              </a:lnSpc>
+              <a:spcAft>
+                <a:spcPts val="900"/>
+              </a:spcAft>
+            </a:pPr>
+            <a:r>
+              <a:rPr sz="1600" b="1">
+                <a:solidFill>
+                  <a:srgbClr val="E0A437"/>
+                </a:solidFill>
+                <a:latin typeface="Fira Sans"/>
+              </a:rPr>
+              <a:t>▸ </a:t>
+            </a:r>
+            <a:r>
+              <a:rPr sz="1600" b="0">
+                <a:solidFill>
+                  <a:srgbClr val="000000"/>
+                </a:solidFill>
+                <a:latin typeface="Fira Sans"/>
+              </a:rPr>
+              <a:t>Los códigos de una tabla se traducen uniéndola con su tabla de parámetros: merge empareja filas por una columna común. En el notebook lo usamos para ponerle nombre a comunas y modos de viaje.</a:t>
             </a:r>
           </a:p>
         </p:txBody>
@@ -6282,88 +6349,21 @@
                 </a:solidFill>
                 <a:latin typeface="Fira Sans"/>
               </a:rPr>
-              <a:t>Pandas: unir tablas con merge</a:t>
-            </a:r>
-          </a:p>
-        </p:txBody>
-      </p:sp>
-      <p:sp>
-        <p:nvSpPr>
-          <p:cNvPr id="4" name="Rectangle 3"/>
-          <p:cNvSpPr/>
-          <p:nvPr/>
-        </p:nvSpPr>
-        <p:spPr>
-          <a:xfrm>
-            <a:off x="704088" y="1280160"/>
-            <a:ext cx="7744968" cy="1371600"/>
-          </a:xfrm>
-          <a:prstGeom prst="rect">
-            <a:avLst/>
-          </a:prstGeom>
-          <a:solidFill>
-            <a:srgbClr val="F0F2F5"/>
-          </a:solidFill>
-          <a:ln>
-            <a:solidFill>
-              <a:srgbClr val="D8DDE3"/>
-            </a:solidFill>
-          </a:ln>
-          <a:effectLst/>
-        </p:spPr>
-        <p:style>
-          <a:lnRef idx="1">
-            <a:schemeClr val="accent1"/>
-          </a:lnRef>
-          <a:fillRef idx="3">
-            <a:schemeClr val="accent1"/>
-          </a:fillRef>
-          <a:effectRef idx="2">
-            <a:schemeClr val="accent1"/>
-          </a:effectRef>
-          <a:fontRef idx="minor">
-            <a:schemeClr val="lt1"/>
-          </a:fontRef>
-        </p:style>
-        <p:txBody>
-          <a:bodyPr rtlCol="0" anchor="ctr" wrap="square" lIns="228600" tIns="137160"/>
-          <a:lstStyle/>
-          <a:p>
-            <a:pPr/>
-            <a:r>
-              <a:rPr sz="1500" b="0">
-                <a:solidFill>
-                  <a:srgbClr val="1D3557"/>
-                </a:solidFill>
-                <a:latin typeface="Menlo"/>
-              </a:rPr>
-              <a:t>comunas = pd.read_csv(URL_COMUNAS)   # Id, Comuna</a:t>
-            </a:r>
-          </a:p>
-          <a:p>
-            <a:pPr/>
-            <a:r>
-              <a:rPr sz="1500" b="0">
-                <a:solidFill>
-                  <a:srgbClr val="1D3557"/>
-                </a:solidFill>
-                <a:latin typeface="Menlo"/>
-              </a:rPr>
-              <a:t>viajes.merge(comunas, left_on="ComunaOrigen", right_on="Id")</a:t>
-            </a:r>
-          </a:p>
-        </p:txBody>
-      </p:sp>
-      <p:sp>
-        <p:nvSpPr>
-          <p:cNvPr id="5" name="TextBox 4"/>
+              <a:t>El DataFrame no es exclusivo de Pandas</a:t>
+            </a:r>
+          </a:p>
+        </p:txBody>
+      </p:sp>
+      <p:sp>
+        <p:nvSpPr>
+          <p:cNvPr id="4" name="TextBox 3"/>
           <p:cNvSpPr txBox="1"/>
           <p:nvPr/>
         </p:nvSpPr>
         <p:spPr>
           <a:xfrm>
-            <a:off x="704088" y="2880360"/>
-            <a:ext cx="7744968" cy="1097280"/>
+            <a:off x="704088" y="1353312"/>
+            <a:ext cx="7744968" cy="3300984"/>
           </a:xfrm>
           <a:prstGeom prst="rect">
             <a:avLst/>
@@ -6385,7 +6385,7 @@
               </a:spcAft>
             </a:pPr>
             <a:r>
-              <a:rPr sz="1600" b="1">
+              <a:rPr sz="1800" b="1">
                 <a:solidFill>
                   <a:srgbClr val="E0A437"/>
                 </a:solidFill>
@@ -6394,13 +6394,153 @@
               <a:t>▸ </a:t>
             </a:r>
             <a:r>
-              <a:rPr sz="1600" b="0">
+              <a:rPr sz="1800" b="0">
                 <a:solidFill>
                   <a:srgbClr val="000000"/>
                 </a:solidFill>
                 <a:latin typeface="Fira Sans"/>
               </a:rPr>
-              <a:t>Los códigos de una tabla se traducen uniéndola con su tabla de parámetros: merge empareja filas por una columna común. En el notebook lo usamos para ponerle nombre a comunas y modos de viaje.</a:t>
+              <a:t>Varias herramientas usan la misma abstracción de tabla, y Pandas no siempre es la mejor opción cuando los datos crecen:</a:t>
+            </a:r>
+          </a:p>
+          <a:p>
+            <a:pPr>
+              <a:lnSpc>
+                <a:spcPct val="112000"/>
+              </a:lnSpc>
+              <a:spcAft>
+                <a:spcPts val="500"/>
+              </a:spcAft>
+            </a:pPr>
+            <a:r>
+              <a:rPr sz="1400" b="0">
+                <a:solidFill>
+                  <a:srgbClr val="333333"/>
+                </a:solidFill>
+                <a:latin typeface="Fira Sans"/>
+              </a:rPr>
+              <a:t>     ◦  </a:t>
+            </a:r>
+            <a:r>
+              <a:rPr sz="1400" b="0">
+                <a:solidFill>
+                  <a:srgbClr val="333333"/>
+                </a:solidFill>
+                <a:latin typeface="Fira Sans"/>
+              </a:rPr>
+              <a:t>Polars: DataFrames implementados en Rust, más rápidos y eficientes en memoria.</a:t>
+            </a:r>
+          </a:p>
+          <a:p>
+            <a:pPr>
+              <a:lnSpc>
+                <a:spcPct val="112000"/>
+              </a:lnSpc>
+              <a:spcAft>
+                <a:spcPts val="500"/>
+              </a:spcAft>
+            </a:pPr>
+            <a:r>
+              <a:rPr sz="1400" b="0">
+                <a:solidFill>
+                  <a:srgbClr val="333333"/>
+                </a:solidFill>
+                <a:latin typeface="Fira Sans"/>
+              </a:rPr>
+              <a:t>     ◦  </a:t>
+            </a:r>
+            <a:r>
+              <a:rPr sz="1400" b="0">
+                <a:solidFill>
+                  <a:srgbClr val="333333"/>
+                </a:solidFill>
+                <a:latin typeface="Fira Sans"/>
+              </a:rPr>
+              <a:t>Apache Spark: DataFrames distribuidos en un clúster, para volúmenes que no caben en una máquina.</a:t>
+            </a:r>
+          </a:p>
+          <a:p>
+            <a:pPr>
+              <a:lnSpc>
+                <a:spcPct val="112000"/>
+              </a:lnSpc>
+              <a:spcAft>
+                <a:spcPts val="500"/>
+              </a:spcAft>
+            </a:pPr>
+            <a:r>
+              <a:rPr sz="1400" b="0">
+                <a:solidFill>
+                  <a:srgbClr val="333333"/>
+                </a:solidFill>
+                <a:latin typeface="Fira Sans"/>
+              </a:rPr>
+              <a:t>     ◦  </a:t>
+            </a:r>
+            <a:r>
+              <a:rPr sz="1400" b="0">
+                <a:solidFill>
+                  <a:srgbClr val="333333"/>
+                </a:solidFill>
+                <a:latin typeface="Fira Sans"/>
+              </a:rPr>
+              <a:t>Dask: paraleliza la interfaz de Pandas sobre varios núcleos o máquinas.</a:t>
+            </a:r>
+          </a:p>
+          <a:p>
+            <a:pPr>
+              <a:lnSpc>
+                <a:spcPct val="112000"/>
+              </a:lnSpc>
+              <a:spcAft>
+                <a:spcPts val="500"/>
+              </a:spcAft>
+            </a:pPr>
+            <a:r>
+              <a:rPr sz="1400" b="0">
+                <a:solidFill>
+                  <a:srgbClr val="333333"/>
+                </a:solidFill>
+                <a:latin typeface="Fira Sans"/>
+              </a:rPr>
+              <a:t>     ◦  </a:t>
+            </a:r>
+            <a:r>
+              <a:rPr sz="1400" b="0">
+                <a:solidFill>
+                  <a:srgbClr val="333333"/>
+                </a:solidFill>
+                <a:latin typeface="Fira Sans"/>
+              </a:rPr>
+              <a:t>DuckDB: consultas SQL directas sobre archivos y DataFrames.</a:t>
+            </a:r>
+          </a:p>
+          <a:p>
+            <a:pPr>
+              <a:lnSpc>
+                <a:spcPct val="112000"/>
+              </a:lnSpc>
+              <a:spcAft>
+                <a:spcPts val="900"/>
+              </a:spcAft>
+            </a:pPr>
+            <a:r>
+              <a:rPr sz="1800" b="1">
+                <a:solidFill>
+                  <a:srgbClr val="E0A437"/>
+                </a:solidFill>
+                <a:latin typeface="Fira Sans"/>
+              </a:rPr>
+              <a:t>▸ </a:t>
+            </a:r>
+            <a:r>
+              <a:rPr sz="1800" b="0">
+                <a:solidFill>
+                  <a:srgbClr val="000000"/>
+                </a:solidFill>
+                <a:latin typeface="Fira Sans"/>
+              </a:rPr>
+              <a:t>En este módulo usamos Pandas: es el estándar para el análisis interactivo con datos de tamaño pequeño y mediano, y su interfaz es la referencia que las demás herramientas siguen.</a:t>
             </a:r>
           </a:p>
         </p:txBody>
@@ -6496,14 +6636,14 @@
                 </a:solidFill>
                 <a:latin typeface="Fira Sans"/>
               </a:rPr>
-              <a:t>Matplotlib: del DataFrame al gráfico</a:t>
+              <a:t>Matplotlib: tres gráficos básicos</a:t>
             </a:r>
           </a:p>
         </p:txBody>
       </p:sp>
       <p:pic>
         <p:nvPicPr>
-          <p:cNvPr id="4" name="Picture 3" descr="06_hist_tiempo.png"/>
+          <p:cNvPr id="4" name="Picture 3" descr="11_tres_graficos.png"/>
           <p:cNvPicPr>
             <a:picLocks noChangeAspect="1"/>
           </p:cNvPicPr>
@@ -6517,8 +6657,8 @@
         </p:blipFill>
         <p:spPr>
           <a:xfrm>
-            <a:off x="1778310" y="1143000"/>
-            <a:ext cx="5587379" cy="3154680"/>
+            <a:off x="1417319" y="1143000"/>
+            <a:ext cx="6309360" cy="1854976"/>
           </a:xfrm>
           <a:prstGeom prst="rect">
             <a:avLst/>
@@ -6554,7 +6694,7 @@
                 </a:solidFill>
                 <a:latin typeface="Fira Sans"/>
               </a:rPr>
-              <a:t>Este histograma sale de la tabla de viajes con unas seis líneas de código; el notebook de la clase las muestra completas.</a:t>
+              <a:t>El gráfico depende del tipo de variable: barras para una cualitativa, histograma para una cuantitativa, dispersión para dos cuantitativas. Los tres salen de la tabla de viajes y se construyen en el notebook.</a:t>
             </a:r>
           </a:p>
         </p:txBody>

</xml_diff>

<commit_message>
Flujo de instalación con git clone y uv sync; slide de opciones con logos, Colab como opción 1
Co-Authored-By: Claude Fable 5 <noreply@anthropic.com>
</commit_message>
<xml_diff>
--- a/presentaciones/clase01_fundamentos_ecosistema.pptx
+++ b/presentaciones/clase01_fundamentos_ecosistema.pptx
@@ -4927,14 +4927,84 @@
       </p:sp>
       <p:sp>
         <p:nvSpPr>
-          <p:cNvPr id="4" name="TextBox 3"/>
+          <p:cNvPr id="4" name="Rectangle 3"/>
+          <p:cNvSpPr/>
+          <p:nvPr/>
+        </p:nvSpPr>
+        <p:spPr>
+          <a:xfrm>
+            <a:off x="502920" y="1143000"/>
+            <a:ext cx="3931920" cy="3246120"/>
+          </a:xfrm>
+          <a:prstGeom prst="rect">
+            <a:avLst/>
+          </a:prstGeom>
+          <a:solidFill>
+            <a:srgbClr val="FFFFFF"/>
+          </a:solidFill>
+          <a:ln>
+            <a:solidFill>
+              <a:srgbClr val="D8DDE3"/>
+            </a:solidFill>
+          </a:ln>
+          <a:effectLst/>
+        </p:spPr>
+        <p:style>
+          <a:lnRef idx="1">
+            <a:schemeClr val="accent1"/>
+          </a:lnRef>
+          <a:fillRef idx="3">
+            <a:schemeClr val="accent1"/>
+          </a:fillRef>
+          <a:effectRef idx="2">
+            <a:schemeClr val="accent1"/>
+          </a:effectRef>
+          <a:fontRef idx="minor">
+            <a:schemeClr val="lt1"/>
+          </a:fontRef>
+        </p:style>
+        <p:txBody>
+          <a:bodyPr rtlCol="0" anchor="ctr"/>
+          <a:lstStyle/>
+          <a:p>
+            <a:pPr algn="ctr"/>
+          </a:p>
+        </p:txBody>
+      </p:sp>
+      <p:pic>
+        <p:nvPicPr>
+          <p:cNvPr id="5" name="Picture 4" descr="colab_logo.png"/>
+          <p:cNvPicPr>
+            <a:picLocks noChangeAspect="1"/>
+          </p:cNvPicPr>
+          <p:nvPr/>
+        </p:nvPicPr>
+        <p:blipFill>
+          <a:blip r:embed="rId2"/>
+          <a:stretch>
+            <a:fillRect/>
+          </a:stretch>
+        </p:blipFill>
+        <p:spPr>
+          <a:xfrm>
+            <a:off x="2103120" y="1371600"/>
+            <a:ext cx="731520" cy="731520"/>
+          </a:xfrm>
+          <a:prstGeom prst="rect">
+            <a:avLst/>
+          </a:prstGeom>
+        </p:spPr>
+      </p:pic>
+      <p:sp>
+        <p:nvSpPr>
+          <p:cNvPr id="6" name="TextBox 5"/>
           <p:cNvSpPr txBox="1"/>
           <p:nvPr/>
         </p:nvSpPr>
         <p:spPr>
           <a:xfrm>
-            <a:off x="704088" y="1353312"/>
-            <a:ext cx="7744968" cy="3300984"/>
+            <a:off x="731520" y="2194560"/>
+            <a:ext cx="3474720" cy="457200"/>
           </a:xfrm>
           <a:prstGeom prst="rect">
             <a:avLst/>
@@ -4947,16 +5017,51 @@
           </a:bodyPr>
           <a:lstStyle/>
           <a:p>
+            <a:pPr algn="ctr"/>
+            <a:r>
+              <a:rPr sz="1700" b="1">
+                <a:solidFill>
+                  <a:srgbClr val="1D3557"/>
+                </a:solidFill>
+                <a:latin typeface="Fira Sans"/>
+              </a:rPr>
+              <a:t>Opción 1 · Google Colab</a:t>
+            </a:r>
+          </a:p>
+        </p:txBody>
+      </p:sp>
+      <p:sp>
+        <p:nvSpPr>
+          <p:cNvPr id="7" name="TextBox 6"/>
+          <p:cNvSpPr txBox="1"/>
+          <p:nvPr/>
+        </p:nvSpPr>
+        <p:spPr>
+          <a:xfrm>
+            <a:off x="777240" y="2697480"/>
+            <a:ext cx="3383280" cy="1600200"/>
+          </a:xfrm>
+          <a:prstGeom prst="rect">
+            <a:avLst/>
+          </a:prstGeom>
+          <a:noFill/>
+        </p:spPr>
+        <p:txBody>
+          <a:bodyPr wrap="square">
+            <a:spAutoFit/>
+          </a:bodyPr>
+          <a:lstStyle/>
+          <a:p>
             <a:pPr>
               <a:lnSpc>
-                <a:spcPct val="112000"/>
+                <a:spcPct val="110000"/>
               </a:lnSpc>
               <a:spcAft>
-                <a:spcPts val="900"/>
+                <a:spcPts val="600"/>
               </a:spcAft>
             </a:pPr>
             <a:r>
-              <a:rPr sz="1800" b="1">
+              <a:rPr sz="1250" b="1">
                 <a:solidFill>
                   <a:srgbClr val="E0A437"/>
                 </a:solidFill>
@@ -4965,26 +5070,26 @@
               <a:t>▸ </a:t>
             </a:r>
             <a:r>
-              <a:rPr sz="1800" b="1">
-                <a:solidFill>
-                  <a:srgbClr val="1D3557"/>
-                </a:solidFill>
-                <a:latin typeface="Fira Sans"/>
-              </a:rPr>
-              <a:t>Opción A, entorno local: uv administra Python y las librerías, y se trabaja en JupyterLab.</a:t>
+              <a:rPr sz="1250" b="0">
+                <a:solidFill>
+                  <a:srgbClr val="000000"/>
+                </a:solidFill>
+                <a:latin typeface="Fira Sans"/>
+              </a:rPr>
+              <a:t>Los notebooks corren en la nube, sin instalar nada.</a:t>
             </a:r>
           </a:p>
           <a:p>
             <a:pPr>
               <a:lnSpc>
-                <a:spcPct val="112000"/>
+                <a:spcPct val="110000"/>
               </a:lnSpc>
               <a:spcAft>
-                <a:spcPts val="900"/>
+                <a:spcPts val="600"/>
               </a:spcAft>
             </a:pPr>
             <a:r>
-              <a:rPr sz="1800" b="1">
+              <a:rPr sz="1250" b="1">
                 <a:solidFill>
                   <a:srgbClr val="E0A437"/>
                 </a:solidFill>
@@ -4993,26 +5098,26 @@
               <a:t>▸ </a:t>
             </a:r>
             <a:r>
-              <a:rPr sz="1800" b="0">
+              <a:rPr sz="1250" b="0">
                 <a:solidFill>
                   <a:srgbClr val="000000"/>
                 </a:solidFill>
                 <a:latin typeface="Fira Sans"/>
               </a:rPr>
-              <a:t>La guía de instalación del repositorio detalla los pasos por sistema operativo y los problemas frecuentes.</a:t>
+              <a:t>Se abren con los enlaces del README del repositorio.</a:t>
             </a:r>
           </a:p>
           <a:p>
             <a:pPr>
               <a:lnSpc>
-                <a:spcPct val="112000"/>
+                <a:spcPct val="110000"/>
               </a:lnSpc>
               <a:spcAft>
-                <a:spcPts val="900"/>
+                <a:spcPts val="600"/>
               </a:spcAft>
             </a:pPr>
             <a:r>
-              <a:rPr sz="1800" b="1">
+              <a:rPr sz="1250" b="1">
                 <a:solidFill>
                   <a:srgbClr val="E0A437"/>
                 </a:solidFill>
@@ -5021,26 +5126,154 @@
               <a:t>▸ </a:t>
             </a:r>
             <a:r>
-              <a:rPr sz="1800" b="1">
+              <a:rPr sz="1250" b="0">
+                <a:solidFill>
+                  <a:srgbClr val="000000"/>
+                </a:solidFill>
+                <a:latin typeface="Fira Sans"/>
+              </a:rPr>
+              <a:t>Solo requiere una cuenta de Google.</a:t>
+            </a:r>
+          </a:p>
+        </p:txBody>
+      </p:sp>
+      <p:sp>
+        <p:nvSpPr>
+          <p:cNvPr id="8" name="Rectangle 7"/>
+          <p:cNvSpPr/>
+          <p:nvPr/>
+        </p:nvSpPr>
+        <p:spPr>
+          <a:xfrm>
+            <a:off x="4709160" y="1143000"/>
+            <a:ext cx="3931920" cy="3246120"/>
+          </a:xfrm>
+          <a:prstGeom prst="rect">
+            <a:avLst/>
+          </a:prstGeom>
+          <a:solidFill>
+            <a:srgbClr val="FFFFFF"/>
+          </a:solidFill>
+          <a:ln>
+            <a:solidFill>
+              <a:srgbClr val="D8DDE3"/>
+            </a:solidFill>
+          </a:ln>
+          <a:effectLst/>
+        </p:spPr>
+        <p:style>
+          <a:lnRef idx="1">
+            <a:schemeClr val="accent1"/>
+          </a:lnRef>
+          <a:fillRef idx="3">
+            <a:schemeClr val="accent1"/>
+          </a:fillRef>
+          <a:effectRef idx="2">
+            <a:schemeClr val="accent1"/>
+          </a:effectRef>
+          <a:fontRef idx="minor">
+            <a:schemeClr val="lt1"/>
+          </a:fontRef>
+        </p:style>
+        <p:txBody>
+          <a:bodyPr rtlCol="0" anchor="ctr"/>
+          <a:lstStyle/>
+          <a:p>
+            <a:pPr algn="ctr"/>
+          </a:p>
+        </p:txBody>
+      </p:sp>
+      <p:pic>
+        <p:nvPicPr>
+          <p:cNvPr id="9" name="Picture 8" descr="github_mark.png"/>
+          <p:cNvPicPr>
+            <a:picLocks noChangeAspect="1"/>
+          </p:cNvPicPr>
+          <p:nvPr/>
+        </p:nvPicPr>
+        <p:blipFill>
+          <a:blip r:embed="rId3"/>
+          <a:stretch>
+            <a:fillRect/>
+          </a:stretch>
+        </p:blipFill>
+        <p:spPr>
+          <a:xfrm>
+            <a:off x="6309360" y="1371600"/>
+            <a:ext cx="731520" cy="731520"/>
+          </a:xfrm>
+          <a:prstGeom prst="rect">
+            <a:avLst/>
+          </a:prstGeom>
+        </p:spPr>
+      </p:pic>
+      <p:sp>
+        <p:nvSpPr>
+          <p:cNvPr id="10" name="TextBox 9"/>
+          <p:cNvSpPr txBox="1"/>
+          <p:nvPr/>
+        </p:nvSpPr>
+        <p:spPr>
+          <a:xfrm>
+            <a:off x="4937760" y="2194560"/>
+            <a:ext cx="3474720" cy="457200"/>
+          </a:xfrm>
+          <a:prstGeom prst="rect">
+            <a:avLst/>
+          </a:prstGeom>
+          <a:noFill/>
+        </p:spPr>
+        <p:txBody>
+          <a:bodyPr wrap="square">
+            <a:spAutoFit/>
+          </a:bodyPr>
+          <a:lstStyle/>
+          <a:p>
+            <a:pPr algn="ctr"/>
+            <a:r>
+              <a:rPr sz="1700" b="1">
                 <a:solidFill>
                   <a:srgbClr val="1D3557"/>
                 </a:solidFill>
                 <a:latin typeface="Fira Sans"/>
               </a:rPr>
-              <a:t>Opción B, Google Colab: los notebooks corren en la nube, sin instalar nada; se abren con los enlaces del README del repositorio.</a:t>
-            </a:r>
-          </a:p>
+              <a:t>Opción 2 · Entorno local</a:t>
+            </a:r>
+          </a:p>
+        </p:txBody>
+      </p:sp>
+      <p:sp>
+        <p:nvSpPr>
+          <p:cNvPr id="11" name="TextBox 10"/>
+          <p:cNvSpPr txBox="1"/>
+          <p:nvPr/>
+        </p:nvSpPr>
+        <p:spPr>
+          <a:xfrm>
+            <a:off x="4983480" y="2697480"/>
+            <a:ext cx="3383280" cy="1600200"/>
+          </a:xfrm>
+          <a:prstGeom prst="rect">
+            <a:avLst/>
+          </a:prstGeom>
+          <a:noFill/>
+        </p:spPr>
+        <p:txBody>
+          <a:bodyPr wrap="square">
+            <a:spAutoFit/>
+          </a:bodyPr>
+          <a:lstStyle/>
           <a:p>
             <a:pPr>
               <a:lnSpc>
-                <a:spcPct val="112000"/>
+                <a:spcPct val="110000"/>
               </a:lnSpc>
               <a:spcAft>
-                <a:spcPts val="900"/>
+                <a:spcPts val="600"/>
               </a:spcAft>
             </a:pPr>
             <a:r>
-              <a:rPr sz="1800" b="1">
+              <a:rPr sz="1250" b="1">
                 <a:solidFill>
                   <a:srgbClr val="E0A437"/>
                 </a:solidFill>
@@ -5049,26 +5282,26 @@
               <a:t>▸ </a:t>
             </a:r>
             <a:r>
-              <a:rPr sz="1800" b="0">
+              <a:rPr sz="1250" b="0">
                 <a:solidFill>
                   <a:srgbClr val="000000"/>
                 </a:solidFill>
                 <a:latin typeface="Fira Sans"/>
               </a:rPr>
-              <a:t>Solo requiere una cuenta de Google. Es la alternativa si su computador tiene restricciones de instalación.</a:t>
+              <a:t>Se clona el repositorio del curso desde GitHub y uv sync instala Python y todas las librerías.</a:t>
             </a:r>
           </a:p>
           <a:p>
             <a:pPr>
               <a:lnSpc>
-                <a:spcPct val="112000"/>
+                <a:spcPct val="110000"/>
               </a:lnSpc>
               <a:spcAft>
-                <a:spcPts val="900"/>
+                <a:spcPts val="600"/>
               </a:spcAft>
             </a:pPr>
             <a:r>
-              <a:rPr sz="1800" b="1">
+              <a:rPr sz="1250" b="1">
                 <a:solidFill>
                   <a:srgbClr val="E0A437"/>
                 </a:solidFill>
@@ -5077,13 +5310,75 @@
               <a:t>▸ </a:t>
             </a:r>
             <a:r>
-              <a:rPr sz="1800" b="0">
+              <a:rPr sz="1250" b="0">
                 <a:solidFill>
                   <a:srgbClr val="000000"/>
                 </a:solidFill>
                 <a:latin typeface="Fira Sans"/>
               </a:rPr>
-              <a:t>Ambas opciones usan los mismos notebooks y los mismos datos (se leen desde una URL). Material en github.com/daniopitz/diplomado-cdd</a:t>
+              <a:t>Todo el material queda descargado: notebooks, datos y guía.</a:t>
+            </a:r>
+          </a:p>
+          <a:p>
+            <a:pPr>
+              <a:lnSpc>
+                <a:spcPct val="110000"/>
+              </a:lnSpc>
+              <a:spcAft>
+                <a:spcPts val="600"/>
+              </a:spcAft>
+            </a:pPr>
+            <a:r>
+              <a:rPr sz="1250" b="1">
+                <a:solidFill>
+                  <a:srgbClr val="E0A437"/>
+                </a:solidFill>
+                <a:latin typeface="Fira Sans"/>
+              </a:rPr>
+              <a:t>▸ </a:t>
+            </a:r>
+            <a:r>
+              <a:rPr sz="1250" b="0">
+                <a:solidFill>
+                  <a:srgbClr val="000000"/>
+                </a:solidFill>
+                <a:latin typeface="Fira Sans"/>
+              </a:rPr>
+              <a:t>Se trabaja en JupyterLab.</a:t>
+            </a:r>
+          </a:p>
+        </p:txBody>
+      </p:sp>
+      <p:sp>
+        <p:nvSpPr>
+          <p:cNvPr id="12" name="TextBox 11"/>
+          <p:cNvSpPr txBox="1"/>
+          <p:nvPr/>
+        </p:nvSpPr>
+        <p:spPr>
+          <a:xfrm>
+            <a:off x="502920" y="4526280"/>
+            <a:ext cx="8138160" cy="457200"/>
+          </a:xfrm>
+          <a:prstGeom prst="rect">
+            <a:avLst/>
+          </a:prstGeom>
+          <a:noFill/>
+        </p:spPr>
+        <p:txBody>
+          <a:bodyPr wrap="square">
+            <a:spAutoFit/>
+          </a:bodyPr>
+          <a:lstStyle/>
+          <a:p>
+            <a:r>
+              <a:rPr sz="1250" b="0">
+                <a:solidFill>
+                  <a:srgbClr val="333333"/>
+                </a:solidFill>
+                <a:latin typeface="Fira Sans"/>
+              </a:rPr>
+              <a:t>Ambas opciones usan los mismos notebooks y los mismos datos. Material en github.com/daniopitz/diplomado-cdd</a:t>
             </a:r>
           </a:p>
         </p:txBody>
@@ -5234,7 +5529,7 @@
                 </a:solidFill>
                 <a:latin typeface="Menlo"/>
               </a:rPr>
-              <a:t>uv init --bare --python 3.12</a:t>
+              <a:t>git clone https://github.com/daniopitz/diplomado-cdd.git</a:t>
             </a:r>
           </a:p>
           <a:p>
@@ -5246,7 +5541,7 @@
                 </a:solidFill>
                 <a:latin typeface="Menlo"/>
               </a:rPr>
-              <a:t>uv add numpy pandas matplotlib seaborn scipy</a:t>
+              <a:t>cd diplomado-cdd</a:t>
             </a:r>
           </a:p>
           <a:p>
@@ -5258,7 +5553,7 @@
                 </a:solidFill>
                 <a:latin typeface="Menlo"/>
               </a:rPr>
-              <a:t>uv add statsmodels scikit-learn jupyterlab</a:t>
+              <a:t>uv sync</a:t>
             </a:r>
           </a:p>
           <a:p>
@@ -5321,7 +5616,7 @@
                 </a:solidFill>
                 <a:latin typeface="Fira Sans"/>
               </a:rPr>
-              <a:t>Lo hacemos juntos ahora; debe quedar funcionando antes de la clase 2. Si algo falla, siga la clase en Colab y revise después la sección de problemas frecuentes de la guía, o escríbanos.</a:t>
+              <a:t>uv sync instala Python 3.12 y las versiones exactas de las librerías, fijadas en el repositorio; git pull trae el material nuevo cada semana. Sin git: en GitHub, Code &gt; Download ZIP. Lo hacemos juntos ahora; si algo falla, siga la clase en Colab y debe quedar funcionando antes de la clase 2.</a:t>
             </a:r>
           </a:p>
         </p:txBody>

</xml_diff>

<commit_message>
VS Code como entorno de las clases; instrucción de guardar copia en Drive para Colab
Co-Authored-By: Claude Fable 5 <noreply@anthropic.com>
</commit_message>
<xml_diff>
--- a/presentaciones/clase01_fundamentos_ecosistema.pptx
+++ b/presentaciones/clase01_fundamentos_ecosistema.pptx
@@ -5132,7 +5132,35 @@
                 </a:solidFill>
                 <a:latin typeface="Fira Sans"/>
               </a:rPr>
-              <a:t>Solo requiere una cuenta de Google.</a:t>
+              <a:t>Requiere una cuenta de Google.</a:t>
+            </a:r>
+          </a:p>
+          <a:p>
+            <a:pPr>
+              <a:lnSpc>
+                <a:spcPct val="110000"/>
+              </a:lnSpc>
+              <a:spcAft>
+                <a:spcPts val="600"/>
+              </a:spcAft>
+            </a:pPr>
+            <a:r>
+              <a:rPr sz="1250" b="1">
+                <a:solidFill>
+                  <a:srgbClr val="E0A437"/>
+                </a:solidFill>
+                <a:latin typeface="Fira Sans"/>
+              </a:rPr>
+              <a:t>▸ </a:t>
+            </a:r>
+            <a:r>
+              <a:rPr sz="1250" b="0">
+                <a:solidFill>
+                  <a:srgbClr val="000000"/>
+                </a:solidFill>
+                <a:latin typeface="Fira Sans"/>
+              </a:rPr>
+              <a:t>Guarde su copia en una carpeta de su Drive.</a:t>
             </a:r>
           </a:p>
         </p:txBody>
@@ -5344,7 +5372,7 @@
                 </a:solidFill>
                 <a:latin typeface="Fira Sans"/>
               </a:rPr>
-              <a:t>Se trabaja en JupyterLab.</a:t>
+              <a:t>Se trabaja en VS Code (así se dictan las clases) o en JupyterLab.</a:t>
             </a:r>
           </a:p>
         </p:txBody>
@@ -5616,7 +5644,7 @@
                 </a:solidFill>
                 <a:latin typeface="Fira Sans"/>
               </a:rPr>
-              <a:t>uv sync instala Python 3.12 y las versiones exactas de las librerías, fijadas en el repositorio; git pull trae el material nuevo cada semana. Sin git: en GitHub, Code &gt; Download ZIP. Lo hacemos juntos ahora; si algo falla, siga la clase en Colab y debe quedar funcionando antes de la clase 2.</a:t>
+              <a:t>uv sync instala Python 3.12 y las librerías con las versiones fijadas en el repositorio; git pull trae el material nuevo cada semana (sin git: Code &gt; Download ZIP). En las clases se trabaja en VS Code con la extensión Jupyter; JupyterLab es la alternativa sin configuración adicional.</a:t>
             </a:r>
           </a:p>
         </p:txBody>

</xml_diff>

<commit_message>
JupyterLab como paso opcional; VS Code primero en la verificación de la guía
Co-Authored-By: Claude Fable 5 <noreply@anthropic.com>
</commit_message>
<xml_diff>
--- a/presentaciones/clase01_fundamentos_ecosistema.pptx
+++ b/presentaciones/clase01_fundamentos_ecosistema.pptx
@@ -5593,7 +5593,7 @@
                 </a:solidFill>
                 <a:latin typeface="Menlo"/>
               </a:rPr>
-              <a:t>uv run jupyter lab</a:t>
+              <a:t>uv run jupyter lab   # opcional, solo si no usa VS Code</a:t>
             </a:r>
           </a:p>
         </p:txBody>
@@ -5644,7 +5644,7 @@
                 </a:solidFill>
                 <a:latin typeface="Fira Sans"/>
               </a:rPr>
-              <a:t>uv sync instala Python 3.12 y las librerías con las versiones fijadas en el repositorio; git pull trae el material nuevo cada semana (sin git: Code &gt; Download ZIP). En las clases se trabaja en VS Code con la extensión Jupyter; JupyterLab es la alternativa sin configuración adicional.</a:t>
+              <a:t>uv sync instala Python 3.12 y las librerías con las versiones fijadas en el repositorio; git pull trae el material nuevo cada semana (sin git: Code &gt; Download ZIP). En las clases se trabaja en VS Code: basta abrir la carpeta y elegir el kernel de .venv, sin comandos adicionales.</a:t>
             </a:r>
           </a:p>
         </p:txBody>

</xml_diff>

<commit_message>
Plantilla limpia restaurada con la celda de where prellenada; ejercicio final ponderado con gráfico; factor de expansión explicado en notebook y slide
Co-Authored-By: Claude Fable 5 <noreply@anthropic.com>
</commit_message>
<xml_diff>
--- a/presentaciones/clase01_fundamentos_ecosistema.pptx
+++ b/presentaciones/clase01_fundamentos_ecosistema.pptx
@@ -32,6 +32,7 @@
     <p:sldId id="280" r:id="rId31"/>
     <p:sldId id="281" r:id="rId32"/>
     <p:sldId id="282" r:id="rId33"/>
+    <p:sldId id="283" r:id="rId34"/>
   </p:sldIdLst>
   <p:sldSz cx="9144000" cy="5138928" type="screen4x3"/>
   <p:notesSz cx="6858000" cy="9144000"/>
@@ -7113,45 +7114,21 @@
                 </a:solidFill>
                 <a:latin typeface="Fira Sans"/>
               </a:rPr>
-              <a:t>Reparto modal de Santiago, EOD 2012</a:t>
-            </a:r>
-          </a:p>
-        </p:txBody>
-      </p:sp>
-      <p:pic>
-        <p:nvPicPr>
-          <p:cNvPr id="4" name="Picture 3" descr="01_reparto_modal.png"/>
-          <p:cNvPicPr>
-            <a:picLocks noChangeAspect="1"/>
-          </p:cNvPicPr>
-          <p:nvPr/>
-        </p:nvPicPr>
-        <p:blipFill>
-          <a:blip r:embed="rId2"/>
-          <a:stretch>
-            <a:fillRect/>
-          </a:stretch>
-        </p:blipFill>
-        <p:spPr>
-          <a:xfrm>
-            <a:off x="1604462" y="1143000"/>
-            <a:ext cx="5935075" cy="3154680"/>
-          </a:xfrm>
-          <a:prstGeom prst="rect">
-            <a:avLst/>
-          </a:prstGeom>
-        </p:spPr>
-      </p:pic>
-      <p:sp>
-        <p:nvSpPr>
-          <p:cNvPr id="5" name="TextBox 4"/>
+              <a:t>El factor de expansión</a:t>
+            </a:r>
+          </a:p>
+        </p:txBody>
+      </p:sp>
+      <p:sp>
+        <p:nvSpPr>
+          <p:cNvPr id="4" name="TextBox 3"/>
           <p:cNvSpPr txBox="1"/>
           <p:nvPr/>
         </p:nvSpPr>
         <p:spPr>
           <a:xfrm>
-            <a:off x="704088" y="4434840"/>
-            <a:ext cx="7744968" cy="457200"/>
+            <a:off x="704088" y="1353312"/>
+            <a:ext cx="7744968" cy="3300984"/>
           </a:xfrm>
           <a:prstGeom prst="rect">
             <a:avLst/>
@@ -7164,14 +7141,143 @@
           </a:bodyPr>
           <a:lstStyle/>
           <a:p>
-            <a:r>
-              <a:rPr sz="1300" b="0">
-                <a:solidFill>
-                  <a:srgbClr val="333333"/>
-                </a:solidFill>
-                <a:latin typeface="Fira Sans"/>
-              </a:rPr>
-              <a:t>Uno de cada tres viajes es a pie. Esta versión está ponderada por factores de expansión, así que habla de la ciudad; en el notebook calcularemos la versión muestral, y la diferencia entre ambas abre las clases 2 y 3.</a:t>
+            <a:pPr>
+              <a:lnSpc>
+                <a:spcPct val="112000"/>
+              </a:lnSpc>
+              <a:spcAft>
+                <a:spcPts val="900"/>
+              </a:spcAft>
+            </a:pPr>
+            <a:r>
+              <a:rPr sz="1800" b="1">
+                <a:solidFill>
+                  <a:srgbClr val="E0A437"/>
+                </a:solidFill>
+                <a:latin typeface="Fira Sans"/>
+              </a:rPr>
+              <a:t>▸ </a:t>
+            </a:r>
+            <a:r>
+              <a:rPr sz="1800" b="0">
+                <a:solidFill>
+                  <a:srgbClr val="000000"/>
+                </a:solidFill>
+                <a:latin typeface="Fira Sans"/>
+              </a:rPr>
+              <a:t>Una encuesta entrevista a una muestra: la EOD, a 60.054 personas de los 6,65 millones de habitantes que cubre.</a:t>
+            </a:r>
+          </a:p>
+          <a:p>
+            <a:pPr>
+              <a:lnSpc>
+                <a:spcPct val="112000"/>
+              </a:lnSpc>
+              <a:spcAft>
+                <a:spcPts val="900"/>
+              </a:spcAft>
+            </a:pPr>
+            <a:r>
+              <a:rPr sz="1800" b="1">
+                <a:solidFill>
+                  <a:srgbClr val="E0A437"/>
+                </a:solidFill>
+                <a:latin typeface="Fira Sans"/>
+              </a:rPr>
+              <a:t>▸ </a:t>
+            </a:r>
+            <a:r>
+              <a:rPr sz="1800" b="0">
+                <a:solidFill>
+                  <a:srgbClr val="000000"/>
+                </a:solidFill>
+                <a:latin typeface="Fira Sans"/>
+              </a:rPr>
+              <a:t>El factor de expansión de cada persona indica a cuántos habitantes representa; sale del diseño muestral (comuna, sexo, edad).</a:t>
+            </a:r>
+          </a:p>
+          <a:p>
+            <a:pPr>
+              <a:lnSpc>
+                <a:spcPct val="112000"/>
+              </a:lnSpc>
+              <a:spcAft>
+                <a:spcPts val="900"/>
+              </a:spcAft>
+            </a:pPr>
+            <a:r>
+              <a:rPr sz="1800" b="1">
+                <a:solidFill>
+                  <a:srgbClr val="E0A437"/>
+                </a:solidFill>
+                <a:latin typeface="Fira Sans"/>
+              </a:rPr>
+              <a:t>▸ </a:t>
+            </a:r>
+            <a:r>
+              <a:rPr sz="1800" b="0">
+                <a:solidFill>
+                  <a:srgbClr val="000000"/>
+                </a:solidFill>
+                <a:latin typeface="Fira Sans"/>
+              </a:rPr>
+              <a:t>La suma de los factores reproduce la población: en la EOD, Factor_LaboralNormal suma 6.651.735.</a:t>
+            </a:r>
+          </a:p>
+          <a:p>
+            <a:pPr>
+              <a:lnSpc>
+                <a:spcPct val="112000"/>
+              </a:lnSpc>
+              <a:spcAft>
+                <a:spcPts val="900"/>
+              </a:spcAft>
+            </a:pPr>
+            <a:r>
+              <a:rPr sz="1800" b="1">
+                <a:solidFill>
+                  <a:srgbClr val="E0A437"/>
+                </a:solidFill>
+                <a:latin typeface="Fira Sans"/>
+              </a:rPr>
+              <a:t>▸ </a:t>
+            </a:r>
+            <a:r>
+              <a:rPr sz="1800" b="1">
+                <a:solidFill>
+                  <a:srgbClr val="1D3557"/>
+                </a:solidFill>
+                <a:latin typeface="Fira Sans"/>
+              </a:rPr>
+              <a:t>Todo resumen tiene dos versiones: muestral (contar filas) y ponderada (sumar factores). ¿De quién habla cada número?</a:t>
+            </a:r>
+          </a:p>
+          <a:p>
+            <a:pPr>
+              <a:lnSpc>
+                <a:spcPct val="112000"/>
+              </a:lnSpc>
+              <a:spcAft>
+                <a:spcPts val="900"/>
+              </a:spcAft>
+            </a:pPr>
+            <a:r>
+              <a:rPr sz="1800" b="1">
+                <a:solidFill>
+                  <a:srgbClr val="E0A437"/>
+                </a:solidFill>
+                <a:latin typeface="Fira Sans"/>
+              </a:rPr>
+              <a:t>▸ </a:t>
+            </a:r>
+            <a:r>
+              <a:rPr sz="1800" b="0">
+                <a:solidFill>
+                  <a:srgbClr val="000000"/>
+                </a:solidFill>
+                <a:latin typeface="Fira Sans"/>
+              </a:rPr>
+              <a:t>En el notebook: 52,8% de mujeres en la muestra, 51,5% ponderado.</a:t>
             </a:r>
           </a:p>
         </p:txBody>
@@ -7267,21 +7373,45 @@
                 </a:solidFill>
                 <a:latin typeface="Fira Sans"/>
               </a:rPr>
-              <a:t>Síntesis</a:t>
-            </a:r>
-          </a:p>
-        </p:txBody>
-      </p:sp>
-      <p:sp>
-        <p:nvSpPr>
-          <p:cNvPr id="4" name="TextBox 3"/>
+              <a:t>Reparto modal de Santiago, EOD 2012</a:t>
+            </a:r>
+          </a:p>
+        </p:txBody>
+      </p:sp>
+      <p:pic>
+        <p:nvPicPr>
+          <p:cNvPr id="4" name="Picture 3" descr="01_reparto_modal.png"/>
+          <p:cNvPicPr>
+            <a:picLocks noChangeAspect="1"/>
+          </p:cNvPicPr>
+          <p:nvPr/>
+        </p:nvPicPr>
+        <p:blipFill>
+          <a:blip r:embed="rId2"/>
+          <a:stretch>
+            <a:fillRect/>
+          </a:stretch>
+        </p:blipFill>
+        <p:spPr>
+          <a:xfrm>
+            <a:off x="1604462" y="1143000"/>
+            <a:ext cx="5935075" cy="3154680"/>
+          </a:xfrm>
+          <a:prstGeom prst="rect">
+            <a:avLst/>
+          </a:prstGeom>
+        </p:spPr>
+      </p:pic>
+      <p:sp>
+        <p:nvSpPr>
+          <p:cNvPr id="5" name="TextBox 4"/>
           <p:cNvSpPr txBox="1"/>
           <p:nvPr/>
         </p:nvSpPr>
         <p:spPr>
           <a:xfrm>
-            <a:off x="704088" y="1353312"/>
-            <a:ext cx="7744968" cy="3300984"/>
+            <a:off x="704088" y="4434840"/>
+            <a:ext cx="7744968" cy="457200"/>
           </a:xfrm>
           <a:prstGeom prst="rect">
             <a:avLst/>
@@ -7294,143 +7424,14 @@
           </a:bodyPr>
           <a:lstStyle/>
           <a:p>
-            <a:pPr>
-              <a:lnSpc>
-                <a:spcPct val="112000"/>
-              </a:lnSpc>
-              <a:spcAft>
-                <a:spcPts val="900"/>
-              </a:spcAft>
-            </a:pPr>
-            <a:r>
-              <a:rPr sz="1800" b="1">
-                <a:solidFill>
-                  <a:srgbClr val="E0A437"/>
-                </a:solidFill>
-                <a:latin typeface="Fira Sans"/>
-              </a:rPr>
-              <a:t>▸ </a:t>
-            </a:r>
-            <a:r>
-              <a:rPr sz="1800" b="1">
-                <a:solidFill>
-                  <a:srgbClr val="1D3557"/>
-                </a:solidFill>
-                <a:latin typeface="Fira Sans"/>
-              </a:rPr>
-              <a:t>El tipo de cada variable determina qué resúmenes, gráficos y análisis son válidos.</a:t>
-            </a:r>
-          </a:p>
-          <a:p>
-            <a:pPr>
-              <a:lnSpc>
-                <a:spcPct val="112000"/>
-              </a:lnSpc>
-              <a:spcAft>
-                <a:spcPts val="900"/>
-              </a:spcAft>
-            </a:pPr>
-            <a:r>
-              <a:rPr sz="1800" b="1">
-                <a:solidFill>
-                  <a:srgbClr val="E0A437"/>
-                </a:solidFill>
-                <a:latin typeface="Fira Sans"/>
-              </a:rPr>
-              <a:t>▸ </a:t>
-            </a:r>
-            <a:r>
-              <a:rPr sz="1800" b="0">
-                <a:solidFill>
-                  <a:srgbClr val="000000"/>
-                </a:solidFill>
-                <a:latin typeface="Fira Sans"/>
-              </a:rPr>
-              <a:t>Ciencia de datos: extracción generalizable de conocimiento a partir de los datos (Dhar, 2013); combina estadística, computación y dominio.</a:t>
-            </a:r>
-          </a:p>
-          <a:p>
-            <a:pPr>
-              <a:lnSpc>
-                <a:spcPct val="112000"/>
-              </a:lnSpc>
-              <a:spcAft>
-                <a:spcPts val="900"/>
-              </a:spcAft>
-            </a:pPr>
-            <a:r>
-              <a:rPr sz="1800" b="1">
-                <a:solidFill>
-                  <a:srgbClr val="E0A437"/>
-                </a:solidFill>
-                <a:latin typeface="Fira Sans"/>
-              </a:rPr>
-              <a:t>▸ </a:t>
-            </a:r>
-            <a:r>
-              <a:rPr sz="1800" b="0">
-                <a:solidFill>
-                  <a:srgbClr val="000000"/>
-                </a:solidFill>
-                <a:latin typeface="Fira Sans"/>
-              </a:rPr>
-              <a:t>El ciclo de vida tiene dos entradas (una necesidad del dominio o datos disponibles) y se recorre de forma iterativa.</a:t>
-            </a:r>
-          </a:p>
-          <a:p>
-            <a:pPr>
-              <a:lnSpc>
-                <a:spcPct val="112000"/>
-              </a:lnSpc>
-              <a:spcAft>
-                <a:spcPts val="900"/>
-              </a:spcAft>
-            </a:pPr>
-            <a:r>
-              <a:rPr sz="1800" b="1">
-                <a:solidFill>
-                  <a:srgbClr val="E0A437"/>
-                </a:solidFill>
-                <a:latin typeface="Fira Sans"/>
-              </a:rPr>
-              <a:t>▸ </a:t>
-            </a:r>
-            <a:r>
-              <a:rPr sz="1800" b="0">
-                <a:solidFill>
-                  <a:srgbClr val="000000"/>
-                </a:solidFill>
-                <a:latin typeface="Fira Sans"/>
-              </a:rPr>
-              <a:t>La preparación de datos consume cerca de la mitad del tiempo de un proyecto (Anaconda, 2020).</a:t>
-            </a:r>
-          </a:p>
-          <a:p>
-            <a:pPr>
-              <a:lnSpc>
-                <a:spcPct val="112000"/>
-              </a:lnSpc>
-              <a:spcAft>
-                <a:spcPts val="900"/>
-              </a:spcAft>
-            </a:pPr>
-            <a:r>
-              <a:rPr sz="1800" b="1">
-                <a:solidFill>
-                  <a:srgbClr val="E0A437"/>
-                </a:solidFill>
-                <a:latin typeface="Fira Sans"/>
-              </a:rPr>
-              <a:t>▸ </a:t>
-            </a:r>
-            <a:r>
-              <a:rPr sz="1800" b="0">
-                <a:solidFill>
-                  <a:srgbClr val="000000"/>
-                </a:solidFill>
-                <a:latin typeface="Fira Sans"/>
-              </a:rPr>
-              <a:t>Próxima clase (jueves 27): estadística descriptiva, con el entorno ya funcionando.</a:t>
+            <a:r>
+              <a:rPr sz="1300" b="0">
+                <a:solidFill>
+                  <a:srgbClr val="333333"/>
+                </a:solidFill>
+                <a:latin typeface="Fira Sans"/>
+              </a:rPr>
+              <a:t>Uno de cada tres viajes es a pie. Esta versión está ponderada por factores de expansión, así que habla de la ciudad; en el notebook calcularemos la versión muestral, y la diferencia entre ambas abre las clases 2 y 3.</a:t>
             </a:r>
           </a:p>
         </p:txBody>
@@ -7444,6 +7445,265 @@
 </file>
 
 <file path=ppt/slides/slide27.xml><?xml version="1.0" encoding="utf-8"?>
+<p:sld xmlns:a="http://schemas.openxmlformats.org/drawingml/2006/main" xmlns:p="http://schemas.openxmlformats.org/presentationml/2006/main" xmlns:r="http://schemas.openxmlformats.org/officeDocument/2006/relationships">
+  <p:cSld>
+    <p:spTree>
+      <p:nvGrpSpPr>
+        <p:cNvPr id="1" name=""/>
+        <p:cNvGrpSpPr/>
+        <p:nvPr/>
+      </p:nvGrpSpPr>
+      <p:grpSpPr/>
+      <p:sp>
+        <p:nvSpPr>
+          <p:cNvPr id="2" name="Rectangle 1"/>
+          <p:cNvSpPr/>
+          <p:nvPr/>
+        </p:nvSpPr>
+        <p:spPr>
+          <a:xfrm>
+            <a:off x="0" y="0"/>
+            <a:ext cx="9144000" cy="5138928"/>
+          </a:xfrm>
+          <a:prstGeom prst="rect">
+            <a:avLst/>
+          </a:prstGeom>
+          <a:solidFill>
+            <a:srgbClr val="FAFBFC"/>
+          </a:solidFill>
+          <a:ln>
+            <a:noFill/>
+          </a:ln>
+          <a:effectLst/>
+        </p:spPr>
+        <p:style>
+          <a:lnRef idx="1">
+            <a:schemeClr val="accent1"/>
+          </a:lnRef>
+          <a:fillRef idx="3">
+            <a:schemeClr val="accent1"/>
+          </a:fillRef>
+          <a:effectRef idx="2">
+            <a:schemeClr val="accent1"/>
+          </a:effectRef>
+          <a:fontRef idx="minor">
+            <a:schemeClr val="lt1"/>
+          </a:fontRef>
+        </p:style>
+        <p:txBody>
+          <a:bodyPr rtlCol="0" anchor="ctr"/>
+          <a:lstStyle/>
+          <a:p>
+            <a:pPr algn="ctr"/>
+          </a:p>
+        </p:txBody>
+      </p:sp>
+      <p:sp>
+        <p:nvSpPr>
+          <p:cNvPr id="3" name="TextBox 2"/>
+          <p:cNvSpPr txBox="1"/>
+          <p:nvPr/>
+        </p:nvSpPr>
+        <p:spPr>
+          <a:xfrm>
+            <a:off x="402336" y="301752"/>
+            <a:ext cx="8348472" cy="795528"/>
+          </a:xfrm>
+          <a:prstGeom prst="rect">
+            <a:avLst/>
+          </a:prstGeom>
+          <a:noFill/>
+        </p:spPr>
+        <p:txBody>
+          <a:bodyPr wrap="square">
+            <a:spAutoFit/>
+          </a:bodyPr>
+          <a:lstStyle/>
+          <a:p>
+            <a:r>
+              <a:rPr sz="2800" b="1">
+                <a:solidFill>
+                  <a:srgbClr val="0F0F0F"/>
+                </a:solidFill>
+                <a:latin typeface="Fira Sans"/>
+              </a:rPr>
+              <a:t>Síntesis</a:t>
+            </a:r>
+          </a:p>
+        </p:txBody>
+      </p:sp>
+      <p:sp>
+        <p:nvSpPr>
+          <p:cNvPr id="4" name="TextBox 3"/>
+          <p:cNvSpPr txBox="1"/>
+          <p:nvPr/>
+        </p:nvSpPr>
+        <p:spPr>
+          <a:xfrm>
+            <a:off x="704088" y="1353312"/>
+            <a:ext cx="7744968" cy="3300984"/>
+          </a:xfrm>
+          <a:prstGeom prst="rect">
+            <a:avLst/>
+          </a:prstGeom>
+          <a:noFill/>
+        </p:spPr>
+        <p:txBody>
+          <a:bodyPr wrap="square">
+            <a:spAutoFit/>
+          </a:bodyPr>
+          <a:lstStyle/>
+          <a:p>
+            <a:pPr>
+              <a:lnSpc>
+                <a:spcPct val="112000"/>
+              </a:lnSpc>
+              <a:spcAft>
+                <a:spcPts val="900"/>
+              </a:spcAft>
+            </a:pPr>
+            <a:r>
+              <a:rPr sz="1800" b="1">
+                <a:solidFill>
+                  <a:srgbClr val="E0A437"/>
+                </a:solidFill>
+                <a:latin typeface="Fira Sans"/>
+              </a:rPr>
+              <a:t>▸ </a:t>
+            </a:r>
+            <a:r>
+              <a:rPr sz="1800" b="1">
+                <a:solidFill>
+                  <a:srgbClr val="1D3557"/>
+                </a:solidFill>
+                <a:latin typeface="Fira Sans"/>
+              </a:rPr>
+              <a:t>El tipo de cada variable determina qué resúmenes, gráficos y análisis son válidos.</a:t>
+            </a:r>
+          </a:p>
+          <a:p>
+            <a:pPr>
+              <a:lnSpc>
+                <a:spcPct val="112000"/>
+              </a:lnSpc>
+              <a:spcAft>
+                <a:spcPts val="900"/>
+              </a:spcAft>
+            </a:pPr>
+            <a:r>
+              <a:rPr sz="1800" b="1">
+                <a:solidFill>
+                  <a:srgbClr val="E0A437"/>
+                </a:solidFill>
+                <a:latin typeface="Fira Sans"/>
+              </a:rPr>
+              <a:t>▸ </a:t>
+            </a:r>
+            <a:r>
+              <a:rPr sz="1800" b="0">
+                <a:solidFill>
+                  <a:srgbClr val="000000"/>
+                </a:solidFill>
+                <a:latin typeface="Fira Sans"/>
+              </a:rPr>
+              <a:t>Ciencia de datos: extracción generalizable de conocimiento a partir de los datos (Dhar, 2013); combina estadística, computación y dominio.</a:t>
+            </a:r>
+          </a:p>
+          <a:p>
+            <a:pPr>
+              <a:lnSpc>
+                <a:spcPct val="112000"/>
+              </a:lnSpc>
+              <a:spcAft>
+                <a:spcPts val="900"/>
+              </a:spcAft>
+            </a:pPr>
+            <a:r>
+              <a:rPr sz="1800" b="1">
+                <a:solidFill>
+                  <a:srgbClr val="E0A437"/>
+                </a:solidFill>
+                <a:latin typeface="Fira Sans"/>
+              </a:rPr>
+              <a:t>▸ </a:t>
+            </a:r>
+            <a:r>
+              <a:rPr sz="1800" b="0">
+                <a:solidFill>
+                  <a:srgbClr val="000000"/>
+                </a:solidFill>
+                <a:latin typeface="Fira Sans"/>
+              </a:rPr>
+              <a:t>El ciclo de vida tiene dos entradas (una necesidad del dominio o datos disponibles) y se recorre de forma iterativa.</a:t>
+            </a:r>
+          </a:p>
+          <a:p>
+            <a:pPr>
+              <a:lnSpc>
+                <a:spcPct val="112000"/>
+              </a:lnSpc>
+              <a:spcAft>
+                <a:spcPts val="900"/>
+              </a:spcAft>
+            </a:pPr>
+            <a:r>
+              <a:rPr sz="1800" b="1">
+                <a:solidFill>
+                  <a:srgbClr val="E0A437"/>
+                </a:solidFill>
+                <a:latin typeface="Fira Sans"/>
+              </a:rPr>
+              <a:t>▸ </a:t>
+            </a:r>
+            <a:r>
+              <a:rPr sz="1800" b="0">
+                <a:solidFill>
+                  <a:srgbClr val="000000"/>
+                </a:solidFill>
+                <a:latin typeface="Fira Sans"/>
+              </a:rPr>
+              <a:t>La preparación de datos consume cerca de la mitad del tiempo de un proyecto (Anaconda, 2020).</a:t>
+            </a:r>
+          </a:p>
+          <a:p>
+            <a:pPr>
+              <a:lnSpc>
+                <a:spcPct val="112000"/>
+              </a:lnSpc>
+              <a:spcAft>
+                <a:spcPts val="900"/>
+              </a:spcAft>
+            </a:pPr>
+            <a:r>
+              <a:rPr sz="1800" b="1">
+                <a:solidFill>
+                  <a:srgbClr val="E0A437"/>
+                </a:solidFill>
+                <a:latin typeface="Fira Sans"/>
+              </a:rPr>
+              <a:t>▸ </a:t>
+            </a:r>
+            <a:r>
+              <a:rPr sz="1800" b="0">
+                <a:solidFill>
+                  <a:srgbClr val="000000"/>
+                </a:solidFill>
+                <a:latin typeface="Fira Sans"/>
+              </a:rPr>
+              <a:t>Próxima clase (jueves 27): estadística descriptiva, con el entorno ya funcionando.</a:t>
+            </a:r>
+          </a:p>
+        </p:txBody>
+      </p:sp>
+    </p:spTree>
+  </p:cSld>
+  <p:clrMapOvr>
+    <a:masterClrMapping/>
+  </p:clrMapOvr>
+</p:sld>
+</file>
+
+<file path=ppt/slides/slide28.xml><?xml version="1.0" encoding="utf-8"?>
 <p:sld xmlns:a="http://schemas.openxmlformats.org/drawingml/2006/main" xmlns:p="http://schemas.openxmlformats.org/presentationml/2006/main" xmlns:r="http://schemas.openxmlformats.org/officeDocument/2006/relationships">
   <p:cSld>
     <p:spTree>

</xml_diff>

<commit_message>
Margen inferior en los paneles de la slide de opciones
Co-Authored-By: Claude Fable 5 <noreply@anthropic.com>
</commit_message>
<xml_diff>
--- a/presentaciones/clase01_fundamentos_ecosistema.pptx
+++ b/presentaciones/clase01_fundamentos_ecosistema.pptx
@@ -5004,7 +5004,7 @@
         </p:nvSpPr>
         <p:spPr>
           <a:xfrm>
-            <a:off x="731520" y="2194560"/>
+            <a:off x="731520" y="2130552"/>
             <a:ext cx="3474720" cy="457200"/>
           </a:xfrm>
           <a:prstGeom prst="rect">
@@ -5039,8 +5039,8 @@
         </p:nvSpPr>
         <p:spPr>
           <a:xfrm>
-            <a:off x="777240" y="2697480"/>
-            <a:ext cx="3383280" cy="1600200"/>
+            <a:off x="777240" y="2587752"/>
+            <a:ext cx="3383280" cy="1691640"/>
           </a:xfrm>
           <a:prstGeom prst="rect">
             <a:avLst/>
@@ -5244,7 +5244,7 @@
         </p:nvSpPr>
         <p:spPr>
           <a:xfrm>
-            <a:off x="4937760" y="2194560"/>
+            <a:off x="4937760" y="2130552"/>
             <a:ext cx="3474720" cy="457200"/>
           </a:xfrm>
           <a:prstGeom prst="rect">
@@ -5279,8 +5279,8 @@
         </p:nvSpPr>
         <p:spPr>
           <a:xfrm>
-            <a:off x="4983480" y="2697480"/>
-            <a:ext cx="3383280" cy="1600200"/>
+            <a:off x="4983480" y="2587752"/>
+            <a:ext cx="3383280" cy="1691640"/>
           </a:xfrm>
           <a:prstGeom prst="rect">
             <a:avLst/>

</xml_diff>

<commit_message>
Diagrama de las tablas de la EOD y sus llaves, en el deck y en los notebooks
Co-Authored-By: Claude Fable 5 <noreply@anthropic.com>
</commit_message>
<xml_diff>
--- a/presentaciones/clase01_fundamentos_ecosistema.pptx
+++ b/presentaciones/clase01_fundamentos_ecosistema.pptx
@@ -33,6 +33,7 @@
     <p:sldId id="281" r:id="rId32"/>
     <p:sldId id="282" r:id="rId33"/>
     <p:sldId id="283" r:id="rId34"/>
+    <p:sldId id="284" r:id="rId35"/>
   </p:sldIdLst>
   <p:sldSz cx="9144000" cy="5138928" type="screen4x3"/>
   <p:notesSz cx="6858000" cy="9144000"/>
@@ -6459,78 +6460,35 @@
                 </a:solidFill>
                 <a:latin typeface="Fira Sans"/>
               </a:rPr>
-              <a:t>Pandas: unir tablas con merge</a:t>
-            </a:r>
-          </a:p>
-        </p:txBody>
-      </p:sp>
-      <p:sp>
-        <p:nvSpPr>
-          <p:cNvPr id="4" name="Rectangle 3"/>
-          <p:cNvSpPr/>
-          <p:nvPr/>
-        </p:nvSpPr>
-        <p:spPr>
-          <a:xfrm>
-            <a:off x="704088" y="1280160"/>
-            <a:ext cx="7744968" cy="1371600"/>
-          </a:xfrm>
-          <a:prstGeom prst="rect">
-            <a:avLst/>
-          </a:prstGeom>
-          <a:solidFill>
-            <a:srgbClr val="F0F2F5"/>
-          </a:solidFill>
-          <a:ln>
-            <a:solidFill>
-              <a:srgbClr val="D8DDE3"/>
-            </a:solidFill>
-          </a:ln>
-          <a:effectLst/>
-        </p:spPr>
-        <p:style>
-          <a:lnRef idx="1">
-            <a:schemeClr val="accent1"/>
-          </a:lnRef>
-          <a:fillRef idx="3">
-            <a:schemeClr val="accent1"/>
-          </a:fillRef>
-          <a:effectRef idx="2">
-            <a:schemeClr val="accent1"/>
-          </a:effectRef>
-          <a:fontRef idx="minor">
-            <a:schemeClr val="lt1"/>
-          </a:fontRef>
-        </p:style>
-        <p:txBody>
-          <a:bodyPr rtlCol="0" anchor="ctr" wrap="square" lIns="228600" tIns="137160"/>
-          <a:lstStyle/>
-          <a:p>
-            <a:pPr/>
-            <a:r>
-              <a:rPr sz="1500" b="0">
-                <a:solidFill>
-                  <a:srgbClr val="1D3557"/>
-                </a:solidFill>
-                <a:latin typeface="Menlo"/>
-              </a:rPr>
-              <a:t>comunas = pd.read_csv(URL_COMUNAS)   # Id, Comuna</a:t>
-            </a:r>
-          </a:p>
-          <a:p>
-            <a:pPr/>
-            <a:r>
-              <a:rPr sz="1500" b="0">
-                <a:solidFill>
-                  <a:srgbClr val="1D3557"/>
-                </a:solidFill>
-                <a:latin typeface="Menlo"/>
-              </a:rPr>
-              <a:t>viajes.merge(comunas, left_on="ComunaOrigen", right_on="Id")</a:t>
-            </a:r>
-          </a:p>
-        </p:txBody>
-      </p:sp>
+              <a:t>La EOD: una encuesta, varias tablas</a:t>
+            </a:r>
+          </a:p>
+        </p:txBody>
+      </p:sp>
+      <p:pic>
+        <p:nvPicPr>
+          <p:cNvPr id="4" name="Picture 3" descr="12_eod_tablas.png"/>
+          <p:cNvPicPr>
+            <a:picLocks noChangeAspect="1"/>
+          </p:cNvPicPr>
+          <p:nvPr/>
+        </p:nvPicPr>
+        <p:blipFill>
+          <a:blip r:embed="rId2"/>
+          <a:stretch>
+            <a:fillRect/>
+          </a:stretch>
+        </p:blipFill>
+        <p:spPr>
+          <a:xfrm>
+            <a:off x="1553651" y="1143000"/>
+            <a:ext cx="6036697" cy="3154680"/>
+          </a:xfrm>
+          <a:prstGeom prst="rect">
+            <a:avLst/>
+          </a:prstGeom>
+        </p:spPr>
+      </p:pic>
       <p:sp>
         <p:nvSpPr>
           <p:cNvPr id="5" name="TextBox 4"/>
@@ -6539,8 +6497,8 @@
         </p:nvSpPr>
         <p:spPr>
           <a:xfrm>
-            <a:off x="704088" y="2880360"/>
-            <a:ext cx="7744968" cy="1097280"/>
+            <a:off x="704088" y="4434840"/>
+            <a:ext cx="7744968" cy="457200"/>
           </a:xfrm>
           <a:prstGeom prst="rect">
             <a:avLst/>
@@ -6553,31 +6511,14 @@
           </a:bodyPr>
           <a:lstStyle/>
           <a:p>
-            <a:pPr>
-              <a:lnSpc>
-                <a:spcPct val="112000"/>
-              </a:lnSpc>
-              <a:spcAft>
-                <a:spcPts val="900"/>
-              </a:spcAft>
-            </a:pPr>
-            <a:r>
-              <a:rPr sz="1600" b="1">
-                <a:solidFill>
-                  <a:srgbClr val="E0A437"/>
-                </a:solidFill>
-                <a:latin typeface="Fira Sans"/>
-              </a:rPr>
-              <a:t>▸ </a:t>
-            </a:r>
-            <a:r>
-              <a:rPr sz="1600" b="0">
-                <a:solidFill>
-                  <a:srgbClr val="000000"/>
-                </a:solidFill>
-                <a:latin typeface="Fira Sans"/>
-              </a:rPr>
-              <a:t>Los códigos de una tabla se traducen uniéndola con su tabla de parámetros: merge empareja filas por una columna común. En el notebook lo usamos para ponerle nombre a comunas y modos de viaje.</a:t>
+            <a:r>
+              <a:rPr sz="1300" b="0">
+                <a:solidFill>
+                  <a:srgbClr val="333333"/>
+                </a:solidFill>
+                <a:latin typeface="Fira Sans"/>
+              </a:rPr>
+              <a:t>Cada tabla tiene su unidad (hogar, persona, viaje) y las llaves las conectan; las tablas de parámetros traducen los códigos. Por eso la operación clave para trabajar con la EOD es merge.</a:t>
             </a:r>
           </a:p>
         </p:txBody>
@@ -6673,21 +6614,88 @@
                 </a:solidFill>
                 <a:latin typeface="Fira Sans"/>
               </a:rPr>
-              <a:t>El DataFrame no es exclusivo de Pandas</a:t>
-            </a:r>
-          </a:p>
-        </p:txBody>
-      </p:sp>
-      <p:sp>
-        <p:nvSpPr>
-          <p:cNvPr id="4" name="TextBox 3"/>
+              <a:t>Pandas: unir tablas con merge</a:t>
+            </a:r>
+          </a:p>
+        </p:txBody>
+      </p:sp>
+      <p:sp>
+        <p:nvSpPr>
+          <p:cNvPr id="4" name="Rectangle 3"/>
+          <p:cNvSpPr/>
+          <p:nvPr/>
+        </p:nvSpPr>
+        <p:spPr>
+          <a:xfrm>
+            <a:off x="704088" y="1280160"/>
+            <a:ext cx="7744968" cy="1371600"/>
+          </a:xfrm>
+          <a:prstGeom prst="rect">
+            <a:avLst/>
+          </a:prstGeom>
+          <a:solidFill>
+            <a:srgbClr val="F0F2F5"/>
+          </a:solidFill>
+          <a:ln>
+            <a:solidFill>
+              <a:srgbClr val="D8DDE3"/>
+            </a:solidFill>
+          </a:ln>
+          <a:effectLst/>
+        </p:spPr>
+        <p:style>
+          <a:lnRef idx="1">
+            <a:schemeClr val="accent1"/>
+          </a:lnRef>
+          <a:fillRef idx="3">
+            <a:schemeClr val="accent1"/>
+          </a:fillRef>
+          <a:effectRef idx="2">
+            <a:schemeClr val="accent1"/>
+          </a:effectRef>
+          <a:fontRef idx="minor">
+            <a:schemeClr val="lt1"/>
+          </a:fontRef>
+        </p:style>
+        <p:txBody>
+          <a:bodyPr rtlCol="0" anchor="ctr" wrap="square" lIns="228600" tIns="137160"/>
+          <a:lstStyle/>
+          <a:p>
+            <a:pPr/>
+            <a:r>
+              <a:rPr sz="1500" b="0">
+                <a:solidFill>
+                  <a:srgbClr val="1D3557"/>
+                </a:solidFill>
+                <a:latin typeface="Menlo"/>
+              </a:rPr>
+              <a:t>comunas = pd.read_csv(URL_COMUNAS)   # Id, Comuna</a:t>
+            </a:r>
+          </a:p>
+          <a:p>
+            <a:pPr/>
+            <a:r>
+              <a:rPr sz="1500" b="0">
+                <a:solidFill>
+                  <a:srgbClr val="1D3557"/>
+                </a:solidFill>
+                <a:latin typeface="Menlo"/>
+              </a:rPr>
+              <a:t>viajes.merge(comunas, left_on="ComunaOrigen", right_on="Id")</a:t>
+            </a:r>
+          </a:p>
+        </p:txBody>
+      </p:sp>
+      <p:sp>
+        <p:nvSpPr>
+          <p:cNvPr id="5" name="TextBox 4"/>
           <p:cNvSpPr txBox="1"/>
           <p:nvPr/>
         </p:nvSpPr>
         <p:spPr>
           <a:xfrm>
-            <a:off x="704088" y="1353312"/>
-            <a:ext cx="7744968" cy="3300984"/>
+            <a:off x="704088" y="2880360"/>
+            <a:ext cx="7744968" cy="1097280"/>
           </a:xfrm>
           <a:prstGeom prst="rect">
             <a:avLst/>
@@ -6709,7 +6717,7 @@
               </a:spcAft>
             </a:pPr>
             <a:r>
-              <a:rPr sz="1800" b="1">
+              <a:rPr sz="1600" b="1">
                 <a:solidFill>
                   <a:srgbClr val="E0A437"/>
                 </a:solidFill>
@@ -6718,153 +6726,13 @@
               <a:t>▸ </a:t>
             </a:r>
             <a:r>
-              <a:rPr sz="1800" b="0">
+              <a:rPr sz="1600" b="0">
                 <a:solidFill>
                   <a:srgbClr val="000000"/>
                 </a:solidFill>
                 <a:latin typeface="Fira Sans"/>
               </a:rPr>
-              <a:t>Varias herramientas usan la misma abstracción de tabla, y Pandas no siempre es la mejor opción cuando los datos crecen:</a:t>
-            </a:r>
-          </a:p>
-          <a:p>
-            <a:pPr>
-              <a:lnSpc>
-                <a:spcPct val="112000"/>
-              </a:lnSpc>
-              <a:spcAft>
-                <a:spcPts val="500"/>
-              </a:spcAft>
-            </a:pPr>
-            <a:r>
-              <a:rPr sz="1400" b="0">
-                <a:solidFill>
-                  <a:srgbClr val="333333"/>
-                </a:solidFill>
-                <a:latin typeface="Fira Sans"/>
-              </a:rPr>
-              <a:t>     ◦  </a:t>
-            </a:r>
-            <a:r>
-              <a:rPr sz="1400" b="0">
-                <a:solidFill>
-                  <a:srgbClr val="333333"/>
-                </a:solidFill>
-                <a:latin typeface="Fira Sans"/>
-              </a:rPr>
-              <a:t>Polars: DataFrames implementados en Rust, más rápidos y eficientes en memoria.</a:t>
-            </a:r>
-          </a:p>
-          <a:p>
-            <a:pPr>
-              <a:lnSpc>
-                <a:spcPct val="112000"/>
-              </a:lnSpc>
-              <a:spcAft>
-                <a:spcPts val="500"/>
-              </a:spcAft>
-            </a:pPr>
-            <a:r>
-              <a:rPr sz="1400" b="0">
-                <a:solidFill>
-                  <a:srgbClr val="333333"/>
-                </a:solidFill>
-                <a:latin typeface="Fira Sans"/>
-              </a:rPr>
-              <a:t>     ◦  </a:t>
-            </a:r>
-            <a:r>
-              <a:rPr sz="1400" b="0">
-                <a:solidFill>
-                  <a:srgbClr val="333333"/>
-                </a:solidFill>
-                <a:latin typeface="Fira Sans"/>
-              </a:rPr>
-              <a:t>Apache Spark: DataFrames distribuidos en un clúster, para volúmenes que no caben en una máquina.</a:t>
-            </a:r>
-          </a:p>
-          <a:p>
-            <a:pPr>
-              <a:lnSpc>
-                <a:spcPct val="112000"/>
-              </a:lnSpc>
-              <a:spcAft>
-                <a:spcPts val="500"/>
-              </a:spcAft>
-            </a:pPr>
-            <a:r>
-              <a:rPr sz="1400" b="0">
-                <a:solidFill>
-                  <a:srgbClr val="333333"/>
-                </a:solidFill>
-                <a:latin typeface="Fira Sans"/>
-              </a:rPr>
-              <a:t>     ◦  </a:t>
-            </a:r>
-            <a:r>
-              <a:rPr sz="1400" b="0">
-                <a:solidFill>
-                  <a:srgbClr val="333333"/>
-                </a:solidFill>
-                <a:latin typeface="Fira Sans"/>
-              </a:rPr>
-              <a:t>Dask: paraleliza la interfaz de Pandas sobre varios núcleos o máquinas.</a:t>
-            </a:r>
-          </a:p>
-          <a:p>
-            <a:pPr>
-              <a:lnSpc>
-                <a:spcPct val="112000"/>
-              </a:lnSpc>
-              <a:spcAft>
-                <a:spcPts val="500"/>
-              </a:spcAft>
-            </a:pPr>
-            <a:r>
-              <a:rPr sz="1400" b="0">
-                <a:solidFill>
-                  <a:srgbClr val="333333"/>
-                </a:solidFill>
-                <a:latin typeface="Fira Sans"/>
-              </a:rPr>
-              <a:t>     ◦  </a:t>
-            </a:r>
-            <a:r>
-              <a:rPr sz="1400" b="0">
-                <a:solidFill>
-                  <a:srgbClr val="333333"/>
-                </a:solidFill>
-                <a:latin typeface="Fira Sans"/>
-              </a:rPr>
-              <a:t>DuckDB: consultas SQL directas sobre archivos y DataFrames.</a:t>
-            </a:r>
-          </a:p>
-          <a:p>
-            <a:pPr>
-              <a:lnSpc>
-                <a:spcPct val="112000"/>
-              </a:lnSpc>
-              <a:spcAft>
-                <a:spcPts val="900"/>
-              </a:spcAft>
-            </a:pPr>
-            <a:r>
-              <a:rPr sz="1800" b="1">
-                <a:solidFill>
-                  <a:srgbClr val="E0A437"/>
-                </a:solidFill>
-                <a:latin typeface="Fira Sans"/>
-              </a:rPr>
-              <a:t>▸ </a:t>
-            </a:r>
-            <a:r>
-              <a:rPr sz="1800" b="0">
-                <a:solidFill>
-                  <a:srgbClr val="000000"/>
-                </a:solidFill>
-                <a:latin typeface="Fira Sans"/>
-              </a:rPr>
-              <a:t>En este módulo usamos Pandas: es el estándar para el análisis interactivo con datos de tamaño pequeño y mediano, y su interfaz es la referencia que las demás herramientas siguen.</a:t>
+              <a:t>Los códigos de una tabla se traducen uniéndola con su tabla de parámetros: merge empareja filas por una columna común. En el notebook lo usamos para ponerle nombre a comunas y modos de viaje.</a:t>
             </a:r>
           </a:p>
         </p:txBody>
@@ -6960,45 +6828,21 @@
                 </a:solidFill>
                 <a:latin typeface="Fira Sans"/>
               </a:rPr>
-              <a:t>Matplotlib: tres gráficos básicos</a:t>
-            </a:r>
-          </a:p>
-        </p:txBody>
-      </p:sp>
-      <p:pic>
-        <p:nvPicPr>
-          <p:cNvPr id="4" name="Picture 3" descr="11_tres_graficos.png"/>
-          <p:cNvPicPr>
-            <a:picLocks noChangeAspect="1"/>
-          </p:cNvPicPr>
-          <p:nvPr/>
-        </p:nvPicPr>
-        <p:blipFill>
-          <a:blip r:embed="rId2"/>
-          <a:stretch>
-            <a:fillRect/>
-          </a:stretch>
-        </p:blipFill>
-        <p:spPr>
-          <a:xfrm>
-            <a:off x="1417319" y="1143000"/>
-            <a:ext cx="6309360" cy="1854976"/>
-          </a:xfrm>
-          <a:prstGeom prst="rect">
-            <a:avLst/>
-          </a:prstGeom>
-        </p:spPr>
-      </p:pic>
-      <p:sp>
-        <p:nvSpPr>
-          <p:cNvPr id="5" name="TextBox 4"/>
+              <a:t>El DataFrame no es exclusivo de Pandas</a:t>
+            </a:r>
+          </a:p>
+        </p:txBody>
+      </p:sp>
+      <p:sp>
+        <p:nvSpPr>
+          <p:cNvPr id="4" name="TextBox 3"/>
           <p:cNvSpPr txBox="1"/>
           <p:nvPr/>
         </p:nvSpPr>
         <p:spPr>
           <a:xfrm>
-            <a:off x="704088" y="4434840"/>
-            <a:ext cx="7744968" cy="457200"/>
+            <a:off x="704088" y="1353312"/>
+            <a:ext cx="7744968" cy="3300984"/>
           </a:xfrm>
           <a:prstGeom prst="rect">
             <a:avLst/>
@@ -7011,14 +6855,171 @@
           </a:bodyPr>
           <a:lstStyle/>
           <a:p>
-            <a:r>
-              <a:rPr sz="1300" b="0">
+            <a:pPr>
+              <a:lnSpc>
+                <a:spcPct val="112000"/>
+              </a:lnSpc>
+              <a:spcAft>
+                <a:spcPts val="900"/>
+              </a:spcAft>
+            </a:pPr>
+            <a:r>
+              <a:rPr sz="1800" b="1">
+                <a:solidFill>
+                  <a:srgbClr val="E0A437"/>
+                </a:solidFill>
+                <a:latin typeface="Fira Sans"/>
+              </a:rPr>
+              <a:t>▸ </a:t>
+            </a:r>
+            <a:r>
+              <a:rPr sz="1800" b="0">
+                <a:solidFill>
+                  <a:srgbClr val="000000"/>
+                </a:solidFill>
+                <a:latin typeface="Fira Sans"/>
+              </a:rPr>
+              <a:t>Varias herramientas usan la misma abstracción de tabla, y Pandas no siempre es la mejor opción cuando los datos crecen:</a:t>
+            </a:r>
+          </a:p>
+          <a:p>
+            <a:pPr>
+              <a:lnSpc>
+                <a:spcPct val="112000"/>
+              </a:lnSpc>
+              <a:spcAft>
+                <a:spcPts val="500"/>
+              </a:spcAft>
+            </a:pPr>
+            <a:r>
+              <a:rPr sz="1400" b="0">
                 <a:solidFill>
                   <a:srgbClr val="333333"/>
                 </a:solidFill>
                 <a:latin typeface="Fira Sans"/>
               </a:rPr>
-              <a:t>El gráfico depende del tipo de variable: barras para una cualitativa, histograma para una cuantitativa, dispersión para dos cuantitativas. Los tres salen de la tabla de viajes y se construyen en el notebook.</a:t>
+              <a:t>     ◦  </a:t>
+            </a:r>
+            <a:r>
+              <a:rPr sz="1400" b="0">
+                <a:solidFill>
+                  <a:srgbClr val="333333"/>
+                </a:solidFill>
+                <a:latin typeface="Fira Sans"/>
+              </a:rPr>
+              <a:t>Polars: DataFrames implementados en Rust, más rápidos y eficientes en memoria.</a:t>
+            </a:r>
+          </a:p>
+          <a:p>
+            <a:pPr>
+              <a:lnSpc>
+                <a:spcPct val="112000"/>
+              </a:lnSpc>
+              <a:spcAft>
+                <a:spcPts val="500"/>
+              </a:spcAft>
+            </a:pPr>
+            <a:r>
+              <a:rPr sz="1400" b="0">
+                <a:solidFill>
+                  <a:srgbClr val="333333"/>
+                </a:solidFill>
+                <a:latin typeface="Fira Sans"/>
+              </a:rPr>
+              <a:t>     ◦  </a:t>
+            </a:r>
+            <a:r>
+              <a:rPr sz="1400" b="0">
+                <a:solidFill>
+                  <a:srgbClr val="333333"/>
+                </a:solidFill>
+                <a:latin typeface="Fira Sans"/>
+              </a:rPr>
+              <a:t>Apache Spark: DataFrames distribuidos en un clúster, para volúmenes que no caben en una máquina.</a:t>
+            </a:r>
+          </a:p>
+          <a:p>
+            <a:pPr>
+              <a:lnSpc>
+                <a:spcPct val="112000"/>
+              </a:lnSpc>
+              <a:spcAft>
+                <a:spcPts val="500"/>
+              </a:spcAft>
+            </a:pPr>
+            <a:r>
+              <a:rPr sz="1400" b="0">
+                <a:solidFill>
+                  <a:srgbClr val="333333"/>
+                </a:solidFill>
+                <a:latin typeface="Fira Sans"/>
+              </a:rPr>
+              <a:t>     ◦  </a:t>
+            </a:r>
+            <a:r>
+              <a:rPr sz="1400" b="0">
+                <a:solidFill>
+                  <a:srgbClr val="333333"/>
+                </a:solidFill>
+                <a:latin typeface="Fira Sans"/>
+              </a:rPr>
+              <a:t>Dask: paraleliza la interfaz de Pandas sobre varios núcleos o máquinas.</a:t>
+            </a:r>
+          </a:p>
+          <a:p>
+            <a:pPr>
+              <a:lnSpc>
+                <a:spcPct val="112000"/>
+              </a:lnSpc>
+              <a:spcAft>
+                <a:spcPts val="500"/>
+              </a:spcAft>
+            </a:pPr>
+            <a:r>
+              <a:rPr sz="1400" b="0">
+                <a:solidFill>
+                  <a:srgbClr val="333333"/>
+                </a:solidFill>
+                <a:latin typeface="Fira Sans"/>
+              </a:rPr>
+              <a:t>     ◦  </a:t>
+            </a:r>
+            <a:r>
+              <a:rPr sz="1400" b="0">
+                <a:solidFill>
+                  <a:srgbClr val="333333"/>
+                </a:solidFill>
+                <a:latin typeface="Fira Sans"/>
+              </a:rPr>
+              <a:t>DuckDB: consultas SQL directas sobre archivos y DataFrames.</a:t>
+            </a:r>
+          </a:p>
+          <a:p>
+            <a:pPr>
+              <a:lnSpc>
+                <a:spcPct val="112000"/>
+              </a:lnSpc>
+              <a:spcAft>
+                <a:spcPts val="900"/>
+              </a:spcAft>
+            </a:pPr>
+            <a:r>
+              <a:rPr sz="1800" b="1">
+                <a:solidFill>
+                  <a:srgbClr val="E0A437"/>
+                </a:solidFill>
+                <a:latin typeface="Fira Sans"/>
+              </a:rPr>
+              <a:t>▸ </a:t>
+            </a:r>
+            <a:r>
+              <a:rPr sz="1800" b="0">
+                <a:solidFill>
+                  <a:srgbClr val="000000"/>
+                </a:solidFill>
+                <a:latin typeface="Fira Sans"/>
+              </a:rPr>
+              <a:t>En este módulo usamos Pandas: es el estándar para el análisis interactivo con datos de tamaño pequeño y mediano, y su interfaz es la referencia que las demás herramientas siguen.</a:t>
             </a:r>
           </a:p>
         </p:txBody>
@@ -7114,21 +7115,45 @@
                 </a:solidFill>
                 <a:latin typeface="Fira Sans"/>
               </a:rPr>
-              <a:t>El factor de expansión</a:t>
-            </a:r>
-          </a:p>
-        </p:txBody>
-      </p:sp>
-      <p:sp>
-        <p:nvSpPr>
-          <p:cNvPr id="4" name="TextBox 3"/>
+              <a:t>Matplotlib: tres gráficos básicos</a:t>
+            </a:r>
+          </a:p>
+        </p:txBody>
+      </p:sp>
+      <p:pic>
+        <p:nvPicPr>
+          <p:cNvPr id="4" name="Picture 3" descr="11_tres_graficos.png"/>
+          <p:cNvPicPr>
+            <a:picLocks noChangeAspect="1"/>
+          </p:cNvPicPr>
+          <p:nvPr/>
+        </p:nvPicPr>
+        <p:blipFill>
+          <a:blip r:embed="rId2"/>
+          <a:stretch>
+            <a:fillRect/>
+          </a:stretch>
+        </p:blipFill>
+        <p:spPr>
+          <a:xfrm>
+            <a:off x="1417319" y="1143000"/>
+            <a:ext cx="6309360" cy="1854976"/>
+          </a:xfrm>
+          <a:prstGeom prst="rect">
+            <a:avLst/>
+          </a:prstGeom>
+        </p:spPr>
+      </p:pic>
+      <p:sp>
+        <p:nvSpPr>
+          <p:cNvPr id="5" name="TextBox 4"/>
           <p:cNvSpPr txBox="1"/>
           <p:nvPr/>
         </p:nvSpPr>
         <p:spPr>
           <a:xfrm>
-            <a:off x="704088" y="1353312"/>
-            <a:ext cx="7744968" cy="3300984"/>
+            <a:off x="704088" y="4434840"/>
+            <a:ext cx="7744968" cy="457200"/>
           </a:xfrm>
           <a:prstGeom prst="rect">
             <a:avLst/>
@@ -7141,143 +7166,14 @@
           </a:bodyPr>
           <a:lstStyle/>
           <a:p>
-            <a:pPr>
-              <a:lnSpc>
-                <a:spcPct val="112000"/>
-              </a:lnSpc>
-              <a:spcAft>
-                <a:spcPts val="900"/>
-              </a:spcAft>
-            </a:pPr>
-            <a:r>
-              <a:rPr sz="1800" b="1">
-                <a:solidFill>
-                  <a:srgbClr val="E0A437"/>
-                </a:solidFill>
-                <a:latin typeface="Fira Sans"/>
-              </a:rPr>
-              <a:t>▸ </a:t>
-            </a:r>
-            <a:r>
-              <a:rPr sz="1800" b="0">
-                <a:solidFill>
-                  <a:srgbClr val="000000"/>
-                </a:solidFill>
-                <a:latin typeface="Fira Sans"/>
-              </a:rPr>
-              <a:t>Una encuesta entrevista a una muestra: la EOD, a 60.054 personas de los 6,65 millones de habitantes que cubre.</a:t>
-            </a:r>
-          </a:p>
-          <a:p>
-            <a:pPr>
-              <a:lnSpc>
-                <a:spcPct val="112000"/>
-              </a:lnSpc>
-              <a:spcAft>
-                <a:spcPts val="900"/>
-              </a:spcAft>
-            </a:pPr>
-            <a:r>
-              <a:rPr sz="1800" b="1">
-                <a:solidFill>
-                  <a:srgbClr val="E0A437"/>
-                </a:solidFill>
-                <a:latin typeface="Fira Sans"/>
-              </a:rPr>
-              <a:t>▸ </a:t>
-            </a:r>
-            <a:r>
-              <a:rPr sz="1800" b="0">
-                <a:solidFill>
-                  <a:srgbClr val="000000"/>
-                </a:solidFill>
-                <a:latin typeface="Fira Sans"/>
-              </a:rPr>
-              <a:t>El factor de expansión de cada persona indica a cuántos habitantes representa; sale del diseño muestral (comuna, sexo, edad).</a:t>
-            </a:r>
-          </a:p>
-          <a:p>
-            <a:pPr>
-              <a:lnSpc>
-                <a:spcPct val="112000"/>
-              </a:lnSpc>
-              <a:spcAft>
-                <a:spcPts val="900"/>
-              </a:spcAft>
-            </a:pPr>
-            <a:r>
-              <a:rPr sz="1800" b="1">
-                <a:solidFill>
-                  <a:srgbClr val="E0A437"/>
-                </a:solidFill>
-                <a:latin typeface="Fira Sans"/>
-              </a:rPr>
-              <a:t>▸ </a:t>
-            </a:r>
-            <a:r>
-              <a:rPr sz="1800" b="0">
-                <a:solidFill>
-                  <a:srgbClr val="000000"/>
-                </a:solidFill>
-                <a:latin typeface="Fira Sans"/>
-              </a:rPr>
-              <a:t>La suma de los factores reproduce la población: en la EOD, Factor_LaboralNormal suma 6.651.735.</a:t>
-            </a:r>
-          </a:p>
-          <a:p>
-            <a:pPr>
-              <a:lnSpc>
-                <a:spcPct val="112000"/>
-              </a:lnSpc>
-              <a:spcAft>
-                <a:spcPts val="900"/>
-              </a:spcAft>
-            </a:pPr>
-            <a:r>
-              <a:rPr sz="1800" b="1">
-                <a:solidFill>
-                  <a:srgbClr val="E0A437"/>
-                </a:solidFill>
-                <a:latin typeface="Fira Sans"/>
-              </a:rPr>
-              <a:t>▸ </a:t>
-            </a:r>
-            <a:r>
-              <a:rPr sz="1800" b="1">
-                <a:solidFill>
-                  <a:srgbClr val="1D3557"/>
-                </a:solidFill>
-                <a:latin typeface="Fira Sans"/>
-              </a:rPr>
-              <a:t>Todo resumen tiene dos versiones: muestral (contar filas) y ponderada (sumar factores). ¿De quién habla cada número?</a:t>
-            </a:r>
-          </a:p>
-          <a:p>
-            <a:pPr>
-              <a:lnSpc>
-                <a:spcPct val="112000"/>
-              </a:lnSpc>
-              <a:spcAft>
-                <a:spcPts val="900"/>
-              </a:spcAft>
-            </a:pPr>
-            <a:r>
-              <a:rPr sz="1800" b="1">
-                <a:solidFill>
-                  <a:srgbClr val="E0A437"/>
-                </a:solidFill>
-                <a:latin typeface="Fira Sans"/>
-              </a:rPr>
-              <a:t>▸ </a:t>
-            </a:r>
-            <a:r>
-              <a:rPr sz="1800" b="0">
-                <a:solidFill>
-                  <a:srgbClr val="000000"/>
-                </a:solidFill>
-                <a:latin typeface="Fira Sans"/>
-              </a:rPr>
-              <a:t>En el notebook: 52,8% de mujeres en la muestra, 51,5% ponderado.</a:t>
+            <a:r>
+              <a:rPr sz="1300" b="0">
+                <a:solidFill>
+                  <a:srgbClr val="333333"/>
+                </a:solidFill>
+                <a:latin typeface="Fira Sans"/>
+              </a:rPr>
+              <a:t>El gráfico depende del tipo de variable: barras para una cualitativa, histograma para una cuantitativa, dispersión para dos cuantitativas. Los tres salen de la tabla de viajes y se construyen en el notebook.</a:t>
             </a:r>
           </a:p>
         </p:txBody>
@@ -7373,45 +7269,21 @@
                 </a:solidFill>
                 <a:latin typeface="Fira Sans"/>
               </a:rPr>
-              <a:t>Reparto modal de Santiago, EOD 2012</a:t>
-            </a:r>
-          </a:p>
-        </p:txBody>
-      </p:sp>
-      <p:pic>
-        <p:nvPicPr>
-          <p:cNvPr id="4" name="Picture 3" descr="01_reparto_modal.png"/>
-          <p:cNvPicPr>
-            <a:picLocks noChangeAspect="1"/>
-          </p:cNvPicPr>
-          <p:nvPr/>
-        </p:nvPicPr>
-        <p:blipFill>
-          <a:blip r:embed="rId2"/>
-          <a:stretch>
-            <a:fillRect/>
-          </a:stretch>
-        </p:blipFill>
-        <p:spPr>
-          <a:xfrm>
-            <a:off x="1604462" y="1143000"/>
-            <a:ext cx="5935075" cy="3154680"/>
-          </a:xfrm>
-          <a:prstGeom prst="rect">
-            <a:avLst/>
-          </a:prstGeom>
-        </p:spPr>
-      </p:pic>
-      <p:sp>
-        <p:nvSpPr>
-          <p:cNvPr id="5" name="TextBox 4"/>
+              <a:t>El factor de expansión</a:t>
+            </a:r>
+          </a:p>
+        </p:txBody>
+      </p:sp>
+      <p:sp>
+        <p:nvSpPr>
+          <p:cNvPr id="4" name="TextBox 3"/>
           <p:cNvSpPr txBox="1"/>
           <p:nvPr/>
         </p:nvSpPr>
         <p:spPr>
           <a:xfrm>
-            <a:off x="704088" y="4434840"/>
-            <a:ext cx="7744968" cy="457200"/>
+            <a:off x="704088" y="1353312"/>
+            <a:ext cx="7744968" cy="3300984"/>
           </a:xfrm>
           <a:prstGeom prst="rect">
             <a:avLst/>
@@ -7424,14 +7296,143 @@
           </a:bodyPr>
           <a:lstStyle/>
           <a:p>
-            <a:r>
-              <a:rPr sz="1300" b="0">
-                <a:solidFill>
-                  <a:srgbClr val="333333"/>
-                </a:solidFill>
-                <a:latin typeface="Fira Sans"/>
-              </a:rPr>
-              <a:t>Uno de cada tres viajes es a pie. Esta versión está ponderada por factores de expansión, así que habla de la ciudad; en el notebook calcularemos la versión muestral, y la diferencia entre ambas abre las clases 2 y 3.</a:t>
+            <a:pPr>
+              <a:lnSpc>
+                <a:spcPct val="112000"/>
+              </a:lnSpc>
+              <a:spcAft>
+                <a:spcPts val="900"/>
+              </a:spcAft>
+            </a:pPr>
+            <a:r>
+              <a:rPr sz="1800" b="1">
+                <a:solidFill>
+                  <a:srgbClr val="E0A437"/>
+                </a:solidFill>
+                <a:latin typeface="Fira Sans"/>
+              </a:rPr>
+              <a:t>▸ </a:t>
+            </a:r>
+            <a:r>
+              <a:rPr sz="1800" b="0">
+                <a:solidFill>
+                  <a:srgbClr val="000000"/>
+                </a:solidFill>
+                <a:latin typeface="Fira Sans"/>
+              </a:rPr>
+              <a:t>Una encuesta entrevista a una muestra: la EOD, a 60.054 personas de los 6,65 millones de habitantes que cubre.</a:t>
+            </a:r>
+          </a:p>
+          <a:p>
+            <a:pPr>
+              <a:lnSpc>
+                <a:spcPct val="112000"/>
+              </a:lnSpc>
+              <a:spcAft>
+                <a:spcPts val="900"/>
+              </a:spcAft>
+            </a:pPr>
+            <a:r>
+              <a:rPr sz="1800" b="1">
+                <a:solidFill>
+                  <a:srgbClr val="E0A437"/>
+                </a:solidFill>
+                <a:latin typeface="Fira Sans"/>
+              </a:rPr>
+              <a:t>▸ </a:t>
+            </a:r>
+            <a:r>
+              <a:rPr sz="1800" b="0">
+                <a:solidFill>
+                  <a:srgbClr val="000000"/>
+                </a:solidFill>
+                <a:latin typeface="Fira Sans"/>
+              </a:rPr>
+              <a:t>El factor de expansión de cada persona indica a cuántos habitantes representa; sale del diseño muestral (comuna, sexo, edad).</a:t>
+            </a:r>
+          </a:p>
+          <a:p>
+            <a:pPr>
+              <a:lnSpc>
+                <a:spcPct val="112000"/>
+              </a:lnSpc>
+              <a:spcAft>
+                <a:spcPts val="900"/>
+              </a:spcAft>
+            </a:pPr>
+            <a:r>
+              <a:rPr sz="1800" b="1">
+                <a:solidFill>
+                  <a:srgbClr val="E0A437"/>
+                </a:solidFill>
+                <a:latin typeface="Fira Sans"/>
+              </a:rPr>
+              <a:t>▸ </a:t>
+            </a:r>
+            <a:r>
+              <a:rPr sz="1800" b="0">
+                <a:solidFill>
+                  <a:srgbClr val="000000"/>
+                </a:solidFill>
+                <a:latin typeface="Fira Sans"/>
+              </a:rPr>
+              <a:t>La suma de los factores reproduce la población: en la EOD, Factor_LaboralNormal suma 6.651.735.</a:t>
+            </a:r>
+          </a:p>
+          <a:p>
+            <a:pPr>
+              <a:lnSpc>
+                <a:spcPct val="112000"/>
+              </a:lnSpc>
+              <a:spcAft>
+                <a:spcPts val="900"/>
+              </a:spcAft>
+            </a:pPr>
+            <a:r>
+              <a:rPr sz="1800" b="1">
+                <a:solidFill>
+                  <a:srgbClr val="E0A437"/>
+                </a:solidFill>
+                <a:latin typeface="Fira Sans"/>
+              </a:rPr>
+              <a:t>▸ </a:t>
+            </a:r>
+            <a:r>
+              <a:rPr sz="1800" b="1">
+                <a:solidFill>
+                  <a:srgbClr val="1D3557"/>
+                </a:solidFill>
+                <a:latin typeface="Fira Sans"/>
+              </a:rPr>
+              <a:t>Todo resumen tiene dos versiones: muestral (contar filas) y ponderada (sumar factores). ¿De quién habla cada número?</a:t>
+            </a:r>
+          </a:p>
+          <a:p>
+            <a:pPr>
+              <a:lnSpc>
+                <a:spcPct val="112000"/>
+              </a:lnSpc>
+              <a:spcAft>
+                <a:spcPts val="900"/>
+              </a:spcAft>
+            </a:pPr>
+            <a:r>
+              <a:rPr sz="1800" b="1">
+                <a:solidFill>
+                  <a:srgbClr val="E0A437"/>
+                </a:solidFill>
+                <a:latin typeface="Fira Sans"/>
+              </a:rPr>
+              <a:t>▸ </a:t>
+            </a:r>
+            <a:r>
+              <a:rPr sz="1800" b="0">
+                <a:solidFill>
+                  <a:srgbClr val="000000"/>
+                </a:solidFill>
+                <a:latin typeface="Fira Sans"/>
+              </a:rPr>
+              <a:t>En el notebook: 52,8% de mujeres en la muestra, 51,5% ponderado.</a:t>
             </a:r>
           </a:p>
         </p:txBody>
@@ -7527,21 +7528,45 @@
                 </a:solidFill>
                 <a:latin typeface="Fira Sans"/>
               </a:rPr>
-              <a:t>Síntesis</a:t>
-            </a:r>
-          </a:p>
-        </p:txBody>
-      </p:sp>
-      <p:sp>
-        <p:nvSpPr>
-          <p:cNvPr id="4" name="TextBox 3"/>
+              <a:t>Reparto modal de Santiago, EOD 2012</a:t>
+            </a:r>
+          </a:p>
+        </p:txBody>
+      </p:sp>
+      <p:pic>
+        <p:nvPicPr>
+          <p:cNvPr id="4" name="Picture 3" descr="01_reparto_modal.png"/>
+          <p:cNvPicPr>
+            <a:picLocks noChangeAspect="1"/>
+          </p:cNvPicPr>
+          <p:nvPr/>
+        </p:nvPicPr>
+        <p:blipFill>
+          <a:blip r:embed="rId2"/>
+          <a:stretch>
+            <a:fillRect/>
+          </a:stretch>
+        </p:blipFill>
+        <p:spPr>
+          <a:xfrm>
+            <a:off x="1604462" y="1143000"/>
+            <a:ext cx="5935075" cy="3154680"/>
+          </a:xfrm>
+          <a:prstGeom prst="rect">
+            <a:avLst/>
+          </a:prstGeom>
+        </p:spPr>
+      </p:pic>
+      <p:sp>
+        <p:nvSpPr>
+          <p:cNvPr id="5" name="TextBox 4"/>
           <p:cNvSpPr txBox="1"/>
           <p:nvPr/>
         </p:nvSpPr>
         <p:spPr>
           <a:xfrm>
-            <a:off x="704088" y="1353312"/>
-            <a:ext cx="7744968" cy="3300984"/>
+            <a:off x="704088" y="4434840"/>
+            <a:ext cx="7744968" cy="457200"/>
           </a:xfrm>
           <a:prstGeom prst="rect">
             <a:avLst/>
@@ -7554,143 +7579,14 @@
           </a:bodyPr>
           <a:lstStyle/>
           <a:p>
-            <a:pPr>
-              <a:lnSpc>
-                <a:spcPct val="112000"/>
-              </a:lnSpc>
-              <a:spcAft>
-                <a:spcPts val="900"/>
-              </a:spcAft>
-            </a:pPr>
-            <a:r>
-              <a:rPr sz="1800" b="1">
-                <a:solidFill>
-                  <a:srgbClr val="E0A437"/>
-                </a:solidFill>
-                <a:latin typeface="Fira Sans"/>
-              </a:rPr>
-              <a:t>▸ </a:t>
-            </a:r>
-            <a:r>
-              <a:rPr sz="1800" b="1">
-                <a:solidFill>
-                  <a:srgbClr val="1D3557"/>
-                </a:solidFill>
-                <a:latin typeface="Fira Sans"/>
-              </a:rPr>
-              <a:t>El tipo de cada variable determina qué resúmenes, gráficos y análisis son válidos.</a:t>
-            </a:r>
-          </a:p>
-          <a:p>
-            <a:pPr>
-              <a:lnSpc>
-                <a:spcPct val="112000"/>
-              </a:lnSpc>
-              <a:spcAft>
-                <a:spcPts val="900"/>
-              </a:spcAft>
-            </a:pPr>
-            <a:r>
-              <a:rPr sz="1800" b="1">
-                <a:solidFill>
-                  <a:srgbClr val="E0A437"/>
-                </a:solidFill>
-                <a:latin typeface="Fira Sans"/>
-              </a:rPr>
-              <a:t>▸ </a:t>
-            </a:r>
-            <a:r>
-              <a:rPr sz="1800" b="0">
-                <a:solidFill>
-                  <a:srgbClr val="000000"/>
-                </a:solidFill>
-                <a:latin typeface="Fira Sans"/>
-              </a:rPr>
-              <a:t>Ciencia de datos: extracción generalizable de conocimiento a partir de los datos (Dhar, 2013); combina estadística, computación y dominio.</a:t>
-            </a:r>
-          </a:p>
-          <a:p>
-            <a:pPr>
-              <a:lnSpc>
-                <a:spcPct val="112000"/>
-              </a:lnSpc>
-              <a:spcAft>
-                <a:spcPts val="900"/>
-              </a:spcAft>
-            </a:pPr>
-            <a:r>
-              <a:rPr sz="1800" b="1">
-                <a:solidFill>
-                  <a:srgbClr val="E0A437"/>
-                </a:solidFill>
-                <a:latin typeface="Fira Sans"/>
-              </a:rPr>
-              <a:t>▸ </a:t>
-            </a:r>
-            <a:r>
-              <a:rPr sz="1800" b="0">
-                <a:solidFill>
-                  <a:srgbClr val="000000"/>
-                </a:solidFill>
-                <a:latin typeface="Fira Sans"/>
-              </a:rPr>
-              <a:t>El ciclo de vida tiene dos entradas (una necesidad del dominio o datos disponibles) y se recorre de forma iterativa.</a:t>
-            </a:r>
-          </a:p>
-          <a:p>
-            <a:pPr>
-              <a:lnSpc>
-                <a:spcPct val="112000"/>
-              </a:lnSpc>
-              <a:spcAft>
-                <a:spcPts val="900"/>
-              </a:spcAft>
-            </a:pPr>
-            <a:r>
-              <a:rPr sz="1800" b="1">
-                <a:solidFill>
-                  <a:srgbClr val="E0A437"/>
-                </a:solidFill>
-                <a:latin typeface="Fira Sans"/>
-              </a:rPr>
-              <a:t>▸ </a:t>
-            </a:r>
-            <a:r>
-              <a:rPr sz="1800" b="0">
-                <a:solidFill>
-                  <a:srgbClr val="000000"/>
-                </a:solidFill>
-                <a:latin typeface="Fira Sans"/>
-              </a:rPr>
-              <a:t>La preparación de datos consume cerca de la mitad del tiempo de un proyecto (Anaconda, 2020).</a:t>
-            </a:r>
-          </a:p>
-          <a:p>
-            <a:pPr>
-              <a:lnSpc>
-                <a:spcPct val="112000"/>
-              </a:lnSpc>
-              <a:spcAft>
-                <a:spcPts val="900"/>
-              </a:spcAft>
-            </a:pPr>
-            <a:r>
-              <a:rPr sz="1800" b="1">
-                <a:solidFill>
-                  <a:srgbClr val="E0A437"/>
-                </a:solidFill>
-                <a:latin typeface="Fira Sans"/>
-              </a:rPr>
-              <a:t>▸ </a:t>
-            </a:r>
-            <a:r>
-              <a:rPr sz="1800" b="0">
-                <a:solidFill>
-                  <a:srgbClr val="000000"/>
-                </a:solidFill>
-                <a:latin typeface="Fira Sans"/>
-              </a:rPr>
-              <a:t>Próxima clase (jueves 27): estadística descriptiva, con el entorno ya funcionando.</a:t>
+            <a:r>
+              <a:rPr sz="1300" b="0">
+                <a:solidFill>
+                  <a:srgbClr val="333333"/>
+                </a:solidFill>
+                <a:latin typeface="Fira Sans"/>
+              </a:rPr>
+              <a:t>Uno de cada tres viajes es a pie. Esta versión está ponderada por factores de expansión, así que habla de la ciudad; en el notebook calcularemos la versión muestral, y la diferencia entre ambas abre las clases 2 y 3.</a:t>
             </a:r>
           </a:p>
         </p:txBody>
@@ -7704,6 +7600,265 @@
 </file>
 
 <file path=ppt/slides/slide28.xml><?xml version="1.0" encoding="utf-8"?>
+<p:sld xmlns:a="http://schemas.openxmlformats.org/drawingml/2006/main" xmlns:p="http://schemas.openxmlformats.org/presentationml/2006/main" xmlns:r="http://schemas.openxmlformats.org/officeDocument/2006/relationships">
+  <p:cSld>
+    <p:spTree>
+      <p:nvGrpSpPr>
+        <p:cNvPr id="1" name=""/>
+        <p:cNvGrpSpPr/>
+        <p:nvPr/>
+      </p:nvGrpSpPr>
+      <p:grpSpPr/>
+      <p:sp>
+        <p:nvSpPr>
+          <p:cNvPr id="2" name="Rectangle 1"/>
+          <p:cNvSpPr/>
+          <p:nvPr/>
+        </p:nvSpPr>
+        <p:spPr>
+          <a:xfrm>
+            <a:off x="0" y="0"/>
+            <a:ext cx="9144000" cy="5138928"/>
+          </a:xfrm>
+          <a:prstGeom prst="rect">
+            <a:avLst/>
+          </a:prstGeom>
+          <a:solidFill>
+            <a:srgbClr val="FAFBFC"/>
+          </a:solidFill>
+          <a:ln>
+            <a:noFill/>
+          </a:ln>
+          <a:effectLst/>
+        </p:spPr>
+        <p:style>
+          <a:lnRef idx="1">
+            <a:schemeClr val="accent1"/>
+          </a:lnRef>
+          <a:fillRef idx="3">
+            <a:schemeClr val="accent1"/>
+          </a:fillRef>
+          <a:effectRef idx="2">
+            <a:schemeClr val="accent1"/>
+          </a:effectRef>
+          <a:fontRef idx="minor">
+            <a:schemeClr val="lt1"/>
+          </a:fontRef>
+        </p:style>
+        <p:txBody>
+          <a:bodyPr rtlCol="0" anchor="ctr"/>
+          <a:lstStyle/>
+          <a:p>
+            <a:pPr algn="ctr"/>
+          </a:p>
+        </p:txBody>
+      </p:sp>
+      <p:sp>
+        <p:nvSpPr>
+          <p:cNvPr id="3" name="TextBox 2"/>
+          <p:cNvSpPr txBox="1"/>
+          <p:nvPr/>
+        </p:nvSpPr>
+        <p:spPr>
+          <a:xfrm>
+            <a:off x="402336" y="301752"/>
+            <a:ext cx="8348472" cy="795528"/>
+          </a:xfrm>
+          <a:prstGeom prst="rect">
+            <a:avLst/>
+          </a:prstGeom>
+          <a:noFill/>
+        </p:spPr>
+        <p:txBody>
+          <a:bodyPr wrap="square">
+            <a:spAutoFit/>
+          </a:bodyPr>
+          <a:lstStyle/>
+          <a:p>
+            <a:r>
+              <a:rPr sz="2800" b="1">
+                <a:solidFill>
+                  <a:srgbClr val="0F0F0F"/>
+                </a:solidFill>
+                <a:latin typeface="Fira Sans"/>
+              </a:rPr>
+              <a:t>Síntesis</a:t>
+            </a:r>
+          </a:p>
+        </p:txBody>
+      </p:sp>
+      <p:sp>
+        <p:nvSpPr>
+          <p:cNvPr id="4" name="TextBox 3"/>
+          <p:cNvSpPr txBox="1"/>
+          <p:nvPr/>
+        </p:nvSpPr>
+        <p:spPr>
+          <a:xfrm>
+            <a:off x="704088" y="1353312"/>
+            <a:ext cx="7744968" cy="3300984"/>
+          </a:xfrm>
+          <a:prstGeom prst="rect">
+            <a:avLst/>
+          </a:prstGeom>
+          <a:noFill/>
+        </p:spPr>
+        <p:txBody>
+          <a:bodyPr wrap="square">
+            <a:spAutoFit/>
+          </a:bodyPr>
+          <a:lstStyle/>
+          <a:p>
+            <a:pPr>
+              <a:lnSpc>
+                <a:spcPct val="112000"/>
+              </a:lnSpc>
+              <a:spcAft>
+                <a:spcPts val="900"/>
+              </a:spcAft>
+            </a:pPr>
+            <a:r>
+              <a:rPr sz="1800" b="1">
+                <a:solidFill>
+                  <a:srgbClr val="E0A437"/>
+                </a:solidFill>
+                <a:latin typeface="Fira Sans"/>
+              </a:rPr>
+              <a:t>▸ </a:t>
+            </a:r>
+            <a:r>
+              <a:rPr sz="1800" b="1">
+                <a:solidFill>
+                  <a:srgbClr val="1D3557"/>
+                </a:solidFill>
+                <a:latin typeface="Fira Sans"/>
+              </a:rPr>
+              <a:t>El tipo de cada variable determina qué resúmenes, gráficos y análisis son válidos.</a:t>
+            </a:r>
+          </a:p>
+          <a:p>
+            <a:pPr>
+              <a:lnSpc>
+                <a:spcPct val="112000"/>
+              </a:lnSpc>
+              <a:spcAft>
+                <a:spcPts val="900"/>
+              </a:spcAft>
+            </a:pPr>
+            <a:r>
+              <a:rPr sz="1800" b="1">
+                <a:solidFill>
+                  <a:srgbClr val="E0A437"/>
+                </a:solidFill>
+                <a:latin typeface="Fira Sans"/>
+              </a:rPr>
+              <a:t>▸ </a:t>
+            </a:r>
+            <a:r>
+              <a:rPr sz="1800" b="0">
+                <a:solidFill>
+                  <a:srgbClr val="000000"/>
+                </a:solidFill>
+                <a:latin typeface="Fira Sans"/>
+              </a:rPr>
+              <a:t>Ciencia de datos: extracción generalizable de conocimiento a partir de los datos (Dhar, 2013); combina estadística, computación y dominio.</a:t>
+            </a:r>
+          </a:p>
+          <a:p>
+            <a:pPr>
+              <a:lnSpc>
+                <a:spcPct val="112000"/>
+              </a:lnSpc>
+              <a:spcAft>
+                <a:spcPts val="900"/>
+              </a:spcAft>
+            </a:pPr>
+            <a:r>
+              <a:rPr sz="1800" b="1">
+                <a:solidFill>
+                  <a:srgbClr val="E0A437"/>
+                </a:solidFill>
+                <a:latin typeface="Fira Sans"/>
+              </a:rPr>
+              <a:t>▸ </a:t>
+            </a:r>
+            <a:r>
+              <a:rPr sz="1800" b="0">
+                <a:solidFill>
+                  <a:srgbClr val="000000"/>
+                </a:solidFill>
+                <a:latin typeface="Fira Sans"/>
+              </a:rPr>
+              <a:t>El ciclo de vida tiene dos entradas (una necesidad del dominio o datos disponibles) y se recorre de forma iterativa.</a:t>
+            </a:r>
+          </a:p>
+          <a:p>
+            <a:pPr>
+              <a:lnSpc>
+                <a:spcPct val="112000"/>
+              </a:lnSpc>
+              <a:spcAft>
+                <a:spcPts val="900"/>
+              </a:spcAft>
+            </a:pPr>
+            <a:r>
+              <a:rPr sz="1800" b="1">
+                <a:solidFill>
+                  <a:srgbClr val="E0A437"/>
+                </a:solidFill>
+                <a:latin typeface="Fira Sans"/>
+              </a:rPr>
+              <a:t>▸ </a:t>
+            </a:r>
+            <a:r>
+              <a:rPr sz="1800" b="0">
+                <a:solidFill>
+                  <a:srgbClr val="000000"/>
+                </a:solidFill>
+                <a:latin typeface="Fira Sans"/>
+              </a:rPr>
+              <a:t>La preparación de datos consume cerca de la mitad del tiempo de un proyecto (Anaconda, 2020).</a:t>
+            </a:r>
+          </a:p>
+          <a:p>
+            <a:pPr>
+              <a:lnSpc>
+                <a:spcPct val="112000"/>
+              </a:lnSpc>
+              <a:spcAft>
+                <a:spcPts val="900"/>
+              </a:spcAft>
+            </a:pPr>
+            <a:r>
+              <a:rPr sz="1800" b="1">
+                <a:solidFill>
+                  <a:srgbClr val="E0A437"/>
+                </a:solidFill>
+                <a:latin typeface="Fira Sans"/>
+              </a:rPr>
+              <a:t>▸ </a:t>
+            </a:r>
+            <a:r>
+              <a:rPr sz="1800" b="0">
+                <a:solidFill>
+                  <a:srgbClr val="000000"/>
+                </a:solidFill>
+                <a:latin typeface="Fira Sans"/>
+              </a:rPr>
+              <a:t>Próxima clase (jueves 27): estadística descriptiva, con el entorno ya funcionando.</a:t>
+            </a:r>
+          </a:p>
+        </p:txBody>
+      </p:sp>
+    </p:spTree>
+  </p:cSld>
+  <p:clrMapOvr>
+    <a:masterClrMapping/>
+  </p:clrMapOvr>
+</p:sld>
+</file>
+
+<file path=ppt/slides/slide29.xml><?xml version="1.0" encoding="utf-8"?>
 <p:sld xmlns:a="http://schemas.openxmlformats.org/drawingml/2006/main" xmlns:p="http://schemas.openxmlformats.org/presentationml/2006/main" xmlns:r="http://schemas.openxmlformats.org/officeDocument/2006/relationships">
   <p:cSld>
     <p:spTree>

</xml_diff>

<commit_message>
Pictograma del factor de expansión en deck y notebooks; ejemplo corregido al factor medio real
Co-Authored-By: Claude Fable 5 <noreply@anthropic.com>
</commit_message>
<xml_diff>
--- a/presentaciones/clase01_fundamentos_ecosistema.pptx
+++ b/presentaciones/clase01_fundamentos_ecosistema.pptx
@@ -34,6 +34,7 @@
     <p:sldId id="282" r:id="rId33"/>
     <p:sldId id="283" r:id="rId34"/>
     <p:sldId id="284" r:id="rId35"/>
+    <p:sldId id="285" r:id="rId36"/>
   </p:sldIdLst>
   <p:sldSz cx="9144000" cy="5138928" type="screen4x3"/>
   <p:notesSz cx="6858000" cy="9144000"/>
@@ -7274,16 +7275,40 @@
           </a:p>
         </p:txBody>
       </p:sp>
-      <p:sp>
-        <p:nvSpPr>
-          <p:cNvPr id="4" name="TextBox 3"/>
+      <p:pic>
+        <p:nvPicPr>
+          <p:cNvPr id="4" name="Picture 3" descr="13_factor_expansion.png"/>
+          <p:cNvPicPr>
+            <a:picLocks noChangeAspect="1"/>
+          </p:cNvPicPr>
+          <p:nvPr/>
+        </p:nvPicPr>
+        <p:blipFill>
+          <a:blip r:embed="rId2"/>
+          <a:stretch>
+            <a:fillRect/>
+          </a:stretch>
+        </p:blipFill>
+        <p:spPr>
+          <a:xfrm>
+            <a:off x="1417319" y="1143000"/>
+            <a:ext cx="6309360" cy="2871234"/>
+          </a:xfrm>
+          <a:prstGeom prst="rect">
+            <a:avLst/>
+          </a:prstGeom>
+        </p:spPr>
+      </p:pic>
+      <p:sp>
+        <p:nvSpPr>
+          <p:cNvPr id="5" name="TextBox 4"/>
           <p:cNvSpPr txBox="1"/>
           <p:nvPr/>
         </p:nvSpPr>
         <p:spPr>
           <a:xfrm>
-            <a:off x="704088" y="1353312"/>
-            <a:ext cx="7744968" cy="3300984"/>
+            <a:off x="704088" y="4434840"/>
+            <a:ext cx="7744968" cy="457200"/>
           </a:xfrm>
           <a:prstGeom prst="rect">
             <a:avLst/>
@@ -7296,143 +7321,14 @@
           </a:bodyPr>
           <a:lstStyle/>
           <a:p>
-            <a:pPr>
-              <a:lnSpc>
-                <a:spcPct val="112000"/>
-              </a:lnSpc>
-              <a:spcAft>
-                <a:spcPts val="900"/>
-              </a:spcAft>
-            </a:pPr>
-            <a:r>
-              <a:rPr sz="1800" b="1">
-                <a:solidFill>
-                  <a:srgbClr val="E0A437"/>
-                </a:solidFill>
-                <a:latin typeface="Fira Sans"/>
-              </a:rPr>
-              <a:t>▸ </a:t>
-            </a:r>
-            <a:r>
-              <a:rPr sz="1800" b="0">
-                <a:solidFill>
-                  <a:srgbClr val="000000"/>
-                </a:solidFill>
-                <a:latin typeface="Fira Sans"/>
-              </a:rPr>
-              <a:t>Una encuesta entrevista a una muestra: la EOD, a 60.054 personas de los 6,65 millones de habitantes que cubre.</a:t>
-            </a:r>
-          </a:p>
-          <a:p>
-            <a:pPr>
-              <a:lnSpc>
-                <a:spcPct val="112000"/>
-              </a:lnSpc>
-              <a:spcAft>
-                <a:spcPts val="900"/>
-              </a:spcAft>
-            </a:pPr>
-            <a:r>
-              <a:rPr sz="1800" b="1">
-                <a:solidFill>
-                  <a:srgbClr val="E0A437"/>
-                </a:solidFill>
-                <a:latin typeface="Fira Sans"/>
-              </a:rPr>
-              <a:t>▸ </a:t>
-            </a:r>
-            <a:r>
-              <a:rPr sz="1800" b="0">
-                <a:solidFill>
-                  <a:srgbClr val="000000"/>
-                </a:solidFill>
-                <a:latin typeface="Fira Sans"/>
-              </a:rPr>
-              <a:t>El factor de expansión de cada persona indica a cuántos habitantes representa; sale del diseño muestral (comuna, sexo, edad).</a:t>
-            </a:r>
-          </a:p>
-          <a:p>
-            <a:pPr>
-              <a:lnSpc>
-                <a:spcPct val="112000"/>
-              </a:lnSpc>
-              <a:spcAft>
-                <a:spcPts val="900"/>
-              </a:spcAft>
-            </a:pPr>
-            <a:r>
-              <a:rPr sz="1800" b="1">
-                <a:solidFill>
-                  <a:srgbClr val="E0A437"/>
-                </a:solidFill>
-                <a:latin typeface="Fira Sans"/>
-              </a:rPr>
-              <a:t>▸ </a:t>
-            </a:r>
-            <a:r>
-              <a:rPr sz="1800" b="0">
-                <a:solidFill>
-                  <a:srgbClr val="000000"/>
-                </a:solidFill>
-                <a:latin typeface="Fira Sans"/>
-              </a:rPr>
-              <a:t>La suma de los factores reproduce la población: en la EOD, Factor_LaboralNormal suma 6.651.735.</a:t>
-            </a:r>
-          </a:p>
-          <a:p>
-            <a:pPr>
-              <a:lnSpc>
-                <a:spcPct val="112000"/>
-              </a:lnSpc>
-              <a:spcAft>
-                <a:spcPts val="900"/>
-              </a:spcAft>
-            </a:pPr>
-            <a:r>
-              <a:rPr sz="1800" b="1">
-                <a:solidFill>
-                  <a:srgbClr val="E0A437"/>
-                </a:solidFill>
-                <a:latin typeface="Fira Sans"/>
-              </a:rPr>
-              <a:t>▸ </a:t>
-            </a:r>
-            <a:r>
-              <a:rPr sz="1800" b="1">
-                <a:solidFill>
-                  <a:srgbClr val="1D3557"/>
-                </a:solidFill>
-                <a:latin typeface="Fira Sans"/>
-              </a:rPr>
-              <a:t>Todo resumen tiene dos versiones: muestral (contar filas) y ponderada (sumar factores). ¿De quién habla cada número?</a:t>
-            </a:r>
-          </a:p>
-          <a:p>
-            <a:pPr>
-              <a:lnSpc>
-                <a:spcPct val="112000"/>
-              </a:lnSpc>
-              <a:spcAft>
-                <a:spcPts val="900"/>
-              </a:spcAft>
-            </a:pPr>
-            <a:r>
-              <a:rPr sz="1800" b="1">
-                <a:solidFill>
-                  <a:srgbClr val="E0A437"/>
-                </a:solidFill>
-                <a:latin typeface="Fira Sans"/>
-              </a:rPr>
-              <a:t>▸ </a:t>
-            </a:r>
-            <a:r>
-              <a:rPr sz="1800" b="0">
-                <a:solidFill>
-                  <a:srgbClr val="000000"/>
-                </a:solidFill>
-                <a:latin typeface="Fira Sans"/>
-              </a:rPr>
-              <a:t>En el notebook: 52,8% de mujeres en la muestra, 51,5% ponderado.</a:t>
+            <a:r>
+              <a:rPr sz="1300" b="0">
+                <a:solidFill>
+                  <a:srgbClr val="333333"/>
+                </a:solidFill>
+                <a:latin typeface="Fira Sans"/>
+              </a:rPr>
+              <a:t>Cada persona encuestada representa a muchas otras; su factor de expansión dice a cuántas. La suma de los factores estima la población completa.</a:t>
             </a:r>
           </a:p>
         </p:txBody>
@@ -7528,45 +7424,21 @@
                 </a:solidFill>
                 <a:latin typeface="Fira Sans"/>
               </a:rPr>
-              <a:t>Reparto modal de Santiago, EOD 2012</a:t>
-            </a:r>
-          </a:p>
-        </p:txBody>
-      </p:sp>
-      <p:pic>
-        <p:nvPicPr>
-          <p:cNvPr id="4" name="Picture 3" descr="01_reparto_modal.png"/>
-          <p:cNvPicPr>
-            <a:picLocks noChangeAspect="1"/>
-          </p:cNvPicPr>
-          <p:nvPr/>
-        </p:nvPicPr>
-        <p:blipFill>
-          <a:blip r:embed="rId2"/>
-          <a:stretch>
-            <a:fillRect/>
-          </a:stretch>
-        </p:blipFill>
-        <p:spPr>
-          <a:xfrm>
-            <a:off x="1604462" y="1143000"/>
-            <a:ext cx="5935075" cy="3154680"/>
-          </a:xfrm>
-          <a:prstGeom prst="rect">
-            <a:avLst/>
-          </a:prstGeom>
-        </p:spPr>
-      </p:pic>
-      <p:sp>
-        <p:nvSpPr>
-          <p:cNvPr id="5" name="TextBox 4"/>
+              <a:t>El factor de expansión en los cálculos</a:t>
+            </a:r>
+          </a:p>
+        </p:txBody>
+      </p:sp>
+      <p:sp>
+        <p:nvSpPr>
+          <p:cNvPr id="4" name="TextBox 3"/>
           <p:cNvSpPr txBox="1"/>
           <p:nvPr/>
         </p:nvSpPr>
         <p:spPr>
           <a:xfrm>
-            <a:off x="704088" y="4434840"/>
-            <a:ext cx="7744968" cy="457200"/>
+            <a:off x="704088" y="1353312"/>
+            <a:ext cx="7744968" cy="3300984"/>
           </a:xfrm>
           <a:prstGeom prst="rect">
             <a:avLst/>
@@ -7579,14 +7451,143 @@
           </a:bodyPr>
           <a:lstStyle/>
           <a:p>
-            <a:r>
-              <a:rPr sz="1300" b="0">
-                <a:solidFill>
-                  <a:srgbClr val="333333"/>
-                </a:solidFill>
-                <a:latin typeface="Fira Sans"/>
-              </a:rPr>
-              <a:t>Uno de cada tres viajes es a pie. Esta versión está ponderada por factores de expansión, así que habla de la ciudad; en el notebook calcularemos la versión muestral, y la diferencia entre ambas abre las clases 2 y 3.</a:t>
+            <a:pPr>
+              <a:lnSpc>
+                <a:spcPct val="112000"/>
+              </a:lnSpc>
+              <a:spcAft>
+                <a:spcPts val="900"/>
+              </a:spcAft>
+            </a:pPr>
+            <a:r>
+              <a:rPr sz="1800" b="1">
+                <a:solidFill>
+                  <a:srgbClr val="E0A437"/>
+                </a:solidFill>
+                <a:latin typeface="Fira Sans"/>
+              </a:rPr>
+              <a:t>▸ </a:t>
+            </a:r>
+            <a:r>
+              <a:rPr sz="1800" b="0">
+                <a:solidFill>
+                  <a:srgbClr val="000000"/>
+                </a:solidFill>
+                <a:latin typeface="Fira Sans"/>
+              </a:rPr>
+              <a:t>Una encuesta entrevista a una muestra: la EOD, a 60.054 personas de los 6,65 millones de habitantes que cubre.</a:t>
+            </a:r>
+          </a:p>
+          <a:p>
+            <a:pPr>
+              <a:lnSpc>
+                <a:spcPct val="112000"/>
+              </a:lnSpc>
+              <a:spcAft>
+                <a:spcPts val="900"/>
+              </a:spcAft>
+            </a:pPr>
+            <a:r>
+              <a:rPr sz="1800" b="1">
+                <a:solidFill>
+                  <a:srgbClr val="E0A437"/>
+                </a:solidFill>
+                <a:latin typeface="Fira Sans"/>
+              </a:rPr>
+              <a:t>▸ </a:t>
+            </a:r>
+            <a:r>
+              <a:rPr sz="1800" b="0">
+                <a:solidFill>
+                  <a:srgbClr val="000000"/>
+                </a:solidFill>
+                <a:latin typeface="Fira Sans"/>
+              </a:rPr>
+              <a:t>El factor de expansión de cada persona indica a cuántos habitantes representa; sale del diseño muestral (comuna, sexo, edad).</a:t>
+            </a:r>
+          </a:p>
+          <a:p>
+            <a:pPr>
+              <a:lnSpc>
+                <a:spcPct val="112000"/>
+              </a:lnSpc>
+              <a:spcAft>
+                <a:spcPts val="900"/>
+              </a:spcAft>
+            </a:pPr>
+            <a:r>
+              <a:rPr sz="1800" b="1">
+                <a:solidFill>
+                  <a:srgbClr val="E0A437"/>
+                </a:solidFill>
+                <a:latin typeface="Fira Sans"/>
+              </a:rPr>
+              <a:t>▸ </a:t>
+            </a:r>
+            <a:r>
+              <a:rPr sz="1800" b="0">
+                <a:solidFill>
+                  <a:srgbClr val="000000"/>
+                </a:solidFill>
+                <a:latin typeface="Fira Sans"/>
+              </a:rPr>
+              <a:t>La suma de los factores reproduce la población: en la EOD, Factor_LaboralNormal suma 6.651.735.</a:t>
+            </a:r>
+          </a:p>
+          <a:p>
+            <a:pPr>
+              <a:lnSpc>
+                <a:spcPct val="112000"/>
+              </a:lnSpc>
+              <a:spcAft>
+                <a:spcPts val="900"/>
+              </a:spcAft>
+            </a:pPr>
+            <a:r>
+              <a:rPr sz="1800" b="1">
+                <a:solidFill>
+                  <a:srgbClr val="E0A437"/>
+                </a:solidFill>
+                <a:latin typeface="Fira Sans"/>
+              </a:rPr>
+              <a:t>▸ </a:t>
+            </a:r>
+            <a:r>
+              <a:rPr sz="1800" b="1">
+                <a:solidFill>
+                  <a:srgbClr val="1D3557"/>
+                </a:solidFill>
+                <a:latin typeface="Fira Sans"/>
+              </a:rPr>
+              <a:t>Todo resumen tiene dos versiones: muestral (contar filas) y ponderada (sumar factores). ¿De quién habla cada número?</a:t>
+            </a:r>
+          </a:p>
+          <a:p>
+            <a:pPr>
+              <a:lnSpc>
+                <a:spcPct val="112000"/>
+              </a:lnSpc>
+              <a:spcAft>
+                <a:spcPts val="900"/>
+              </a:spcAft>
+            </a:pPr>
+            <a:r>
+              <a:rPr sz="1800" b="1">
+                <a:solidFill>
+                  <a:srgbClr val="E0A437"/>
+                </a:solidFill>
+                <a:latin typeface="Fira Sans"/>
+              </a:rPr>
+              <a:t>▸ </a:t>
+            </a:r>
+            <a:r>
+              <a:rPr sz="1800" b="0">
+                <a:solidFill>
+                  <a:srgbClr val="000000"/>
+                </a:solidFill>
+                <a:latin typeface="Fira Sans"/>
+              </a:rPr>
+              <a:t>En el notebook: 52,8% de mujeres en la muestra, 51,5% ponderado.</a:t>
             </a:r>
           </a:p>
         </p:txBody>
@@ -7682,21 +7683,45 @@
                 </a:solidFill>
                 <a:latin typeface="Fira Sans"/>
               </a:rPr>
-              <a:t>Síntesis</a:t>
-            </a:r>
-          </a:p>
-        </p:txBody>
-      </p:sp>
-      <p:sp>
-        <p:nvSpPr>
-          <p:cNvPr id="4" name="TextBox 3"/>
+              <a:t>Reparto modal de Santiago, EOD 2012</a:t>
+            </a:r>
+          </a:p>
+        </p:txBody>
+      </p:sp>
+      <p:pic>
+        <p:nvPicPr>
+          <p:cNvPr id="4" name="Picture 3" descr="01_reparto_modal.png"/>
+          <p:cNvPicPr>
+            <a:picLocks noChangeAspect="1"/>
+          </p:cNvPicPr>
+          <p:nvPr/>
+        </p:nvPicPr>
+        <p:blipFill>
+          <a:blip r:embed="rId2"/>
+          <a:stretch>
+            <a:fillRect/>
+          </a:stretch>
+        </p:blipFill>
+        <p:spPr>
+          <a:xfrm>
+            <a:off x="1604462" y="1143000"/>
+            <a:ext cx="5935075" cy="3154680"/>
+          </a:xfrm>
+          <a:prstGeom prst="rect">
+            <a:avLst/>
+          </a:prstGeom>
+        </p:spPr>
+      </p:pic>
+      <p:sp>
+        <p:nvSpPr>
+          <p:cNvPr id="5" name="TextBox 4"/>
           <p:cNvSpPr txBox="1"/>
           <p:nvPr/>
         </p:nvSpPr>
         <p:spPr>
           <a:xfrm>
-            <a:off x="704088" y="1353312"/>
-            <a:ext cx="7744968" cy="3300984"/>
+            <a:off x="704088" y="4434840"/>
+            <a:ext cx="7744968" cy="457200"/>
           </a:xfrm>
           <a:prstGeom prst="rect">
             <a:avLst/>
@@ -7709,143 +7734,14 @@
           </a:bodyPr>
           <a:lstStyle/>
           <a:p>
-            <a:pPr>
-              <a:lnSpc>
-                <a:spcPct val="112000"/>
-              </a:lnSpc>
-              <a:spcAft>
-                <a:spcPts val="900"/>
-              </a:spcAft>
-            </a:pPr>
-            <a:r>
-              <a:rPr sz="1800" b="1">
-                <a:solidFill>
-                  <a:srgbClr val="E0A437"/>
-                </a:solidFill>
-                <a:latin typeface="Fira Sans"/>
-              </a:rPr>
-              <a:t>▸ </a:t>
-            </a:r>
-            <a:r>
-              <a:rPr sz="1800" b="1">
-                <a:solidFill>
-                  <a:srgbClr val="1D3557"/>
-                </a:solidFill>
-                <a:latin typeface="Fira Sans"/>
-              </a:rPr>
-              <a:t>El tipo de cada variable determina qué resúmenes, gráficos y análisis son válidos.</a:t>
-            </a:r>
-          </a:p>
-          <a:p>
-            <a:pPr>
-              <a:lnSpc>
-                <a:spcPct val="112000"/>
-              </a:lnSpc>
-              <a:spcAft>
-                <a:spcPts val="900"/>
-              </a:spcAft>
-            </a:pPr>
-            <a:r>
-              <a:rPr sz="1800" b="1">
-                <a:solidFill>
-                  <a:srgbClr val="E0A437"/>
-                </a:solidFill>
-                <a:latin typeface="Fira Sans"/>
-              </a:rPr>
-              <a:t>▸ </a:t>
-            </a:r>
-            <a:r>
-              <a:rPr sz="1800" b="0">
-                <a:solidFill>
-                  <a:srgbClr val="000000"/>
-                </a:solidFill>
-                <a:latin typeface="Fira Sans"/>
-              </a:rPr>
-              <a:t>Ciencia de datos: extracción generalizable de conocimiento a partir de los datos (Dhar, 2013); combina estadística, computación y dominio.</a:t>
-            </a:r>
-          </a:p>
-          <a:p>
-            <a:pPr>
-              <a:lnSpc>
-                <a:spcPct val="112000"/>
-              </a:lnSpc>
-              <a:spcAft>
-                <a:spcPts val="900"/>
-              </a:spcAft>
-            </a:pPr>
-            <a:r>
-              <a:rPr sz="1800" b="1">
-                <a:solidFill>
-                  <a:srgbClr val="E0A437"/>
-                </a:solidFill>
-                <a:latin typeface="Fira Sans"/>
-              </a:rPr>
-              <a:t>▸ </a:t>
-            </a:r>
-            <a:r>
-              <a:rPr sz="1800" b="0">
-                <a:solidFill>
-                  <a:srgbClr val="000000"/>
-                </a:solidFill>
-                <a:latin typeface="Fira Sans"/>
-              </a:rPr>
-              <a:t>El ciclo de vida tiene dos entradas (una necesidad del dominio o datos disponibles) y se recorre de forma iterativa.</a:t>
-            </a:r>
-          </a:p>
-          <a:p>
-            <a:pPr>
-              <a:lnSpc>
-                <a:spcPct val="112000"/>
-              </a:lnSpc>
-              <a:spcAft>
-                <a:spcPts val="900"/>
-              </a:spcAft>
-            </a:pPr>
-            <a:r>
-              <a:rPr sz="1800" b="1">
-                <a:solidFill>
-                  <a:srgbClr val="E0A437"/>
-                </a:solidFill>
-                <a:latin typeface="Fira Sans"/>
-              </a:rPr>
-              <a:t>▸ </a:t>
-            </a:r>
-            <a:r>
-              <a:rPr sz="1800" b="0">
-                <a:solidFill>
-                  <a:srgbClr val="000000"/>
-                </a:solidFill>
-                <a:latin typeface="Fira Sans"/>
-              </a:rPr>
-              <a:t>La preparación de datos consume cerca de la mitad del tiempo de un proyecto (Anaconda, 2020).</a:t>
-            </a:r>
-          </a:p>
-          <a:p>
-            <a:pPr>
-              <a:lnSpc>
-                <a:spcPct val="112000"/>
-              </a:lnSpc>
-              <a:spcAft>
-                <a:spcPts val="900"/>
-              </a:spcAft>
-            </a:pPr>
-            <a:r>
-              <a:rPr sz="1800" b="1">
-                <a:solidFill>
-                  <a:srgbClr val="E0A437"/>
-                </a:solidFill>
-                <a:latin typeface="Fira Sans"/>
-              </a:rPr>
-              <a:t>▸ </a:t>
-            </a:r>
-            <a:r>
-              <a:rPr sz="1800" b="0">
-                <a:solidFill>
-                  <a:srgbClr val="000000"/>
-                </a:solidFill>
-                <a:latin typeface="Fira Sans"/>
-              </a:rPr>
-              <a:t>Próxima clase (jueves 27): estadística descriptiva, con el entorno ya funcionando.</a:t>
+            <a:r>
+              <a:rPr sz="1300" b="0">
+                <a:solidFill>
+                  <a:srgbClr val="333333"/>
+                </a:solidFill>
+                <a:latin typeface="Fira Sans"/>
+              </a:rPr>
+              <a:t>Uno de cada tres viajes es a pie. Esta versión está ponderada por factores de expansión, así que habla de la ciudad; en el notebook calcularemos la versión muestral, y la diferencia entre ambas abre las clases 2 y 3.</a:t>
             </a:r>
           </a:p>
         </p:txBody>
@@ -7941,7 +7837,7 @@
                 </a:solidFill>
                 <a:latin typeface="Fira Sans"/>
               </a:rPr>
-              <a:t>Referencias</a:t>
+              <a:t>Síntesis</a:t>
             </a:r>
           </a:p>
         </p:txBody>
@@ -7954,8 +7850,8 @@
         </p:nvSpPr>
         <p:spPr>
           <a:xfrm>
-            <a:off x="704088" y="1234440"/>
-            <a:ext cx="7744968" cy="3566160"/>
+            <a:off x="704088" y="1353312"/>
+            <a:ext cx="7744968" cy="3300984"/>
           </a:xfrm>
           <a:prstGeom prst="rect">
             <a:avLst/>
@@ -7970,96 +7866,141 @@
           <a:p>
             <a:pPr>
               <a:lnSpc>
-                <a:spcPct val="115000"/>
+                <a:spcPct val="112000"/>
               </a:lnSpc>
               <a:spcAft>
-                <a:spcPts val="700"/>
+                <a:spcPts val="900"/>
               </a:spcAft>
             </a:pPr>
             <a:r>
-              <a:rPr sz="1300" b="0">
-                <a:solidFill>
-                  <a:srgbClr val="333333"/>
-                </a:solidFill>
-                <a:latin typeface="Fira Sans"/>
-              </a:rPr>
-              <a:t>Anaconda (2020). 2020 State of Data Science. Reporte de encuesta (n=2.360). anaconda.com/resources/whitepaper/state-of-data-science-2020</a:t>
+              <a:rPr sz="1800" b="1">
+                <a:solidFill>
+                  <a:srgbClr val="E0A437"/>
+                </a:solidFill>
+                <a:latin typeface="Fira Sans"/>
+              </a:rPr>
+              <a:t>▸ </a:t>
+            </a:r>
+            <a:r>
+              <a:rPr sz="1800" b="1">
+                <a:solidFill>
+                  <a:srgbClr val="1D3557"/>
+                </a:solidFill>
+                <a:latin typeface="Fira Sans"/>
+              </a:rPr>
+              <a:t>El tipo de cada variable determina qué resúmenes, gráficos y análisis son válidos.</a:t>
             </a:r>
           </a:p>
           <a:p>
             <a:pPr>
               <a:lnSpc>
-                <a:spcPct val="115000"/>
+                <a:spcPct val="112000"/>
               </a:lnSpc>
               <a:spcAft>
-                <a:spcPts val="700"/>
+                <a:spcPts val="900"/>
               </a:spcAft>
             </a:pPr>
             <a:r>
-              <a:rPr sz="1300" b="0">
-                <a:solidFill>
-                  <a:srgbClr val="333333"/>
-                </a:solidFill>
-                <a:latin typeface="Fira Sans"/>
-              </a:rPr>
-              <a:t>Cleveland, W. S. (2001). Data Science: An Action Plan for Expanding the Technical Areas of the Field of Statistics. International Statistical Review, 69(1), 21-26.</a:t>
+              <a:rPr sz="1800" b="1">
+                <a:solidFill>
+                  <a:srgbClr val="E0A437"/>
+                </a:solidFill>
+                <a:latin typeface="Fira Sans"/>
+              </a:rPr>
+              <a:t>▸ </a:t>
+            </a:r>
+            <a:r>
+              <a:rPr sz="1800" b="0">
+                <a:solidFill>
+                  <a:srgbClr val="000000"/>
+                </a:solidFill>
+                <a:latin typeface="Fira Sans"/>
+              </a:rPr>
+              <a:t>Ciencia de datos: extracción generalizable de conocimiento a partir de los datos (Dhar, 2013); combina estadística, computación y dominio.</a:t>
             </a:r>
           </a:p>
           <a:p>
             <a:pPr>
               <a:lnSpc>
-                <a:spcPct val="115000"/>
+                <a:spcPct val="112000"/>
               </a:lnSpc>
               <a:spcAft>
-                <a:spcPts val="700"/>
+                <a:spcPts val="900"/>
               </a:spcAft>
             </a:pPr>
             <a:r>
-              <a:rPr sz="1300" b="0">
-                <a:solidFill>
-                  <a:srgbClr val="333333"/>
-                </a:solidFill>
-                <a:latin typeface="Fira Sans"/>
-              </a:rPr>
-              <a:t>Dhar, V. (2013). Data Science and Prediction. Communications of the ACM, 56(12), 64-73.</a:t>
+              <a:rPr sz="1800" b="1">
+                <a:solidFill>
+                  <a:srgbClr val="E0A437"/>
+                </a:solidFill>
+                <a:latin typeface="Fira Sans"/>
+              </a:rPr>
+              <a:t>▸ </a:t>
+            </a:r>
+            <a:r>
+              <a:rPr sz="1800" b="0">
+                <a:solidFill>
+                  <a:srgbClr val="000000"/>
+                </a:solidFill>
+                <a:latin typeface="Fira Sans"/>
+              </a:rPr>
+              <a:t>El ciclo de vida tiene dos entradas (una necesidad del dominio o datos disponibles) y se recorre de forma iterativa.</a:t>
             </a:r>
           </a:p>
           <a:p>
             <a:pPr>
               <a:lnSpc>
-                <a:spcPct val="115000"/>
+                <a:spcPct val="112000"/>
               </a:lnSpc>
               <a:spcAft>
-                <a:spcPts val="700"/>
+                <a:spcPts val="900"/>
               </a:spcAft>
             </a:pPr>
             <a:r>
-              <a:rPr sz="1300" b="0">
-                <a:solidFill>
-                  <a:srgbClr val="333333"/>
-                </a:solidFill>
-                <a:latin typeface="Fira Sans"/>
-              </a:rPr>
-              <a:t>Donoho, D. (2017). 50 Years of Data Science. Journal of Computational and Graphical Statistics, 26(4), 745-766.</a:t>
+              <a:rPr sz="1800" b="1">
+                <a:solidFill>
+                  <a:srgbClr val="E0A437"/>
+                </a:solidFill>
+                <a:latin typeface="Fira Sans"/>
+              </a:rPr>
+              <a:t>▸ </a:t>
+            </a:r>
+            <a:r>
+              <a:rPr sz="1800" b="0">
+                <a:solidFill>
+                  <a:srgbClr val="000000"/>
+                </a:solidFill>
+                <a:latin typeface="Fira Sans"/>
+              </a:rPr>
+              <a:t>La preparación de datos consume cerca de la mitad del tiempo de un proyecto (Anaconda, 2020).</a:t>
             </a:r>
           </a:p>
           <a:p>
             <a:pPr>
               <a:lnSpc>
-                <a:spcPct val="115000"/>
+                <a:spcPct val="112000"/>
               </a:lnSpc>
               <a:spcAft>
-                <a:spcPts val="700"/>
+                <a:spcPts val="900"/>
               </a:spcAft>
             </a:pPr>
             <a:r>
-              <a:rPr sz="1300" b="0">
-                <a:solidFill>
-                  <a:srgbClr val="333333"/>
-                </a:solidFill>
-                <a:latin typeface="Fira Sans"/>
-              </a:rPr>
-              <a:t>VanderPlas, J. (2016). Python Data Science Handbook. O'Reilly. Versión en línea: jakevdp.github.io/PythonDataScienceHandbook</a:t>
+              <a:rPr sz="1800" b="1">
+                <a:solidFill>
+                  <a:srgbClr val="E0A437"/>
+                </a:solidFill>
+                <a:latin typeface="Fira Sans"/>
+              </a:rPr>
+              <a:t>▸ </a:t>
+            </a:r>
+            <a:r>
+              <a:rPr sz="1800" b="0">
+                <a:solidFill>
+                  <a:srgbClr val="000000"/>
+                </a:solidFill>
+                <a:latin typeface="Fira Sans"/>
+              </a:rPr>
+              <a:t>Próxima clase (jueves 27): estadística descriptiva, con el entorno ya funcionando.</a:t>
             </a:r>
           </a:p>
         </p:txBody>
@@ -8167,6 +8108,220 @@
                 <a:latin typeface="Fira Sans"/>
               </a:rPr>
               <a:t>Definición, componentes y objetivos</a:t>
+            </a:r>
+          </a:p>
+        </p:txBody>
+      </p:sp>
+    </p:spTree>
+  </p:cSld>
+  <p:clrMapOvr>
+    <a:masterClrMapping/>
+  </p:clrMapOvr>
+</p:sld>
+</file>
+
+<file path=ppt/slides/slide30.xml><?xml version="1.0" encoding="utf-8"?>
+<p:sld xmlns:a="http://schemas.openxmlformats.org/drawingml/2006/main" xmlns:p="http://schemas.openxmlformats.org/presentationml/2006/main" xmlns:r="http://schemas.openxmlformats.org/officeDocument/2006/relationships">
+  <p:cSld>
+    <p:spTree>
+      <p:nvGrpSpPr>
+        <p:cNvPr id="1" name=""/>
+        <p:cNvGrpSpPr/>
+        <p:nvPr/>
+      </p:nvGrpSpPr>
+      <p:grpSpPr/>
+      <p:sp>
+        <p:nvSpPr>
+          <p:cNvPr id="2" name="Rectangle 1"/>
+          <p:cNvSpPr/>
+          <p:nvPr/>
+        </p:nvSpPr>
+        <p:spPr>
+          <a:xfrm>
+            <a:off x="0" y="0"/>
+            <a:ext cx="9144000" cy="5138928"/>
+          </a:xfrm>
+          <a:prstGeom prst="rect">
+            <a:avLst/>
+          </a:prstGeom>
+          <a:solidFill>
+            <a:srgbClr val="FAFBFC"/>
+          </a:solidFill>
+          <a:ln>
+            <a:noFill/>
+          </a:ln>
+          <a:effectLst/>
+        </p:spPr>
+        <p:style>
+          <a:lnRef idx="1">
+            <a:schemeClr val="accent1"/>
+          </a:lnRef>
+          <a:fillRef idx="3">
+            <a:schemeClr val="accent1"/>
+          </a:fillRef>
+          <a:effectRef idx="2">
+            <a:schemeClr val="accent1"/>
+          </a:effectRef>
+          <a:fontRef idx="minor">
+            <a:schemeClr val="lt1"/>
+          </a:fontRef>
+        </p:style>
+        <p:txBody>
+          <a:bodyPr rtlCol="0" anchor="ctr"/>
+          <a:lstStyle/>
+          <a:p>
+            <a:pPr algn="ctr"/>
+          </a:p>
+        </p:txBody>
+      </p:sp>
+      <p:sp>
+        <p:nvSpPr>
+          <p:cNvPr id="3" name="TextBox 2"/>
+          <p:cNvSpPr txBox="1"/>
+          <p:nvPr/>
+        </p:nvSpPr>
+        <p:spPr>
+          <a:xfrm>
+            <a:off x="402336" y="301752"/>
+            <a:ext cx="8348472" cy="795528"/>
+          </a:xfrm>
+          <a:prstGeom prst="rect">
+            <a:avLst/>
+          </a:prstGeom>
+          <a:noFill/>
+        </p:spPr>
+        <p:txBody>
+          <a:bodyPr wrap="square">
+            <a:spAutoFit/>
+          </a:bodyPr>
+          <a:lstStyle/>
+          <a:p>
+            <a:r>
+              <a:rPr sz="2800" b="1">
+                <a:solidFill>
+                  <a:srgbClr val="0F0F0F"/>
+                </a:solidFill>
+                <a:latin typeface="Fira Sans"/>
+              </a:rPr>
+              <a:t>Referencias</a:t>
+            </a:r>
+          </a:p>
+        </p:txBody>
+      </p:sp>
+      <p:sp>
+        <p:nvSpPr>
+          <p:cNvPr id="4" name="TextBox 3"/>
+          <p:cNvSpPr txBox="1"/>
+          <p:nvPr/>
+        </p:nvSpPr>
+        <p:spPr>
+          <a:xfrm>
+            <a:off x="704088" y="1234440"/>
+            <a:ext cx="7744968" cy="3566160"/>
+          </a:xfrm>
+          <a:prstGeom prst="rect">
+            <a:avLst/>
+          </a:prstGeom>
+          <a:noFill/>
+        </p:spPr>
+        <p:txBody>
+          <a:bodyPr wrap="square">
+            <a:spAutoFit/>
+          </a:bodyPr>
+          <a:lstStyle/>
+          <a:p>
+            <a:pPr>
+              <a:lnSpc>
+                <a:spcPct val="115000"/>
+              </a:lnSpc>
+              <a:spcAft>
+                <a:spcPts val="700"/>
+              </a:spcAft>
+            </a:pPr>
+            <a:r>
+              <a:rPr sz="1300" b="0">
+                <a:solidFill>
+                  <a:srgbClr val="333333"/>
+                </a:solidFill>
+                <a:latin typeface="Fira Sans"/>
+              </a:rPr>
+              <a:t>Anaconda (2020). 2020 State of Data Science. Reporte de encuesta (n=2.360). anaconda.com/resources/whitepaper/state-of-data-science-2020</a:t>
+            </a:r>
+          </a:p>
+          <a:p>
+            <a:pPr>
+              <a:lnSpc>
+                <a:spcPct val="115000"/>
+              </a:lnSpc>
+              <a:spcAft>
+                <a:spcPts val="700"/>
+              </a:spcAft>
+            </a:pPr>
+            <a:r>
+              <a:rPr sz="1300" b="0">
+                <a:solidFill>
+                  <a:srgbClr val="333333"/>
+                </a:solidFill>
+                <a:latin typeface="Fira Sans"/>
+              </a:rPr>
+              <a:t>Cleveland, W. S. (2001). Data Science: An Action Plan for Expanding the Technical Areas of the Field of Statistics. International Statistical Review, 69(1), 21-26.</a:t>
+            </a:r>
+          </a:p>
+          <a:p>
+            <a:pPr>
+              <a:lnSpc>
+                <a:spcPct val="115000"/>
+              </a:lnSpc>
+              <a:spcAft>
+                <a:spcPts val="700"/>
+              </a:spcAft>
+            </a:pPr>
+            <a:r>
+              <a:rPr sz="1300" b="0">
+                <a:solidFill>
+                  <a:srgbClr val="333333"/>
+                </a:solidFill>
+                <a:latin typeface="Fira Sans"/>
+              </a:rPr>
+              <a:t>Dhar, V. (2013). Data Science and Prediction. Communications of the ACM, 56(12), 64-73.</a:t>
+            </a:r>
+          </a:p>
+          <a:p>
+            <a:pPr>
+              <a:lnSpc>
+                <a:spcPct val="115000"/>
+              </a:lnSpc>
+              <a:spcAft>
+                <a:spcPts val="700"/>
+              </a:spcAft>
+            </a:pPr>
+            <a:r>
+              <a:rPr sz="1300" b="0">
+                <a:solidFill>
+                  <a:srgbClr val="333333"/>
+                </a:solidFill>
+                <a:latin typeface="Fira Sans"/>
+              </a:rPr>
+              <a:t>Donoho, D. (2017). 50 Years of Data Science. Journal of Computational and Graphical Statistics, 26(4), 745-766.</a:t>
+            </a:r>
+          </a:p>
+          <a:p>
+            <a:pPr>
+              <a:lnSpc>
+                <a:spcPct val="115000"/>
+              </a:lnSpc>
+              <a:spcAft>
+                <a:spcPts val="700"/>
+              </a:spcAft>
+            </a:pPr>
+            <a:r>
+              <a:rPr sz="1300" b="0">
+                <a:solidFill>
+                  <a:srgbClr val="333333"/>
+                </a:solidFill>
+                <a:latin typeface="Fira Sans"/>
+              </a:rPr>
+              <a:t>VanderPlas, J. (2016). Python Data Science Handbook. O'Reilly. Versión en línea: jakevdp.github.io/PythonDataScienceHandbook</a:t>
             </a:r>
           </a:p>
         </p:txBody>

</xml_diff>

<commit_message>
Tres gráficos básicos a ancho completo con letra mayor; precisión sobre los factores por tipo de día y el ajuste a nivel de viaje
Co-Authored-By: Claude Fable 5 <noreply@anthropic.com>
</commit_message>
<xml_diff>
--- a/presentaciones/clase01_fundamentos_ecosistema.pptx
+++ b/presentaciones/clase01_fundamentos_ecosistema.pptx
@@ -7137,8 +7137,8 @@
         </p:blipFill>
         <p:spPr>
           <a:xfrm>
-            <a:off x="1417319" y="1143000"/>
-            <a:ext cx="6309360" cy="1854976"/>
+            <a:off x="320040" y="1234440"/>
+            <a:ext cx="8503920" cy="2715401"/>
           </a:xfrm>
           <a:prstGeom prst="rect">
             <a:avLst/>
@@ -7153,8 +7153,8 @@
         </p:nvSpPr>
         <p:spPr>
           <a:xfrm>
-            <a:off x="704088" y="4434840"/>
-            <a:ext cx="7744968" cy="457200"/>
+            <a:off x="502920" y="4251960"/>
+            <a:ext cx="8138160" cy="731520"/>
           </a:xfrm>
           <a:prstGeom prst="rect">
             <a:avLst/>

</xml_diff>

<commit_message>
Fuera la slide de merge; el concepto queda en el diagrama de tablas y en el notebook
Co-Authored-By: Claude Fable 5 <noreply@anthropic.com>
</commit_message>
<xml_diff>
--- a/presentaciones/clase01_fundamentos_ecosistema.pptx
+++ b/presentaciones/clase01_fundamentos_ecosistema.pptx
@@ -34,7 +34,6 @@
     <p:sldId id="282" r:id="rId33"/>
     <p:sldId id="283" r:id="rId34"/>
     <p:sldId id="284" r:id="rId35"/>
-    <p:sldId id="285" r:id="rId36"/>
   </p:sldIdLst>
   <p:sldSz cx="9144000" cy="5138928" type="screen4x3"/>
   <p:notesSz cx="6858000" cy="9144000"/>
@@ -6615,88 +6614,21 @@
                 </a:solidFill>
                 <a:latin typeface="Fira Sans"/>
               </a:rPr>
-              <a:t>Pandas: unir tablas con merge</a:t>
-            </a:r>
-          </a:p>
-        </p:txBody>
-      </p:sp>
-      <p:sp>
-        <p:nvSpPr>
-          <p:cNvPr id="4" name="Rectangle 3"/>
-          <p:cNvSpPr/>
-          <p:nvPr/>
-        </p:nvSpPr>
-        <p:spPr>
-          <a:xfrm>
-            <a:off x="704088" y="1280160"/>
-            <a:ext cx="7744968" cy="1371600"/>
-          </a:xfrm>
-          <a:prstGeom prst="rect">
-            <a:avLst/>
-          </a:prstGeom>
-          <a:solidFill>
-            <a:srgbClr val="F0F2F5"/>
-          </a:solidFill>
-          <a:ln>
-            <a:solidFill>
-              <a:srgbClr val="D8DDE3"/>
-            </a:solidFill>
-          </a:ln>
-          <a:effectLst/>
-        </p:spPr>
-        <p:style>
-          <a:lnRef idx="1">
-            <a:schemeClr val="accent1"/>
-          </a:lnRef>
-          <a:fillRef idx="3">
-            <a:schemeClr val="accent1"/>
-          </a:fillRef>
-          <a:effectRef idx="2">
-            <a:schemeClr val="accent1"/>
-          </a:effectRef>
-          <a:fontRef idx="minor">
-            <a:schemeClr val="lt1"/>
-          </a:fontRef>
-        </p:style>
-        <p:txBody>
-          <a:bodyPr rtlCol="0" anchor="ctr" wrap="square" lIns="228600" tIns="137160"/>
-          <a:lstStyle/>
-          <a:p>
-            <a:pPr/>
-            <a:r>
-              <a:rPr sz="1500" b="0">
-                <a:solidFill>
-                  <a:srgbClr val="1D3557"/>
-                </a:solidFill>
-                <a:latin typeface="Menlo"/>
-              </a:rPr>
-              <a:t>comunas = pd.read_csv(URL_COMUNAS)   # Id, Comuna</a:t>
-            </a:r>
-          </a:p>
-          <a:p>
-            <a:pPr/>
-            <a:r>
-              <a:rPr sz="1500" b="0">
-                <a:solidFill>
-                  <a:srgbClr val="1D3557"/>
-                </a:solidFill>
-                <a:latin typeface="Menlo"/>
-              </a:rPr>
-              <a:t>viajes.merge(comunas, left_on="ComunaOrigen", right_on="Id")</a:t>
-            </a:r>
-          </a:p>
-        </p:txBody>
-      </p:sp>
-      <p:sp>
-        <p:nvSpPr>
-          <p:cNvPr id="5" name="TextBox 4"/>
+              <a:t>El DataFrame no es exclusivo de Pandas</a:t>
+            </a:r>
+          </a:p>
+        </p:txBody>
+      </p:sp>
+      <p:sp>
+        <p:nvSpPr>
+          <p:cNvPr id="4" name="TextBox 3"/>
           <p:cNvSpPr txBox="1"/>
           <p:nvPr/>
         </p:nvSpPr>
         <p:spPr>
           <a:xfrm>
-            <a:off x="704088" y="2880360"/>
-            <a:ext cx="7744968" cy="1097280"/>
+            <a:off x="704088" y="1353312"/>
+            <a:ext cx="7744968" cy="3300984"/>
           </a:xfrm>
           <a:prstGeom prst="rect">
             <a:avLst/>
@@ -6718,7 +6650,7 @@
               </a:spcAft>
             </a:pPr>
             <a:r>
-              <a:rPr sz="1600" b="1">
+              <a:rPr sz="1800" b="1">
                 <a:solidFill>
                   <a:srgbClr val="E0A437"/>
                 </a:solidFill>
@@ -6727,13 +6659,153 @@
               <a:t>▸ </a:t>
             </a:r>
             <a:r>
-              <a:rPr sz="1600" b="0">
+              <a:rPr sz="1800" b="0">
                 <a:solidFill>
                   <a:srgbClr val="000000"/>
                 </a:solidFill>
                 <a:latin typeface="Fira Sans"/>
               </a:rPr>
-              <a:t>Los códigos de una tabla se traducen uniéndola con su tabla de parámetros: merge empareja filas por una columna común. En el notebook lo usamos para ponerle nombre a comunas y modos de viaje.</a:t>
+              <a:t>Varias herramientas usan la misma abstracción de tabla, y Pandas no siempre es la mejor opción cuando los datos crecen:</a:t>
+            </a:r>
+          </a:p>
+          <a:p>
+            <a:pPr>
+              <a:lnSpc>
+                <a:spcPct val="112000"/>
+              </a:lnSpc>
+              <a:spcAft>
+                <a:spcPts val="500"/>
+              </a:spcAft>
+            </a:pPr>
+            <a:r>
+              <a:rPr sz="1400" b="0">
+                <a:solidFill>
+                  <a:srgbClr val="333333"/>
+                </a:solidFill>
+                <a:latin typeface="Fira Sans"/>
+              </a:rPr>
+              <a:t>     ◦  </a:t>
+            </a:r>
+            <a:r>
+              <a:rPr sz="1400" b="0">
+                <a:solidFill>
+                  <a:srgbClr val="333333"/>
+                </a:solidFill>
+                <a:latin typeface="Fira Sans"/>
+              </a:rPr>
+              <a:t>Polars: DataFrames implementados en Rust, más rápidos y eficientes en memoria.</a:t>
+            </a:r>
+          </a:p>
+          <a:p>
+            <a:pPr>
+              <a:lnSpc>
+                <a:spcPct val="112000"/>
+              </a:lnSpc>
+              <a:spcAft>
+                <a:spcPts val="500"/>
+              </a:spcAft>
+            </a:pPr>
+            <a:r>
+              <a:rPr sz="1400" b="0">
+                <a:solidFill>
+                  <a:srgbClr val="333333"/>
+                </a:solidFill>
+                <a:latin typeface="Fira Sans"/>
+              </a:rPr>
+              <a:t>     ◦  </a:t>
+            </a:r>
+            <a:r>
+              <a:rPr sz="1400" b="0">
+                <a:solidFill>
+                  <a:srgbClr val="333333"/>
+                </a:solidFill>
+                <a:latin typeface="Fira Sans"/>
+              </a:rPr>
+              <a:t>Apache Spark: DataFrames distribuidos en un clúster, para volúmenes que no caben en una máquina.</a:t>
+            </a:r>
+          </a:p>
+          <a:p>
+            <a:pPr>
+              <a:lnSpc>
+                <a:spcPct val="112000"/>
+              </a:lnSpc>
+              <a:spcAft>
+                <a:spcPts val="500"/>
+              </a:spcAft>
+            </a:pPr>
+            <a:r>
+              <a:rPr sz="1400" b="0">
+                <a:solidFill>
+                  <a:srgbClr val="333333"/>
+                </a:solidFill>
+                <a:latin typeface="Fira Sans"/>
+              </a:rPr>
+              <a:t>     ◦  </a:t>
+            </a:r>
+            <a:r>
+              <a:rPr sz="1400" b="0">
+                <a:solidFill>
+                  <a:srgbClr val="333333"/>
+                </a:solidFill>
+                <a:latin typeface="Fira Sans"/>
+              </a:rPr>
+              <a:t>Dask: paraleliza la interfaz de Pandas sobre varios núcleos o máquinas.</a:t>
+            </a:r>
+          </a:p>
+          <a:p>
+            <a:pPr>
+              <a:lnSpc>
+                <a:spcPct val="112000"/>
+              </a:lnSpc>
+              <a:spcAft>
+                <a:spcPts val="500"/>
+              </a:spcAft>
+            </a:pPr>
+            <a:r>
+              <a:rPr sz="1400" b="0">
+                <a:solidFill>
+                  <a:srgbClr val="333333"/>
+                </a:solidFill>
+                <a:latin typeface="Fira Sans"/>
+              </a:rPr>
+              <a:t>     ◦  </a:t>
+            </a:r>
+            <a:r>
+              <a:rPr sz="1400" b="0">
+                <a:solidFill>
+                  <a:srgbClr val="333333"/>
+                </a:solidFill>
+                <a:latin typeface="Fira Sans"/>
+              </a:rPr>
+              <a:t>DuckDB: consultas SQL directas sobre archivos y DataFrames.</a:t>
+            </a:r>
+          </a:p>
+          <a:p>
+            <a:pPr>
+              <a:lnSpc>
+                <a:spcPct val="112000"/>
+              </a:lnSpc>
+              <a:spcAft>
+                <a:spcPts val="900"/>
+              </a:spcAft>
+            </a:pPr>
+            <a:r>
+              <a:rPr sz="1800" b="1">
+                <a:solidFill>
+                  <a:srgbClr val="E0A437"/>
+                </a:solidFill>
+                <a:latin typeface="Fira Sans"/>
+              </a:rPr>
+              <a:t>▸ </a:t>
+            </a:r>
+            <a:r>
+              <a:rPr sz="1800" b="0">
+                <a:solidFill>
+                  <a:srgbClr val="000000"/>
+                </a:solidFill>
+                <a:latin typeface="Fira Sans"/>
+              </a:rPr>
+              <a:t>En este módulo usamos Pandas: es el estándar para el análisis interactivo con datos de tamaño pequeño y mediano, y su interfaz es la referencia que las demás herramientas siguen.</a:t>
             </a:r>
           </a:p>
         </p:txBody>
@@ -6829,21 +6901,45 @@
                 </a:solidFill>
                 <a:latin typeface="Fira Sans"/>
               </a:rPr>
-              <a:t>El DataFrame no es exclusivo de Pandas</a:t>
-            </a:r>
-          </a:p>
-        </p:txBody>
-      </p:sp>
-      <p:sp>
-        <p:nvSpPr>
-          <p:cNvPr id="4" name="TextBox 3"/>
+              <a:t>Matplotlib: tres gráficos básicos</a:t>
+            </a:r>
+          </a:p>
+        </p:txBody>
+      </p:sp>
+      <p:pic>
+        <p:nvPicPr>
+          <p:cNvPr id="4" name="Picture 3" descr="11_tres_graficos.png"/>
+          <p:cNvPicPr>
+            <a:picLocks noChangeAspect="1"/>
+          </p:cNvPicPr>
+          <p:nvPr/>
+        </p:nvPicPr>
+        <p:blipFill>
+          <a:blip r:embed="rId2"/>
+          <a:stretch>
+            <a:fillRect/>
+          </a:stretch>
+        </p:blipFill>
+        <p:spPr>
+          <a:xfrm>
+            <a:off x="320040" y="1234440"/>
+            <a:ext cx="8503920" cy="2715401"/>
+          </a:xfrm>
+          <a:prstGeom prst="rect">
+            <a:avLst/>
+          </a:prstGeom>
+        </p:spPr>
+      </p:pic>
+      <p:sp>
+        <p:nvSpPr>
+          <p:cNvPr id="5" name="TextBox 4"/>
           <p:cNvSpPr txBox="1"/>
           <p:nvPr/>
         </p:nvSpPr>
         <p:spPr>
           <a:xfrm>
-            <a:off x="704088" y="1353312"/>
-            <a:ext cx="7744968" cy="3300984"/>
+            <a:off x="502920" y="4251960"/>
+            <a:ext cx="8138160" cy="731520"/>
           </a:xfrm>
           <a:prstGeom prst="rect">
             <a:avLst/>
@@ -6856,171 +6952,14 @@
           </a:bodyPr>
           <a:lstStyle/>
           <a:p>
-            <a:pPr>
-              <a:lnSpc>
-                <a:spcPct val="112000"/>
-              </a:lnSpc>
-              <a:spcAft>
-                <a:spcPts val="900"/>
-              </a:spcAft>
-            </a:pPr>
-            <a:r>
-              <a:rPr sz="1800" b="1">
-                <a:solidFill>
-                  <a:srgbClr val="E0A437"/>
-                </a:solidFill>
-                <a:latin typeface="Fira Sans"/>
-              </a:rPr>
-              <a:t>▸ </a:t>
-            </a:r>
-            <a:r>
-              <a:rPr sz="1800" b="0">
-                <a:solidFill>
-                  <a:srgbClr val="000000"/>
-                </a:solidFill>
-                <a:latin typeface="Fira Sans"/>
-              </a:rPr>
-              <a:t>Varias herramientas usan la misma abstracción de tabla, y Pandas no siempre es la mejor opción cuando los datos crecen:</a:t>
-            </a:r>
-          </a:p>
-          <a:p>
-            <a:pPr>
-              <a:lnSpc>
-                <a:spcPct val="112000"/>
-              </a:lnSpc>
-              <a:spcAft>
-                <a:spcPts val="500"/>
-              </a:spcAft>
-            </a:pPr>
-            <a:r>
-              <a:rPr sz="1400" b="0">
+            <a:r>
+              <a:rPr sz="1300" b="0">
                 <a:solidFill>
                   <a:srgbClr val="333333"/>
                 </a:solidFill>
                 <a:latin typeface="Fira Sans"/>
               </a:rPr>
-              <a:t>     ◦  </a:t>
-            </a:r>
-            <a:r>
-              <a:rPr sz="1400" b="0">
-                <a:solidFill>
-                  <a:srgbClr val="333333"/>
-                </a:solidFill>
-                <a:latin typeface="Fira Sans"/>
-              </a:rPr>
-              <a:t>Polars: DataFrames implementados en Rust, más rápidos y eficientes en memoria.</a:t>
-            </a:r>
-          </a:p>
-          <a:p>
-            <a:pPr>
-              <a:lnSpc>
-                <a:spcPct val="112000"/>
-              </a:lnSpc>
-              <a:spcAft>
-                <a:spcPts val="500"/>
-              </a:spcAft>
-            </a:pPr>
-            <a:r>
-              <a:rPr sz="1400" b="0">
-                <a:solidFill>
-                  <a:srgbClr val="333333"/>
-                </a:solidFill>
-                <a:latin typeface="Fira Sans"/>
-              </a:rPr>
-              <a:t>     ◦  </a:t>
-            </a:r>
-            <a:r>
-              <a:rPr sz="1400" b="0">
-                <a:solidFill>
-                  <a:srgbClr val="333333"/>
-                </a:solidFill>
-                <a:latin typeface="Fira Sans"/>
-              </a:rPr>
-              <a:t>Apache Spark: DataFrames distribuidos en un clúster, para volúmenes que no caben en una máquina.</a:t>
-            </a:r>
-          </a:p>
-          <a:p>
-            <a:pPr>
-              <a:lnSpc>
-                <a:spcPct val="112000"/>
-              </a:lnSpc>
-              <a:spcAft>
-                <a:spcPts val="500"/>
-              </a:spcAft>
-            </a:pPr>
-            <a:r>
-              <a:rPr sz="1400" b="0">
-                <a:solidFill>
-                  <a:srgbClr val="333333"/>
-                </a:solidFill>
-                <a:latin typeface="Fira Sans"/>
-              </a:rPr>
-              <a:t>     ◦  </a:t>
-            </a:r>
-            <a:r>
-              <a:rPr sz="1400" b="0">
-                <a:solidFill>
-                  <a:srgbClr val="333333"/>
-                </a:solidFill>
-                <a:latin typeface="Fira Sans"/>
-              </a:rPr>
-              <a:t>Dask: paraleliza la interfaz de Pandas sobre varios núcleos o máquinas.</a:t>
-            </a:r>
-          </a:p>
-          <a:p>
-            <a:pPr>
-              <a:lnSpc>
-                <a:spcPct val="112000"/>
-              </a:lnSpc>
-              <a:spcAft>
-                <a:spcPts val="500"/>
-              </a:spcAft>
-            </a:pPr>
-            <a:r>
-              <a:rPr sz="1400" b="0">
-                <a:solidFill>
-                  <a:srgbClr val="333333"/>
-                </a:solidFill>
-                <a:latin typeface="Fira Sans"/>
-              </a:rPr>
-              <a:t>     ◦  </a:t>
-            </a:r>
-            <a:r>
-              <a:rPr sz="1400" b="0">
-                <a:solidFill>
-                  <a:srgbClr val="333333"/>
-                </a:solidFill>
-                <a:latin typeface="Fira Sans"/>
-              </a:rPr>
-              <a:t>DuckDB: consultas SQL directas sobre archivos y DataFrames.</a:t>
-            </a:r>
-          </a:p>
-          <a:p>
-            <a:pPr>
-              <a:lnSpc>
-                <a:spcPct val="112000"/>
-              </a:lnSpc>
-              <a:spcAft>
-                <a:spcPts val="900"/>
-              </a:spcAft>
-            </a:pPr>
-            <a:r>
-              <a:rPr sz="1800" b="1">
-                <a:solidFill>
-                  <a:srgbClr val="E0A437"/>
-                </a:solidFill>
-                <a:latin typeface="Fira Sans"/>
-              </a:rPr>
-              <a:t>▸ </a:t>
-            </a:r>
-            <a:r>
-              <a:rPr sz="1800" b="0">
-                <a:solidFill>
-                  <a:srgbClr val="000000"/>
-                </a:solidFill>
-                <a:latin typeface="Fira Sans"/>
-              </a:rPr>
-              <a:t>En este módulo usamos Pandas: es el estándar para el análisis interactivo con datos de tamaño pequeño y mediano, y su interfaz es la referencia que las demás herramientas siguen.</a:t>
+              <a:t>El gráfico depende del tipo de variable: barras para una cualitativa, histograma para una cuantitativa, dispersión para dos cuantitativas. Los tres salen de la tabla de viajes y se construyen en el notebook.</a:t>
             </a:r>
           </a:p>
         </p:txBody>
@@ -7116,14 +7055,14 @@
                 </a:solidFill>
                 <a:latin typeface="Fira Sans"/>
               </a:rPr>
-              <a:t>Matplotlib: tres gráficos básicos</a:t>
+              <a:t>El factor de expansión</a:t>
             </a:r>
           </a:p>
         </p:txBody>
       </p:sp>
       <p:pic>
         <p:nvPicPr>
-          <p:cNvPr id="4" name="Picture 3" descr="11_tres_graficos.png"/>
+          <p:cNvPr id="4" name="Picture 3" descr="13_factor_expansion.png"/>
           <p:cNvPicPr>
             <a:picLocks noChangeAspect="1"/>
           </p:cNvPicPr>
@@ -7137,8 +7076,8 @@
         </p:blipFill>
         <p:spPr>
           <a:xfrm>
-            <a:off x="320040" y="1234440"/>
-            <a:ext cx="8503920" cy="2715401"/>
+            <a:off x="1417319" y="1143000"/>
+            <a:ext cx="6309360" cy="2871234"/>
           </a:xfrm>
           <a:prstGeom prst="rect">
             <a:avLst/>
@@ -7153,8 +7092,8 @@
         </p:nvSpPr>
         <p:spPr>
           <a:xfrm>
-            <a:off x="502920" y="4251960"/>
-            <a:ext cx="8138160" cy="731520"/>
+            <a:off x="704088" y="4434840"/>
+            <a:ext cx="7744968" cy="457200"/>
           </a:xfrm>
           <a:prstGeom prst="rect">
             <a:avLst/>
@@ -7174,7 +7113,7 @@
                 </a:solidFill>
                 <a:latin typeface="Fira Sans"/>
               </a:rPr>
-              <a:t>El gráfico depende del tipo de variable: barras para una cualitativa, histograma para una cuantitativa, dispersión para dos cuantitativas. Los tres salen de la tabla de viajes y se construyen en el notebook.</a:t>
+              <a:t>Cada persona encuestada representa a muchas otras; su factor de expansión dice a cuántas. La suma de los factores estima la población completa.</a:t>
             </a:r>
           </a:p>
         </p:txBody>
@@ -7270,45 +7209,21 @@
                 </a:solidFill>
                 <a:latin typeface="Fira Sans"/>
               </a:rPr>
-              <a:t>El factor de expansión</a:t>
-            </a:r>
-          </a:p>
-        </p:txBody>
-      </p:sp>
-      <p:pic>
-        <p:nvPicPr>
-          <p:cNvPr id="4" name="Picture 3" descr="13_factor_expansion.png"/>
-          <p:cNvPicPr>
-            <a:picLocks noChangeAspect="1"/>
-          </p:cNvPicPr>
-          <p:nvPr/>
-        </p:nvPicPr>
-        <p:blipFill>
-          <a:blip r:embed="rId2"/>
-          <a:stretch>
-            <a:fillRect/>
-          </a:stretch>
-        </p:blipFill>
-        <p:spPr>
-          <a:xfrm>
-            <a:off x="1417319" y="1143000"/>
-            <a:ext cx="6309360" cy="2871234"/>
-          </a:xfrm>
-          <a:prstGeom prst="rect">
-            <a:avLst/>
-          </a:prstGeom>
-        </p:spPr>
-      </p:pic>
-      <p:sp>
-        <p:nvSpPr>
-          <p:cNvPr id="5" name="TextBox 4"/>
+              <a:t>El factor de expansión en los cálculos</a:t>
+            </a:r>
+          </a:p>
+        </p:txBody>
+      </p:sp>
+      <p:sp>
+        <p:nvSpPr>
+          <p:cNvPr id="4" name="TextBox 3"/>
           <p:cNvSpPr txBox="1"/>
           <p:nvPr/>
         </p:nvSpPr>
         <p:spPr>
           <a:xfrm>
-            <a:off x="704088" y="4434840"/>
-            <a:ext cx="7744968" cy="457200"/>
+            <a:off x="704088" y="1353312"/>
+            <a:ext cx="7744968" cy="3300984"/>
           </a:xfrm>
           <a:prstGeom prst="rect">
             <a:avLst/>
@@ -7321,14 +7236,143 @@
           </a:bodyPr>
           <a:lstStyle/>
           <a:p>
-            <a:r>
-              <a:rPr sz="1300" b="0">
-                <a:solidFill>
-                  <a:srgbClr val="333333"/>
-                </a:solidFill>
-                <a:latin typeface="Fira Sans"/>
-              </a:rPr>
-              <a:t>Cada persona encuestada representa a muchas otras; su factor de expansión dice a cuántas. La suma de los factores estima la población completa.</a:t>
+            <a:pPr>
+              <a:lnSpc>
+                <a:spcPct val="112000"/>
+              </a:lnSpc>
+              <a:spcAft>
+                <a:spcPts val="900"/>
+              </a:spcAft>
+            </a:pPr>
+            <a:r>
+              <a:rPr sz="1800" b="1">
+                <a:solidFill>
+                  <a:srgbClr val="E0A437"/>
+                </a:solidFill>
+                <a:latin typeface="Fira Sans"/>
+              </a:rPr>
+              <a:t>▸ </a:t>
+            </a:r>
+            <a:r>
+              <a:rPr sz="1800" b="0">
+                <a:solidFill>
+                  <a:srgbClr val="000000"/>
+                </a:solidFill>
+                <a:latin typeface="Fira Sans"/>
+              </a:rPr>
+              <a:t>Una encuesta entrevista a una muestra: la EOD, a 60.054 personas de los 6,65 millones de habitantes que cubre.</a:t>
+            </a:r>
+          </a:p>
+          <a:p>
+            <a:pPr>
+              <a:lnSpc>
+                <a:spcPct val="112000"/>
+              </a:lnSpc>
+              <a:spcAft>
+                <a:spcPts val="900"/>
+              </a:spcAft>
+            </a:pPr>
+            <a:r>
+              <a:rPr sz="1800" b="1">
+                <a:solidFill>
+                  <a:srgbClr val="E0A437"/>
+                </a:solidFill>
+                <a:latin typeface="Fira Sans"/>
+              </a:rPr>
+              <a:t>▸ </a:t>
+            </a:r>
+            <a:r>
+              <a:rPr sz="1800" b="0">
+                <a:solidFill>
+                  <a:srgbClr val="000000"/>
+                </a:solidFill>
+                <a:latin typeface="Fira Sans"/>
+              </a:rPr>
+              <a:t>El factor de expansión de cada persona indica a cuántos habitantes representa; sale del diseño muestral (comuna, sexo, edad).</a:t>
+            </a:r>
+          </a:p>
+          <a:p>
+            <a:pPr>
+              <a:lnSpc>
+                <a:spcPct val="112000"/>
+              </a:lnSpc>
+              <a:spcAft>
+                <a:spcPts val="900"/>
+              </a:spcAft>
+            </a:pPr>
+            <a:r>
+              <a:rPr sz="1800" b="1">
+                <a:solidFill>
+                  <a:srgbClr val="E0A437"/>
+                </a:solidFill>
+                <a:latin typeface="Fira Sans"/>
+              </a:rPr>
+              <a:t>▸ </a:t>
+            </a:r>
+            <a:r>
+              <a:rPr sz="1800" b="0">
+                <a:solidFill>
+                  <a:srgbClr val="000000"/>
+                </a:solidFill>
+                <a:latin typeface="Fira Sans"/>
+              </a:rPr>
+              <a:t>La suma de los factores reproduce la población: en la EOD, Factor_LaboralNormal suma 6.651.735.</a:t>
+            </a:r>
+          </a:p>
+          <a:p>
+            <a:pPr>
+              <a:lnSpc>
+                <a:spcPct val="112000"/>
+              </a:lnSpc>
+              <a:spcAft>
+                <a:spcPts val="900"/>
+              </a:spcAft>
+            </a:pPr>
+            <a:r>
+              <a:rPr sz="1800" b="1">
+                <a:solidFill>
+                  <a:srgbClr val="E0A437"/>
+                </a:solidFill>
+                <a:latin typeface="Fira Sans"/>
+              </a:rPr>
+              <a:t>▸ </a:t>
+            </a:r>
+            <a:r>
+              <a:rPr sz="1800" b="1">
+                <a:solidFill>
+                  <a:srgbClr val="1D3557"/>
+                </a:solidFill>
+                <a:latin typeface="Fira Sans"/>
+              </a:rPr>
+              <a:t>Todo resumen tiene dos versiones: muestral (contar filas) y ponderada (sumar factores). ¿De quién habla cada número?</a:t>
+            </a:r>
+          </a:p>
+          <a:p>
+            <a:pPr>
+              <a:lnSpc>
+                <a:spcPct val="112000"/>
+              </a:lnSpc>
+              <a:spcAft>
+                <a:spcPts val="900"/>
+              </a:spcAft>
+            </a:pPr>
+            <a:r>
+              <a:rPr sz="1800" b="1">
+                <a:solidFill>
+                  <a:srgbClr val="E0A437"/>
+                </a:solidFill>
+                <a:latin typeface="Fira Sans"/>
+              </a:rPr>
+              <a:t>▸ </a:t>
+            </a:r>
+            <a:r>
+              <a:rPr sz="1800" b="0">
+                <a:solidFill>
+                  <a:srgbClr val="000000"/>
+                </a:solidFill>
+                <a:latin typeface="Fira Sans"/>
+              </a:rPr>
+              <a:t>En el notebook: 52,8% de mujeres en la muestra, 51,5% ponderado.</a:t>
             </a:r>
           </a:p>
         </p:txBody>
@@ -7424,21 +7468,45 @@
                 </a:solidFill>
                 <a:latin typeface="Fira Sans"/>
               </a:rPr>
-              <a:t>El factor de expansión en los cálculos</a:t>
-            </a:r>
-          </a:p>
-        </p:txBody>
-      </p:sp>
-      <p:sp>
-        <p:nvSpPr>
-          <p:cNvPr id="4" name="TextBox 3"/>
+              <a:t>Reparto modal de Santiago, EOD 2012</a:t>
+            </a:r>
+          </a:p>
+        </p:txBody>
+      </p:sp>
+      <p:pic>
+        <p:nvPicPr>
+          <p:cNvPr id="4" name="Picture 3" descr="01_reparto_modal.png"/>
+          <p:cNvPicPr>
+            <a:picLocks noChangeAspect="1"/>
+          </p:cNvPicPr>
+          <p:nvPr/>
+        </p:nvPicPr>
+        <p:blipFill>
+          <a:blip r:embed="rId2"/>
+          <a:stretch>
+            <a:fillRect/>
+          </a:stretch>
+        </p:blipFill>
+        <p:spPr>
+          <a:xfrm>
+            <a:off x="1604462" y="1143000"/>
+            <a:ext cx="5935075" cy="3154680"/>
+          </a:xfrm>
+          <a:prstGeom prst="rect">
+            <a:avLst/>
+          </a:prstGeom>
+        </p:spPr>
+      </p:pic>
+      <p:sp>
+        <p:nvSpPr>
+          <p:cNvPr id="5" name="TextBox 4"/>
           <p:cNvSpPr txBox="1"/>
           <p:nvPr/>
         </p:nvSpPr>
         <p:spPr>
           <a:xfrm>
-            <a:off x="704088" y="1353312"/>
-            <a:ext cx="7744968" cy="3300984"/>
+            <a:off x="704088" y="4434840"/>
+            <a:ext cx="7744968" cy="457200"/>
           </a:xfrm>
           <a:prstGeom prst="rect">
             <a:avLst/>
@@ -7451,143 +7519,14 @@
           </a:bodyPr>
           <a:lstStyle/>
           <a:p>
-            <a:pPr>
-              <a:lnSpc>
-                <a:spcPct val="112000"/>
-              </a:lnSpc>
-              <a:spcAft>
-                <a:spcPts val="900"/>
-              </a:spcAft>
-            </a:pPr>
-            <a:r>
-              <a:rPr sz="1800" b="1">
-                <a:solidFill>
-                  <a:srgbClr val="E0A437"/>
-                </a:solidFill>
-                <a:latin typeface="Fira Sans"/>
-              </a:rPr>
-              <a:t>▸ </a:t>
-            </a:r>
-            <a:r>
-              <a:rPr sz="1800" b="0">
-                <a:solidFill>
-                  <a:srgbClr val="000000"/>
-                </a:solidFill>
-                <a:latin typeface="Fira Sans"/>
-              </a:rPr>
-              <a:t>Una encuesta entrevista a una muestra: la EOD, a 60.054 personas de los 6,65 millones de habitantes que cubre.</a:t>
-            </a:r>
-          </a:p>
-          <a:p>
-            <a:pPr>
-              <a:lnSpc>
-                <a:spcPct val="112000"/>
-              </a:lnSpc>
-              <a:spcAft>
-                <a:spcPts val="900"/>
-              </a:spcAft>
-            </a:pPr>
-            <a:r>
-              <a:rPr sz="1800" b="1">
-                <a:solidFill>
-                  <a:srgbClr val="E0A437"/>
-                </a:solidFill>
-                <a:latin typeface="Fira Sans"/>
-              </a:rPr>
-              <a:t>▸ </a:t>
-            </a:r>
-            <a:r>
-              <a:rPr sz="1800" b="0">
-                <a:solidFill>
-                  <a:srgbClr val="000000"/>
-                </a:solidFill>
-                <a:latin typeface="Fira Sans"/>
-              </a:rPr>
-              <a:t>El factor de expansión de cada persona indica a cuántos habitantes representa; sale del diseño muestral (comuna, sexo, edad).</a:t>
-            </a:r>
-          </a:p>
-          <a:p>
-            <a:pPr>
-              <a:lnSpc>
-                <a:spcPct val="112000"/>
-              </a:lnSpc>
-              <a:spcAft>
-                <a:spcPts val="900"/>
-              </a:spcAft>
-            </a:pPr>
-            <a:r>
-              <a:rPr sz="1800" b="1">
-                <a:solidFill>
-                  <a:srgbClr val="E0A437"/>
-                </a:solidFill>
-                <a:latin typeface="Fira Sans"/>
-              </a:rPr>
-              <a:t>▸ </a:t>
-            </a:r>
-            <a:r>
-              <a:rPr sz="1800" b="0">
-                <a:solidFill>
-                  <a:srgbClr val="000000"/>
-                </a:solidFill>
-                <a:latin typeface="Fira Sans"/>
-              </a:rPr>
-              <a:t>La suma de los factores reproduce la población: en la EOD, Factor_LaboralNormal suma 6.651.735.</a:t>
-            </a:r>
-          </a:p>
-          <a:p>
-            <a:pPr>
-              <a:lnSpc>
-                <a:spcPct val="112000"/>
-              </a:lnSpc>
-              <a:spcAft>
-                <a:spcPts val="900"/>
-              </a:spcAft>
-            </a:pPr>
-            <a:r>
-              <a:rPr sz="1800" b="1">
-                <a:solidFill>
-                  <a:srgbClr val="E0A437"/>
-                </a:solidFill>
-                <a:latin typeface="Fira Sans"/>
-              </a:rPr>
-              <a:t>▸ </a:t>
-            </a:r>
-            <a:r>
-              <a:rPr sz="1800" b="1">
-                <a:solidFill>
-                  <a:srgbClr val="1D3557"/>
-                </a:solidFill>
-                <a:latin typeface="Fira Sans"/>
-              </a:rPr>
-              <a:t>Todo resumen tiene dos versiones: muestral (contar filas) y ponderada (sumar factores). ¿De quién habla cada número?</a:t>
-            </a:r>
-          </a:p>
-          <a:p>
-            <a:pPr>
-              <a:lnSpc>
-                <a:spcPct val="112000"/>
-              </a:lnSpc>
-              <a:spcAft>
-                <a:spcPts val="900"/>
-              </a:spcAft>
-            </a:pPr>
-            <a:r>
-              <a:rPr sz="1800" b="1">
-                <a:solidFill>
-                  <a:srgbClr val="E0A437"/>
-                </a:solidFill>
-                <a:latin typeface="Fira Sans"/>
-              </a:rPr>
-              <a:t>▸ </a:t>
-            </a:r>
-            <a:r>
-              <a:rPr sz="1800" b="0">
-                <a:solidFill>
-                  <a:srgbClr val="000000"/>
-                </a:solidFill>
-                <a:latin typeface="Fira Sans"/>
-              </a:rPr>
-              <a:t>En el notebook: 52,8% de mujeres en la muestra, 51,5% ponderado.</a:t>
+            <a:r>
+              <a:rPr sz="1300" b="0">
+                <a:solidFill>
+                  <a:srgbClr val="333333"/>
+                </a:solidFill>
+                <a:latin typeface="Fira Sans"/>
+              </a:rPr>
+              <a:t>Uno de cada tres viajes es a pie. Esta versión está ponderada por factores de expansión, así que habla de la ciudad; en el notebook calcularemos la versión muestral, y la diferencia entre ambas abre las clases 2 y 3.</a:t>
             </a:r>
           </a:p>
         </p:txBody>
@@ -7683,45 +7622,21 @@
                 </a:solidFill>
                 <a:latin typeface="Fira Sans"/>
               </a:rPr>
-              <a:t>Reparto modal de Santiago, EOD 2012</a:t>
-            </a:r>
-          </a:p>
-        </p:txBody>
-      </p:sp>
-      <p:pic>
-        <p:nvPicPr>
-          <p:cNvPr id="4" name="Picture 3" descr="01_reparto_modal.png"/>
-          <p:cNvPicPr>
-            <a:picLocks noChangeAspect="1"/>
-          </p:cNvPicPr>
-          <p:nvPr/>
-        </p:nvPicPr>
-        <p:blipFill>
-          <a:blip r:embed="rId2"/>
-          <a:stretch>
-            <a:fillRect/>
-          </a:stretch>
-        </p:blipFill>
-        <p:spPr>
-          <a:xfrm>
-            <a:off x="1604462" y="1143000"/>
-            <a:ext cx="5935075" cy="3154680"/>
-          </a:xfrm>
-          <a:prstGeom prst="rect">
-            <a:avLst/>
-          </a:prstGeom>
-        </p:spPr>
-      </p:pic>
-      <p:sp>
-        <p:nvSpPr>
-          <p:cNvPr id="5" name="TextBox 4"/>
+              <a:t>Síntesis</a:t>
+            </a:r>
+          </a:p>
+        </p:txBody>
+      </p:sp>
+      <p:sp>
+        <p:nvSpPr>
+          <p:cNvPr id="4" name="TextBox 3"/>
           <p:cNvSpPr txBox="1"/>
           <p:nvPr/>
         </p:nvSpPr>
         <p:spPr>
           <a:xfrm>
-            <a:off x="704088" y="4434840"/>
-            <a:ext cx="7744968" cy="457200"/>
+            <a:off x="704088" y="1353312"/>
+            <a:ext cx="7744968" cy="3300984"/>
           </a:xfrm>
           <a:prstGeom prst="rect">
             <a:avLst/>
@@ -7734,14 +7649,143 @@
           </a:bodyPr>
           <a:lstStyle/>
           <a:p>
-            <a:r>
-              <a:rPr sz="1300" b="0">
-                <a:solidFill>
-                  <a:srgbClr val="333333"/>
-                </a:solidFill>
-                <a:latin typeface="Fira Sans"/>
-              </a:rPr>
-              <a:t>Uno de cada tres viajes es a pie. Esta versión está ponderada por factores de expansión, así que habla de la ciudad; en el notebook calcularemos la versión muestral, y la diferencia entre ambas abre las clases 2 y 3.</a:t>
+            <a:pPr>
+              <a:lnSpc>
+                <a:spcPct val="112000"/>
+              </a:lnSpc>
+              <a:spcAft>
+                <a:spcPts val="900"/>
+              </a:spcAft>
+            </a:pPr>
+            <a:r>
+              <a:rPr sz="1800" b="1">
+                <a:solidFill>
+                  <a:srgbClr val="E0A437"/>
+                </a:solidFill>
+                <a:latin typeface="Fira Sans"/>
+              </a:rPr>
+              <a:t>▸ </a:t>
+            </a:r>
+            <a:r>
+              <a:rPr sz="1800" b="1">
+                <a:solidFill>
+                  <a:srgbClr val="1D3557"/>
+                </a:solidFill>
+                <a:latin typeface="Fira Sans"/>
+              </a:rPr>
+              <a:t>El tipo de cada variable determina qué resúmenes, gráficos y análisis son válidos.</a:t>
+            </a:r>
+          </a:p>
+          <a:p>
+            <a:pPr>
+              <a:lnSpc>
+                <a:spcPct val="112000"/>
+              </a:lnSpc>
+              <a:spcAft>
+                <a:spcPts val="900"/>
+              </a:spcAft>
+            </a:pPr>
+            <a:r>
+              <a:rPr sz="1800" b="1">
+                <a:solidFill>
+                  <a:srgbClr val="E0A437"/>
+                </a:solidFill>
+                <a:latin typeface="Fira Sans"/>
+              </a:rPr>
+              <a:t>▸ </a:t>
+            </a:r>
+            <a:r>
+              <a:rPr sz="1800" b="0">
+                <a:solidFill>
+                  <a:srgbClr val="000000"/>
+                </a:solidFill>
+                <a:latin typeface="Fira Sans"/>
+              </a:rPr>
+              <a:t>Ciencia de datos: extracción generalizable de conocimiento a partir de los datos (Dhar, 2013); combina estadística, computación y dominio.</a:t>
+            </a:r>
+          </a:p>
+          <a:p>
+            <a:pPr>
+              <a:lnSpc>
+                <a:spcPct val="112000"/>
+              </a:lnSpc>
+              <a:spcAft>
+                <a:spcPts val="900"/>
+              </a:spcAft>
+            </a:pPr>
+            <a:r>
+              <a:rPr sz="1800" b="1">
+                <a:solidFill>
+                  <a:srgbClr val="E0A437"/>
+                </a:solidFill>
+                <a:latin typeface="Fira Sans"/>
+              </a:rPr>
+              <a:t>▸ </a:t>
+            </a:r>
+            <a:r>
+              <a:rPr sz="1800" b="0">
+                <a:solidFill>
+                  <a:srgbClr val="000000"/>
+                </a:solidFill>
+                <a:latin typeface="Fira Sans"/>
+              </a:rPr>
+              <a:t>El ciclo de vida tiene dos entradas (una necesidad del dominio o datos disponibles) y se recorre de forma iterativa.</a:t>
+            </a:r>
+          </a:p>
+          <a:p>
+            <a:pPr>
+              <a:lnSpc>
+                <a:spcPct val="112000"/>
+              </a:lnSpc>
+              <a:spcAft>
+                <a:spcPts val="900"/>
+              </a:spcAft>
+            </a:pPr>
+            <a:r>
+              <a:rPr sz="1800" b="1">
+                <a:solidFill>
+                  <a:srgbClr val="E0A437"/>
+                </a:solidFill>
+                <a:latin typeface="Fira Sans"/>
+              </a:rPr>
+              <a:t>▸ </a:t>
+            </a:r>
+            <a:r>
+              <a:rPr sz="1800" b="0">
+                <a:solidFill>
+                  <a:srgbClr val="000000"/>
+                </a:solidFill>
+                <a:latin typeface="Fira Sans"/>
+              </a:rPr>
+              <a:t>La preparación de datos consume cerca de la mitad del tiempo de un proyecto (Anaconda, 2020).</a:t>
+            </a:r>
+          </a:p>
+          <a:p>
+            <a:pPr>
+              <a:lnSpc>
+                <a:spcPct val="112000"/>
+              </a:lnSpc>
+              <a:spcAft>
+                <a:spcPts val="900"/>
+              </a:spcAft>
+            </a:pPr>
+            <a:r>
+              <a:rPr sz="1800" b="1">
+                <a:solidFill>
+                  <a:srgbClr val="E0A437"/>
+                </a:solidFill>
+                <a:latin typeface="Fira Sans"/>
+              </a:rPr>
+              <a:t>▸ </a:t>
+            </a:r>
+            <a:r>
+              <a:rPr sz="1800" b="0">
+                <a:solidFill>
+                  <a:srgbClr val="000000"/>
+                </a:solidFill>
+                <a:latin typeface="Fira Sans"/>
+              </a:rPr>
+              <a:t>Próxima clase (jueves 27): estadística descriptiva, con el entorno ya funcionando.</a:t>
             </a:r>
           </a:p>
         </p:txBody>
@@ -7837,7 +7881,7 @@
                 </a:solidFill>
                 <a:latin typeface="Fira Sans"/>
               </a:rPr>
-              <a:t>Síntesis</a:t>
+              <a:t>Referencias</a:t>
             </a:r>
           </a:p>
         </p:txBody>
@@ -7850,8 +7894,8 @@
         </p:nvSpPr>
         <p:spPr>
           <a:xfrm>
-            <a:off x="704088" y="1353312"/>
-            <a:ext cx="7744968" cy="3300984"/>
+            <a:off x="704088" y="1234440"/>
+            <a:ext cx="7744968" cy="3566160"/>
           </a:xfrm>
           <a:prstGeom prst="rect">
             <a:avLst/>
@@ -7866,141 +7910,96 @@
           <a:p>
             <a:pPr>
               <a:lnSpc>
-                <a:spcPct val="112000"/>
+                <a:spcPct val="115000"/>
               </a:lnSpc>
               <a:spcAft>
-                <a:spcPts val="900"/>
+                <a:spcPts val="700"/>
               </a:spcAft>
             </a:pPr>
             <a:r>
-              <a:rPr sz="1800" b="1">
-                <a:solidFill>
-                  <a:srgbClr val="E0A437"/>
-                </a:solidFill>
-                <a:latin typeface="Fira Sans"/>
-              </a:rPr>
-              <a:t>▸ </a:t>
-            </a:r>
-            <a:r>
-              <a:rPr sz="1800" b="1">
-                <a:solidFill>
-                  <a:srgbClr val="1D3557"/>
-                </a:solidFill>
-                <a:latin typeface="Fira Sans"/>
-              </a:rPr>
-              <a:t>El tipo de cada variable determina qué resúmenes, gráficos y análisis son válidos.</a:t>
+              <a:rPr sz="1300" b="0">
+                <a:solidFill>
+                  <a:srgbClr val="333333"/>
+                </a:solidFill>
+                <a:latin typeface="Fira Sans"/>
+              </a:rPr>
+              <a:t>Anaconda (2020). 2020 State of Data Science. Reporte de encuesta (n=2.360). anaconda.com/resources/whitepaper/state-of-data-science-2020</a:t>
             </a:r>
           </a:p>
           <a:p>
             <a:pPr>
               <a:lnSpc>
-                <a:spcPct val="112000"/>
+                <a:spcPct val="115000"/>
               </a:lnSpc>
               <a:spcAft>
-                <a:spcPts val="900"/>
+                <a:spcPts val="700"/>
               </a:spcAft>
             </a:pPr>
             <a:r>
-              <a:rPr sz="1800" b="1">
-                <a:solidFill>
-                  <a:srgbClr val="E0A437"/>
-                </a:solidFill>
-                <a:latin typeface="Fira Sans"/>
-              </a:rPr>
-              <a:t>▸ </a:t>
-            </a:r>
-            <a:r>
-              <a:rPr sz="1800" b="0">
-                <a:solidFill>
-                  <a:srgbClr val="000000"/>
-                </a:solidFill>
-                <a:latin typeface="Fira Sans"/>
-              </a:rPr>
-              <a:t>Ciencia de datos: extracción generalizable de conocimiento a partir de los datos (Dhar, 2013); combina estadística, computación y dominio.</a:t>
+              <a:rPr sz="1300" b="0">
+                <a:solidFill>
+                  <a:srgbClr val="333333"/>
+                </a:solidFill>
+                <a:latin typeface="Fira Sans"/>
+              </a:rPr>
+              <a:t>Cleveland, W. S. (2001). Data Science: An Action Plan for Expanding the Technical Areas of the Field of Statistics. International Statistical Review, 69(1), 21-26.</a:t>
             </a:r>
           </a:p>
           <a:p>
             <a:pPr>
               <a:lnSpc>
-                <a:spcPct val="112000"/>
+                <a:spcPct val="115000"/>
               </a:lnSpc>
               <a:spcAft>
-                <a:spcPts val="900"/>
+                <a:spcPts val="700"/>
               </a:spcAft>
             </a:pPr>
             <a:r>
-              <a:rPr sz="1800" b="1">
-                <a:solidFill>
-                  <a:srgbClr val="E0A437"/>
-                </a:solidFill>
-                <a:latin typeface="Fira Sans"/>
-              </a:rPr>
-              <a:t>▸ </a:t>
-            </a:r>
-            <a:r>
-              <a:rPr sz="1800" b="0">
-                <a:solidFill>
-                  <a:srgbClr val="000000"/>
-                </a:solidFill>
-                <a:latin typeface="Fira Sans"/>
-              </a:rPr>
-              <a:t>El ciclo de vida tiene dos entradas (una necesidad del dominio o datos disponibles) y se recorre de forma iterativa.</a:t>
+              <a:rPr sz="1300" b="0">
+                <a:solidFill>
+                  <a:srgbClr val="333333"/>
+                </a:solidFill>
+                <a:latin typeface="Fira Sans"/>
+              </a:rPr>
+              <a:t>Dhar, V. (2013). Data Science and Prediction. Communications of the ACM, 56(12), 64-73.</a:t>
             </a:r>
           </a:p>
           <a:p>
             <a:pPr>
               <a:lnSpc>
-                <a:spcPct val="112000"/>
+                <a:spcPct val="115000"/>
               </a:lnSpc>
               <a:spcAft>
-                <a:spcPts val="900"/>
+                <a:spcPts val="700"/>
               </a:spcAft>
             </a:pPr>
             <a:r>
-              <a:rPr sz="1800" b="1">
-                <a:solidFill>
-                  <a:srgbClr val="E0A437"/>
-                </a:solidFill>
-                <a:latin typeface="Fira Sans"/>
-              </a:rPr>
-              <a:t>▸ </a:t>
-            </a:r>
-            <a:r>
-              <a:rPr sz="1800" b="0">
-                <a:solidFill>
-                  <a:srgbClr val="000000"/>
-                </a:solidFill>
-                <a:latin typeface="Fira Sans"/>
-              </a:rPr>
-              <a:t>La preparación de datos consume cerca de la mitad del tiempo de un proyecto (Anaconda, 2020).</a:t>
+              <a:rPr sz="1300" b="0">
+                <a:solidFill>
+                  <a:srgbClr val="333333"/>
+                </a:solidFill>
+                <a:latin typeface="Fira Sans"/>
+              </a:rPr>
+              <a:t>Donoho, D. (2017). 50 Years of Data Science. Journal of Computational and Graphical Statistics, 26(4), 745-766.</a:t>
             </a:r>
           </a:p>
           <a:p>
             <a:pPr>
               <a:lnSpc>
-                <a:spcPct val="112000"/>
+                <a:spcPct val="115000"/>
               </a:lnSpc>
               <a:spcAft>
-                <a:spcPts val="900"/>
+                <a:spcPts val="700"/>
               </a:spcAft>
             </a:pPr>
             <a:r>
-              <a:rPr sz="1800" b="1">
-                <a:solidFill>
-                  <a:srgbClr val="E0A437"/>
-                </a:solidFill>
-                <a:latin typeface="Fira Sans"/>
-              </a:rPr>
-              <a:t>▸ </a:t>
-            </a:r>
-            <a:r>
-              <a:rPr sz="1800" b="0">
-                <a:solidFill>
-                  <a:srgbClr val="000000"/>
-                </a:solidFill>
-                <a:latin typeface="Fira Sans"/>
-              </a:rPr>
-              <a:t>Próxima clase (jueves 27): estadística descriptiva, con el entorno ya funcionando.</a:t>
+              <a:rPr sz="1300" b="0">
+                <a:solidFill>
+                  <a:srgbClr val="333333"/>
+                </a:solidFill>
+                <a:latin typeface="Fira Sans"/>
+              </a:rPr>
+              <a:t>VanderPlas, J. (2016). Python Data Science Handbook. O'Reilly. Versión en línea: jakevdp.github.io/PythonDataScienceHandbook</a:t>
             </a:r>
           </a:p>
         </p:txBody>
@@ -8108,220 +8107,6 @@
                 <a:latin typeface="Fira Sans"/>
               </a:rPr>
               <a:t>Definición, componentes y objetivos</a:t>
-            </a:r>
-          </a:p>
-        </p:txBody>
-      </p:sp>
-    </p:spTree>
-  </p:cSld>
-  <p:clrMapOvr>
-    <a:masterClrMapping/>
-  </p:clrMapOvr>
-</p:sld>
-</file>
-
-<file path=ppt/slides/slide30.xml><?xml version="1.0" encoding="utf-8"?>
-<p:sld xmlns:a="http://schemas.openxmlformats.org/drawingml/2006/main" xmlns:p="http://schemas.openxmlformats.org/presentationml/2006/main" xmlns:r="http://schemas.openxmlformats.org/officeDocument/2006/relationships">
-  <p:cSld>
-    <p:spTree>
-      <p:nvGrpSpPr>
-        <p:cNvPr id="1" name=""/>
-        <p:cNvGrpSpPr/>
-        <p:nvPr/>
-      </p:nvGrpSpPr>
-      <p:grpSpPr/>
-      <p:sp>
-        <p:nvSpPr>
-          <p:cNvPr id="2" name="Rectangle 1"/>
-          <p:cNvSpPr/>
-          <p:nvPr/>
-        </p:nvSpPr>
-        <p:spPr>
-          <a:xfrm>
-            <a:off x="0" y="0"/>
-            <a:ext cx="9144000" cy="5138928"/>
-          </a:xfrm>
-          <a:prstGeom prst="rect">
-            <a:avLst/>
-          </a:prstGeom>
-          <a:solidFill>
-            <a:srgbClr val="FAFBFC"/>
-          </a:solidFill>
-          <a:ln>
-            <a:noFill/>
-          </a:ln>
-          <a:effectLst/>
-        </p:spPr>
-        <p:style>
-          <a:lnRef idx="1">
-            <a:schemeClr val="accent1"/>
-          </a:lnRef>
-          <a:fillRef idx="3">
-            <a:schemeClr val="accent1"/>
-          </a:fillRef>
-          <a:effectRef idx="2">
-            <a:schemeClr val="accent1"/>
-          </a:effectRef>
-          <a:fontRef idx="minor">
-            <a:schemeClr val="lt1"/>
-          </a:fontRef>
-        </p:style>
-        <p:txBody>
-          <a:bodyPr rtlCol="0" anchor="ctr"/>
-          <a:lstStyle/>
-          <a:p>
-            <a:pPr algn="ctr"/>
-          </a:p>
-        </p:txBody>
-      </p:sp>
-      <p:sp>
-        <p:nvSpPr>
-          <p:cNvPr id="3" name="TextBox 2"/>
-          <p:cNvSpPr txBox="1"/>
-          <p:nvPr/>
-        </p:nvSpPr>
-        <p:spPr>
-          <a:xfrm>
-            <a:off x="402336" y="301752"/>
-            <a:ext cx="8348472" cy="795528"/>
-          </a:xfrm>
-          <a:prstGeom prst="rect">
-            <a:avLst/>
-          </a:prstGeom>
-          <a:noFill/>
-        </p:spPr>
-        <p:txBody>
-          <a:bodyPr wrap="square">
-            <a:spAutoFit/>
-          </a:bodyPr>
-          <a:lstStyle/>
-          <a:p>
-            <a:r>
-              <a:rPr sz="2800" b="1">
-                <a:solidFill>
-                  <a:srgbClr val="0F0F0F"/>
-                </a:solidFill>
-                <a:latin typeface="Fira Sans"/>
-              </a:rPr>
-              <a:t>Referencias</a:t>
-            </a:r>
-          </a:p>
-        </p:txBody>
-      </p:sp>
-      <p:sp>
-        <p:nvSpPr>
-          <p:cNvPr id="4" name="TextBox 3"/>
-          <p:cNvSpPr txBox="1"/>
-          <p:nvPr/>
-        </p:nvSpPr>
-        <p:spPr>
-          <a:xfrm>
-            <a:off x="704088" y="1234440"/>
-            <a:ext cx="7744968" cy="3566160"/>
-          </a:xfrm>
-          <a:prstGeom prst="rect">
-            <a:avLst/>
-          </a:prstGeom>
-          <a:noFill/>
-        </p:spPr>
-        <p:txBody>
-          <a:bodyPr wrap="square">
-            <a:spAutoFit/>
-          </a:bodyPr>
-          <a:lstStyle/>
-          <a:p>
-            <a:pPr>
-              <a:lnSpc>
-                <a:spcPct val="115000"/>
-              </a:lnSpc>
-              <a:spcAft>
-                <a:spcPts val="700"/>
-              </a:spcAft>
-            </a:pPr>
-            <a:r>
-              <a:rPr sz="1300" b="0">
-                <a:solidFill>
-                  <a:srgbClr val="333333"/>
-                </a:solidFill>
-                <a:latin typeface="Fira Sans"/>
-              </a:rPr>
-              <a:t>Anaconda (2020). 2020 State of Data Science. Reporte de encuesta (n=2.360). anaconda.com/resources/whitepaper/state-of-data-science-2020</a:t>
-            </a:r>
-          </a:p>
-          <a:p>
-            <a:pPr>
-              <a:lnSpc>
-                <a:spcPct val="115000"/>
-              </a:lnSpc>
-              <a:spcAft>
-                <a:spcPts val="700"/>
-              </a:spcAft>
-            </a:pPr>
-            <a:r>
-              <a:rPr sz="1300" b="0">
-                <a:solidFill>
-                  <a:srgbClr val="333333"/>
-                </a:solidFill>
-                <a:latin typeface="Fira Sans"/>
-              </a:rPr>
-              <a:t>Cleveland, W. S. (2001). Data Science: An Action Plan for Expanding the Technical Areas of the Field of Statistics. International Statistical Review, 69(1), 21-26.</a:t>
-            </a:r>
-          </a:p>
-          <a:p>
-            <a:pPr>
-              <a:lnSpc>
-                <a:spcPct val="115000"/>
-              </a:lnSpc>
-              <a:spcAft>
-                <a:spcPts val="700"/>
-              </a:spcAft>
-            </a:pPr>
-            <a:r>
-              <a:rPr sz="1300" b="0">
-                <a:solidFill>
-                  <a:srgbClr val="333333"/>
-                </a:solidFill>
-                <a:latin typeface="Fira Sans"/>
-              </a:rPr>
-              <a:t>Dhar, V. (2013). Data Science and Prediction. Communications of the ACM, 56(12), 64-73.</a:t>
-            </a:r>
-          </a:p>
-          <a:p>
-            <a:pPr>
-              <a:lnSpc>
-                <a:spcPct val="115000"/>
-              </a:lnSpc>
-              <a:spcAft>
-                <a:spcPts val="700"/>
-              </a:spcAft>
-            </a:pPr>
-            <a:r>
-              <a:rPr sz="1300" b="0">
-                <a:solidFill>
-                  <a:srgbClr val="333333"/>
-                </a:solidFill>
-                <a:latin typeface="Fira Sans"/>
-              </a:rPr>
-              <a:t>Donoho, D. (2017). 50 Years of Data Science. Journal of Computational and Graphical Statistics, 26(4), 745-766.</a:t>
-            </a:r>
-          </a:p>
-          <a:p>
-            <a:pPr>
-              <a:lnSpc>
-                <a:spcPct val="115000"/>
-              </a:lnSpc>
-              <a:spcAft>
-                <a:spcPts val="700"/>
-              </a:spcAft>
-            </a:pPr>
-            <a:r>
-              <a:rPr sz="1300" b="0">
-                <a:solidFill>
-                  <a:srgbClr val="333333"/>
-                </a:solidFill>
-                <a:latin typeface="Fira Sans"/>
-              </a:rPr>
-              <a:t>VanderPlas, J. (2016). Python Data Science Handbook. O'Reilly. Versión en línea: jakevdp.github.io/PythonDataScienceHandbook</a:t>
             </a:r>
           </a:p>
         </p:txBody>

</xml_diff>

<commit_message>
Fuera la slide de NumPy; el concepto vive en el notebook y en el mapa del ecosistema
Co-Authored-By: Claude Fable 5 <noreply@anthropic.com>
</commit_message>
<xml_diff>
--- a/presentaciones/clase01_fundamentos_ecosistema.pptx
+++ b/presentaciones/clase01_fundamentos_ecosistema.pptx
@@ -33,7 +33,6 @@
     <p:sldId id="281" r:id="rId32"/>
     <p:sldId id="282" r:id="rId33"/>
     <p:sldId id="283" r:id="rId34"/>
-    <p:sldId id="284" r:id="rId35"/>
   </p:sldIdLst>
   <p:sldSz cx="9144000" cy="5138928" type="screen4x3"/>
   <p:notesSz cx="6858000" cy="9144000"/>
@@ -6001,7 +6000,7 @@
                 </a:solidFill>
                 <a:latin typeface="Fira Sans"/>
               </a:rPr>
-              <a:t>NumPy: cálculo sobre arreglos completos</a:t>
+              <a:t>Pandas: la tabla como objeto de trabajo</a:t>
             </a:r>
           </a:p>
         </p:txBody>
@@ -6014,8 +6013,8 @@
         </p:nvSpPr>
         <p:spPr>
           <a:xfrm>
-            <a:off x="704088" y="1280160"/>
-            <a:ext cx="7744968" cy="1874520"/>
+            <a:off x="704088" y="1143000"/>
+            <a:ext cx="7744968" cy="1325880"/>
           </a:xfrm>
           <a:prstGeom prst="rect">
             <a:avLst/>
@@ -6045,56 +6044,80 @@
           </a:fontRef>
         </p:style>
         <p:txBody>
-          <a:bodyPr rtlCol="0" anchor="ctr" wrap="square" lIns="228600" tIns="137160"/>
-          <a:lstStyle/>
-          <a:p>
-            <a:pPr/>
-            <a:r>
-              <a:rPr sz="1500" b="0">
+          <a:bodyPr rtlCol="0" anchor="ctr" wrap="square" lIns="228600" tIns="109728"/>
+          <a:lstStyle/>
+          <a:p>
+            <a:pPr algn="l"/>
+            <a:r>
+              <a:rPr sz="1400" b="0">
                 <a:solidFill>
                   <a:srgbClr val="1D3557"/>
                 </a:solidFill>
                 <a:latin typeface="Menlo"/>
               </a:rPr>
-              <a:t>import numpy as np</a:t>
-            </a:r>
-          </a:p>
-          <a:p>
-            <a:pPr/>
-            <a:r>
-              <a:rPr sz="1500" b="0">
+              <a:t>import pandas as pd</a:t>
+            </a:r>
+          </a:p>
+          <a:p>
+            <a:pPr algn="l"/>
+            <a:r>
+              <a:rPr sz="1400" b="0">
                 <a:solidFill>
                   <a:srgbClr val="1D3557"/>
                 </a:solidFill>
                 <a:latin typeface="Menlo"/>
               </a:rPr>
-              <a:t>tiempos = np.array([70, 105, 90, 25, 40])</a:t>
-            </a:r>
-          </a:p>
-          <a:p>
-            <a:pPr/>
-            <a:r>
-              <a:rPr sz="1500" b="0">
+              <a:t>viajes = pd.read_csv(URL_VIAJES, sep=";", decimal=",")</a:t>
+            </a:r>
+          </a:p>
+          <a:p>
+            <a:pPr algn="l"/>
+            <a:r>
+              <a:rPr sz="1400" b="0">
                 <a:solidFill>
                   <a:srgbClr val="1D3557"/>
                 </a:solidFill>
                 <a:latin typeface="Menlo"/>
               </a:rPr>
-              <a:t>tiempos.mean()          # 66.0, sin escribir un ciclo</a:t>
-            </a:r>
-          </a:p>
-        </p:txBody>
-      </p:sp>
-      <p:sp>
-        <p:nvSpPr>
-          <p:cNvPr id="5" name="TextBox 4"/>
+              <a:t>viajes.head()</a:t>
+            </a:r>
+          </a:p>
+        </p:txBody>
+      </p:sp>
+      <p:pic>
+        <p:nvPicPr>
+          <p:cNvPr id="5" name="Picture 4" descr="02_df_viajes.png"/>
+          <p:cNvPicPr>
+            <a:picLocks noChangeAspect="1"/>
+          </p:cNvPicPr>
+          <p:nvPr/>
+        </p:nvPicPr>
+        <p:blipFill>
+          <a:blip r:embed="rId2"/>
+          <a:stretch>
+            <a:fillRect/>
+          </a:stretch>
+        </p:blipFill>
+        <p:spPr>
+          <a:xfrm>
+            <a:off x="1828800" y="2606040"/>
+            <a:ext cx="5486400" cy="1996828"/>
+          </a:xfrm>
+          <a:prstGeom prst="rect">
+            <a:avLst/>
+          </a:prstGeom>
+        </p:spPr>
+      </p:pic>
+      <p:sp>
+        <p:nvSpPr>
+          <p:cNvPr id="6" name="TextBox 5"/>
           <p:cNvSpPr txBox="1"/>
           <p:nvPr/>
         </p:nvSpPr>
         <p:spPr>
           <a:xfrm>
-            <a:off x="704088" y="3383279"/>
-            <a:ext cx="7744968" cy="1097280"/>
+            <a:off x="704088" y="4590288"/>
+            <a:ext cx="7744968" cy="502920"/>
           </a:xfrm>
           <a:prstGeom prst="rect">
             <a:avLst/>
@@ -6107,31 +6130,14 @@
           </a:bodyPr>
           <a:lstStyle/>
           <a:p>
-            <a:pPr>
-              <a:lnSpc>
-                <a:spcPct val="112000"/>
-              </a:lnSpc>
-              <a:spcAft>
-                <a:spcPts val="900"/>
-              </a:spcAft>
-            </a:pPr>
-            <a:r>
-              <a:rPr sz="1600" b="1">
-                <a:solidFill>
-                  <a:srgbClr val="E0A437"/>
-                </a:solidFill>
-                <a:latin typeface="Fira Sans"/>
-              </a:rPr>
-              <a:t>▸ </a:t>
-            </a:r>
-            <a:r>
-              <a:rPr sz="1600" b="0">
-                <a:solidFill>
-                  <a:srgbClr val="000000"/>
-                </a:solidFill>
-                <a:latin typeface="Fira Sans"/>
-              </a:rPr>
-              <a:t>La operación se aplica al arreglo completo (vectorización): menos código y mucho más rápido que iterar en Python puro. Es la base sobre la que se construye todo lo demás.</a:t>
+            <a:r>
+              <a:rPr sz="1300" b="0">
+                <a:solidFill>
+                  <a:srgbClr val="333333"/>
+                </a:solidFill>
+                <a:latin typeface="Fira Sans"/>
+              </a:rPr>
+              <a:t>Con esas tres líneas se abre la EOD 2012 completa: 18.264 hogares, 60.054 personas y 113.591 viajes. Cada columna es una variable de su propio tipo.</a:t>
             </a:r>
           </a:p>
         </p:txBody>
@@ -6227,93 +6233,14 @@
                 </a:solidFill>
                 <a:latin typeface="Fira Sans"/>
               </a:rPr>
-              <a:t>Pandas: la tabla como objeto de trabajo</a:t>
-            </a:r>
-          </a:p>
-        </p:txBody>
-      </p:sp>
-      <p:sp>
-        <p:nvSpPr>
-          <p:cNvPr id="4" name="Rectangle 3"/>
-          <p:cNvSpPr/>
-          <p:nvPr/>
-        </p:nvSpPr>
-        <p:spPr>
-          <a:xfrm>
-            <a:off x="704088" y="1143000"/>
-            <a:ext cx="7744968" cy="1325880"/>
-          </a:xfrm>
-          <a:prstGeom prst="rect">
-            <a:avLst/>
-          </a:prstGeom>
-          <a:solidFill>
-            <a:srgbClr val="F0F2F5"/>
-          </a:solidFill>
-          <a:ln>
-            <a:solidFill>
-              <a:srgbClr val="D8DDE3"/>
-            </a:solidFill>
-          </a:ln>
-          <a:effectLst/>
-        </p:spPr>
-        <p:style>
-          <a:lnRef idx="1">
-            <a:schemeClr val="accent1"/>
-          </a:lnRef>
-          <a:fillRef idx="3">
-            <a:schemeClr val="accent1"/>
-          </a:fillRef>
-          <a:effectRef idx="2">
-            <a:schemeClr val="accent1"/>
-          </a:effectRef>
-          <a:fontRef idx="minor">
-            <a:schemeClr val="lt1"/>
-          </a:fontRef>
-        </p:style>
-        <p:txBody>
-          <a:bodyPr rtlCol="0" anchor="ctr" wrap="square" lIns="228600" tIns="109728"/>
-          <a:lstStyle/>
-          <a:p>
-            <a:pPr algn="l"/>
-            <a:r>
-              <a:rPr sz="1400" b="0">
-                <a:solidFill>
-                  <a:srgbClr val="1D3557"/>
-                </a:solidFill>
-                <a:latin typeface="Menlo"/>
-              </a:rPr>
-              <a:t>import pandas as pd</a:t>
-            </a:r>
-          </a:p>
-          <a:p>
-            <a:pPr algn="l"/>
-            <a:r>
-              <a:rPr sz="1400" b="0">
-                <a:solidFill>
-                  <a:srgbClr val="1D3557"/>
-                </a:solidFill>
-                <a:latin typeface="Menlo"/>
-              </a:rPr>
-              <a:t>viajes = pd.read_csv(URL_VIAJES, sep=";", decimal=",")</a:t>
-            </a:r>
-          </a:p>
-          <a:p>
-            <a:pPr algn="l"/>
-            <a:r>
-              <a:rPr sz="1400" b="0">
-                <a:solidFill>
-                  <a:srgbClr val="1D3557"/>
-                </a:solidFill>
-                <a:latin typeface="Menlo"/>
-              </a:rPr>
-              <a:t>viajes.head()</a:t>
+              <a:t>La EOD: una encuesta, varias tablas</a:t>
             </a:r>
           </a:p>
         </p:txBody>
       </p:sp>
       <p:pic>
         <p:nvPicPr>
-          <p:cNvPr id="5" name="Picture 4" descr="02_df_viajes.png"/>
+          <p:cNvPr id="4" name="Picture 3" descr="12_eod_tablas.png"/>
           <p:cNvPicPr>
             <a:picLocks noChangeAspect="1"/>
           </p:cNvPicPr>
@@ -6327,8 +6254,8 @@
         </p:blipFill>
         <p:spPr>
           <a:xfrm>
-            <a:off x="1828800" y="2606040"/>
-            <a:ext cx="5486400" cy="1996828"/>
+            <a:off x="1553651" y="1143000"/>
+            <a:ext cx="6036697" cy="3154680"/>
           </a:xfrm>
           <a:prstGeom prst="rect">
             <a:avLst/>
@@ -6337,14 +6264,14 @@
       </p:pic>
       <p:sp>
         <p:nvSpPr>
-          <p:cNvPr id="6" name="TextBox 5"/>
+          <p:cNvPr id="5" name="TextBox 4"/>
           <p:cNvSpPr txBox="1"/>
           <p:nvPr/>
         </p:nvSpPr>
         <p:spPr>
           <a:xfrm>
-            <a:off x="704088" y="4590288"/>
-            <a:ext cx="7744968" cy="502920"/>
+            <a:off x="704088" y="4434840"/>
+            <a:ext cx="7744968" cy="457200"/>
           </a:xfrm>
           <a:prstGeom prst="rect">
             <a:avLst/>
@@ -6364,7 +6291,7 @@
                 </a:solidFill>
                 <a:latin typeface="Fira Sans"/>
               </a:rPr>
-              <a:t>Con esas tres líneas se abre la EOD 2012 completa: 18.264 hogares, 60.054 personas y 113.591 viajes. Cada columna es una variable de su propio tipo.</a:t>
+              <a:t>Cada tabla tiene su unidad (hogar, persona, viaje) y las llaves las conectan; las tablas de parámetros traducen los códigos. Por eso la operación clave para trabajar con la EOD es merge.</a:t>
             </a:r>
           </a:p>
         </p:txBody>
@@ -6460,45 +6387,21 @@
                 </a:solidFill>
                 <a:latin typeface="Fira Sans"/>
               </a:rPr>
-              <a:t>La EOD: una encuesta, varias tablas</a:t>
-            </a:r>
-          </a:p>
-        </p:txBody>
-      </p:sp>
-      <p:pic>
-        <p:nvPicPr>
-          <p:cNvPr id="4" name="Picture 3" descr="12_eod_tablas.png"/>
-          <p:cNvPicPr>
-            <a:picLocks noChangeAspect="1"/>
-          </p:cNvPicPr>
-          <p:nvPr/>
-        </p:nvPicPr>
-        <p:blipFill>
-          <a:blip r:embed="rId2"/>
-          <a:stretch>
-            <a:fillRect/>
-          </a:stretch>
-        </p:blipFill>
-        <p:spPr>
-          <a:xfrm>
-            <a:off x="1553651" y="1143000"/>
-            <a:ext cx="6036697" cy="3154680"/>
-          </a:xfrm>
-          <a:prstGeom prst="rect">
-            <a:avLst/>
-          </a:prstGeom>
-        </p:spPr>
-      </p:pic>
-      <p:sp>
-        <p:nvSpPr>
-          <p:cNvPr id="5" name="TextBox 4"/>
+              <a:t>El DataFrame no es exclusivo de Pandas</a:t>
+            </a:r>
+          </a:p>
+        </p:txBody>
+      </p:sp>
+      <p:sp>
+        <p:nvSpPr>
+          <p:cNvPr id="4" name="TextBox 3"/>
           <p:cNvSpPr txBox="1"/>
           <p:nvPr/>
         </p:nvSpPr>
         <p:spPr>
           <a:xfrm>
-            <a:off x="704088" y="4434840"/>
-            <a:ext cx="7744968" cy="457200"/>
+            <a:off x="704088" y="1353312"/>
+            <a:ext cx="7744968" cy="3300984"/>
           </a:xfrm>
           <a:prstGeom prst="rect">
             <a:avLst/>
@@ -6511,14 +6414,171 @@
           </a:bodyPr>
           <a:lstStyle/>
           <a:p>
-            <a:r>
-              <a:rPr sz="1300" b="0">
+            <a:pPr>
+              <a:lnSpc>
+                <a:spcPct val="112000"/>
+              </a:lnSpc>
+              <a:spcAft>
+                <a:spcPts val="900"/>
+              </a:spcAft>
+            </a:pPr>
+            <a:r>
+              <a:rPr sz="1800" b="1">
+                <a:solidFill>
+                  <a:srgbClr val="E0A437"/>
+                </a:solidFill>
+                <a:latin typeface="Fira Sans"/>
+              </a:rPr>
+              <a:t>▸ </a:t>
+            </a:r>
+            <a:r>
+              <a:rPr sz="1800" b="0">
+                <a:solidFill>
+                  <a:srgbClr val="000000"/>
+                </a:solidFill>
+                <a:latin typeface="Fira Sans"/>
+              </a:rPr>
+              <a:t>Varias herramientas usan la misma abstracción de tabla, y Pandas no siempre es la mejor opción cuando los datos crecen:</a:t>
+            </a:r>
+          </a:p>
+          <a:p>
+            <a:pPr>
+              <a:lnSpc>
+                <a:spcPct val="112000"/>
+              </a:lnSpc>
+              <a:spcAft>
+                <a:spcPts val="500"/>
+              </a:spcAft>
+            </a:pPr>
+            <a:r>
+              <a:rPr sz="1400" b="0">
                 <a:solidFill>
                   <a:srgbClr val="333333"/>
                 </a:solidFill>
                 <a:latin typeface="Fira Sans"/>
               </a:rPr>
-              <a:t>Cada tabla tiene su unidad (hogar, persona, viaje) y las llaves las conectan; las tablas de parámetros traducen los códigos. Por eso la operación clave para trabajar con la EOD es merge.</a:t>
+              <a:t>     ◦  </a:t>
+            </a:r>
+            <a:r>
+              <a:rPr sz="1400" b="0">
+                <a:solidFill>
+                  <a:srgbClr val="333333"/>
+                </a:solidFill>
+                <a:latin typeface="Fira Sans"/>
+              </a:rPr>
+              <a:t>Polars: DataFrames implementados en Rust, más rápidos y eficientes en memoria.</a:t>
+            </a:r>
+          </a:p>
+          <a:p>
+            <a:pPr>
+              <a:lnSpc>
+                <a:spcPct val="112000"/>
+              </a:lnSpc>
+              <a:spcAft>
+                <a:spcPts val="500"/>
+              </a:spcAft>
+            </a:pPr>
+            <a:r>
+              <a:rPr sz="1400" b="0">
+                <a:solidFill>
+                  <a:srgbClr val="333333"/>
+                </a:solidFill>
+                <a:latin typeface="Fira Sans"/>
+              </a:rPr>
+              <a:t>     ◦  </a:t>
+            </a:r>
+            <a:r>
+              <a:rPr sz="1400" b="0">
+                <a:solidFill>
+                  <a:srgbClr val="333333"/>
+                </a:solidFill>
+                <a:latin typeface="Fira Sans"/>
+              </a:rPr>
+              <a:t>Apache Spark: DataFrames distribuidos en un clúster, para volúmenes que no caben en una máquina.</a:t>
+            </a:r>
+          </a:p>
+          <a:p>
+            <a:pPr>
+              <a:lnSpc>
+                <a:spcPct val="112000"/>
+              </a:lnSpc>
+              <a:spcAft>
+                <a:spcPts val="500"/>
+              </a:spcAft>
+            </a:pPr>
+            <a:r>
+              <a:rPr sz="1400" b="0">
+                <a:solidFill>
+                  <a:srgbClr val="333333"/>
+                </a:solidFill>
+                <a:latin typeface="Fira Sans"/>
+              </a:rPr>
+              <a:t>     ◦  </a:t>
+            </a:r>
+            <a:r>
+              <a:rPr sz="1400" b="0">
+                <a:solidFill>
+                  <a:srgbClr val="333333"/>
+                </a:solidFill>
+                <a:latin typeface="Fira Sans"/>
+              </a:rPr>
+              <a:t>Dask: paraleliza la interfaz de Pandas sobre varios núcleos o máquinas.</a:t>
+            </a:r>
+          </a:p>
+          <a:p>
+            <a:pPr>
+              <a:lnSpc>
+                <a:spcPct val="112000"/>
+              </a:lnSpc>
+              <a:spcAft>
+                <a:spcPts val="500"/>
+              </a:spcAft>
+            </a:pPr>
+            <a:r>
+              <a:rPr sz="1400" b="0">
+                <a:solidFill>
+                  <a:srgbClr val="333333"/>
+                </a:solidFill>
+                <a:latin typeface="Fira Sans"/>
+              </a:rPr>
+              <a:t>     ◦  </a:t>
+            </a:r>
+            <a:r>
+              <a:rPr sz="1400" b="0">
+                <a:solidFill>
+                  <a:srgbClr val="333333"/>
+                </a:solidFill>
+                <a:latin typeface="Fira Sans"/>
+              </a:rPr>
+              <a:t>DuckDB: consultas SQL directas sobre archivos y DataFrames.</a:t>
+            </a:r>
+          </a:p>
+          <a:p>
+            <a:pPr>
+              <a:lnSpc>
+                <a:spcPct val="112000"/>
+              </a:lnSpc>
+              <a:spcAft>
+                <a:spcPts val="900"/>
+              </a:spcAft>
+            </a:pPr>
+            <a:r>
+              <a:rPr sz="1800" b="1">
+                <a:solidFill>
+                  <a:srgbClr val="E0A437"/>
+                </a:solidFill>
+                <a:latin typeface="Fira Sans"/>
+              </a:rPr>
+              <a:t>▸ </a:t>
+            </a:r>
+            <a:r>
+              <a:rPr sz="1800" b="0">
+                <a:solidFill>
+                  <a:srgbClr val="000000"/>
+                </a:solidFill>
+                <a:latin typeface="Fira Sans"/>
+              </a:rPr>
+              <a:t>En este módulo usamos Pandas: es el estándar para el análisis interactivo con datos de tamaño pequeño y mediano, y su interfaz es la referencia que las demás herramientas siguen.</a:t>
             </a:r>
           </a:p>
         </p:txBody>
@@ -6614,21 +6674,45 @@
                 </a:solidFill>
                 <a:latin typeface="Fira Sans"/>
               </a:rPr>
-              <a:t>El DataFrame no es exclusivo de Pandas</a:t>
-            </a:r>
-          </a:p>
-        </p:txBody>
-      </p:sp>
-      <p:sp>
-        <p:nvSpPr>
-          <p:cNvPr id="4" name="TextBox 3"/>
+              <a:t>Matplotlib: tres gráficos básicos</a:t>
+            </a:r>
+          </a:p>
+        </p:txBody>
+      </p:sp>
+      <p:pic>
+        <p:nvPicPr>
+          <p:cNvPr id="4" name="Picture 3" descr="11_tres_graficos.png"/>
+          <p:cNvPicPr>
+            <a:picLocks noChangeAspect="1"/>
+          </p:cNvPicPr>
+          <p:nvPr/>
+        </p:nvPicPr>
+        <p:blipFill>
+          <a:blip r:embed="rId2"/>
+          <a:stretch>
+            <a:fillRect/>
+          </a:stretch>
+        </p:blipFill>
+        <p:spPr>
+          <a:xfrm>
+            <a:off x="320040" y="1234440"/>
+            <a:ext cx="8503920" cy="2715401"/>
+          </a:xfrm>
+          <a:prstGeom prst="rect">
+            <a:avLst/>
+          </a:prstGeom>
+        </p:spPr>
+      </p:pic>
+      <p:sp>
+        <p:nvSpPr>
+          <p:cNvPr id="5" name="TextBox 4"/>
           <p:cNvSpPr txBox="1"/>
           <p:nvPr/>
         </p:nvSpPr>
         <p:spPr>
           <a:xfrm>
-            <a:off x="704088" y="1353312"/>
-            <a:ext cx="7744968" cy="3300984"/>
+            <a:off x="502920" y="4251960"/>
+            <a:ext cx="8138160" cy="731520"/>
           </a:xfrm>
           <a:prstGeom prst="rect">
             <a:avLst/>
@@ -6641,171 +6725,14 @@
           </a:bodyPr>
           <a:lstStyle/>
           <a:p>
-            <a:pPr>
-              <a:lnSpc>
-                <a:spcPct val="112000"/>
-              </a:lnSpc>
-              <a:spcAft>
-                <a:spcPts val="900"/>
-              </a:spcAft>
-            </a:pPr>
-            <a:r>
-              <a:rPr sz="1800" b="1">
-                <a:solidFill>
-                  <a:srgbClr val="E0A437"/>
-                </a:solidFill>
-                <a:latin typeface="Fira Sans"/>
-              </a:rPr>
-              <a:t>▸ </a:t>
-            </a:r>
-            <a:r>
-              <a:rPr sz="1800" b="0">
-                <a:solidFill>
-                  <a:srgbClr val="000000"/>
-                </a:solidFill>
-                <a:latin typeface="Fira Sans"/>
-              </a:rPr>
-              <a:t>Varias herramientas usan la misma abstracción de tabla, y Pandas no siempre es la mejor opción cuando los datos crecen:</a:t>
-            </a:r>
-          </a:p>
-          <a:p>
-            <a:pPr>
-              <a:lnSpc>
-                <a:spcPct val="112000"/>
-              </a:lnSpc>
-              <a:spcAft>
-                <a:spcPts val="500"/>
-              </a:spcAft>
-            </a:pPr>
-            <a:r>
-              <a:rPr sz="1400" b="0">
+            <a:r>
+              <a:rPr sz="1300" b="0">
                 <a:solidFill>
                   <a:srgbClr val="333333"/>
                 </a:solidFill>
                 <a:latin typeface="Fira Sans"/>
               </a:rPr>
-              <a:t>     ◦  </a:t>
-            </a:r>
-            <a:r>
-              <a:rPr sz="1400" b="0">
-                <a:solidFill>
-                  <a:srgbClr val="333333"/>
-                </a:solidFill>
-                <a:latin typeface="Fira Sans"/>
-              </a:rPr>
-              <a:t>Polars: DataFrames implementados en Rust, más rápidos y eficientes en memoria.</a:t>
-            </a:r>
-          </a:p>
-          <a:p>
-            <a:pPr>
-              <a:lnSpc>
-                <a:spcPct val="112000"/>
-              </a:lnSpc>
-              <a:spcAft>
-                <a:spcPts val="500"/>
-              </a:spcAft>
-            </a:pPr>
-            <a:r>
-              <a:rPr sz="1400" b="0">
-                <a:solidFill>
-                  <a:srgbClr val="333333"/>
-                </a:solidFill>
-                <a:latin typeface="Fira Sans"/>
-              </a:rPr>
-              <a:t>     ◦  </a:t>
-            </a:r>
-            <a:r>
-              <a:rPr sz="1400" b="0">
-                <a:solidFill>
-                  <a:srgbClr val="333333"/>
-                </a:solidFill>
-                <a:latin typeface="Fira Sans"/>
-              </a:rPr>
-              <a:t>Apache Spark: DataFrames distribuidos en un clúster, para volúmenes que no caben en una máquina.</a:t>
-            </a:r>
-          </a:p>
-          <a:p>
-            <a:pPr>
-              <a:lnSpc>
-                <a:spcPct val="112000"/>
-              </a:lnSpc>
-              <a:spcAft>
-                <a:spcPts val="500"/>
-              </a:spcAft>
-            </a:pPr>
-            <a:r>
-              <a:rPr sz="1400" b="0">
-                <a:solidFill>
-                  <a:srgbClr val="333333"/>
-                </a:solidFill>
-                <a:latin typeface="Fira Sans"/>
-              </a:rPr>
-              <a:t>     ◦  </a:t>
-            </a:r>
-            <a:r>
-              <a:rPr sz="1400" b="0">
-                <a:solidFill>
-                  <a:srgbClr val="333333"/>
-                </a:solidFill>
-                <a:latin typeface="Fira Sans"/>
-              </a:rPr>
-              <a:t>Dask: paraleliza la interfaz de Pandas sobre varios núcleos o máquinas.</a:t>
-            </a:r>
-          </a:p>
-          <a:p>
-            <a:pPr>
-              <a:lnSpc>
-                <a:spcPct val="112000"/>
-              </a:lnSpc>
-              <a:spcAft>
-                <a:spcPts val="500"/>
-              </a:spcAft>
-            </a:pPr>
-            <a:r>
-              <a:rPr sz="1400" b="0">
-                <a:solidFill>
-                  <a:srgbClr val="333333"/>
-                </a:solidFill>
-                <a:latin typeface="Fira Sans"/>
-              </a:rPr>
-              <a:t>     ◦  </a:t>
-            </a:r>
-            <a:r>
-              <a:rPr sz="1400" b="0">
-                <a:solidFill>
-                  <a:srgbClr val="333333"/>
-                </a:solidFill>
-                <a:latin typeface="Fira Sans"/>
-              </a:rPr>
-              <a:t>DuckDB: consultas SQL directas sobre archivos y DataFrames.</a:t>
-            </a:r>
-          </a:p>
-          <a:p>
-            <a:pPr>
-              <a:lnSpc>
-                <a:spcPct val="112000"/>
-              </a:lnSpc>
-              <a:spcAft>
-                <a:spcPts val="900"/>
-              </a:spcAft>
-            </a:pPr>
-            <a:r>
-              <a:rPr sz="1800" b="1">
-                <a:solidFill>
-                  <a:srgbClr val="E0A437"/>
-                </a:solidFill>
-                <a:latin typeface="Fira Sans"/>
-              </a:rPr>
-              <a:t>▸ </a:t>
-            </a:r>
-            <a:r>
-              <a:rPr sz="1800" b="0">
-                <a:solidFill>
-                  <a:srgbClr val="000000"/>
-                </a:solidFill>
-                <a:latin typeface="Fira Sans"/>
-              </a:rPr>
-              <a:t>En este módulo usamos Pandas: es el estándar para el análisis interactivo con datos de tamaño pequeño y mediano, y su interfaz es la referencia que las demás herramientas siguen.</a:t>
+              <a:t>El gráfico depende del tipo de variable: barras para una cualitativa, histograma para una cuantitativa, dispersión para dos cuantitativas. Los tres salen de la tabla de viajes y se construyen en el notebook.</a:t>
             </a:r>
           </a:p>
         </p:txBody>
@@ -6901,14 +6828,14 @@
                 </a:solidFill>
                 <a:latin typeface="Fira Sans"/>
               </a:rPr>
-              <a:t>Matplotlib: tres gráficos básicos</a:t>
+              <a:t>El factor de expansión</a:t>
             </a:r>
           </a:p>
         </p:txBody>
       </p:sp>
       <p:pic>
         <p:nvPicPr>
-          <p:cNvPr id="4" name="Picture 3" descr="11_tres_graficos.png"/>
+          <p:cNvPr id="4" name="Picture 3" descr="13_factor_expansion.png"/>
           <p:cNvPicPr>
             <a:picLocks noChangeAspect="1"/>
           </p:cNvPicPr>
@@ -6922,8 +6849,8 @@
         </p:blipFill>
         <p:spPr>
           <a:xfrm>
-            <a:off x="320040" y="1234440"/>
-            <a:ext cx="8503920" cy="2715401"/>
+            <a:off x="1417319" y="1143000"/>
+            <a:ext cx="6309360" cy="2871234"/>
           </a:xfrm>
           <a:prstGeom prst="rect">
             <a:avLst/>
@@ -6938,8 +6865,8 @@
         </p:nvSpPr>
         <p:spPr>
           <a:xfrm>
-            <a:off x="502920" y="4251960"/>
-            <a:ext cx="8138160" cy="731520"/>
+            <a:off x="704088" y="4434840"/>
+            <a:ext cx="7744968" cy="457200"/>
           </a:xfrm>
           <a:prstGeom prst="rect">
             <a:avLst/>
@@ -6959,7 +6886,7 @@
                 </a:solidFill>
                 <a:latin typeface="Fira Sans"/>
               </a:rPr>
-              <a:t>El gráfico depende del tipo de variable: barras para una cualitativa, histograma para una cuantitativa, dispersión para dos cuantitativas. Los tres salen de la tabla de viajes y se construyen en el notebook.</a:t>
+              <a:t>Cada persona encuestada representa a muchas otras; su factor de expansión dice a cuántas. La suma de los factores estima la población completa.</a:t>
             </a:r>
           </a:p>
         </p:txBody>
@@ -7055,45 +6982,21 @@
                 </a:solidFill>
                 <a:latin typeface="Fira Sans"/>
               </a:rPr>
-              <a:t>El factor de expansión</a:t>
-            </a:r>
-          </a:p>
-        </p:txBody>
-      </p:sp>
-      <p:pic>
-        <p:nvPicPr>
-          <p:cNvPr id="4" name="Picture 3" descr="13_factor_expansion.png"/>
-          <p:cNvPicPr>
-            <a:picLocks noChangeAspect="1"/>
-          </p:cNvPicPr>
-          <p:nvPr/>
-        </p:nvPicPr>
-        <p:blipFill>
-          <a:blip r:embed="rId2"/>
-          <a:stretch>
-            <a:fillRect/>
-          </a:stretch>
-        </p:blipFill>
-        <p:spPr>
-          <a:xfrm>
-            <a:off x="1417319" y="1143000"/>
-            <a:ext cx="6309360" cy="2871234"/>
-          </a:xfrm>
-          <a:prstGeom prst="rect">
-            <a:avLst/>
-          </a:prstGeom>
-        </p:spPr>
-      </p:pic>
-      <p:sp>
-        <p:nvSpPr>
-          <p:cNvPr id="5" name="TextBox 4"/>
+              <a:t>El factor de expansión en los cálculos</a:t>
+            </a:r>
+          </a:p>
+        </p:txBody>
+      </p:sp>
+      <p:sp>
+        <p:nvSpPr>
+          <p:cNvPr id="4" name="TextBox 3"/>
           <p:cNvSpPr txBox="1"/>
           <p:nvPr/>
         </p:nvSpPr>
         <p:spPr>
           <a:xfrm>
-            <a:off x="704088" y="4434840"/>
-            <a:ext cx="7744968" cy="457200"/>
+            <a:off x="704088" y="1353312"/>
+            <a:ext cx="7744968" cy="3300984"/>
           </a:xfrm>
           <a:prstGeom prst="rect">
             <a:avLst/>
@@ -7106,14 +7009,143 @@
           </a:bodyPr>
           <a:lstStyle/>
           <a:p>
-            <a:r>
-              <a:rPr sz="1300" b="0">
-                <a:solidFill>
-                  <a:srgbClr val="333333"/>
-                </a:solidFill>
-                <a:latin typeface="Fira Sans"/>
-              </a:rPr>
-              <a:t>Cada persona encuestada representa a muchas otras; su factor de expansión dice a cuántas. La suma de los factores estima la población completa.</a:t>
+            <a:pPr>
+              <a:lnSpc>
+                <a:spcPct val="112000"/>
+              </a:lnSpc>
+              <a:spcAft>
+                <a:spcPts val="900"/>
+              </a:spcAft>
+            </a:pPr>
+            <a:r>
+              <a:rPr sz="1800" b="1">
+                <a:solidFill>
+                  <a:srgbClr val="E0A437"/>
+                </a:solidFill>
+                <a:latin typeface="Fira Sans"/>
+              </a:rPr>
+              <a:t>▸ </a:t>
+            </a:r>
+            <a:r>
+              <a:rPr sz="1800" b="0">
+                <a:solidFill>
+                  <a:srgbClr val="000000"/>
+                </a:solidFill>
+                <a:latin typeface="Fira Sans"/>
+              </a:rPr>
+              <a:t>Una encuesta entrevista a una muestra: la EOD, a 60.054 personas de los 6,65 millones de habitantes que cubre.</a:t>
+            </a:r>
+          </a:p>
+          <a:p>
+            <a:pPr>
+              <a:lnSpc>
+                <a:spcPct val="112000"/>
+              </a:lnSpc>
+              <a:spcAft>
+                <a:spcPts val="900"/>
+              </a:spcAft>
+            </a:pPr>
+            <a:r>
+              <a:rPr sz="1800" b="1">
+                <a:solidFill>
+                  <a:srgbClr val="E0A437"/>
+                </a:solidFill>
+                <a:latin typeface="Fira Sans"/>
+              </a:rPr>
+              <a:t>▸ </a:t>
+            </a:r>
+            <a:r>
+              <a:rPr sz="1800" b="0">
+                <a:solidFill>
+                  <a:srgbClr val="000000"/>
+                </a:solidFill>
+                <a:latin typeface="Fira Sans"/>
+              </a:rPr>
+              <a:t>El factor de expansión de cada persona indica a cuántos habitantes representa; sale del diseño muestral (comuna, sexo, edad).</a:t>
+            </a:r>
+          </a:p>
+          <a:p>
+            <a:pPr>
+              <a:lnSpc>
+                <a:spcPct val="112000"/>
+              </a:lnSpc>
+              <a:spcAft>
+                <a:spcPts val="900"/>
+              </a:spcAft>
+            </a:pPr>
+            <a:r>
+              <a:rPr sz="1800" b="1">
+                <a:solidFill>
+                  <a:srgbClr val="E0A437"/>
+                </a:solidFill>
+                <a:latin typeface="Fira Sans"/>
+              </a:rPr>
+              <a:t>▸ </a:t>
+            </a:r>
+            <a:r>
+              <a:rPr sz="1800" b="0">
+                <a:solidFill>
+                  <a:srgbClr val="000000"/>
+                </a:solidFill>
+                <a:latin typeface="Fira Sans"/>
+              </a:rPr>
+              <a:t>La suma de los factores reproduce la población: en la EOD, Factor_LaboralNormal suma 6.651.735.</a:t>
+            </a:r>
+          </a:p>
+          <a:p>
+            <a:pPr>
+              <a:lnSpc>
+                <a:spcPct val="112000"/>
+              </a:lnSpc>
+              <a:spcAft>
+                <a:spcPts val="900"/>
+              </a:spcAft>
+            </a:pPr>
+            <a:r>
+              <a:rPr sz="1800" b="1">
+                <a:solidFill>
+                  <a:srgbClr val="E0A437"/>
+                </a:solidFill>
+                <a:latin typeface="Fira Sans"/>
+              </a:rPr>
+              <a:t>▸ </a:t>
+            </a:r>
+            <a:r>
+              <a:rPr sz="1800" b="1">
+                <a:solidFill>
+                  <a:srgbClr val="1D3557"/>
+                </a:solidFill>
+                <a:latin typeface="Fira Sans"/>
+              </a:rPr>
+              <a:t>Todo resumen tiene dos versiones: muestral (contar filas) y ponderada (sumar factores). ¿De quién habla cada número?</a:t>
+            </a:r>
+          </a:p>
+          <a:p>
+            <a:pPr>
+              <a:lnSpc>
+                <a:spcPct val="112000"/>
+              </a:lnSpc>
+              <a:spcAft>
+                <a:spcPts val="900"/>
+              </a:spcAft>
+            </a:pPr>
+            <a:r>
+              <a:rPr sz="1800" b="1">
+                <a:solidFill>
+                  <a:srgbClr val="E0A437"/>
+                </a:solidFill>
+                <a:latin typeface="Fira Sans"/>
+              </a:rPr>
+              <a:t>▸ </a:t>
+            </a:r>
+            <a:r>
+              <a:rPr sz="1800" b="0">
+                <a:solidFill>
+                  <a:srgbClr val="000000"/>
+                </a:solidFill>
+                <a:latin typeface="Fira Sans"/>
+              </a:rPr>
+              <a:t>En el notebook: 52,8% de mujeres en la muestra, 51,5% ponderado.</a:t>
             </a:r>
           </a:p>
         </p:txBody>
@@ -7209,21 +7241,45 @@
                 </a:solidFill>
                 <a:latin typeface="Fira Sans"/>
               </a:rPr>
-              <a:t>El factor de expansión en los cálculos</a:t>
-            </a:r>
-          </a:p>
-        </p:txBody>
-      </p:sp>
-      <p:sp>
-        <p:nvSpPr>
-          <p:cNvPr id="4" name="TextBox 3"/>
+              <a:t>Reparto modal de Santiago, EOD 2012</a:t>
+            </a:r>
+          </a:p>
+        </p:txBody>
+      </p:sp>
+      <p:pic>
+        <p:nvPicPr>
+          <p:cNvPr id="4" name="Picture 3" descr="01_reparto_modal.png"/>
+          <p:cNvPicPr>
+            <a:picLocks noChangeAspect="1"/>
+          </p:cNvPicPr>
+          <p:nvPr/>
+        </p:nvPicPr>
+        <p:blipFill>
+          <a:blip r:embed="rId2"/>
+          <a:stretch>
+            <a:fillRect/>
+          </a:stretch>
+        </p:blipFill>
+        <p:spPr>
+          <a:xfrm>
+            <a:off x="1604462" y="1143000"/>
+            <a:ext cx="5935075" cy="3154680"/>
+          </a:xfrm>
+          <a:prstGeom prst="rect">
+            <a:avLst/>
+          </a:prstGeom>
+        </p:spPr>
+      </p:pic>
+      <p:sp>
+        <p:nvSpPr>
+          <p:cNvPr id="5" name="TextBox 4"/>
           <p:cNvSpPr txBox="1"/>
           <p:nvPr/>
         </p:nvSpPr>
         <p:spPr>
           <a:xfrm>
-            <a:off x="704088" y="1353312"/>
-            <a:ext cx="7744968" cy="3300984"/>
+            <a:off x="704088" y="4434840"/>
+            <a:ext cx="7744968" cy="457200"/>
           </a:xfrm>
           <a:prstGeom prst="rect">
             <a:avLst/>
@@ -7236,143 +7292,14 @@
           </a:bodyPr>
           <a:lstStyle/>
           <a:p>
-            <a:pPr>
-              <a:lnSpc>
-                <a:spcPct val="112000"/>
-              </a:lnSpc>
-              <a:spcAft>
-                <a:spcPts val="900"/>
-              </a:spcAft>
-            </a:pPr>
-            <a:r>
-              <a:rPr sz="1800" b="1">
-                <a:solidFill>
-                  <a:srgbClr val="E0A437"/>
-                </a:solidFill>
-                <a:latin typeface="Fira Sans"/>
-              </a:rPr>
-              <a:t>▸ </a:t>
-            </a:r>
-            <a:r>
-              <a:rPr sz="1800" b="0">
-                <a:solidFill>
-                  <a:srgbClr val="000000"/>
-                </a:solidFill>
-                <a:latin typeface="Fira Sans"/>
-              </a:rPr>
-              <a:t>Una encuesta entrevista a una muestra: la EOD, a 60.054 personas de los 6,65 millones de habitantes que cubre.</a:t>
-            </a:r>
-          </a:p>
-          <a:p>
-            <a:pPr>
-              <a:lnSpc>
-                <a:spcPct val="112000"/>
-              </a:lnSpc>
-              <a:spcAft>
-                <a:spcPts val="900"/>
-              </a:spcAft>
-            </a:pPr>
-            <a:r>
-              <a:rPr sz="1800" b="1">
-                <a:solidFill>
-                  <a:srgbClr val="E0A437"/>
-                </a:solidFill>
-                <a:latin typeface="Fira Sans"/>
-              </a:rPr>
-              <a:t>▸ </a:t>
-            </a:r>
-            <a:r>
-              <a:rPr sz="1800" b="0">
-                <a:solidFill>
-                  <a:srgbClr val="000000"/>
-                </a:solidFill>
-                <a:latin typeface="Fira Sans"/>
-              </a:rPr>
-              <a:t>El factor de expansión de cada persona indica a cuántos habitantes representa; sale del diseño muestral (comuna, sexo, edad).</a:t>
-            </a:r>
-          </a:p>
-          <a:p>
-            <a:pPr>
-              <a:lnSpc>
-                <a:spcPct val="112000"/>
-              </a:lnSpc>
-              <a:spcAft>
-                <a:spcPts val="900"/>
-              </a:spcAft>
-            </a:pPr>
-            <a:r>
-              <a:rPr sz="1800" b="1">
-                <a:solidFill>
-                  <a:srgbClr val="E0A437"/>
-                </a:solidFill>
-                <a:latin typeface="Fira Sans"/>
-              </a:rPr>
-              <a:t>▸ </a:t>
-            </a:r>
-            <a:r>
-              <a:rPr sz="1800" b="0">
-                <a:solidFill>
-                  <a:srgbClr val="000000"/>
-                </a:solidFill>
-                <a:latin typeface="Fira Sans"/>
-              </a:rPr>
-              <a:t>La suma de los factores reproduce la población: en la EOD, Factor_LaboralNormal suma 6.651.735.</a:t>
-            </a:r>
-          </a:p>
-          <a:p>
-            <a:pPr>
-              <a:lnSpc>
-                <a:spcPct val="112000"/>
-              </a:lnSpc>
-              <a:spcAft>
-                <a:spcPts val="900"/>
-              </a:spcAft>
-            </a:pPr>
-            <a:r>
-              <a:rPr sz="1800" b="1">
-                <a:solidFill>
-                  <a:srgbClr val="E0A437"/>
-                </a:solidFill>
-                <a:latin typeface="Fira Sans"/>
-              </a:rPr>
-              <a:t>▸ </a:t>
-            </a:r>
-            <a:r>
-              <a:rPr sz="1800" b="1">
-                <a:solidFill>
-                  <a:srgbClr val="1D3557"/>
-                </a:solidFill>
-                <a:latin typeface="Fira Sans"/>
-              </a:rPr>
-              <a:t>Todo resumen tiene dos versiones: muestral (contar filas) y ponderada (sumar factores). ¿De quién habla cada número?</a:t>
-            </a:r>
-          </a:p>
-          <a:p>
-            <a:pPr>
-              <a:lnSpc>
-                <a:spcPct val="112000"/>
-              </a:lnSpc>
-              <a:spcAft>
-                <a:spcPts val="900"/>
-              </a:spcAft>
-            </a:pPr>
-            <a:r>
-              <a:rPr sz="1800" b="1">
-                <a:solidFill>
-                  <a:srgbClr val="E0A437"/>
-                </a:solidFill>
-                <a:latin typeface="Fira Sans"/>
-              </a:rPr>
-              <a:t>▸ </a:t>
-            </a:r>
-            <a:r>
-              <a:rPr sz="1800" b="0">
-                <a:solidFill>
-                  <a:srgbClr val="000000"/>
-                </a:solidFill>
-                <a:latin typeface="Fira Sans"/>
-              </a:rPr>
-              <a:t>En el notebook: 52,8% de mujeres en la muestra, 51,5% ponderado.</a:t>
+            <a:r>
+              <a:rPr sz="1300" b="0">
+                <a:solidFill>
+                  <a:srgbClr val="333333"/>
+                </a:solidFill>
+                <a:latin typeface="Fira Sans"/>
+              </a:rPr>
+              <a:t>Uno de cada tres viajes es a pie. Esta versión está ponderada por factores de expansión, así que habla de la ciudad; en el notebook calcularemos la versión muestral, y la diferencia entre ambas abre las clases 2 y 3.</a:t>
             </a:r>
           </a:p>
         </p:txBody>
@@ -7468,45 +7395,21 @@
                 </a:solidFill>
                 <a:latin typeface="Fira Sans"/>
               </a:rPr>
-              <a:t>Reparto modal de Santiago, EOD 2012</a:t>
-            </a:r>
-          </a:p>
-        </p:txBody>
-      </p:sp>
-      <p:pic>
-        <p:nvPicPr>
-          <p:cNvPr id="4" name="Picture 3" descr="01_reparto_modal.png"/>
-          <p:cNvPicPr>
-            <a:picLocks noChangeAspect="1"/>
-          </p:cNvPicPr>
-          <p:nvPr/>
-        </p:nvPicPr>
-        <p:blipFill>
-          <a:blip r:embed="rId2"/>
-          <a:stretch>
-            <a:fillRect/>
-          </a:stretch>
-        </p:blipFill>
-        <p:spPr>
-          <a:xfrm>
-            <a:off x="1604462" y="1143000"/>
-            <a:ext cx="5935075" cy="3154680"/>
-          </a:xfrm>
-          <a:prstGeom prst="rect">
-            <a:avLst/>
-          </a:prstGeom>
-        </p:spPr>
-      </p:pic>
-      <p:sp>
-        <p:nvSpPr>
-          <p:cNvPr id="5" name="TextBox 4"/>
+              <a:t>Síntesis</a:t>
+            </a:r>
+          </a:p>
+        </p:txBody>
+      </p:sp>
+      <p:sp>
+        <p:nvSpPr>
+          <p:cNvPr id="4" name="TextBox 3"/>
           <p:cNvSpPr txBox="1"/>
           <p:nvPr/>
         </p:nvSpPr>
         <p:spPr>
           <a:xfrm>
-            <a:off x="704088" y="4434840"/>
-            <a:ext cx="7744968" cy="457200"/>
+            <a:off x="704088" y="1353312"/>
+            <a:ext cx="7744968" cy="3300984"/>
           </a:xfrm>
           <a:prstGeom prst="rect">
             <a:avLst/>
@@ -7519,14 +7422,143 @@
           </a:bodyPr>
           <a:lstStyle/>
           <a:p>
-            <a:r>
-              <a:rPr sz="1300" b="0">
-                <a:solidFill>
-                  <a:srgbClr val="333333"/>
-                </a:solidFill>
-                <a:latin typeface="Fira Sans"/>
-              </a:rPr>
-              <a:t>Uno de cada tres viajes es a pie. Esta versión está ponderada por factores de expansión, así que habla de la ciudad; en el notebook calcularemos la versión muestral, y la diferencia entre ambas abre las clases 2 y 3.</a:t>
+            <a:pPr>
+              <a:lnSpc>
+                <a:spcPct val="112000"/>
+              </a:lnSpc>
+              <a:spcAft>
+                <a:spcPts val="900"/>
+              </a:spcAft>
+            </a:pPr>
+            <a:r>
+              <a:rPr sz="1800" b="1">
+                <a:solidFill>
+                  <a:srgbClr val="E0A437"/>
+                </a:solidFill>
+                <a:latin typeface="Fira Sans"/>
+              </a:rPr>
+              <a:t>▸ </a:t>
+            </a:r>
+            <a:r>
+              <a:rPr sz="1800" b="1">
+                <a:solidFill>
+                  <a:srgbClr val="1D3557"/>
+                </a:solidFill>
+                <a:latin typeface="Fira Sans"/>
+              </a:rPr>
+              <a:t>El tipo de cada variable determina qué resúmenes, gráficos y análisis son válidos.</a:t>
+            </a:r>
+          </a:p>
+          <a:p>
+            <a:pPr>
+              <a:lnSpc>
+                <a:spcPct val="112000"/>
+              </a:lnSpc>
+              <a:spcAft>
+                <a:spcPts val="900"/>
+              </a:spcAft>
+            </a:pPr>
+            <a:r>
+              <a:rPr sz="1800" b="1">
+                <a:solidFill>
+                  <a:srgbClr val="E0A437"/>
+                </a:solidFill>
+                <a:latin typeface="Fira Sans"/>
+              </a:rPr>
+              <a:t>▸ </a:t>
+            </a:r>
+            <a:r>
+              <a:rPr sz="1800" b="0">
+                <a:solidFill>
+                  <a:srgbClr val="000000"/>
+                </a:solidFill>
+                <a:latin typeface="Fira Sans"/>
+              </a:rPr>
+              <a:t>Ciencia de datos: extracción generalizable de conocimiento a partir de los datos (Dhar, 2013); combina estadística, computación y dominio.</a:t>
+            </a:r>
+          </a:p>
+          <a:p>
+            <a:pPr>
+              <a:lnSpc>
+                <a:spcPct val="112000"/>
+              </a:lnSpc>
+              <a:spcAft>
+                <a:spcPts val="900"/>
+              </a:spcAft>
+            </a:pPr>
+            <a:r>
+              <a:rPr sz="1800" b="1">
+                <a:solidFill>
+                  <a:srgbClr val="E0A437"/>
+                </a:solidFill>
+                <a:latin typeface="Fira Sans"/>
+              </a:rPr>
+              <a:t>▸ </a:t>
+            </a:r>
+            <a:r>
+              <a:rPr sz="1800" b="0">
+                <a:solidFill>
+                  <a:srgbClr val="000000"/>
+                </a:solidFill>
+                <a:latin typeface="Fira Sans"/>
+              </a:rPr>
+              <a:t>El ciclo de vida tiene dos entradas (una necesidad del dominio o datos disponibles) y se recorre de forma iterativa.</a:t>
+            </a:r>
+          </a:p>
+          <a:p>
+            <a:pPr>
+              <a:lnSpc>
+                <a:spcPct val="112000"/>
+              </a:lnSpc>
+              <a:spcAft>
+                <a:spcPts val="900"/>
+              </a:spcAft>
+            </a:pPr>
+            <a:r>
+              <a:rPr sz="1800" b="1">
+                <a:solidFill>
+                  <a:srgbClr val="E0A437"/>
+                </a:solidFill>
+                <a:latin typeface="Fira Sans"/>
+              </a:rPr>
+              <a:t>▸ </a:t>
+            </a:r>
+            <a:r>
+              <a:rPr sz="1800" b="0">
+                <a:solidFill>
+                  <a:srgbClr val="000000"/>
+                </a:solidFill>
+                <a:latin typeface="Fira Sans"/>
+              </a:rPr>
+              <a:t>La preparación de datos consume cerca de la mitad del tiempo de un proyecto (Anaconda, 2020).</a:t>
+            </a:r>
+          </a:p>
+          <a:p>
+            <a:pPr>
+              <a:lnSpc>
+                <a:spcPct val="112000"/>
+              </a:lnSpc>
+              <a:spcAft>
+                <a:spcPts val="900"/>
+              </a:spcAft>
+            </a:pPr>
+            <a:r>
+              <a:rPr sz="1800" b="1">
+                <a:solidFill>
+                  <a:srgbClr val="E0A437"/>
+                </a:solidFill>
+                <a:latin typeface="Fira Sans"/>
+              </a:rPr>
+              <a:t>▸ </a:t>
+            </a:r>
+            <a:r>
+              <a:rPr sz="1800" b="0">
+                <a:solidFill>
+                  <a:srgbClr val="000000"/>
+                </a:solidFill>
+                <a:latin typeface="Fira Sans"/>
+              </a:rPr>
+              <a:t>Próxima clase (jueves 27): estadística descriptiva, con el entorno ya funcionando.</a:t>
             </a:r>
           </a:p>
         </p:txBody>
@@ -7540,265 +7572,6 @@
 </file>
 
 <file path=ppt/slides/slide28.xml><?xml version="1.0" encoding="utf-8"?>
-<p:sld xmlns:a="http://schemas.openxmlformats.org/drawingml/2006/main" xmlns:p="http://schemas.openxmlformats.org/presentationml/2006/main" xmlns:r="http://schemas.openxmlformats.org/officeDocument/2006/relationships">
-  <p:cSld>
-    <p:spTree>
-      <p:nvGrpSpPr>
-        <p:cNvPr id="1" name=""/>
-        <p:cNvGrpSpPr/>
-        <p:nvPr/>
-      </p:nvGrpSpPr>
-      <p:grpSpPr/>
-      <p:sp>
-        <p:nvSpPr>
-          <p:cNvPr id="2" name="Rectangle 1"/>
-          <p:cNvSpPr/>
-          <p:nvPr/>
-        </p:nvSpPr>
-        <p:spPr>
-          <a:xfrm>
-            <a:off x="0" y="0"/>
-            <a:ext cx="9144000" cy="5138928"/>
-          </a:xfrm>
-          <a:prstGeom prst="rect">
-            <a:avLst/>
-          </a:prstGeom>
-          <a:solidFill>
-            <a:srgbClr val="FAFBFC"/>
-          </a:solidFill>
-          <a:ln>
-            <a:noFill/>
-          </a:ln>
-          <a:effectLst/>
-        </p:spPr>
-        <p:style>
-          <a:lnRef idx="1">
-            <a:schemeClr val="accent1"/>
-          </a:lnRef>
-          <a:fillRef idx="3">
-            <a:schemeClr val="accent1"/>
-          </a:fillRef>
-          <a:effectRef idx="2">
-            <a:schemeClr val="accent1"/>
-          </a:effectRef>
-          <a:fontRef idx="minor">
-            <a:schemeClr val="lt1"/>
-          </a:fontRef>
-        </p:style>
-        <p:txBody>
-          <a:bodyPr rtlCol="0" anchor="ctr"/>
-          <a:lstStyle/>
-          <a:p>
-            <a:pPr algn="ctr"/>
-          </a:p>
-        </p:txBody>
-      </p:sp>
-      <p:sp>
-        <p:nvSpPr>
-          <p:cNvPr id="3" name="TextBox 2"/>
-          <p:cNvSpPr txBox="1"/>
-          <p:nvPr/>
-        </p:nvSpPr>
-        <p:spPr>
-          <a:xfrm>
-            <a:off x="402336" y="301752"/>
-            <a:ext cx="8348472" cy="795528"/>
-          </a:xfrm>
-          <a:prstGeom prst="rect">
-            <a:avLst/>
-          </a:prstGeom>
-          <a:noFill/>
-        </p:spPr>
-        <p:txBody>
-          <a:bodyPr wrap="square">
-            <a:spAutoFit/>
-          </a:bodyPr>
-          <a:lstStyle/>
-          <a:p>
-            <a:r>
-              <a:rPr sz="2800" b="1">
-                <a:solidFill>
-                  <a:srgbClr val="0F0F0F"/>
-                </a:solidFill>
-                <a:latin typeface="Fira Sans"/>
-              </a:rPr>
-              <a:t>Síntesis</a:t>
-            </a:r>
-          </a:p>
-        </p:txBody>
-      </p:sp>
-      <p:sp>
-        <p:nvSpPr>
-          <p:cNvPr id="4" name="TextBox 3"/>
-          <p:cNvSpPr txBox="1"/>
-          <p:nvPr/>
-        </p:nvSpPr>
-        <p:spPr>
-          <a:xfrm>
-            <a:off x="704088" y="1353312"/>
-            <a:ext cx="7744968" cy="3300984"/>
-          </a:xfrm>
-          <a:prstGeom prst="rect">
-            <a:avLst/>
-          </a:prstGeom>
-          <a:noFill/>
-        </p:spPr>
-        <p:txBody>
-          <a:bodyPr wrap="square">
-            <a:spAutoFit/>
-          </a:bodyPr>
-          <a:lstStyle/>
-          <a:p>
-            <a:pPr>
-              <a:lnSpc>
-                <a:spcPct val="112000"/>
-              </a:lnSpc>
-              <a:spcAft>
-                <a:spcPts val="900"/>
-              </a:spcAft>
-            </a:pPr>
-            <a:r>
-              <a:rPr sz="1800" b="1">
-                <a:solidFill>
-                  <a:srgbClr val="E0A437"/>
-                </a:solidFill>
-                <a:latin typeface="Fira Sans"/>
-              </a:rPr>
-              <a:t>▸ </a:t>
-            </a:r>
-            <a:r>
-              <a:rPr sz="1800" b="1">
-                <a:solidFill>
-                  <a:srgbClr val="1D3557"/>
-                </a:solidFill>
-                <a:latin typeface="Fira Sans"/>
-              </a:rPr>
-              <a:t>El tipo de cada variable determina qué resúmenes, gráficos y análisis son válidos.</a:t>
-            </a:r>
-          </a:p>
-          <a:p>
-            <a:pPr>
-              <a:lnSpc>
-                <a:spcPct val="112000"/>
-              </a:lnSpc>
-              <a:spcAft>
-                <a:spcPts val="900"/>
-              </a:spcAft>
-            </a:pPr>
-            <a:r>
-              <a:rPr sz="1800" b="1">
-                <a:solidFill>
-                  <a:srgbClr val="E0A437"/>
-                </a:solidFill>
-                <a:latin typeface="Fira Sans"/>
-              </a:rPr>
-              <a:t>▸ </a:t>
-            </a:r>
-            <a:r>
-              <a:rPr sz="1800" b="0">
-                <a:solidFill>
-                  <a:srgbClr val="000000"/>
-                </a:solidFill>
-                <a:latin typeface="Fira Sans"/>
-              </a:rPr>
-              <a:t>Ciencia de datos: extracción generalizable de conocimiento a partir de los datos (Dhar, 2013); combina estadística, computación y dominio.</a:t>
-            </a:r>
-          </a:p>
-          <a:p>
-            <a:pPr>
-              <a:lnSpc>
-                <a:spcPct val="112000"/>
-              </a:lnSpc>
-              <a:spcAft>
-                <a:spcPts val="900"/>
-              </a:spcAft>
-            </a:pPr>
-            <a:r>
-              <a:rPr sz="1800" b="1">
-                <a:solidFill>
-                  <a:srgbClr val="E0A437"/>
-                </a:solidFill>
-                <a:latin typeface="Fira Sans"/>
-              </a:rPr>
-              <a:t>▸ </a:t>
-            </a:r>
-            <a:r>
-              <a:rPr sz="1800" b="0">
-                <a:solidFill>
-                  <a:srgbClr val="000000"/>
-                </a:solidFill>
-                <a:latin typeface="Fira Sans"/>
-              </a:rPr>
-              <a:t>El ciclo de vida tiene dos entradas (una necesidad del dominio o datos disponibles) y se recorre de forma iterativa.</a:t>
-            </a:r>
-          </a:p>
-          <a:p>
-            <a:pPr>
-              <a:lnSpc>
-                <a:spcPct val="112000"/>
-              </a:lnSpc>
-              <a:spcAft>
-                <a:spcPts val="900"/>
-              </a:spcAft>
-            </a:pPr>
-            <a:r>
-              <a:rPr sz="1800" b="1">
-                <a:solidFill>
-                  <a:srgbClr val="E0A437"/>
-                </a:solidFill>
-                <a:latin typeface="Fira Sans"/>
-              </a:rPr>
-              <a:t>▸ </a:t>
-            </a:r>
-            <a:r>
-              <a:rPr sz="1800" b="0">
-                <a:solidFill>
-                  <a:srgbClr val="000000"/>
-                </a:solidFill>
-                <a:latin typeface="Fira Sans"/>
-              </a:rPr>
-              <a:t>La preparación de datos consume cerca de la mitad del tiempo de un proyecto (Anaconda, 2020).</a:t>
-            </a:r>
-          </a:p>
-          <a:p>
-            <a:pPr>
-              <a:lnSpc>
-                <a:spcPct val="112000"/>
-              </a:lnSpc>
-              <a:spcAft>
-                <a:spcPts val="900"/>
-              </a:spcAft>
-            </a:pPr>
-            <a:r>
-              <a:rPr sz="1800" b="1">
-                <a:solidFill>
-                  <a:srgbClr val="E0A437"/>
-                </a:solidFill>
-                <a:latin typeface="Fira Sans"/>
-              </a:rPr>
-              <a:t>▸ </a:t>
-            </a:r>
-            <a:r>
-              <a:rPr sz="1800" b="0">
-                <a:solidFill>
-                  <a:srgbClr val="000000"/>
-                </a:solidFill>
-                <a:latin typeface="Fira Sans"/>
-              </a:rPr>
-              <a:t>Próxima clase (jueves 27): estadística descriptiva, con el entorno ya funcionando.</a:t>
-            </a:r>
-          </a:p>
-        </p:txBody>
-      </p:sp>
-    </p:spTree>
-  </p:cSld>
-  <p:clrMapOvr>
-    <a:masterClrMapping/>
-  </p:clrMapOvr>
-</p:sld>
-</file>
-
-<file path=ppt/slides/slide29.xml><?xml version="1.0" encoding="utf-8"?>
 <p:sld xmlns:a="http://schemas.openxmlformats.org/drawingml/2006/main" xmlns:p="http://schemas.openxmlformats.org/presentationml/2006/main" xmlns:r="http://schemas.openxmlformats.org/officeDocument/2006/relationships">
   <p:cSld>
     <p:spTree>

</xml_diff>

<commit_message>
Logo del Departamento de Informática en la portada
Co-Authored-By: Claude Fable 5 <noreply@anthropic.com>
</commit_message>
<xml_diff>
--- a/presentaciones/clase01_fundamentos_ecosistema.pptx
+++ b/presentaciones/clase01_fundamentos_ecosistema.pptx
@@ -3291,6 +3291,74 @@
           </a:p>
         </p:txBody>
       </p:sp>
+      <p:sp>
+        <p:nvSpPr>
+          <p:cNvPr id="6" name="Rectangle 5"/>
+          <p:cNvSpPr/>
+          <p:nvPr/>
+        </p:nvSpPr>
+        <p:spPr>
+          <a:xfrm>
+            <a:off x="5806440" y="4480560"/>
+            <a:ext cx="3017520" cy="530352"/>
+          </a:xfrm>
+          <a:prstGeom prst="rect">
+            <a:avLst/>
+          </a:prstGeom>
+          <a:solidFill>
+            <a:srgbClr val="FFFFFF"/>
+          </a:solidFill>
+          <a:ln>
+            <a:noFill/>
+          </a:ln>
+          <a:effectLst/>
+        </p:spPr>
+        <p:style>
+          <a:lnRef idx="1">
+            <a:schemeClr val="accent1"/>
+          </a:lnRef>
+          <a:fillRef idx="3">
+            <a:schemeClr val="accent1"/>
+          </a:fillRef>
+          <a:effectRef idx="2">
+            <a:schemeClr val="accent1"/>
+          </a:effectRef>
+          <a:fontRef idx="minor">
+            <a:schemeClr val="lt1"/>
+          </a:fontRef>
+        </p:style>
+        <p:txBody>
+          <a:bodyPr rtlCol="0" anchor="ctr"/>
+          <a:lstStyle/>
+          <a:p>
+            <a:pPr algn="ctr"/>
+          </a:p>
+        </p:txBody>
+      </p:sp>
+      <p:pic>
+        <p:nvPicPr>
+          <p:cNvPr id="7" name="Picture 6" descr="di_logo_recortado.png"/>
+          <p:cNvPicPr>
+            <a:picLocks noChangeAspect="1"/>
+          </p:cNvPicPr>
+          <p:nvPr/>
+        </p:nvPicPr>
+        <p:blipFill>
+          <a:blip r:embed="rId2"/>
+          <a:stretch>
+            <a:fillRect/>
+          </a:stretch>
+        </p:blipFill>
+        <p:spPr>
+          <a:xfrm>
+            <a:off x="5943600" y="4562856"/>
+            <a:ext cx="2743200" cy="393192"/>
+          </a:xfrm>
+          <a:prstGeom prst="rect">
+            <a:avLst/>
+          </a:prstGeom>
+        </p:spPr>
+      </p:pic>
     </p:spTree>
   </p:cSld>
   <p:clrMapOvr>

</xml_diff>

<commit_message>
Clases 1, 3 y 4: la entrega del EDA es el martes 15, no el lunes
Co-Authored-By: Claude Fable 5.1 <noreply@anthropic.com>
</commit_message>
<xml_diff>
--- a/presentaciones/clase01_fundamentos_ecosistema.pptx
+++ b/presentaciones/clase01_fundamentos_ecosistema.pptx
@@ -3951,7 +3951,7 @@
                           </a:solidFill>
                           <a:latin typeface="Fira Sans"/>
                         </a:rPr>
-                        <a:t>Entrega: lu 15-sep</a:t>
+                        <a:t>Entrega: ma 15-sep</a:t>
                       </a:r>
                     </a:p>
                     <a:p>
@@ -4334,8 +4334,8 @@
         </p:blipFill>
         <p:spPr>
           <a:xfrm>
-            <a:off x="1417319" y="1143000"/>
-            <a:ext cx="6309360" cy="2884949"/>
+            <a:off x="1182363" y="1143000"/>
+            <a:ext cx="6779272" cy="3099816"/>
           </a:xfrm>
           <a:prstGeom prst="rect">
             <a:avLst/>
@@ -4350,8 +4350,8 @@
         </p:nvSpPr>
         <p:spPr>
           <a:xfrm>
-            <a:off x="704088" y="4434840"/>
-            <a:ext cx="7744968" cy="457200"/>
+            <a:off x="704088" y="4379976"/>
+            <a:ext cx="7744968" cy="512064"/>
           </a:xfrm>
           <a:prstGeom prst="rect">
             <a:avLst/>
@@ -4488,7 +4488,7 @@
         </p:blipFill>
         <p:spPr>
           <a:xfrm>
-            <a:off x="1423172" y="1143000"/>
+            <a:off x="1423172" y="1243584"/>
             <a:ext cx="6297654" cy="3154680"/>
           </a:xfrm>
           <a:prstGeom prst="rect">
@@ -4504,8 +4504,8 @@
         </p:nvSpPr>
         <p:spPr>
           <a:xfrm>
-            <a:off x="704088" y="4434840"/>
-            <a:ext cx="7744968" cy="457200"/>
+            <a:off x="704088" y="4535424"/>
+            <a:ext cx="7744968" cy="256032"/>
           </a:xfrm>
           <a:prstGeom prst="rect">
             <a:avLst/>
@@ -4856,8 +4856,8 @@
         </p:blipFill>
         <p:spPr>
           <a:xfrm>
-            <a:off x="1417319" y="1143000"/>
-            <a:ext cx="6309360" cy="2814584"/>
+            <a:off x="1097622" y="1143000"/>
+            <a:ext cx="6948754" cy="3099816"/>
           </a:xfrm>
           <a:prstGeom prst="rect">
             <a:avLst/>
@@ -4872,8 +4872,8 @@
         </p:nvSpPr>
         <p:spPr>
           <a:xfrm>
-            <a:off x="704088" y="4434840"/>
-            <a:ext cx="7744968" cy="457200"/>
+            <a:off x="704088" y="4379976"/>
+            <a:ext cx="7744968" cy="512064"/>
           </a:xfrm>
           <a:prstGeom prst="rect">
             <a:avLst/>
@@ -6322,8 +6322,8 @@
         </p:blipFill>
         <p:spPr>
           <a:xfrm>
-            <a:off x="1553651" y="1143000"/>
-            <a:ext cx="6036697" cy="3154680"/>
+            <a:off x="1606144" y="1143000"/>
+            <a:ext cx="5931711" cy="3099816"/>
           </a:xfrm>
           <a:prstGeom prst="rect">
             <a:avLst/>
@@ -6338,8 +6338,8 @@
         </p:nvSpPr>
         <p:spPr>
           <a:xfrm>
-            <a:off x="704088" y="4434840"/>
-            <a:ext cx="7744968" cy="457200"/>
+            <a:off x="704088" y="4379976"/>
+            <a:ext cx="7744968" cy="512064"/>
           </a:xfrm>
           <a:prstGeom prst="rect">
             <a:avLst/>
@@ -6917,8 +6917,8 @@
         </p:blipFill>
         <p:spPr>
           <a:xfrm>
-            <a:off x="1417319" y="1143000"/>
-            <a:ext cx="6309360" cy="2871234"/>
+            <a:off x="1166172" y="1143000"/>
+            <a:ext cx="6811655" cy="3099816"/>
           </a:xfrm>
           <a:prstGeom prst="rect">
             <a:avLst/>
@@ -6933,8 +6933,8 @@
         </p:nvSpPr>
         <p:spPr>
           <a:xfrm>
-            <a:off x="704088" y="4434840"/>
-            <a:ext cx="7744968" cy="457200"/>
+            <a:off x="704088" y="4379976"/>
+            <a:ext cx="7744968" cy="512064"/>
           </a:xfrm>
           <a:prstGeom prst="rect">
             <a:avLst/>
@@ -7330,8 +7330,8 @@
         </p:blipFill>
         <p:spPr>
           <a:xfrm>
-            <a:off x="1604462" y="1143000"/>
-            <a:ext cx="5935075" cy="3154680"/>
+            <a:off x="1896915" y="1143000"/>
+            <a:ext cx="5350169" cy="2843784"/>
           </a:xfrm>
           <a:prstGeom prst="rect">
             <a:avLst/>
@@ -7346,8 +7346,8 @@
         </p:nvSpPr>
         <p:spPr>
           <a:xfrm>
-            <a:off x="704088" y="4434840"/>
-            <a:ext cx="7744968" cy="457200"/>
+            <a:off x="704088" y="4123944"/>
+            <a:ext cx="7744968" cy="768096"/>
           </a:xfrm>
           <a:prstGeom prst="rect">
             <a:avLst/>
@@ -8295,8 +8295,8 @@
         </p:blipFill>
         <p:spPr>
           <a:xfrm>
-            <a:off x="2316727" y="1143000"/>
-            <a:ext cx="4510544" cy="3154680"/>
+            <a:off x="2355950" y="1143000"/>
+            <a:ext cx="4432099" cy="3099815"/>
           </a:xfrm>
           <a:prstGeom prst="rect">
             <a:avLst/>
@@ -8311,8 +8311,8 @@
         </p:nvSpPr>
         <p:spPr>
           <a:xfrm>
-            <a:off x="704088" y="4434840"/>
-            <a:ext cx="7744968" cy="457200"/>
+            <a:off x="704088" y="4379976"/>
+            <a:ext cx="7744968" cy="512064"/>
           </a:xfrm>
           <a:prstGeom prst="rect">
             <a:avLst/>
@@ -8449,8 +8449,8 @@
         </p:blipFill>
         <p:spPr>
           <a:xfrm>
-            <a:off x="1417319" y="1143000"/>
-            <a:ext cx="6309360" cy="2342555"/>
+            <a:off x="699515" y="1383138"/>
+            <a:ext cx="7744968" cy="2875571"/>
           </a:xfrm>
           <a:prstGeom prst="rect">
             <a:avLst/>
@@ -8465,8 +8465,8 @@
         </p:nvSpPr>
         <p:spPr>
           <a:xfrm>
-            <a:off x="704088" y="4434840"/>
-            <a:ext cx="7744968" cy="457200"/>
+            <a:off x="704088" y="4395869"/>
+            <a:ext cx="7744968" cy="256032"/>
           </a:xfrm>
           <a:prstGeom prst="rect">
             <a:avLst/>
@@ -8710,8 +8710,8 @@
         </p:blipFill>
         <p:spPr>
           <a:xfrm>
-            <a:off x="1417319" y="1143000"/>
-            <a:ext cx="6309360" cy="2137325"/>
+            <a:off x="699515" y="1381086"/>
+            <a:ext cx="7744968" cy="2623644"/>
           </a:xfrm>
           <a:prstGeom prst="rect">
             <a:avLst/>
@@ -8726,8 +8726,8 @@
         </p:nvSpPr>
         <p:spPr>
           <a:xfrm>
-            <a:off x="704088" y="4434840"/>
-            <a:ext cx="7744968" cy="457200"/>
+            <a:off x="704088" y="4141889"/>
+            <a:ext cx="7744968" cy="512064"/>
           </a:xfrm>
           <a:prstGeom prst="rect">
             <a:avLst/>
@@ -8864,8 +8864,8 @@
         </p:blipFill>
         <p:spPr>
           <a:xfrm>
-            <a:off x="1417319" y="1143000"/>
-            <a:ext cx="6309360" cy="2409988"/>
+            <a:off x="849479" y="1143000"/>
+            <a:ext cx="7445040" cy="2843784"/>
           </a:xfrm>
           <a:prstGeom prst="rect">
             <a:avLst/>
@@ -8880,8 +8880,8 @@
         </p:nvSpPr>
         <p:spPr>
           <a:xfrm>
-            <a:off x="704088" y="4434840"/>
-            <a:ext cx="7744968" cy="457200"/>
+            <a:off x="704088" y="4123944"/>
+            <a:ext cx="7744968" cy="768096"/>
           </a:xfrm>
           <a:prstGeom prst="rect">
             <a:avLst/>

</xml_diff>